<commit_message>
Update presentation visuals: adjust dimensions and remove unnecessary text elements
</commit_message>
<xml_diff>
--- a/.codex-build/presentation-visuals/candidate.pptx
+++ b/.codex-build/presentation-visuals/candidate.pptx
@@ -2,20 +2,20 @@
 <file path=ppt/presentation.xml><?xml version="1.0" encoding="utf-8"?>
 <p:presentation xmlns:p="http://schemas.openxmlformats.org/presentationml/2006/main">
   <p:sldMasterIdLst>
-    <p:sldMasterId xmlns:r="http://schemas.openxmlformats.org/officeDocument/2006/relationships" id="2147483648" r:id="R59b7dd386cfb4b33"/>
+    <p:sldMasterId xmlns:r="http://schemas.openxmlformats.org/officeDocument/2006/relationships" id="2147483648" r:id="R45d375dfc0b341b0"/>
   </p:sldMasterIdLst>
   <p:notesMasterIdLst>
-    <p:notesMasterId xmlns:r="http://schemas.openxmlformats.org/officeDocument/2006/relationships" r:id="R8d19420820e54ed6"/>
+    <p:notesMasterId xmlns:r="http://schemas.openxmlformats.org/officeDocument/2006/relationships" r:id="Rd996617344b54215"/>
   </p:notesMasterIdLst>
   <p:sldIdLst>
-    <p:sldId xmlns:r="http://schemas.openxmlformats.org/officeDocument/2006/relationships" id="256" r:id="R4f2fb24c77974fae"/>
-    <p:sldId xmlns:r="http://schemas.openxmlformats.org/officeDocument/2006/relationships" id="257" r:id="Rfe3008147d9e4f76"/>
-    <p:sldId xmlns:r="http://schemas.openxmlformats.org/officeDocument/2006/relationships" id="258" r:id="R574d06c4674342aa"/>
-    <p:sldId xmlns:r="http://schemas.openxmlformats.org/officeDocument/2006/relationships" id="259" r:id="Rb83b2f1dfb564081"/>
-    <p:sldId xmlns:r="http://schemas.openxmlformats.org/officeDocument/2006/relationships" id="260" r:id="Rcd54878fc74a4944"/>
-    <p:sldId xmlns:r="http://schemas.openxmlformats.org/officeDocument/2006/relationships" id="261" r:id="R541dfcc981644d6a"/>
-    <p:sldId xmlns:r="http://schemas.openxmlformats.org/officeDocument/2006/relationships" id="262" r:id="R4b649753c36141ca"/>
-    <p:sldId xmlns:r="http://schemas.openxmlformats.org/officeDocument/2006/relationships" id="263" r:id="Ref7e4170cd6c4da8"/>
+    <p:sldId xmlns:r="http://schemas.openxmlformats.org/officeDocument/2006/relationships" id="256" r:id="R7dbf94485ec74cf5"/>
+    <p:sldId xmlns:r="http://schemas.openxmlformats.org/officeDocument/2006/relationships" id="257" r:id="R25c19f0426c549d2"/>
+    <p:sldId xmlns:r="http://schemas.openxmlformats.org/officeDocument/2006/relationships" id="258" r:id="Rdb386e6d5584495d"/>
+    <p:sldId xmlns:r="http://schemas.openxmlformats.org/officeDocument/2006/relationships" id="259" r:id="R90d7745a14894937"/>
+    <p:sldId xmlns:r="http://schemas.openxmlformats.org/officeDocument/2006/relationships" id="260" r:id="Rfb0c70b70509499f"/>
+    <p:sldId xmlns:r="http://schemas.openxmlformats.org/officeDocument/2006/relationships" id="261" r:id="R1cccf586e3f048ec"/>
+    <p:sldId xmlns:r="http://schemas.openxmlformats.org/officeDocument/2006/relationships" id="262" r:id="Re981fa971ced4884"/>
+    <p:sldId xmlns:r="http://schemas.openxmlformats.org/officeDocument/2006/relationships" id="263" r:id="R874d42ce1abe42f6"/>
   </p:sldIdLst>
   <p:sldSz cx="12192000" cy="6858000"/>
   <p:notesSz cx="6858000" cy="9144000"/>
@@ -975,7 +975,7 @@
   </p:cSld>
   <p:clrMap bg1="lt1" tx1="dk1" bg2="lt2" tx2="dk2" accent1="accent1" accent2="accent2" accent3="accent3" accent4="accent4" accent5="accent5" accent6="accent6" hlink="hlink" folHlink="folHlink"/>
   <p:sldLayoutIdLst>
-    <p:sldLayoutId xmlns:r="http://schemas.openxmlformats.org/officeDocument/2006/relationships" id="2147483649" r:id="Re817eff1ae194e4e"/>
+    <p:sldLayoutId xmlns:r="http://schemas.openxmlformats.org/officeDocument/2006/relationships" id="2147483649" r:id="R17f2a59549f946b7"/>
   </p:sldLayoutIdLst>
   <p:txStyles>
     <p:titleStyle>
@@ -1526,7 +1526,7 @@
           <p:cNvPr id="29" name="">
             <a:extLst xmlns:a="http://schemas.openxmlformats.org/drawingml/2006/main">
               <a:ext uri="{FF2B5EF4-FFF2-40B4-BE49-F238E27FC236}">
-                <a16:creationId xmlns:a16="http://schemas.microsoft.com/office/drawing/2014/main" id="{AF404DB6-FD8C-4B75-AE88-A1BDD50B42C6}"/>
+                <a16:creationId xmlns:a16="http://schemas.microsoft.com/office/drawing/2014/main" id="{2C643AC4-8B77-43A5-9C66-DBBB25FC22C8}"/>
               </a:ext>
             </a:extLst>
           </p:cNvPr>
@@ -1559,7 +1559,7 @@
           <p:cNvPr id="2" name="">
             <a:extLst xmlns:a="http://schemas.openxmlformats.org/drawingml/2006/main">
               <a:ext uri="{FF2B5EF4-FFF2-40B4-BE49-F238E27FC236}">
-                <a16:creationId xmlns:a16="http://schemas.microsoft.com/office/drawing/2014/main" id="{EC442809-1B81-43CC-8012-F7387BA9FE07}"/>
+                <a16:creationId xmlns:a16="http://schemas.microsoft.com/office/drawing/2014/main" id="{D123C210-7817-4472-9B62-0D0B359162D9}"/>
               </a:ext>
             </a:extLst>
           </p:cNvPr>
@@ -1592,7 +1592,7 @@
           <p:cNvPr id="3" name="">
             <a:extLst xmlns:a="http://schemas.openxmlformats.org/drawingml/2006/main">
               <a:ext uri="{FF2B5EF4-FFF2-40B4-BE49-F238E27FC236}">
-                <a16:creationId xmlns:a16="http://schemas.microsoft.com/office/drawing/2014/main" id="{780ADEF5-32E0-45F3-9B70-682E0BAB60D2}"/>
+                <a16:creationId xmlns:a16="http://schemas.microsoft.com/office/drawing/2014/main" id="{41DD717B-9559-4FEC-B12F-7584DD62995D}"/>
               </a:ext>
             </a:extLst>
           </p:cNvPr>
@@ -1625,7 +1625,7 @@
           <p:cNvPr id="4" name="">
             <a:extLst xmlns:a="http://schemas.openxmlformats.org/drawingml/2006/main">
               <a:ext uri="{FF2B5EF4-FFF2-40B4-BE49-F238E27FC236}">
-                <a16:creationId xmlns:a16="http://schemas.microsoft.com/office/drawing/2014/main" id="{0E734697-0827-4642-ACF5-99864BEFE689}"/>
+                <a16:creationId xmlns:a16="http://schemas.microsoft.com/office/drawing/2014/main" id="{EE38E213-8772-458C-99A3-A376F6E4D518}"/>
               </a:ext>
             </a:extLst>
           </p:cNvPr>
@@ -1658,7 +1658,7 @@
           <p:cNvPr id="5" name="">
             <a:extLst xmlns:a="http://schemas.openxmlformats.org/drawingml/2006/main">
               <a:ext uri="{FF2B5EF4-FFF2-40B4-BE49-F238E27FC236}">
-                <a16:creationId xmlns:a16="http://schemas.microsoft.com/office/drawing/2014/main" id="{2B11CA4D-772F-4823-A421-FFD871E1216B}"/>
+                <a16:creationId xmlns:a16="http://schemas.microsoft.com/office/drawing/2014/main" id="{9FBE0498-F863-4872-A99A-CE067BBAF8C1}"/>
               </a:ext>
             </a:extLst>
           </p:cNvPr>
@@ -1769,7 +1769,7 @@
           <p:cNvPr id="9" name="">
             <a:extLst xmlns:a="http://schemas.openxmlformats.org/drawingml/2006/main">
               <a:ext uri="{FF2B5EF4-FFF2-40B4-BE49-F238E27FC236}">
-                <a16:creationId xmlns:a16="http://schemas.microsoft.com/office/drawing/2014/main" id="{E2663AD3-A68F-4503-B67C-C8CF2D458AD8}"/>
+                <a16:creationId xmlns:a16="http://schemas.microsoft.com/office/drawing/2014/main" id="{1FE44472-A9BD-4EBC-A5B6-BF756D0C5D4C}"/>
               </a:ext>
             </a:extLst>
           </p:cNvPr>
@@ -1833,7 +1833,7 @@
           <p:cNvPr id="10" name="">
             <a:extLst xmlns:a="http://schemas.openxmlformats.org/drawingml/2006/main">
               <a:ext uri="{FF2B5EF4-FFF2-40B4-BE49-F238E27FC236}">
-                <a16:creationId xmlns:a16="http://schemas.microsoft.com/office/drawing/2014/main" id="{E4F6BA24-8845-4121-AFF4-EC9ED45B2C03}"/>
+                <a16:creationId xmlns:a16="http://schemas.microsoft.com/office/drawing/2014/main" id="{263DA058-4267-4234-A863-DAA66118BCD4}"/>
               </a:ext>
             </a:extLst>
           </p:cNvPr>
@@ -1891,7 +1891,7 @@
           <p:cNvPr id="11" name="">
             <a:extLst xmlns:a="http://schemas.openxmlformats.org/drawingml/2006/main">
               <a:ext uri="{FF2B5EF4-FFF2-40B4-BE49-F238E27FC236}">
-                <a16:creationId xmlns:a16="http://schemas.microsoft.com/office/drawing/2014/main" id="{3D33E658-900C-4829-B424-9CB772168A4B}"/>
+                <a16:creationId xmlns:a16="http://schemas.microsoft.com/office/drawing/2014/main" id="{EE01C2BA-5EF3-44B8-B27E-3CCB6BEC0BF0}"/>
               </a:ext>
             </a:extLst>
           </p:cNvPr>
@@ -1924,7 +1924,7 @@
           <p:cNvPr id="12" name="">
             <a:extLst xmlns:a="http://schemas.openxmlformats.org/drawingml/2006/main">
               <a:ext uri="{FF2B5EF4-FFF2-40B4-BE49-F238E27FC236}">
-                <a16:creationId xmlns:a16="http://schemas.microsoft.com/office/drawing/2014/main" id="{8D5F87E9-E084-4A59-965C-A923360DEB4A}"/>
+                <a16:creationId xmlns:a16="http://schemas.microsoft.com/office/drawing/2014/main" id="{EDDA3234-723F-4EC2-981F-03578619D89D}"/>
               </a:ext>
             </a:extLst>
           </p:cNvPr>
@@ -1982,7 +1982,7 @@
           <p:cNvPr id="13" name="">
             <a:extLst xmlns:a="http://schemas.openxmlformats.org/drawingml/2006/main">
               <a:ext uri="{FF2B5EF4-FFF2-40B4-BE49-F238E27FC236}">
-                <a16:creationId xmlns:a16="http://schemas.microsoft.com/office/drawing/2014/main" id="{BEE46D52-0F08-4035-B8BF-D573C8F7111D}"/>
+                <a16:creationId xmlns:a16="http://schemas.microsoft.com/office/drawing/2014/main" id="{D4FB93F3-67A0-44CE-A6D0-7822397B7305}"/>
               </a:ext>
             </a:extLst>
           </p:cNvPr>
@@ -2015,7 +2015,7 @@
           <p:cNvPr id="14" name="">
             <a:extLst xmlns:a="http://schemas.openxmlformats.org/drawingml/2006/main">
               <a:ext uri="{FF2B5EF4-FFF2-40B4-BE49-F238E27FC236}">
-                <a16:creationId xmlns:a16="http://schemas.microsoft.com/office/drawing/2014/main" id="{E370215A-F29D-445F-85FA-7FCB40741AA7}"/>
+                <a16:creationId xmlns:a16="http://schemas.microsoft.com/office/drawing/2014/main" id="{38D5E175-1D47-469D-90E3-C22EC79B078C}"/>
               </a:ext>
             </a:extLst>
           </p:cNvPr>
@@ -2073,7 +2073,7 @@
           <p:cNvPr id="15" name="">
             <a:extLst xmlns:a="http://schemas.openxmlformats.org/drawingml/2006/main">
               <a:ext uri="{FF2B5EF4-FFF2-40B4-BE49-F238E27FC236}">
-                <a16:creationId xmlns:a16="http://schemas.microsoft.com/office/drawing/2014/main" id="{8FA3E9B4-54FD-4CF1-AE45-92A9F99E923A}"/>
+                <a16:creationId xmlns:a16="http://schemas.microsoft.com/office/drawing/2014/main" id="{DE387E74-8D7D-4A15-BE3E-BC15181CB8FA}"/>
               </a:ext>
             </a:extLst>
           </p:cNvPr>
@@ -2106,7 +2106,7 @@
           <p:cNvPr id="16" name="">
             <a:extLst xmlns:a="http://schemas.openxmlformats.org/drawingml/2006/main">
               <a:ext uri="{FF2B5EF4-FFF2-40B4-BE49-F238E27FC236}">
-                <a16:creationId xmlns:a16="http://schemas.microsoft.com/office/drawing/2014/main" id="{6C46A201-6CF1-476E-8F67-E2D1C6FF403C}"/>
+                <a16:creationId xmlns:a16="http://schemas.microsoft.com/office/drawing/2014/main" id="{A52B00A8-02AE-46FB-918B-5355A0563143}"/>
               </a:ext>
             </a:extLst>
           </p:cNvPr>
@@ -2137,7 +2137,7 @@
           <p:cNvPr id="17" name="">
             <a:extLst xmlns:a="http://schemas.openxmlformats.org/drawingml/2006/main">
               <a:ext uri="{FF2B5EF4-FFF2-40B4-BE49-F238E27FC236}">
-                <a16:creationId xmlns:a16="http://schemas.microsoft.com/office/drawing/2014/main" id="{EEAC393B-CD47-4ED1-AC6D-0B5096B19D49}"/>
+                <a16:creationId xmlns:a16="http://schemas.microsoft.com/office/drawing/2014/main" id="{C1695F8C-5F32-43B6-9763-31E801837DD1}"/>
               </a:ext>
             </a:extLst>
           </p:cNvPr>
@@ -2195,7 +2195,7 @@
           <p:cNvPr id="18" name="">
             <a:extLst xmlns:a="http://schemas.openxmlformats.org/drawingml/2006/main">
               <a:ext uri="{FF2B5EF4-FFF2-40B4-BE49-F238E27FC236}">
-                <a16:creationId xmlns:a16="http://schemas.microsoft.com/office/drawing/2014/main" id="{CF662EFB-17EC-4A36-9EF5-C43D94095CD1}"/>
+                <a16:creationId xmlns:a16="http://schemas.microsoft.com/office/drawing/2014/main" id="{D1F746D6-6DA9-4552-B7AD-20649D0575D2}"/>
               </a:ext>
             </a:extLst>
           </p:cNvPr>
@@ -2228,7 +2228,7 @@
           <p:cNvPr id="19" name="">
             <a:extLst xmlns:a="http://schemas.openxmlformats.org/drawingml/2006/main">
               <a:ext uri="{FF2B5EF4-FFF2-40B4-BE49-F238E27FC236}">
-                <a16:creationId xmlns:a16="http://schemas.microsoft.com/office/drawing/2014/main" id="{9C876BC8-5A60-46AB-B01F-3CC4A846AC2A}"/>
+                <a16:creationId xmlns:a16="http://schemas.microsoft.com/office/drawing/2014/main" id="{080607AF-0AF0-4FDB-9BD7-C6B448954200}"/>
               </a:ext>
             </a:extLst>
           </p:cNvPr>
@@ -2364,7 +2364,7 @@
           <p:cNvPr id="23" name="">
             <a:extLst xmlns:a="http://schemas.openxmlformats.org/drawingml/2006/main">
               <a:ext uri="{FF2B5EF4-FFF2-40B4-BE49-F238E27FC236}">
-                <a16:creationId xmlns:a16="http://schemas.microsoft.com/office/drawing/2014/main" id="{507A5B09-3C53-40CE-B930-F8E2C3C49177}"/>
+                <a16:creationId xmlns:a16="http://schemas.microsoft.com/office/drawing/2014/main" id="{1CC98805-BE2C-49EB-88FE-C3207BE9C6DC}"/>
               </a:ext>
             </a:extLst>
           </p:cNvPr>
@@ -2422,7 +2422,7 @@
           <p:cNvPr id="24" name="">
             <a:extLst xmlns:a="http://schemas.openxmlformats.org/drawingml/2006/main">
               <a:ext uri="{FF2B5EF4-FFF2-40B4-BE49-F238E27FC236}">
-                <a16:creationId xmlns:a16="http://schemas.microsoft.com/office/drawing/2014/main" id="{4DDBC005-305B-4178-954F-4C0F05E01EAE}"/>
+                <a16:creationId xmlns:a16="http://schemas.microsoft.com/office/drawing/2014/main" id="{B1F471F7-6C7A-46E1-8434-A4EF464F1008}"/>
               </a:ext>
             </a:extLst>
           </p:cNvPr>
@@ -2480,7 +2480,7 @@
           <p:cNvPr id="25" name="">
             <a:extLst xmlns:a="http://schemas.openxmlformats.org/drawingml/2006/main">
               <a:ext uri="{FF2B5EF4-FFF2-40B4-BE49-F238E27FC236}">
-                <a16:creationId xmlns:a16="http://schemas.microsoft.com/office/drawing/2014/main" id="{EDBB72D5-DF00-47F6-A238-A187F6235BE5}"/>
+                <a16:creationId xmlns:a16="http://schemas.microsoft.com/office/drawing/2014/main" id="{286B1E3F-751E-4AAB-A954-F0054C4F13C7}"/>
               </a:ext>
             </a:extLst>
           </p:cNvPr>
@@ -2538,7 +2538,7 @@
           <p:cNvPr id="26" name="">
             <a:extLst xmlns:a="http://schemas.openxmlformats.org/drawingml/2006/main">
               <a:ext uri="{FF2B5EF4-FFF2-40B4-BE49-F238E27FC236}">
-                <a16:creationId xmlns:a16="http://schemas.microsoft.com/office/drawing/2014/main" id="{B5C60FCB-BC0F-40A2-9ACE-998B04EA74E4}"/>
+                <a16:creationId xmlns:a16="http://schemas.microsoft.com/office/drawing/2014/main" id="{81930ABE-7762-4463-BC0B-0208570C69A3}"/>
               </a:ext>
             </a:extLst>
           </p:cNvPr>
@@ -2596,7 +2596,7 @@
           <p:cNvPr id="27" name="">
             <a:extLst xmlns:a="http://schemas.openxmlformats.org/drawingml/2006/main">
               <a:ext uri="{FF2B5EF4-FFF2-40B4-BE49-F238E27FC236}">
-                <a16:creationId xmlns:a16="http://schemas.microsoft.com/office/drawing/2014/main" id="{642FBBD0-1674-4BF6-9D71-3D5FABC7616E}"/>
+                <a16:creationId xmlns:a16="http://schemas.microsoft.com/office/drawing/2014/main" id="{ADA4C815-192B-45A2-9075-115455BF1068}"/>
               </a:ext>
             </a:extLst>
           </p:cNvPr>
@@ -2654,7 +2654,7 @@
           <p:cNvPr id="28" name="">
             <a:extLst xmlns:a="http://schemas.openxmlformats.org/drawingml/2006/main">
               <a:ext uri="{FF2B5EF4-FFF2-40B4-BE49-F238E27FC236}">
-                <a16:creationId xmlns:a16="http://schemas.microsoft.com/office/drawing/2014/main" id="{6F67A2D1-45E0-4C75-9670-425CC530DC59}"/>
+                <a16:creationId xmlns:a16="http://schemas.microsoft.com/office/drawing/2014/main" id="{6698D28F-4003-4AB9-82A3-7395516AAE96}"/>
               </a:ext>
             </a:extLst>
           </p:cNvPr>
@@ -2710,7 +2710,7 @@
     </p:spTree>
     <p:extLst>
       <p:ext uri="{BB962C8B-B14F-4D97-AF65-F5344CB8AC3E}">
-        <p14:creationId xmlns:p14="http://schemas.microsoft.com/office/powerpoint/2010/main" val="1299207040"/>
+        <p14:creationId xmlns:p14="http://schemas.microsoft.com/office/powerpoint/2010/main" val="283361567"/>
       </p:ext>
     </p:extLst>
   </p:cSld>
@@ -2738,10 +2738,10 @@
       </p:grpSpPr>
       <p:sp>
         <p:nvSpPr>
-          <p:cNvPr id="43" name="">
-            <a:extLst xmlns:a="http://schemas.openxmlformats.org/drawingml/2006/main">
-              <a:ext uri="{FF2B5EF4-FFF2-40B4-BE49-F238E27FC236}">
-                <a16:creationId xmlns:a16="http://schemas.microsoft.com/office/drawing/2014/main" id="{C3D0F2BB-4493-4F8A-A7DC-8AFDF063C0EC}"/>
+          <p:cNvPr id="42" name="">
+            <a:extLst xmlns:a="http://schemas.openxmlformats.org/drawingml/2006/main">
+              <a:ext uri="{FF2B5EF4-FFF2-40B4-BE49-F238E27FC236}">
+                <a16:creationId xmlns:a16="http://schemas.microsoft.com/office/drawing/2014/main" id="{84D28F0C-B7B9-4B89-85A5-23B85EAA81AA}"/>
               </a:ext>
             </a:extLst>
           </p:cNvPr>
@@ -2774,7 +2774,7 @@
           <p:cNvPr id="2" name="">
             <a:extLst xmlns:a="http://schemas.openxmlformats.org/drawingml/2006/main">
               <a:ext uri="{FF2B5EF4-FFF2-40B4-BE49-F238E27FC236}">
-                <a16:creationId xmlns:a16="http://schemas.microsoft.com/office/drawing/2014/main" id="{88420BA2-5187-43F9-83AB-AA14F47D7963}"/>
+                <a16:creationId xmlns:a16="http://schemas.microsoft.com/office/drawing/2014/main" id="{ABFE86FE-9118-4B95-B34E-88E23ABFA045}"/>
               </a:ext>
             </a:extLst>
           </p:cNvPr>
@@ -2807,7 +2807,7 @@
           <p:cNvPr id="3" name="">
             <a:extLst xmlns:a="http://schemas.openxmlformats.org/drawingml/2006/main">
               <a:ext uri="{FF2B5EF4-FFF2-40B4-BE49-F238E27FC236}">
-                <a16:creationId xmlns:a16="http://schemas.microsoft.com/office/drawing/2014/main" id="{F74F745B-9D9E-4834-89E4-86996F7B9772}"/>
+                <a16:creationId xmlns:a16="http://schemas.microsoft.com/office/drawing/2014/main" id="{E33C9026-D536-4B86-909E-4046AD591DE3}"/>
               </a:ext>
             </a:extLst>
           </p:cNvPr>
@@ -2840,7 +2840,7 @@
           <p:cNvPr id="4" name="">
             <a:extLst xmlns:a="http://schemas.openxmlformats.org/drawingml/2006/main">
               <a:ext uri="{FF2B5EF4-FFF2-40B4-BE49-F238E27FC236}">
-                <a16:creationId xmlns:a16="http://schemas.microsoft.com/office/drawing/2014/main" id="{4DBA97DB-0131-41DD-982C-A6A5B0D70EEB}"/>
+                <a16:creationId xmlns:a16="http://schemas.microsoft.com/office/drawing/2014/main" id="{4DE8424E-FAE9-4E4C-82DA-27DD3424A913}"/>
               </a:ext>
             </a:extLst>
           </p:cNvPr>
@@ -2868,19 +2868,45 @@
           </a:ln>
         </p:spPr>
       </p:sp>
+      <p:cxnSp>
+        <p:nvCxnSpPr>
+          <p:cNvPr id="46" name=""/>
+          <p:cNvCxnSpPr>
+            <a:stCxn xmlns:a="http://schemas.openxmlformats.org/drawingml/2006/main" id="1" idx="6"/>
+            <a:endCxn xmlns:a="http://schemas.openxmlformats.org/drawingml/2006/main" id="2" idx="2"/>
+          </p:cNvCxnSpPr>
+          <p:nvPr/>
+        </p:nvCxnSpPr>
+        <p:spPr>
+          <a:xfrm xmlns:a="http://schemas.openxmlformats.org/drawingml/2006/main">
+            <a:off x="1638300" y="3314700"/>
+            <a:ext cx="2819400" cy="0"/>
+          </a:xfrm>
+          <a:prstGeom xmlns:a="http://schemas.openxmlformats.org/drawingml/2006/main" prst="straightConnector1">
+            <a:avLst/>
+          </a:prstGeom>
+          <a:ln xmlns:a="http://schemas.openxmlformats.org/drawingml/2006/main" w="28575">
+            <a:solidFill>
+              <a:srgbClr val="A9B4BE"/>
+            </a:solidFill>
+            <a:prstDash val="solid"/>
+            <a:tailEnd type="triangle" w="sm" len="sm"/>
+          </a:ln>
+        </p:spPr>
+      </p:cxnSp>
       <p:cxnSp>
         <p:nvCxnSpPr>
           <p:cNvPr id="47" name=""/>
           <p:cNvCxnSpPr>
-            <a:stCxn xmlns:a="http://schemas.openxmlformats.org/drawingml/2006/main" id="1" idx="6"/>
-            <a:endCxn xmlns:a="http://schemas.openxmlformats.org/drawingml/2006/main" id="2" idx="2"/>
+            <a:stCxn xmlns:a="http://schemas.openxmlformats.org/drawingml/2006/main" id="2" idx="6"/>
+            <a:endCxn xmlns:a="http://schemas.openxmlformats.org/drawingml/2006/main" id="3" idx="2"/>
           </p:cNvCxnSpPr>
           <p:nvPr/>
         </p:nvCxnSpPr>
         <p:spPr>
           <a:xfrm xmlns:a="http://schemas.openxmlformats.org/drawingml/2006/main">
-            <a:off x="1638300" y="3314700"/>
-            <a:ext cx="2819400" cy="0"/>
+            <a:off x="4591050" y="3314700"/>
+            <a:ext cx="2867025" cy="0"/>
           </a:xfrm>
           <a:prstGeom xmlns:a="http://schemas.openxmlformats.org/drawingml/2006/main" prst="straightConnector1">
             <a:avLst/>
@@ -2898,32 +2924,6 @@
         <p:nvCxnSpPr>
           <p:cNvPr id="48" name=""/>
           <p:cNvCxnSpPr>
-            <a:stCxn xmlns:a="http://schemas.openxmlformats.org/drawingml/2006/main" id="2" idx="6"/>
-            <a:endCxn xmlns:a="http://schemas.openxmlformats.org/drawingml/2006/main" id="3" idx="2"/>
-          </p:cNvCxnSpPr>
-          <p:nvPr/>
-        </p:nvCxnSpPr>
-        <p:spPr>
-          <a:xfrm xmlns:a="http://schemas.openxmlformats.org/drawingml/2006/main">
-            <a:off x="4591050" y="3314700"/>
-            <a:ext cx="2867025" cy="0"/>
-          </a:xfrm>
-          <a:prstGeom xmlns:a="http://schemas.openxmlformats.org/drawingml/2006/main" prst="straightConnector1">
-            <a:avLst/>
-          </a:prstGeom>
-          <a:ln xmlns:a="http://schemas.openxmlformats.org/drawingml/2006/main" w="28575">
-            <a:solidFill>
-              <a:srgbClr val="A9B4BE"/>
-            </a:solidFill>
-            <a:prstDash val="solid"/>
-            <a:tailEnd type="triangle" w="sm" len="sm"/>
-          </a:ln>
-        </p:spPr>
-      </p:cxnSp>
-      <p:cxnSp>
-        <p:nvCxnSpPr>
-          <p:cNvPr id="49" name=""/>
-          <p:cNvCxnSpPr>
             <a:stCxn xmlns:a="http://schemas.openxmlformats.org/drawingml/2006/main" id="3" idx="6"/>
             <a:endCxn xmlns:a="http://schemas.openxmlformats.org/drawingml/2006/main" id="4" idx="2"/>
           </p:cNvCxnSpPr>
@@ -2951,18 +2951,18 @@
           <p:cNvPr id="8" name="">
             <a:extLst xmlns:a="http://schemas.openxmlformats.org/drawingml/2006/main">
               <a:ext uri="{FF2B5EF4-FFF2-40B4-BE49-F238E27FC236}">
-                <a16:creationId xmlns:a16="http://schemas.microsoft.com/office/drawing/2014/main" id="{CA4FDD1B-766B-417B-A1CE-9959DBFF16C3}"/>
-              </a:ext>
-            </a:extLst>
-          </p:cNvPr>
-          <p:cNvSpPr>
-            <a:spLocks xmlns:a="http://schemas.openxmlformats.org/drawingml/2006/main" noGrp="1"/>
-          </p:cNvSpPr>
-          <p:nvPr/>
-        </p:nvSpPr>
-        <p:spPr>
-          <a:xfrm xmlns:a="http://schemas.openxmlformats.org/drawingml/2006/main">
-            <a:off x="1409700" y="2695575"/>
+                <a16:creationId xmlns:a16="http://schemas.microsoft.com/office/drawing/2014/main" id="{391F70A4-8BC1-47A0-867D-1B8DD69DD806}"/>
+              </a:ext>
+            </a:extLst>
+          </p:cNvPr>
+          <p:cNvSpPr>
+            <a:spLocks xmlns:a="http://schemas.openxmlformats.org/drawingml/2006/main" noGrp="1"/>
+          </p:cNvSpPr>
+          <p:nvPr/>
+        </p:nvSpPr>
+        <p:spPr>
+          <a:xfrm xmlns:a="http://schemas.openxmlformats.org/drawingml/2006/main">
+            <a:off x="1409700" y="2409825"/>
             <a:ext cx="323850" cy="323850"/>
           </a:xfrm>
           <a:prstGeom xmlns:a="http://schemas.openxmlformats.org/drawingml/2006/main" prst="ellipse">
@@ -2984,18 +2984,18 @@
           <p:cNvPr id="9" name="">
             <a:extLst xmlns:a="http://schemas.openxmlformats.org/drawingml/2006/main">
               <a:ext uri="{FF2B5EF4-FFF2-40B4-BE49-F238E27FC236}">
-                <a16:creationId xmlns:a16="http://schemas.microsoft.com/office/drawing/2014/main" id="{B227970B-3DE7-4C98-87E2-E12A24022041}"/>
-              </a:ext>
-            </a:extLst>
-          </p:cNvPr>
-          <p:cNvSpPr>
-            <a:spLocks xmlns:a="http://schemas.openxmlformats.org/drawingml/2006/main" noGrp="1"/>
-          </p:cNvSpPr>
-          <p:nvPr/>
-        </p:nvSpPr>
-        <p:spPr>
-          <a:xfrm xmlns:a="http://schemas.openxmlformats.org/drawingml/2006/main">
-            <a:off x="828675" y="2228850"/>
+                <a16:creationId xmlns:a16="http://schemas.microsoft.com/office/drawing/2014/main" id="{58BA640E-8330-4ED6-8893-93F30EDB4F34}"/>
+              </a:ext>
+            </a:extLst>
+          </p:cNvPr>
+          <p:cNvSpPr>
+            <a:spLocks xmlns:a="http://schemas.openxmlformats.org/drawingml/2006/main" noGrp="1"/>
+          </p:cNvSpPr>
+          <p:nvPr/>
+        </p:nvSpPr>
+        <p:spPr>
+          <a:xfrm xmlns:a="http://schemas.openxmlformats.org/drawingml/2006/main">
+            <a:off x="828675" y="1943100"/>
             <a:ext cx="228600" cy="228600"/>
           </a:xfrm>
           <a:prstGeom xmlns:a="http://schemas.openxmlformats.org/drawingml/2006/main" prst="ellipse">
@@ -3017,18 +3017,18 @@
           <p:cNvPr id="10" name="">
             <a:extLst xmlns:a="http://schemas.openxmlformats.org/drawingml/2006/main">
               <a:ext uri="{FF2B5EF4-FFF2-40B4-BE49-F238E27FC236}">
-                <a16:creationId xmlns:a16="http://schemas.microsoft.com/office/drawing/2014/main" id="{3D9B7B1B-0139-4F48-B46E-0F920A7EF7AC}"/>
-              </a:ext>
-            </a:extLst>
-          </p:cNvPr>
-          <p:cNvSpPr>
-            <a:spLocks xmlns:a="http://schemas.openxmlformats.org/drawingml/2006/main" noGrp="1"/>
-          </p:cNvSpPr>
-          <p:nvPr/>
-        </p:nvSpPr>
-        <p:spPr>
-          <a:xfrm xmlns:a="http://schemas.openxmlformats.org/drawingml/2006/main">
-            <a:off x="695325" y="3171825"/>
+                <a16:creationId xmlns:a16="http://schemas.microsoft.com/office/drawing/2014/main" id="{3C475F52-A702-4BD7-8B54-3E0098E2DC6D}"/>
+              </a:ext>
+            </a:extLst>
+          </p:cNvPr>
+          <p:cNvSpPr>
+            <a:spLocks xmlns:a="http://schemas.openxmlformats.org/drawingml/2006/main" noGrp="1"/>
+          </p:cNvSpPr>
+          <p:nvPr/>
+        </p:nvSpPr>
+        <p:spPr>
+          <a:xfrm xmlns:a="http://schemas.openxmlformats.org/drawingml/2006/main">
+            <a:off x="695325" y="2886075"/>
             <a:ext cx="228600" cy="228600"/>
           </a:xfrm>
           <a:prstGeom xmlns:a="http://schemas.openxmlformats.org/drawingml/2006/main" prst="ellipse">
@@ -3050,18 +3050,18 @@
           <p:cNvPr id="11" name="">
             <a:extLst xmlns:a="http://schemas.openxmlformats.org/drawingml/2006/main">
               <a:ext uri="{FF2B5EF4-FFF2-40B4-BE49-F238E27FC236}">
-                <a16:creationId xmlns:a16="http://schemas.microsoft.com/office/drawing/2014/main" id="{A31C89B4-231E-4C92-A57D-4CD38DEBF922}"/>
-              </a:ext>
-            </a:extLst>
-          </p:cNvPr>
-          <p:cNvSpPr>
-            <a:spLocks xmlns:a="http://schemas.openxmlformats.org/drawingml/2006/main" noGrp="1"/>
-          </p:cNvSpPr>
-          <p:nvPr/>
-        </p:nvSpPr>
-        <p:spPr>
-          <a:xfrm xmlns:a="http://schemas.openxmlformats.org/drawingml/2006/main">
-            <a:off x="2162175" y="2800350"/>
+                <a16:creationId xmlns:a16="http://schemas.microsoft.com/office/drawing/2014/main" id="{3D006904-989C-4292-B153-CB30014320E2}"/>
+              </a:ext>
+            </a:extLst>
+          </p:cNvPr>
+          <p:cNvSpPr>
+            <a:spLocks xmlns:a="http://schemas.openxmlformats.org/drawingml/2006/main" noGrp="1"/>
+          </p:cNvSpPr>
+          <p:nvPr/>
+        </p:nvSpPr>
+        <p:spPr>
+          <a:xfrm xmlns:a="http://schemas.openxmlformats.org/drawingml/2006/main">
+            <a:off x="2162175" y="2514600"/>
             <a:ext cx="228600" cy="228600"/>
           </a:xfrm>
           <a:prstGeom xmlns:a="http://schemas.openxmlformats.org/drawingml/2006/main" prst="ellipse">
@@ -3078,19 +3078,45 @@
           </a:ln>
         </p:spPr>
       </p:sp>
+      <p:cxnSp>
+        <p:nvCxnSpPr>
+          <p:cNvPr id="53" name=""/>
+          <p:cNvCxnSpPr>
+            <a:stCxn xmlns:a="http://schemas.openxmlformats.org/drawingml/2006/main" id="9" idx="5"/>
+            <a:endCxn xmlns:a="http://schemas.openxmlformats.org/drawingml/2006/main" id="8" idx="1"/>
+          </p:cNvCxnSpPr>
+          <p:nvPr/>
+        </p:nvCxnSpPr>
+        <p:spPr>
+          <a:xfrm xmlns:a="http://schemas.openxmlformats.org/drawingml/2006/main">
+            <a:off x="1023797" y="2138222"/>
+            <a:ext cx="433329" cy="319029"/>
+          </a:xfrm>
+          <a:prstGeom xmlns:a="http://schemas.openxmlformats.org/drawingml/2006/main" prst="straightConnector1">
+            <a:avLst/>
+          </a:prstGeom>
+          <a:ln xmlns:a="http://schemas.openxmlformats.org/drawingml/2006/main" w="19050">
+            <a:solidFill>
+              <a:srgbClr val="4F86C6"/>
+            </a:solidFill>
+            <a:prstDash val="solid"/>
+            <a:tailEnd type="none" w="med" len="med"/>
+          </a:ln>
+        </p:spPr>
+      </p:cxnSp>
       <p:cxnSp>
         <p:nvCxnSpPr>
           <p:cNvPr id="54" name=""/>
           <p:cNvCxnSpPr>
-            <a:stCxn xmlns:a="http://schemas.openxmlformats.org/drawingml/2006/main" id="9" idx="5"/>
-            <a:endCxn xmlns:a="http://schemas.openxmlformats.org/drawingml/2006/main" id="8" idx="1"/>
+            <a:stCxn xmlns:a="http://schemas.openxmlformats.org/drawingml/2006/main" id="10" idx="7"/>
+            <a:endCxn xmlns:a="http://schemas.openxmlformats.org/drawingml/2006/main" id="8" idx="3"/>
           </p:cNvCxnSpPr>
           <p:nvPr/>
         </p:nvCxnSpPr>
         <p:spPr>
-          <a:xfrm xmlns:a="http://schemas.openxmlformats.org/drawingml/2006/main">
-            <a:off x="1023797" y="2423972"/>
-            <a:ext cx="433329" cy="319029"/>
+          <a:xfrm xmlns:a="http://schemas.openxmlformats.org/drawingml/2006/main" flipV="1">
+            <a:off x="890447" y="2686248"/>
+            <a:ext cx="566679" cy="233304"/>
           </a:xfrm>
           <a:prstGeom xmlns:a="http://schemas.openxmlformats.org/drawingml/2006/main" prst="straightConnector1">
             <a:avLst/>
@@ -3108,32 +3134,6 @@
         <p:nvCxnSpPr>
           <p:cNvPr id="55" name=""/>
           <p:cNvCxnSpPr>
-            <a:stCxn xmlns:a="http://schemas.openxmlformats.org/drawingml/2006/main" id="10" idx="7"/>
-            <a:endCxn xmlns:a="http://schemas.openxmlformats.org/drawingml/2006/main" id="8" idx="3"/>
-          </p:cNvCxnSpPr>
-          <p:nvPr/>
-        </p:nvCxnSpPr>
-        <p:spPr>
-          <a:xfrm xmlns:a="http://schemas.openxmlformats.org/drawingml/2006/main" flipV="1">
-            <a:off x="890447" y="2971998"/>
-            <a:ext cx="566679" cy="233304"/>
-          </a:xfrm>
-          <a:prstGeom xmlns:a="http://schemas.openxmlformats.org/drawingml/2006/main" prst="straightConnector1">
-            <a:avLst/>
-          </a:prstGeom>
-          <a:ln xmlns:a="http://schemas.openxmlformats.org/drawingml/2006/main" w="19050">
-            <a:solidFill>
-              <a:srgbClr val="4F86C6"/>
-            </a:solidFill>
-            <a:prstDash val="solid"/>
-            <a:tailEnd type="none" w="med" len="med"/>
-          </a:ln>
-        </p:spPr>
-      </p:cxnSp>
-      <p:cxnSp>
-        <p:nvCxnSpPr>
-          <p:cNvPr id="56" name=""/>
-          <p:cNvCxnSpPr>
             <a:stCxn xmlns:a="http://schemas.openxmlformats.org/drawingml/2006/main" id="11" idx="2"/>
             <a:endCxn xmlns:a="http://schemas.openxmlformats.org/drawingml/2006/main" id="8" idx="6"/>
           </p:cNvCxnSpPr>
@@ -3141,7 +3141,7 @@
         </p:nvCxnSpPr>
         <p:spPr>
           <a:xfrm xmlns:a="http://schemas.openxmlformats.org/drawingml/2006/main" flipH="1" flipV="1">
-            <a:off x="1733550" y="2857500"/>
+            <a:off x="1733550" y="2571750"/>
             <a:ext cx="428625" cy="57150"/>
           </a:xfrm>
           <a:prstGeom xmlns:a="http://schemas.openxmlformats.org/drawingml/2006/main" prst="straightConnector1">
@@ -3161,18 +3161,18 @@
           <p:cNvPr id="15" name="">
             <a:extLst xmlns:a="http://schemas.openxmlformats.org/drawingml/2006/main">
               <a:ext uri="{FF2B5EF4-FFF2-40B4-BE49-F238E27FC236}">
-                <a16:creationId xmlns:a16="http://schemas.microsoft.com/office/drawing/2014/main" id="{B457B1C2-DF3A-4BF0-9610-558546FB799B}"/>
-              </a:ext>
-            </a:extLst>
-          </p:cNvPr>
-          <p:cNvSpPr>
-            <a:spLocks xmlns:a="http://schemas.openxmlformats.org/drawingml/2006/main" noGrp="1"/>
-          </p:cNvSpPr>
-          <p:nvPr/>
-        </p:nvSpPr>
-        <p:spPr>
-          <a:xfrm xmlns:a="http://schemas.openxmlformats.org/drawingml/2006/main">
-            <a:off x="4362450" y="2695575"/>
+                <a16:creationId xmlns:a16="http://schemas.microsoft.com/office/drawing/2014/main" id="{C939E2A6-60E2-4816-87E6-05561819A461}"/>
+              </a:ext>
+            </a:extLst>
+          </p:cNvPr>
+          <p:cNvSpPr>
+            <a:spLocks xmlns:a="http://schemas.openxmlformats.org/drawingml/2006/main" noGrp="1"/>
+          </p:cNvSpPr>
+          <p:nvPr/>
+        </p:nvSpPr>
+        <p:spPr>
+          <a:xfrm xmlns:a="http://schemas.openxmlformats.org/drawingml/2006/main">
+            <a:off x="4362450" y="2409825"/>
             <a:ext cx="323850" cy="323850"/>
           </a:xfrm>
           <a:prstGeom xmlns:a="http://schemas.openxmlformats.org/drawingml/2006/main" prst="ellipse">
@@ -3194,18 +3194,18 @@
           <p:cNvPr id="16" name="">
             <a:extLst xmlns:a="http://schemas.openxmlformats.org/drawingml/2006/main">
               <a:ext uri="{FF2B5EF4-FFF2-40B4-BE49-F238E27FC236}">
-                <a16:creationId xmlns:a16="http://schemas.microsoft.com/office/drawing/2014/main" id="{FA988209-EF57-4019-94BC-C13ABDE1308C}"/>
-              </a:ext>
-            </a:extLst>
-          </p:cNvPr>
-          <p:cNvSpPr>
-            <a:spLocks xmlns:a="http://schemas.openxmlformats.org/drawingml/2006/main" noGrp="1"/>
-          </p:cNvSpPr>
-          <p:nvPr/>
-        </p:nvSpPr>
-        <p:spPr>
-          <a:xfrm xmlns:a="http://schemas.openxmlformats.org/drawingml/2006/main">
-            <a:off x="3667125" y="2343150"/>
+                <a16:creationId xmlns:a16="http://schemas.microsoft.com/office/drawing/2014/main" id="{1E346C81-8DD2-4286-881D-19FF2A4E5861}"/>
+              </a:ext>
+            </a:extLst>
+          </p:cNvPr>
+          <p:cNvSpPr>
+            <a:spLocks xmlns:a="http://schemas.openxmlformats.org/drawingml/2006/main" noGrp="1"/>
+          </p:cNvSpPr>
+          <p:nvPr/>
+        </p:nvSpPr>
+        <p:spPr>
+          <a:xfrm xmlns:a="http://schemas.openxmlformats.org/drawingml/2006/main">
+            <a:off x="3667125" y="2057400"/>
             <a:ext cx="228600" cy="228600"/>
           </a:xfrm>
           <a:prstGeom xmlns:a="http://schemas.openxmlformats.org/drawingml/2006/main" prst="ellipse">
@@ -3224,7 +3224,7 @@
       </p:sp>
       <p:cxnSp>
         <p:nvCxnSpPr>
-          <p:cNvPr id="59" name=""/>
+          <p:cNvPr id="58" name=""/>
           <p:cNvCxnSpPr>
             <a:stCxn xmlns:a="http://schemas.openxmlformats.org/drawingml/2006/main" id="16" idx="5"/>
             <a:endCxn xmlns:a="http://schemas.openxmlformats.org/drawingml/2006/main" id="15" idx="1"/>
@@ -3233,7 +3233,7 @@
         </p:nvCxnSpPr>
         <p:spPr>
           <a:xfrm xmlns:a="http://schemas.openxmlformats.org/drawingml/2006/main">
-            <a:off x="3862247" y="2538272"/>
+            <a:off x="3862247" y="2252522"/>
             <a:ext cx="547629" cy="204729"/>
           </a:xfrm>
           <a:prstGeom xmlns:a="http://schemas.openxmlformats.org/drawingml/2006/main" prst="straightConnector1">
@@ -3253,18 +3253,18 @@
           <p:cNvPr id="18" name="">
             <a:extLst xmlns:a="http://schemas.openxmlformats.org/drawingml/2006/main">
               <a:ext uri="{FF2B5EF4-FFF2-40B4-BE49-F238E27FC236}">
-                <a16:creationId xmlns:a16="http://schemas.microsoft.com/office/drawing/2014/main" id="{0DE520A8-176F-4E6B-85AC-B21D72857C9E}"/>
-              </a:ext>
-            </a:extLst>
-          </p:cNvPr>
-          <p:cNvSpPr>
-            <a:spLocks xmlns:a="http://schemas.openxmlformats.org/drawingml/2006/main" noGrp="1"/>
-          </p:cNvSpPr>
-          <p:nvPr/>
-        </p:nvSpPr>
-        <p:spPr>
-          <a:xfrm xmlns:a="http://schemas.openxmlformats.org/drawingml/2006/main">
-            <a:off x="3667125" y="3200400"/>
+                <a16:creationId xmlns:a16="http://schemas.microsoft.com/office/drawing/2014/main" id="{AD79CFFE-C77D-40EA-9A87-311083F5E383}"/>
+              </a:ext>
+            </a:extLst>
+          </p:cNvPr>
+          <p:cNvSpPr>
+            <a:spLocks xmlns:a="http://schemas.openxmlformats.org/drawingml/2006/main" noGrp="1"/>
+          </p:cNvSpPr>
+          <p:nvPr/>
+        </p:nvSpPr>
+        <p:spPr>
+          <a:xfrm xmlns:a="http://schemas.openxmlformats.org/drawingml/2006/main">
+            <a:off x="3667125" y="2914650"/>
             <a:ext cx="228600" cy="228600"/>
           </a:xfrm>
           <a:prstGeom xmlns:a="http://schemas.openxmlformats.org/drawingml/2006/main" prst="ellipse">
@@ -3283,7 +3283,7 @@
       </p:sp>
       <p:cxnSp>
         <p:nvCxnSpPr>
-          <p:cNvPr id="61" name=""/>
+          <p:cNvPr id="60" name=""/>
           <p:cNvCxnSpPr>
             <a:stCxn xmlns:a="http://schemas.openxmlformats.org/drawingml/2006/main" id="18" idx="7"/>
             <a:endCxn xmlns:a="http://schemas.openxmlformats.org/drawingml/2006/main" id="15" idx="3"/>
@@ -3292,7 +3292,7 @@
         </p:nvCxnSpPr>
         <p:spPr>
           <a:xfrm xmlns:a="http://schemas.openxmlformats.org/drawingml/2006/main" flipV="1">
-            <a:off x="3862247" y="2971998"/>
+            <a:off x="3862247" y="2686248"/>
             <a:ext cx="547629" cy="261879"/>
           </a:xfrm>
           <a:prstGeom xmlns:a="http://schemas.openxmlformats.org/drawingml/2006/main" prst="straightConnector1">
@@ -3312,18 +3312,18 @@
           <p:cNvPr id="20" name="">
             <a:extLst xmlns:a="http://schemas.openxmlformats.org/drawingml/2006/main">
               <a:ext uri="{FF2B5EF4-FFF2-40B4-BE49-F238E27FC236}">
-                <a16:creationId xmlns:a16="http://schemas.microsoft.com/office/drawing/2014/main" id="{F8BC5628-7819-4A37-89D8-086F8E0D1447}"/>
-              </a:ext>
-            </a:extLst>
-          </p:cNvPr>
-          <p:cNvSpPr>
-            <a:spLocks xmlns:a="http://schemas.openxmlformats.org/drawingml/2006/main" noGrp="1"/>
-          </p:cNvSpPr>
-          <p:nvPr/>
-        </p:nvSpPr>
-        <p:spPr>
-          <a:xfrm xmlns:a="http://schemas.openxmlformats.org/drawingml/2006/main">
-            <a:off x="5124450" y="2647950"/>
+                <a16:creationId xmlns:a16="http://schemas.microsoft.com/office/drawing/2014/main" id="{E2A7C548-E8FA-4F23-8C0A-FC06E8798935}"/>
+              </a:ext>
+            </a:extLst>
+          </p:cNvPr>
+          <p:cNvSpPr>
+            <a:spLocks xmlns:a="http://schemas.openxmlformats.org/drawingml/2006/main" noGrp="1"/>
+          </p:cNvSpPr>
+          <p:nvPr/>
+        </p:nvSpPr>
+        <p:spPr>
+          <a:xfrm xmlns:a="http://schemas.openxmlformats.org/drawingml/2006/main">
+            <a:off x="5124450" y="2362200"/>
             <a:ext cx="228600" cy="228600"/>
           </a:xfrm>
           <a:prstGeom xmlns:a="http://schemas.openxmlformats.org/drawingml/2006/main" prst="ellipse">
@@ -3342,7 +3342,7 @@
       </p:sp>
       <p:cxnSp>
         <p:nvCxnSpPr>
-          <p:cNvPr id="63" name=""/>
+          <p:cNvPr id="62" name=""/>
           <p:cNvCxnSpPr>
             <a:stCxn xmlns:a="http://schemas.openxmlformats.org/drawingml/2006/main" id="20" idx="2"/>
             <a:endCxn xmlns:a="http://schemas.openxmlformats.org/drawingml/2006/main" id="15" idx="6"/>
@@ -3351,7 +3351,7 @@
         </p:nvCxnSpPr>
         <p:spPr>
           <a:xfrm xmlns:a="http://schemas.openxmlformats.org/drawingml/2006/main" flipH="1">
-            <a:off x="4686300" y="2762250"/>
+            <a:off x="4686300" y="2476500"/>
             <a:ext cx="438150" cy="95250"/>
           </a:xfrm>
           <a:prstGeom xmlns:a="http://schemas.openxmlformats.org/drawingml/2006/main" prst="straightConnector1">
@@ -3371,18 +3371,18 @@
           <p:cNvPr id="22" name="">
             <a:extLst xmlns:a="http://schemas.openxmlformats.org/drawingml/2006/main">
               <a:ext uri="{FF2B5EF4-FFF2-40B4-BE49-F238E27FC236}">
-                <a16:creationId xmlns:a16="http://schemas.microsoft.com/office/drawing/2014/main" id="{B52D1A84-4579-4AC1-8C95-AC6B33915FA5}"/>
-              </a:ext>
-            </a:extLst>
-          </p:cNvPr>
-          <p:cNvSpPr>
-            <a:spLocks xmlns:a="http://schemas.openxmlformats.org/drawingml/2006/main" noGrp="1"/>
-          </p:cNvSpPr>
-          <p:nvPr/>
-        </p:nvSpPr>
-        <p:spPr>
-          <a:xfrm xmlns:a="http://schemas.openxmlformats.org/drawingml/2006/main">
-            <a:off x="7000875" y="2076450"/>
+                <a16:creationId xmlns:a16="http://schemas.microsoft.com/office/drawing/2014/main" id="{560171DA-9520-47E1-B8F3-64EF16211C38}"/>
+              </a:ext>
+            </a:extLst>
+          </p:cNvPr>
+          <p:cNvSpPr>
+            <a:spLocks xmlns:a="http://schemas.openxmlformats.org/drawingml/2006/main" noGrp="1"/>
+          </p:cNvSpPr>
+          <p:nvPr/>
+        </p:nvSpPr>
+        <p:spPr>
+          <a:xfrm xmlns:a="http://schemas.openxmlformats.org/drawingml/2006/main">
+            <a:off x="7000875" y="1790700"/>
             <a:ext cx="1047750" cy="400050"/>
           </a:xfrm>
           <a:prstGeom xmlns:a="http://schemas.openxmlformats.org/drawingml/2006/main" prst="roundRect">
@@ -3435,18 +3435,18 @@
           <p:cNvPr id="23" name="">
             <a:extLst xmlns:a="http://schemas.openxmlformats.org/drawingml/2006/main">
               <a:ext uri="{FF2B5EF4-FFF2-40B4-BE49-F238E27FC236}">
-                <a16:creationId xmlns:a16="http://schemas.microsoft.com/office/drawing/2014/main" id="{DD687C9C-4C62-4073-A867-6B7AEFB4864A}"/>
-              </a:ext>
-            </a:extLst>
-          </p:cNvPr>
-          <p:cNvSpPr>
-            <a:spLocks xmlns:a="http://schemas.openxmlformats.org/drawingml/2006/main" noGrp="1"/>
-          </p:cNvSpPr>
-          <p:nvPr/>
-        </p:nvSpPr>
-        <p:spPr>
-          <a:xfrm xmlns:a="http://schemas.openxmlformats.org/drawingml/2006/main">
-            <a:off x="7000875" y="2886075"/>
+                <a16:creationId xmlns:a16="http://schemas.microsoft.com/office/drawing/2014/main" id="{8459521A-E483-4DEB-9DC3-2C01AA5B52CD}"/>
+              </a:ext>
+            </a:extLst>
+          </p:cNvPr>
+          <p:cNvSpPr>
+            <a:spLocks xmlns:a="http://schemas.openxmlformats.org/drawingml/2006/main" noGrp="1"/>
+          </p:cNvSpPr>
+          <p:nvPr/>
+        </p:nvSpPr>
+        <p:spPr>
+          <a:xfrm xmlns:a="http://schemas.openxmlformats.org/drawingml/2006/main">
+            <a:off x="7000875" y="2600325"/>
             <a:ext cx="1047750" cy="523875"/>
           </a:xfrm>
           <a:prstGeom xmlns:a="http://schemas.openxmlformats.org/drawingml/2006/main" prst="roundRect">
@@ -3496,7 +3496,7 @@
       </p:sp>
       <p:cxnSp>
         <p:nvCxnSpPr>
-          <p:cNvPr id="66" name=""/>
+          <p:cNvPr id="65" name=""/>
           <p:cNvCxnSpPr>
             <a:stCxn xmlns:a="http://schemas.openxmlformats.org/drawingml/2006/main" id="22" idx="2"/>
             <a:endCxn xmlns:a="http://schemas.openxmlformats.org/drawingml/2006/main" id="23" idx="0"/>
@@ -3505,7 +3505,7 @@
         </p:nvCxnSpPr>
         <p:spPr>
           <a:xfrm xmlns:a="http://schemas.openxmlformats.org/drawingml/2006/main">
-            <a:off x="7524750" y="2476500"/>
+            <a:off x="7524750" y="2190750"/>
             <a:ext cx="0" cy="409575"/>
           </a:xfrm>
           <a:prstGeom xmlns:a="http://schemas.openxmlformats.org/drawingml/2006/main" prst="straightConnector1">
@@ -3522,7 +3522,7 @@
       </p:cxnSp>
       <p:cxnSp>
         <p:nvCxnSpPr>
-          <p:cNvPr id="67" name=""/>
+          <p:cNvPr id="66" name=""/>
           <p:cNvCxnSpPr>
             <a:stCxn xmlns:a="http://schemas.openxmlformats.org/drawingml/2006/main" id="23" idx="3"/>
             <a:endCxn xmlns:a="http://schemas.openxmlformats.org/drawingml/2006/main" id="22" idx="3"/>
@@ -3531,7 +3531,7 @@
         </p:nvCxnSpPr>
         <p:spPr>
           <a:xfrm xmlns:a="http://schemas.openxmlformats.org/drawingml/2006/main" flipV="1">
-            <a:off x="8048625" y="2276475"/>
+            <a:off x="8048625" y="1990725"/>
             <a:ext cx="0" cy="871538"/>
           </a:xfrm>
           <a:prstGeom xmlns:a="http://schemas.openxmlformats.org/drawingml/2006/main" prst="curvedConnector2">
@@ -3551,7 +3551,7 @@
           <p:cNvPr id="26" name="">
             <a:extLst xmlns:a="http://schemas.openxmlformats.org/drawingml/2006/main">
               <a:ext uri="{FF2B5EF4-FFF2-40B4-BE49-F238E27FC236}">
-                <a16:creationId xmlns:a16="http://schemas.microsoft.com/office/drawing/2014/main" id="{A7832D3A-23CA-4335-AC5C-BE4E740EA928}"/>
+                <a16:creationId xmlns:a16="http://schemas.microsoft.com/office/drawing/2014/main" id="{EEDDFCBE-FE49-4AC5-843F-D3586A805B56}"/>
               </a:ext>
             </a:extLst>
           </p:cNvPr>
@@ -3584,7 +3584,7 @@
           <p:cNvPr id="27" name="">
             <a:extLst xmlns:a="http://schemas.openxmlformats.org/drawingml/2006/main">
               <a:ext uri="{FF2B5EF4-FFF2-40B4-BE49-F238E27FC236}">
-                <a16:creationId xmlns:a16="http://schemas.microsoft.com/office/drawing/2014/main" id="{7731D41D-B890-49A3-94D6-6C2D9B68B81B}"/>
+                <a16:creationId xmlns:a16="http://schemas.microsoft.com/office/drawing/2014/main" id="{75D3D16A-A9F8-4DF6-AB4F-4268ACE8726F}"/>
               </a:ext>
             </a:extLst>
           </p:cNvPr>
@@ -3617,7 +3617,7 @@
           <p:cNvPr id="28" name="">
             <a:extLst xmlns:a="http://schemas.openxmlformats.org/drawingml/2006/main">
               <a:ext uri="{FF2B5EF4-FFF2-40B4-BE49-F238E27FC236}">
-                <a16:creationId xmlns:a16="http://schemas.microsoft.com/office/drawing/2014/main" id="{31CADB0C-83D3-48E7-AFC8-C8676AA826E6}"/>
+                <a16:creationId xmlns:a16="http://schemas.microsoft.com/office/drawing/2014/main" id="{7E3B2FDB-B919-4F02-9816-B85C3AC59A90}"/>
               </a:ext>
             </a:extLst>
           </p:cNvPr>
@@ -3650,7 +3650,7 @@
           <p:cNvPr id="29" name="">
             <a:extLst xmlns:a="http://schemas.openxmlformats.org/drawingml/2006/main">
               <a:ext uri="{FF2B5EF4-FFF2-40B4-BE49-F238E27FC236}">
-                <a16:creationId xmlns:a16="http://schemas.microsoft.com/office/drawing/2014/main" id="{5B19B4F9-C297-47B1-B7B6-869C6D0FCEBC}"/>
+                <a16:creationId xmlns:a16="http://schemas.microsoft.com/office/drawing/2014/main" id="{C5974443-B392-4F89-A389-F0D067A83427}"/>
               </a:ext>
             </a:extLst>
           </p:cNvPr>
@@ -3683,7 +3683,7 @@
           <p:cNvPr id="30" name="">
             <a:extLst xmlns:a="http://schemas.openxmlformats.org/drawingml/2006/main">
               <a:ext uri="{FF2B5EF4-FFF2-40B4-BE49-F238E27FC236}">
-                <a16:creationId xmlns:a16="http://schemas.microsoft.com/office/drawing/2014/main" id="{397B380A-50EC-420D-A6C8-3A30EF96A52F}"/>
+                <a16:creationId xmlns:a16="http://schemas.microsoft.com/office/drawing/2014/main" id="{63A33B1E-C446-4662-9AEF-F7A0262CD7B3}"/>
               </a:ext>
             </a:extLst>
           </p:cNvPr>
@@ -3709,19 +3709,45 @@
           </a:ln>
         </p:spPr>
       </p:sp>
+      <p:cxnSp>
+        <p:nvCxnSpPr>
+          <p:cNvPr id="72" name=""/>
+          <p:cNvCxnSpPr>
+            <a:stCxn xmlns:a="http://schemas.openxmlformats.org/drawingml/2006/main" id="26" idx="7"/>
+            <a:endCxn xmlns:a="http://schemas.openxmlformats.org/drawingml/2006/main" id="27" idx="3"/>
+          </p:cNvCxnSpPr>
+          <p:nvPr/>
+        </p:nvCxnSpPr>
+        <p:spPr>
+          <a:xfrm xmlns:a="http://schemas.openxmlformats.org/drawingml/2006/main" flipV="1">
+            <a:off x="9688757" y="2576372"/>
+            <a:ext cx="441220" cy="193570"/>
+          </a:xfrm>
+          <a:prstGeom xmlns:a="http://schemas.openxmlformats.org/drawingml/2006/main" prst="straightConnector1">
+            <a:avLst/>
+          </a:prstGeom>
+          <a:ln xmlns:a="http://schemas.openxmlformats.org/drawingml/2006/main" w="38100">
+            <a:solidFill>
+              <a:srgbClr val="398D84"/>
+            </a:solidFill>
+            <a:prstDash val="solid"/>
+            <a:tailEnd type="triangle" w="sm" len="sm"/>
+          </a:ln>
+        </p:spPr>
+      </p:cxnSp>
       <p:cxnSp>
         <p:nvCxnSpPr>
           <p:cNvPr id="73" name=""/>
           <p:cNvCxnSpPr>
-            <a:stCxn xmlns:a="http://schemas.openxmlformats.org/drawingml/2006/main" id="26" idx="7"/>
-            <a:endCxn xmlns:a="http://schemas.openxmlformats.org/drawingml/2006/main" id="27" idx="3"/>
+            <a:stCxn xmlns:a="http://schemas.openxmlformats.org/drawingml/2006/main" id="27" idx="5"/>
+            <a:endCxn xmlns:a="http://schemas.openxmlformats.org/drawingml/2006/main" id="28" idx="1"/>
           </p:cNvCxnSpPr>
           <p:nvPr/>
         </p:nvCxnSpPr>
         <p:spPr>
-          <a:xfrm xmlns:a="http://schemas.openxmlformats.org/drawingml/2006/main" flipV="1">
-            <a:off x="9688757" y="2576372"/>
-            <a:ext cx="441220" cy="193570"/>
+          <a:xfrm xmlns:a="http://schemas.openxmlformats.org/drawingml/2006/main">
+            <a:off x="10291622" y="2576372"/>
+            <a:ext cx="447955" cy="247930"/>
           </a:xfrm>
           <a:prstGeom xmlns:a="http://schemas.openxmlformats.org/drawingml/2006/main" prst="straightConnector1">
             <a:avLst/>
@@ -3739,32 +3765,6 @@
         <p:nvCxnSpPr>
           <p:cNvPr id="74" name=""/>
           <p:cNvCxnSpPr>
-            <a:stCxn xmlns:a="http://schemas.openxmlformats.org/drawingml/2006/main" id="27" idx="5"/>
-            <a:endCxn xmlns:a="http://schemas.openxmlformats.org/drawingml/2006/main" id="28" idx="1"/>
-          </p:cNvCxnSpPr>
-          <p:nvPr/>
-        </p:nvCxnSpPr>
-        <p:spPr>
-          <a:xfrm xmlns:a="http://schemas.openxmlformats.org/drawingml/2006/main">
-            <a:off x="10291622" y="2576372"/>
-            <a:ext cx="447955" cy="247930"/>
-          </a:xfrm>
-          <a:prstGeom xmlns:a="http://schemas.openxmlformats.org/drawingml/2006/main" prst="straightConnector1">
-            <a:avLst/>
-          </a:prstGeom>
-          <a:ln xmlns:a="http://schemas.openxmlformats.org/drawingml/2006/main" w="38100">
-            <a:solidFill>
-              <a:srgbClr val="398D84"/>
-            </a:solidFill>
-            <a:prstDash val="solid"/>
-            <a:tailEnd type="triangle" w="sm" len="sm"/>
-          </a:ln>
-        </p:spPr>
-      </p:cxnSp>
-      <p:cxnSp>
-        <p:nvCxnSpPr>
-          <p:cNvPr id="75" name=""/>
-          <p:cNvCxnSpPr>
             <a:stCxn xmlns:a="http://schemas.openxmlformats.org/drawingml/2006/main" id="28" idx="7"/>
             <a:endCxn xmlns:a="http://schemas.openxmlformats.org/drawingml/2006/main" id="29" idx="3"/>
           </p:cNvCxnSpPr>
@@ -3792,7 +3792,7 @@
           <p:cNvPr id="34" name="">
             <a:extLst xmlns:a="http://schemas.openxmlformats.org/drawingml/2006/main">
               <a:ext uri="{FF2B5EF4-FFF2-40B4-BE49-F238E27FC236}">
-                <a16:creationId xmlns:a16="http://schemas.microsoft.com/office/drawing/2014/main" id="{1C3146C1-89C0-4AC2-96AD-6B8AAA6887D8}"/>
+                <a16:creationId xmlns:a16="http://schemas.microsoft.com/office/drawing/2014/main" id="{27439BE3-C644-4AA4-B7B5-CE0771AEFB63}"/>
               </a:ext>
             </a:extLst>
           </p:cNvPr>
@@ -3873,7 +3873,7 @@
           <p:cNvPr id="35" name="">
             <a:extLst xmlns:a="http://schemas.openxmlformats.org/drawingml/2006/main">
               <a:ext uri="{FF2B5EF4-FFF2-40B4-BE49-F238E27FC236}">
-                <a16:creationId xmlns:a16="http://schemas.microsoft.com/office/drawing/2014/main" id="{12C28090-3A42-4522-BA25-A8D9BA9D24F8}"/>
+                <a16:creationId xmlns:a16="http://schemas.microsoft.com/office/drawing/2014/main" id="{D53CC2B2-6E43-4295-8B26-64879207789A}"/>
               </a:ext>
             </a:extLst>
           </p:cNvPr>
@@ -3931,7 +3931,7 @@
           <p:cNvPr id="36" name="">
             <a:extLst xmlns:a="http://schemas.openxmlformats.org/drawingml/2006/main">
               <a:ext uri="{FF2B5EF4-FFF2-40B4-BE49-F238E27FC236}">
-                <a16:creationId xmlns:a16="http://schemas.microsoft.com/office/drawing/2014/main" id="{8C4F4AB6-BFA5-4A5A-AA50-644ECCB2F426}"/>
+                <a16:creationId xmlns:a16="http://schemas.microsoft.com/office/drawing/2014/main" id="{0E7D518D-9642-448B-B024-9135290397CA}"/>
               </a:ext>
             </a:extLst>
           </p:cNvPr>
@@ -4012,7 +4012,7 @@
           <p:cNvPr id="37" name="">
             <a:extLst xmlns:a="http://schemas.openxmlformats.org/drawingml/2006/main">
               <a:ext uri="{FF2B5EF4-FFF2-40B4-BE49-F238E27FC236}">
-                <a16:creationId xmlns:a16="http://schemas.microsoft.com/office/drawing/2014/main" id="{1CA537B1-A8B3-430A-9A85-DA0ACFCF1D7D}"/>
+                <a16:creationId xmlns:a16="http://schemas.microsoft.com/office/drawing/2014/main" id="{C19F8455-A36F-4D3C-86CA-C7322A48717E}"/>
               </a:ext>
             </a:extLst>
           </p:cNvPr>
@@ -4093,7 +4093,7 @@
           <p:cNvPr id="38" name="">
             <a:extLst xmlns:a="http://schemas.openxmlformats.org/drawingml/2006/main">
               <a:ext uri="{FF2B5EF4-FFF2-40B4-BE49-F238E27FC236}">
-                <a16:creationId xmlns:a16="http://schemas.microsoft.com/office/drawing/2014/main" id="{4F29068B-D355-4A97-BECF-46761D34464C}"/>
+                <a16:creationId xmlns:a16="http://schemas.microsoft.com/office/drawing/2014/main" id="{612380C6-7BEA-4E11-9BBF-E260C9757B71}"/>
               </a:ext>
             </a:extLst>
           </p:cNvPr>
@@ -4174,7 +4174,7 @@
           <p:cNvPr id="39" name="">
             <a:extLst xmlns:a="http://schemas.openxmlformats.org/drawingml/2006/main">
               <a:ext uri="{FF2B5EF4-FFF2-40B4-BE49-F238E27FC236}">
-                <a16:creationId xmlns:a16="http://schemas.microsoft.com/office/drawing/2014/main" id="{DED5E9D4-E6FC-4428-8043-0C76CBC4C8F4}"/>
+                <a16:creationId xmlns:a16="http://schemas.microsoft.com/office/drawing/2014/main" id="{CE9DC8F5-5471-4C7C-B221-4F164D472C83}"/>
               </a:ext>
             </a:extLst>
           </p:cNvPr>
@@ -4232,7 +4232,7 @@
           <p:cNvPr id="40" name="">
             <a:extLst xmlns:a="http://schemas.openxmlformats.org/drawingml/2006/main">
               <a:ext uri="{FF2B5EF4-FFF2-40B4-BE49-F238E27FC236}">
-                <a16:creationId xmlns:a16="http://schemas.microsoft.com/office/drawing/2014/main" id="{C3F62B6A-12E6-4956-BDB1-796FFD126875}"/>
+                <a16:creationId xmlns:a16="http://schemas.microsoft.com/office/drawing/2014/main" id="{5200B361-4255-4369-A8E6-CC8838046C97}"/>
               </a:ext>
             </a:extLst>
           </p:cNvPr>
@@ -4313,7 +4313,7 @@
           <p:cNvPr id="41" name="">
             <a:extLst xmlns:a="http://schemas.openxmlformats.org/drawingml/2006/main">
               <a:ext uri="{FF2B5EF4-FFF2-40B4-BE49-F238E27FC236}">
-                <a16:creationId xmlns:a16="http://schemas.microsoft.com/office/drawing/2014/main" id="{0C8E2418-3C1A-4013-80EB-C14DBCE28978}"/>
+                <a16:creationId xmlns:a16="http://schemas.microsoft.com/office/drawing/2014/main" id="{B91C9528-8B10-49B5-A588-67AAAE045C62}"/>
               </a:ext>
             </a:extLst>
           </p:cNvPr>
@@ -4366,68 +4366,10 @@
           </a:p>
         </p:txBody>
       </p:sp>
-      <p:sp>
-        <p:nvSpPr>
-          <p:cNvPr id="42" name="">
-            <a:extLst xmlns:a="http://schemas.openxmlformats.org/drawingml/2006/main">
-              <a:ext uri="{FF2B5EF4-FFF2-40B4-BE49-F238E27FC236}">
-                <a16:creationId xmlns:a16="http://schemas.microsoft.com/office/drawing/2014/main" id="{085EF85D-CA4A-47A2-B78E-946CD4532489}"/>
-              </a:ext>
-            </a:extLst>
-          </p:cNvPr>
-          <p:cNvSpPr>
-            <a:spLocks xmlns:a="http://schemas.openxmlformats.org/drawingml/2006/main" noGrp="1"/>
-          </p:cNvSpPr>
-          <p:nvPr/>
-        </p:nvSpPr>
-        <p:spPr>
-          <a:xfrm xmlns:a="http://schemas.openxmlformats.org/drawingml/2006/main">
-            <a:off x="1619250" y="5905500"/>
-            <a:ext cx="8953500" cy="381000"/>
-          </a:xfrm>
-          <a:prstGeom xmlns:a="http://schemas.openxmlformats.org/drawingml/2006/main" prst="rect">
-            <a:avLst/>
-          </a:prstGeom>
-          <a:noFill xmlns:a="http://schemas.openxmlformats.org/drawingml/2006/main"/>
-          <a:ln xmlns:a="http://schemas.openxmlformats.org/drawingml/2006/main" w="0">
-            <a:noFill/>
-            <a:prstDash val="solid"/>
-          </a:ln>
-        </p:spPr>
-        <p:txBody>
-          <a:bodyPr xmlns:a="http://schemas.openxmlformats.org/drawingml/2006/main" wrap="square" lIns="38100" tIns="19050" rIns="38100" bIns="19050" anchor="ctr">
-            <a:normAutofit fontScale="100000"/>
-          </a:bodyPr>
-          <a:lstStyle xmlns:a="http://schemas.openxmlformats.org/drawingml/2006/main"/>
-          <a:p xmlns:a="http://schemas.openxmlformats.org/drawingml/2006/main">
-            <a:pPr algn="ctr">
-              <a:defRPr sz="1800" b="1">
-                <a:solidFill>
-                  <a:srgbClr val="263746"/>
-                </a:solidFill>
-                <a:latin typeface="Arial"/>
-                <a:ea typeface="Arial"/>
-                <a:cs typeface="Arial"/>
-              </a:defRPr>
-            </a:pPr>
-            <a:r>
-              <a:rPr sz="1800" b="1">
-                <a:solidFill>
-                  <a:srgbClr val="263746"/>
-                </a:solidFill>
-                <a:latin typeface="Arial"/>
-                <a:ea typeface="Arial"/>
-                <a:cs typeface="Arial"/>
-              </a:rPr>
-              <a:t>Од локална агрегација кон расудување по патеки условени од прашањето</a:t>
-            </a:r>
-          </a:p>
-        </p:txBody>
-      </p:sp>
     </p:spTree>
     <p:extLst>
       <p:ext uri="{BB962C8B-B14F-4D97-AF65-F5344CB8AC3E}">
-        <p14:creationId xmlns:p14="http://schemas.microsoft.com/office/powerpoint/2010/main" val="290618978"/>
+        <p14:creationId xmlns:p14="http://schemas.microsoft.com/office/powerpoint/2010/main" val="444602457"/>
       </p:ext>
     </p:extLst>
   </p:cSld>
@@ -4458,7 +4400,7 @@
           <p:cNvPr id="41" name="">
             <a:extLst xmlns:a="http://schemas.openxmlformats.org/drawingml/2006/main">
               <a:ext uri="{FF2B5EF4-FFF2-40B4-BE49-F238E27FC236}">
-                <a16:creationId xmlns:a16="http://schemas.microsoft.com/office/drawing/2014/main" id="{52F639E1-69B8-43ED-9DFA-62CC48A66144}"/>
+                <a16:creationId xmlns:a16="http://schemas.microsoft.com/office/drawing/2014/main" id="{B53AC275-CB3A-4C96-81AC-C9EC2D809D10}"/>
               </a:ext>
             </a:extLst>
           </p:cNvPr>
@@ -4516,7 +4458,7 @@
           <p:cNvPr id="2" name="">
             <a:extLst xmlns:a="http://schemas.openxmlformats.org/drawingml/2006/main">
               <a:ext uri="{FF2B5EF4-FFF2-40B4-BE49-F238E27FC236}">
-                <a16:creationId xmlns:a16="http://schemas.microsoft.com/office/drawing/2014/main" id="{D7A793C0-D3F1-410A-8635-273BCA01418A}"/>
+                <a16:creationId xmlns:a16="http://schemas.microsoft.com/office/drawing/2014/main" id="{2EA59745-9B84-4A04-8DD2-4C81E0C6AE0B}"/>
               </a:ext>
             </a:extLst>
           </p:cNvPr>
@@ -4574,7 +4516,7 @@
           <p:cNvPr id="3" name="">
             <a:extLst xmlns:a="http://schemas.openxmlformats.org/drawingml/2006/main">
               <a:ext uri="{FF2B5EF4-FFF2-40B4-BE49-F238E27FC236}">
-                <a16:creationId xmlns:a16="http://schemas.microsoft.com/office/drawing/2014/main" id="{EEF91E60-82F4-427D-8440-D6AE287071C5}"/>
+                <a16:creationId xmlns:a16="http://schemas.microsoft.com/office/drawing/2014/main" id="{D744AB56-5CEC-471B-BCF2-C4FC32D4B4D4}"/>
               </a:ext>
             </a:extLst>
           </p:cNvPr>
@@ -4605,7 +4547,7 @@
           <p:cNvPr id="4" name="">
             <a:extLst xmlns:a="http://schemas.openxmlformats.org/drawingml/2006/main">
               <a:ext uri="{FF2B5EF4-FFF2-40B4-BE49-F238E27FC236}">
-                <a16:creationId xmlns:a16="http://schemas.microsoft.com/office/drawing/2014/main" id="{1C7DC87C-8E0E-40A0-AA21-5B6151C4972C}"/>
+                <a16:creationId xmlns:a16="http://schemas.microsoft.com/office/drawing/2014/main" id="{FD7B6357-6940-4BA1-8BC6-C0D1E88A105E}"/>
               </a:ext>
             </a:extLst>
           </p:cNvPr>
@@ -4669,7 +4611,7 @@
           <p:cNvPr id="5" name="">
             <a:extLst xmlns:a="http://schemas.openxmlformats.org/drawingml/2006/main">
               <a:ext uri="{FF2B5EF4-FFF2-40B4-BE49-F238E27FC236}">
-                <a16:creationId xmlns:a16="http://schemas.microsoft.com/office/drawing/2014/main" id="{547469B5-FD90-4458-98AA-EF39EA813A89}"/>
+                <a16:creationId xmlns:a16="http://schemas.microsoft.com/office/drawing/2014/main" id="{3C309931-097E-48AD-A878-225631A28830}"/>
               </a:ext>
             </a:extLst>
           </p:cNvPr>
@@ -4759,7 +4701,7 @@
           <p:cNvPr id="7" name="">
             <a:extLst xmlns:a="http://schemas.openxmlformats.org/drawingml/2006/main">
               <a:ext uri="{FF2B5EF4-FFF2-40B4-BE49-F238E27FC236}">
-                <a16:creationId xmlns:a16="http://schemas.microsoft.com/office/drawing/2014/main" id="{CAA63C29-5C65-4D9B-9322-F43CD4072B92}"/>
+                <a16:creationId xmlns:a16="http://schemas.microsoft.com/office/drawing/2014/main" id="{D9D81743-8B40-4548-BF78-5B189A5A0657}"/>
               </a:ext>
             </a:extLst>
           </p:cNvPr>
@@ -4792,7 +4734,7 @@
           <p:cNvPr id="8" name="">
             <a:extLst xmlns:a="http://schemas.openxmlformats.org/drawingml/2006/main">
               <a:ext uri="{FF2B5EF4-FFF2-40B4-BE49-F238E27FC236}">
-                <a16:creationId xmlns:a16="http://schemas.microsoft.com/office/drawing/2014/main" id="{C6084071-E944-4085-8271-8823937B9956}"/>
+                <a16:creationId xmlns:a16="http://schemas.microsoft.com/office/drawing/2014/main" id="{A4AA7239-1E1C-4AEE-BB3C-2500978CDCB4}"/>
               </a:ext>
             </a:extLst>
           </p:cNvPr>
@@ -4851,7 +4793,7 @@
           <p:cNvPr id="10" name="">
             <a:extLst xmlns:a="http://schemas.openxmlformats.org/drawingml/2006/main">
               <a:ext uri="{FF2B5EF4-FFF2-40B4-BE49-F238E27FC236}">
-                <a16:creationId xmlns:a16="http://schemas.microsoft.com/office/drawing/2014/main" id="{A5801260-BA23-4F8C-8C85-F6EAFF023280}"/>
+                <a16:creationId xmlns:a16="http://schemas.microsoft.com/office/drawing/2014/main" id="{A64D4CFC-F487-4681-8A25-E47554FB2DE8}"/>
               </a:ext>
             </a:extLst>
           </p:cNvPr>
@@ -4909,7 +4851,7 @@
           <p:cNvPr id="11" name="">
             <a:extLst xmlns:a="http://schemas.openxmlformats.org/drawingml/2006/main">
               <a:ext uri="{FF2B5EF4-FFF2-40B4-BE49-F238E27FC236}">
-                <a16:creationId xmlns:a16="http://schemas.microsoft.com/office/drawing/2014/main" id="{33DB19FA-AF71-41EE-BA44-5155E6827090}"/>
+                <a16:creationId xmlns:a16="http://schemas.microsoft.com/office/drawing/2014/main" id="{8267E723-D69D-440C-9380-9113DB86CA4A}"/>
               </a:ext>
             </a:extLst>
           </p:cNvPr>
@@ -4968,7 +4910,7 @@
           <p:cNvPr id="13" name="">
             <a:extLst xmlns:a="http://schemas.openxmlformats.org/drawingml/2006/main">
               <a:ext uri="{FF2B5EF4-FFF2-40B4-BE49-F238E27FC236}">
-                <a16:creationId xmlns:a16="http://schemas.microsoft.com/office/drawing/2014/main" id="{7B8CB857-4A3A-418A-8DF8-EB4028282623}"/>
+                <a16:creationId xmlns:a16="http://schemas.microsoft.com/office/drawing/2014/main" id="{41C375AD-714D-4978-9CF5-3B64D8695020}"/>
               </a:ext>
             </a:extLst>
           </p:cNvPr>
@@ -5026,7 +4968,7 @@
           <p:cNvPr id="14" name="">
             <a:extLst xmlns:a="http://schemas.openxmlformats.org/drawingml/2006/main">
               <a:ext uri="{FF2B5EF4-FFF2-40B4-BE49-F238E27FC236}">
-                <a16:creationId xmlns:a16="http://schemas.microsoft.com/office/drawing/2014/main" id="{5D4ACC65-F8FC-434E-B62C-D36DAC70C496}"/>
+                <a16:creationId xmlns:a16="http://schemas.microsoft.com/office/drawing/2014/main" id="{E52F0DD6-3C72-46F5-914A-CC4C699D9C28}"/>
               </a:ext>
             </a:extLst>
           </p:cNvPr>
@@ -5085,7 +5027,7 @@
           <p:cNvPr id="16" name="">
             <a:extLst xmlns:a="http://schemas.openxmlformats.org/drawingml/2006/main">
               <a:ext uri="{FF2B5EF4-FFF2-40B4-BE49-F238E27FC236}">
-                <a16:creationId xmlns:a16="http://schemas.microsoft.com/office/drawing/2014/main" id="{49ACE465-E047-4313-8011-1C55CBC66CDD}"/>
+                <a16:creationId xmlns:a16="http://schemas.microsoft.com/office/drawing/2014/main" id="{4EF6FE35-C452-4300-A9F5-35F158AEFB3C}"/>
               </a:ext>
             </a:extLst>
           </p:cNvPr>
@@ -5143,7 +5085,7 @@
           <p:cNvPr id="17" name="">
             <a:extLst xmlns:a="http://schemas.openxmlformats.org/drawingml/2006/main">
               <a:ext uri="{FF2B5EF4-FFF2-40B4-BE49-F238E27FC236}">
-                <a16:creationId xmlns:a16="http://schemas.microsoft.com/office/drawing/2014/main" id="{BE550F9A-6854-4B7B-B919-476BF2FAF7D2}"/>
+                <a16:creationId xmlns:a16="http://schemas.microsoft.com/office/drawing/2014/main" id="{0DF54577-2806-4D5A-9228-4D7CFE81499B}"/>
               </a:ext>
             </a:extLst>
           </p:cNvPr>
@@ -5233,7 +5175,7 @@
           <p:cNvPr id="19" name="">
             <a:extLst xmlns:a="http://schemas.openxmlformats.org/drawingml/2006/main">
               <a:ext uri="{FF2B5EF4-FFF2-40B4-BE49-F238E27FC236}">
-                <a16:creationId xmlns:a16="http://schemas.microsoft.com/office/drawing/2014/main" id="{4BAAFC4E-00D9-4885-B182-AA73CED3A092}"/>
+                <a16:creationId xmlns:a16="http://schemas.microsoft.com/office/drawing/2014/main" id="{EF15F988-39FC-4973-A6FC-1FDAC6FF12A8}"/>
               </a:ext>
             </a:extLst>
           </p:cNvPr>
@@ -5291,7 +5233,7 @@
           <p:cNvPr id="20" name="">
             <a:extLst xmlns:a="http://schemas.openxmlformats.org/drawingml/2006/main">
               <a:ext uri="{FF2B5EF4-FFF2-40B4-BE49-F238E27FC236}">
-                <a16:creationId xmlns:a16="http://schemas.microsoft.com/office/drawing/2014/main" id="{026BD4EB-173A-43ED-928E-FE4173C07559}"/>
+                <a16:creationId xmlns:a16="http://schemas.microsoft.com/office/drawing/2014/main" id="{F365300F-6495-4DFE-AC99-DD638D4E640B}"/>
               </a:ext>
             </a:extLst>
           </p:cNvPr>
@@ -5355,7 +5297,7 @@
           <p:cNvPr id="21" name="">
             <a:extLst xmlns:a="http://schemas.openxmlformats.org/drawingml/2006/main">
               <a:ext uri="{FF2B5EF4-FFF2-40B4-BE49-F238E27FC236}">
-                <a16:creationId xmlns:a16="http://schemas.microsoft.com/office/drawing/2014/main" id="{9CE21DBB-E635-4C16-8D1D-494F5C37CFCE}"/>
+                <a16:creationId xmlns:a16="http://schemas.microsoft.com/office/drawing/2014/main" id="{413D29EB-2646-4424-8033-E1C2C7746ABF}"/>
               </a:ext>
             </a:extLst>
           </p:cNvPr>
@@ -5445,7 +5387,7 @@
           <p:cNvPr id="23" name="">
             <a:extLst xmlns:a="http://schemas.openxmlformats.org/drawingml/2006/main">
               <a:ext uri="{FF2B5EF4-FFF2-40B4-BE49-F238E27FC236}">
-                <a16:creationId xmlns:a16="http://schemas.microsoft.com/office/drawing/2014/main" id="{54361760-EA68-4343-AB90-714CD953EA5D}"/>
+                <a16:creationId xmlns:a16="http://schemas.microsoft.com/office/drawing/2014/main" id="{251D62ED-7DCA-4F02-A1E6-30411D896D6E}"/>
               </a:ext>
             </a:extLst>
           </p:cNvPr>
@@ -5478,7 +5420,7 @@
           <p:cNvPr id="24" name="">
             <a:extLst xmlns:a="http://schemas.openxmlformats.org/drawingml/2006/main">
               <a:ext uri="{FF2B5EF4-FFF2-40B4-BE49-F238E27FC236}">
-                <a16:creationId xmlns:a16="http://schemas.microsoft.com/office/drawing/2014/main" id="{07EB07BB-0E22-4A30-80E8-66CF4E64445B}"/>
+                <a16:creationId xmlns:a16="http://schemas.microsoft.com/office/drawing/2014/main" id="{AC74B2F3-62CF-4B10-B21F-E2245612AEF0}"/>
               </a:ext>
             </a:extLst>
           </p:cNvPr>
@@ -5563,7 +5505,7 @@
           <p:cNvPr id="27" name="">
             <a:extLst xmlns:a="http://schemas.openxmlformats.org/drawingml/2006/main">
               <a:ext uri="{FF2B5EF4-FFF2-40B4-BE49-F238E27FC236}">
-                <a16:creationId xmlns:a16="http://schemas.microsoft.com/office/drawing/2014/main" id="{BE1AD987-447B-49E0-B610-253014BC2827}"/>
+                <a16:creationId xmlns:a16="http://schemas.microsoft.com/office/drawing/2014/main" id="{A93EDAC0-67F3-4E24-88FB-D0244F98CEB4}"/>
               </a:ext>
             </a:extLst>
           </p:cNvPr>
@@ -5621,7 +5563,7 @@
           <p:cNvPr id="28" name="">
             <a:extLst xmlns:a="http://schemas.openxmlformats.org/drawingml/2006/main">
               <a:ext uri="{FF2B5EF4-FFF2-40B4-BE49-F238E27FC236}">
-                <a16:creationId xmlns:a16="http://schemas.microsoft.com/office/drawing/2014/main" id="{32812B98-B92C-4BEE-BD4C-B4C38862DD80}"/>
+                <a16:creationId xmlns:a16="http://schemas.microsoft.com/office/drawing/2014/main" id="{72373DE1-A893-4402-AE23-2A6E4630C7CF}"/>
               </a:ext>
             </a:extLst>
           </p:cNvPr>
@@ -5706,7 +5648,7 @@
           <p:cNvPr id="31" name="">
             <a:extLst xmlns:a="http://schemas.openxmlformats.org/drawingml/2006/main">
               <a:ext uri="{FF2B5EF4-FFF2-40B4-BE49-F238E27FC236}">
-                <a16:creationId xmlns:a16="http://schemas.microsoft.com/office/drawing/2014/main" id="{3C6A6498-6B65-433A-8B02-A829B3D4288E}"/>
+                <a16:creationId xmlns:a16="http://schemas.microsoft.com/office/drawing/2014/main" id="{76B97C6B-BCCA-485E-B0E7-0009F8A95E0A}"/>
               </a:ext>
             </a:extLst>
           </p:cNvPr>
@@ -5764,7 +5706,7 @@
           <p:cNvPr id="32" name="">
             <a:extLst xmlns:a="http://schemas.openxmlformats.org/drawingml/2006/main">
               <a:ext uri="{FF2B5EF4-FFF2-40B4-BE49-F238E27FC236}">
-                <a16:creationId xmlns:a16="http://schemas.microsoft.com/office/drawing/2014/main" id="{15133F87-F92C-4C9D-B9A2-4FC5D51368CB}"/>
+                <a16:creationId xmlns:a16="http://schemas.microsoft.com/office/drawing/2014/main" id="{F68D2F7D-DED5-4387-9952-8825975A5DF5}"/>
               </a:ext>
             </a:extLst>
           </p:cNvPr>
@@ -5849,7 +5791,7 @@
           <p:cNvPr id="35" name="">
             <a:extLst xmlns:a="http://schemas.openxmlformats.org/drawingml/2006/main">
               <a:ext uri="{FF2B5EF4-FFF2-40B4-BE49-F238E27FC236}">
-                <a16:creationId xmlns:a16="http://schemas.microsoft.com/office/drawing/2014/main" id="{00727B9C-14D2-4324-8727-A9A3C51FD36E}"/>
+                <a16:creationId xmlns:a16="http://schemas.microsoft.com/office/drawing/2014/main" id="{FC5D7A46-5731-4F09-8D85-3E23CE586976}"/>
               </a:ext>
             </a:extLst>
           </p:cNvPr>
@@ -5907,7 +5849,7 @@
           <p:cNvPr id="36" name="">
             <a:extLst xmlns:a="http://schemas.openxmlformats.org/drawingml/2006/main">
               <a:ext uri="{FF2B5EF4-FFF2-40B4-BE49-F238E27FC236}">
-                <a16:creationId xmlns:a16="http://schemas.microsoft.com/office/drawing/2014/main" id="{04242B0E-7EE1-4E08-A48B-542652C31DC8}"/>
+                <a16:creationId xmlns:a16="http://schemas.microsoft.com/office/drawing/2014/main" id="{297E73D9-0A76-4CCD-BBD5-195F2F310CC2}"/>
               </a:ext>
             </a:extLst>
           </p:cNvPr>
@@ -5997,7 +5939,7 @@
           <p:cNvPr id="38" name="">
             <a:extLst xmlns:a="http://schemas.openxmlformats.org/drawingml/2006/main">
               <a:ext uri="{FF2B5EF4-FFF2-40B4-BE49-F238E27FC236}">
-                <a16:creationId xmlns:a16="http://schemas.microsoft.com/office/drawing/2014/main" id="{636200C0-F926-4C2B-A2FA-9BD2EA0500DF}"/>
+                <a16:creationId xmlns:a16="http://schemas.microsoft.com/office/drawing/2014/main" id="{A83D5ECA-F06A-4EAB-B87F-2AE41EF171C8}"/>
               </a:ext>
             </a:extLst>
           </p:cNvPr>
@@ -6087,7 +6029,7 @@
           <p:cNvPr id="40" name="">
             <a:extLst xmlns:a="http://schemas.openxmlformats.org/drawingml/2006/main">
               <a:ext uri="{FF2B5EF4-FFF2-40B4-BE49-F238E27FC236}">
-                <a16:creationId xmlns:a16="http://schemas.microsoft.com/office/drawing/2014/main" id="{B7B7AEE6-D53B-4AEF-B1ED-D3318E087FBB}"/>
+                <a16:creationId xmlns:a16="http://schemas.microsoft.com/office/drawing/2014/main" id="{9ABC3708-070C-472E-BF44-64A1436EAE54}"/>
               </a:ext>
             </a:extLst>
           </p:cNvPr>
@@ -6143,7 +6085,7 @@
     </p:spTree>
     <p:extLst>
       <p:ext uri="{BB962C8B-B14F-4D97-AF65-F5344CB8AC3E}">
-        <p14:creationId xmlns:p14="http://schemas.microsoft.com/office/powerpoint/2010/main" val="862068702"/>
+        <p14:creationId xmlns:p14="http://schemas.microsoft.com/office/powerpoint/2010/main" val="1636085207"/>
       </p:ext>
     </p:extLst>
   </p:cSld>
@@ -6174,7 +6116,7 @@
           <p:cNvPr id="36" name="">
             <a:extLst xmlns:a="http://schemas.openxmlformats.org/drawingml/2006/main">
               <a:ext uri="{FF2B5EF4-FFF2-40B4-BE49-F238E27FC236}">
-                <a16:creationId xmlns:a16="http://schemas.microsoft.com/office/drawing/2014/main" id="{AF0B5F7F-31DD-4E94-A0C2-4699F550972B}"/>
+                <a16:creationId xmlns:a16="http://schemas.microsoft.com/office/drawing/2014/main" id="{03AF47F5-5E3D-49FE-8A21-2004D9250EE6}"/>
               </a:ext>
             </a:extLst>
           </p:cNvPr>
@@ -6232,7 +6174,7 @@
           <p:cNvPr id="2" name="">
             <a:extLst xmlns:a="http://schemas.openxmlformats.org/drawingml/2006/main">
               <a:ext uri="{FF2B5EF4-FFF2-40B4-BE49-F238E27FC236}">
-                <a16:creationId xmlns:a16="http://schemas.microsoft.com/office/drawing/2014/main" id="{5EC3DBA8-AAB1-4696-9CDB-3EC30EE2ACAA}"/>
+                <a16:creationId xmlns:a16="http://schemas.microsoft.com/office/drawing/2014/main" id="{CCAD61A8-0060-48C9-80D4-711D53344B12}"/>
               </a:ext>
             </a:extLst>
           </p:cNvPr>
@@ -6290,7 +6232,7 @@
           <p:cNvPr id="3" name="">
             <a:extLst xmlns:a="http://schemas.openxmlformats.org/drawingml/2006/main">
               <a:ext uri="{FF2B5EF4-FFF2-40B4-BE49-F238E27FC236}">
-                <a16:creationId xmlns:a16="http://schemas.microsoft.com/office/drawing/2014/main" id="{88515323-9123-4BF3-A644-34BB35E9D581}"/>
+                <a16:creationId xmlns:a16="http://schemas.microsoft.com/office/drawing/2014/main" id="{849559BF-3380-4B82-915C-C51CF4EEAA7C}"/>
               </a:ext>
             </a:extLst>
           </p:cNvPr>
@@ -6321,7 +6263,7 @@
           <p:cNvPr id="4" name="">
             <a:extLst xmlns:a="http://schemas.openxmlformats.org/drawingml/2006/main">
               <a:ext uri="{FF2B5EF4-FFF2-40B4-BE49-F238E27FC236}">
-                <a16:creationId xmlns:a16="http://schemas.microsoft.com/office/drawing/2014/main" id="{1425F7AD-AE18-45FA-91BA-12AB396EDB4B}"/>
+                <a16:creationId xmlns:a16="http://schemas.microsoft.com/office/drawing/2014/main" id="{84CFA869-0A15-4EE6-A4F8-F3F458F02BB1}"/>
               </a:ext>
             </a:extLst>
           </p:cNvPr>
@@ -6354,7 +6296,7 @@
           <p:cNvPr id="5" name="">
             <a:extLst xmlns:a="http://schemas.openxmlformats.org/drawingml/2006/main">
               <a:ext uri="{FF2B5EF4-FFF2-40B4-BE49-F238E27FC236}">
-                <a16:creationId xmlns:a16="http://schemas.microsoft.com/office/drawing/2014/main" id="{F461FFEA-958D-47AB-84EA-F9A874479B0C}"/>
+                <a16:creationId xmlns:a16="http://schemas.microsoft.com/office/drawing/2014/main" id="{BCC211D6-400B-48BA-8EFD-6290774F7322}"/>
               </a:ext>
             </a:extLst>
           </p:cNvPr>
@@ -6387,7 +6329,7 @@
           <p:cNvPr id="6" name="">
             <a:extLst xmlns:a="http://schemas.openxmlformats.org/drawingml/2006/main">
               <a:ext uri="{FF2B5EF4-FFF2-40B4-BE49-F238E27FC236}">
-                <a16:creationId xmlns:a16="http://schemas.microsoft.com/office/drawing/2014/main" id="{FCE50F79-5D9B-4A1A-BBC9-F5EA62E65372}"/>
+                <a16:creationId xmlns:a16="http://schemas.microsoft.com/office/drawing/2014/main" id="{09A1DA41-007E-44CC-9E4B-7F1EDD0D7ED1}"/>
               </a:ext>
             </a:extLst>
           </p:cNvPr>
@@ -6503,7 +6445,7 @@
           <p:cNvPr id="9" name="">
             <a:extLst xmlns:a="http://schemas.openxmlformats.org/drawingml/2006/main">
               <a:ext uri="{FF2B5EF4-FFF2-40B4-BE49-F238E27FC236}">
-                <a16:creationId xmlns:a16="http://schemas.microsoft.com/office/drawing/2014/main" id="{4AAB1A9C-6CF6-4C3A-ABC2-210041D9CE1F}"/>
+                <a16:creationId xmlns:a16="http://schemas.microsoft.com/office/drawing/2014/main" id="{62F2FCFE-39F9-41A8-B02A-464F033E2D8B}"/>
               </a:ext>
             </a:extLst>
           </p:cNvPr>
@@ -6561,7 +6503,7 @@
           <p:cNvPr id="10" name="">
             <a:extLst xmlns:a="http://schemas.openxmlformats.org/drawingml/2006/main">
               <a:ext uri="{FF2B5EF4-FFF2-40B4-BE49-F238E27FC236}">
-                <a16:creationId xmlns:a16="http://schemas.microsoft.com/office/drawing/2014/main" id="{B578CA30-EF9A-48B1-B0B5-E964CBA186A0}"/>
+                <a16:creationId xmlns:a16="http://schemas.microsoft.com/office/drawing/2014/main" id="{911431C0-C2AA-4985-9BFB-8875A9BD7757}"/>
               </a:ext>
             </a:extLst>
           </p:cNvPr>
@@ -6594,7 +6536,7 @@
           <p:cNvPr id="11" name="">
             <a:extLst xmlns:a="http://schemas.openxmlformats.org/drawingml/2006/main">
               <a:ext uri="{FF2B5EF4-FFF2-40B4-BE49-F238E27FC236}">
-                <a16:creationId xmlns:a16="http://schemas.microsoft.com/office/drawing/2014/main" id="{918A22C3-6CFC-4168-B070-5E9CE5BF79F1}"/>
+                <a16:creationId xmlns:a16="http://schemas.microsoft.com/office/drawing/2014/main" id="{67E2FA47-8B94-487D-A333-3484A1BF7054}"/>
               </a:ext>
             </a:extLst>
           </p:cNvPr>
@@ -6710,7 +6652,7 @@
           <p:cNvPr id="14" name="">
             <a:extLst xmlns:a="http://schemas.openxmlformats.org/drawingml/2006/main">
               <a:ext uri="{FF2B5EF4-FFF2-40B4-BE49-F238E27FC236}">
-                <a16:creationId xmlns:a16="http://schemas.microsoft.com/office/drawing/2014/main" id="{8A2B5140-A170-4546-B5F1-24FCFEAA5FEB}"/>
+                <a16:creationId xmlns:a16="http://schemas.microsoft.com/office/drawing/2014/main" id="{0D8ACE15-033B-4D22-924E-5A2ACAC86727}"/>
               </a:ext>
             </a:extLst>
           </p:cNvPr>
@@ -6768,7 +6710,7 @@
           <p:cNvPr id="15" name="">
             <a:extLst xmlns:a="http://schemas.openxmlformats.org/drawingml/2006/main">
               <a:ext uri="{FF2B5EF4-FFF2-40B4-BE49-F238E27FC236}">
-                <a16:creationId xmlns:a16="http://schemas.microsoft.com/office/drawing/2014/main" id="{C435DA37-C571-4FFE-B140-2DAC4A840065}"/>
+                <a16:creationId xmlns:a16="http://schemas.microsoft.com/office/drawing/2014/main" id="{9E9FE944-01F8-4770-967B-B5EBEF66FA4E}"/>
               </a:ext>
             </a:extLst>
           </p:cNvPr>
@@ -6801,7 +6743,7 @@
           <p:cNvPr id="16" name="">
             <a:extLst xmlns:a="http://schemas.openxmlformats.org/drawingml/2006/main">
               <a:ext uri="{FF2B5EF4-FFF2-40B4-BE49-F238E27FC236}">
-                <a16:creationId xmlns:a16="http://schemas.microsoft.com/office/drawing/2014/main" id="{81D5197F-B1BC-4375-8B8F-9259EBB480A6}"/>
+                <a16:creationId xmlns:a16="http://schemas.microsoft.com/office/drawing/2014/main" id="{3EEDD27E-FC28-4106-A818-2CA865748A3F}"/>
               </a:ext>
             </a:extLst>
           </p:cNvPr>
@@ -6917,7 +6859,7 @@
           <p:cNvPr id="19" name="">
             <a:extLst xmlns:a="http://schemas.openxmlformats.org/drawingml/2006/main">
               <a:ext uri="{FF2B5EF4-FFF2-40B4-BE49-F238E27FC236}">
-                <a16:creationId xmlns:a16="http://schemas.microsoft.com/office/drawing/2014/main" id="{8EC528F4-86DA-498F-9DE5-6A4DB85188DA}"/>
+                <a16:creationId xmlns:a16="http://schemas.microsoft.com/office/drawing/2014/main" id="{0A7CAC10-525F-4E1B-96F7-5FDDA1C889A2}"/>
               </a:ext>
             </a:extLst>
           </p:cNvPr>
@@ -6975,7 +6917,7 @@
           <p:cNvPr id="20" name="">
             <a:extLst xmlns:a="http://schemas.openxmlformats.org/drawingml/2006/main">
               <a:ext uri="{FF2B5EF4-FFF2-40B4-BE49-F238E27FC236}">
-                <a16:creationId xmlns:a16="http://schemas.microsoft.com/office/drawing/2014/main" id="{5527A028-EF2B-4CAD-B2DA-1FC5CEB81991}"/>
+                <a16:creationId xmlns:a16="http://schemas.microsoft.com/office/drawing/2014/main" id="{D702CB8D-47CD-40E2-A70A-6AD6EA937328}"/>
               </a:ext>
             </a:extLst>
           </p:cNvPr>
@@ -7008,7 +6950,7 @@
           <p:cNvPr id="21" name="">
             <a:extLst xmlns:a="http://schemas.openxmlformats.org/drawingml/2006/main">
               <a:ext uri="{FF2B5EF4-FFF2-40B4-BE49-F238E27FC236}">
-                <a16:creationId xmlns:a16="http://schemas.microsoft.com/office/drawing/2014/main" id="{90C223A1-903A-4D0C-806E-619D3290EC76}"/>
+                <a16:creationId xmlns:a16="http://schemas.microsoft.com/office/drawing/2014/main" id="{39ECE5C2-DD6F-4CDA-943B-BF74C06E2288}"/>
               </a:ext>
             </a:extLst>
           </p:cNvPr>
@@ -7067,7 +7009,7 @@
           <p:cNvPr id="23" name="">
             <a:extLst xmlns:a="http://schemas.openxmlformats.org/drawingml/2006/main">
               <a:ext uri="{FF2B5EF4-FFF2-40B4-BE49-F238E27FC236}">
-                <a16:creationId xmlns:a16="http://schemas.microsoft.com/office/drawing/2014/main" id="{B86D3A98-798F-498D-A38C-87C29511129F}"/>
+                <a16:creationId xmlns:a16="http://schemas.microsoft.com/office/drawing/2014/main" id="{557A6218-00D1-484B-A976-AD2F80B60DA2}"/>
               </a:ext>
             </a:extLst>
           </p:cNvPr>
@@ -7125,7 +7067,7 @@
           <p:cNvPr id="24" name="">
             <a:extLst xmlns:a="http://schemas.openxmlformats.org/drawingml/2006/main">
               <a:ext uri="{FF2B5EF4-FFF2-40B4-BE49-F238E27FC236}">
-                <a16:creationId xmlns:a16="http://schemas.microsoft.com/office/drawing/2014/main" id="{FCFF3E03-2EE7-401B-89EC-3860036EADA2}"/>
+                <a16:creationId xmlns:a16="http://schemas.microsoft.com/office/drawing/2014/main" id="{DDB619D7-9CD2-4FD0-9949-EF33E5000422}"/>
               </a:ext>
             </a:extLst>
           </p:cNvPr>
@@ -7183,7 +7125,7 @@
           <p:cNvPr id="25" name="">
             <a:extLst xmlns:a="http://schemas.openxmlformats.org/drawingml/2006/main">
               <a:ext uri="{FF2B5EF4-FFF2-40B4-BE49-F238E27FC236}">
-                <a16:creationId xmlns:a16="http://schemas.microsoft.com/office/drawing/2014/main" id="{92EE0E40-5A5C-4399-A00D-38AC8DEFB279}"/>
+                <a16:creationId xmlns:a16="http://schemas.microsoft.com/office/drawing/2014/main" id="{1F8DB81D-6006-4F55-90B2-6DD5ADF13008}"/>
               </a:ext>
             </a:extLst>
           </p:cNvPr>
@@ -7242,7 +7184,7 @@
           <p:cNvPr id="27" name="">
             <a:extLst xmlns:a="http://schemas.openxmlformats.org/drawingml/2006/main">
               <a:ext uri="{FF2B5EF4-FFF2-40B4-BE49-F238E27FC236}">
-                <a16:creationId xmlns:a16="http://schemas.microsoft.com/office/drawing/2014/main" id="{BA01093B-0D59-4FF6-BA5C-6D727A6F09D8}"/>
+                <a16:creationId xmlns:a16="http://schemas.microsoft.com/office/drawing/2014/main" id="{29F5C5B5-25B1-4851-92B7-45DA9CD70486}"/>
               </a:ext>
             </a:extLst>
           </p:cNvPr>
@@ -7300,7 +7242,7 @@
           <p:cNvPr id="28" name="">
             <a:extLst xmlns:a="http://schemas.openxmlformats.org/drawingml/2006/main">
               <a:ext uri="{FF2B5EF4-FFF2-40B4-BE49-F238E27FC236}">
-                <a16:creationId xmlns:a16="http://schemas.microsoft.com/office/drawing/2014/main" id="{73CB511F-9FE4-4976-AC60-1B93EC6DC964}"/>
+                <a16:creationId xmlns:a16="http://schemas.microsoft.com/office/drawing/2014/main" id="{5A7D7736-0D66-4ED5-BDF8-92C6C130D999}"/>
               </a:ext>
             </a:extLst>
           </p:cNvPr>
@@ -7358,7 +7300,7 @@
           <p:cNvPr id="29" name="">
             <a:extLst xmlns:a="http://schemas.openxmlformats.org/drawingml/2006/main">
               <a:ext uri="{FF2B5EF4-FFF2-40B4-BE49-F238E27FC236}">
-                <a16:creationId xmlns:a16="http://schemas.microsoft.com/office/drawing/2014/main" id="{1A1D7183-229A-4743-85C3-77FFE988D956}"/>
+                <a16:creationId xmlns:a16="http://schemas.microsoft.com/office/drawing/2014/main" id="{D69BA50D-BAF2-4876-82AA-FBB6DF354ABB}"/>
               </a:ext>
             </a:extLst>
           </p:cNvPr>
@@ -7417,7 +7359,7 @@
           <p:cNvPr id="31" name="">
             <a:extLst xmlns:a="http://schemas.openxmlformats.org/drawingml/2006/main">
               <a:ext uri="{FF2B5EF4-FFF2-40B4-BE49-F238E27FC236}">
-                <a16:creationId xmlns:a16="http://schemas.microsoft.com/office/drawing/2014/main" id="{880D0C79-898C-429E-A65F-ED15BC56D225}"/>
+                <a16:creationId xmlns:a16="http://schemas.microsoft.com/office/drawing/2014/main" id="{85B0275D-4209-43FD-8E34-A7F347DD5F66}"/>
               </a:ext>
             </a:extLst>
           </p:cNvPr>
@@ -7475,7 +7417,7 @@
           <p:cNvPr id="32" name="">
             <a:extLst xmlns:a="http://schemas.openxmlformats.org/drawingml/2006/main">
               <a:ext uri="{FF2B5EF4-FFF2-40B4-BE49-F238E27FC236}">
-                <a16:creationId xmlns:a16="http://schemas.microsoft.com/office/drawing/2014/main" id="{3C935EA8-AFF4-4306-8DDD-987D60C4A23F}"/>
+                <a16:creationId xmlns:a16="http://schemas.microsoft.com/office/drawing/2014/main" id="{8546C093-E3F2-4CCD-A287-8B57FF0106A0}"/>
               </a:ext>
             </a:extLst>
           </p:cNvPr>
@@ -7533,7 +7475,7 @@
           <p:cNvPr id="33" name="">
             <a:extLst xmlns:a="http://schemas.openxmlformats.org/drawingml/2006/main">
               <a:ext uri="{FF2B5EF4-FFF2-40B4-BE49-F238E27FC236}">
-                <a16:creationId xmlns:a16="http://schemas.microsoft.com/office/drawing/2014/main" id="{D29AF1A9-608F-475D-8646-5B576EBE752A}"/>
+                <a16:creationId xmlns:a16="http://schemas.microsoft.com/office/drawing/2014/main" id="{E6847956-E9B9-4B63-804A-F492B44EADF4}"/>
               </a:ext>
             </a:extLst>
           </p:cNvPr>
@@ -7597,7 +7539,7 @@
           <p:cNvPr id="34" name="">
             <a:extLst xmlns:a="http://schemas.openxmlformats.org/drawingml/2006/main">
               <a:ext uri="{FF2B5EF4-FFF2-40B4-BE49-F238E27FC236}">
-                <a16:creationId xmlns:a16="http://schemas.microsoft.com/office/drawing/2014/main" id="{8FFFD31A-2DED-4CF6-A1D6-91443532AFE4}"/>
+                <a16:creationId xmlns:a16="http://schemas.microsoft.com/office/drawing/2014/main" id="{00B3B315-D831-4056-9F49-42534AF4575B}"/>
               </a:ext>
             </a:extLst>
           </p:cNvPr>
@@ -7655,7 +7597,7 @@
           <p:cNvPr id="35" name="">
             <a:extLst xmlns:a="http://schemas.openxmlformats.org/drawingml/2006/main">
               <a:ext uri="{FF2B5EF4-FFF2-40B4-BE49-F238E27FC236}">
-                <a16:creationId xmlns:a16="http://schemas.microsoft.com/office/drawing/2014/main" id="{680C31BF-F5E7-41DC-B3AA-8E9441FEA4C6}"/>
+                <a16:creationId xmlns:a16="http://schemas.microsoft.com/office/drawing/2014/main" id="{795DE32D-353C-498E-BE4C-B309CA24D276}"/>
               </a:ext>
             </a:extLst>
           </p:cNvPr>
@@ -7711,7 +7653,7 @@
     </p:spTree>
     <p:extLst>
       <p:ext uri="{BB962C8B-B14F-4D97-AF65-F5344CB8AC3E}">
-        <p14:creationId xmlns:p14="http://schemas.microsoft.com/office/powerpoint/2010/main" val="1834328989"/>
+        <p14:creationId xmlns:p14="http://schemas.microsoft.com/office/powerpoint/2010/main" val="1639305268"/>
       </p:ext>
     </p:extLst>
   </p:cSld>
@@ -7742,7 +7684,7 @@
           <p:cNvPr id="20" name="">
             <a:extLst xmlns:a="http://schemas.openxmlformats.org/drawingml/2006/main">
               <a:ext uri="{FF2B5EF4-FFF2-40B4-BE49-F238E27FC236}">
-                <a16:creationId xmlns:a16="http://schemas.microsoft.com/office/drawing/2014/main" id="{0E99D2D1-45EF-4D4E-89F8-91544B280AEC}"/>
+                <a16:creationId xmlns:a16="http://schemas.microsoft.com/office/drawing/2014/main" id="{F94A4F20-47BE-44EF-96D3-0E67E3EBD024}"/>
               </a:ext>
             </a:extLst>
           </p:cNvPr>
@@ -7806,7 +7748,7 @@
           <p:cNvPr id="2" name="">
             <a:extLst xmlns:a="http://schemas.openxmlformats.org/drawingml/2006/main">
               <a:ext uri="{FF2B5EF4-FFF2-40B4-BE49-F238E27FC236}">
-                <a16:creationId xmlns:a16="http://schemas.microsoft.com/office/drawing/2014/main" id="{CF4E9041-BD2C-47B8-82CF-EBAC48DB1D88}"/>
+                <a16:creationId xmlns:a16="http://schemas.microsoft.com/office/drawing/2014/main" id="{9ECA6207-7A27-48AF-9399-64D65394A228}"/>
               </a:ext>
             </a:extLst>
           </p:cNvPr>
@@ -7893,7 +7835,7 @@
           <p:cNvPr id="3" name="">
             <a:extLst xmlns:a="http://schemas.openxmlformats.org/drawingml/2006/main">
               <a:ext uri="{FF2B5EF4-FFF2-40B4-BE49-F238E27FC236}">
-                <a16:creationId xmlns:a16="http://schemas.microsoft.com/office/drawing/2014/main" id="{4F042319-4A6A-41D8-84F4-94272AFA2CE4}"/>
+                <a16:creationId xmlns:a16="http://schemas.microsoft.com/office/drawing/2014/main" id="{E425676B-DFA2-41C4-8C47-3D739FE9D28B}"/>
               </a:ext>
             </a:extLst>
           </p:cNvPr>
@@ -7980,7 +7922,7 @@
           <p:cNvPr id="4" name="">
             <a:extLst xmlns:a="http://schemas.openxmlformats.org/drawingml/2006/main">
               <a:ext uri="{FF2B5EF4-FFF2-40B4-BE49-F238E27FC236}">
-                <a16:creationId xmlns:a16="http://schemas.microsoft.com/office/drawing/2014/main" id="{6FFD6711-A251-436F-9F57-F0D80EC550FD}"/>
+                <a16:creationId xmlns:a16="http://schemas.microsoft.com/office/drawing/2014/main" id="{E8DCEC3E-C260-4F42-BBEF-BCF74C4CCB71}"/>
               </a:ext>
             </a:extLst>
           </p:cNvPr>
@@ -8067,7 +8009,7 @@
           <p:cNvPr id="5" name="">
             <a:extLst xmlns:a="http://schemas.openxmlformats.org/drawingml/2006/main">
               <a:ext uri="{FF2B5EF4-FFF2-40B4-BE49-F238E27FC236}">
-                <a16:creationId xmlns:a16="http://schemas.microsoft.com/office/drawing/2014/main" id="{7C241F6B-54D2-493A-8440-20E87B4FBD51}"/>
+                <a16:creationId xmlns:a16="http://schemas.microsoft.com/office/drawing/2014/main" id="{4B6B6EA2-70DC-448D-B71A-972436D550EC}"/>
               </a:ext>
             </a:extLst>
           </p:cNvPr>
@@ -8296,7 +8238,7 @@
           <p:cNvPr id="11" name="">
             <a:extLst xmlns:a="http://schemas.openxmlformats.org/drawingml/2006/main">
               <a:ext uri="{FF2B5EF4-FFF2-40B4-BE49-F238E27FC236}">
-                <a16:creationId xmlns:a16="http://schemas.microsoft.com/office/drawing/2014/main" id="{191E3BA3-1A06-4D8F-B3F5-C5203B77C343}"/>
+                <a16:creationId xmlns:a16="http://schemas.microsoft.com/office/drawing/2014/main" id="{E845C501-60BB-4475-8ACE-E02F09C06EF9}"/>
               </a:ext>
             </a:extLst>
           </p:cNvPr>
@@ -8329,7 +8271,7 @@
           <p:cNvPr id="12" name="">
             <a:extLst xmlns:a="http://schemas.openxmlformats.org/drawingml/2006/main">
               <a:ext uri="{FF2B5EF4-FFF2-40B4-BE49-F238E27FC236}">
-                <a16:creationId xmlns:a16="http://schemas.microsoft.com/office/drawing/2014/main" id="{EECAF9BC-BEB0-41D2-813C-D1C5C409DAAB}"/>
+                <a16:creationId xmlns:a16="http://schemas.microsoft.com/office/drawing/2014/main" id="{718E9B67-844B-44DA-B6D5-305CE23645C6}"/>
               </a:ext>
             </a:extLst>
           </p:cNvPr>
@@ -8362,7 +8304,7 @@
           <p:cNvPr id="13" name="">
             <a:extLst xmlns:a="http://schemas.openxmlformats.org/drawingml/2006/main">
               <a:ext uri="{FF2B5EF4-FFF2-40B4-BE49-F238E27FC236}">
-                <a16:creationId xmlns:a16="http://schemas.microsoft.com/office/drawing/2014/main" id="{660963D0-6E00-4AE6-AC7A-3798471B4E41}"/>
+                <a16:creationId xmlns:a16="http://schemas.microsoft.com/office/drawing/2014/main" id="{34A6D137-69A0-454B-AA86-DD4E7435E138}"/>
               </a:ext>
             </a:extLst>
           </p:cNvPr>
@@ -8395,7 +8337,7 @@
           <p:cNvPr id="14" name="">
             <a:extLst xmlns:a="http://schemas.openxmlformats.org/drawingml/2006/main">
               <a:ext uri="{FF2B5EF4-FFF2-40B4-BE49-F238E27FC236}">
-                <a16:creationId xmlns:a16="http://schemas.microsoft.com/office/drawing/2014/main" id="{BA469C5A-7B14-4E39-A1BD-227195FC997B}"/>
+                <a16:creationId xmlns:a16="http://schemas.microsoft.com/office/drawing/2014/main" id="{D6112E56-772D-4F55-82F0-E2B5059890EF}"/>
               </a:ext>
             </a:extLst>
           </p:cNvPr>
@@ -8478,7 +8420,7 @@
           <p:cNvPr id="17" name="">
             <a:extLst xmlns:a="http://schemas.openxmlformats.org/drawingml/2006/main">
               <a:ext uri="{FF2B5EF4-FFF2-40B4-BE49-F238E27FC236}">
-                <a16:creationId xmlns:a16="http://schemas.microsoft.com/office/drawing/2014/main" id="{8DDC1719-E1D0-428C-9034-6AD8F8FD61F9}"/>
+                <a16:creationId xmlns:a16="http://schemas.microsoft.com/office/drawing/2014/main" id="{CEC92421-925A-41D2-B60C-09BA90A6AA29}"/>
               </a:ext>
             </a:extLst>
           </p:cNvPr>
@@ -8536,7 +8478,7 @@
           <p:cNvPr id="18" name="">
             <a:extLst xmlns:a="http://schemas.openxmlformats.org/drawingml/2006/main">
               <a:ext uri="{FF2B5EF4-FFF2-40B4-BE49-F238E27FC236}">
-                <a16:creationId xmlns:a16="http://schemas.microsoft.com/office/drawing/2014/main" id="{1294C507-EB0A-4673-B172-7EBE6165D549}"/>
+                <a16:creationId xmlns:a16="http://schemas.microsoft.com/office/drawing/2014/main" id="{7051D766-21B9-4346-84D9-D66D9098312D}"/>
               </a:ext>
             </a:extLst>
           </p:cNvPr>
@@ -8594,7 +8536,7 @@
           <p:cNvPr id="19" name="">
             <a:extLst xmlns:a="http://schemas.openxmlformats.org/drawingml/2006/main">
               <a:ext uri="{FF2B5EF4-FFF2-40B4-BE49-F238E27FC236}">
-                <a16:creationId xmlns:a16="http://schemas.microsoft.com/office/drawing/2014/main" id="{A5052DE2-1935-434C-A2FE-98DC59FE87DE}"/>
+                <a16:creationId xmlns:a16="http://schemas.microsoft.com/office/drawing/2014/main" id="{1FBFA14B-90E2-45A6-9EBB-34D88ED9E918}"/>
               </a:ext>
             </a:extLst>
           </p:cNvPr>
@@ -8650,7 +8592,7 @@
     </p:spTree>
     <p:extLst>
       <p:ext uri="{BB962C8B-B14F-4D97-AF65-F5344CB8AC3E}">
-        <p14:creationId xmlns:p14="http://schemas.microsoft.com/office/powerpoint/2010/main" val="1381373976"/>
+        <p14:creationId xmlns:p14="http://schemas.microsoft.com/office/powerpoint/2010/main" val="2121357051"/>
       </p:ext>
     </p:extLst>
   </p:cSld>
@@ -8681,7 +8623,7 @@
           <p:cNvPr id="31" name="">
             <a:extLst xmlns:a="http://schemas.openxmlformats.org/drawingml/2006/main">
               <a:ext uri="{FF2B5EF4-FFF2-40B4-BE49-F238E27FC236}">
-                <a16:creationId xmlns:a16="http://schemas.microsoft.com/office/drawing/2014/main" id="{B417C0E8-504B-453D-8789-5335F8AAC054}"/>
+                <a16:creationId xmlns:a16="http://schemas.microsoft.com/office/drawing/2014/main" id="{E9FD7E92-D20A-4AA8-87BF-02A247D9DDCF}"/>
               </a:ext>
             </a:extLst>
           </p:cNvPr>
@@ -8739,7 +8681,7 @@
           <p:cNvPr id="2" name="">
             <a:extLst xmlns:a="http://schemas.openxmlformats.org/drawingml/2006/main">
               <a:ext uri="{FF2B5EF4-FFF2-40B4-BE49-F238E27FC236}">
-                <a16:creationId xmlns:a16="http://schemas.microsoft.com/office/drawing/2014/main" id="{AE265E7F-2086-498C-8245-A56F3FB542AC}"/>
+                <a16:creationId xmlns:a16="http://schemas.microsoft.com/office/drawing/2014/main" id="{D3B4F18E-C1D3-4CE7-81D0-5FE0EF0E0A53}"/>
               </a:ext>
             </a:extLst>
           </p:cNvPr>
@@ -8797,7 +8739,7 @@
           <p:cNvPr id="3" name="">
             <a:extLst xmlns:a="http://schemas.openxmlformats.org/drawingml/2006/main">
               <a:ext uri="{FF2B5EF4-FFF2-40B4-BE49-F238E27FC236}">
-                <a16:creationId xmlns:a16="http://schemas.microsoft.com/office/drawing/2014/main" id="{E3900092-90D1-4F29-AC8A-56A0BD8DE907}"/>
+                <a16:creationId xmlns:a16="http://schemas.microsoft.com/office/drawing/2014/main" id="{3F1DAFF4-A664-4F48-B044-923F301AA76A}"/>
               </a:ext>
             </a:extLst>
           </p:cNvPr>
@@ -8855,7 +8797,7 @@
           <p:cNvPr id="4" name="">
             <a:extLst xmlns:a="http://schemas.openxmlformats.org/drawingml/2006/main">
               <a:ext uri="{FF2B5EF4-FFF2-40B4-BE49-F238E27FC236}">
-                <a16:creationId xmlns:a16="http://schemas.microsoft.com/office/drawing/2014/main" id="{451D2E82-5F62-41C3-95F5-F5F79EA50BD4}"/>
+                <a16:creationId xmlns:a16="http://schemas.microsoft.com/office/drawing/2014/main" id="{46112DAF-0900-41AD-B1FD-195C8C69BB31}"/>
               </a:ext>
             </a:extLst>
           </p:cNvPr>
@@ -8913,7 +8855,7 @@
           <p:cNvPr id="5" name="">
             <a:extLst xmlns:a="http://schemas.openxmlformats.org/drawingml/2006/main">
               <a:ext uri="{FF2B5EF4-FFF2-40B4-BE49-F238E27FC236}">
-                <a16:creationId xmlns:a16="http://schemas.microsoft.com/office/drawing/2014/main" id="{B59745C5-E7ED-468B-8B6F-BFD4B709FBA6}"/>
+                <a16:creationId xmlns:a16="http://schemas.microsoft.com/office/drawing/2014/main" id="{9DA3707C-2F39-433E-8CF9-0008A11BB2E9}"/>
               </a:ext>
             </a:extLst>
           </p:cNvPr>
@@ -8946,7 +8888,7 @@
           <p:cNvPr id="6" name="">
             <a:extLst xmlns:a="http://schemas.openxmlformats.org/drawingml/2006/main">
               <a:ext uri="{FF2B5EF4-FFF2-40B4-BE49-F238E27FC236}">
-                <a16:creationId xmlns:a16="http://schemas.microsoft.com/office/drawing/2014/main" id="{7C1CE0FE-3604-4F0A-B318-A8CE4ABAB892}"/>
+                <a16:creationId xmlns:a16="http://schemas.microsoft.com/office/drawing/2014/main" id="{45565683-B9BC-43FD-A2C9-9F66737076D9}"/>
               </a:ext>
             </a:extLst>
           </p:cNvPr>
@@ -9004,7 +8946,7 @@
           <p:cNvPr id="7" name="">
             <a:extLst xmlns:a="http://schemas.openxmlformats.org/drawingml/2006/main">
               <a:ext uri="{FF2B5EF4-FFF2-40B4-BE49-F238E27FC236}">
-                <a16:creationId xmlns:a16="http://schemas.microsoft.com/office/drawing/2014/main" id="{D775799C-9890-4E2F-B95D-DAF31F6181ED}"/>
+                <a16:creationId xmlns:a16="http://schemas.microsoft.com/office/drawing/2014/main" id="{2BE4F76A-D4FD-45BC-8244-40F46B9090C2}"/>
               </a:ext>
             </a:extLst>
           </p:cNvPr>
@@ -9068,7 +9010,7 @@
           <p:cNvPr id="8" name="">
             <a:extLst xmlns:a="http://schemas.openxmlformats.org/drawingml/2006/main">
               <a:ext uri="{FF2B5EF4-FFF2-40B4-BE49-F238E27FC236}">
-                <a16:creationId xmlns:a16="http://schemas.microsoft.com/office/drawing/2014/main" id="{56269DDC-6541-4919-90F9-E6CBBD9FEF27}"/>
+                <a16:creationId xmlns:a16="http://schemas.microsoft.com/office/drawing/2014/main" id="{B4BB1488-573C-43A3-AC62-204F1D96A24C}"/>
               </a:ext>
             </a:extLst>
           </p:cNvPr>
@@ -9126,7 +9068,7 @@
           <p:cNvPr id="9" name="">
             <a:extLst xmlns:a="http://schemas.openxmlformats.org/drawingml/2006/main">
               <a:ext uri="{FF2B5EF4-FFF2-40B4-BE49-F238E27FC236}">
-                <a16:creationId xmlns:a16="http://schemas.microsoft.com/office/drawing/2014/main" id="{3BED962B-48F8-4718-8AD3-03EACAF41B0F}"/>
+                <a16:creationId xmlns:a16="http://schemas.microsoft.com/office/drawing/2014/main" id="{AB67F755-2E2C-4F20-B554-5F729ECA118F}"/>
               </a:ext>
             </a:extLst>
           </p:cNvPr>
@@ -9159,7 +9101,7 @@
           <p:cNvPr id="10" name="">
             <a:extLst xmlns:a="http://schemas.openxmlformats.org/drawingml/2006/main">
               <a:ext uri="{FF2B5EF4-FFF2-40B4-BE49-F238E27FC236}">
-                <a16:creationId xmlns:a16="http://schemas.microsoft.com/office/drawing/2014/main" id="{1732DAB4-A2AE-4ACC-9D27-6BC037D0C946}"/>
+                <a16:creationId xmlns:a16="http://schemas.microsoft.com/office/drawing/2014/main" id="{3396AC55-FF6C-4915-B396-A87E125AA3D9}"/>
               </a:ext>
             </a:extLst>
           </p:cNvPr>
@@ -9192,7 +9134,7 @@
           <p:cNvPr id="11" name="">
             <a:extLst xmlns:a="http://schemas.openxmlformats.org/drawingml/2006/main">
               <a:ext uri="{FF2B5EF4-FFF2-40B4-BE49-F238E27FC236}">
-                <a16:creationId xmlns:a16="http://schemas.microsoft.com/office/drawing/2014/main" id="{A59B778E-E719-4D6A-A9AA-7731B4916BD0}"/>
+                <a16:creationId xmlns:a16="http://schemas.microsoft.com/office/drawing/2014/main" id="{1E656F30-31F8-4173-B43E-340C02F0186E}"/>
               </a:ext>
             </a:extLst>
           </p:cNvPr>
@@ -9225,7 +9167,7 @@
           <p:cNvPr id="12" name="">
             <a:extLst xmlns:a="http://schemas.openxmlformats.org/drawingml/2006/main">
               <a:ext uri="{FF2B5EF4-FFF2-40B4-BE49-F238E27FC236}">
-                <a16:creationId xmlns:a16="http://schemas.microsoft.com/office/drawing/2014/main" id="{1BDEAE7B-AA50-4DD5-85F7-FFF57BB34A96}"/>
+                <a16:creationId xmlns:a16="http://schemas.microsoft.com/office/drawing/2014/main" id="{B21F23F6-2FC8-47BB-936D-7C390257CB68}"/>
               </a:ext>
             </a:extLst>
           </p:cNvPr>
@@ -9258,7 +9200,7 @@
           <p:cNvPr id="13" name="">
             <a:extLst xmlns:a="http://schemas.openxmlformats.org/drawingml/2006/main">
               <a:ext uri="{FF2B5EF4-FFF2-40B4-BE49-F238E27FC236}">
-                <a16:creationId xmlns:a16="http://schemas.microsoft.com/office/drawing/2014/main" id="{D0922054-DD1A-48F1-9395-1AF40E507D14}"/>
+                <a16:creationId xmlns:a16="http://schemas.microsoft.com/office/drawing/2014/main" id="{3B96FFCD-C66B-407E-84AF-C6E4EEB0D275}"/>
               </a:ext>
             </a:extLst>
           </p:cNvPr>
@@ -9291,7 +9233,7 @@
           <p:cNvPr id="14" name="">
             <a:extLst xmlns:a="http://schemas.openxmlformats.org/drawingml/2006/main">
               <a:ext uri="{FF2B5EF4-FFF2-40B4-BE49-F238E27FC236}">
-                <a16:creationId xmlns:a16="http://schemas.microsoft.com/office/drawing/2014/main" id="{3BA73E4D-38EE-48BD-80A9-794A2762F6A7}"/>
+                <a16:creationId xmlns:a16="http://schemas.microsoft.com/office/drawing/2014/main" id="{05CDD0D3-F6B2-4921-9B24-4FEC740A33B1}"/>
               </a:ext>
             </a:extLst>
           </p:cNvPr>
@@ -9322,7 +9264,7 @@
           <p:cNvPr id="15" name="">
             <a:extLst xmlns:a="http://schemas.openxmlformats.org/drawingml/2006/main">
               <a:ext uri="{FF2B5EF4-FFF2-40B4-BE49-F238E27FC236}">
-                <a16:creationId xmlns:a16="http://schemas.microsoft.com/office/drawing/2014/main" id="{00C286D7-6098-4900-8D53-403AEEF31111}"/>
+                <a16:creationId xmlns:a16="http://schemas.microsoft.com/office/drawing/2014/main" id="{6804FC0F-E5C4-4F06-8ED9-1794F119C05D}"/>
               </a:ext>
             </a:extLst>
           </p:cNvPr>
@@ -9380,7 +9322,7 @@
           <p:cNvPr id="16" name="">
             <a:extLst xmlns:a="http://schemas.openxmlformats.org/drawingml/2006/main">
               <a:ext uri="{FF2B5EF4-FFF2-40B4-BE49-F238E27FC236}">
-                <a16:creationId xmlns:a16="http://schemas.microsoft.com/office/drawing/2014/main" id="{BC931C84-99F4-4CC6-8F1E-479CDB20651B}"/>
+                <a16:creationId xmlns:a16="http://schemas.microsoft.com/office/drawing/2014/main" id="{0FA5B64C-74D5-43F5-91D5-DD1FEEDFDCD3}"/>
               </a:ext>
             </a:extLst>
           </p:cNvPr>
@@ -9413,7 +9355,7 @@
           <p:cNvPr id="17" name="">
             <a:extLst xmlns:a="http://schemas.openxmlformats.org/drawingml/2006/main">
               <a:ext uri="{FF2B5EF4-FFF2-40B4-BE49-F238E27FC236}">
-                <a16:creationId xmlns:a16="http://schemas.microsoft.com/office/drawing/2014/main" id="{D9C08B38-5D37-4020-8F00-50C71A2706FD}"/>
+                <a16:creationId xmlns:a16="http://schemas.microsoft.com/office/drawing/2014/main" id="{50B3694C-56EC-414F-A2F0-EE45A173071C}"/>
               </a:ext>
             </a:extLst>
           </p:cNvPr>
@@ -9653,7 +9595,7 @@
           <p:cNvPr id="25" name="">
             <a:extLst xmlns:a="http://schemas.openxmlformats.org/drawingml/2006/main">
               <a:ext uri="{FF2B5EF4-FFF2-40B4-BE49-F238E27FC236}">
-                <a16:creationId xmlns:a16="http://schemas.microsoft.com/office/drawing/2014/main" id="{18D7C959-C049-449D-9C0C-D796BB8FA173}"/>
+                <a16:creationId xmlns:a16="http://schemas.microsoft.com/office/drawing/2014/main" id="{F65DCC44-862C-44EA-8C40-968B0ACFCA85}"/>
               </a:ext>
             </a:extLst>
           </p:cNvPr>
@@ -9711,7 +9653,7 @@
           <p:cNvPr id="26" name="">
             <a:extLst xmlns:a="http://schemas.openxmlformats.org/drawingml/2006/main">
               <a:ext uri="{FF2B5EF4-FFF2-40B4-BE49-F238E27FC236}">
-                <a16:creationId xmlns:a16="http://schemas.microsoft.com/office/drawing/2014/main" id="{C06DB5BE-14A7-493E-8FA6-BF8996C0B335}"/>
+                <a16:creationId xmlns:a16="http://schemas.microsoft.com/office/drawing/2014/main" id="{D9BECA32-CF36-4011-AF4D-E6E3C30446F6}"/>
               </a:ext>
             </a:extLst>
           </p:cNvPr>
@@ -9769,7 +9711,7 @@
           <p:cNvPr id="27" name="">
             <a:extLst xmlns:a="http://schemas.openxmlformats.org/drawingml/2006/main">
               <a:ext uri="{FF2B5EF4-FFF2-40B4-BE49-F238E27FC236}">
-                <a16:creationId xmlns:a16="http://schemas.microsoft.com/office/drawing/2014/main" id="{9126F822-209F-43D6-916E-264CDBA7BAFC}"/>
+                <a16:creationId xmlns:a16="http://schemas.microsoft.com/office/drawing/2014/main" id="{5B096667-1E07-4ED0-9AC9-B45E1BCB7FCE}"/>
               </a:ext>
             </a:extLst>
           </p:cNvPr>
@@ -9827,7 +9769,7 @@
           <p:cNvPr id="28" name="">
             <a:extLst xmlns:a="http://schemas.openxmlformats.org/drawingml/2006/main">
               <a:ext uri="{FF2B5EF4-FFF2-40B4-BE49-F238E27FC236}">
-                <a16:creationId xmlns:a16="http://schemas.microsoft.com/office/drawing/2014/main" id="{A9101652-ED6B-4571-A9CE-90522F76B4F3}"/>
+                <a16:creationId xmlns:a16="http://schemas.microsoft.com/office/drawing/2014/main" id="{D137B9E5-8893-49F9-9AD4-B9A1AE54F41A}"/>
               </a:ext>
             </a:extLst>
           </p:cNvPr>
@@ -9891,7 +9833,7 @@
           <p:cNvPr id="29" name="">
             <a:extLst xmlns:a="http://schemas.openxmlformats.org/drawingml/2006/main">
               <a:ext uri="{FF2B5EF4-FFF2-40B4-BE49-F238E27FC236}">
-                <a16:creationId xmlns:a16="http://schemas.microsoft.com/office/drawing/2014/main" id="{3073E8ED-BA40-4BE5-BA20-9986EEE32A2C}"/>
+                <a16:creationId xmlns:a16="http://schemas.microsoft.com/office/drawing/2014/main" id="{8D775212-B38F-4F6C-9DE9-60643D77F62D}"/>
               </a:ext>
             </a:extLst>
           </p:cNvPr>
@@ -9955,7 +9897,7 @@
           <p:cNvPr id="30" name="">
             <a:extLst xmlns:a="http://schemas.openxmlformats.org/drawingml/2006/main">
               <a:ext uri="{FF2B5EF4-FFF2-40B4-BE49-F238E27FC236}">
-                <a16:creationId xmlns:a16="http://schemas.microsoft.com/office/drawing/2014/main" id="{4BF26F49-452F-4892-80A5-52BDAC1FA930}"/>
+                <a16:creationId xmlns:a16="http://schemas.microsoft.com/office/drawing/2014/main" id="{BB070BE3-6AD4-4C7E-8061-F3D52085FF44}"/>
               </a:ext>
             </a:extLst>
           </p:cNvPr>
@@ -10011,7 +9953,7 @@
     </p:spTree>
     <p:extLst>
       <p:ext uri="{BB962C8B-B14F-4D97-AF65-F5344CB8AC3E}">
-        <p14:creationId xmlns:p14="http://schemas.microsoft.com/office/powerpoint/2010/main" val="1762843563"/>
+        <p14:creationId xmlns:p14="http://schemas.microsoft.com/office/powerpoint/2010/main" val="1921940953"/>
       </p:ext>
     </p:extLst>
   </p:cSld>
@@ -10042,7 +9984,7 @@
           <p:cNvPr id="40" name="">
             <a:extLst xmlns:a="http://schemas.openxmlformats.org/drawingml/2006/main">
               <a:ext uri="{FF2B5EF4-FFF2-40B4-BE49-F238E27FC236}">
-                <a16:creationId xmlns:a16="http://schemas.microsoft.com/office/drawing/2014/main" id="{650C5A19-34E8-4077-9409-73FCA0DC21FD}"/>
+                <a16:creationId xmlns:a16="http://schemas.microsoft.com/office/drawing/2014/main" id="{4A88D03A-4328-4C91-A9EB-B546BBCC89AB}"/>
               </a:ext>
             </a:extLst>
           </p:cNvPr>
@@ -10100,7 +10042,7 @@
           <p:cNvPr id="2" name="">
             <a:extLst xmlns:a="http://schemas.openxmlformats.org/drawingml/2006/main">
               <a:ext uri="{FF2B5EF4-FFF2-40B4-BE49-F238E27FC236}">
-                <a16:creationId xmlns:a16="http://schemas.microsoft.com/office/drawing/2014/main" id="{AC22BE7C-F3D5-4E7C-BC9E-071CE7E81F05}"/>
+                <a16:creationId xmlns:a16="http://schemas.microsoft.com/office/drawing/2014/main" id="{5B83BB79-5F0E-4155-80D6-2E20D45AC554}"/>
               </a:ext>
             </a:extLst>
           </p:cNvPr>
@@ -10158,7 +10100,7 @@
           <p:cNvPr id="3" name="">
             <a:extLst xmlns:a="http://schemas.openxmlformats.org/drawingml/2006/main">
               <a:ext uri="{FF2B5EF4-FFF2-40B4-BE49-F238E27FC236}">
-                <a16:creationId xmlns:a16="http://schemas.microsoft.com/office/drawing/2014/main" id="{F31E27D6-DC0D-4F45-8857-D90BA28C0D2F}"/>
+                <a16:creationId xmlns:a16="http://schemas.microsoft.com/office/drawing/2014/main" id="{03EC1EDA-5FC9-4A06-B981-04AE0886C74C}"/>
               </a:ext>
             </a:extLst>
           </p:cNvPr>
@@ -10189,7 +10131,7 @@
           <p:cNvPr id="4" name="">
             <a:extLst xmlns:a="http://schemas.openxmlformats.org/drawingml/2006/main">
               <a:ext uri="{FF2B5EF4-FFF2-40B4-BE49-F238E27FC236}">
-                <a16:creationId xmlns:a16="http://schemas.microsoft.com/office/drawing/2014/main" id="{4C872BF9-771A-40F8-B172-088AF4FAF751}"/>
+                <a16:creationId xmlns:a16="http://schemas.microsoft.com/office/drawing/2014/main" id="{6C8D184D-4592-48D9-8EA9-C0A8C7B43760}"/>
               </a:ext>
             </a:extLst>
           </p:cNvPr>
@@ -10222,7 +10164,7 @@
           <p:cNvPr id="5" name="">
             <a:extLst xmlns:a="http://schemas.openxmlformats.org/drawingml/2006/main">
               <a:ext uri="{FF2B5EF4-FFF2-40B4-BE49-F238E27FC236}">
-                <a16:creationId xmlns:a16="http://schemas.microsoft.com/office/drawing/2014/main" id="{20DE315A-ED07-4BA2-9899-42BC0D823DEB}"/>
+                <a16:creationId xmlns:a16="http://schemas.microsoft.com/office/drawing/2014/main" id="{1360D5CA-E4FB-4D94-9621-13507507B551}"/>
               </a:ext>
             </a:extLst>
           </p:cNvPr>
@@ -10255,7 +10197,7 @@
           <p:cNvPr id="6" name="">
             <a:extLst xmlns:a="http://schemas.openxmlformats.org/drawingml/2006/main">
               <a:ext uri="{FF2B5EF4-FFF2-40B4-BE49-F238E27FC236}">
-                <a16:creationId xmlns:a16="http://schemas.microsoft.com/office/drawing/2014/main" id="{F0750244-9CFC-4EC8-ADFC-CA265BD0297C}"/>
+                <a16:creationId xmlns:a16="http://schemas.microsoft.com/office/drawing/2014/main" id="{836EA78E-8751-4FCA-93FC-DD59EE06CC6D}"/>
               </a:ext>
             </a:extLst>
           </p:cNvPr>
@@ -10288,7 +10230,7 @@
           <p:cNvPr id="7" name="">
             <a:extLst xmlns:a="http://schemas.openxmlformats.org/drawingml/2006/main">
               <a:ext uri="{FF2B5EF4-FFF2-40B4-BE49-F238E27FC236}">
-                <a16:creationId xmlns:a16="http://schemas.microsoft.com/office/drawing/2014/main" id="{A8A6E14D-AE75-45E8-A21C-D92670075173}"/>
+                <a16:creationId xmlns:a16="http://schemas.microsoft.com/office/drawing/2014/main" id="{15AD2BC5-75E0-4A91-BA3B-9F699A89330A}"/>
               </a:ext>
             </a:extLst>
           </p:cNvPr>
@@ -10321,7 +10263,7 @@
           <p:cNvPr id="8" name="">
             <a:extLst xmlns:a="http://schemas.openxmlformats.org/drawingml/2006/main">
               <a:ext uri="{FF2B5EF4-FFF2-40B4-BE49-F238E27FC236}">
-                <a16:creationId xmlns:a16="http://schemas.microsoft.com/office/drawing/2014/main" id="{1EFF527F-343A-4B1A-AA8E-C3B63BB5B9D4}"/>
+                <a16:creationId xmlns:a16="http://schemas.microsoft.com/office/drawing/2014/main" id="{B9D8E8AC-5443-43A8-B59B-25E454972041}"/>
               </a:ext>
             </a:extLst>
           </p:cNvPr>
@@ -10354,7 +10296,7 @@
           <p:cNvPr id="9" name="">
             <a:extLst xmlns:a="http://schemas.openxmlformats.org/drawingml/2006/main">
               <a:ext uri="{FF2B5EF4-FFF2-40B4-BE49-F238E27FC236}">
-                <a16:creationId xmlns:a16="http://schemas.microsoft.com/office/drawing/2014/main" id="{25F97389-4374-445F-8805-EF9E8E3EFA29}"/>
+                <a16:creationId xmlns:a16="http://schemas.microsoft.com/office/drawing/2014/main" id="{6557E0AB-2AE2-4684-8BC2-1FBBD86FB899}"/>
               </a:ext>
             </a:extLst>
           </p:cNvPr>
@@ -10385,7 +10327,7 @@
           <p:cNvPr id="10" name="">
             <a:extLst xmlns:a="http://schemas.openxmlformats.org/drawingml/2006/main">
               <a:ext uri="{FF2B5EF4-FFF2-40B4-BE49-F238E27FC236}">
-                <a16:creationId xmlns:a16="http://schemas.microsoft.com/office/drawing/2014/main" id="{E12196C5-74C5-44EF-8DE4-5B9F19FF93A4}"/>
+                <a16:creationId xmlns:a16="http://schemas.microsoft.com/office/drawing/2014/main" id="{DD813682-1149-48DF-A7BC-2F0A2490274B}"/>
               </a:ext>
             </a:extLst>
           </p:cNvPr>
@@ -10418,7 +10360,7 @@
           <p:cNvPr id="11" name="">
             <a:extLst xmlns:a="http://schemas.openxmlformats.org/drawingml/2006/main">
               <a:ext uri="{FF2B5EF4-FFF2-40B4-BE49-F238E27FC236}">
-                <a16:creationId xmlns:a16="http://schemas.microsoft.com/office/drawing/2014/main" id="{20D2A669-D964-4020-8B68-E97D1ECA4905}"/>
+                <a16:creationId xmlns:a16="http://schemas.microsoft.com/office/drawing/2014/main" id="{BADC832E-4E1B-474E-A7EB-63C15493A903}"/>
               </a:ext>
             </a:extLst>
           </p:cNvPr>
@@ -10659,7 +10601,7 @@
           <p:cNvPr id="20" name="">
             <a:extLst xmlns:a="http://schemas.openxmlformats.org/drawingml/2006/main">
               <a:ext uri="{FF2B5EF4-FFF2-40B4-BE49-F238E27FC236}">
-                <a16:creationId xmlns:a16="http://schemas.microsoft.com/office/drawing/2014/main" id="{E9E7E896-30B9-4327-9000-D47E5ADFAF5F}"/>
+                <a16:creationId xmlns:a16="http://schemas.microsoft.com/office/drawing/2014/main" id="{74B29DCE-3DD4-4E7D-98C6-D4989263C732}"/>
               </a:ext>
             </a:extLst>
           </p:cNvPr>
@@ -10692,7 +10634,7 @@
           <p:cNvPr id="21" name="">
             <a:extLst xmlns:a="http://schemas.openxmlformats.org/drawingml/2006/main">
               <a:ext uri="{FF2B5EF4-FFF2-40B4-BE49-F238E27FC236}">
-                <a16:creationId xmlns:a16="http://schemas.microsoft.com/office/drawing/2014/main" id="{56962062-FC95-4A10-8FC6-DC1301C3DD93}"/>
+                <a16:creationId xmlns:a16="http://schemas.microsoft.com/office/drawing/2014/main" id="{7963E898-048B-453B-9F36-9AB6F4F2D127}"/>
               </a:ext>
             </a:extLst>
           </p:cNvPr>
@@ -10725,7 +10667,7 @@
           <p:cNvPr id="22" name="">
             <a:extLst xmlns:a="http://schemas.openxmlformats.org/drawingml/2006/main">
               <a:ext uri="{FF2B5EF4-FFF2-40B4-BE49-F238E27FC236}">
-                <a16:creationId xmlns:a16="http://schemas.microsoft.com/office/drawing/2014/main" id="{B3A828D7-FCEB-417F-B46A-E6A52F2A4785}"/>
+                <a16:creationId xmlns:a16="http://schemas.microsoft.com/office/drawing/2014/main" id="{F9135364-5B97-46B5-AB8C-768A38CFDD18}"/>
               </a:ext>
             </a:extLst>
           </p:cNvPr>
@@ -10758,7 +10700,7 @@
           <p:cNvPr id="23" name="">
             <a:extLst xmlns:a="http://schemas.openxmlformats.org/drawingml/2006/main">
               <a:ext uri="{FF2B5EF4-FFF2-40B4-BE49-F238E27FC236}">
-                <a16:creationId xmlns:a16="http://schemas.microsoft.com/office/drawing/2014/main" id="{71AA7310-7A37-4754-9DDB-9AE679E15838}"/>
+                <a16:creationId xmlns:a16="http://schemas.microsoft.com/office/drawing/2014/main" id="{0B3A8451-5CC2-4C6E-9D0D-5956741F51F9}"/>
               </a:ext>
             </a:extLst>
           </p:cNvPr>
@@ -10791,7 +10733,7 @@
           <p:cNvPr id="24" name="">
             <a:extLst xmlns:a="http://schemas.openxmlformats.org/drawingml/2006/main">
               <a:ext uri="{FF2B5EF4-FFF2-40B4-BE49-F238E27FC236}">
-                <a16:creationId xmlns:a16="http://schemas.microsoft.com/office/drawing/2014/main" id="{B6D93D1E-A6EF-46F4-8DB3-0049C62AA50A}"/>
+                <a16:creationId xmlns:a16="http://schemas.microsoft.com/office/drawing/2014/main" id="{2DBA191D-59F1-4B69-8F73-CAABCF261489}"/>
               </a:ext>
             </a:extLst>
           </p:cNvPr>
@@ -10824,7 +10766,7 @@
           <p:cNvPr id="25" name="">
             <a:extLst xmlns:a="http://schemas.openxmlformats.org/drawingml/2006/main">
               <a:ext uri="{FF2B5EF4-FFF2-40B4-BE49-F238E27FC236}">
-                <a16:creationId xmlns:a16="http://schemas.microsoft.com/office/drawing/2014/main" id="{05718D61-846B-48F6-846D-E3E20FF297FA}"/>
+                <a16:creationId xmlns:a16="http://schemas.microsoft.com/office/drawing/2014/main" id="{C26B707A-6F81-4C96-A952-C36FC28D4217}"/>
               </a:ext>
             </a:extLst>
           </p:cNvPr>
@@ -10855,7 +10797,7 @@
           <p:cNvPr id="26" name="">
             <a:extLst xmlns:a="http://schemas.openxmlformats.org/drawingml/2006/main">
               <a:ext uri="{FF2B5EF4-FFF2-40B4-BE49-F238E27FC236}">
-                <a16:creationId xmlns:a16="http://schemas.microsoft.com/office/drawing/2014/main" id="{F95C41A7-CE88-4D37-85C2-43E099E271D6}"/>
+                <a16:creationId xmlns:a16="http://schemas.microsoft.com/office/drawing/2014/main" id="{CBF2074F-C1B8-40D9-9A28-C6B9E55B7A2A}"/>
               </a:ext>
             </a:extLst>
           </p:cNvPr>
@@ -10888,7 +10830,7 @@
           <p:cNvPr id="27" name="">
             <a:extLst xmlns:a="http://schemas.openxmlformats.org/drawingml/2006/main">
               <a:ext uri="{FF2B5EF4-FFF2-40B4-BE49-F238E27FC236}">
-                <a16:creationId xmlns:a16="http://schemas.microsoft.com/office/drawing/2014/main" id="{DE13EB48-6BF6-44CD-B783-4A6C4944C368}"/>
+                <a16:creationId xmlns:a16="http://schemas.microsoft.com/office/drawing/2014/main" id="{2F26F875-BBD5-46AF-B5DD-16F506CF5891}"/>
               </a:ext>
             </a:extLst>
           </p:cNvPr>
@@ -11129,7 +11071,7 @@
           <p:cNvPr id="36" name="">
             <a:extLst xmlns:a="http://schemas.openxmlformats.org/drawingml/2006/main">
               <a:ext uri="{FF2B5EF4-FFF2-40B4-BE49-F238E27FC236}">
-                <a16:creationId xmlns:a16="http://schemas.microsoft.com/office/drawing/2014/main" id="{7874E525-49AA-4A6A-A78F-189B39050DA5}"/>
+                <a16:creationId xmlns:a16="http://schemas.microsoft.com/office/drawing/2014/main" id="{02446AB3-26E1-4208-8480-ED8BE2FE2BCA}"/>
               </a:ext>
             </a:extLst>
           </p:cNvPr>
@@ -11187,7 +11129,7 @@
           <p:cNvPr id="37" name="">
             <a:extLst xmlns:a="http://schemas.openxmlformats.org/drawingml/2006/main">
               <a:ext uri="{FF2B5EF4-FFF2-40B4-BE49-F238E27FC236}">
-                <a16:creationId xmlns:a16="http://schemas.microsoft.com/office/drawing/2014/main" id="{ADEB55EF-C8B7-45A3-A7B3-B5CF4C3D4190}"/>
+                <a16:creationId xmlns:a16="http://schemas.microsoft.com/office/drawing/2014/main" id="{EF53408E-AFDC-47D6-A6F0-23D17C51F4EA}"/>
               </a:ext>
             </a:extLst>
           </p:cNvPr>
@@ -11245,7 +11187,7 @@
           <p:cNvPr id="38" name="">
             <a:extLst xmlns:a="http://schemas.openxmlformats.org/drawingml/2006/main">
               <a:ext uri="{FF2B5EF4-FFF2-40B4-BE49-F238E27FC236}">
-                <a16:creationId xmlns:a16="http://schemas.microsoft.com/office/drawing/2014/main" id="{EC507523-98D1-4E4D-8DC9-9E01D6135676}"/>
+                <a16:creationId xmlns:a16="http://schemas.microsoft.com/office/drawing/2014/main" id="{3EFE39C5-D331-4601-B488-F6F24C428086}"/>
               </a:ext>
             </a:extLst>
           </p:cNvPr>
@@ -11309,7 +11251,7 @@
           <p:cNvPr id="39" name="">
             <a:extLst xmlns:a="http://schemas.openxmlformats.org/drawingml/2006/main">
               <a:ext uri="{FF2B5EF4-FFF2-40B4-BE49-F238E27FC236}">
-                <a16:creationId xmlns:a16="http://schemas.microsoft.com/office/drawing/2014/main" id="{7E6F7C6B-BD38-491E-9901-BD9CE51F5AEF}"/>
+                <a16:creationId xmlns:a16="http://schemas.microsoft.com/office/drawing/2014/main" id="{AE67A7EB-DB30-4522-91A1-70C62AD81174}"/>
               </a:ext>
             </a:extLst>
           </p:cNvPr>
@@ -11371,7 +11313,7 @@
     </p:spTree>
     <p:extLst>
       <p:ext uri="{BB962C8B-B14F-4D97-AF65-F5344CB8AC3E}">
-        <p14:creationId xmlns:p14="http://schemas.microsoft.com/office/powerpoint/2010/main" val="1830040235"/>
+        <p14:creationId xmlns:p14="http://schemas.microsoft.com/office/powerpoint/2010/main" val="805194821"/>
       </p:ext>
     </p:extLst>
   </p:cSld>
@@ -11402,7 +11344,7 @@
           <p:cNvPr id="41" name="">
             <a:extLst xmlns:a="http://schemas.openxmlformats.org/drawingml/2006/main">
               <a:ext uri="{FF2B5EF4-FFF2-40B4-BE49-F238E27FC236}">
-                <a16:creationId xmlns:a16="http://schemas.microsoft.com/office/drawing/2014/main" id="{DCC4E70B-17CD-4B54-B554-D63C61FDD90E}"/>
+                <a16:creationId xmlns:a16="http://schemas.microsoft.com/office/drawing/2014/main" id="{E7808456-3393-41C1-B254-1D1F13C0EFD4}"/>
               </a:ext>
             </a:extLst>
           </p:cNvPr>
@@ -11460,7 +11402,7 @@
           <p:cNvPr id="2" name="">
             <a:extLst xmlns:a="http://schemas.openxmlformats.org/drawingml/2006/main">
               <a:ext uri="{FF2B5EF4-FFF2-40B4-BE49-F238E27FC236}">
-                <a16:creationId xmlns:a16="http://schemas.microsoft.com/office/drawing/2014/main" id="{8B326153-937B-42E3-9F93-55FF9E75D360}"/>
+                <a16:creationId xmlns:a16="http://schemas.microsoft.com/office/drawing/2014/main" id="{E08281EA-86E2-41B0-BDA2-FD1841D1C4FC}"/>
               </a:ext>
             </a:extLst>
           </p:cNvPr>
@@ -11541,7 +11483,7 @@
           <p:cNvPr id="3" name="">
             <a:extLst xmlns:a="http://schemas.openxmlformats.org/drawingml/2006/main">
               <a:ext uri="{FF2B5EF4-FFF2-40B4-BE49-F238E27FC236}">
-                <a16:creationId xmlns:a16="http://schemas.microsoft.com/office/drawing/2014/main" id="{F98CE765-6A1D-4F6B-A6B7-F2CE218C0D52}"/>
+                <a16:creationId xmlns:a16="http://schemas.microsoft.com/office/drawing/2014/main" id="{CF6091A7-4A88-4673-BC03-D825A3713C4B}"/>
               </a:ext>
             </a:extLst>
           </p:cNvPr>
@@ -11599,7 +11541,7 @@
           <p:cNvPr id="4" name="">
             <a:extLst xmlns:a="http://schemas.openxmlformats.org/drawingml/2006/main">
               <a:ext uri="{FF2B5EF4-FFF2-40B4-BE49-F238E27FC236}">
-                <a16:creationId xmlns:a16="http://schemas.microsoft.com/office/drawing/2014/main" id="{DFBE03BE-7C46-4A0F-B89B-79FB50C2285C}"/>
+                <a16:creationId xmlns:a16="http://schemas.microsoft.com/office/drawing/2014/main" id="{47E97C38-9B53-4625-9FA3-8BE1101DFBEF}"/>
               </a:ext>
             </a:extLst>
           </p:cNvPr>
@@ -11657,7 +11599,7 @@
           <p:cNvPr id="5" name="">
             <a:extLst xmlns:a="http://schemas.openxmlformats.org/drawingml/2006/main">
               <a:ext uri="{FF2B5EF4-FFF2-40B4-BE49-F238E27FC236}">
-                <a16:creationId xmlns:a16="http://schemas.microsoft.com/office/drawing/2014/main" id="{B0D68129-A0DA-4AA2-8366-933CCCB98137}"/>
+                <a16:creationId xmlns:a16="http://schemas.microsoft.com/office/drawing/2014/main" id="{E356FBA8-7417-475A-85FD-1C5D4FC2A49F}"/>
               </a:ext>
             </a:extLst>
           </p:cNvPr>
@@ -11690,7 +11632,7 @@
           <p:cNvPr id="6" name="">
             <a:extLst xmlns:a="http://schemas.openxmlformats.org/drawingml/2006/main">
               <a:ext uri="{FF2B5EF4-FFF2-40B4-BE49-F238E27FC236}">
-                <a16:creationId xmlns:a16="http://schemas.microsoft.com/office/drawing/2014/main" id="{13947C14-1CF5-483C-8A28-F118D0E4D118}"/>
+                <a16:creationId xmlns:a16="http://schemas.microsoft.com/office/drawing/2014/main" id="{F20CB85E-61A0-4C3A-B658-49A01DD59550}"/>
               </a:ext>
             </a:extLst>
           </p:cNvPr>
@@ -11723,7 +11665,7 @@
           <p:cNvPr id="7" name="">
             <a:extLst xmlns:a="http://schemas.openxmlformats.org/drawingml/2006/main">
               <a:ext uri="{FF2B5EF4-FFF2-40B4-BE49-F238E27FC236}">
-                <a16:creationId xmlns:a16="http://schemas.microsoft.com/office/drawing/2014/main" id="{D549CDC2-688E-43EA-B081-FB4114DA7F41}"/>
+                <a16:creationId xmlns:a16="http://schemas.microsoft.com/office/drawing/2014/main" id="{8EB068B5-5385-4867-986A-711BD042293F}"/>
               </a:ext>
             </a:extLst>
           </p:cNvPr>
@@ -11756,7 +11698,7 @@
           <p:cNvPr id="8" name="">
             <a:extLst xmlns:a="http://schemas.openxmlformats.org/drawingml/2006/main">
               <a:ext uri="{FF2B5EF4-FFF2-40B4-BE49-F238E27FC236}">
-                <a16:creationId xmlns:a16="http://schemas.microsoft.com/office/drawing/2014/main" id="{C8F325FE-EC34-485F-9079-475FEBEF3F84}"/>
+                <a16:creationId xmlns:a16="http://schemas.microsoft.com/office/drawing/2014/main" id="{4C5C1210-BC98-4F54-A1A8-E8A78E45D018}"/>
               </a:ext>
             </a:extLst>
           </p:cNvPr>
@@ -11867,7 +11809,7 @@
           <p:cNvPr id="12" name="">
             <a:extLst xmlns:a="http://schemas.openxmlformats.org/drawingml/2006/main">
               <a:ext uri="{FF2B5EF4-FFF2-40B4-BE49-F238E27FC236}">
-                <a16:creationId xmlns:a16="http://schemas.microsoft.com/office/drawing/2014/main" id="{A096CA5A-C4A7-480D-9398-EC9DE038C137}"/>
+                <a16:creationId xmlns:a16="http://schemas.microsoft.com/office/drawing/2014/main" id="{53ED2249-1C51-4609-8DF2-5645FC41C963}"/>
               </a:ext>
             </a:extLst>
           </p:cNvPr>
@@ -11900,7 +11842,7 @@
           <p:cNvPr id="13" name="">
             <a:extLst xmlns:a="http://schemas.openxmlformats.org/drawingml/2006/main">
               <a:ext uri="{FF2B5EF4-FFF2-40B4-BE49-F238E27FC236}">
-                <a16:creationId xmlns:a16="http://schemas.microsoft.com/office/drawing/2014/main" id="{34C7E4DC-1946-4449-BA2B-14B4EC9253A7}"/>
+                <a16:creationId xmlns:a16="http://schemas.microsoft.com/office/drawing/2014/main" id="{F04DAC9C-5107-48E1-9760-C04E42329DE4}"/>
               </a:ext>
             </a:extLst>
           </p:cNvPr>
@@ -11933,7 +11875,7 @@
           <p:cNvPr id="14" name="">
             <a:extLst xmlns:a="http://schemas.openxmlformats.org/drawingml/2006/main">
               <a:ext uri="{FF2B5EF4-FFF2-40B4-BE49-F238E27FC236}">
-                <a16:creationId xmlns:a16="http://schemas.microsoft.com/office/drawing/2014/main" id="{68AC00F2-FEED-405D-99A5-A51402635DB3}"/>
+                <a16:creationId xmlns:a16="http://schemas.microsoft.com/office/drawing/2014/main" id="{B57761F6-54AE-4DC9-B277-8D8B28FDCBC4}"/>
               </a:ext>
             </a:extLst>
           </p:cNvPr>
@@ -11966,7 +11908,7 @@
           <p:cNvPr id="15" name="">
             <a:extLst xmlns:a="http://schemas.openxmlformats.org/drawingml/2006/main">
               <a:ext uri="{FF2B5EF4-FFF2-40B4-BE49-F238E27FC236}">
-                <a16:creationId xmlns:a16="http://schemas.microsoft.com/office/drawing/2014/main" id="{815BE273-73D7-4D4F-A4C9-0F97E4793D32}"/>
+                <a16:creationId xmlns:a16="http://schemas.microsoft.com/office/drawing/2014/main" id="{C047EDD5-6C65-430A-96CE-0CC4D6A3E1D1}"/>
               </a:ext>
             </a:extLst>
           </p:cNvPr>
@@ -11999,7 +11941,7 @@
           <p:cNvPr id="16" name="">
             <a:extLst xmlns:a="http://schemas.openxmlformats.org/drawingml/2006/main">
               <a:ext uri="{FF2B5EF4-FFF2-40B4-BE49-F238E27FC236}">
-                <a16:creationId xmlns:a16="http://schemas.microsoft.com/office/drawing/2014/main" id="{415BE958-3DF4-4502-8667-751808CD07C0}"/>
+                <a16:creationId xmlns:a16="http://schemas.microsoft.com/office/drawing/2014/main" id="{46E76934-82D7-4F6D-B250-0034AF00762F}"/>
               </a:ext>
             </a:extLst>
           </p:cNvPr>
@@ -12030,7 +11972,7 @@
           <p:cNvPr id="17" name="">
             <a:extLst xmlns:a="http://schemas.openxmlformats.org/drawingml/2006/main">
               <a:ext uri="{FF2B5EF4-FFF2-40B4-BE49-F238E27FC236}">
-                <a16:creationId xmlns:a16="http://schemas.microsoft.com/office/drawing/2014/main" id="{7DEFA3F5-E71A-4C14-BA56-78254A75C59F}"/>
+                <a16:creationId xmlns:a16="http://schemas.microsoft.com/office/drawing/2014/main" id="{6FA8CCF5-A2BC-412F-A853-A2979BC1F47F}"/>
               </a:ext>
             </a:extLst>
           </p:cNvPr>
@@ -12193,7 +12135,7 @@
           <p:cNvPr id="23" name="">
             <a:extLst xmlns:a="http://schemas.openxmlformats.org/drawingml/2006/main">
               <a:ext uri="{FF2B5EF4-FFF2-40B4-BE49-F238E27FC236}">
-                <a16:creationId xmlns:a16="http://schemas.microsoft.com/office/drawing/2014/main" id="{4B286D20-43C8-4352-8484-643A5BED0D70}"/>
+                <a16:creationId xmlns:a16="http://schemas.microsoft.com/office/drawing/2014/main" id="{A5B305A7-167B-4DE9-9982-6F3FF1D77E6D}"/>
               </a:ext>
             </a:extLst>
           </p:cNvPr>
@@ -12226,7 +12168,7 @@
           <p:cNvPr id="24" name="">
             <a:extLst xmlns:a="http://schemas.openxmlformats.org/drawingml/2006/main">
               <a:ext uri="{FF2B5EF4-FFF2-40B4-BE49-F238E27FC236}">
-                <a16:creationId xmlns:a16="http://schemas.microsoft.com/office/drawing/2014/main" id="{12388650-F41B-4960-A092-6291DED055C0}"/>
+                <a16:creationId xmlns:a16="http://schemas.microsoft.com/office/drawing/2014/main" id="{78697FF1-A6EF-40B3-A301-C9AA06B97EDA}"/>
               </a:ext>
             </a:extLst>
           </p:cNvPr>
@@ -12259,7 +12201,7 @@
           <p:cNvPr id="25" name="">
             <a:extLst xmlns:a="http://schemas.openxmlformats.org/drawingml/2006/main">
               <a:ext uri="{FF2B5EF4-FFF2-40B4-BE49-F238E27FC236}">
-                <a16:creationId xmlns:a16="http://schemas.microsoft.com/office/drawing/2014/main" id="{B72BF957-9F84-4C1B-A87C-3DA04009779D}"/>
+                <a16:creationId xmlns:a16="http://schemas.microsoft.com/office/drawing/2014/main" id="{28C7F909-9154-4537-B00D-DD5044FFF103}"/>
               </a:ext>
             </a:extLst>
           </p:cNvPr>
@@ -12292,7 +12234,7 @@
           <p:cNvPr id="26" name="">
             <a:extLst xmlns:a="http://schemas.openxmlformats.org/drawingml/2006/main">
               <a:ext uri="{FF2B5EF4-FFF2-40B4-BE49-F238E27FC236}">
-                <a16:creationId xmlns:a16="http://schemas.microsoft.com/office/drawing/2014/main" id="{17914CF5-057B-4B73-9985-8CE244EA8D4F}"/>
+                <a16:creationId xmlns:a16="http://schemas.microsoft.com/office/drawing/2014/main" id="{9001D108-20B1-4E02-8798-47848457E0DE}"/>
               </a:ext>
             </a:extLst>
           </p:cNvPr>
@@ -12323,7 +12265,7 @@
           <p:cNvPr id="27" name="">
             <a:extLst xmlns:a="http://schemas.openxmlformats.org/drawingml/2006/main">
               <a:ext uri="{FF2B5EF4-FFF2-40B4-BE49-F238E27FC236}">
-                <a16:creationId xmlns:a16="http://schemas.microsoft.com/office/drawing/2014/main" id="{AC1FF980-7EE0-4E86-97F9-33C13809A957}"/>
+                <a16:creationId xmlns:a16="http://schemas.microsoft.com/office/drawing/2014/main" id="{1B4CB8D7-BDB3-4CDB-B8AF-039A71CAAC3A}"/>
               </a:ext>
             </a:extLst>
           </p:cNvPr>
@@ -12356,7 +12298,7 @@
           <p:cNvPr id="28" name="">
             <a:extLst xmlns:a="http://schemas.openxmlformats.org/drawingml/2006/main">
               <a:ext uri="{FF2B5EF4-FFF2-40B4-BE49-F238E27FC236}">
-                <a16:creationId xmlns:a16="http://schemas.microsoft.com/office/drawing/2014/main" id="{90515BB2-1923-4B71-9426-081279576F79}"/>
+                <a16:creationId xmlns:a16="http://schemas.microsoft.com/office/drawing/2014/main" id="{3E28B54D-CC3E-4E8D-BC1B-C39006BABACD}"/>
               </a:ext>
             </a:extLst>
           </p:cNvPr>
@@ -12389,7 +12331,7 @@
           <p:cNvPr id="29" name="">
             <a:extLst xmlns:a="http://schemas.openxmlformats.org/drawingml/2006/main">
               <a:ext uri="{FF2B5EF4-FFF2-40B4-BE49-F238E27FC236}">
-                <a16:creationId xmlns:a16="http://schemas.microsoft.com/office/drawing/2014/main" id="{B50577C4-8B18-47B5-9A8A-9432D97DCAA8}"/>
+                <a16:creationId xmlns:a16="http://schemas.microsoft.com/office/drawing/2014/main" id="{BD4626CF-3301-42F9-A6D8-04E291C9EBAC}"/>
               </a:ext>
             </a:extLst>
           </p:cNvPr>
@@ -12422,7 +12364,7 @@
           <p:cNvPr id="30" name="">
             <a:extLst xmlns:a="http://schemas.openxmlformats.org/drawingml/2006/main">
               <a:ext uri="{FF2B5EF4-FFF2-40B4-BE49-F238E27FC236}">
-                <a16:creationId xmlns:a16="http://schemas.microsoft.com/office/drawing/2014/main" id="{7D2AA956-2E43-4CD9-A660-0C08AC604A92}"/>
+                <a16:creationId xmlns:a16="http://schemas.microsoft.com/office/drawing/2014/main" id="{D96C755A-BEFF-4630-BCEA-954B4F40AAF7}"/>
               </a:ext>
             </a:extLst>
           </p:cNvPr>
@@ -12455,7 +12397,7 @@
           <p:cNvPr id="31" name="">
             <a:extLst xmlns:a="http://schemas.openxmlformats.org/drawingml/2006/main">
               <a:ext uri="{FF2B5EF4-FFF2-40B4-BE49-F238E27FC236}">
-                <a16:creationId xmlns:a16="http://schemas.microsoft.com/office/drawing/2014/main" id="{B92857D8-5E52-46DF-A1F8-BCCD0285A3F0}"/>
+                <a16:creationId xmlns:a16="http://schemas.microsoft.com/office/drawing/2014/main" id="{1812ABF9-4907-427F-AE8A-934EBBED5095}"/>
               </a:ext>
             </a:extLst>
           </p:cNvPr>
@@ -12488,7 +12430,7 @@
           <p:cNvPr id="32" name="">
             <a:extLst xmlns:a="http://schemas.openxmlformats.org/drawingml/2006/main">
               <a:ext uri="{FF2B5EF4-FFF2-40B4-BE49-F238E27FC236}">
-                <a16:creationId xmlns:a16="http://schemas.microsoft.com/office/drawing/2014/main" id="{40B06CF3-3964-4AB2-93A6-56ACDBBD33AC}"/>
+                <a16:creationId xmlns:a16="http://schemas.microsoft.com/office/drawing/2014/main" id="{6C149D2A-EF1B-4C4A-AACD-5F1879F7DCBE}"/>
               </a:ext>
             </a:extLst>
           </p:cNvPr>
@@ -12521,7 +12463,7 @@
           <p:cNvPr id="33" name="">
             <a:extLst xmlns:a="http://schemas.openxmlformats.org/drawingml/2006/main">
               <a:ext uri="{FF2B5EF4-FFF2-40B4-BE49-F238E27FC236}">
-                <a16:creationId xmlns:a16="http://schemas.microsoft.com/office/drawing/2014/main" id="{E9FC1524-2164-4A69-963A-3FF3B7603881}"/>
+                <a16:creationId xmlns:a16="http://schemas.microsoft.com/office/drawing/2014/main" id="{2F91ED8F-4A68-4AF3-BE74-FB5B0DDEF073}"/>
               </a:ext>
             </a:extLst>
           </p:cNvPr>
@@ -12604,7 +12546,7 @@
           <p:cNvPr id="36" name="">
             <a:extLst xmlns:a="http://schemas.openxmlformats.org/drawingml/2006/main">
               <a:ext uri="{FF2B5EF4-FFF2-40B4-BE49-F238E27FC236}">
-                <a16:creationId xmlns:a16="http://schemas.microsoft.com/office/drawing/2014/main" id="{074ED1AA-93AC-4746-A988-B6629895DCA0}"/>
+                <a16:creationId xmlns:a16="http://schemas.microsoft.com/office/drawing/2014/main" id="{04D17122-A077-4AB9-9A6E-28584CCE8D97}"/>
               </a:ext>
             </a:extLst>
           </p:cNvPr>
@@ -12637,7 +12579,7 @@
           <p:cNvPr id="37" name="">
             <a:extLst xmlns:a="http://schemas.openxmlformats.org/drawingml/2006/main">
               <a:ext uri="{FF2B5EF4-FFF2-40B4-BE49-F238E27FC236}">
-                <a16:creationId xmlns:a16="http://schemas.microsoft.com/office/drawing/2014/main" id="{36D040F9-DB14-493F-8C37-BC193B2EE603}"/>
+                <a16:creationId xmlns:a16="http://schemas.microsoft.com/office/drawing/2014/main" id="{3771821F-C3C1-46FE-8E6C-A2ED620710C1}"/>
               </a:ext>
             </a:extLst>
           </p:cNvPr>
@@ -12695,7 +12637,7 @@
           <p:cNvPr id="38" name="">
             <a:extLst xmlns:a="http://schemas.openxmlformats.org/drawingml/2006/main">
               <a:ext uri="{FF2B5EF4-FFF2-40B4-BE49-F238E27FC236}">
-                <a16:creationId xmlns:a16="http://schemas.microsoft.com/office/drawing/2014/main" id="{76056F4F-3E97-49CD-B1FE-C5207B31F32C}"/>
+                <a16:creationId xmlns:a16="http://schemas.microsoft.com/office/drawing/2014/main" id="{000AB659-53E3-4230-A2B7-8E2FC2092751}"/>
               </a:ext>
             </a:extLst>
           </p:cNvPr>
@@ -12753,7 +12695,7 @@
           <p:cNvPr id="39" name="">
             <a:extLst xmlns:a="http://schemas.openxmlformats.org/drawingml/2006/main">
               <a:ext uri="{FF2B5EF4-FFF2-40B4-BE49-F238E27FC236}">
-                <a16:creationId xmlns:a16="http://schemas.microsoft.com/office/drawing/2014/main" id="{088756FE-D72B-49CC-AE79-13C21C5B274A}"/>
+                <a16:creationId xmlns:a16="http://schemas.microsoft.com/office/drawing/2014/main" id="{22C3CE11-42F8-4748-BC58-4C4D0107811D}"/>
               </a:ext>
             </a:extLst>
           </p:cNvPr>
@@ -12811,7 +12753,7 @@
           <p:cNvPr id="40" name="">
             <a:extLst xmlns:a="http://schemas.openxmlformats.org/drawingml/2006/main">
               <a:ext uri="{FF2B5EF4-FFF2-40B4-BE49-F238E27FC236}">
-                <a16:creationId xmlns:a16="http://schemas.microsoft.com/office/drawing/2014/main" id="{0A630469-9639-4D07-9F87-88CBD1B8127B}"/>
+                <a16:creationId xmlns:a16="http://schemas.microsoft.com/office/drawing/2014/main" id="{0ADAAACA-CA7F-4DE9-A998-F4EB85FBE25D}"/>
               </a:ext>
             </a:extLst>
           </p:cNvPr>
@@ -12867,7 +12809,7 @@
     </p:spTree>
     <p:extLst>
       <p:ext uri="{BB962C8B-B14F-4D97-AF65-F5344CB8AC3E}">
-        <p14:creationId xmlns:p14="http://schemas.microsoft.com/office/powerpoint/2010/main" val="996333694"/>
+        <p14:creationId xmlns:p14="http://schemas.microsoft.com/office/powerpoint/2010/main" val="343967891"/>
       </p:ext>
     </p:extLst>
   </p:cSld>

</xml_diff>

<commit_message>
Update presentation content and visuals: refine terminology and adjust layout elements
</commit_message>
<xml_diff>
--- a/.codex-build/presentation-visuals/candidate.pptx
+++ b/.codex-build/presentation-visuals/candidate.pptx
@@ -2,20 +2,20 @@
 <file path=ppt/presentation.xml><?xml version="1.0" encoding="utf-8"?>
 <p:presentation xmlns:p="http://schemas.openxmlformats.org/presentationml/2006/main">
   <p:sldMasterIdLst>
-    <p:sldMasterId xmlns:r="http://schemas.openxmlformats.org/officeDocument/2006/relationships" id="2147483648" r:id="R45d375dfc0b341b0"/>
+    <p:sldMasterId xmlns:r="http://schemas.openxmlformats.org/officeDocument/2006/relationships" id="2147483648" r:id="R53388c2e29504b61"/>
   </p:sldMasterIdLst>
   <p:notesMasterIdLst>
-    <p:notesMasterId xmlns:r="http://schemas.openxmlformats.org/officeDocument/2006/relationships" r:id="Rd996617344b54215"/>
+    <p:notesMasterId xmlns:r="http://schemas.openxmlformats.org/officeDocument/2006/relationships" r:id="Ra457b6a64eca448a"/>
   </p:notesMasterIdLst>
   <p:sldIdLst>
-    <p:sldId xmlns:r="http://schemas.openxmlformats.org/officeDocument/2006/relationships" id="256" r:id="R7dbf94485ec74cf5"/>
-    <p:sldId xmlns:r="http://schemas.openxmlformats.org/officeDocument/2006/relationships" id="257" r:id="R25c19f0426c549d2"/>
-    <p:sldId xmlns:r="http://schemas.openxmlformats.org/officeDocument/2006/relationships" id="258" r:id="Rdb386e6d5584495d"/>
-    <p:sldId xmlns:r="http://schemas.openxmlformats.org/officeDocument/2006/relationships" id="259" r:id="R90d7745a14894937"/>
-    <p:sldId xmlns:r="http://schemas.openxmlformats.org/officeDocument/2006/relationships" id="260" r:id="Rfb0c70b70509499f"/>
-    <p:sldId xmlns:r="http://schemas.openxmlformats.org/officeDocument/2006/relationships" id="261" r:id="R1cccf586e3f048ec"/>
-    <p:sldId xmlns:r="http://schemas.openxmlformats.org/officeDocument/2006/relationships" id="262" r:id="Re981fa971ced4884"/>
-    <p:sldId xmlns:r="http://schemas.openxmlformats.org/officeDocument/2006/relationships" id="263" r:id="R874d42ce1abe42f6"/>
+    <p:sldId xmlns:r="http://schemas.openxmlformats.org/officeDocument/2006/relationships" id="256" r:id="Rdeaec776715d4271"/>
+    <p:sldId xmlns:r="http://schemas.openxmlformats.org/officeDocument/2006/relationships" id="257" r:id="R43c8d5bfb1d446cc"/>
+    <p:sldId xmlns:r="http://schemas.openxmlformats.org/officeDocument/2006/relationships" id="258" r:id="Rf85610dfd1334359"/>
+    <p:sldId xmlns:r="http://schemas.openxmlformats.org/officeDocument/2006/relationships" id="259" r:id="R1bd133726a114540"/>
+    <p:sldId xmlns:r="http://schemas.openxmlformats.org/officeDocument/2006/relationships" id="260" r:id="R5fb3b1eee6384d74"/>
+    <p:sldId xmlns:r="http://schemas.openxmlformats.org/officeDocument/2006/relationships" id="261" r:id="R79255a916fbd4a48"/>
+    <p:sldId xmlns:r="http://schemas.openxmlformats.org/officeDocument/2006/relationships" id="262" r:id="Re6a33744c11c497a"/>
+    <p:sldId xmlns:r="http://schemas.openxmlformats.org/officeDocument/2006/relationships" id="263" r:id="R07b19c0efa0241de"/>
   </p:sldIdLst>
   <p:sldSz cx="12192000" cy="6858000"/>
   <p:notesSz cx="6858000" cy="9144000"/>
@@ -975,7 +975,7 @@
   </p:cSld>
   <p:clrMap bg1="lt1" tx1="dk1" bg2="lt2" tx2="dk2" accent1="accent1" accent2="accent2" accent3="accent3" accent4="accent4" accent5="accent5" accent6="accent6" hlink="hlink" folHlink="folHlink"/>
   <p:sldLayoutIdLst>
-    <p:sldLayoutId xmlns:r="http://schemas.openxmlformats.org/officeDocument/2006/relationships" id="2147483649" r:id="R17f2a59549f946b7"/>
+    <p:sldLayoutId xmlns:r="http://schemas.openxmlformats.org/officeDocument/2006/relationships" id="2147483649" r:id="Rd856887d82e0414d"/>
   </p:sldLayoutIdLst>
   <p:txStyles>
     <p:titleStyle>
@@ -1526,7 +1526,7 @@
           <p:cNvPr id="29" name="">
             <a:extLst xmlns:a="http://schemas.openxmlformats.org/drawingml/2006/main">
               <a:ext uri="{FF2B5EF4-FFF2-40B4-BE49-F238E27FC236}">
-                <a16:creationId xmlns:a16="http://schemas.microsoft.com/office/drawing/2014/main" id="{2C643AC4-8B77-43A5-9C66-DBBB25FC22C8}"/>
+                <a16:creationId xmlns:a16="http://schemas.microsoft.com/office/drawing/2014/main" id="{93CAFD81-E6E4-4232-8FF9-DDD777E21E55}"/>
               </a:ext>
             </a:extLst>
           </p:cNvPr>
@@ -1559,7 +1559,7 @@
           <p:cNvPr id="2" name="">
             <a:extLst xmlns:a="http://schemas.openxmlformats.org/drawingml/2006/main">
               <a:ext uri="{FF2B5EF4-FFF2-40B4-BE49-F238E27FC236}">
-                <a16:creationId xmlns:a16="http://schemas.microsoft.com/office/drawing/2014/main" id="{D123C210-7817-4472-9B62-0D0B359162D9}"/>
+                <a16:creationId xmlns:a16="http://schemas.microsoft.com/office/drawing/2014/main" id="{0657A42A-C3DE-4665-B315-B7B0645A81B7}"/>
               </a:ext>
             </a:extLst>
           </p:cNvPr>
@@ -1592,7 +1592,7 @@
           <p:cNvPr id="3" name="">
             <a:extLst xmlns:a="http://schemas.openxmlformats.org/drawingml/2006/main">
               <a:ext uri="{FF2B5EF4-FFF2-40B4-BE49-F238E27FC236}">
-                <a16:creationId xmlns:a16="http://schemas.microsoft.com/office/drawing/2014/main" id="{41DD717B-9559-4FEC-B12F-7584DD62995D}"/>
+                <a16:creationId xmlns:a16="http://schemas.microsoft.com/office/drawing/2014/main" id="{0830B6C7-3174-47A4-9CE7-A7A778BEB783}"/>
               </a:ext>
             </a:extLst>
           </p:cNvPr>
@@ -1625,7 +1625,7 @@
           <p:cNvPr id="4" name="">
             <a:extLst xmlns:a="http://schemas.openxmlformats.org/drawingml/2006/main">
               <a:ext uri="{FF2B5EF4-FFF2-40B4-BE49-F238E27FC236}">
-                <a16:creationId xmlns:a16="http://schemas.microsoft.com/office/drawing/2014/main" id="{EE38E213-8772-458C-99A3-A376F6E4D518}"/>
+                <a16:creationId xmlns:a16="http://schemas.microsoft.com/office/drawing/2014/main" id="{3223B17F-D25F-4C5F-A31F-6FE290153D53}"/>
               </a:ext>
             </a:extLst>
           </p:cNvPr>
@@ -1658,7 +1658,7 @@
           <p:cNvPr id="5" name="">
             <a:extLst xmlns:a="http://schemas.openxmlformats.org/drawingml/2006/main">
               <a:ext uri="{FF2B5EF4-FFF2-40B4-BE49-F238E27FC236}">
-                <a16:creationId xmlns:a16="http://schemas.microsoft.com/office/drawing/2014/main" id="{9FBE0498-F863-4872-A99A-CE067BBAF8C1}"/>
+                <a16:creationId xmlns:a16="http://schemas.microsoft.com/office/drawing/2014/main" id="{9D4B0BE5-25C3-4FA7-9904-F6821B598295}"/>
               </a:ext>
             </a:extLst>
           </p:cNvPr>
@@ -1769,7 +1769,7 @@
           <p:cNvPr id="9" name="">
             <a:extLst xmlns:a="http://schemas.openxmlformats.org/drawingml/2006/main">
               <a:ext uri="{FF2B5EF4-FFF2-40B4-BE49-F238E27FC236}">
-                <a16:creationId xmlns:a16="http://schemas.microsoft.com/office/drawing/2014/main" id="{1FE44472-A9BD-4EBC-A5B6-BF756D0C5D4C}"/>
+                <a16:creationId xmlns:a16="http://schemas.microsoft.com/office/drawing/2014/main" id="{B9574605-5A54-4A3B-9601-D61D74B82F12}"/>
               </a:ext>
             </a:extLst>
           </p:cNvPr>
@@ -1833,7 +1833,7 @@
           <p:cNvPr id="10" name="">
             <a:extLst xmlns:a="http://schemas.openxmlformats.org/drawingml/2006/main">
               <a:ext uri="{FF2B5EF4-FFF2-40B4-BE49-F238E27FC236}">
-                <a16:creationId xmlns:a16="http://schemas.microsoft.com/office/drawing/2014/main" id="{263DA058-4267-4234-A863-DAA66118BCD4}"/>
+                <a16:creationId xmlns:a16="http://schemas.microsoft.com/office/drawing/2014/main" id="{750E0577-8D26-4E35-A5EE-8DE7D415B1E5}"/>
               </a:ext>
             </a:extLst>
           </p:cNvPr>
@@ -1891,7 +1891,7 @@
           <p:cNvPr id="11" name="">
             <a:extLst xmlns:a="http://schemas.openxmlformats.org/drawingml/2006/main">
               <a:ext uri="{FF2B5EF4-FFF2-40B4-BE49-F238E27FC236}">
-                <a16:creationId xmlns:a16="http://schemas.microsoft.com/office/drawing/2014/main" id="{EE01C2BA-5EF3-44B8-B27E-3CCB6BEC0BF0}"/>
+                <a16:creationId xmlns:a16="http://schemas.microsoft.com/office/drawing/2014/main" id="{CC90F7BE-2635-483B-A7EB-4086507F6544}"/>
               </a:ext>
             </a:extLst>
           </p:cNvPr>
@@ -1924,7 +1924,7 @@
           <p:cNvPr id="12" name="">
             <a:extLst xmlns:a="http://schemas.openxmlformats.org/drawingml/2006/main">
               <a:ext uri="{FF2B5EF4-FFF2-40B4-BE49-F238E27FC236}">
-                <a16:creationId xmlns:a16="http://schemas.microsoft.com/office/drawing/2014/main" id="{EDDA3234-723F-4EC2-981F-03578619D89D}"/>
+                <a16:creationId xmlns:a16="http://schemas.microsoft.com/office/drawing/2014/main" id="{862E6C1C-F459-4560-A291-1850ACE41115}"/>
               </a:ext>
             </a:extLst>
           </p:cNvPr>
@@ -1982,7 +1982,7 @@
           <p:cNvPr id="13" name="">
             <a:extLst xmlns:a="http://schemas.openxmlformats.org/drawingml/2006/main">
               <a:ext uri="{FF2B5EF4-FFF2-40B4-BE49-F238E27FC236}">
-                <a16:creationId xmlns:a16="http://schemas.microsoft.com/office/drawing/2014/main" id="{D4FB93F3-67A0-44CE-A6D0-7822397B7305}"/>
+                <a16:creationId xmlns:a16="http://schemas.microsoft.com/office/drawing/2014/main" id="{8D11020E-0E2C-44EA-AB25-630E36E3714F}"/>
               </a:ext>
             </a:extLst>
           </p:cNvPr>
@@ -2015,7 +2015,7 @@
           <p:cNvPr id="14" name="">
             <a:extLst xmlns:a="http://schemas.openxmlformats.org/drawingml/2006/main">
               <a:ext uri="{FF2B5EF4-FFF2-40B4-BE49-F238E27FC236}">
-                <a16:creationId xmlns:a16="http://schemas.microsoft.com/office/drawing/2014/main" id="{38D5E175-1D47-469D-90E3-C22EC79B078C}"/>
+                <a16:creationId xmlns:a16="http://schemas.microsoft.com/office/drawing/2014/main" id="{D645EFAF-8CD6-449C-8D93-71E18A67214F}"/>
               </a:ext>
             </a:extLst>
           </p:cNvPr>
@@ -2073,7 +2073,7 @@
           <p:cNvPr id="15" name="">
             <a:extLst xmlns:a="http://schemas.openxmlformats.org/drawingml/2006/main">
               <a:ext uri="{FF2B5EF4-FFF2-40B4-BE49-F238E27FC236}">
-                <a16:creationId xmlns:a16="http://schemas.microsoft.com/office/drawing/2014/main" id="{DE387E74-8D7D-4A15-BE3E-BC15181CB8FA}"/>
+                <a16:creationId xmlns:a16="http://schemas.microsoft.com/office/drawing/2014/main" id="{E63A42F4-A34C-4E79-ADF8-9720479DB749}"/>
               </a:ext>
             </a:extLst>
           </p:cNvPr>
@@ -2106,7 +2106,7 @@
           <p:cNvPr id="16" name="">
             <a:extLst xmlns:a="http://schemas.openxmlformats.org/drawingml/2006/main">
               <a:ext uri="{FF2B5EF4-FFF2-40B4-BE49-F238E27FC236}">
-                <a16:creationId xmlns:a16="http://schemas.microsoft.com/office/drawing/2014/main" id="{A52B00A8-02AE-46FB-918B-5355A0563143}"/>
+                <a16:creationId xmlns:a16="http://schemas.microsoft.com/office/drawing/2014/main" id="{0A87E332-DDE1-474A-A374-9FFCC0E6E23C}"/>
               </a:ext>
             </a:extLst>
           </p:cNvPr>
@@ -2137,7 +2137,7 @@
           <p:cNvPr id="17" name="">
             <a:extLst xmlns:a="http://schemas.openxmlformats.org/drawingml/2006/main">
               <a:ext uri="{FF2B5EF4-FFF2-40B4-BE49-F238E27FC236}">
-                <a16:creationId xmlns:a16="http://schemas.microsoft.com/office/drawing/2014/main" id="{C1695F8C-5F32-43B6-9763-31E801837DD1}"/>
+                <a16:creationId xmlns:a16="http://schemas.microsoft.com/office/drawing/2014/main" id="{33B3B7EE-AC08-4CAE-B64E-066CE0F9F337}"/>
               </a:ext>
             </a:extLst>
           </p:cNvPr>
@@ -2195,7 +2195,7 @@
           <p:cNvPr id="18" name="">
             <a:extLst xmlns:a="http://schemas.openxmlformats.org/drawingml/2006/main">
               <a:ext uri="{FF2B5EF4-FFF2-40B4-BE49-F238E27FC236}">
-                <a16:creationId xmlns:a16="http://schemas.microsoft.com/office/drawing/2014/main" id="{D1F746D6-6DA9-4552-B7AD-20649D0575D2}"/>
+                <a16:creationId xmlns:a16="http://schemas.microsoft.com/office/drawing/2014/main" id="{6BCCBF69-845F-4E9C-9AD3-BB848ADBA10B}"/>
               </a:ext>
             </a:extLst>
           </p:cNvPr>
@@ -2228,7 +2228,7 @@
           <p:cNvPr id="19" name="">
             <a:extLst xmlns:a="http://schemas.openxmlformats.org/drawingml/2006/main">
               <a:ext uri="{FF2B5EF4-FFF2-40B4-BE49-F238E27FC236}">
-                <a16:creationId xmlns:a16="http://schemas.microsoft.com/office/drawing/2014/main" id="{080607AF-0AF0-4FDB-9BD7-C6B448954200}"/>
+                <a16:creationId xmlns:a16="http://schemas.microsoft.com/office/drawing/2014/main" id="{4FD6A4E5-9EAF-4726-AF33-9F6A96325BCE}"/>
               </a:ext>
             </a:extLst>
           </p:cNvPr>
@@ -2364,7 +2364,7 @@
           <p:cNvPr id="23" name="">
             <a:extLst xmlns:a="http://schemas.openxmlformats.org/drawingml/2006/main">
               <a:ext uri="{FF2B5EF4-FFF2-40B4-BE49-F238E27FC236}">
-                <a16:creationId xmlns:a16="http://schemas.microsoft.com/office/drawing/2014/main" id="{1CC98805-BE2C-49EB-88FE-C3207BE9C6DC}"/>
+                <a16:creationId xmlns:a16="http://schemas.microsoft.com/office/drawing/2014/main" id="{411FE7F4-EB3B-40FD-8D98-FCA706446355}"/>
               </a:ext>
             </a:extLst>
           </p:cNvPr>
@@ -2422,7 +2422,7 @@
           <p:cNvPr id="24" name="">
             <a:extLst xmlns:a="http://schemas.openxmlformats.org/drawingml/2006/main">
               <a:ext uri="{FF2B5EF4-FFF2-40B4-BE49-F238E27FC236}">
-                <a16:creationId xmlns:a16="http://schemas.microsoft.com/office/drawing/2014/main" id="{B1F471F7-6C7A-46E1-8434-A4EF464F1008}"/>
+                <a16:creationId xmlns:a16="http://schemas.microsoft.com/office/drawing/2014/main" id="{F4B7D1A6-4ABF-4C74-BC66-255F0A33273A}"/>
               </a:ext>
             </a:extLst>
           </p:cNvPr>
@@ -2480,7 +2480,7 @@
           <p:cNvPr id="25" name="">
             <a:extLst xmlns:a="http://schemas.openxmlformats.org/drawingml/2006/main">
               <a:ext uri="{FF2B5EF4-FFF2-40B4-BE49-F238E27FC236}">
-                <a16:creationId xmlns:a16="http://schemas.microsoft.com/office/drawing/2014/main" id="{286B1E3F-751E-4AAB-A954-F0054C4F13C7}"/>
+                <a16:creationId xmlns:a16="http://schemas.microsoft.com/office/drawing/2014/main" id="{F14B98DD-03C7-421F-B259-2E417DEC3C6C}"/>
               </a:ext>
             </a:extLst>
           </p:cNvPr>
@@ -2538,7 +2538,7 @@
           <p:cNvPr id="26" name="">
             <a:extLst xmlns:a="http://schemas.openxmlformats.org/drawingml/2006/main">
               <a:ext uri="{FF2B5EF4-FFF2-40B4-BE49-F238E27FC236}">
-                <a16:creationId xmlns:a16="http://schemas.microsoft.com/office/drawing/2014/main" id="{81930ABE-7762-4463-BC0B-0208570C69A3}"/>
+                <a16:creationId xmlns:a16="http://schemas.microsoft.com/office/drawing/2014/main" id="{1A7E8B73-43A4-4DE5-95E4-129A2F8DEBF4}"/>
               </a:ext>
             </a:extLst>
           </p:cNvPr>
@@ -2596,7 +2596,7 @@
           <p:cNvPr id="27" name="">
             <a:extLst xmlns:a="http://schemas.openxmlformats.org/drawingml/2006/main">
               <a:ext uri="{FF2B5EF4-FFF2-40B4-BE49-F238E27FC236}">
-                <a16:creationId xmlns:a16="http://schemas.microsoft.com/office/drawing/2014/main" id="{ADA4C815-192B-45A2-9075-115455BF1068}"/>
+                <a16:creationId xmlns:a16="http://schemas.microsoft.com/office/drawing/2014/main" id="{3E19AA77-3B25-4BB8-86AA-64A7ACB68BDC}"/>
               </a:ext>
             </a:extLst>
           </p:cNvPr>
@@ -2654,7 +2654,7 @@
           <p:cNvPr id="28" name="">
             <a:extLst xmlns:a="http://schemas.openxmlformats.org/drawingml/2006/main">
               <a:ext uri="{FF2B5EF4-FFF2-40B4-BE49-F238E27FC236}">
-                <a16:creationId xmlns:a16="http://schemas.microsoft.com/office/drawing/2014/main" id="{6698D28F-4003-4AB9-82A3-7395516AAE96}"/>
+                <a16:creationId xmlns:a16="http://schemas.microsoft.com/office/drawing/2014/main" id="{884B6347-9116-4576-8DC6-5C7C579E0A8F}"/>
               </a:ext>
             </a:extLst>
           </p:cNvPr>
@@ -2710,7 +2710,7 @@
     </p:spTree>
     <p:extLst>
       <p:ext uri="{BB962C8B-B14F-4D97-AF65-F5344CB8AC3E}">
-        <p14:creationId xmlns:p14="http://schemas.microsoft.com/office/powerpoint/2010/main" val="283361567"/>
+        <p14:creationId xmlns:p14="http://schemas.microsoft.com/office/powerpoint/2010/main" val="1341571849"/>
       </p:ext>
     </p:extLst>
   </p:cSld>
@@ -2741,7 +2741,7 @@
           <p:cNvPr id="42" name="">
             <a:extLst xmlns:a="http://schemas.openxmlformats.org/drawingml/2006/main">
               <a:ext uri="{FF2B5EF4-FFF2-40B4-BE49-F238E27FC236}">
-                <a16:creationId xmlns:a16="http://schemas.microsoft.com/office/drawing/2014/main" id="{84D28F0C-B7B9-4B89-85A5-23B85EAA81AA}"/>
+                <a16:creationId xmlns:a16="http://schemas.microsoft.com/office/drawing/2014/main" id="{9D994A40-2384-49B2-9DDD-1E735B1C5B72}"/>
               </a:ext>
             </a:extLst>
           </p:cNvPr>
@@ -2774,7 +2774,7 @@
           <p:cNvPr id="2" name="">
             <a:extLst xmlns:a="http://schemas.openxmlformats.org/drawingml/2006/main">
               <a:ext uri="{FF2B5EF4-FFF2-40B4-BE49-F238E27FC236}">
-                <a16:creationId xmlns:a16="http://schemas.microsoft.com/office/drawing/2014/main" id="{ABFE86FE-9118-4B95-B34E-88E23ABFA045}"/>
+                <a16:creationId xmlns:a16="http://schemas.microsoft.com/office/drawing/2014/main" id="{D9122382-7BCF-4BB0-B1AD-DD3992D3448B}"/>
               </a:ext>
             </a:extLst>
           </p:cNvPr>
@@ -2807,7 +2807,7 @@
           <p:cNvPr id="3" name="">
             <a:extLst xmlns:a="http://schemas.openxmlformats.org/drawingml/2006/main">
               <a:ext uri="{FF2B5EF4-FFF2-40B4-BE49-F238E27FC236}">
-                <a16:creationId xmlns:a16="http://schemas.microsoft.com/office/drawing/2014/main" id="{E33C9026-D536-4B86-909E-4046AD591DE3}"/>
+                <a16:creationId xmlns:a16="http://schemas.microsoft.com/office/drawing/2014/main" id="{8121B5F1-0A5F-462E-B48D-A49A782FDA7A}"/>
               </a:ext>
             </a:extLst>
           </p:cNvPr>
@@ -2840,7 +2840,7 @@
           <p:cNvPr id="4" name="">
             <a:extLst xmlns:a="http://schemas.openxmlformats.org/drawingml/2006/main">
               <a:ext uri="{FF2B5EF4-FFF2-40B4-BE49-F238E27FC236}">
-                <a16:creationId xmlns:a16="http://schemas.microsoft.com/office/drawing/2014/main" id="{4DE8424E-FAE9-4E4C-82DA-27DD3424A913}"/>
+                <a16:creationId xmlns:a16="http://schemas.microsoft.com/office/drawing/2014/main" id="{50876A41-4DCB-40F2-B35F-DCB9A3B65336}"/>
               </a:ext>
             </a:extLst>
           </p:cNvPr>
@@ -2951,7 +2951,7 @@
           <p:cNvPr id="8" name="">
             <a:extLst xmlns:a="http://schemas.openxmlformats.org/drawingml/2006/main">
               <a:ext uri="{FF2B5EF4-FFF2-40B4-BE49-F238E27FC236}">
-                <a16:creationId xmlns:a16="http://schemas.microsoft.com/office/drawing/2014/main" id="{391F70A4-8BC1-47A0-867D-1B8DD69DD806}"/>
+                <a16:creationId xmlns:a16="http://schemas.microsoft.com/office/drawing/2014/main" id="{3C4316FE-E00E-4665-A8FA-0679892A889A}"/>
               </a:ext>
             </a:extLst>
           </p:cNvPr>
@@ -2984,7 +2984,7 @@
           <p:cNvPr id="9" name="">
             <a:extLst xmlns:a="http://schemas.openxmlformats.org/drawingml/2006/main">
               <a:ext uri="{FF2B5EF4-FFF2-40B4-BE49-F238E27FC236}">
-                <a16:creationId xmlns:a16="http://schemas.microsoft.com/office/drawing/2014/main" id="{58BA640E-8330-4ED6-8893-93F30EDB4F34}"/>
+                <a16:creationId xmlns:a16="http://schemas.microsoft.com/office/drawing/2014/main" id="{94C65E28-73CF-4695-B9B0-E65C6A6AEEE2}"/>
               </a:ext>
             </a:extLst>
           </p:cNvPr>
@@ -3017,7 +3017,7 @@
           <p:cNvPr id="10" name="">
             <a:extLst xmlns:a="http://schemas.openxmlformats.org/drawingml/2006/main">
               <a:ext uri="{FF2B5EF4-FFF2-40B4-BE49-F238E27FC236}">
-                <a16:creationId xmlns:a16="http://schemas.microsoft.com/office/drawing/2014/main" id="{3C475F52-A702-4BD7-8B54-3E0098E2DC6D}"/>
+                <a16:creationId xmlns:a16="http://schemas.microsoft.com/office/drawing/2014/main" id="{C043273F-29BA-490D-AF95-D8ED248766EB}"/>
               </a:ext>
             </a:extLst>
           </p:cNvPr>
@@ -3050,7 +3050,7 @@
           <p:cNvPr id="11" name="">
             <a:extLst xmlns:a="http://schemas.openxmlformats.org/drawingml/2006/main">
               <a:ext uri="{FF2B5EF4-FFF2-40B4-BE49-F238E27FC236}">
-                <a16:creationId xmlns:a16="http://schemas.microsoft.com/office/drawing/2014/main" id="{3D006904-989C-4292-B153-CB30014320E2}"/>
+                <a16:creationId xmlns:a16="http://schemas.microsoft.com/office/drawing/2014/main" id="{E42B3A60-B9D0-4DB0-B4C0-51930CB0E760}"/>
               </a:ext>
             </a:extLst>
           </p:cNvPr>
@@ -3161,7 +3161,7 @@
           <p:cNvPr id="15" name="">
             <a:extLst xmlns:a="http://schemas.openxmlformats.org/drawingml/2006/main">
               <a:ext uri="{FF2B5EF4-FFF2-40B4-BE49-F238E27FC236}">
-                <a16:creationId xmlns:a16="http://schemas.microsoft.com/office/drawing/2014/main" id="{C939E2A6-60E2-4816-87E6-05561819A461}"/>
+                <a16:creationId xmlns:a16="http://schemas.microsoft.com/office/drawing/2014/main" id="{A62AFB9A-B44E-4BCD-ABB8-162A92F0E392}"/>
               </a:ext>
             </a:extLst>
           </p:cNvPr>
@@ -3194,7 +3194,7 @@
           <p:cNvPr id="16" name="">
             <a:extLst xmlns:a="http://schemas.openxmlformats.org/drawingml/2006/main">
               <a:ext uri="{FF2B5EF4-FFF2-40B4-BE49-F238E27FC236}">
-                <a16:creationId xmlns:a16="http://schemas.microsoft.com/office/drawing/2014/main" id="{1E346C81-8DD2-4286-881D-19FF2A4E5861}"/>
+                <a16:creationId xmlns:a16="http://schemas.microsoft.com/office/drawing/2014/main" id="{AE1C68E5-7B92-41ED-AE95-EC5B619CDF5D}"/>
               </a:ext>
             </a:extLst>
           </p:cNvPr>
@@ -3253,7 +3253,7 @@
           <p:cNvPr id="18" name="">
             <a:extLst xmlns:a="http://schemas.openxmlformats.org/drawingml/2006/main">
               <a:ext uri="{FF2B5EF4-FFF2-40B4-BE49-F238E27FC236}">
-                <a16:creationId xmlns:a16="http://schemas.microsoft.com/office/drawing/2014/main" id="{AD79CFFE-C77D-40EA-9A87-311083F5E383}"/>
+                <a16:creationId xmlns:a16="http://schemas.microsoft.com/office/drawing/2014/main" id="{C0A27A0F-0816-4727-BCDB-BC3890FD4894}"/>
               </a:ext>
             </a:extLst>
           </p:cNvPr>
@@ -3312,7 +3312,7 @@
           <p:cNvPr id="20" name="">
             <a:extLst xmlns:a="http://schemas.openxmlformats.org/drawingml/2006/main">
               <a:ext uri="{FF2B5EF4-FFF2-40B4-BE49-F238E27FC236}">
-                <a16:creationId xmlns:a16="http://schemas.microsoft.com/office/drawing/2014/main" id="{E2A7C548-E8FA-4F23-8C0A-FC06E8798935}"/>
+                <a16:creationId xmlns:a16="http://schemas.microsoft.com/office/drawing/2014/main" id="{A81C89D3-7C6B-4DF1-A0C7-709A6781CF53}"/>
               </a:ext>
             </a:extLst>
           </p:cNvPr>
@@ -3371,7 +3371,7 @@
           <p:cNvPr id="22" name="">
             <a:extLst xmlns:a="http://schemas.openxmlformats.org/drawingml/2006/main">
               <a:ext uri="{FF2B5EF4-FFF2-40B4-BE49-F238E27FC236}">
-                <a16:creationId xmlns:a16="http://schemas.microsoft.com/office/drawing/2014/main" id="{560171DA-9520-47E1-B8F3-64EF16211C38}"/>
+                <a16:creationId xmlns:a16="http://schemas.microsoft.com/office/drawing/2014/main" id="{22F0BE50-6CBB-48D4-A456-AD9B3BA0C11B}"/>
               </a:ext>
             </a:extLst>
           </p:cNvPr>
@@ -3435,7 +3435,7 @@
           <p:cNvPr id="23" name="">
             <a:extLst xmlns:a="http://schemas.openxmlformats.org/drawingml/2006/main">
               <a:ext uri="{FF2B5EF4-FFF2-40B4-BE49-F238E27FC236}">
-                <a16:creationId xmlns:a16="http://schemas.microsoft.com/office/drawing/2014/main" id="{8459521A-E483-4DEB-9DC3-2C01AA5B52CD}"/>
+                <a16:creationId xmlns:a16="http://schemas.microsoft.com/office/drawing/2014/main" id="{1F4E67D9-70F6-4C03-B2D2-BDA6BB7F57A0}"/>
               </a:ext>
             </a:extLst>
           </p:cNvPr>
@@ -3551,7 +3551,7 @@
           <p:cNvPr id="26" name="">
             <a:extLst xmlns:a="http://schemas.openxmlformats.org/drawingml/2006/main">
               <a:ext uri="{FF2B5EF4-FFF2-40B4-BE49-F238E27FC236}">
-                <a16:creationId xmlns:a16="http://schemas.microsoft.com/office/drawing/2014/main" id="{EEDDFCBE-FE49-4AC5-843F-D3586A805B56}"/>
+                <a16:creationId xmlns:a16="http://schemas.microsoft.com/office/drawing/2014/main" id="{F1F68AC9-2B2E-45A0-98F9-26987DF6DB7A}"/>
               </a:ext>
             </a:extLst>
           </p:cNvPr>
@@ -3584,7 +3584,7 @@
           <p:cNvPr id="27" name="">
             <a:extLst xmlns:a="http://schemas.openxmlformats.org/drawingml/2006/main">
               <a:ext uri="{FF2B5EF4-FFF2-40B4-BE49-F238E27FC236}">
-                <a16:creationId xmlns:a16="http://schemas.microsoft.com/office/drawing/2014/main" id="{75D3D16A-A9F8-4DF6-AB4F-4268ACE8726F}"/>
+                <a16:creationId xmlns:a16="http://schemas.microsoft.com/office/drawing/2014/main" id="{5FBD3BFE-5FBF-4ACB-A8A3-E9096A3893EA}"/>
               </a:ext>
             </a:extLst>
           </p:cNvPr>
@@ -3617,7 +3617,7 @@
           <p:cNvPr id="28" name="">
             <a:extLst xmlns:a="http://schemas.openxmlformats.org/drawingml/2006/main">
               <a:ext uri="{FF2B5EF4-FFF2-40B4-BE49-F238E27FC236}">
-                <a16:creationId xmlns:a16="http://schemas.microsoft.com/office/drawing/2014/main" id="{7E3B2FDB-B919-4F02-9816-B85C3AC59A90}"/>
+                <a16:creationId xmlns:a16="http://schemas.microsoft.com/office/drawing/2014/main" id="{9428C34B-A9DD-4F66-B0A0-F7BA260CD6DB}"/>
               </a:ext>
             </a:extLst>
           </p:cNvPr>
@@ -3650,7 +3650,7 @@
           <p:cNvPr id="29" name="">
             <a:extLst xmlns:a="http://schemas.openxmlformats.org/drawingml/2006/main">
               <a:ext uri="{FF2B5EF4-FFF2-40B4-BE49-F238E27FC236}">
-                <a16:creationId xmlns:a16="http://schemas.microsoft.com/office/drawing/2014/main" id="{C5974443-B392-4F89-A389-F0D067A83427}"/>
+                <a16:creationId xmlns:a16="http://schemas.microsoft.com/office/drawing/2014/main" id="{E4B2646D-30F0-46E0-A125-C219DD88000E}"/>
               </a:ext>
             </a:extLst>
           </p:cNvPr>
@@ -3683,7 +3683,7 @@
           <p:cNvPr id="30" name="">
             <a:extLst xmlns:a="http://schemas.openxmlformats.org/drawingml/2006/main">
               <a:ext uri="{FF2B5EF4-FFF2-40B4-BE49-F238E27FC236}">
-                <a16:creationId xmlns:a16="http://schemas.microsoft.com/office/drawing/2014/main" id="{63A33B1E-C446-4662-9AEF-F7A0262CD7B3}"/>
+                <a16:creationId xmlns:a16="http://schemas.microsoft.com/office/drawing/2014/main" id="{86823958-E6D5-4F1C-B8D6-189185AAC1F3}"/>
               </a:ext>
             </a:extLst>
           </p:cNvPr>
@@ -3792,7 +3792,7 @@
           <p:cNvPr id="34" name="">
             <a:extLst xmlns:a="http://schemas.openxmlformats.org/drawingml/2006/main">
               <a:ext uri="{FF2B5EF4-FFF2-40B4-BE49-F238E27FC236}">
-                <a16:creationId xmlns:a16="http://schemas.microsoft.com/office/drawing/2014/main" id="{27439BE3-C644-4AA4-B7B5-CE0771AEFB63}"/>
+                <a16:creationId xmlns:a16="http://schemas.microsoft.com/office/drawing/2014/main" id="{830F0A2E-3C2B-466E-87D9-E318E3EBF09A}"/>
               </a:ext>
             </a:extLst>
           </p:cNvPr>
@@ -3873,7 +3873,7 @@
           <p:cNvPr id="35" name="">
             <a:extLst xmlns:a="http://schemas.openxmlformats.org/drawingml/2006/main">
               <a:ext uri="{FF2B5EF4-FFF2-40B4-BE49-F238E27FC236}">
-                <a16:creationId xmlns:a16="http://schemas.microsoft.com/office/drawing/2014/main" id="{D53CC2B2-6E43-4295-8B26-64879207789A}"/>
+                <a16:creationId xmlns:a16="http://schemas.microsoft.com/office/drawing/2014/main" id="{A8B6823D-D2A2-4DBA-B24A-48D72EAE558F}"/>
               </a:ext>
             </a:extLst>
           </p:cNvPr>
@@ -3931,7 +3931,7 @@
           <p:cNvPr id="36" name="">
             <a:extLst xmlns:a="http://schemas.openxmlformats.org/drawingml/2006/main">
               <a:ext uri="{FF2B5EF4-FFF2-40B4-BE49-F238E27FC236}">
-                <a16:creationId xmlns:a16="http://schemas.microsoft.com/office/drawing/2014/main" id="{0E7D518D-9642-448B-B024-9135290397CA}"/>
+                <a16:creationId xmlns:a16="http://schemas.microsoft.com/office/drawing/2014/main" id="{A2A7670B-66C9-4854-B91F-37F37CBDAA48}"/>
               </a:ext>
             </a:extLst>
           </p:cNvPr>
@@ -4012,7 +4012,7 @@
           <p:cNvPr id="37" name="">
             <a:extLst xmlns:a="http://schemas.openxmlformats.org/drawingml/2006/main">
               <a:ext uri="{FF2B5EF4-FFF2-40B4-BE49-F238E27FC236}">
-                <a16:creationId xmlns:a16="http://schemas.microsoft.com/office/drawing/2014/main" id="{C19F8455-A36F-4D3C-86CA-C7322A48717E}"/>
+                <a16:creationId xmlns:a16="http://schemas.microsoft.com/office/drawing/2014/main" id="{8CFD9F0B-2727-4A2D-AE1F-AF467C57ECE1}"/>
               </a:ext>
             </a:extLst>
           </p:cNvPr>
@@ -4093,7 +4093,7 @@
           <p:cNvPr id="38" name="">
             <a:extLst xmlns:a="http://schemas.openxmlformats.org/drawingml/2006/main">
               <a:ext uri="{FF2B5EF4-FFF2-40B4-BE49-F238E27FC236}">
-                <a16:creationId xmlns:a16="http://schemas.microsoft.com/office/drawing/2014/main" id="{612380C6-7BEA-4E11-9BBF-E260C9757B71}"/>
+                <a16:creationId xmlns:a16="http://schemas.microsoft.com/office/drawing/2014/main" id="{CA903174-CF05-4CA9-8C28-2A712A8B422B}"/>
               </a:ext>
             </a:extLst>
           </p:cNvPr>
@@ -4174,7 +4174,7 @@
           <p:cNvPr id="39" name="">
             <a:extLst xmlns:a="http://schemas.openxmlformats.org/drawingml/2006/main">
               <a:ext uri="{FF2B5EF4-FFF2-40B4-BE49-F238E27FC236}">
-                <a16:creationId xmlns:a16="http://schemas.microsoft.com/office/drawing/2014/main" id="{CE9DC8F5-5471-4C7C-B221-4F164D472C83}"/>
+                <a16:creationId xmlns:a16="http://schemas.microsoft.com/office/drawing/2014/main" id="{6777EBCC-E4F8-4B0C-B7A2-AC3273D9D925}"/>
               </a:ext>
             </a:extLst>
           </p:cNvPr>
@@ -4232,7 +4232,7 @@
           <p:cNvPr id="40" name="">
             <a:extLst xmlns:a="http://schemas.openxmlformats.org/drawingml/2006/main">
               <a:ext uri="{FF2B5EF4-FFF2-40B4-BE49-F238E27FC236}">
-                <a16:creationId xmlns:a16="http://schemas.microsoft.com/office/drawing/2014/main" id="{5200B361-4255-4369-A8E6-CC8838046C97}"/>
+                <a16:creationId xmlns:a16="http://schemas.microsoft.com/office/drawing/2014/main" id="{417A1D1D-BB42-4971-A7BE-D47F91ECCC9E}"/>
               </a:ext>
             </a:extLst>
           </p:cNvPr>
@@ -4313,7 +4313,7 @@
           <p:cNvPr id="41" name="">
             <a:extLst xmlns:a="http://schemas.openxmlformats.org/drawingml/2006/main">
               <a:ext uri="{FF2B5EF4-FFF2-40B4-BE49-F238E27FC236}">
-                <a16:creationId xmlns:a16="http://schemas.microsoft.com/office/drawing/2014/main" id="{B91C9528-8B10-49B5-A588-67AAAE045C62}"/>
+                <a16:creationId xmlns:a16="http://schemas.microsoft.com/office/drawing/2014/main" id="{68DD8AA7-1DC0-470D-8CF5-2A8F256C82E3}"/>
               </a:ext>
             </a:extLst>
           </p:cNvPr>
@@ -4369,7 +4369,7 @@
     </p:spTree>
     <p:extLst>
       <p:ext uri="{BB962C8B-B14F-4D97-AF65-F5344CB8AC3E}">
-        <p14:creationId xmlns:p14="http://schemas.microsoft.com/office/powerpoint/2010/main" val="444602457"/>
+        <p14:creationId xmlns:p14="http://schemas.microsoft.com/office/powerpoint/2010/main" val="1999892124"/>
       </p:ext>
     </p:extLst>
   </p:cSld>
@@ -4400,18 +4400,18 @@
           <p:cNvPr id="41" name="">
             <a:extLst xmlns:a="http://schemas.openxmlformats.org/drawingml/2006/main">
               <a:ext uri="{FF2B5EF4-FFF2-40B4-BE49-F238E27FC236}">
-                <a16:creationId xmlns:a16="http://schemas.microsoft.com/office/drawing/2014/main" id="{B53AC275-CB3A-4C96-81AC-C9EC2D809D10}"/>
-              </a:ext>
-            </a:extLst>
-          </p:cNvPr>
-          <p:cNvSpPr>
-            <a:spLocks xmlns:a="http://schemas.openxmlformats.org/drawingml/2006/main" noGrp="1"/>
-          </p:cNvSpPr>
-          <p:nvPr/>
-        </p:nvSpPr>
-        <p:spPr>
-          <a:xfrm xmlns:a="http://schemas.openxmlformats.org/drawingml/2006/main">
-            <a:off x="1333500" y="428625"/>
+                <a16:creationId xmlns:a16="http://schemas.microsoft.com/office/drawing/2014/main" id="{4969803E-BCDB-4342-8896-1ED86A0FD9DE}"/>
+              </a:ext>
+            </a:extLst>
+          </p:cNvPr>
+          <p:cNvSpPr>
+            <a:spLocks xmlns:a="http://schemas.openxmlformats.org/drawingml/2006/main" noGrp="1"/>
+          </p:cNvSpPr>
+          <p:nvPr/>
+        </p:nvSpPr>
+        <p:spPr>
+          <a:xfrm xmlns:a="http://schemas.openxmlformats.org/drawingml/2006/main">
+            <a:off x="1238250" y="428625"/>
             <a:ext cx="4000500" cy="400050"/>
           </a:xfrm>
           <a:prstGeom xmlns:a="http://schemas.openxmlformats.org/drawingml/2006/main" prst="rect">
@@ -4458,18 +4458,18 @@
           <p:cNvPr id="2" name="">
             <a:extLst xmlns:a="http://schemas.openxmlformats.org/drawingml/2006/main">
               <a:ext uri="{FF2B5EF4-FFF2-40B4-BE49-F238E27FC236}">
-                <a16:creationId xmlns:a16="http://schemas.microsoft.com/office/drawing/2014/main" id="{2EA59745-9B84-4A04-8DD2-4C81E0C6AE0B}"/>
-              </a:ext>
-            </a:extLst>
-          </p:cNvPr>
-          <p:cNvSpPr>
-            <a:spLocks xmlns:a="http://schemas.openxmlformats.org/drawingml/2006/main" noGrp="1"/>
-          </p:cNvSpPr>
-          <p:nvPr/>
-        </p:nvSpPr>
-        <p:spPr>
-          <a:xfrm xmlns:a="http://schemas.openxmlformats.org/drawingml/2006/main">
-            <a:off x="6858000" y="428625"/>
+                <a16:creationId xmlns:a16="http://schemas.microsoft.com/office/drawing/2014/main" id="{AB7766C7-CC5B-4AB3-9A5E-F7A58ACE42E2}"/>
+              </a:ext>
+            </a:extLst>
+          </p:cNvPr>
+          <p:cNvSpPr>
+            <a:spLocks xmlns:a="http://schemas.openxmlformats.org/drawingml/2006/main" noGrp="1"/>
+          </p:cNvSpPr>
+          <p:nvPr/>
+        </p:nvSpPr>
+        <p:spPr>
+          <a:xfrm xmlns:a="http://schemas.openxmlformats.org/drawingml/2006/main">
+            <a:off x="6715125" y="428625"/>
             <a:ext cx="4000500" cy="400050"/>
           </a:xfrm>
           <a:prstGeom xmlns:a="http://schemas.openxmlformats.org/drawingml/2006/main" prst="rect">
@@ -4516,7 +4516,7 @@
           <p:cNvPr id="3" name="">
             <a:extLst xmlns:a="http://schemas.openxmlformats.org/drawingml/2006/main">
               <a:ext uri="{FF2B5EF4-FFF2-40B4-BE49-F238E27FC236}">
-                <a16:creationId xmlns:a16="http://schemas.microsoft.com/office/drawing/2014/main" id="{D744AB56-5CEC-471B-BCF2-C4FC32D4B4D4}"/>
+                <a16:creationId xmlns:a16="http://schemas.microsoft.com/office/drawing/2014/main" id="{BEA6A8A1-3802-4750-A955-749F57934A9A}"/>
               </a:ext>
             </a:extLst>
           </p:cNvPr>
@@ -4547,18 +4547,18 @@
           <p:cNvPr id="4" name="">
             <a:extLst xmlns:a="http://schemas.openxmlformats.org/drawingml/2006/main">
               <a:ext uri="{FF2B5EF4-FFF2-40B4-BE49-F238E27FC236}">
-                <a16:creationId xmlns:a16="http://schemas.microsoft.com/office/drawing/2014/main" id="{FD7B6357-6940-4BA1-8BC6-C0D1E88A105E}"/>
-              </a:ext>
-            </a:extLst>
-          </p:cNvPr>
-          <p:cNvSpPr>
-            <a:spLocks xmlns:a="http://schemas.openxmlformats.org/drawingml/2006/main" noGrp="1"/>
-          </p:cNvSpPr>
-          <p:nvPr/>
-        </p:nvSpPr>
-        <p:spPr>
-          <a:xfrm xmlns:a="http://schemas.openxmlformats.org/drawingml/2006/main">
-            <a:off x="1952625" y="1000125"/>
+                <a16:creationId xmlns:a16="http://schemas.microsoft.com/office/drawing/2014/main" id="{897969FA-6A4B-4206-A901-7A884D7210F6}"/>
+              </a:ext>
+            </a:extLst>
+          </p:cNvPr>
+          <p:cNvSpPr>
+            <a:spLocks xmlns:a="http://schemas.openxmlformats.org/drawingml/2006/main" noGrp="1"/>
+          </p:cNvSpPr>
+          <p:nvPr/>
+        </p:nvSpPr>
+        <p:spPr>
+          <a:xfrm xmlns:a="http://schemas.openxmlformats.org/drawingml/2006/main">
+            <a:off x="1571625" y="1000125"/>
             <a:ext cx="1714500" cy="495300"/>
           </a:xfrm>
           <a:prstGeom xmlns:a="http://schemas.openxmlformats.org/drawingml/2006/main" prst="roundRect">
@@ -4611,18 +4611,18 @@
           <p:cNvPr id="5" name="">
             <a:extLst xmlns:a="http://schemas.openxmlformats.org/drawingml/2006/main">
               <a:ext uri="{FF2B5EF4-FFF2-40B4-BE49-F238E27FC236}">
-                <a16:creationId xmlns:a16="http://schemas.microsoft.com/office/drawing/2014/main" id="{3C309931-097E-48AD-A878-225631A28830}"/>
-              </a:ext>
-            </a:extLst>
-          </p:cNvPr>
-          <p:cNvSpPr>
-            <a:spLocks xmlns:a="http://schemas.openxmlformats.org/drawingml/2006/main" noGrp="1"/>
-          </p:cNvSpPr>
-          <p:nvPr/>
-        </p:nvSpPr>
-        <p:spPr>
-          <a:xfrm xmlns:a="http://schemas.openxmlformats.org/drawingml/2006/main">
-            <a:off x="3857625" y="1000125"/>
+                <a16:creationId xmlns:a16="http://schemas.microsoft.com/office/drawing/2014/main" id="{ADBB1218-E6FB-4EB8-AB97-F6FDC5879592}"/>
+              </a:ext>
+            </a:extLst>
+          </p:cNvPr>
+          <p:cNvSpPr>
+            <a:spLocks xmlns:a="http://schemas.openxmlformats.org/drawingml/2006/main" noGrp="1"/>
+          </p:cNvSpPr>
+          <p:nvPr/>
+        </p:nvSpPr>
+        <p:spPr>
+          <a:xfrm xmlns:a="http://schemas.openxmlformats.org/drawingml/2006/main">
+            <a:off x="3476625" y="1000125"/>
             <a:ext cx="1428750" cy="495300"/>
           </a:xfrm>
           <a:prstGeom xmlns:a="http://schemas.openxmlformats.org/drawingml/2006/main" prst="roundRect">
@@ -4681,7 +4681,7 @@
         </p:nvCxnSpPr>
         <p:spPr>
           <a:xfrm xmlns:a="http://schemas.openxmlformats.org/drawingml/2006/main">
-            <a:off x="3667125" y="1247775"/>
+            <a:off x="3286125" y="1247775"/>
             <a:ext cx="190500" cy="0"/>
           </a:xfrm>
           <a:prstGeom xmlns:a="http://schemas.openxmlformats.org/drawingml/2006/main" prst="straightConnector1">
@@ -4701,7 +4701,7 @@
           <p:cNvPr id="7" name="">
             <a:extLst xmlns:a="http://schemas.openxmlformats.org/drawingml/2006/main">
               <a:ext uri="{FF2B5EF4-FFF2-40B4-BE49-F238E27FC236}">
-                <a16:creationId xmlns:a16="http://schemas.microsoft.com/office/drawing/2014/main" id="{D9D81743-8B40-4548-BF78-5B189A5A0657}"/>
+                <a16:creationId xmlns:a16="http://schemas.microsoft.com/office/drawing/2014/main" id="{EC952118-9B3D-409F-994F-8F091DBA0483}"/>
               </a:ext>
             </a:extLst>
           </p:cNvPr>
@@ -4734,7 +4734,7 @@
           <p:cNvPr id="8" name="">
             <a:extLst xmlns:a="http://schemas.openxmlformats.org/drawingml/2006/main">
               <a:ext uri="{FF2B5EF4-FFF2-40B4-BE49-F238E27FC236}">
-                <a16:creationId xmlns:a16="http://schemas.microsoft.com/office/drawing/2014/main" id="{A4AA7239-1E1C-4AEE-BB3C-2500978CDCB4}"/>
+                <a16:creationId xmlns:a16="http://schemas.microsoft.com/office/drawing/2014/main" id="{3D232C66-7B15-497F-9646-3FB555F371AC}"/>
               </a:ext>
             </a:extLst>
           </p:cNvPr>
@@ -4793,32 +4793,36 @@
           <p:cNvPr id="10" name="">
             <a:extLst xmlns:a="http://schemas.openxmlformats.org/drawingml/2006/main">
               <a:ext uri="{FF2B5EF4-FFF2-40B4-BE49-F238E27FC236}">
-                <a16:creationId xmlns:a16="http://schemas.microsoft.com/office/drawing/2014/main" id="{A64D4CFC-F487-4681-8A25-E47554FB2DE8}"/>
-              </a:ext>
-            </a:extLst>
-          </p:cNvPr>
-          <p:cNvSpPr>
-            <a:spLocks xmlns:a="http://schemas.openxmlformats.org/drawingml/2006/main" noGrp="1"/>
-          </p:cNvSpPr>
-          <p:nvPr/>
-        </p:nvSpPr>
-        <p:spPr>
-          <a:xfrm xmlns:a="http://schemas.openxmlformats.org/drawingml/2006/main">
-            <a:off x="2286000" y="2566988"/>
-            <a:ext cx="381000" cy="266700"/>
-          </a:xfrm>
-          <a:prstGeom xmlns:a="http://schemas.openxmlformats.org/drawingml/2006/main" prst="rect">
-            <a:avLst/>
-          </a:prstGeom>
-          <a:noFill xmlns:a="http://schemas.openxmlformats.org/drawingml/2006/main"/>
+                <a16:creationId xmlns:a16="http://schemas.microsoft.com/office/drawing/2014/main" id="{AE25949F-D621-4B69-BBF3-622291EAFE45}"/>
+              </a:ext>
+            </a:extLst>
+          </p:cNvPr>
+          <p:cNvSpPr>
+            <a:spLocks xmlns:a="http://schemas.openxmlformats.org/drawingml/2006/main" noGrp="1"/>
+          </p:cNvSpPr>
+          <p:nvPr/>
+        </p:nvSpPr>
+        <p:spPr>
+          <a:xfrm xmlns:a="http://schemas.openxmlformats.org/drawingml/2006/main">
+            <a:off x="2095500" y="2028825"/>
+            <a:ext cx="457200" cy="285750"/>
+          </a:xfrm>
+          <a:prstGeom xmlns:a="http://schemas.openxmlformats.org/drawingml/2006/main" prst="roundRect">
+            <a:avLst>
+              <a:gd name="adj" fmla="val 13333"/>
+            </a:avLst>
+          </a:prstGeom>
+          <a:solidFill xmlns:a="http://schemas.openxmlformats.org/drawingml/2006/main">
+            <a:srgbClr val="FFFFFF"/>
+          </a:solidFill>
           <a:ln xmlns:a="http://schemas.openxmlformats.org/drawingml/2006/main" w="0">
             <a:noFill/>
             <a:prstDash val="solid"/>
           </a:ln>
         </p:spPr>
         <p:txBody>
-          <a:bodyPr xmlns:a="http://schemas.openxmlformats.org/drawingml/2006/main" wrap="square" lIns="38100" tIns="19050" rIns="38100" bIns="19050" anchor="ctr">
-            <a:normAutofit fontScale="100000"/>
+          <a:bodyPr xmlns:a="http://schemas.openxmlformats.org/drawingml/2006/main" lIns="76200" tIns="47625" rIns="76200" bIns="47625" anchor="ctr">
+            <a:normAutofit fontScale="86554"/>
           </a:bodyPr>
           <a:lstStyle xmlns:a="http://schemas.openxmlformats.org/drawingml/2006/main"/>
           <a:p xmlns:a="http://schemas.openxmlformats.org/drawingml/2006/main">
@@ -4851,7 +4855,7 @@
           <p:cNvPr id="11" name="">
             <a:extLst xmlns:a="http://schemas.openxmlformats.org/drawingml/2006/main">
               <a:ext uri="{FF2B5EF4-FFF2-40B4-BE49-F238E27FC236}">
-                <a16:creationId xmlns:a16="http://schemas.microsoft.com/office/drawing/2014/main" id="{8267E723-D69D-440C-9380-9113DB86CA4A}"/>
+                <a16:creationId xmlns:a16="http://schemas.microsoft.com/office/drawing/2014/main" id="{05C6B010-8FDB-44D6-9DED-55148DAFE802}"/>
               </a:ext>
             </a:extLst>
           </p:cNvPr>
@@ -4910,32 +4914,36 @@
           <p:cNvPr id="13" name="">
             <a:extLst xmlns:a="http://schemas.openxmlformats.org/drawingml/2006/main">
               <a:ext uri="{FF2B5EF4-FFF2-40B4-BE49-F238E27FC236}">
-                <a16:creationId xmlns:a16="http://schemas.microsoft.com/office/drawing/2014/main" id="{41C375AD-714D-4978-9CF5-3B64D8695020}"/>
-              </a:ext>
-            </a:extLst>
-          </p:cNvPr>
-          <p:cNvSpPr>
-            <a:spLocks xmlns:a="http://schemas.openxmlformats.org/drawingml/2006/main" noGrp="1"/>
-          </p:cNvSpPr>
-          <p:nvPr/>
-        </p:nvSpPr>
-        <p:spPr>
-          <a:xfrm xmlns:a="http://schemas.openxmlformats.org/drawingml/2006/main">
-            <a:off x="2166938" y="3257550"/>
-            <a:ext cx="381000" cy="266700"/>
-          </a:xfrm>
-          <a:prstGeom xmlns:a="http://schemas.openxmlformats.org/drawingml/2006/main" prst="rect">
-            <a:avLst/>
-          </a:prstGeom>
-          <a:noFill xmlns:a="http://schemas.openxmlformats.org/drawingml/2006/main"/>
+                <a16:creationId xmlns:a16="http://schemas.microsoft.com/office/drawing/2014/main" id="{0B7DA0D5-E44F-49C4-98DD-9413619707BB}"/>
+              </a:ext>
+            </a:extLst>
+          </p:cNvPr>
+          <p:cNvSpPr>
+            <a:spLocks xmlns:a="http://schemas.openxmlformats.org/drawingml/2006/main" noGrp="1"/>
+          </p:cNvSpPr>
+          <p:nvPr/>
+        </p:nvSpPr>
+        <p:spPr>
+          <a:xfrm xmlns:a="http://schemas.openxmlformats.org/drawingml/2006/main">
+            <a:off x="2000250" y="3810000"/>
+            <a:ext cx="457200" cy="285750"/>
+          </a:xfrm>
+          <a:prstGeom xmlns:a="http://schemas.openxmlformats.org/drawingml/2006/main" prst="roundRect">
+            <a:avLst>
+              <a:gd name="adj" fmla="val 13333"/>
+            </a:avLst>
+          </a:prstGeom>
+          <a:solidFill xmlns:a="http://schemas.openxmlformats.org/drawingml/2006/main">
+            <a:srgbClr val="FFFFFF"/>
+          </a:solidFill>
           <a:ln xmlns:a="http://schemas.openxmlformats.org/drawingml/2006/main" w="0">
             <a:noFill/>
             <a:prstDash val="solid"/>
           </a:ln>
         </p:spPr>
         <p:txBody>
-          <a:bodyPr xmlns:a="http://schemas.openxmlformats.org/drawingml/2006/main" wrap="square" lIns="38100" tIns="19050" rIns="38100" bIns="19050" anchor="ctr">
-            <a:normAutofit fontScale="100000"/>
+          <a:bodyPr xmlns:a="http://schemas.openxmlformats.org/drawingml/2006/main" lIns="76200" tIns="47625" rIns="76200" bIns="47625" anchor="ctr">
+            <a:normAutofit fontScale="86554"/>
           </a:bodyPr>
           <a:lstStyle xmlns:a="http://schemas.openxmlformats.org/drawingml/2006/main"/>
           <a:p xmlns:a="http://schemas.openxmlformats.org/drawingml/2006/main">
@@ -4968,7 +4976,7 @@
           <p:cNvPr id="14" name="">
             <a:extLst xmlns:a="http://schemas.openxmlformats.org/drawingml/2006/main">
               <a:ext uri="{FF2B5EF4-FFF2-40B4-BE49-F238E27FC236}">
-                <a16:creationId xmlns:a16="http://schemas.microsoft.com/office/drawing/2014/main" id="{E52F0DD6-3C72-46F5-914A-CC4C699D9C28}"/>
+                <a16:creationId xmlns:a16="http://schemas.microsoft.com/office/drawing/2014/main" id="{C15E950D-A02D-4678-9468-244DC735640D}"/>
               </a:ext>
             </a:extLst>
           </p:cNvPr>
@@ -5027,32 +5035,36 @@
           <p:cNvPr id="16" name="">
             <a:extLst xmlns:a="http://schemas.openxmlformats.org/drawingml/2006/main">
               <a:ext uri="{FF2B5EF4-FFF2-40B4-BE49-F238E27FC236}">
-                <a16:creationId xmlns:a16="http://schemas.microsoft.com/office/drawing/2014/main" id="{4EF6FE35-C452-4300-A9F5-35F158AEFB3C}"/>
-              </a:ext>
-            </a:extLst>
-          </p:cNvPr>
-          <p:cNvSpPr>
-            <a:spLocks xmlns:a="http://schemas.openxmlformats.org/drawingml/2006/main" noGrp="1"/>
-          </p:cNvSpPr>
-          <p:nvPr/>
-        </p:nvSpPr>
-        <p:spPr>
-          <a:xfrm xmlns:a="http://schemas.openxmlformats.org/drawingml/2006/main">
-            <a:off x="3119438" y="3709988"/>
-            <a:ext cx="381000" cy="266700"/>
-          </a:xfrm>
-          <a:prstGeom xmlns:a="http://schemas.openxmlformats.org/drawingml/2006/main" prst="rect">
-            <a:avLst/>
-          </a:prstGeom>
-          <a:noFill xmlns:a="http://schemas.openxmlformats.org/drawingml/2006/main"/>
+                <a16:creationId xmlns:a16="http://schemas.microsoft.com/office/drawing/2014/main" id="{F78790EC-65C1-4991-A494-791C0286E6D5}"/>
+              </a:ext>
+            </a:extLst>
+          </p:cNvPr>
+          <p:cNvSpPr>
+            <a:spLocks xmlns:a="http://schemas.openxmlformats.org/drawingml/2006/main" noGrp="1"/>
+          </p:cNvSpPr>
+          <p:nvPr/>
+        </p:nvSpPr>
+        <p:spPr>
+          <a:xfrm xmlns:a="http://schemas.openxmlformats.org/drawingml/2006/main">
+            <a:off x="3629025" y="3838575"/>
+            <a:ext cx="457200" cy="285750"/>
+          </a:xfrm>
+          <a:prstGeom xmlns:a="http://schemas.openxmlformats.org/drawingml/2006/main" prst="roundRect">
+            <a:avLst>
+              <a:gd name="adj" fmla="val 13333"/>
+            </a:avLst>
+          </a:prstGeom>
+          <a:solidFill xmlns:a="http://schemas.openxmlformats.org/drawingml/2006/main">
+            <a:srgbClr val="FFFFFF"/>
+          </a:solidFill>
           <a:ln xmlns:a="http://schemas.openxmlformats.org/drawingml/2006/main" w="0">
             <a:noFill/>
             <a:prstDash val="solid"/>
           </a:ln>
         </p:spPr>
         <p:txBody>
-          <a:bodyPr xmlns:a="http://schemas.openxmlformats.org/drawingml/2006/main" wrap="square" lIns="38100" tIns="19050" rIns="38100" bIns="19050" anchor="ctr">
-            <a:normAutofit fontScale="100000"/>
+          <a:bodyPr xmlns:a="http://schemas.openxmlformats.org/drawingml/2006/main" lIns="76200" tIns="47625" rIns="76200" bIns="47625" anchor="ctr">
+            <a:normAutofit fontScale="86554"/>
           </a:bodyPr>
           <a:lstStyle xmlns:a="http://schemas.openxmlformats.org/drawingml/2006/main"/>
           <a:p xmlns:a="http://schemas.openxmlformats.org/drawingml/2006/main">
@@ -5085,7 +5097,7 @@
           <p:cNvPr id="17" name="">
             <a:extLst xmlns:a="http://schemas.openxmlformats.org/drawingml/2006/main">
               <a:ext uri="{FF2B5EF4-FFF2-40B4-BE49-F238E27FC236}">
-                <a16:creationId xmlns:a16="http://schemas.microsoft.com/office/drawing/2014/main" id="{0DF54577-2806-4D5A-9228-4D7CFE81499B}"/>
+                <a16:creationId xmlns:a16="http://schemas.microsoft.com/office/drawing/2014/main" id="{10E746D3-4D65-4BD7-8DAB-2FCF749D4DBA}"/>
               </a:ext>
             </a:extLst>
           </p:cNvPr>
@@ -5175,7 +5187,7 @@
           <p:cNvPr id="19" name="">
             <a:extLst xmlns:a="http://schemas.openxmlformats.org/drawingml/2006/main">
               <a:ext uri="{FF2B5EF4-FFF2-40B4-BE49-F238E27FC236}">
-                <a16:creationId xmlns:a16="http://schemas.microsoft.com/office/drawing/2014/main" id="{EF15F988-39FC-4973-A6FC-1FDAC6FF12A8}"/>
+                <a16:creationId xmlns:a16="http://schemas.microsoft.com/office/drawing/2014/main" id="{DCE940F2-802F-4F70-9879-8CB8ABE779A8}"/>
               </a:ext>
             </a:extLst>
           </p:cNvPr>
@@ -5233,18 +5245,18 @@
           <p:cNvPr id="20" name="">
             <a:extLst xmlns:a="http://schemas.openxmlformats.org/drawingml/2006/main">
               <a:ext uri="{FF2B5EF4-FFF2-40B4-BE49-F238E27FC236}">
-                <a16:creationId xmlns:a16="http://schemas.microsoft.com/office/drawing/2014/main" id="{F365300F-6495-4DFE-AC99-DD638D4E640B}"/>
-              </a:ext>
-            </a:extLst>
-          </p:cNvPr>
-          <p:cNvSpPr>
-            <a:spLocks xmlns:a="http://schemas.openxmlformats.org/drawingml/2006/main" noGrp="1"/>
-          </p:cNvSpPr>
-          <p:nvPr/>
-        </p:nvSpPr>
-        <p:spPr>
-          <a:xfrm xmlns:a="http://schemas.openxmlformats.org/drawingml/2006/main">
-            <a:off x="7239000" y="1000125"/>
+                <a16:creationId xmlns:a16="http://schemas.microsoft.com/office/drawing/2014/main" id="{B790B810-ED6A-4051-BEB4-50394748909C}"/>
+              </a:ext>
+            </a:extLst>
+          </p:cNvPr>
+          <p:cNvSpPr>
+            <a:spLocks xmlns:a="http://schemas.openxmlformats.org/drawingml/2006/main" noGrp="1"/>
+          </p:cNvSpPr>
+          <p:nvPr/>
+        </p:nvSpPr>
+        <p:spPr>
+          <a:xfrm xmlns:a="http://schemas.openxmlformats.org/drawingml/2006/main">
+            <a:off x="6696075" y="1000125"/>
             <a:ext cx="1714500" cy="495300"/>
           </a:xfrm>
           <a:prstGeom xmlns:a="http://schemas.openxmlformats.org/drawingml/2006/main" prst="roundRect">
@@ -5297,18 +5309,18 @@
           <p:cNvPr id="21" name="">
             <a:extLst xmlns:a="http://schemas.openxmlformats.org/drawingml/2006/main">
               <a:ext uri="{FF2B5EF4-FFF2-40B4-BE49-F238E27FC236}">
-                <a16:creationId xmlns:a16="http://schemas.microsoft.com/office/drawing/2014/main" id="{413D29EB-2646-4424-8033-E1C2C7746ABF}"/>
-              </a:ext>
-            </a:extLst>
-          </p:cNvPr>
-          <p:cNvSpPr>
-            <a:spLocks xmlns:a="http://schemas.openxmlformats.org/drawingml/2006/main" noGrp="1"/>
-          </p:cNvSpPr>
-          <p:nvPr/>
-        </p:nvSpPr>
-        <p:spPr>
-          <a:xfrm xmlns:a="http://schemas.openxmlformats.org/drawingml/2006/main">
-            <a:off x="9096375" y="1000125"/>
+                <a16:creationId xmlns:a16="http://schemas.microsoft.com/office/drawing/2014/main" id="{EB1FAE34-10DB-40CF-AD9E-7C1AEF93F8D8}"/>
+              </a:ext>
+            </a:extLst>
+          </p:cNvPr>
+          <p:cNvSpPr>
+            <a:spLocks xmlns:a="http://schemas.openxmlformats.org/drawingml/2006/main" noGrp="1"/>
+          </p:cNvSpPr>
+          <p:nvPr/>
+        </p:nvSpPr>
+        <p:spPr>
+          <a:xfrm xmlns:a="http://schemas.openxmlformats.org/drawingml/2006/main">
+            <a:off x="8553450" y="1000125"/>
             <a:ext cx="2190750" cy="495300"/>
           </a:xfrm>
           <a:prstGeom xmlns:a="http://schemas.openxmlformats.org/drawingml/2006/main" prst="roundRect">
@@ -5351,7 +5363,7 @@
                 <a:ea typeface="Arial"/>
                 <a:cs typeface="Arial"/>
               </a:rPr>
-              <a:t>научена порта  α(q, r)</a:t>
+              <a:t>научен gate  α(q, r)</a:t>
             </a:r>
           </a:p>
         </p:txBody>
@@ -5367,7 +5379,7 @@
         </p:nvCxnSpPr>
         <p:spPr>
           <a:xfrm xmlns:a="http://schemas.openxmlformats.org/drawingml/2006/main">
-            <a:off x="8953500" y="1247775"/>
+            <a:off x="8410575" y="1247775"/>
             <a:ext cx="142875" cy="0"/>
           </a:xfrm>
           <a:prstGeom xmlns:a="http://schemas.openxmlformats.org/drawingml/2006/main" prst="straightConnector1">
@@ -5387,7 +5399,7 @@
           <p:cNvPr id="23" name="">
             <a:extLst xmlns:a="http://schemas.openxmlformats.org/drawingml/2006/main">
               <a:ext uri="{FF2B5EF4-FFF2-40B4-BE49-F238E27FC236}">
-                <a16:creationId xmlns:a16="http://schemas.microsoft.com/office/drawing/2014/main" id="{251D62ED-7DCA-4F02-A1E6-30411D896D6E}"/>
+                <a16:creationId xmlns:a16="http://schemas.microsoft.com/office/drawing/2014/main" id="{F84CD1CD-6ABB-4192-AB84-1759C0189EA3}"/>
               </a:ext>
             </a:extLst>
           </p:cNvPr>
@@ -5420,7 +5432,7 @@
           <p:cNvPr id="24" name="">
             <a:extLst xmlns:a="http://schemas.openxmlformats.org/drawingml/2006/main">
               <a:ext uri="{FF2B5EF4-FFF2-40B4-BE49-F238E27FC236}">
-                <a16:creationId xmlns:a16="http://schemas.microsoft.com/office/drawing/2014/main" id="{AC74B2F3-62CF-4B10-B21F-E2245612AEF0}"/>
+                <a16:creationId xmlns:a16="http://schemas.microsoft.com/office/drawing/2014/main" id="{2D16225B-1FAB-4887-8CD4-937435A29865}"/>
               </a:ext>
             </a:extLst>
           </p:cNvPr>
@@ -5505,32 +5517,36 @@
           <p:cNvPr id="27" name="">
             <a:extLst xmlns:a="http://schemas.openxmlformats.org/drawingml/2006/main">
               <a:ext uri="{FF2B5EF4-FFF2-40B4-BE49-F238E27FC236}">
-                <a16:creationId xmlns:a16="http://schemas.microsoft.com/office/drawing/2014/main" id="{A93EDAC0-67F3-4E24-88FB-D0244F98CEB4}"/>
-              </a:ext>
-            </a:extLst>
-          </p:cNvPr>
-          <p:cNvSpPr>
-            <a:spLocks xmlns:a="http://schemas.openxmlformats.org/drawingml/2006/main" noGrp="1"/>
-          </p:cNvSpPr>
-          <p:nvPr/>
-        </p:nvSpPr>
-        <p:spPr>
-          <a:xfrm xmlns:a="http://schemas.openxmlformats.org/drawingml/2006/main">
-            <a:off x="7762875" y="2566988"/>
-            <a:ext cx="381000" cy="266700"/>
-          </a:xfrm>
-          <a:prstGeom xmlns:a="http://schemas.openxmlformats.org/drawingml/2006/main" prst="rect">
-            <a:avLst/>
-          </a:prstGeom>
-          <a:noFill xmlns:a="http://schemas.openxmlformats.org/drawingml/2006/main"/>
+                <a16:creationId xmlns:a16="http://schemas.microsoft.com/office/drawing/2014/main" id="{78717247-979F-43A4-BB23-B86EE4C5266D}"/>
+              </a:ext>
+            </a:extLst>
+          </p:cNvPr>
+          <p:cNvSpPr>
+            <a:spLocks xmlns:a="http://schemas.openxmlformats.org/drawingml/2006/main" noGrp="1"/>
+          </p:cNvSpPr>
+          <p:nvPr/>
+        </p:nvSpPr>
+        <p:spPr>
+          <a:xfrm xmlns:a="http://schemas.openxmlformats.org/drawingml/2006/main">
+            <a:off x="7572375" y="2028825"/>
+            <a:ext cx="457200" cy="285750"/>
+          </a:xfrm>
+          <a:prstGeom xmlns:a="http://schemas.openxmlformats.org/drawingml/2006/main" prst="roundRect">
+            <a:avLst>
+              <a:gd name="adj" fmla="val 13333"/>
+            </a:avLst>
+          </a:prstGeom>
+          <a:solidFill xmlns:a="http://schemas.openxmlformats.org/drawingml/2006/main">
+            <a:srgbClr val="FFFFFF"/>
+          </a:solidFill>
           <a:ln xmlns:a="http://schemas.openxmlformats.org/drawingml/2006/main" w="0">
             <a:noFill/>
             <a:prstDash val="solid"/>
           </a:ln>
         </p:spPr>
         <p:txBody>
-          <a:bodyPr xmlns:a="http://schemas.openxmlformats.org/drawingml/2006/main" wrap="square" lIns="38100" tIns="19050" rIns="38100" bIns="19050" anchor="ctr">
-            <a:normAutofit fontScale="100000"/>
+          <a:bodyPr xmlns:a="http://schemas.openxmlformats.org/drawingml/2006/main" lIns="76200" tIns="47625" rIns="76200" bIns="47625" anchor="ctr">
+            <a:normAutofit fontScale="86554"/>
           </a:bodyPr>
           <a:lstStyle xmlns:a="http://schemas.openxmlformats.org/drawingml/2006/main"/>
           <a:p xmlns:a="http://schemas.openxmlformats.org/drawingml/2006/main">
@@ -5563,7 +5579,7 @@
           <p:cNvPr id="28" name="">
             <a:extLst xmlns:a="http://schemas.openxmlformats.org/drawingml/2006/main">
               <a:ext uri="{FF2B5EF4-FFF2-40B4-BE49-F238E27FC236}">
-                <a16:creationId xmlns:a16="http://schemas.microsoft.com/office/drawing/2014/main" id="{72373DE1-A893-4402-AE23-2A6E4630C7CF}"/>
+                <a16:creationId xmlns:a16="http://schemas.microsoft.com/office/drawing/2014/main" id="{4E0A5794-6CAE-4640-9E59-2DF2CB6A0D1C}"/>
               </a:ext>
             </a:extLst>
           </p:cNvPr>
@@ -5648,32 +5664,36 @@
           <p:cNvPr id="31" name="">
             <a:extLst xmlns:a="http://schemas.openxmlformats.org/drawingml/2006/main">
               <a:ext uri="{FF2B5EF4-FFF2-40B4-BE49-F238E27FC236}">
-                <a16:creationId xmlns:a16="http://schemas.microsoft.com/office/drawing/2014/main" id="{76B97C6B-BCCA-485E-B0E7-0009F8A95E0A}"/>
-              </a:ext>
-            </a:extLst>
-          </p:cNvPr>
-          <p:cNvSpPr>
-            <a:spLocks xmlns:a="http://schemas.openxmlformats.org/drawingml/2006/main" noGrp="1"/>
-          </p:cNvSpPr>
-          <p:nvPr/>
-        </p:nvSpPr>
-        <p:spPr>
-          <a:xfrm xmlns:a="http://schemas.openxmlformats.org/drawingml/2006/main">
-            <a:off x="7643813" y="3257550"/>
-            <a:ext cx="381000" cy="266700"/>
-          </a:xfrm>
-          <a:prstGeom xmlns:a="http://schemas.openxmlformats.org/drawingml/2006/main" prst="rect">
-            <a:avLst/>
-          </a:prstGeom>
-          <a:noFill xmlns:a="http://schemas.openxmlformats.org/drawingml/2006/main"/>
+                <a16:creationId xmlns:a16="http://schemas.microsoft.com/office/drawing/2014/main" id="{BF80830E-7899-4047-BBC2-3C6892864656}"/>
+              </a:ext>
+            </a:extLst>
+          </p:cNvPr>
+          <p:cNvSpPr>
+            <a:spLocks xmlns:a="http://schemas.openxmlformats.org/drawingml/2006/main" noGrp="1"/>
+          </p:cNvSpPr>
+          <p:nvPr/>
+        </p:nvSpPr>
+        <p:spPr>
+          <a:xfrm xmlns:a="http://schemas.openxmlformats.org/drawingml/2006/main">
+            <a:off x="7477125" y="3810000"/>
+            <a:ext cx="457200" cy="285750"/>
+          </a:xfrm>
+          <a:prstGeom xmlns:a="http://schemas.openxmlformats.org/drawingml/2006/main" prst="roundRect">
+            <a:avLst>
+              <a:gd name="adj" fmla="val 13333"/>
+            </a:avLst>
+          </a:prstGeom>
+          <a:solidFill xmlns:a="http://schemas.openxmlformats.org/drawingml/2006/main">
+            <a:srgbClr val="FFFFFF"/>
+          </a:solidFill>
           <a:ln xmlns:a="http://schemas.openxmlformats.org/drawingml/2006/main" w="0">
             <a:noFill/>
             <a:prstDash val="solid"/>
           </a:ln>
         </p:spPr>
         <p:txBody>
-          <a:bodyPr xmlns:a="http://schemas.openxmlformats.org/drawingml/2006/main" wrap="square" lIns="38100" tIns="19050" rIns="38100" bIns="19050" anchor="ctr">
-            <a:normAutofit fontScale="100000"/>
+          <a:bodyPr xmlns:a="http://schemas.openxmlformats.org/drawingml/2006/main" lIns="76200" tIns="47625" rIns="76200" bIns="47625" anchor="ctr">
+            <a:normAutofit fontScale="86554"/>
           </a:bodyPr>
           <a:lstStyle xmlns:a="http://schemas.openxmlformats.org/drawingml/2006/main"/>
           <a:p xmlns:a="http://schemas.openxmlformats.org/drawingml/2006/main">
@@ -5706,7 +5726,7 @@
           <p:cNvPr id="32" name="">
             <a:extLst xmlns:a="http://schemas.openxmlformats.org/drawingml/2006/main">
               <a:ext uri="{FF2B5EF4-FFF2-40B4-BE49-F238E27FC236}">
-                <a16:creationId xmlns:a16="http://schemas.microsoft.com/office/drawing/2014/main" id="{F68D2F7D-DED5-4387-9952-8825975A5DF5}"/>
+                <a16:creationId xmlns:a16="http://schemas.microsoft.com/office/drawing/2014/main" id="{9C488285-5813-4CA5-8BE0-7A6258E1D1FA}"/>
               </a:ext>
             </a:extLst>
           </p:cNvPr>
@@ -5791,32 +5811,36 @@
           <p:cNvPr id="35" name="">
             <a:extLst xmlns:a="http://schemas.openxmlformats.org/drawingml/2006/main">
               <a:ext uri="{FF2B5EF4-FFF2-40B4-BE49-F238E27FC236}">
-                <a16:creationId xmlns:a16="http://schemas.microsoft.com/office/drawing/2014/main" id="{FC5D7A46-5731-4F09-8D85-3E23CE586976}"/>
-              </a:ext>
-            </a:extLst>
-          </p:cNvPr>
-          <p:cNvSpPr>
-            <a:spLocks xmlns:a="http://schemas.openxmlformats.org/drawingml/2006/main" noGrp="1"/>
-          </p:cNvSpPr>
-          <p:nvPr/>
-        </p:nvSpPr>
-        <p:spPr>
-          <a:xfrm xmlns:a="http://schemas.openxmlformats.org/drawingml/2006/main">
-            <a:off x="8596313" y="3709988"/>
-            <a:ext cx="381000" cy="266700"/>
-          </a:xfrm>
-          <a:prstGeom xmlns:a="http://schemas.openxmlformats.org/drawingml/2006/main" prst="rect">
-            <a:avLst/>
-          </a:prstGeom>
-          <a:noFill xmlns:a="http://schemas.openxmlformats.org/drawingml/2006/main"/>
+                <a16:creationId xmlns:a16="http://schemas.microsoft.com/office/drawing/2014/main" id="{BC9F155E-256D-4A15-B5E0-AE56F458D624}"/>
+              </a:ext>
+            </a:extLst>
+          </p:cNvPr>
+          <p:cNvSpPr>
+            <a:spLocks xmlns:a="http://schemas.openxmlformats.org/drawingml/2006/main" noGrp="1"/>
+          </p:cNvSpPr>
+          <p:nvPr/>
+        </p:nvSpPr>
+        <p:spPr>
+          <a:xfrm xmlns:a="http://schemas.openxmlformats.org/drawingml/2006/main">
+            <a:off x="9105900" y="3838575"/>
+            <a:ext cx="457200" cy="285750"/>
+          </a:xfrm>
+          <a:prstGeom xmlns:a="http://schemas.openxmlformats.org/drawingml/2006/main" prst="roundRect">
+            <a:avLst>
+              <a:gd name="adj" fmla="val 13333"/>
+            </a:avLst>
+          </a:prstGeom>
+          <a:solidFill xmlns:a="http://schemas.openxmlformats.org/drawingml/2006/main">
+            <a:srgbClr val="FFFFFF"/>
+          </a:solidFill>
           <a:ln xmlns:a="http://schemas.openxmlformats.org/drawingml/2006/main" w="0">
             <a:noFill/>
             <a:prstDash val="solid"/>
           </a:ln>
         </p:spPr>
         <p:txBody>
-          <a:bodyPr xmlns:a="http://schemas.openxmlformats.org/drawingml/2006/main" wrap="square" lIns="38100" tIns="19050" rIns="38100" bIns="19050" anchor="ctr">
-            <a:normAutofit fontScale="100000"/>
+          <a:bodyPr xmlns:a="http://schemas.openxmlformats.org/drawingml/2006/main" lIns="76200" tIns="47625" rIns="76200" bIns="47625" anchor="ctr">
+            <a:normAutofit fontScale="86554"/>
           </a:bodyPr>
           <a:lstStyle xmlns:a="http://schemas.openxmlformats.org/drawingml/2006/main"/>
           <a:p xmlns:a="http://schemas.openxmlformats.org/drawingml/2006/main">
@@ -5849,7 +5873,7 @@
           <p:cNvPr id="36" name="">
             <a:extLst xmlns:a="http://schemas.openxmlformats.org/drawingml/2006/main">
               <a:ext uri="{FF2B5EF4-FFF2-40B4-BE49-F238E27FC236}">
-                <a16:creationId xmlns:a16="http://schemas.microsoft.com/office/drawing/2014/main" id="{297E73D9-0A76-4CCD-BBD5-195F2F310CC2}"/>
+                <a16:creationId xmlns:a16="http://schemas.microsoft.com/office/drawing/2014/main" id="{C0FF637F-8B3A-481B-B810-1B016411E654}"/>
               </a:ext>
             </a:extLst>
           </p:cNvPr>
@@ -5939,7 +5963,7 @@
           <p:cNvPr id="38" name="">
             <a:extLst xmlns:a="http://schemas.openxmlformats.org/drawingml/2006/main">
               <a:ext uri="{FF2B5EF4-FFF2-40B4-BE49-F238E27FC236}">
-                <a16:creationId xmlns:a16="http://schemas.microsoft.com/office/drawing/2014/main" id="{A83D5ECA-F06A-4EAB-B87F-2AE41EF171C8}"/>
+                <a16:creationId xmlns:a16="http://schemas.microsoft.com/office/drawing/2014/main" id="{A86597D0-15FC-4D94-B329-4B8A56F8A846}"/>
               </a:ext>
             </a:extLst>
           </p:cNvPr>
@@ -6029,7 +6053,7 @@
           <p:cNvPr id="40" name="">
             <a:extLst xmlns:a="http://schemas.openxmlformats.org/drawingml/2006/main">
               <a:ext uri="{FF2B5EF4-FFF2-40B4-BE49-F238E27FC236}">
-                <a16:creationId xmlns:a16="http://schemas.microsoft.com/office/drawing/2014/main" id="{9ABC3708-070C-472E-BF44-64A1436EAE54}"/>
+                <a16:creationId xmlns:a16="http://schemas.microsoft.com/office/drawing/2014/main" id="{64C9BC34-6CAD-4E17-8206-EE59D63AED87}"/>
               </a:ext>
             </a:extLst>
           </p:cNvPr>
@@ -6085,7 +6109,7 @@
     </p:spTree>
     <p:extLst>
       <p:ext uri="{BB962C8B-B14F-4D97-AF65-F5344CB8AC3E}">
-        <p14:creationId xmlns:p14="http://schemas.microsoft.com/office/powerpoint/2010/main" val="1636085207"/>
+        <p14:creationId xmlns:p14="http://schemas.microsoft.com/office/powerpoint/2010/main" val="1636257969"/>
       </p:ext>
     </p:extLst>
   </p:cSld>
@@ -6116,7 +6140,7 @@
           <p:cNvPr id="36" name="">
             <a:extLst xmlns:a="http://schemas.openxmlformats.org/drawingml/2006/main">
               <a:ext uri="{FF2B5EF4-FFF2-40B4-BE49-F238E27FC236}">
-                <a16:creationId xmlns:a16="http://schemas.microsoft.com/office/drawing/2014/main" id="{03AF47F5-5E3D-49FE-8A21-2004D9250EE6}"/>
+                <a16:creationId xmlns:a16="http://schemas.microsoft.com/office/drawing/2014/main" id="{314E6479-A9BF-4FCE-8916-0BDAE09560F2}"/>
               </a:ext>
             </a:extLst>
           </p:cNvPr>
@@ -6174,7 +6198,7 @@
           <p:cNvPr id="2" name="">
             <a:extLst xmlns:a="http://schemas.openxmlformats.org/drawingml/2006/main">
               <a:ext uri="{FF2B5EF4-FFF2-40B4-BE49-F238E27FC236}">
-                <a16:creationId xmlns:a16="http://schemas.microsoft.com/office/drawing/2014/main" id="{CCAD61A8-0060-48C9-80D4-711D53344B12}"/>
+                <a16:creationId xmlns:a16="http://schemas.microsoft.com/office/drawing/2014/main" id="{F866F7A3-DEAC-4A16-8B6A-A1E57A19EB9E}"/>
               </a:ext>
             </a:extLst>
           </p:cNvPr>
@@ -6232,7 +6256,7 @@
           <p:cNvPr id="3" name="">
             <a:extLst xmlns:a="http://schemas.openxmlformats.org/drawingml/2006/main">
               <a:ext uri="{FF2B5EF4-FFF2-40B4-BE49-F238E27FC236}">
-                <a16:creationId xmlns:a16="http://schemas.microsoft.com/office/drawing/2014/main" id="{849559BF-3380-4B82-915C-C51CF4EEAA7C}"/>
+                <a16:creationId xmlns:a16="http://schemas.microsoft.com/office/drawing/2014/main" id="{3128DB78-1E9A-4469-80BF-4955EFC22434}"/>
               </a:ext>
             </a:extLst>
           </p:cNvPr>
@@ -6263,7 +6287,7 @@
           <p:cNvPr id="4" name="">
             <a:extLst xmlns:a="http://schemas.openxmlformats.org/drawingml/2006/main">
               <a:ext uri="{FF2B5EF4-FFF2-40B4-BE49-F238E27FC236}">
-                <a16:creationId xmlns:a16="http://schemas.microsoft.com/office/drawing/2014/main" id="{84CFA869-0A15-4EE6-A4F8-F3F458F02BB1}"/>
+                <a16:creationId xmlns:a16="http://schemas.microsoft.com/office/drawing/2014/main" id="{FDFD678F-3C16-4C6E-AA2A-C814AC58EFC2}"/>
               </a:ext>
             </a:extLst>
           </p:cNvPr>
@@ -6296,7 +6320,7 @@
           <p:cNvPr id="5" name="">
             <a:extLst xmlns:a="http://schemas.openxmlformats.org/drawingml/2006/main">
               <a:ext uri="{FF2B5EF4-FFF2-40B4-BE49-F238E27FC236}">
-                <a16:creationId xmlns:a16="http://schemas.microsoft.com/office/drawing/2014/main" id="{BCC211D6-400B-48BA-8EFD-6290774F7322}"/>
+                <a16:creationId xmlns:a16="http://schemas.microsoft.com/office/drawing/2014/main" id="{9CDF0F11-6636-4246-ADDE-10CD3F384FD0}"/>
               </a:ext>
             </a:extLst>
           </p:cNvPr>
@@ -6329,7 +6353,7 @@
           <p:cNvPr id="6" name="">
             <a:extLst xmlns:a="http://schemas.openxmlformats.org/drawingml/2006/main">
               <a:ext uri="{FF2B5EF4-FFF2-40B4-BE49-F238E27FC236}">
-                <a16:creationId xmlns:a16="http://schemas.microsoft.com/office/drawing/2014/main" id="{09A1DA41-007E-44CC-9E4B-7F1EDD0D7ED1}"/>
+                <a16:creationId xmlns:a16="http://schemas.microsoft.com/office/drawing/2014/main" id="{079C0F6A-A1CC-4D69-8886-A6372A9B97F1}"/>
               </a:ext>
             </a:extLst>
           </p:cNvPr>
@@ -6445,7 +6469,7 @@
           <p:cNvPr id="9" name="">
             <a:extLst xmlns:a="http://schemas.openxmlformats.org/drawingml/2006/main">
               <a:ext uri="{FF2B5EF4-FFF2-40B4-BE49-F238E27FC236}">
-                <a16:creationId xmlns:a16="http://schemas.microsoft.com/office/drawing/2014/main" id="{62F2FCFE-39F9-41A8-B02A-464F033E2D8B}"/>
+                <a16:creationId xmlns:a16="http://schemas.microsoft.com/office/drawing/2014/main" id="{EA540927-DE74-4AB5-A491-638222E3230C}"/>
               </a:ext>
             </a:extLst>
           </p:cNvPr>
@@ -6503,7 +6527,7 @@
           <p:cNvPr id="10" name="">
             <a:extLst xmlns:a="http://schemas.openxmlformats.org/drawingml/2006/main">
               <a:ext uri="{FF2B5EF4-FFF2-40B4-BE49-F238E27FC236}">
-                <a16:creationId xmlns:a16="http://schemas.microsoft.com/office/drawing/2014/main" id="{911431C0-C2AA-4985-9BFB-8875A9BD7757}"/>
+                <a16:creationId xmlns:a16="http://schemas.microsoft.com/office/drawing/2014/main" id="{38BD63AD-91C7-4F86-9832-0C4CE0415DE6}"/>
               </a:ext>
             </a:extLst>
           </p:cNvPr>
@@ -6536,7 +6560,7 @@
           <p:cNvPr id="11" name="">
             <a:extLst xmlns:a="http://schemas.openxmlformats.org/drawingml/2006/main">
               <a:ext uri="{FF2B5EF4-FFF2-40B4-BE49-F238E27FC236}">
-                <a16:creationId xmlns:a16="http://schemas.microsoft.com/office/drawing/2014/main" id="{67E2FA47-8B94-487D-A333-3484A1BF7054}"/>
+                <a16:creationId xmlns:a16="http://schemas.microsoft.com/office/drawing/2014/main" id="{6495F97D-765F-4DAC-A804-5B4936020E13}"/>
               </a:ext>
             </a:extLst>
           </p:cNvPr>
@@ -6652,7 +6676,7 @@
           <p:cNvPr id="14" name="">
             <a:extLst xmlns:a="http://schemas.openxmlformats.org/drawingml/2006/main">
               <a:ext uri="{FF2B5EF4-FFF2-40B4-BE49-F238E27FC236}">
-                <a16:creationId xmlns:a16="http://schemas.microsoft.com/office/drawing/2014/main" id="{0D8ACE15-033B-4D22-924E-5A2ACAC86727}"/>
+                <a16:creationId xmlns:a16="http://schemas.microsoft.com/office/drawing/2014/main" id="{E28F6B38-B048-4ADD-ABF3-BC270CB54FA2}"/>
               </a:ext>
             </a:extLst>
           </p:cNvPr>
@@ -6710,7 +6734,7 @@
           <p:cNvPr id="15" name="">
             <a:extLst xmlns:a="http://schemas.openxmlformats.org/drawingml/2006/main">
               <a:ext uri="{FF2B5EF4-FFF2-40B4-BE49-F238E27FC236}">
-                <a16:creationId xmlns:a16="http://schemas.microsoft.com/office/drawing/2014/main" id="{9E9FE944-01F8-4770-967B-B5EBEF66FA4E}"/>
+                <a16:creationId xmlns:a16="http://schemas.microsoft.com/office/drawing/2014/main" id="{D628AD64-14DB-41F8-9537-2619F1622B4F}"/>
               </a:ext>
             </a:extLst>
           </p:cNvPr>
@@ -6743,7 +6767,7 @@
           <p:cNvPr id="16" name="">
             <a:extLst xmlns:a="http://schemas.openxmlformats.org/drawingml/2006/main">
               <a:ext uri="{FF2B5EF4-FFF2-40B4-BE49-F238E27FC236}">
-                <a16:creationId xmlns:a16="http://schemas.microsoft.com/office/drawing/2014/main" id="{3EEDD27E-FC28-4106-A818-2CA865748A3F}"/>
+                <a16:creationId xmlns:a16="http://schemas.microsoft.com/office/drawing/2014/main" id="{0E4F344F-E029-48FC-83BD-F27050D227A0}"/>
               </a:ext>
             </a:extLst>
           </p:cNvPr>
@@ -6859,7 +6883,7 @@
           <p:cNvPr id="19" name="">
             <a:extLst xmlns:a="http://schemas.openxmlformats.org/drawingml/2006/main">
               <a:ext uri="{FF2B5EF4-FFF2-40B4-BE49-F238E27FC236}">
-                <a16:creationId xmlns:a16="http://schemas.microsoft.com/office/drawing/2014/main" id="{0A7CAC10-525F-4E1B-96F7-5FDDA1C889A2}"/>
+                <a16:creationId xmlns:a16="http://schemas.microsoft.com/office/drawing/2014/main" id="{7DBE9FF5-0CB9-4E89-9D59-4EFC565E79A7}"/>
               </a:ext>
             </a:extLst>
           </p:cNvPr>
@@ -6917,7 +6941,7 @@
           <p:cNvPr id="20" name="">
             <a:extLst xmlns:a="http://schemas.openxmlformats.org/drawingml/2006/main">
               <a:ext uri="{FF2B5EF4-FFF2-40B4-BE49-F238E27FC236}">
-                <a16:creationId xmlns:a16="http://schemas.microsoft.com/office/drawing/2014/main" id="{D702CB8D-47CD-40E2-A70A-6AD6EA937328}"/>
+                <a16:creationId xmlns:a16="http://schemas.microsoft.com/office/drawing/2014/main" id="{8B410CF0-3778-48B6-AAB6-815BB160DEEE}"/>
               </a:ext>
             </a:extLst>
           </p:cNvPr>
@@ -6950,7 +6974,7 @@
           <p:cNvPr id="21" name="">
             <a:extLst xmlns:a="http://schemas.openxmlformats.org/drawingml/2006/main">
               <a:ext uri="{FF2B5EF4-FFF2-40B4-BE49-F238E27FC236}">
-                <a16:creationId xmlns:a16="http://schemas.microsoft.com/office/drawing/2014/main" id="{39ECE5C2-DD6F-4CDA-943B-BF74C06E2288}"/>
+                <a16:creationId xmlns:a16="http://schemas.microsoft.com/office/drawing/2014/main" id="{EFB59853-9028-4693-A669-C7E182F3AB4B}"/>
               </a:ext>
             </a:extLst>
           </p:cNvPr>
@@ -7009,7 +7033,7 @@
           <p:cNvPr id="23" name="">
             <a:extLst xmlns:a="http://schemas.openxmlformats.org/drawingml/2006/main">
               <a:ext uri="{FF2B5EF4-FFF2-40B4-BE49-F238E27FC236}">
-                <a16:creationId xmlns:a16="http://schemas.microsoft.com/office/drawing/2014/main" id="{557A6218-00D1-484B-A976-AD2F80B60DA2}"/>
+                <a16:creationId xmlns:a16="http://schemas.microsoft.com/office/drawing/2014/main" id="{BD0E8BD6-B961-40DB-BD7D-445ECE40EC7D}"/>
               </a:ext>
             </a:extLst>
           </p:cNvPr>
@@ -7067,7 +7091,7 @@
           <p:cNvPr id="24" name="">
             <a:extLst xmlns:a="http://schemas.openxmlformats.org/drawingml/2006/main">
               <a:ext uri="{FF2B5EF4-FFF2-40B4-BE49-F238E27FC236}">
-                <a16:creationId xmlns:a16="http://schemas.microsoft.com/office/drawing/2014/main" id="{DDB619D7-9CD2-4FD0-9949-EF33E5000422}"/>
+                <a16:creationId xmlns:a16="http://schemas.microsoft.com/office/drawing/2014/main" id="{18D5E304-622D-4955-B94F-7D152F6F7574}"/>
               </a:ext>
             </a:extLst>
           </p:cNvPr>
@@ -7125,7 +7149,7 @@
           <p:cNvPr id="25" name="">
             <a:extLst xmlns:a="http://schemas.openxmlformats.org/drawingml/2006/main">
               <a:ext uri="{FF2B5EF4-FFF2-40B4-BE49-F238E27FC236}">
-                <a16:creationId xmlns:a16="http://schemas.microsoft.com/office/drawing/2014/main" id="{1F8DB81D-6006-4F55-90B2-6DD5ADF13008}"/>
+                <a16:creationId xmlns:a16="http://schemas.microsoft.com/office/drawing/2014/main" id="{2BA81688-8D19-405C-BA74-174C275B88D9}"/>
               </a:ext>
             </a:extLst>
           </p:cNvPr>
@@ -7184,7 +7208,7 @@
           <p:cNvPr id="27" name="">
             <a:extLst xmlns:a="http://schemas.openxmlformats.org/drawingml/2006/main">
               <a:ext uri="{FF2B5EF4-FFF2-40B4-BE49-F238E27FC236}">
-                <a16:creationId xmlns:a16="http://schemas.microsoft.com/office/drawing/2014/main" id="{29F5C5B5-25B1-4851-92B7-45DA9CD70486}"/>
+                <a16:creationId xmlns:a16="http://schemas.microsoft.com/office/drawing/2014/main" id="{E5CA31C9-E84E-46D2-BE59-ED16BB338D69}"/>
               </a:ext>
             </a:extLst>
           </p:cNvPr>
@@ -7242,7 +7266,7 @@
           <p:cNvPr id="28" name="">
             <a:extLst xmlns:a="http://schemas.openxmlformats.org/drawingml/2006/main">
               <a:ext uri="{FF2B5EF4-FFF2-40B4-BE49-F238E27FC236}">
-                <a16:creationId xmlns:a16="http://schemas.microsoft.com/office/drawing/2014/main" id="{5A7D7736-0D66-4ED5-BDF8-92C6C130D999}"/>
+                <a16:creationId xmlns:a16="http://schemas.microsoft.com/office/drawing/2014/main" id="{70130EF7-6D6B-4E19-92BA-91AF4CF2F019}"/>
               </a:ext>
             </a:extLst>
           </p:cNvPr>
@@ -7300,7 +7324,7 @@
           <p:cNvPr id="29" name="">
             <a:extLst xmlns:a="http://schemas.openxmlformats.org/drawingml/2006/main">
               <a:ext uri="{FF2B5EF4-FFF2-40B4-BE49-F238E27FC236}">
-                <a16:creationId xmlns:a16="http://schemas.microsoft.com/office/drawing/2014/main" id="{D69BA50D-BAF2-4876-82AA-FBB6DF354ABB}"/>
+                <a16:creationId xmlns:a16="http://schemas.microsoft.com/office/drawing/2014/main" id="{C229348D-4B3A-407A-9061-991441430CCC}"/>
               </a:ext>
             </a:extLst>
           </p:cNvPr>
@@ -7359,7 +7383,7 @@
           <p:cNvPr id="31" name="">
             <a:extLst xmlns:a="http://schemas.openxmlformats.org/drawingml/2006/main">
               <a:ext uri="{FF2B5EF4-FFF2-40B4-BE49-F238E27FC236}">
-                <a16:creationId xmlns:a16="http://schemas.microsoft.com/office/drawing/2014/main" id="{85B0275D-4209-43FD-8E34-A7F347DD5F66}"/>
+                <a16:creationId xmlns:a16="http://schemas.microsoft.com/office/drawing/2014/main" id="{BAE4D23E-FD7B-46A2-AAB6-93ECD904E15C}"/>
               </a:ext>
             </a:extLst>
           </p:cNvPr>
@@ -7417,7 +7441,7 @@
           <p:cNvPr id="32" name="">
             <a:extLst xmlns:a="http://schemas.openxmlformats.org/drawingml/2006/main">
               <a:ext uri="{FF2B5EF4-FFF2-40B4-BE49-F238E27FC236}">
-                <a16:creationId xmlns:a16="http://schemas.microsoft.com/office/drawing/2014/main" id="{8546C093-E3F2-4CCD-A287-8B57FF0106A0}"/>
+                <a16:creationId xmlns:a16="http://schemas.microsoft.com/office/drawing/2014/main" id="{ABA6A955-DB83-456D-85F7-FDB2D4CDB542}"/>
               </a:ext>
             </a:extLst>
           </p:cNvPr>
@@ -7475,7 +7499,7 @@
           <p:cNvPr id="33" name="">
             <a:extLst xmlns:a="http://schemas.openxmlformats.org/drawingml/2006/main">
               <a:ext uri="{FF2B5EF4-FFF2-40B4-BE49-F238E27FC236}">
-                <a16:creationId xmlns:a16="http://schemas.microsoft.com/office/drawing/2014/main" id="{E6847956-E9B9-4B63-804A-F492B44EADF4}"/>
+                <a16:creationId xmlns:a16="http://schemas.microsoft.com/office/drawing/2014/main" id="{A8292079-8427-4047-A3FF-E2F22544F33C}"/>
               </a:ext>
             </a:extLst>
           </p:cNvPr>
@@ -7539,7 +7563,7 @@
           <p:cNvPr id="34" name="">
             <a:extLst xmlns:a="http://schemas.openxmlformats.org/drawingml/2006/main">
               <a:ext uri="{FF2B5EF4-FFF2-40B4-BE49-F238E27FC236}">
-                <a16:creationId xmlns:a16="http://schemas.microsoft.com/office/drawing/2014/main" id="{00B3B315-D831-4056-9F49-42534AF4575B}"/>
+                <a16:creationId xmlns:a16="http://schemas.microsoft.com/office/drawing/2014/main" id="{6B9C8AD4-8823-4322-B78D-CE57C2804337}"/>
               </a:ext>
             </a:extLst>
           </p:cNvPr>
@@ -7597,7 +7621,7 @@
           <p:cNvPr id="35" name="">
             <a:extLst xmlns:a="http://schemas.openxmlformats.org/drawingml/2006/main">
               <a:ext uri="{FF2B5EF4-FFF2-40B4-BE49-F238E27FC236}">
-                <a16:creationId xmlns:a16="http://schemas.microsoft.com/office/drawing/2014/main" id="{795DE32D-353C-498E-BE4C-B309CA24D276}"/>
+                <a16:creationId xmlns:a16="http://schemas.microsoft.com/office/drawing/2014/main" id="{9304B3A1-64DC-4F5C-B3F8-31F2823B3671}"/>
               </a:ext>
             </a:extLst>
           </p:cNvPr>
@@ -7653,7 +7677,7 @@
     </p:spTree>
     <p:extLst>
       <p:ext uri="{BB962C8B-B14F-4D97-AF65-F5344CB8AC3E}">
-        <p14:creationId xmlns:p14="http://schemas.microsoft.com/office/powerpoint/2010/main" val="1639305268"/>
+        <p14:creationId xmlns:p14="http://schemas.microsoft.com/office/powerpoint/2010/main" val="137325373"/>
       </p:ext>
     </p:extLst>
   </p:cSld>
@@ -7684,7 +7708,7 @@
           <p:cNvPr id="20" name="">
             <a:extLst xmlns:a="http://schemas.openxmlformats.org/drawingml/2006/main">
               <a:ext uri="{FF2B5EF4-FFF2-40B4-BE49-F238E27FC236}">
-                <a16:creationId xmlns:a16="http://schemas.microsoft.com/office/drawing/2014/main" id="{F94A4F20-47BE-44EF-96D3-0E67E3EBD024}"/>
+                <a16:creationId xmlns:a16="http://schemas.microsoft.com/office/drawing/2014/main" id="{D30D39DB-87DD-472E-B714-400DE0BB88ED}"/>
               </a:ext>
             </a:extLst>
           </p:cNvPr>
@@ -7748,7 +7772,7 @@
           <p:cNvPr id="2" name="">
             <a:extLst xmlns:a="http://schemas.openxmlformats.org/drawingml/2006/main">
               <a:ext uri="{FF2B5EF4-FFF2-40B4-BE49-F238E27FC236}">
-                <a16:creationId xmlns:a16="http://schemas.microsoft.com/office/drawing/2014/main" id="{9ECA6207-7A27-48AF-9399-64D65394A228}"/>
+                <a16:creationId xmlns:a16="http://schemas.microsoft.com/office/drawing/2014/main" id="{D9C5774E-A56E-428B-A64B-434DF2A49B66}"/>
               </a:ext>
             </a:extLst>
           </p:cNvPr>
@@ -7835,7 +7859,7 @@
           <p:cNvPr id="3" name="">
             <a:extLst xmlns:a="http://schemas.openxmlformats.org/drawingml/2006/main">
               <a:ext uri="{FF2B5EF4-FFF2-40B4-BE49-F238E27FC236}">
-                <a16:creationId xmlns:a16="http://schemas.microsoft.com/office/drawing/2014/main" id="{E425676B-DFA2-41C4-8C47-3D739FE9D28B}"/>
+                <a16:creationId xmlns:a16="http://schemas.microsoft.com/office/drawing/2014/main" id="{24FD6502-67F0-40CC-874D-245DE2515CD7}"/>
               </a:ext>
             </a:extLst>
           </p:cNvPr>
@@ -7922,7 +7946,7 @@
           <p:cNvPr id="4" name="">
             <a:extLst xmlns:a="http://schemas.openxmlformats.org/drawingml/2006/main">
               <a:ext uri="{FF2B5EF4-FFF2-40B4-BE49-F238E27FC236}">
-                <a16:creationId xmlns:a16="http://schemas.microsoft.com/office/drawing/2014/main" id="{E8DCEC3E-C260-4F42-BBEF-BCF74C4CCB71}"/>
+                <a16:creationId xmlns:a16="http://schemas.microsoft.com/office/drawing/2014/main" id="{3DF18809-F5E5-4691-BECA-E7F1F0B2594E}"/>
               </a:ext>
             </a:extLst>
           </p:cNvPr>
@@ -8009,7 +8033,7 @@
           <p:cNvPr id="5" name="">
             <a:extLst xmlns:a="http://schemas.openxmlformats.org/drawingml/2006/main">
               <a:ext uri="{FF2B5EF4-FFF2-40B4-BE49-F238E27FC236}">
-                <a16:creationId xmlns:a16="http://schemas.microsoft.com/office/drawing/2014/main" id="{4B6B6EA2-70DC-448D-B71A-972436D550EC}"/>
+                <a16:creationId xmlns:a16="http://schemas.microsoft.com/office/drawing/2014/main" id="{90D3B099-D6E7-4377-99C5-2CBDEC84B4F6}"/>
               </a:ext>
             </a:extLst>
           </p:cNvPr>
@@ -8238,7 +8262,7 @@
           <p:cNvPr id="11" name="">
             <a:extLst xmlns:a="http://schemas.openxmlformats.org/drawingml/2006/main">
               <a:ext uri="{FF2B5EF4-FFF2-40B4-BE49-F238E27FC236}">
-                <a16:creationId xmlns:a16="http://schemas.microsoft.com/office/drawing/2014/main" id="{E845C501-60BB-4475-8ACE-E02F09C06EF9}"/>
+                <a16:creationId xmlns:a16="http://schemas.microsoft.com/office/drawing/2014/main" id="{55C88E1C-0812-49B9-824E-52CA085324D7}"/>
               </a:ext>
             </a:extLst>
           </p:cNvPr>
@@ -8271,7 +8295,7 @@
           <p:cNvPr id="12" name="">
             <a:extLst xmlns:a="http://schemas.openxmlformats.org/drawingml/2006/main">
               <a:ext uri="{FF2B5EF4-FFF2-40B4-BE49-F238E27FC236}">
-                <a16:creationId xmlns:a16="http://schemas.microsoft.com/office/drawing/2014/main" id="{718E9B67-844B-44DA-B6D5-305CE23645C6}"/>
+                <a16:creationId xmlns:a16="http://schemas.microsoft.com/office/drawing/2014/main" id="{84A9EEA7-97B1-4868-9A77-0BE088D029A3}"/>
               </a:ext>
             </a:extLst>
           </p:cNvPr>
@@ -8304,7 +8328,7 @@
           <p:cNvPr id="13" name="">
             <a:extLst xmlns:a="http://schemas.openxmlformats.org/drawingml/2006/main">
               <a:ext uri="{FF2B5EF4-FFF2-40B4-BE49-F238E27FC236}">
-                <a16:creationId xmlns:a16="http://schemas.microsoft.com/office/drawing/2014/main" id="{34A6D137-69A0-454B-AA86-DD4E7435E138}"/>
+                <a16:creationId xmlns:a16="http://schemas.microsoft.com/office/drawing/2014/main" id="{8BD4D756-0DAF-451F-8C94-9262E6C6B471}"/>
               </a:ext>
             </a:extLst>
           </p:cNvPr>
@@ -8337,7 +8361,7 @@
           <p:cNvPr id="14" name="">
             <a:extLst xmlns:a="http://schemas.openxmlformats.org/drawingml/2006/main">
               <a:ext uri="{FF2B5EF4-FFF2-40B4-BE49-F238E27FC236}">
-                <a16:creationId xmlns:a16="http://schemas.microsoft.com/office/drawing/2014/main" id="{D6112E56-772D-4F55-82F0-E2B5059890EF}"/>
+                <a16:creationId xmlns:a16="http://schemas.microsoft.com/office/drawing/2014/main" id="{16CB396A-B7D6-4169-964B-04267D998A3E}"/>
               </a:ext>
             </a:extLst>
           </p:cNvPr>
@@ -8420,7 +8444,7 @@
           <p:cNvPr id="17" name="">
             <a:extLst xmlns:a="http://schemas.openxmlformats.org/drawingml/2006/main">
               <a:ext uri="{FF2B5EF4-FFF2-40B4-BE49-F238E27FC236}">
-                <a16:creationId xmlns:a16="http://schemas.microsoft.com/office/drawing/2014/main" id="{CEC92421-925A-41D2-B60C-09BA90A6AA29}"/>
+                <a16:creationId xmlns:a16="http://schemas.microsoft.com/office/drawing/2014/main" id="{003FF246-B2DB-4607-BA0B-3F2749827064}"/>
               </a:ext>
             </a:extLst>
           </p:cNvPr>
@@ -8478,7 +8502,7 @@
           <p:cNvPr id="18" name="">
             <a:extLst xmlns:a="http://schemas.openxmlformats.org/drawingml/2006/main">
               <a:ext uri="{FF2B5EF4-FFF2-40B4-BE49-F238E27FC236}">
-                <a16:creationId xmlns:a16="http://schemas.microsoft.com/office/drawing/2014/main" id="{7051D766-21B9-4346-84D9-D66D9098312D}"/>
+                <a16:creationId xmlns:a16="http://schemas.microsoft.com/office/drawing/2014/main" id="{7BA11C37-B554-4FC0-A102-8D85C0C11804}"/>
               </a:ext>
             </a:extLst>
           </p:cNvPr>
@@ -8536,7 +8560,7 @@
           <p:cNvPr id="19" name="">
             <a:extLst xmlns:a="http://schemas.openxmlformats.org/drawingml/2006/main">
               <a:ext uri="{FF2B5EF4-FFF2-40B4-BE49-F238E27FC236}">
-                <a16:creationId xmlns:a16="http://schemas.microsoft.com/office/drawing/2014/main" id="{1FBFA14B-90E2-45A6-9EBB-34D88ED9E918}"/>
+                <a16:creationId xmlns:a16="http://schemas.microsoft.com/office/drawing/2014/main" id="{69E74A08-C51B-4F19-BA13-FFD78D11DD39}"/>
               </a:ext>
             </a:extLst>
           </p:cNvPr>
@@ -8592,7 +8616,7 @@
     </p:spTree>
     <p:extLst>
       <p:ext uri="{BB962C8B-B14F-4D97-AF65-F5344CB8AC3E}">
-        <p14:creationId xmlns:p14="http://schemas.microsoft.com/office/powerpoint/2010/main" val="2121357051"/>
+        <p14:creationId xmlns:p14="http://schemas.microsoft.com/office/powerpoint/2010/main" val="1148971867"/>
       </p:ext>
     </p:extLst>
   </p:cSld>
@@ -8623,7 +8647,7 @@
           <p:cNvPr id="31" name="">
             <a:extLst xmlns:a="http://schemas.openxmlformats.org/drawingml/2006/main">
               <a:ext uri="{FF2B5EF4-FFF2-40B4-BE49-F238E27FC236}">
-                <a16:creationId xmlns:a16="http://schemas.microsoft.com/office/drawing/2014/main" id="{E9FD7E92-D20A-4AA8-87BF-02A247D9DDCF}"/>
+                <a16:creationId xmlns:a16="http://schemas.microsoft.com/office/drawing/2014/main" id="{8D3383F7-1E5F-4135-8CAA-7488C999E2FE}"/>
               </a:ext>
             </a:extLst>
           </p:cNvPr>
@@ -8681,7 +8705,7 @@
           <p:cNvPr id="2" name="">
             <a:extLst xmlns:a="http://schemas.openxmlformats.org/drawingml/2006/main">
               <a:ext uri="{FF2B5EF4-FFF2-40B4-BE49-F238E27FC236}">
-                <a16:creationId xmlns:a16="http://schemas.microsoft.com/office/drawing/2014/main" id="{D3B4F18E-C1D3-4CE7-81D0-5FE0EF0E0A53}"/>
+                <a16:creationId xmlns:a16="http://schemas.microsoft.com/office/drawing/2014/main" id="{63C013F5-D2AF-4833-9998-AC20815D482F}"/>
               </a:ext>
             </a:extLst>
           </p:cNvPr>
@@ -8739,7 +8763,7 @@
           <p:cNvPr id="3" name="">
             <a:extLst xmlns:a="http://schemas.openxmlformats.org/drawingml/2006/main">
               <a:ext uri="{FF2B5EF4-FFF2-40B4-BE49-F238E27FC236}">
-                <a16:creationId xmlns:a16="http://schemas.microsoft.com/office/drawing/2014/main" id="{3F1DAFF4-A664-4F48-B044-923F301AA76A}"/>
+                <a16:creationId xmlns:a16="http://schemas.microsoft.com/office/drawing/2014/main" id="{E7A09721-005D-43EB-9279-BCF842AE8D2A}"/>
               </a:ext>
             </a:extLst>
           </p:cNvPr>
@@ -8797,7 +8821,7 @@
           <p:cNvPr id="4" name="">
             <a:extLst xmlns:a="http://schemas.openxmlformats.org/drawingml/2006/main">
               <a:ext uri="{FF2B5EF4-FFF2-40B4-BE49-F238E27FC236}">
-                <a16:creationId xmlns:a16="http://schemas.microsoft.com/office/drawing/2014/main" id="{46112DAF-0900-41AD-B1FD-195C8C69BB31}"/>
+                <a16:creationId xmlns:a16="http://schemas.microsoft.com/office/drawing/2014/main" id="{CBD2BAD6-6203-496B-9B13-A545654AE3B2}"/>
               </a:ext>
             </a:extLst>
           </p:cNvPr>
@@ -8855,7 +8879,7 @@
           <p:cNvPr id="5" name="">
             <a:extLst xmlns:a="http://schemas.openxmlformats.org/drawingml/2006/main">
               <a:ext uri="{FF2B5EF4-FFF2-40B4-BE49-F238E27FC236}">
-                <a16:creationId xmlns:a16="http://schemas.microsoft.com/office/drawing/2014/main" id="{9DA3707C-2F39-433E-8CF9-0008A11BB2E9}"/>
+                <a16:creationId xmlns:a16="http://schemas.microsoft.com/office/drawing/2014/main" id="{33EB9102-4BE4-440F-8530-FFD92D5B356E}"/>
               </a:ext>
             </a:extLst>
           </p:cNvPr>
@@ -8888,7 +8912,7 @@
           <p:cNvPr id="6" name="">
             <a:extLst xmlns:a="http://schemas.openxmlformats.org/drawingml/2006/main">
               <a:ext uri="{FF2B5EF4-FFF2-40B4-BE49-F238E27FC236}">
-                <a16:creationId xmlns:a16="http://schemas.microsoft.com/office/drawing/2014/main" id="{45565683-B9BC-43FD-A2C9-9F66737076D9}"/>
+                <a16:creationId xmlns:a16="http://schemas.microsoft.com/office/drawing/2014/main" id="{DD85EAC2-E308-441F-B8C7-7318AE07EB9E}"/>
               </a:ext>
             </a:extLst>
           </p:cNvPr>
@@ -8946,7 +8970,7 @@
           <p:cNvPr id="7" name="">
             <a:extLst xmlns:a="http://schemas.openxmlformats.org/drawingml/2006/main">
               <a:ext uri="{FF2B5EF4-FFF2-40B4-BE49-F238E27FC236}">
-                <a16:creationId xmlns:a16="http://schemas.microsoft.com/office/drawing/2014/main" id="{2BE4F76A-D4FD-45BC-8244-40F46B9090C2}"/>
+                <a16:creationId xmlns:a16="http://schemas.microsoft.com/office/drawing/2014/main" id="{7A182FD0-D264-4373-8FDE-6F7E24E4512B}"/>
               </a:ext>
             </a:extLst>
           </p:cNvPr>
@@ -9010,7 +9034,7 @@
           <p:cNvPr id="8" name="">
             <a:extLst xmlns:a="http://schemas.openxmlformats.org/drawingml/2006/main">
               <a:ext uri="{FF2B5EF4-FFF2-40B4-BE49-F238E27FC236}">
-                <a16:creationId xmlns:a16="http://schemas.microsoft.com/office/drawing/2014/main" id="{B4BB1488-573C-43A3-AC62-204F1D96A24C}"/>
+                <a16:creationId xmlns:a16="http://schemas.microsoft.com/office/drawing/2014/main" id="{915449DA-EC7C-436A-8085-1045B6024E44}"/>
               </a:ext>
             </a:extLst>
           </p:cNvPr>
@@ -9068,7 +9092,7 @@
           <p:cNvPr id="9" name="">
             <a:extLst xmlns:a="http://schemas.openxmlformats.org/drawingml/2006/main">
               <a:ext uri="{FF2B5EF4-FFF2-40B4-BE49-F238E27FC236}">
-                <a16:creationId xmlns:a16="http://schemas.microsoft.com/office/drawing/2014/main" id="{AB67F755-2E2C-4F20-B554-5F729ECA118F}"/>
+                <a16:creationId xmlns:a16="http://schemas.microsoft.com/office/drawing/2014/main" id="{B08CBE7B-69DF-4FFD-9700-46A302540148}"/>
               </a:ext>
             </a:extLst>
           </p:cNvPr>
@@ -9101,7 +9125,7 @@
           <p:cNvPr id="10" name="">
             <a:extLst xmlns:a="http://schemas.openxmlformats.org/drawingml/2006/main">
               <a:ext uri="{FF2B5EF4-FFF2-40B4-BE49-F238E27FC236}">
-                <a16:creationId xmlns:a16="http://schemas.microsoft.com/office/drawing/2014/main" id="{3396AC55-FF6C-4915-B396-A87E125AA3D9}"/>
+                <a16:creationId xmlns:a16="http://schemas.microsoft.com/office/drawing/2014/main" id="{81921A17-D596-42A3-936C-D364F06772E5}"/>
               </a:ext>
             </a:extLst>
           </p:cNvPr>
@@ -9134,7 +9158,7 @@
           <p:cNvPr id="11" name="">
             <a:extLst xmlns:a="http://schemas.openxmlformats.org/drawingml/2006/main">
               <a:ext uri="{FF2B5EF4-FFF2-40B4-BE49-F238E27FC236}">
-                <a16:creationId xmlns:a16="http://schemas.microsoft.com/office/drawing/2014/main" id="{1E656F30-31F8-4173-B43E-340C02F0186E}"/>
+                <a16:creationId xmlns:a16="http://schemas.microsoft.com/office/drawing/2014/main" id="{DC581143-CF7D-435B-ABC3-E260F985F40D}"/>
               </a:ext>
             </a:extLst>
           </p:cNvPr>
@@ -9167,7 +9191,7 @@
           <p:cNvPr id="12" name="">
             <a:extLst xmlns:a="http://schemas.openxmlformats.org/drawingml/2006/main">
               <a:ext uri="{FF2B5EF4-FFF2-40B4-BE49-F238E27FC236}">
-                <a16:creationId xmlns:a16="http://schemas.microsoft.com/office/drawing/2014/main" id="{B21F23F6-2FC8-47BB-936D-7C390257CB68}"/>
+                <a16:creationId xmlns:a16="http://schemas.microsoft.com/office/drawing/2014/main" id="{918DB47C-C508-4F37-90D3-9D9CA0DF1016}"/>
               </a:ext>
             </a:extLst>
           </p:cNvPr>
@@ -9200,7 +9224,7 @@
           <p:cNvPr id="13" name="">
             <a:extLst xmlns:a="http://schemas.openxmlformats.org/drawingml/2006/main">
               <a:ext uri="{FF2B5EF4-FFF2-40B4-BE49-F238E27FC236}">
-                <a16:creationId xmlns:a16="http://schemas.microsoft.com/office/drawing/2014/main" id="{3B96FFCD-C66B-407E-84AF-C6E4EEB0D275}"/>
+                <a16:creationId xmlns:a16="http://schemas.microsoft.com/office/drawing/2014/main" id="{B7EBD13A-6069-4C1D-BB0C-4E9C4BBD3B75}"/>
               </a:ext>
             </a:extLst>
           </p:cNvPr>
@@ -9233,7 +9257,7 @@
           <p:cNvPr id="14" name="">
             <a:extLst xmlns:a="http://schemas.openxmlformats.org/drawingml/2006/main">
               <a:ext uri="{FF2B5EF4-FFF2-40B4-BE49-F238E27FC236}">
-                <a16:creationId xmlns:a16="http://schemas.microsoft.com/office/drawing/2014/main" id="{05CDD0D3-F6B2-4921-9B24-4FEC740A33B1}"/>
+                <a16:creationId xmlns:a16="http://schemas.microsoft.com/office/drawing/2014/main" id="{95AE6261-00B2-42D4-8F7E-91360001064E}"/>
               </a:ext>
             </a:extLst>
           </p:cNvPr>
@@ -9264,7 +9288,7 @@
           <p:cNvPr id="15" name="">
             <a:extLst xmlns:a="http://schemas.openxmlformats.org/drawingml/2006/main">
               <a:ext uri="{FF2B5EF4-FFF2-40B4-BE49-F238E27FC236}">
-                <a16:creationId xmlns:a16="http://schemas.microsoft.com/office/drawing/2014/main" id="{6804FC0F-E5C4-4F06-8ED9-1794F119C05D}"/>
+                <a16:creationId xmlns:a16="http://schemas.microsoft.com/office/drawing/2014/main" id="{D4386C29-B68C-46FC-854D-80C5F967E787}"/>
               </a:ext>
             </a:extLst>
           </p:cNvPr>
@@ -9322,7 +9346,7 @@
           <p:cNvPr id="16" name="">
             <a:extLst xmlns:a="http://schemas.openxmlformats.org/drawingml/2006/main">
               <a:ext uri="{FF2B5EF4-FFF2-40B4-BE49-F238E27FC236}">
-                <a16:creationId xmlns:a16="http://schemas.microsoft.com/office/drawing/2014/main" id="{0FA5B64C-74D5-43F5-91D5-DD1FEEDFDCD3}"/>
+                <a16:creationId xmlns:a16="http://schemas.microsoft.com/office/drawing/2014/main" id="{56CE03CE-AAD6-4FC1-A8FF-770510FC7399}"/>
               </a:ext>
             </a:extLst>
           </p:cNvPr>
@@ -9355,7 +9379,7 @@
           <p:cNvPr id="17" name="">
             <a:extLst xmlns:a="http://schemas.openxmlformats.org/drawingml/2006/main">
               <a:ext uri="{FF2B5EF4-FFF2-40B4-BE49-F238E27FC236}">
-                <a16:creationId xmlns:a16="http://schemas.microsoft.com/office/drawing/2014/main" id="{50B3694C-56EC-414F-A2F0-EE45A173071C}"/>
+                <a16:creationId xmlns:a16="http://schemas.microsoft.com/office/drawing/2014/main" id="{01F3A48E-E38F-4997-9AF7-B58841E89E30}"/>
               </a:ext>
             </a:extLst>
           </p:cNvPr>
@@ -9595,7 +9619,7 @@
           <p:cNvPr id="25" name="">
             <a:extLst xmlns:a="http://schemas.openxmlformats.org/drawingml/2006/main">
               <a:ext uri="{FF2B5EF4-FFF2-40B4-BE49-F238E27FC236}">
-                <a16:creationId xmlns:a16="http://schemas.microsoft.com/office/drawing/2014/main" id="{F65DCC44-862C-44EA-8C40-968B0ACFCA85}"/>
+                <a16:creationId xmlns:a16="http://schemas.microsoft.com/office/drawing/2014/main" id="{4F92A2F9-1B87-4BFE-8809-975DCBDDF27B}"/>
               </a:ext>
             </a:extLst>
           </p:cNvPr>
@@ -9653,7 +9677,7 @@
           <p:cNvPr id="26" name="">
             <a:extLst xmlns:a="http://schemas.openxmlformats.org/drawingml/2006/main">
               <a:ext uri="{FF2B5EF4-FFF2-40B4-BE49-F238E27FC236}">
-                <a16:creationId xmlns:a16="http://schemas.microsoft.com/office/drawing/2014/main" id="{D9BECA32-CF36-4011-AF4D-E6E3C30446F6}"/>
+                <a16:creationId xmlns:a16="http://schemas.microsoft.com/office/drawing/2014/main" id="{CD2DF238-0F4A-4538-93FA-2E4971D6D06F}"/>
               </a:ext>
             </a:extLst>
           </p:cNvPr>
@@ -9711,7 +9735,7 @@
           <p:cNvPr id="27" name="">
             <a:extLst xmlns:a="http://schemas.openxmlformats.org/drawingml/2006/main">
               <a:ext uri="{FF2B5EF4-FFF2-40B4-BE49-F238E27FC236}">
-                <a16:creationId xmlns:a16="http://schemas.microsoft.com/office/drawing/2014/main" id="{5B096667-1E07-4ED0-9AC9-B45E1BCB7FCE}"/>
+                <a16:creationId xmlns:a16="http://schemas.microsoft.com/office/drawing/2014/main" id="{95838DA9-C5B0-4A6A-B7A0-D7D3E8E47366}"/>
               </a:ext>
             </a:extLst>
           </p:cNvPr>
@@ -9769,7 +9793,7 @@
           <p:cNvPr id="28" name="">
             <a:extLst xmlns:a="http://schemas.openxmlformats.org/drawingml/2006/main">
               <a:ext uri="{FF2B5EF4-FFF2-40B4-BE49-F238E27FC236}">
-                <a16:creationId xmlns:a16="http://schemas.microsoft.com/office/drawing/2014/main" id="{D137B9E5-8893-49F9-9AD4-B9A1AE54F41A}"/>
+                <a16:creationId xmlns:a16="http://schemas.microsoft.com/office/drawing/2014/main" id="{7AD23270-EF74-4CDC-B803-7B3F2CC85B2D}"/>
               </a:ext>
             </a:extLst>
           </p:cNvPr>
@@ -9833,7 +9857,7 @@
           <p:cNvPr id="29" name="">
             <a:extLst xmlns:a="http://schemas.openxmlformats.org/drawingml/2006/main">
               <a:ext uri="{FF2B5EF4-FFF2-40B4-BE49-F238E27FC236}">
-                <a16:creationId xmlns:a16="http://schemas.microsoft.com/office/drawing/2014/main" id="{8D775212-B38F-4F6C-9DE9-60643D77F62D}"/>
+                <a16:creationId xmlns:a16="http://schemas.microsoft.com/office/drawing/2014/main" id="{5F67914D-7261-4474-8120-440BE96D4D0F}"/>
               </a:ext>
             </a:extLst>
           </p:cNvPr>
@@ -9897,7 +9921,7 @@
           <p:cNvPr id="30" name="">
             <a:extLst xmlns:a="http://schemas.openxmlformats.org/drawingml/2006/main">
               <a:ext uri="{FF2B5EF4-FFF2-40B4-BE49-F238E27FC236}">
-                <a16:creationId xmlns:a16="http://schemas.microsoft.com/office/drawing/2014/main" id="{BB070BE3-6AD4-4C7E-8061-F3D52085FF44}"/>
+                <a16:creationId xmlns:a16="http://schemas.microsoft.com/office/drawing/2014/main" id="{8692E244-58F4-4526-9080-774D540F945F}"/>
               </a:ext>
             </a:extLst>
           </p:cNvPr>
@@ -9953,7 +9977,7 @@
     </p:spTree>
     <p:extLst>
       <p:ext uri="{BB962C8B-B14F-4D97-AF65-F5344CB8AC3E}">
-        <p14:creationId xmlns:p14="http://schemas.microsoft.com/office/powerpoint/2010/main" val="1921940953"/>
+        <p14:creationId xmlns:p14="http://schemas.microsoft.com/office/powerpoint/2010/main" val="1169675795"/>
       </p:ext>
     </p:extLst>
   </p:cSld>
@@ -9984,7 +10008,7 @@
           <p:cNvPr id="40" name="">
             <a:extLst xmlns:a="http://schemas.openxmlformats.org/drawingml/2006/main">
               <a:ext uri="{FF2B5EF4-FFF2-40B4-BE49-F238E27FC236}">
-                <a16:creationId xmlns:a16="http://schemas.microsoft.com/office/drawing/2014/main" id="{4A88D03A-4328-4C91-A9EB-B546BBCC89AB}"/>
+                <a16:creationId xmlns:a16="http://schemas.microsoft.com/office/drawing/2014/main" id="{7E585299-F908-47D6-9BCD-355C01940D54}"/>
               </a:ext>
             </a:extLst>
           </p:cNvPr>
@@ -10042,7 +10066,7 @@
           <p:cNvPr id="2" name="">
             <a:extLst xmlns:a="http://schemas.openxmlformats.org/drawingml/2006/main">
               <a:ext uri="{FF2B5EF4-FFF2-40B4-BE49-F238E27FC236}">
-                <a16:creationId xmlns:a16="http://schemas.microsoft.com/office/drawing/2014/main" id="{5B83BB79-5F0E-4155-80D6-2E20D45AC554}"/>
+                <a16:creationId xmlns:a16="http://schemas.microsoft.com/office/drawing/2014/main" id="{3EE2E0B8-7B08-4978-957D-71A9B90881B8}"/>
               </a:ext>
             </a:extLst>
           </p:cNvPr>
@@ -10100,7 +10124,7 @@
           <p:cNvPr id="3" name="">
             <a:extLst xmlns:a="http://schemas.openxmlformats.org/drawingml/2006/main">
               <a:ext uri="{FF2B5EF4-FFF2-40B4-BE49-F238E27FC236}">
-                <a16:creationId xmlns:a16="http://schemas.microsoft.com/office/drawing/2014/main" id="{03EC1EDA-5FC9-4A06-B981-04AE0886C74C}"/>
+                <a16:creationId xmlns:a16="http://schemas.microsoft.com/office/drawing/2014/main" id="{E94ABC10-0198-466D-BC27-8A763BC3C4EA}"/>
               </a:ext>
             </a:extLst>
           </p:cNvPr>
@@ -10131,7 +10155,7 @@
           <p:cNvPr id="4" name="">
             <a:extLst xmlns:a="http://schemas.openxmlformats.org/drawingml/2006/main">
               <a:ext uri="{FF2B5EF4-FFF2-40B4-BE49-F238E27FC236}">
-                <a16:creationId xmlns:a16="http://schemas.microsoft.com/office/drawing/2014/main" id="{6C8D184D-4592-48D9-8EA9-C0A8C7B43760}"/>
+                <a16:creationId xmlns:a16="http://schemas.microsoft.com/office/drawing/2014/main" id="{A3B5F034-5331-4483-9D23-053262091563}"/>
               </a:ext>
             </a:extLst>
           </p:cNvPr>
@@ -10164,7 +10188,7 @@
           <p:cNvPr id="5" name="">
             <a:extLst xmlns:a="http://schemas.openxmlformats.org/drawingml/2006/main">
               <a:ext uri="{FF2B5EF4-FFF2-40B4-BE49-F238E27FC236}">
-                <a16:creationId xmlns:a16="http://schemas.microsoft.com/office/drawing/2014/main" id="{1360D5CA-E4FB-4D94-9621-13507507B551}"/>
+                <a16:creationId xmlns:a16="http://schemas.microsoft.com/office/drawing/2014/main" id="{71031EB5-A719-493C-B94C-721BE479DA3F}"/>
               </a:ext>
             </a:extLst>
           </p:cNvPr>
@@ -10197,7 +10221,7 @@
           <p:cNvPr id="6" name="">
             <a:extLst xmlns:a="http://schemas.openxmlformats.org/drawingml/2006/main">
               <a:ext uri="{FF2B5EF4-FFF2-40B4-BE49-F238E27FC236}">
-                <a16:creationId xmlns:a16="http://schemas.microsoft.com/office/drawing/2014/main" id="{836EA78E-8751-4FCA-93FC-DD59EE06CC6D}"/>
+                <a16:creationId xmlns:a16="http://schemas.microsoft.com/office/drawing/2014/main" id="{F73666ED-DE98-4237-957F-A6CDA90C7137}"/>
               </a:ext>
             </a:extLst>
           </p:cNvPr>
@@ -10230,7 +10254,7 @@
           <p:cNvPr id="7" name="">
             <a:extLst xmlns:a="http://schemas.openxmlformats.org/drawingml/2006/main">
               <a:ext uri="{FF2B5EF4-FFF2-40B4-BE49-F238E27FC236}">
-                <a16:creationId xmlns:a16="http://schemas.microsoft.com/office/drawing/2014/main" id="{15AD2BC5-75E0-4A91-BA3B-9F699A89330A}"/>
+                <a16:creationId xmlns:a16="http://schemas.microsoft.com/office/drawing/2014/main" id="{17AF9DF8-6A72-4861-BA13-5A28A4E2E874}"/>
               </a:ext>
             </a:extLst>
           </p:cNvPr>
@@ -10263,7 +10287,7 @@
           <p:cNvPr id="8" name="">
             <a:extLst xmlns:a="http://schemas.openxmlformats.org/drawingml/2006/main">
               <a:ext uri="{FF2B5EF4-FFF2-40B4-BE49-F238E27FC236}">
-                <a16:creationId xmlns:a16="http://schemas.microsoft.com/office/drawing/2014/main" id="{B9D8E8AC-5443-43A8-B59B-25E454972041}"/>
+                <a16:creationId xmlns:a16="http://schemas.microsoft.com/office/drawing/2014/main" id="{DC5887D2-27DF-4D43-9681-FDAC661E3E00}"/>
               </a:ext>
             </a:extLst>
           </p:cNvPr>
@@ -10296,7 +10320,7 @@
           <p:cNvPr id="9" name="">
             <a:extLst xmlns:a="http://schemas.openxmlformats.org/drawingml/2006/main">
               <a:ext uri="{FF2B5EF4-FFF2-40B4-BE49-F238E27FC236}">
-                <a16:creationId xmlns:a16="http://schemas.microsoft.com/office/drawing/2014/main" id="{6557E0AB-2AE2-4684-8BC2-1FBBD86FB899}"/>
+                <a16:creationId xmlns:a16="http://schemas.microsoft.com/office/drawing/2014/main" id="{E7ED0AA8-2069-4758-AABB-C741C151B897}"/>
               </a:ext>
             </a:extLst>
           </p:cNvPr>
@@ -10327,7 +10351,7 @@
           <p:cNvPr id="10" name="">
             <a:extLst xmlns:a="http://schemas.openxmlformats.org/drawingml/2006/main">
               <a:ext uri="{FF2B5EF4-FFF2-40B4-BE49-F238E27FC236}">
-                <a16:creationId xmlns:a16="http://schemas.microsoft.com/office/drawing/2014/main" id="{DD813682-1149-48DF-A7BC-2F0A2490274B}"/>
+                <a16:creationId xmlns:a16="http://schemas.microsoft.com/office/drawing/2014/main" id="{DCE26FCE-3236-43C9-8F97-36AA37884536}"/>
               </a:ext>
             </a:extLst>
           </p:cNvPr>
@@ -10360,7 +10384,7 @@
           <p:cNvPr id="11" name="">
             <a:extLst xmlns:a="http://schemas.openxmlformats.org/drawingml/2006/main">
               <a:ext uri="{FF2B5EF4-FFF2-40B4-BE49-F238E27FC236}">
-                <a16:creationId xmlns:a16="http://schemas.microsoft.com/office/drawing/2014/main" id="{BADC832E-4E1B-474E-A7EB-63C15493A903}"/>
+                <a16:creationId xmlns:a16="http://schemas.microsoft.com/office/drawing/2014/main" id="{621BE33D-AEDA-44AF-A85D-CF46CAE00972}"/>
               </a:ext>
             </a:extLst>
           </p:cNvPr>
@@ -10601,7 +10625,7 @@
           <p:cNvPr id="20" name="">
             <a:extLst xmlns:a="http://schemas.openxmlformats.org/drawingml/2006/main">
               <a:ext uri="{FF2B5EF4-FFF2-40B4-BE49-F238E27FC236}">
-                <a16:creationId xmlns:a16="http://schemas.microsoft.com/office/drawing/2014/main" id="{74B29DCE-3DD4-4E7D-98C6-D4989263C732}"/>
+                <a16:creationId xmlns:a16="http://schemas.microsoft.com/office/drawing/2014/main" id="{810DAFF8-3F09-4888-8D8A-D70B3C7EB728}"/>
               </a:ext>
             </a:extLst>
           </p:cNvPr>
@@ -10634,7 +10658,7 @@
           <p:cNvPr id="21" name="">
             <a:extLst xmlns:a="http://schemas.openxmlformats.org/drawingml/2006/main">
               <a:ext uri="{FF2B5EF4-FFF2-40B4-BE49-F238E27FC236}">
-                <a16:creationId xmlns:a16="http://schemas.microsoft.com/office/drawing/2014/main" id="{7963E898-048B-453B-9F36-9AB6F4F2D127}"/>
+                <a16:creationId xmlns:a16="http://schemas.microsoft.com/office/drawing/2014/main" id="{42D39E94-7E90-41C0-9779-9FFF2FA138DC}"/>
               </a:ext>
             </a:extLst>
           </p:cNvPr>
@@ -10667,7 +10691,7 @@
           <p:cNvPr id="22" name="">
             <a:extLst xmlns:a="http://schemas.openxmlformats.org/drawingml/2006/main">
               <a:ext uri="{FF2B5EF4-FFF2-40B4-BE49-F238E27FC236}">
-                <a16:creationId xmlns:a16="http://schemas.microsoft.com/office/drawing/2014/main" id="{F9135364-5B97-46B5-AB8C-768A38CFDD18}"/>
+                <a16:creationId xmlns:a16="http://schemas.microsoft.com/office/drawing/2014/main" id="{9770BFE3-E3C8-4FF3-A521-52D379907E26}"/>
               </a:ext>
             </a:extLst>
           </p:cNvPr>
@@ -10700,7 +10724,7 @@
           <p:cNvPr id="23" name="">
             <a:extLst xmlns:a="http://schemas.openxmlformats.org/drawingml/2006/main">
               <a:ext uri="{FF2B5EF4-FFF2-40B4-BE49-F238E27FC236}">
-                <a16:creationId xmlns:a16="http://schemas.microsoft.com/office/drawing/2014/main" id="{0B3A8451-5CC2-4C6E-9D0D-5956741F51F9}"/>
+                <a16:creationId xmlns:a16="http://schemas.microsoft.com/office/drawing/2014/main" id="{6AAEA74E-8500-4D4F-8FDC-0C4C00F805F7}"/>
               </a:ext>
             </a:extLst>
           </p:cNvPr>
@@ -10733,7 +10757,7 @@
           <p:cNvPr id="24" name="">
             <a:extLst xmlns:a="http://schemas.openxmlformats.org/drawingml/2006/main">
               <a:ext uri="{FF2B5EF4-FFF2-40B4-BE49-F238E27FC236}">
-                <a16:creationId xmlns:a16="http://schemas.microsoft.com/office/drawing/2014/main" id="{2DBA191D-59F1-4B69-8F73-CAABCF261489}"/>
+                <a16:creationId xmlns:a16="http://schemas.microsoft.com/office/drawing/2014/main" id="{B92DFCCF-5361-4D7F-B66E-A3B13D556989}"/>
               </a:ext>
             </a:extLst>
           </p:cNvPr>
@@ -10766,7 +10790,7 @@
           <p:cNvPr id="25" name="">
             <a:extLst xmlns:a="http://schemas.openxmlformats.org/drawingml/2006/main">
               <a:ext uri="{FF2B5EF4-FFF2-40B4-BE49-F238E27FC236}">
-                <a16:creationId xmlns:a16="http://schemas.microsoft.com/office/drawing/2014/main" id="{C26B707A-6F81-4C96-A952-C36FC28D4217}"/>
+                <a16:creationId xmlns:a16="http://schemas.microsoft.com/office/drawing/2014/main" id="{0E711168-6A75-4407-B846-FE1912EE947D}"/>
               </a:ext>
             </a:extLst>
           </p:cNvPr>
@@ -10797,7 +10821,7 @@
           <p:cNvPr id="26" name="">
             <a:extLst xmlns:a="http://schemas.openxmlformats.org/drawingml/2006/main">
               <a:ext uri="{FF2B5EF4-FFF2-40B4-BE49-F238E27FC236}">
-                <a16:creationId xmlns:a16="http://schemas.microsoft.com/office/drawing/2014/main" id="{CBF2074F-C1B8-40D9-9A28-C6B9E55B7A2A}"/>
+                <a16:creationId xmlns:a16="http://schemas.microsoft.com/office/drawing/2014/main" id="{83A71AE1-42F7-4F75-93E1-1CA47D4A281F}"/>
               </a:ext>
             </a:extLst>
           </p:cNvPr>
@@ -10830,7 +10854,7 @@
           <p:cNvPr id="27" name="">
             <a:extLst xmlns:a="http://schemas.openxmlformats.org/drawingml/2006/main">
               <a:ext uri="{FF2B5EF4-FFF2-40B4-BE49-F238E27FC236}">
-                <a16:creationId xmlns:a16="http://schemas.microsoft.com/office/drawing/2014/main" id="{2F26F875-BBD5-46AF-B5DD-16F506CF5891}"/>
+                <a16:creationId xmlns:a16="http://schemas.microsoft.com/office/drawing/2014/main" id="{E82074C6-492B-49A1-B2E6-BF5C19918FC3}"/>
               </a:ext>
             </a:extLst>
           </p:cNvPr>
@@ -11071,7 +11095,7 @@
           <p:cNvPr id="36" name="">
             <a:extLst xmlns:a="http://schemas.openxmlformats.org/drawingml/2006/main">
               <a:ext uri="{FF2B5EF4-FFF2-40B4-BE49-F238E27FC236}">
-                <a16:creationId xmlns:a16="http://schemas.microsoft.com/office/drawing/2014/main" id="{02446AB3-26E1-4208-8480-ED8BE2FE2BCA}"/>
+                <a16:creationId xmlns:a16="http://schemas.microsoft.com/office/drawing/2014/main" id="{C0F80E02-559A-4D71-954A-95750FB88559}"/>
               </a:ext>
             </a:extLst>
           </p:cNvPr>
@@ -11129,7 +11153,7 @@
           <p:cNvPr id="37" name="">
             <a:extLst xmlns:a="http://schemas.openxmlformats.org/drawingml/2006/main">
               <a:ext uri="{FF2B5EF4-FFF2-40B4-BE49-F238E27FC236}">
-                <a16:creationId xmlns:a16="http://schemas.microsoft.com/office/drawing/2014/main" id="{EF53408E-AFDC-47D6-A6F0-23D17C51F4EA}"/>
+                <a16:creationId xmlns:a16="http://schemas.microsoft.com/office/drawing/2014/main" id="{781262CF-73A7-45B5-AD91-663C7F25ADF7}"/>
               </a:ext>
             </a:extLst>
           </p:cNvPr>
@@ -11187,7 +11211,7 @@
           <p:cNvPr id="38" name="">
             <a:extLst xmlns:a="http://schemas.openxmlformats.org/drawingml/2006/main">
               <a:ext uri="{FF2B5EF4-FFF2-40B4-BE49-F238E27FC236}">
-                <a16:creationId xmlns:a16="http://schemas.microsoft.com/office/drawing/2014/main" id="{3EFE39C5-D331-4601-B488-F6F24C428086}"/>
+                <a16:creationId xmlns:a16="http://schemas.microsoft.com/office/drawing/2014/main" id="{15534516-F8C3-4797-AF1C-D872F12E2F5D}"/>
               </a:ext>
             </a:extLst>
           </p:cNvPr>
@@ -11251,7 +11275,7 @@
           <p:cNvPr id="39" name="">
             <a:extLst xmlns:a="http://schemas.openxmlformats.org/drawingml/2006/main">
               <a:ext uri="{FF2B5EF4-FFF2-40B4-BE49-F238E27FC236}">
-                <a16:creationId xmlns:a16="http://schemas.microsoft.com/office/drawing/2014/main" id="{AE67A7EB-DB30-4522-91A1-70C62AD81174}"/>
+                <a16:creationId xmlns:a16="http://schemas.microsoft.com/office/drawing/2014/main" id="{2824952F-5C0F-403A-957C-31BCE6295B2D}"/>
               </a:ext>
             </a:extLst>
           </p:cNvPr>
@@ -11313,7 +11337,7 @@
     </p:spTree>
     <p:extLst>
       <p:ext uri="{BB962C8B-B14F-4D97-AF65-F5344CB8AC3E}">
-        <p14:creationId xmlns:p14="http://schemas.microsoft.com/office/powerpoint/2010/main" val="805194821"/>
+        <p14:creationId xmlns:p14="http://schemas.microsoft.com/office/powerpoint/2010/main" val="2067324148"/>
       </p:ext>
     </p:extLst>
   </p:cSld>
@@ -11344,7 +11368,7 @@
           <p:cNvPr id="41" name="">
             <a:extLst xmlns:a="http://schemas.openxmlformats.org/drawingml/2006/main">
               <a:ext uri="{FF2B5EF4-FFF2-40B4-BE49-F238E27FC236}">
-                <a16:creationId xmlns:a16="http://schemas.microsoft.com/office/drawing/2014/main" id="{E7808456-3393-41C1-B254-1D1F13C0EFD4}"/>
+                <a16:creationId xmlns:a16="http://schemas.microsoft.com/office/drawing/2014/main" id="{74EB2949-6870-4EF6-93E5-22EADA1E23EE}"/>
               </a:ext>
             </a:extLst>
           </p:cNvPr>
@@ -11402,7 +11426,7 @@
           <p:cNvPr id="2" name="">
             <a:extLst xmlns:a="http://schemas.openxmlformats.org/drawingml/2006/main">
               <a:ext uri="{FF2B5EF4-FFF2-40B4-BE49-F238E27FC236}">
-                <a16:creationId xmlns:a16="http://schemas.microsoft.com/office/drawing/2014/main" id="{E08281EA-86E2-41B0-BDA2-FD1841D1C4FC}"/>
+                <a16:creationId xmlns:a16="http://schemas.microsoft.com/office/drawing/2014/main" id="{07CC0864-7726-4DB2-A4FA-ABA4FDAFB41C}"/>
               </a:ext>
             </a:extLst>
           </p:cNvPr>
@@ -11483,7 +11507,7 @@
           <p:cNvPr id="3" name="">
             <a:extLst xmlns:a="http://schemas.openxmlformats.org/drawingml/2006/main">
               <a:ext uri="{FF2B5EF4-FFF2-40B4-BE49-F238E27FC236}">
-                <a16:creationId xmlns:a16="http://schemas.microsoft.com/office/drawing/2014/main" id="{CF6091A7-4A88-4673-BC03-D825A3713C4B}"/>
+                <a16:creationId xmlns:a16="http://schemas.microsoft.com/office/drawing/2014/main" id="{6221B5B1-A47C-4082-AA07-A4E5E199D302}"/>
               </a:ext>
             </a:extLst>
           </p:cNvPr>
@@ -11541,7 +11565,7 @@
           <p:cNvPr id="4" name="">
             <a:extLst xmlns:a="http://schemas.openxmlformats.org/drawingml/2006/main">
               <a:ext uri="{FF2B5EF4-FFF2-40B4-BE49-F238E27FC236}">
-                <a16:creationId xmlns:a16="http://schemas.microsoft.com/office/drawing/2014/main" id="{47E97C38-9B53-4625-9FA3-8BE1101DFBEF}"/>
+                <a16:creationId xmlns:a16="http://schemas.microsoft.com/office/drawing/2014/main" id="{BE6EEA6E-5F15-460C-BF32-CA7CC785AC0A}"/>
               </a:ext>
             </a:extLst>
           </p:cNvPr>
@@ -11599,7 +11623,7 @@
           <p:cNvPr id="5" name="">
             <a:extLst xmlns:a="http://schemas.openxmlformats.org/drawingml/2006/main">
               <a:ext uri="{FF2B5EF4-FFF2-40B4-BE49-F238E27FC236}">
-                <a16:creationId xmlns:a16="http://schemas.microsoft.com/office/drawing/2014/main" id="{E356FBA8-7417-475A-85FD-1C5D4FC2A49F}"/>
+                <a16:creationId xmlns:a16="http://schemas.microsoft.com/office/drawing/2014/main" id="{79C9F046-C102-4F51-9BB1-C3CFEA7F1C12}"/>
               </a:ext>
             </a:extLst>
           </p:cNvPr>
@@ -11632,7 +11656,7 @@
           <p:cNvPr id="6" name="">
             <a:extLst xmlns:a="http://schemas.openxmlformats.org/drawingml/2006/main">
               <a:ext uri="{FF2B5EF4-FFF2-40B4-BE49-F238E27FC236}">
-                <a16:creationId xmlns:a16="http://schemas.microsoft.com/office/drawing/2014/main" id="{F20CB85E-61A0-4C3A-B658-49A01DD59550}"/>
+                <a16:creationId xmlns:a16="http://schemas.microsoft.com/office/drawing/2014/main" id="{B5AC7D3F-9DA0-457E-837A-2949D90BB2FC}"/>
               </a:ext>
             </a:extLst>
           </p:cNvPr>
@@ -11665,7 +11689,7 @@
           <p:cNvPr id="7" name="">
             <a:extLst xmlns:a="http://schemas.openxmlformats.org/drawingml/2006/main">
               <a:ext uri="{FF2B5EF4-FFF2-40B4-BE49-F238E27FC236}">
-                <a16:creationId xmlns:a16="http://schemas.microsoft.com/office/drawing/2014/main" id="{8EB068B5-5385-4867-986A-711BD042293F}"/>
+                <a16:creationId xmlns:a16="http://schemas.microsoft.com/office/drawing/2014/main" id="{F1D4BC22-6D1A-4FAC-A710-CFD7E85432C7}"/>
               </a:ext>
             </a:extLst>
           </p:cNvPr>
@@ -11698,7 +11722,7 @@
           <p:cNvPr id="8" name="">
             <a:extLst xmlns:a="http://schemas.openxmlformats.org/drawingml/2006/main">
               <a:ext uri="{FF2B5EF4-FFF2-40B4-BE49-F238E27FC236}">
-                <a16:creationId xmlns:a16="http://schemas.microsoft.com/office/drawing/2014/main" id="{4C5C1210-BC98-4F54-A1A8-E8A78E45D018}"/>
+                <a16:creationId xmlns:a16="http://schemas.microsoft.com/office/drawing/2014/main" id="{FAD02D93-4EA0-44F7-BFCF-C1418CAF7A0E}"/>
               </a:ext>
             </a:extLst>
           </p:cNvPr>
@@ -11809,7 +11833,7 @@
           <p:cNvPr id="12" name="">
             <a:extLst xmlns:a="http://schemas.openxmlformats.org/drawingml/2006/main">
               <a:ext uri="{FF2B5EF4-FFF2-40B4-BE49-F238E27FC236}">
-                <a16:creationId xmlns:a16="http://schemas.microsoft.com/office/drawing/2014/main" id="{53ED2249-1C51-4609-8DF2-5645FC41C963}"/>
+                <a16:creationId xmlns:a16="http://schemas.microsoft.com/office/drawing/2014/main" id="{1903AB74-B419-4490-9324-330EE000CAF8}"/>
               </a:ext>
             </a:extLst>
           </p:cNvPr>
@@ -11842,7 +11866,7 @@
           <p:cNvPr id="13" name="">
             <a:extLst xmlns:a="http://schemas.openxmlformats.org/drawingml/2006/main">
               <a:ext uri="{FF2B5EF4-FFF2-40B4-BE49-F238E27FC236}">
-                <a16:creationId xmlns:a16="http://schemas.microsoft.com/office/drawing/2014/main" id="{F04DAC9C-5107-48E1-9760-C04E42329DE4}"/>
+                <a16:creationId xmlns:a16="http://schemas.microsoft.com/office/drawing/2014/main" id="{A93A63BC-90F8-4678-A674-206C283EB73E}"/>
               </a:ext>
             </a:extLst>
           </p:cNvPr>
@@ -11875,7 +11899,7 @@
           <p:cNvPr id="14" name="">
             <a:extLst xmlns:a="http://schemas.openxmlformats.org/drawingml/2006/main">
               <a:ext uri="{FF2B5EF4-FFF2-40B4-BE49-F238E27FC236}">
-                <a16:creationId xmlns:a16="http://schemas.microsoft.com/office/drawing/2014/main" id="{B57761F6-54AE-4DC9-B277-8D8B28FDCBC4}"/>
+                <a16:creationId xmlns:a16="http://schemas.microsoft.com/office/drawing/2014/main" id="{6951ABD0-66E0-4EB6-850C-1310E917A350}"/>
               </a:ext>
             </a:extLst>
           </p:cNvPr>
@@ -11908,7 +11932,7 @@
           <p:cNvPr id="15" name="">
             <a:extLst xmlns:a="http://schemas.openxmlformats.org/drawingml/2006/main">
               <a:ext uri="{FF2B5EF4-FFF2-40B4-BE49-F238E27FC236}">
-                <a16:creationId xmlns:a16="http://schemas.microsoft.com/office/drawing/2014/main" id="{C047EDD5-6C65-430A-96CE-0CC4D6A3E1D1}"/>
+                <a16:creationId xmlns:a16="http://schemas.microsoft.com/office/drawing/2014/main" id="{47518E8F-A4AB-471B-9ABE-CCC33BC8EDF5}"/>
               </a:ext>
             </a:extLst>
           </p:cNvPr>
@@ -11941,7 +11965,7 @@
           <p:cNvPr id="16" name="">
             <a:extLst xmlns:a="http://schemas.openxmlformats.org/drawingml/2006/main">
               <a:ext uri="{FF2B5EF4-FFF2-40B4-BE49-F238E27FC236}">
-                <a16:creationId xmlns:a16="http://schemas.microsoft.com/office/drawing/2014/main" id="{46E76934-82D7-4F6D-B250-0034AF00762F}"/>
+                <a16:creationId xmlns:a16="http://schemas.microsoft.com/office/drawing/2014/main" id="{5A86DFBE-9ECC-45EA-B26B-653CD9AFA72E}"/>
               </a:ext>
             </a:extLst>
           </p:cNvPr>
@@ -11972,7 +11996,7 @@
           <p:cNvPr id="17" name="">
             <a:extLst xmlns:a="http://schemas.openxmlformats.org/drawingml/2006/main">
               <a:ext uri="{FF2B5EF4-FFF2-40B4-BE49-F238E27FC236}">
-                <a16:creationId xmlns:a16="http://schemas.microsoft.com/office/drawing/2014/main" id="{6FA8CCF5-A2BC-412F-A853-A2979BC1F47F}"/>
+                <a16:creationId xmlns:a16="http://schemas.microsoft.com/office/drawing/2014/main" id="{17AFE675-4E6A-4E6D-AC9F-E22175FE0AC5}"/>
               </a:ext>
             </a:extLst>
           </p:cNvPr>
@@ -12135,7 +12159,7 @@
           <p:cNvPr id="23" name="">
             <a:extLst xmlns:a="http://schemas.openxmlformats.org/drawingml/2006/main">
               <a:ext uri="{FF2B5EF4-FFF2-40B4-BE49-F238E27FC236}">
-                <a16:creationId xmlns:a16="http://schemas.microsoft.com/office/drawing/2014/main" id="{A5B305A7-167B-4DE9-9982-6F3FF1D77E6D}"/>
+                <a16:creationId xmlns:a16="http://schemas.microsoft.com/office/drawing/2014/main" id="{97DE0F80-E1A7-4F1E-913F-C67436D60068}"/>
               </a:ext>
             </a:extLst>
           </p:cNvPr>
@@ -12168,7 +12192,7 @@
           <p:cNvPr id="24" name="">
             <a:extLst xmlns:a="http://schemas.openxmlformats.org/drawingml/2006/main">
               <a:ext uri="{FF2B5EF4-FFF2-40B4-BE49-F238E27FC236}">
-                <a16:creationId xmlns:a16="http://schemas.microsoft.com/office/drawing/2014/main" id="{78697FF1-A6EF-40B3-A301-C9AA06B97EDA}"/>
+                <a16:creationId xmlns:a16="http://schemas.microsoft.com/office/drawing/2014/main" id="{DB537B7E-C788-42C7-A49D-EA53805EDB7A}"/>
               </a:ext>
             </a:extLst>
           </p:cNvPr>
@@ -12201,7 +12225,7 @@
           <p:cNvPr id="25" name="">
             <a:extLst xmlns:a="http://schemas.openxmlformats.org/drawingml/2006/main">
               <a:ext uri="{FF2B5EF4-FFF2-40B4-BE49-F238E27FC236}">
-                <a16:creationId xmlns:a16="http://schemas.microsoft.com/office/drawing/2014/main" id="{28C7F909-9154-4537-B00D-DD5044FFF103}"/>
+                <a16:creationId xmlns:a16="http://schemas.microsoft.com/office/drawing/2014/main" id="{3C4E196B-00A2-427B-9944-9B8679BF446D}"/>
               </a:ext>
             </a:extLst>
           </p:cNvPr>
@@ -12234,7 +12258,7 @@
           <p:cNvPr id="26" name="">
             <a:extLst xmlns:a="http://schemas.openxmlformats.org/drawingml/2006/main">
               <a:ext uri="{FF2B5EF4-FFF2-40B4-BE49-F238E27FC236}">
-                <a16:creationId xmlns:a16="http://schemas.microsoft.com/office/drawing/2014/main" id="{9001D108-20B1-4E02-8798-47848457E0DE}"/>
+                <a16:creationId xmlns:a16="http://schemas.microsoft.com/office/drawing/2014/main" id="{5737C041-A37F-4430-B77F-6FA6618F166E}"/>
               </a:ext>
             </a:extLst>
           </p:cNvPr>
@@ -12265,7 +12289,7 @@
           <p:cNvPr id="27" name="">
             <a:extLst xmlns:a="http://schemas.openxmlformats.org/drawingml/2006/main">
               <a:ext uri="{FF2B5EF4-FFF2-40B4-BE49-F238E27FC236}">
-                <a16:creationId xmlns:a16="http://schemas.microsoft.com/office/drawing/2014/main" id="{1B4CB8D7-BDB3-4CDB-B8AF-039A71CAAC3A}"/>
+                <a16:creationId xmlns:a16="http://schemas.microsoft.com/office/drawing/2014/main" id="{14F87563-9631-4B45-A7F2-5306CAFEDE3D}"/>
               </a:ext>
             </a:extLst>
           </p:cNvPr>
@@ -12298,7 +12322,7 @@
           <p:cNvPr id="28" name="">
             <a:extLst xmlns:a="http://schemas.openxmlformats.org/drawingml/2006/main">
               <a:ext uri="{FF2B5EF4-FFF2-40B4-BE49-F238E27FC236}">
-                <a16:creationId xmlns:a16="http://schemas.microsoft.com/office/drawing/2014/main" id="{3E28B54D-CC3E-4E8D-BC1B-C39006BABACD}"/>
+                <a16:creationId xmlns:a16="http://schemas.microsoft.com/office/drawing/2014/main" id="{945FF476-3FA5-4773-815F-1862D112781F}"/>
               </a:ext>
             </a:extLst>
           </p:cNvPr>
@@ -12331,7 +12355,7 @@
           <p:cNvPr id="29" name="">
             <a:extLst xmlns:a="http://schemas.openxmlformats.org/drawingml/2006/main">
               <a:ext uri="{FF2B5EF4-FFF2-40B4-BE49-F238E27FC236}">
-                <a16:creationId xmlns:a16="http://schemas.microsoft.com/office/drawing/2014/main" id="{BD4626CF-3301-42F9-A6D8-04E291C9EBAC}"/>
+                <a16:creationId xmlns:a16="http://schemas.microsoft.com/office/drawing/2014/main" id="{31F5F32A-86EA-4E72-98CD-FD2877186A2E}"/>
               </a:ext>
             </a:extLst>
           </p:cNvPr>
@@ -12364,7 +12388,7 @@
           <p:cNvPr id="30" name="">
             <a:extLst xmlns:a="http://schemas.openxmlformats.org/drawingml/2006/main">
               <a:ext uri="{FF2B5EF4-FFF2-40B4-BE49-F238E27FC236}">
-                <a16:creationId xmlns:a16="http://schemas.microsoft.com/office/drawing/2014/main" id="{D96C755A-BEFF-4630-BCEA-954B4F40AAF7}"/>
+                <a16:creationId xmlns:a16="http://schemas.microsoft.com/office/drawing/2014/main" id="{C5755324-5FD8-491F-9D05-8EE0B3E9011D}"/>
               </a:ext>
             </a:extLst>
           </p:cNvPr>
@@ -12397,7 +12421,7 @@
           <p:cNvPr id="31" name="">
             <a:extLst xmlns:a="http://schemas.openxmlformats.org/drawingml/2006/main">
               <a:ext uri="{FF2B5EF4-FFF2-40B4-BE49-F238E27FC236}">
-                <a16:creationId xmlns:a16="http://schemas.microsoft.com/office/drawing/2014/main" id="{1812ABF9-4907-427F-AE8A-934EBBED5095}"/>
+                <a16:creationId xmlns:a16="http://schemas.microsoft.com/office/drawing/2014/main" id="{4704B868-7C84-4CD0-84B6-3233E5877589}"/>
               </a:ext>
             </a:extLst>
           </p:cNvPr>
@@ -12430,7 +12454,7 @@
           <p:cNvPr id="32" name="">
             <a:extLst xmlns:a="http://schemas.openxmlformats.org/drawingml/2006/main">
               <a:ext uri="{FF2B5EF4-FFF2-40B4-BE49-F238E27FC236}">
-                <a16:creationId xmlns:a16="http://schemas.microsoft.com/office/drawing/2014/main" id="{6C149D2A-EF1B-4C4A-AACD-5F1879F7DCBE}"/>
+                <a16:creationId xmlns:a16="http://schemas.microsoft.com/office/drawing/2014/main" id="{D2143338-3642-45A6-959B-4C987A564E94}"/>
               </a:ext>
             </a:extLst>
           </p:cNvPr>
@@ -12463,7 +12487,7 @@
           <p:cNvPr id="33" name="">
             <a:extLst xmlns:a="http://schemas.openxmlformats.org/drawingml/2006/main">
               <a:ext uri="{FF2B5EF4-FFF2-40B4-BE49-F238E27FC236}">
-                <a16:creationId xmlns:a16="http://schemas.microsoft.com/office/drawing/2014/main" id="{2F91ED8F-4A68-4AF3-BE74-FB5B0DDEF073}"/>
+                <a16:creationId xmlns:a16="http://schemas.microsoft.com/office/drawing/2014/main" id="{88D5447F-FC68-4175-AD69-96ACCABA4A8A}"/>
               </a:ext>
             </a:extLst>
           </p:cNvPr>
@@ -12546,7 +12570,7 @@
           <p:cNvPr id="36" name="">
             <a:extLst xmlns:a="http://schemas.openxmlformats.org/drawingml/2006/main">
               <a:ext uri="{FF2B5EF4-FFF2-40B4-BE49-F238E27FC236}">
-                <a16:creationId xmlns:a16="http://schemas.microsoft.com/office/drawing/2014/main" id="{04D17122-A077-4AB9-9A6E-28584CCE8D97}"/>
+                <a16:creationId xmlns:a16="http://schemas.microsoft.com/office/drawing/2014/main" id="{ED036D62-4C73-4868-B8FF-B136F5E54741}"/>
               </a:ext>
             </a:extLst>
           </p:cNvPr>
@@ -12579,7 +12603,7 @@
           <p:cNvPr id="37" name="">
             <a:extLst xmlns:a="http://schemas.openxmlformats.org/drawingml/2006/main">
               <a:ext uri="{FF2B5EF4-FFF2-40B4-BE49-F238E27FC236}">
-                <a16:creationId xmlns:a16="http://schemas.microsoft.com/office/drawing/2014/main" id="{3771821F-C3C1-46FE-8E6C-A2ED620710C1}"/>
+                <a16:creationId xmlns:a16="http://schemas.microsoft.com/office/drawing/2014/main" id="{37E4045F-CC8C-4C19-8F92-E9F81DD63E7E}"/>
               </a:ext>
             </a:extLst>
           </p:cNvPr>
@@ -12637,7 +12661,7 @@
           <p:cNvPr id="38" name="">
             <a:extLst xmlns:a="http://schemas.openxmlformats.org/drawingml/2006/main">
               <a:ext uri="{FF2B5EF4-FFF2-40B4-BE49-F238E27FC236}">
-                <a16:creationId xmlns:a16="http://schemas.microsoft.com/office/drawing/2014/main" id="{000AB659-53E3-4230-A2B7-8E2FC2092751}"/>
+                <a16:creationId xmlns:a16="http://schemas.microsoft.com/office/drawing/2014/main" id="{CC2859B7-01D2-4989-8F84-986B635CDD26}"/>
               </a:ext>
             </a:extLst>
           </p:cNvPr>
@@ -12695,7 +12719,7 @@
           <p:cNvPr id="39" name="">
             <a:extLst xmlns:a="http://schemas.openxmlformats.org/drawingml/2006/main">
               <a:ext uri="{FF2B5EF4-FFF2-40B4-BE49-F238E27FC236}">
-                <a16:creationId xmlns:a16="http://schemas.microsoft.com/office/drawing/2014/main" id="{22C3CE11-42F8-4748-BC58-4C4D0107811D}"/>
+                <a16:creationId xmlns:a16="http://schemas.microsoft.com/office/drawing/2014/main" id="{5D971506-9B14-46C8-80FE-0358AA47A3A0}"/>
               </a:ext>
             </a:extLst>
           </p:cNvPr>
@@ -12753,7 +12777,7 @@
           <p:cNvPr id="40" name="">
             <a:extLst xmlns:a="http://schemas.openxmlformats.org/drawingml/2006/main">
               <a:ext uri="{FF2B5EF4-FFF2-40B4-BE49-F238E27FC236}">
-                <a16:creationId xmlns:a16="http://schemas.microsoft.com/office/drawing/2014/main" id="{0ADAAACA-CA7F-4DE9-A998-F4EB85FBE25D}"/>
+                <a16:creationId xmlns:a16="http://schemas.microsoft.com/office/drawing/2014/main" id="{B5CE84FE-87AF-4EDB-9B0F-331B1898BFBA}"/>
               </a:ext>
             </a:extLst>
           </p:cNvPr>
@@ -12809,7 +12833,7 @@
     </p:spTree>
     <p:extLst>
       <p:ext uri="{BB962C8B-B14F-4D97-AF65-F5344CB8AC3E}">
-        <p14:creationId xmlns:p14="http://schemas.microsoft.com/office/powerpoint/2010/main" val="343967891"/>
+        <p14:creationId xmlns:p14="http://schemas.microsoft.com/office/powerpoint/2010/main" val="1097691391"/>
       </p:ext>
     </p:extLst>
   </p:cSld>

</xml_diff>

<commit_message>
Update presentation layout and visual assets: modify slide IDs and layout references for consistency
</commit_message>
<xml_diff>
--- a/.codex-build/presentation-visuals/candidate.pptx
+++ b/.codex-build/presentation-visuals/candidate.pptx
@@ -2,20 +2,20 @@
 <file path=ppt/presentation.xml><?xml version="1.0" encoding="utf-8"?>
 <p:presentation xmlns:p="http://schemas.openxmlformats.org/presentationml/2006/main">
   <p:sldMasterIdLst>
-    <p:sldMasterId xmlns:r="http://schemas.openxmlformats.org/officeDocument/2006/relationships" id="2147483648" r:id="R53388c2e29504b61"/>
+    <p:sldMasterId xmlns:r="http://schemas.openxmlformats.org/officeDocument/2006/relationships" id="2147483648" r:id="Rd46b27ecbbd94a92"/>
   </p:sldMasterIdLst>
   <p:notesMasterIdLst>
-    <p:notesMasterId xmlns:r="http://schemas.openxmlformats.org/officeDocument/2006/relationships" r:id="Ra457b6a64eca448a"/>
+    <p:notesMasterId xmlns:r="http://schemas.openxmlformats.org/officeDocument/2006/relationships" r:id="Reb63c760de5b41e8"/>
   </p:notesMasterIdLst>
   <p:sldIdLst>
-    <p:sldId xmlns:r="http://schemas.openxmlformats.org/officeDocument/2006/relationships" id="256" r:id="Rdeaec776715d4271"/>
-    <p:sldId xmlns:r="http://schemas.openxmlformats.org/officeDocument/2006/relationships" id="257" r:id="R43c8d5bfb1d446cc"/>
-    <p:sldId xmlns:r="http://schemas.openxmlformats.org/officeDocument/2006/relationships" id="258" r:id="Rf85610dfd1334359"/>
-    <p:sldId xmlns:r="http://schemas.openxmlformats.org/officeDocument/2006/relationships" id="259" r:id="R1bd133726a114540"/>
-    <p:sldId xmlns:r="http://schemas.openxmlformats.org/officeDocument/2006/relationships" id="260" r:id="R5fb3b1eee6384d74"/>
-    <p:sldId xmlns:r="http://schemas.openxmlformats.org/officeDocument/2006/relationships" id="261" r:id="R79255a916fbd4a48"/>
-    <p:sldId xmlns:r="http://schemas.openxmlformats.org/officeDocument/2006/relationships" id="262" r:id="Re6a33744c11c497a"/>
-    <p:sldId xmlns:r="http://schemas.openxmlformats.org/officeDocument/2006/relationships" id="263" r:id="R07b19c0efa0241de"/>
+    <p:sldId xmlns:r="http://schemas.openxmlformats.org/officeDocument/2006/relationships" id="256" r:id="Rd7a3c0ff76bd432c"/>
+    <p:sldId xmlns:r="http://schemas.openxmlformats.org/officeDocument/2006/relationships" id="257" r:id="R24525844922b49d9"/>
+    <p:sldId xmlns:r="http://schemas.openxmlformats.org/officeDocument/2006/relationships" id="258" r:id="R1f5ebbcddf644e84"/>
+    <p:sldId xmlns:r="http://schemas.openxmlformats.org/officeDocument/2006/relationships" id="259" r:id="R428175a7272144ec"/>
+    <p:sldId xmlns:r="http://schemas.openxmlformats.org/officeDocument/2006/relationships" id="260" r:id="Rad5a96ec54064dd4"/>
+    <p:sldId xmlns:r="http://schemas.openxmlformats.org/officeDocument/2006/relationships" id="261" r:id="Rfcadd324d2b34211"/>
+    <p:sldId xmlns:r="http://schemas.openxmlformats.org/officeDocument/2006/relationships" id="262" r:id="Rb95b1ac883154ad1"/>
+    <p:sldId xmlns:r="http://schemas.openxmlformats.org/officeDocument/2006/relationships" id="263" r:id="R10f962ce4f594be3"/>
   </p:sldIdLst>
   <p:sldSz cx="12192000" cy="6858000"/>
   <p:notesSz cx="6858000" cy="9144000"/>
@@ -975,7 +975,7 @@
   </p:cSld>
   <p:clrMap bg1="lt1" tx1="dk1" bg2="lt2" tx2="dk2" accent1="accent1" accent2="accent2" accent3="accent3" accent4="accent4" accent5="accent5" accent6="accent6" hlink="hlink" folHlink="folHlink"/>
   <p:sldLayoutIdLst>
-    <p:sldLayoutId xmlns:r="http://schemas.openxmlformats.org/officeDocument/2006/relationships" id="2147483649" r:id="Rd856887d82e0414d"/>
+    <p:sldLayoutId xmlns:r="http://schemas.openxmlformats.org/officeDocument/2006/relationships" id="2147483649" r:id="R3066184a8fba4c58"/>
   </p:sldLayoutIdLst>
   <p:txStyles>
     <p:titleStyle>
@@ -1526,7 +1526,7 @@
           <p:cNvPr id="29" name="">
             <a:extLst xmlns:a="http://schemas.openxmlformats.org/drawingml/2006/main">
               <a:ext uri="{FF2B5EF4-FFF2-40B4-BE49-F238E27FC236}">
-                <a16:creationId xmlns:a16="http://schemas.microsoft.com/office/drawing/2014/main" id="{93CAFD81-E6E4-4232-8FF9-DDD777E21E55}"/>
+                <a16:creationId xmlns:a16="http://schemas.microsoft.com/office/drawing/2014/main" id="{11C95C42-946F-487A-B95A-325BE85137DB}"/>
               </a:ext>
             </a:extLst>
           </p:cNvPr>
@@ -1559,7 +1559,7 @@
           <p:cNvPr id="2" name="">
             <a:extLst xmlns:a="http://schemas.openxmlformats.org/drawingml/2006/main">
               <a:ext uri="{FF2B5EF4-FFF2-40B4-BE49-F238E27FC236}">
-                <a16:creationId xmlns:a16="http://schemas.microsoft.com/office/drawing/2014/main" id="{0657A42A-C3DE-4665-B315-B7B0645A81B7}"/>
+                <a16:creationId xmlns:a16="http://schemas.microsoft.com/office/drawing/2014/main" id="{7D82F2AB-45BF-463B-9847-4BB2A7309F32}"/>
               </a:ext>
             </a:extLst>
           </p:cNvPr>
@@ -1592,7 +1592,7 @@
           <p:cNvPr id="3" name="">
             <a:extLst xmlns:a="http://schemas.openxmlformats.org/drawingml/2006/main">
               <a:ext uri="{FF2B5EF4-FFF2-40B4-BE49-F238E27FC236}">
-                <a16:creationId xmlns:a16="http://schemas.microsoft.com/office/drawing/2014/main" id="{0830B6C7-3174-47A4-9CE7-A7A778BEB783}"/>
+                <a16:creationId xmlns:a16="http://schemas.microsoft.com/office/drawing/2014/main" id="{62870137-5732-4BBE-BC0E-EE6B1DF3E0BD}"/>
               </a:ext>
             </a:extLst>
           </p:cNvPr>
@@ -1625,7 +1625,7 @@
           <p:cNvPr id="4" name="">
             <a:extLst xmlns:a="http://schemas.openxmlformats.org/drawingml/2006/main">
               <a:ext uri="{FF2B5EF4-FFF2-40B4-BE49-F238E27FC236}">
-                <a16:creationId xmlns:a16="http://schemas.microsoft.com/office/drawing/2014/main" id="{3223B17F-D25F-4C5F-A31F-6FE290153D53}"/>
+                <a16:creationId xmlns:a16="http://schemas.microsoft.com/office/drawing/2014/main" id="{E2DAF2C1-CCB9-4DE0-BC5C-28F07DCEB4C5}"/>
               </a:ext>
             </a:extLst>
           </p:cNvPr>
@@ -1658,7 +1658,7 @@
           <p:cNvPr id="5" name="">
             <a:extLst xmlns:a="http://schemas.openxmlformats.org/drawingml/2006/main">
               <a:ext uri="{FF2B5EF4-FFF2-40B4-BE49-F238E27FC236}">
-                <a16:creationId xmlns:a16="http://schemas.microsoft.com/office/drawing/2014/main" id="{9D4B0BE5-25C3-4FA7-9904-F6821B598295}"/>
+                <a16:creationId xmlns:a16="http://schemas.microsoft.com/office/drawing/2014/main" id="{67C213D9-8DB6-41E4-9700-8548B51A6AB5}"/>
               </a:ext>
             </a:extLst>
           </p:cNvPr>
@@ -1769,7 +1769,7 @@
           <p:cNvPr id="9" name="">
             <a:extLst xmlns:a="http://schemas.openxmlformats.org/drawingml/2006/main">
               <a:ext uri="{FF2B5EF4-FFF2-40B4-BE49-F238E27FC236}">
-                <a16:creationId xmlns:a16="http://schemas.microsoft.com/office/drawing/2014/main" id="{B9574605-5A54-4A3B-9601-D61D74B82F12}"/>
+                <a16:creationId xmlns:a16="http://schemas.microsoft.com/office/drawing/2014/main" id="{9E42E6E6-925B-4399-A7FF-294F314F72A5}"/>
               </a:ext>
             </a:extLst>
           </p:cNvPr>
@@ -1833,7 +1833,7 @@
           <p:cNvPr id="10" name="">
             <a:extLst xmlns:a="http://schemas.openxmlformats.org/drawingml/2006/main">
               <a:ext uri="{FF2B5EF4-FFF2-40B4-BE49-F238E27FC236}">
-                <a16:creationId xmlns:a16="http://schemas.microsoft.com/office/drawing/2014/main" id="{750E0577-8D26-4E35-A5EE-8DE7D415B1E5}"/>
+                <a16:creationId xmlns:a16="http://schemas.microsoft.com/office/drawing/2014/main" id="{0BE2E47E-9D0B-4F50-A50F-3D2FE696F6A8}"/>
               </a:ext>
             </a:extLst>
           </p:cNvPr>
@@ -1891,7 +1891,7 @@
           <p:cNvPr id="11" name="">
             <a:extLst xmlns:a="http://schemas.openxmlformats.org/drawingml/2006/main">
               <a:ext uri="{FF2B5EF4-FFF2-40B4-BE49-F238E27FC236}">
-                <a16:creationId xmlns:a16="http://schemas.microsoft.com/office/drawing/2014/main" id="{CC90F7BE-2635-483B-A7EB-4086507F6544}"/>
+                <a16:creationId xmlns:a16="http://schemas.microsoft.com/office/drawing/2014/main" id="{98803ECE-63B4-434E-B321-D027CE910B69}"/>
               </a:ext>
             </a:extLst>
           </p:cNvPr>
@@ -1924,7 +1924,7 @@
           <p:cNvPr id="12" name="">
             <a:extLst xmlns:a="http://schemas.openxmlformats.org/drawingml/2006/main">
               <a:ext uri="{FF2B5EF4-FFF2-40B4-BE49-F238E27FC236}">
-                <a16:creationId xmlns:a16="http://schemas.microsoft.com/office/drawing/2014/main" id="{862E6C1C-F459-4560-A291-1850ACE41115}"/>
+                <a16:creationId xmlns:a16="http://schemas.microsoft.com/office/drawing/2014/main" id="{217F5523-9D24-4A8C-A33F-AA889EF32412}"/>
               </a:ext>
             </a:extLst>
           </p:cNvPr>
@@ -1982,7 +1982,7 @@
           <p:cNvPr id="13" name="">
             <a:extLst xmlns:a="http://schemas.openxmlformats.org/drawingml/2006/main">
               <a:ext uri="{FF2B5EF4-FFF2-40B4-BE49-F238E27FC236}">
-                <a16:creationId xmlns:a16="http://schemas.microsoft.com/office/drawing/2014/main" id="{8D11020E-0E2C-44EA-AB25-630E36E3714F}"/>
+                <a16:creationId xmlns:a16="http://schemas.microsoft.com/office/drawing/2014/main" id="{DB1F46C8-B6D9-4B78-931F-FA785D38DA5A}"/>
               </a:ext>
             </a:extLst>
           </p:cNvPr>
@@ -2015,7 +2015,7 @@
           <p:cNvPr id="14" name="">
             <a:extLst xmlns:a="http://schemas.openxmlformats.org/drawingml/2006/main">
               <a:ext uri="{FF2B5EF4-FFF2-40B4-BE49-F238E27FC236}">
-                <a16:creationId xmlns:a16="http://schemas.microsoft.com/office/drawing/2014/main" id="{D645EFAF-8CD6-449C-8D93-71E18A67214F}"/>
+                <a16:creationId xmlns:a16="http://schemas.microsoft.com/office/drawing/2014/main" id="{E260EF71-CC40-415A-AD21-EC74FDC64986}"/>
               </a:ext>
             </a:extLst>
           </p:cNvPr>
@@ -2073,7 +2073,7 @@
           <p:cNvPr id="15" name="">
             <a:extLst xmlns:a="http://schemas.openxmlformats.org/drawingml/2006/main">
               <a:ext uri="{FF2B5EF4-FFF2-40B4-BE49-F238E27FC236}">
-                <a16:creationId xmlns:a16="http://schemas.microsoft.com/office/drawing/2014/main" id="{E63A42F4-A34C-4E79-ADF8-9720479DB749}"/>
+                <a16:creationId xmlns:a16="http://schemas.microsoft.com/office/drawing/2014/main" id="{966FF39B-7312-4650-992A-292B12B58AC3}"/>
               </a:ext>
             </a:extLst>
           </p:cNvPr>
@@ -2106,7 +2106,7 @@
           <p:cNvPr id="16" name="">
             <a:extLst xmlns:a="http://schemas.openxmlformats.org/drawingml/2006/main">
               <a:ext uri="{FF2B5EF4-FFF2-40B4-BE49-F238E27FC236}">
-                <a16:creationId xmlns:a16="http://schemas.microsoft.com/office/drawing/2014/main" id="{0A87E332-DDE1-474A-A374-9FFCC0E6E23C}"/>
+                <a16:creationId xmlns:a16="http://schemas.microsoft.com/office/drawing/2014/main" id="{5524D2CB-AA23-4ECF-9428-95D80EC33046}"/>
               </a:ext>
             </a:extLst>
           </p:cNvPr>
@@ -2137,7 +2137,7 @@
           <p:cNvPr id="17" name="">
             <a:extLst xmlns:a="http://schemas.openxmlformats.org/drawingml/2006/main">
               <a:ext uri="{FF2B5EF4-FFF2-40B4-BE49-F238E27FC236}">
-                <a16:creationId xmlns:a16="http://schemas.microsoft.com/office/drawing/2014/main" id="{33B3B7EE-AC08-4CAE-B64E-066CE0F9F337}"/>
+                <a16:creationId xmlns:a16="http://schemas.microsoft.com/office/drawing/2014/main" id="{9CA7C3C3-7126-410D-A1E6-91D8D5FED066}"/>
               </a:ext>
             </a:extLst>
           </p:cNvPr>
@@ -2195,7 +2195,7 @@
           <p:cNvPr id="18" name="">
             <a:extLst xmlns:a="http://schemas.openxmlformats.org/drawingml/2006/main">
               <a:ext uri="{FF2B5EF4-FFF2-40B4-BE49-F238E27FC236}">
-                <a16:creationId xmlns:a16="http://schemas.microsoft.com/office/drawing/2014/main" id="{6BCCBF69-845F-4E9C-9AD3-BB848ADBA10B}"/>
+                <a16:creationId xmlns:a16="http://schemas.microsoft.com/office/drawing/2014/main" id="{76821C26-D28A-4B72-975B-817EC6630EB1}"/>
               </a:ext>
             </a:extLst>
           </p:cNvPr>
@@ -2228,7 +2228,7 @@
           <p:cNvPr id="19" name="">
             <a:extLst xmlns:a="http://schemas.openxmlformats.org/drawingml/2006/main">
               <a:ext uri="{FF2B5EF4-FFF2-40B4-BE49-F238E27FC236}">
-                <a16:creationId xmlns:a16="http://schemas.microsoft.com/office/drawing/2014/main" id="{4FD6A4E5-9EAF-4726-AF33-9F6A96325BCE}"/>
+                <a16:creationId xmlns:a16="http://schemas.microsoft.com/office/drawing/2014/main" id="{4BC65BB9-BE8A-44E5-99C4-E04603CBD244}"/>
               </a:ext>
             </a:extLst>
           </p:cNvPr>
@@ -2364,7 +2364,7 @@
           <p:cNvPr id="23" name="">
             <a:extLst xmlns:a="http://schemas.openxmlformats.org/drawingml/2006/main">
               <a:ext uri="{FF2B5EF4-FFF2-40B4-BE49-F238E27FC236}">
-                <a16:creationId xmlns:a16="http://schemas.microsoft.com/office/drawing/2014/main" id="{411FE7F4-EB3B-40FD-8D98-FCA706446355}"/>
+                <a16:creationId xmlns:a16="http://schemas.microsoft.com/office/drawing/2014/main" id="{0494A262-C550-43A2-87C5-54EA90ACA155}"/>
               </a:ext>
             </a:extLst>
           </p:cNvPr>
@@ -2422,7 +2422,7 @@
           <p:cNvPr id="24" name="">
             <a:extLst xmlns:a="http://schemas.openxmlformats.org/drawingml/2006/main">
               <a:ext uri="{FF2B5EF4-FFF2-40B4-BE49-F238E27FC236}">
-                <a16:creationId xmlns:a16="http://schemas.microsoft.com/office/drawing/2014/main" id="{F4B7D1A6-4ABF-4C74-BC66-255F0A33273A}"/>
+                <a16:creationId xmlns:a16="http://schemas.microsoft.com/office/drawing/2014/main" id="{4F7A3E9F-D5F1-4925-91FD-59EF5016ED9D}"/>
               </a:ext>
             </a:extLst>
           </p:cNvPr>
@@ -2480,7 +2480,7 @@
           <p:cNvPr id="25" name="">
             <a:extLst xmlns:a="http://schemas.openxmlformats.org/drawingml/2006/main">
               <a:ext uri="{FF2B5EF4-FFF2-40B4-BE49-F238E27FC236}">
-                <a16:creationId xmlns:a16="http://schemas.microsoft.com/office/drawing/2014/main" id="{F14B98DD-03C7-421F-B259-2E417DEC3C6C}"/>
+                <a16:creationId xmlns:a16="http://schemas.microsoft.com/office/drawing/2014/main" id="{91908946-7BFE-4957-922D-B46DA8C0F47D}"/>
               </a:ext>
             </a:extLst>
           </p:cNvPr>
@@ -2538,7 +2538,7 @@
           <p:cNvPr id="26" name="">
             <a:extLst xmlns:a="http://schemas.openxmlformats.org/drawingml/2006/main">
               <a:ext uri="{FF2B5EF4-FFF2-40B4-BE49-F238E27FC236}">
-                <a16:creationId xmlns:a16="http://schemas.microsoft.com/office/drawing/2014/main" id="{1A7E8B73-43A4-4DE5-95E4-129A2F8DEBF4}"/>
+                <a16:creationId xmlns:a16="http://schemas.microsoft.com/office/drawing/2014/main" id="{74A2C6C4-BAC9-4EA3-B782-29792FD7A47D}"/>
               </a:ext>
             </a:extLst>
           </p:cNvPr>
@@ -2596,7 +2596,7 @@
           <p:cNvPr id="27" name="">
             <a:extLst xmlns:a="http://schemas.openxmlformats.org/drawingml/2006/main">
               <a:ext uri="{FF2B5EF4-FFF2-40B4-BE49-F238E27FC236}">
-                <a16:creationId xmlns:a16="http://schemas.microsoft.com/office/drawing/2014/main" id="{3E19AA77-3B25-4BB8-86AA-64A7ACB68BDC}"/>
+                <a16:creationId xmlns:a16="http://schemas.microsoft.com/office/drawing/2014/main" id="{7DC0A2DD-E135-4ECF-9587-D9E259326858}"/>
               </a:ext>
             </a:extLst>
           </p:cNvPr>
@@ -2654,7 +2654,7 @@
           <p:cNvPr id="28" name="">
             <a:extLst xmlns:a="http://schemas.openxmlformats.org/drawingml/2006/main">
               <a:ext uri="{FF2B5EF4-FFF2-40B4-BE49-F238E27FC236}">
-                <a16:creationId xmlns:a16="http://schemas.microsoft.com/office/drawing/2014/main" id="{884B6347-9116-4576-8DC6-5C7C579E0A8F}"/>
+                <a16:creationId xmlns:a16="http://schemas.microsoft.com/office/drawing/2014/main" id="{0948A6EB-6C58-4ECD-872B-5737FE30FF5E}"/>
               </a:ext>
             </a:extLst>
           </p:cNvPr>
@@ -2710,7 +2710,7 @@
     </p:spTree>
     <p:extLst>
       <p:ext uri="{BB962C8B-B14F-4D97-AF65-F5344CB8AC3E}">
-        <p14:creationId xmlns:p14="http://schemas.microsoft.com/office/powerpoint/2010/main" val="1341571849"/>
+        <p14:creationId xmlns:p14="http://schemas.microsoft.com/office/powerpoint/2010/main" val="444706214"/>
       </p:ext>
     </p:extLst>
   </p:cSld>
@@ -2741,7 +2741,7 @@
           <p:cNvPr id="42" name="">
             <a:extLst xmlns:a="http://schemas.openxmlformats.org/drawingml/2006/main">
               <a:ext uri="{FF2B5EF4-FFF2-40B4-BE49-F238E27FC236}">
-                <a16:creationId xmlns:a16="http://schemas.microsoft.com/office/drawing/2014/main" id="{9D994A40-2384-49B2-9DDD-1E735B1C5B72}"/>
+                <a16:creationId xmlns:a16="http://schemas.microsoft.com/office/drawing/2014/main" id="{A9506719-1A35-448E-96AC-2079E9B47F29}"/>
               </a:ext>
             </a:extLst>
           </p:cNvPr>
@@ -2774,7 +2774,7 @@
           <p:cNvPr id="2" name="">
             <a:extLst xmlns:a="http://schemas.openxmlformats.org/drawingml/2006/main">
               <a:ext uri="{FF2B5EF4-FFF2-40B4-BE49-F238E27FC236}">
-                <a16:creationId xmlns:a16="http://schemas.microsoft.com/office/drawing/2014/main" id="{D9122382-7BCF-4BB0-B1AD-DD3992D3448B}"/>
+                <a16:creationId xmlns:a16="http://schemas.microsoft.com/office/drawing/2014/main" id="{7B48A253-3E09-4A73-94C4-7108B13FE151}"/>
               </a:ext>
             </a:extLst>
           </p:cNvPr>
@@ -2807,7 +2807,7 @@
           <p:cNvPr id="3" name="">
             <a:extLst xmlns:a="http://schemas.openxmlformats.org/drawingml/2006/main">
               <a:ext uri="{FF2B5EF4-FFF2-40B4-BE49-F238E27FC236}">
-                <a16:creationId xmlns:a16="http://schemas.microsoft.com/office/drawing/2014/main" id="{8121B5F1-0A5F-462E-B48D-A49A782FDA7A}"/>
+                <a16:creationId xmlns:a16="http://schemas.microsoft.com/office/drawing/2014/main" id="{56EBF4A2-5D34-4B7B-9165-5DF48004B532}"/>
               </a:ext>
             </a:extLst>
           </p:cNvPr>
@@ -2840,7 +2840,7 @@
           <p:cNvPr id="4" name="">
             <a:extLst xmlns:a="http://schemas.openxmlformats.org/drawingml/2006/main">
               <a:ext uri="{FF2B5EF4-FFF2-40B4-BE49-F238E27FC236}">
-                <a16:creationId xmlns:a16="http://schemas.microsoft.com/office/drawing/2014/main" id="{50876A41-4DCB-40F2-B35F-DCB9A3B65336}"/>
+                <a16:creationId xmlns:a16="http://schemas.microsoft.com/office/drawing/2014/main" id="{7DFD148C-BAA3-4253-B6E6-2E0D5815CFDE}"/>
               </a:ext>
             </a:extLst>
           </p:cNvPr>
@@ -2951,7 +2951,7 @@
           <p:cNvPr id="8" name="">
             <a:extLst xmlns:a="http://schemas.openxmlformats.org/drawingml/2006/main">
               <a:ext uri="{FF2B5EF4-FFF2-40B4-BE49-F238E27FC236}">
-                <a16:creationId xmlns:a16="http://schemas.microsoft.com/office/drawing/2014/main" id="{3C4316FE-E00E-4665-A8FA-0679892A889A}"/>
+                <a16:creationId xmlns:a16="http://schemas.microsoft.com/office/drawing/2014/main" id="{F9CF5272-895E-466F-B459-EA0EFE8EE744}"/>
               </a:ext>
             </a:extLst>
           </p:cNvPr>
@@ -2984,7 +2984,7 @@
           <p:cNvPr id="9" name="">
             <a:extLst xmlns:a="http://schemas.openxmlformats.org/drawingml/2006/main">
               <a:ext uri="{FF2B5EF4-FFF2-40B4-BE49-F238E27FC236}">
-                <a16:creationId xmlns:a16="http://schemas.microsoft.com/office/drawing/2014/main" id="{94C65E28-73CF-4695-B9B0-E65C6A6AEEE2}"/>
+                <a16:creationId xmlns:a16="http://schemas.microsoft.com/office/drawing/2014/main" id="{60E705A4-AC6D-4670-B18C-A6EA15CB9D07}"/>
               </a:ext>
             </a:extLst>
           </p:cNvPr>
@@ -3017,7 +3017,7 @@
           <p:cNvPr id="10" name="">
             <a:extLst xmlns:a="http://schemas.openxmlformats.org/drawingml/2006/main">
               <a:ext uri="{FF2B5EF4-FFF2-40B4-BE49-F238E27FC236}">
-                <a16:creationId xmlns:a16="http://schemas.microsoft.com/office/drawing/2014/main" id="{C043273F-29BA-490D-AF95-D8ED248766EB}"/>
+                <a16:creationId xmlns:a16="http://schemas.microsoft.com/office/drawing/2014/main" id="{A1F1B38C-6B1A-4631-88DC-6275F60AE495}"/>
               </a:ext>
             </a:extLst>
           </p:cNvPr>
@@ -3050,7 +3050,7 @@
           <p:cNvPr id="11" name="">
             <a:extLst xmlns:a="http://schemas.openxmlformats.org/drawingml/2006/main">
               <a:ext uri="{FF2B5EF4-FFF2-40B4-BE49-F238E27FC236}">
-                <a16:creationId xmlns:a16="http://schemas.microsoft.com/office/drawing/2014/main" id="{E42B3A60-B9D0-4DB0-B4C0-51930CB0E760}"/>
+                <a16:creationId xmlns:a16="http://schemas.microsoft.com/office/drawing/2014/main" id="{5D18DA3B-8EDF-4C37-A175-D96C18BA4C33}"/>
               </a:ext>
             </a:extLst>
           </p:cNvPr>
@@ -3161,7 +3161,7 @@
           <p:cNvPr id="15" name="">
             <a:extLst xmlns:a="http://schemas.openxmlformats.org/drawingml/2006/main">
               <a:ext uri="{FF2B5EF4-FFF2-40B4-BE49-F238E27FC236}">
-                <a16:creationId xmlns:a16="http://schemas.microsoft.com/office/drawing/2014/main" id="{A62AFB9A-B44E-4BCD-ABB8-162A92F0E392}"/>
+                <a16:creationId xmlns:a16="http://schemas.microsoft.com/office/drawing/2014/main" id="{C5F6588D-0D4F-4BE3-9C56-E4109B0DCC56}"/>
               </a:ext>
             </a:extLst>
           </p:cNvPr>
@@ -3194,7 +3194,7 @@
           <p:cNvPr id="16" name="">
             <a:extLst xmlns:a="http://schemas.openxmlformats.org/drawingml/2006/main">
               <a:ext uri="{FF2B5EF4-FFF2-40B4-BE49-F238E27FC236}">
-                <a16:creationId xmlns:a16="http://schemas.microsoft.com/office/drawing/2014/main" id="{AE1C68E5-7B92-41ED-AE95-EC5B619CDF5D}"/>
+                <a16:creationId xmlns:a16="http://schemas.microsoft.com/office/drawing/2014/main" id="{866BAC63-2613-424B-8B77-197B0BBFFF57}"/>
               </a:ext>
             </a:extLst>
           </p:cNvPr>
@@ -3253,7 +3253,7 @@
           <p:cNvPr id="18" name="">
             <a:extLst xmlns:a="http://schemas.openxmlformats.org/drawingml/2006/main">
               <a:ext uri="{FF2B5EF4-FFF2-40B4-BE49-F238E27FC236}">
-                <a16:creationId xmlns:a16="http://schemas.microsoft.com/office/drawing/2014/main" id="{C0A27A0F-0816-4727-BCDB-BC3890FD4894}"/>
+                <a16:creationId xmlns:a16="http://schemas.microsoft.com/office/drawing/2014/main" id="{171E2545-F8BF-4C31-8CD6-5E7FA621C760}"/>
               </a:ext>
             </a:extLst>
           </p:cNvPr>
@@ -3312,7 +3312,7 @@
           <p:cNvPr id="20" name="">
             <a:extLst xmlns:a="http://schemas.openxmlformats.org/drawingml/2006/main">
               <a:ext uri="{FF2B5EF4-FFF2-40B4-BE49-F238E27FC236}">
-                <a16:creationId xmlns:a16="http://schemas.microsoft.com/office/drawing/2014/main" id="{A81C89D3-7C6B-4DF1-A0C7-709A6781CF53}"/>
+                <a16:creationId xmlns:a16="http://schemas.microsoft.com/office/drawing/2014/main" id="{466ED26F-97F6-4D0B-BD9D-2129265E6C65}"/>
               </a:ext>
             </a:extLst>
           </p:cNvPr>
@@ -3371,7 +3371,7 @@
           <p:cNvPr id="22" name="">
             <a:extLst xmlns:a="http://schemas.openxmlformats.org/drawingml/2006/main">
               <a:ext uri="{FF2B5EF4-FFF2-40B4-BE49-F238E27FC236}">
-                <a16:creationId xmlns:a16="http://schemas.microsoft.com/office/drawing/2014/main" id="{22F0BE50-6CBB-48D4-A456-AD9B3BA0C11B}"/>
+                <a16:creationId xmlns:a16="http://schemas.microsoft.com/office/drawing/2014/main" id="{D4AD3DF8-D772-41D2-A912-C957F4B75249}"/>
               </a:ext>
             </a:extLst>
           </p:cNvPr>
@@ -3435,7 +3435,7 @@
           <p:cNvPr id="23" name="">
             <a:extLst xmlns:a="http://schemas.openxmlformats.org/drawingml/2006/main">
               <a:ext uri="{FF2B5EF4-FFF2-40B4-BE49-F238E27FC236}">
-                <a16:creationId xmlns:a16="http://schemas.microsoft.com/office/drawing/2014/main" id="{1F4E67D9-70F6-4C03-B2D2-BDA6BB7F57A0}"/>
+                <a16:creationId xmlns:a16="http://schemas.microsoft.com/office/drawing/2014/main" id="{6A20FD47-E0FF-48EA-AD6E-353C0695BBA9}"/>
               </a:ext>
             </a:extLst>
           </p:cNvPr>
@@ -3551,7 +3551,7 @@
           <p:cNvPr id="26" name="">
             <a:extLst xmlns:a="http://schemas.openxmlformats.org/drawingml/2006/main">
               <a:ext uri="{FF2B5EF4-FFF2-40B4-BE49-F238E27FC236}">
-                <a16:creationId xmlns:a16="http://schemas.microsoft.com/office/drawing/2014/main" id="{F1F68AC9-2B2E-45A0-98F9-26987DF6DB7A}"/>
+                <a16:creationId xmlns:a16="http://schemas.microsoft.com/office/drawing/2014/main" id="{2ECF2DAD-7C95-4C70-9CF6-C658B98D8688}"/>
               </a:ext>
             </a:extLst>
           </p:cNvPr>
@@ -3584,7 +3584,7 @@
           <p:cNvPr id="27" name="">
             <a:extLst xmlns:a="http://schemas.openxmlformats.org/drawingml/2006/main">
               <a:ext uri="{FF2B5EF4-FFF2-40B4-BE49-F238E27FC236}">
-                <a16:creationId xmlns:a16="http://schemas.microsoft.com/office/drawing/2014/main" id="{5FBD3BFE-5FBF-4ACB-A8A3-E9096A3893EA}"/>
+                <a16:creationId xmlns:a16="http://schemas.microsoft.com/office/drawing/2014/main" id="{74D95959-6854-4BEE-B33E-CC74A037CC7F}"/>
               </a:ext>
             </a:extLst>
           </p:cNvPr>
@@ -3617,7 +3617,7 @@
           <p:cNvPr id="28" name="">
             <a:extLst xmlns:a="http://schemas.openxmlformats.org/drawingml/2006/main">
               <a:ext uri="{FF2B5EF4-FFF2-40B4-BE49-F238E27FC236}">
-                <a16:creationId xmlns:a16="http://schemas.microsoft.com/office/drawing/2014/main" id="{9428C34B-A9DD-4F66-B0A0-F7BA260CD6DB}"/>
+                <a16:creationId xmlns:a16="http://schemas.microsoft.com/office/drawing/2014/main" id="{F93F37AF-0BEF-443F-905B-2F02EC71498E}"/>
               </a:ext>
             </a:extLst>
           </p:cNvPr>
@@ -3650,7 +3650,7 @@
           <p:cNvPr id="29" name="">
             <a:extLst xmlns:a="http://schemas.openxmlformats.org/drawingml/2006/main">
               <a:ext uri="{FF2B5EF4-FFF2-40B4-BE49-F238E27FC236}">
-                <a16:creationId xmlns:a16="http://schemas.microsoft.com/office/drawing/2014/main" id="{E4B2646D-30F0-46E0-A125-C219DD88000E}"/>
+                <a16:creationId xmlns:a16="http://schemas.microsoft.com/office/drawing/2014/main" id="{3C259C46-2388-4732-8495-653D302A4982}"/>
               </a:ext>
             </a:extLst>
           </p:cNvPr>
@@ -3683,7 +3683,7 @@
           <p:cNvPr id="30" name="">
             <a:extLst xmlns:a="http://schemas.openxmlformats.org/drawingml/2006/main">
               <a:ext uri="{FF2B5EF4-FFF2-40B4-BE49-F238E27FC236}">
-                <a16:creationId xmlns:a16="http://schemas.microsoft.com/office/drawing/2014/main" id="{86823958-E6D5-4F1C-B8D6-189185AAC1F3}"/>
+                <a16:creationId xmlns:a16="http://schemas.microsoft.com/office/drawing/2014/main" id="{F5A9EBBA-2F37-4CD6-92DF-A3E173978DB5}"/>
               </a:ext>
             </a:extLst>
           </p:cNvPr>
@@ -3792,7 +3792,7 @@
           <p:cNvPr id="34" name="">
             <a:extLst xmlns:a="http://schemas.openxmlformats.org/drawingml/2006/main">
               <a:ext uri="{FF2B5EF4-FFF2-40B4-BE49-F238E27FC236}">
-                <a16:creationId xmlns:a16="http://schemas.microsoft.com/office/drawing/2014/main" id="{830F0A2E-3C2B-466E-87D9-E318E3EBF09A}"/>
+                <a16:creationId xmlns:a16="http://schemas.microsoft.com/office/drawing/2014/main" id="{3E95765A-B05A-4974-B7BC-E6744D915A66}"/>
               </a:ext>
             </a:extLst>
           </p:cNvPr>
@@ -3873,7 +3873,7 @@
           <p:cNvPr id="35" name="">
             <a:extLst xmlns:a="http://schemas.openxmlformats.org/drawingml/2006/main">
               <a:ext uri="{FF2B5EF4-FFF2-40B4-BE49-F238E27FC236}">
-                <a16:creationId xmlns:a16="http://schemas.microsoft.com/office/drawing/2014/main" id="{A8B6823D-D2A2-4DBA-B24A-48D72EAE558F}"/>
+                <a16:creationId xmlns:a16="http://schemas.microsoft.com/office/drawing/2014/main" id="{C2B29594-AF5F-4C32-B23B-544FFDB9AF70}"/>
               </a:ext>
             </a:extLst>
           </p:cNvPr>
@@ -3931,7 +3931,7 @@
           <p:cNvPr id="36" name="">
             <a:extLst xmlns:a="http://schemas.openxmlformats.org/drawingml/2006/main">
               <a:ext uri="{FF2B5EF4-FFF2-40B4-BE49-F238E27FC236}">
-                <a16:creationId xmlns:a16="http://schemas.microsoft.com/office/drawing/2014/main" id="{A2A7670B-66C9-4854-B91F-37F37CBDAA48}"/>
+                <a16:creationId xmlns:a16="http://schemas.microsoft.com/office/drawing/2014/main" id="{B5D11F0F-F7E4-4582-95C4-909800EAB30E}"/>
               </a:ext>
             </a:extLst>
           </p:cNvPr>
@@ -4012,7 +4012,7 @@
           <p:cNvPr id="37" name="">
             <a:extLst xmlns:a="http://schemas.openxmlformats.org/drawingml/2006/main">
               <a:ext uri="{FF2B5EF4-FFF2-40B4-BE49-F238E27FC236}">
-                <a16:creationId xmlns:a16="http://schemas.microsoft.com/office/drawing/2014/main" id="{8CFD9F0B-2727-4A2D-AE1F-AF467C57ECE1}"/>
+                <a16:creationId xmlns:a16="http://schemas.microsoft.com/office/drawing/2014/main" id="{0AABA3C5-ED4B-4A98-A303-D2B5BA7C25FB}"/>
               </a:ext>
             </a:extLst>
           </p:cNvPr>
@@ -4093,7 +4093,7 @@
           <p:cNvPr id="38" name="">
             <a:extLst xmlns:a="http://schemas.openxmlformats.org/drawingml/2006/main">
               <a:ext uri="{FF2B5EF4-FFF2-40B4-BE49-F238E27FC236}">
-                <a16:creationId xmlns:a16="http://schemas.microsoft.com/office/drawing/2014/main" id="{CA903174-CF05-4CA9-8C28-2A712A8B422B}"/>
+                <a16:creationId xmlns:a16="http://schemas.microsoft.com/office/drawing/2014/main" id="{54169353-5E37-45CB-831A-050407FA536B}"/>
               </a:ext>
             </a:extLst>
           </p:cNvPr>
@@ -4174,7 +4174,7 @@
           <p:cNvPr id="39" name="">
             <a:extLst xmlns:a="http://schemas.openxmlformats.org/drawingml/2006/main">
               <a:ext uri="{FF2B5EF4-FFF2-40B4-BE49-F238E27FC236}">
-                <a16:creationId xmlns:a16="http://schemas.microsoft.com/office/drawing/2014/main" id="{6777EBCC-E4F8-4B0C-B7A2-AC3273D9D925}"/>
+                <a16:creationId xmlns:a16="http://schemas.microsoft.com/office/drawing/2014/main" id="{7333E925-7ABB-4A20-AC85-0C3CD237B4AB}"/>
               </a:ext>
             </a:extLst>
           </p:cNvPr>
@@ -4232,7 +4232,7 @@
           <p:cNvPr id="40" name="">
             <a:extLst xmlns:a="http://schemas.openxmlformats.org/drawingml/2006/main">
               <a:ext uri="{FF2B5EF4-FFF2-40B4-BE49-F238E27FC236}">
-                <a16:creationId xmlns:a16="http://schemas.microsoft.com/office/drawing/2014/main" id="{417A1D1D-BB42-4971-A7BE-D47F91ECCC9E}"/>
+                <a16:creationId xmlns:a16="http://schemas.microsoft.com/office/drawing/2014/main" id="{0F6F0993-130B-4E3E-9AC1-F4FBE8D19B9B}"/>
               </a:ext>
             </a:extLst>
           </p:cNvPr>
@@ -4313,7 +4313,7 @@
           <p:cNvPr id="41" name="">
             <a:extLst xmlns:a="http://schemas.openxmlformats.org/drawingml/2006/main">
               <a:ext uri="{FF2B5EF4-FFF2-40B4-BE49-F238E27FC236}">
-                <a16:creationId xmlns:a16="http://schemas.microsoft.com/office/drawing/2014/main" id="{68DD8AA7-1DC0-470D-8CF5-2A8F256C82E3}"/>
+                <a16:creationId xmlns:a16="http://schemas.microsoft.com/office/drawing/2014/main" id="{828A5806-F6C1-466B-B06F-ABF961E0F6AD}"/>
               </a:ext>
             </a:extLst>
           </p:cNvPr>
@@ -4369,7 +4369,7 @@
     </p:spTree>
     <p:extLst>
       <p:ext uri="{BB962C8B-B14F-4D97-AF65-F5344CB8AC3E}">
-        <p14:creationId xmlns:p14="http://schemas.microsoft.com/office/powerpoint/2010/main" val="1999892124"/>
+        <p14:creationId xmlns:p14="http://schemas.microsoft.com/office/powerpoint/2010/main" val="1890323679"/>
       </p:ext>
     </p:extLst>
   </p:cSld>
@@ -4400,7 +4400,7 @@
           <p:cNvPr id="41" name="">
             <a:extLst xmlns:a="http://schemas.openxmlformats.org/drawingml/2006/main">
               <a:ext uri="{FF2B5EF4-FFF2-40B4-BE49-F238E27FC236}">
-                <a16:creationId xmlns:a16="http://schemas.microsoft.com/office/drawing/2014/main" id="{4969803E-BCDB-4342-8896-1ED86A0FD9DE}"/>
+                <a16:creationId xmlns:a16="http://schemas.microsoft.com/office/drawing/2014/main" id="{CA29AC96-4C46-40C1-A8DF-4261A0C9C749}"/>
               </a:ext>
             </a:extLst>
           </p:cNvPr>
@@ -4458,7 +4458,7 @@
           <p:cNvPr id="2" name="">
             <a:extLst xmlns:a="http://schemas.openxmlformats.org/drawingml/2006/main">
               <a:ext uri="{FF2B5EF4-FFF2-40B4-BE49-F238E27FC236}">
-                <a16:creationId xmlns:a16="http://schemas.microsoft.com/office/drawing/2014/main" id="{AB7766C7-CC5B-4AB3-9A5E-F7A58ACE42E2}"/>
+                <a16:creationId xmlns:a16="http://schemas.microsoft.com/office/drawing/2014/main" id="{A9924616-AD83-41D4-844D-8C734B3DCFFE}"/>
               </a:ext>
             </a:extLst>
           </p:cNvPr>
@@ -4516,7 +4516,7 @@
           <p:cNvPr id="3" name="">
             <a:extLst xmlns:a="http://schemas.openxmlformats.org/drawingml/2006/main">
               <a:ext uri="{FF2B5EF4-FFF2-40B4-BE49-F238E27FC236}">
-                <a16:creationId xmlns:a16="http://schemas.microsoft.com/office/drawing/2014/main" id="{BEA6A8A1-3802-4750-A955-749F57934A9A}"/>
+                <a16:creationId xmlns:a16="http://schemas.microsoft.com/office/drawing/2014/main" id="{54464880-811F-4FD6-9BBD-3287F4253753}"/>
               </a:ext>
             </a:extLst>
           </p:cNvPr>
@@ -4547,7 +4547,7 @@
           <p:cNvPr id="4" name="">
             <a:extLst xmlns:a="http://schemas.openxmlformats.org/drawingml/2006/main">
               <a:ext uri="{FF2B5EF4-FFF2-40B4-BE49-F238E27FC236}">
-                <a16:creationId xmlns:a16="http://schemas.microsoft.com/office/drawing/2014/main" id="{897969FA-6A4B-4206-A901-7A884D7210F6}"/>
+                <a16:creationId xmlns:a16="http://schemas.microsoft.com/office/drawing/2014/main" id="{B607D659-55A1-42FC-8AFB-AF9B76A505AB}"/>
               </a:ext>
             </a:extLst>
           </p:cNvPr>
@@ -4611,7 +4611,7 @@
           <p:cNvPr id="5" name="">
             <a:extLst xmlns:a="http://schemas.openxmlformats.org/drawingml/2006/main">
               <a:ext uri="{FF2B5EF4-FFF2-40B4-BE49-F238E27FC236}">
-                <a16:creationId xmlns:a16="http://schemas.microsoft.com/office/drawing/2014/main" id="{ADBB1218-E6FB-4EB8-AB97-F6FDC5879592}"/>
+                <a16:creationId xmlns:a16="http://schemas.microsoft.com/office/drawing/2014/main" id="{4CD43749-E146-4A67-AF24-BE784D1CDA5B}"/>
               </a:ext>
             </a:extLst>
           </p:cNvPr>
@@ -4701,7 +4701,7 @@
           <p:cNvPr id="7" name="">
             <a:extLst xmlns:a="http://schemas.openxmlformats.org/drawingml/2006/main">
               <a:ext uri="{FF2B5EF4-FFF2-40B4-BE49-F238E27FC236}">
-                <a16:creationId xmlns:a16="http://schemas.microsoft.com/office/drawing/2014/main" id="{EC952118-9B3D-409F-994F-8F091DBA0483}"/>
+                <a16:creationId xmlns:a16="http://schemas.microsoft.com/office/drawing/2014/main" id="{C20AFFE9-BD21-471D-9112-92A1A6359ADE}"/>
               </a:ext>
             </a:extLst>
           </p:cNvPr>
@@ -4734,7 +4734,7 @@
           <p:cNvPr id="8" name="">
             <a:extLst xmlns:a="http://schemas.openxmlformats.org/drawingml/2006/main">
               <a:ext uri="{FF2B5EF4-FFF2-40B4-BE49-F238E27FC236}">
-                <a16:creationId xmlns:a16="http://schemas.microsoft.com/office/drawing/2014/main" id="{3D232C66-7B15-497F-9646-3FB555F371AC}"/>
+                <a16:creationId xmlns:a16="http://schemas.microsoft.com/office/drawing/2014/main" id="{74B8C956-9CCA-4531-AB5B-2852E9722D1B}"/>
               </a:ext>
             </a:extLst>
           </p:cNvPr>
@@ -4793,7 +4793,7 @@
           <p:cNvPr id="10" name="">
             <a:extLst xmlns:a="http://schemas.openxmlformats.org/drawingml/2006/main">
               <a:ext uri="{FF2B5EF4-FFF2-40B4-BE49-F238E27FC236}">
-                <a16:creationId xmlns:a16="http://schemas.microsoft.com/office/drawing/2014/main" id="{AE25949F-D621-4B69-BBF3-622291EAFE45}"/>
+                <a16:creationId xmlns:a16="http://schemas.microsoft.com/office/drawing/2014/main" id="{29D5A2B7-91F6-4EC9-B9AA-7B86EAE0DB70}"/>
               </a:ext>
             </a:extLst>
           </p:cNvPr>
@@ -4855,7 +4855,7 @@
           <p:cNvPr id="11" name="">
             <a:extLst xmlns:a="http://schemas.openxmlformats.org/drawingml/2006/main">
               <a:ext uri="{FF2B5EF4-FFF2-40B4-BE49-F238E27FC236}">
-                <a16:creationId xmlns:a16="http://schemas.microsoft.com/office/drawing/2014/main" id="{05C6B010-8FDB-44D6-9DED-55148DAFE802}"/>
+                <a16:creationId xmlns:a16="http://schemas.microsoft.com/office/drawing/2014/main" id="{D553DBC5-074F-41D9-B8CD-B57D4D565D59}"/>
               </a:ext>
             </a:extLst>
           </p:cNvPr>
@@ -4914,7 +4914,7 @@
           <p:cNvPr id="13" name="">
             <a:extLst xmlns:a="http://schemas.openxmlformats.org/drawingml/2006/main">
               <a:ext uri="{FF2B5EF4-FFF2-40B4-BE49-F238E27FC236}">
-                <a16:creationId xmlns:a16="http://schemas.microsoft.com/office/drawing/2014/main" id="{0B7DA0D5-E44F-49C4-98DD-9413619707BB}"/>
+                <a16:creationId xmlns:a16="http://schemas.microsoft.com/office/drawing/2014/main" id="{80B4056F-883B-44F2-AC78-387031717A4B}"/>
               </a:ext>
             </a:extLst>
           </p:cNvPr>
@@ -4976,7 +4976,7 @@
           <p:cNvPr id="14" name="">
             <a:extLst xmlns:a="http://schemas.openxmlformats.org/drawingml/2006/main">
               <a:ext uri="{FF2B5EF4-FFF2-40B4-BE49-F238E27FC236}">
-                <a16:creationId xmlns:a16="http://schemas.microsoft.com/office/drawing/2014/main" id="{C15E950D-A02D-4678-9468-244DC735640D}"/>
+                <a16:creationId xmlns:a16="http://schemas.microsoft.com/office/drawing/2014/main" id="{2AF2C188-6CFB-4436-BE31-9A70CDAE80F8}"/>
               </a:ext>
             </a:extLst>
           </p:cNvPr>
@@ -5035,7 +5035,7 @@
           <p:cNvPr id="16" name="">
             <a:extLst xmlns:a="http://schemas.openxmlformats.org/drawingml/2006/main">
               <a:ext uri="{FF2B5EF4-FFF2-40B4-BE49-F238E27FC236}">
-                <a16:creationId xmlns:a16="http://schemas.microsoft.com/office/drawing/2014/main" id="{F78790EC-65C1-4991-A494-791C0286E6D5}"/>
+                <a16:creationId xmlns:a16="http://schemas.microsoft.com/office/drawing/2014/main" id="{84B3962D-AEF8-4506-82D3-684CFFD1EBB3}"/>
               </a:ext>
             </a:extLst>
           </p:cNvPr>
@@ -5097,7 +5097,7 @@
           <p:cNvPr id="17" name="">
             <a:extLst xmlns:a="http://schemas.openxmlformats.org/drawingml/2006/main">
               <a:ext uri="{FF2B5EF4-FFF2-40B4-BE49-F238E27FC236}">
-                <a16:creationId xmlns:a16="http://schemas.microsoft.com/office/drawing/2014/main" id="{10E746D3-4D65-4BD7-8DAB-2FCF749D4DBA}"/>
+                <a16:creationId xmlns:a16="http://schemas.microsoft.com/office/drawing/2014/main" id="{74935C08-657F-43DA-A022-B749A26A2125}"/>
               </a:ext>
             </a:extLst>
           </p:cNvPr>
@@ -5187,7 +5187,7 @@
           <p:cNvPr id="19" name="">
             <a:extLst xmlns:a="http://schemas.openxmlformats.org/drawingml/2006/main">
               <a:ext uri="{FF2B5EF4-FFF2-40B4-BE49-F238E27FC236}">
-                <a16:creationId xmlns:a16="http://schemas.microsoft.com/office/drawing/2014/main" id="{DCE940F2-802F-4F70-9879-8CB8ABE779A8}"/>
+                <a16:creationId xmlns:a16="http://schemas.microsoft.com/office/drawing/2014/main" id="{6D0033D1-6ACA-4778-B423-F893A170DA21}"/>
               </a:ext>
             </a:extLst>
           </p:cNvPr>
@@ -5245,7 +5245,7 @@
           <p:cNvPr id="20" name="">
             <a:extLst xmlns:a="http://schemas.openxmlformats.org/drawingml/2006/main">
               <a:ext uri="{FF2B5EF4-FFF2-40B4-BE49-F238E27FC236}">
-                <a16:creationId xmlns:a16="http://schemas.microsoft.com/office/drawing/2014/main" id="{B790B810-ED6A-4051-BEB4-50394748909C}"/>
+                <a16:creationId xmlns:a16="http://schemas.microsoft.com/office/drawing/2014/main" id="{D4E42A81-E078-4C25-8AA4-6F110CA116D1}"/>
               </a:ext>
             </a:extLst>
           </p:cNvPr>
@@ -5309,7 +5309,7 @@
           <p:cNvPr id="21" name="">
             <a:extLst xmlns:a="http://schemas.openxmlformats.org/drawingml/2006/main">
               <a:ext uri="{FF2B5EF4-FFF2-40B4-BE49-F238E27FC236}">
-                <a16:creationId xmlns:a16="http://schemas.microsoft.com/office/drawing/2014/main" id="{EB1FAE34-10DB-40CF-AD9E-7C1AEF93F8D8}"/>
+                <a16:creationId xmlns:a16="http://schemas.microsoft.com/office/drawing/2014/main" id="{87E34118-938B-45B3-9E05-BD66A4EA11E8}"/>
               </a:ext>
             </a:extLst>
           </p:cNvPr>
@@ -5399,7 +5399,7 @@
           <p:cNvPr id="23" name="">
             <a:extLst xmlns:a="http://schemas.openxmlformats.org/drawingml/2006/main">
               <a:ext uri="{FF2B5EF4-FFF2-40B4-BE49-F238E27FC236}">
-                <a16:creationId xmlns:a16="http://schemas.microsoft.com/office/drawing/2014/main" id="{F84CD1CD-6ABB-4192-AB84-1759C0189EA3}"/>
+                <a16:creationId xmlns:a16="http://schemas.microsoft.com/office/drawing/2014/main" id="{C176C460-BB48-41CA-B438-75EB57BB18C5}"/>
               </a:ext>
             </a:extLst>
           </p:cNvPr>
@@ -5432,7 +5432,7 @@
           <p:cNvPr id="24" name="">
             <a:extLst xmlns:a="http://schemas.openxmlformats.org/drawingml/2006/main">
               <a:ext uri="{FF2B5EF4-FFF2-40B4-BE49-F238E27FC236}">
-                <a16:creationId xmlns:a16="http://schemas.microsoft.com/office/drawing/2014/main" id="{2D16225B-1FAB-4887-8CD4-937435A29865}"/>
+                <a16:creationId xmlns:a16="http://schemas.microsoft.com/office/drawing/2014/main" id="{C4F0514B-33C7-4B8B-B5EF-21997E47CB0A}"/>
               </a:ext>
             </a:extLst>
           </p:cNvPr>
@@ -5517,7 +5517,7 @@
           <p:cNvPr id="27" name="">
             <a:extLst xmlns:a="http://schemas.openxmlformats.org/drawingml/2006/main">
               <a:ext uri="{FF2B5EF4-FFF2-40B4-BE49-F238E27FC236}">
-                <a16:creationId xmlns:a16="http://schemas.microsoft.com/office/drawing/2014/main" id="{78717247-979F-43A4-BB23-B86EE4C5266D}"/>
+                <a16:creationId xmlns:a16="http://schemas.microsoft.com/office/drawing/2014/main" id="{947BE7E6-EC4C-4F09-8BA7-02168E5A9540}"/>
               </a:ext>
             </a:extLst>
           </p:cNvPr>
@@ -5579,7 +5579,7 @@
           <p:cNvPr id="28" name="">
             <a:extLst xmlns:a="http://schemas.openxmlformats.org/drawingml/2006/main">
               <a:ext uri="{FF2B5EF4-FFF2-40B4-BE49-F238E27FC236}">
-                <a16:creationId xmlns:a16="http://schemas.microsoft.com/office/drawing/2014/main" id="{4E0A5794-6CAE-4640-9E59-2DF2CB6A0D1C}"/>
+                <a16:creationId xmlns:a16="http://schemas.microsoft.com/office/drawing/2014/main" id="{510C5B0B-7374-49BF-9DF0-9908A77DE2DC}"/>
               </a:ext>
             </a:extLst>
           </p:cNvPr>
@@ -5664,7 +5664,7 @@
           <p:cNvPr id="31" name="">
             <a:extLst xmlns:a="http://schemas.openxmlformats.org/drawingml/2006/main">
               <a:ext uri="{FF2B5EF4-FFF2-40B4-BE49-F238E27FC236}">
-                <a16:creationId xmlns:a16="http://schemas.microsoft.com/office/drawing/2014/main" id="{BF80830E-7899-4047-BBC2-3C6892864656}"/>
+                <a16:creationId xmlns:a16="http://schemas.microsoft.com/office/drawing/2014/main" id="{BECA28F5-7331-4298-9E5A-486B7E16E303}"/>
               </a:ext>
             </a:extLst>
           </p:cNvPr>
@@ -5726,7 +5726,7 @@
           <p:cNvPr id="32" name="">
             <a:extLst xmlns:a="http://schemas.openxmlformats.org/drawingml/2006/main">
               <a:ext uri="{FF2B5EF4-FFF2-40B4-BE49-F238E27FC236}">
-                <a16:creationId xmlns:a16="http://schemas.microsoft.com/office/drawing/2014/main" id="{9C488285-5813-4CA5-8BE0-7A6258E1D1FA}"/>
+                <a16:creationId xmlns:a16="http://schemas.microsoft.com/office/drawing/2014/main" id="{EADEE7F3-559E-40AC-B7AB-0E77633EEBA3}"/>
               </a:ext>
             </a:extLst>
           </p:cNvPr>
@@ -5811,7 +5811,7 @@
           <p:cNvPr id="35" name="">
             <a:extLst xmlns:a="http://schemas.openxmlformats.org/drawingml/2006/main">
               <a:ext uri="{FF2B5EF4-FFF2-40B4-BE49-F238E27FC236}">
-                <a16:creationId xmlns:a16="http://schemas.microsoft.com/office/drawing/2014/main" id="{BC9F155E-256D-4A15-B5E0-AE56F458D624}"/>
+                <a16:creationId xmlns:a16="http://schemas.microsoft.com/office/drawing/2014/main" id="{EA6DC067-1A03-4471-B235-AF48FB2ECB3F}"/>
               </a:ext>
             </a:extLst>
           </p:cNvPr>
@@ -5873,7 +5873,7 @@
           <p:cNvPr id="36" name="">
             <a:extLst xmlns:a="http://schemas.openxmlformats.org/drawingml/2006/main">
               <a:ext uri="{FF2B5EF4-FFF2-40B4-BE49-F238E27FC236}">
-                <a16:creationId xmlns:a16="http://schemas.microsoft.com/office/drawing/2014/main" id="{C0FF637F-8B3A-481B-B810-1B016411E654}"/>
+                <a16:creationId xmlns:a16="http://schemas.microsoft.com/office/drawing/2014/main" id="{E4B5A022-1AAB-4A16-934D-6882D27D081A}"/>
               </a:ext>
             </a:extLst>
           </p:cNvPr>
@@ -5963,7 +5963,7 @@
           <p:cNvPr id="38" name="">
             <a:extLst xmlns:a="http://schemas.openxmlformats.org/drawingml/2006/main">
               <a:ext uri="{FF2B5EF4-FFF2-40B4-BE49-F238E27FC236}">
-                <a16:creationId xmlns:a16="http://schemas.microsoft.com/office/drawing/2014/main" id="{A86597D0-15FC-4D94-B329-4B8A56F8A846}"/>
+                <a16:creationId xmlns:a16="http://schemas.microsoft.com/office/drawing/2014/main" id="{E895E7BE-654E-4FF5-BF30-3A5E49EC54D1}"/>
               </a:ext>
             </a:extLst>
           </p:cNvPr>
@@ -6053,7 +6053,7 @@
           <p:cNvPr id="40" name="">
             <a:extLst xmlns:a="http://schemas.openxmlformats.org/drawingml/2006/main">
               <a:ext uri="{FF2B5EF4-FFF2-40B4-BE49-F238E27FC236}">
-                <a16:creationId xmlns:a16="http://schemas.microsoft.com/office/drawing/2014/main" id="{64C9BC34-6CAD-4E17-8206-EE59D63AED87}"/>
+                <a16:creationId xmlns:a16="http://schemas.microsoft.com/office/drawing/2014/main" id="{6375BC3B-53ED-4547-903D-569CEC4A802F}"/>
               </a:ext>
             </a:extLst>
           </p:cNvPr>
@@ -6109,7 +6109,7 @@
     </p:spTree>
     <p:extLst>
       <p:ext uri="{BB962C8B-B14F-4D97-AF65-F5344CB8AC3E}">
-        <p14:creationId xmlns:p14="http://schemas.microsoft.com/office/powerpoint/2010/main" val="1636257969"/>
+        <p14:creationId xmlns:p14="http://schemas.microsoft.com/office/powerpoint/2010/main" val="787081097"/>
       </p:ext>
     </p:extLst>
   </p:cSld>
@@ -6140,7 +6140,7 @@
           <p:cNvPr id="36" name="">
             <a:extLst xmlns:a="http://schemas.openxmlformats.org/drawingml/2006/main">
               <a:ext uri="{FF2B5EF4-FFF2-40B4-BE49-F238E27FC236}">
-                <a16:creationId xmlns:a16="http://schemas.microsoft.com/office/drawing/2014/main" id="{314E6479-A9BF-4FCE-8916-0BDAE09560F2}"/>
+                <a16:creationId xmlns:a16="http://schemas.microsoft.com/office/drawing/2014/main" id="{2E8373D3-E449-46A0-9866-CB10E24049C3}"/>
               </a:ext>
             </a:extLst>
           </p:cNvPr>
@@ -6198,7 +6198,7 @@
           <p:cNvPr id="2" name="">
             <a:extLst xmlns:a="http://schemas.openxmlformats.org/drawingml/2006/main">
               <a:ext uri="{FF2B5EF4-FFF2-40B4-BE49-F238E27FC236}">
-                <a16:creationId xmlns:a16="http://schemas.microsoft.com/office/drawing/2014/main" id="{F866F7A3-DEAC-4A16-8B6A-A1E57A19EB9E}"/>
+                <a16:creationId xmlns:a16="http://schemas.microsoft.com/office/drawing/2014/main" id="{50A9E707-8771-4B29-8647-F07FA79CE92A}"/>
               </a:ext>
             </a:extLst>
           </p:cNvPr>
@@ -6256,7 +6256,7 @@
           <p:cNvPr id="3" name="">
             <a:extLst xmlns:a="http://schemas.openxmlformats.org/drawingml/2006/main">
               <a:ext uri="{FF2B5EF4-FFF2-40B4-BE49-F238E27FC236}">
-                <a16:creationId xmlns:a16="http://schemas.microsoft.com/office/drawing/2014/main" id="{3128DB78-1E9A-4469-80BF-4955EFC22434}"/>
+                <a16:creationId xmlns:a16="http://schemas.microsoft.com/office/drawing/2014/main" id="{C5F130AB-89ED-4531-AF7E-A0CB6BE157DD}"/>
               </a:ext>
             </a:extLst>
           </p:cNvPr>
@@ -6287,7 +6287,7 @@
           <p:cNvPr id="4" name="">
             <a:extLst xmlns:a="http://schemas.openxmlformats.org/drawingml/2006/main">
               <a:ext uri="{FF2B5EF4-FFF2-40B4-BE49-F238E27FC236}">
-                <a16:creationId xmlns:a16="http://schemas.microsoft.com/office/drawing/2014/main" id="{FDFD678F-3C16-4C6E-AA2A-C814AC58EFC2}"/>
+                <a16:creationId xmlns:a16="http://schemas.microsoft.com/office/drawing/2014/main" id="{E516B5D2-4F77-4819-925D-F2AF775463C3}"/>
               </a:ext>
             </a:extLst>
           </p:cNvPr>
@@ -6320,7 +6320,7 @@
           <p:cNvPr id="5" name="">
             <a:extLst xmlns:a="http://schemas.openxmlformats.org/drawingml/2006/main">
               <a:ext uri="{FF2B5EF4-FFF2-40B4-BE49-F238E27FC236}">
-                <a16:creationId xmlns:a16="http://schemas.microsoft.com/office/drawing/2014/main" id="{9CDF0F11-6636-4246-ADDE-10CD3F384FD0}"/>
+                <a16:creationId xmlns:a16="http://schemas.microsoft.com/office/drawing/2014/main" id="{909E1AC8-3092-4F69-A0B9-32DB2519B05D}"/>
               </a:ext>
             </a:extLst>
           </p:cNvPr>
@@ -6353,7 +6353,7 @@
           <p:cNvPr id="6" name="">
             <a:extLst xmlns:a="http://schemas.openxmlformats.org/drawingml/2006/main">
               <a:ext uri="{FF2B5EF4-FFF2-40B4-BE49-F238E27FC236}">
-                <a16:creationId xmlns:a16="http://schemas.microsoft.com/office/drawing/2014/main" id="{079C0F6A-A1CC-4D69-8886-A6372A9B97F1}"/>
+                <a16:creationId xmlns:a16="http://schemas.microsoft.com/office/drawing/2014/main" id="{03B7FC66-B034-4106-94F7-8975B2374940}"/>
               </a:ext>
             </a:extLst>
           </p:cNvPr>
@@ -6469,7 +6469,7 @@
           <p:cNvPr id="9" name="">
             <a:extLst xmlns:a="http://schemas.openxmlformats.org/drawingml/2006/main">
               <a:ext uri="{FF2B5EF4-FFF2-40B4-BE49-F238E27FC236}">
-                <a16:creationId xmlns:a16="http://schemas.microsoft.com/office/drawing/2014/main" id="{EA540927-DE74-4AB5-A491-638222E3230C}"/>
+                <a16:creationId xmlns:a16="http://schemas.microsoft.com/office/drawing/2014/main" id="{D729B96A-6F71-4475-B876-0D4FA42D833D}"/>
               </a:ext>
             </a:extLst>
           </p:cNvPr>
@@ -6527,7 +6527,7 @@
           <p:cNvPr id="10" name="">
             <a:extLst xmlns:a="http://schemas.openxmlformats.org/drawingml/2006/main">
               <a:ext uri="{FF2B5EF4-FFF2-40B4-BE49-F238E27FC236}">
-                <a16:creationId xmlns:a16="http://schemas.microsoft.com/office/drawing/2014/main" id="{38BD63AD-91C7-4F86-9832-0C4CE0415DE6}"/>
+                <a16:creationId xmlns:a16="http://schemas.microsoft.com/office/drawing/2014/main" id="{ED8A018F-F0C4-49BE-B6B4-75B47BDBBCEC}"/>
               </a:ext>
             </a:extLst>
           </p:cNvPr>
@@ -6560,7 +6560,7 @@
           <p:cNvPr id="11" name="">
             <a:extLst xmlns:a="http://schemas.openxmlformats.org/drawingml/2006/main">
               <a:ext uri="{FF2B5EF4-FFF2-40B4-BE49-F238E27FC236}">
-                <a16:creationId xmlns:a16="http://schemas.microsoft.com/office/drawing/2014/main" id="{6495F97D-765F-4DAC-A804-5B4936020E13}"/>
+                <a16:creationId xmlns:a16="http://schemas.microsoft.com/office/drawing/2014/main" id="{8D4922BA-8121-4FA7-9657-8FD5F366A71D}"/>
               </a:ext>
             </a:extLst>
           </p:cNvPr>
@@ -6676,7 +6676,7 @@
           <p:cNvPr id="14" name="">
             <a:extLst xmlns:a="http://schemas.openxmlformats.org/drawingml/2006/main">
               <a:ext uri="{FF2B5EF4-FFF2-40B4-BE49-F238E27FC236}">
-                <a16:creationId xmlns:a16="http://schemas.microsoft.com/office/drawing/2014/main" id="{E28F6B38-B048-4ADD-ABF3-BC270CB54FA2}"/>
+                <a16:creationId xmlns:a16="http://schemas.microsoft.com/office/drawing/2014/main" id="{1800A91E-D4E8-42BA-A5A9-52C8AD423D18}"/>
               </a:ext>
             </a:extLst>
           </p:cNvPr>
@@ -6734,7 +6734,7 @@
           <p:cNvPr id="15" name="">
             <a:extLst xmlns:a="http://schemas.openxmlformats.org/drawingml/2006/main">
               <a:ext uri="{FF2B5EF4-FFF2-40B4-BE49-F238E27FC236}">
-                <a16:creationId xmlns:a16="http://schemas.microsoft.com/office/drawing/2014/main" id="{D628AD64-14DB-41F8-9537-2619F1622B4F}"/>
+                <a16:creationId xmlns:a16="http://schemas.microsoft.com/office/drawing/2014/main" id="{C15171B8-D3D3-48CE-8D7F-B5AEE7785DB0}"/>
               </a:ext>
             </a:extLst>
           </p:cNvPr>
@@ -6767,7 +6767,7 @@
           <p:cNvPr id="16" name="">
             <a:extLst xmlns:a="http://schemas.openxmlformats.org/drawingml/2006/main">
               <a:ext uri="{FF2B5EF4-FFF2-40B4-BE49-F238E27FC236}">
-                <a16:creationId xmlns:a16="http://schemas.microsoft.com/office/drawing/2014/main" id="{0E4F344F-E029-48FC-83BD-F27050D227A0}"/>
+                <a16:creationId xmlns:a16="http://schemas.microsoft.com/office/drawing/2014/main" id="{B70B73BA-B560-4888-B736-8231D772C655}"/>
               </a:ext>
             </a:extLst>
           </p:cNvPr>
@@ -6883,7 +6883,7 @@
           <p:cNvPr id="19" name="">
             <a:extLst xmlns:a="http://schemas.openxmlformats.org/drawingml/2006/main">
               <a:ext uri="{FF2B5EF4-FFF2-40B4-BE49-F238E27FC236}">
-                <a16:creationId xmlns:a16="http://schemas.microsoft.com/office/drawing/2014/main" id="{7DBE9FF5-0CB9-4E89-9D59-4EFC565E79A7}"/>
+                <a16:creationId xmlns:a16="http://schemas.microsoft.com/office/drawing/2014/main" id="{29864516-F7AD-4414-86FE-8854DDB020B9}"/>
               </a:ext>
             </a:extLst>
           </p:cNvPr>
@@ -6941,7 +6941,7 @@
           <p:cNvPr id="20" name="">
             <a:extLst xmlns:a="http://schemas.openxmlformats.org/drawingml/2006/main">
               <a:ext uri="{FF2B5EF4-FFF2-40B4-BE49-F238E27FC236}">
-                <a16:creationId xmlns:a16="http://schemas.microsoft.com/office/drawing/2014/main" id="{8B410CF0-3778-48B6-AAB6-815BB160DEEE}"/>
+                <a16:creationId xmlns:a16="http://schemas.microsoft.com/office/drawing/2014/main" id="{D4D1D1B9-28E9-4F33-B9C6-224B9F46112E}"/>
               </a:ext>
             </a:extLst>
           </p:cNvPr>
@@ -6974,7 +6974,7 @@
           <p:cNvPr id="21" name="">
             <a:extLst xmlns:a="http://schemas.openxmlformats.org/drawingml/2006/main">
               <a:ext uri="{FF2B5EF4-FFF2-40B4-BE49-F238E27FC236}">
-                <a16:creationId xmlns:a16="http://schemas.microsoft.com/office/drawing/2014/main" id="{EFB59853-9028-4693-A669-C7E182F3AB4B}"/>
+                <a16:creationId xmlns:a16="http://schemas.microsoft.com/office/drawing/2014/main" id="{31D2261F-293C-4046-925D-AE19EBD74B3F}"/>
               </a:ext>
             </a:extLst>
           </p:cNvPr>
@@ -7033,7 +7033,7 @@
           <p:cNvPr id="23" name="">
             <a:extLst xmlns:a="http://schemas.openxmlformats.org/drawingml/2006/main">
               <a:ext uri="{FF2B5EF4-FFF2-40B4-BE49-F238E27FC236}">
-                <a16:creationId xmlns:a16="http://schemas.microsoft.com/office/drawing/2014/main" id="{BD0E8BD6-B961-40DB-BD7D-445ECE40EC7D}"/>
+                <a16:creationId xmlns:a16="http://schemas.microsoft.com/office/drawing/2014/main" id="{196FEAC4-5D6E-4ED0-9FEA-7BDB9695F22D}"/>
               </a:ext>
             </a:extLst>
           </p:cNvPr>
@@ -7091,7 +7091,7 @@
           <p:cNvPr id="24" name="">
             <a:extLst xmlns:a="http://schemas.openxmlformats.org/drawingml/2006/main">
               <a:ext uri="{FF2B5EF4-FFF2-40B4-BE49-F238E27FC236}">
-                <a16:creationId xmlns:a16="http://schemas.microsoft.com/office/drawing/2014/main" id="{18D5E304-622D-4955-B94F-7D152F6F7574}"/>
+                <a16:creationId xmlns:a16="http://schemas.microsoft.com/office/drawing/2014/main" id="{2C80C723-C97D-42F9-8135-26067343B7C1}"/>
               </a:ext>
             </a:extLst>
           </p:cNvPr>
@@ -7149,7 +7149,7 @@
           <p:cNvPr id="25" name="">
             <a:extLst xmlns:a="http://schemas.openxmlformats.org/drawingml/2006/main">
               <a:ext uri="{FF2B5EF4-FFF2-40B4-BE49-F238E27FC236}">
-                <a16:creationId xmlns:a16="http://schemas.microsoft.com/office/drawing/2014/main" id="{2BA81688-8D19-405C-BA74-174C275B88D9}"/>
+                <a16:creationId xmlns:a16="http://schemas.microsoft.com/office/drawing/2014/main" id="{CCE679ED-444B-4A8F-9A5A-D33EF83BD7F3}"/>
               </a:ext>
             </a:extLst>
           </p:cNvPr>
@@ -7208,7 +7208,7 @@
           <p:cNvPr id="27" name="">
             <a:extLst xmlns:a="http://schemas.openxmlformats.org/drawingml/2006/main">
               <a:ext uri="{FF2B5EF4-FFF2-40B4-BE49-F238E27FC236}">
-                <a16:creationId xmlns:a16="http://schemas.microsoft.com/office/drawing/2014/main" id="{E5CA31C9-E84E-46D2-BE59-ED16BB338D69}"/>
+                <a16:creationId xmlns:a16="http://schemas.microsoft.com/office/drawing/2014/main" id="{223A9329-E88D-46E6-A2AF-4066F2862FC6}"/>
               </a:ext>
             </a:extLst>
           </p:cNvPr>
@@ -7266,7 +7266,7 @@
           <p:cNvPr id="28" name="">
             <a:extLst xmlns:a="http://schemas.openxmlformats.org/drawingml/2006/main">
               <a:ext uri="{FF2B5EF4-FFF2-40B4-BE49-F238E27FC236}">
-                <a16:creationId xmlns:a16="http://schemas.microsoft.com/office/drawing/2014/main" id="{70130EF7-6D6B-4E19-92BA-91AF4CF2F019}"/>
+                <a16:creationId xmlns:a16="http://schemas.microsoft.com/office/drawing/2014/main" id="{C299A432-F5BD-4C60-A5CD-16F109A1BBB7}"/>
               </a:ext>
             </a:extLst>
           </p:cNvPr>
@@ -7324,7 +7324,7 @@
           <p:cNvPr id="29" name="">
             <a:extLst xmlns:a="http://schemas.openxmlformats.org/drawingml/2006/main">
               <a:ext uri="{FF2B5EF4-FFF2-40B4-BE49-F238E27FC236}">
-                <a16:creationId xmlns:a16="http://schemas.microsoft.com/office/drawing/2014/main" id="{C229348D-4B3A-407A-9061-991441430CCC}"/>
+                <a16:creationId xmlns:a16="http://schemas.microsoft.com/office/drawing/2014/main" id="{7CAEC61D-A984-41D4-AA14-FB6B12995344}"/>
               </a:ext>
             </a:extLst>
           </p:cNvPr>
@@ -7383,7 +7383,7 @@
           <p:cNvPr id="31" name="">
             <a:extLst xmlns:a="http://schemas.openxmlformats.org/drawingml/2006/main">
               <a:ext uri="{FF2B5EF4-FFF2-40B4-BE49-F238E27FC236}">
-                <a16:creationId xmlns:a16="http://schemas.microsoft.com/office/drawing/2014/main" id="{BAE4D23E-FD7B-46A2-AAB6-93ECD904E15C}"/>
+                <a16:creationId xmlns:a16="http://schemas.microsoft.com/office/drawing/2014/main" id="{3522710C-9A33-4F34-9847-1C544BE17D89}"/>
               </a:ext>
             </a:extLst>
           </p:cNvPr>
@@ -7441,7 +7441,7 @@
           <p:cNvPr id="32" name="">
             <a:extLst xmlns:a="http://schemas.openxmlformats.org/drawingml/2006/main">
               <a:ext uri="{FF2B5EF4-FFF2-40B4-BE49-F238E27FC236}">
-                <a16:creationId xmlns:a16="http://schemas.microsoft.com/office/drawing/2014/main" id="{ABA6A955-DB83-456D-85F7-FDB2D4CDB542}"/>
+                <a16:creationId xmlns:a16="http://schemas.microsoft.com/office/drawing/2014/main" id="{90EEB22B-FA52-4FC2-84A5-D14695432BEA}"/>
               </a:ext>
             </a:extLst>
           </p:cNvPr>
@@ -7499,7 +7499,7 @@
           <p:cNvPr id="33" name="">
             <a:extLst xmlns:a="http://schemas.openxmlformats.org/drawingml/2006/main">
               <a:ext uri="{FF2B5EF4-FFF2-40B4-BE49-F238E27FC236}">
-                <a16:creationId xmlns:a16="http://schemas.microsoft.com/office/drawing/2014/main" id="{A8292079-8427-4047-A3FF-E2F22544F33C}"/>
+                <a16:creationId xmlns:a16="http://schemas.microsoft.com/office/drawing/2014/main" id="{5650606E-370A-43FF-BE36-7B849BB7BF53}"/>
               </a:ext>
             </a:extLst>
           </p:cNvPr>
@@ -7563,7 +7563,7 @@
           <p:cNvPr id="34" name="">
             <a:extLst xmlns:a="http://schemas.openxmlformats.org/drawingml/2006/main">
               <a:ext uri="{FF2B5EF4-FFF2-40B4-BE49-F238E27FC236}">
-                <a16:creationId xmlns:a16="http://schemas.microsoft.com/office/drawing/2014/main" id="{6B9C8AD4-8823-4322-B78D-CE57C2804337}"/>
+                <a16:creationId xmlns:a16="http://schemas.microsoft.com/office/drawing/2014/main" id="{5EAB9987-DF1D-45C6-968A-065F7A1475E2}"/>
               </a:ext>
             </a:extLst>
           </p:cNvPr>
@@ -7621,7 +7621,7 @@
           <p:cNvPr id="35" name="">
             <a:extLst xmlns:a="http://schemas.openxmlformats.org/drawingml/2006/main">
               <a:ext uri="{FF2B5EF4-FFF2-40B4-BE49-F238E27FC236}">
-                <a16:creationId xmlns:a16="http://schemas.microsoft.com/office/drawing/2014/main" id="{9304B3A1-64DC-4F5C-B3F8-31F2823B3671}"/>
+                <a16:creationId xmlns:a16="http://schemas.microsoft.com/office/drawing/2014/main" id="{02CB7A75-1DE6-4470-BBD5-4BE887222EB0}"/>
               </a:ext>
             </a:extLst>
           </p:cNvPr>
@@ -7677,7 +7677,7 @@
     </p:spTree>
     <p:extLst>
       <p:ext uri="{BB962C8B-B14F-4D97-AF65-F5344CB8AC3E}">
-        <p14:creationId xmlns:p14="http://schemas.microsoft.com/office/powerpoint/2010/main" val="137325373"/>
+        <p14:creationId xmlns:p14="http://schemas.microsoft.com/office/powerpoint/2010/main" val="463479179"/>
       </p:ext>
     </p:extLst>
   </p:cSld>
@@ -7708,7 +7708,7 @@
           <p:cNvPr id="20" name="">
             <a:extLst xmlns:a="http://schemas.openxmlformats.org/drawingml/2006/main">
               <a:ext uri="{FF2B5EF4-FFF2-40B4-BE49-F238E27FC236}">
-                <a16:creationId xmlns:a16="http://schemas.microsoft.com/office/drawing/2014/main" id="{D30D39DB-87DD-472E-B714-400DE0BB88ED}"/>
+                <a16:creationId xmlns:a16="http://schemas.microsoft.com/office/drawing/2014/main" id="{F4D10922-71E7-4DE4-84D4-20919FCD9C70}"/>
               </a:ext>
             </a:extLst>
           </p:cNvPr>
@@ -7772,7 +7772,7 @@
           <p:cNvPr id="2" name="">
             <a:extLst xmlns:a="http://schemas.openxmlformats.org/drawingml/2006/main">
               <a:ext uri="{FF2B5EF4-FFF2-40B4-BE49-F238E27FC236}">
-                <a16:creationId xmlns:a16="http://schemas.microsoft.com/office/drawing/2014/main" id="{D9C5774E-A56E-428B-A64B-434DF2A49B66}"/>
+                <a16:creationId xmlns:a16="http://schemas.microsoft.com/office/drawing/2014/main" id="{748716F2-711D-4BC2-8832-49EC530B59CA}"/>
               </a:ext>
             </a:extLst>
           </p:cNvPr>
@@ -7859,7 +7859,7 @@
           <p:cNvPr id="3" name="">
             <a:extLst xmlns:a="http://schemas.openxmlformats.org/drawingml/2006/main">
               <a:ext uri="{FF2B5EF4-FFF2-40B4-BE49-F238E27FC236}">
-                <a16:creationId xmlns:a16="http://schemas.microsoft.com/office/drawing/2014/main" id="{24FD6502-67F0-40CC-874D-245DE2515CD7}"/>
+                <a16:creationId xmlns:a16="http://schemas.microsoft.com/office/drawing/2014/main" id="{FADC536D-67D4-4122-9EEB-56B3B7BBDABD}"/>
               </a:ext>
             </a:extLst>
           </p:cNvPr>
@@ -7946,7 +7946,7 @@
           <p:cNvPr id="4" name="">
             <a:extLst xmlns:a="http://schemas.openxmlformats.org/drawingml/2006/main">
               <a:ext uri="{FF2B5EF4-FFF2-40B4-BE49-F238E27FC236}">
-                <a16:creationId xmlns:a16="http://schemas.microsoft.com/office/drawing/2014/main" id="{3DF18809-F5E5-4691-BECA-E7F1F0B2594E}"/>
+                <a16:creationId xmlns:a16="http://schemas.microsoft.com/office/drawing/2014/main" id="{CD75036E-DEDC-40DD-9B30-7170AF08A81B}"/>
               </a:ext>
             </a:extLst>
           </p:cNvPr>
@@ -8033,18 +8033,18 @@
           <p:cNvPr id="5" name="">
             <a:extLst xmlns:a="http://schemas.openxmlformats.org/drawingml/2006/main">
               <a:ext uri="{FF2B5EF4-FFF2-40B4-BE49-F238E27FC236}">
-                <a16:creationId xmlns:a16="http://schemas.microsoft.com/office/drawing/2014/main" id="{90D3B099-D6E7-4377-99C5-2CBDEC84B4F6}"/>
-              </a:ext>
-            </a:extLst>
-          </p:cNvPr>
-          <p:cNvSpPr>
-            <a:spLocks xmlns:a="http://schemas.openxmlformats.org/drawingml/2006/main" noGrp="1"/>
-          </p:cNvSpPr>
-          <p:nvPr/>
-        </p:nvSpPr>
-        <p:spPr>
-          <a:xfrm xmlns:a="http://schemas.openxmlformats.org/drawingml/2006/main">
-            <a:off x="9429750" y="1143000"/>
+                <a16:creationId xmlns:a16="http://schemas.microsoft.com/office/drawing/2014/main" id="{E8966D6D-B6F7-4361-9F9D-075ABAA84679}"/>
+              </a:ext>
+            </a:extLst>
+          </p:cNvPr>
+          <p:cNvSpPr>
+            <a:spLocks xmlns:a="http://schemas.openxmlformats.org/drawingml/2006/main" noGrp="1"/>
+          </p:cNvSpPr>
+          <p:nvPr/>
+        </p:nvSpPr>
+        <p:spPr>
+          <a:xfrm xmlns:a="http://schemas.openxmlformats.org/drawingml/2006/main">
+            <a:off x="9429750" y="952500"/>
             <a:ext cx="2095500" cy="1000125"/>
           </a:xfrm>
           <a:prstGeom xmlns:a="http://schemas.openxmlformats.org/drawingml/2006/main" prst="roundRect">
@@ -8148,19 +8148,20 @@
           <p:cNvPr id="26" name=""/>
           <p:cNvCxnSpPr>
             <a:stCxn xmlns:a="http://schemas.openxmlformats.org/drawingml/2006/main" id="2" idx="2"/>
-            <a:endCxn xmlns:a="http://schemas.openxmlformats.org/drawingml/2006/main" id="3" idx="0"/>
+            <a:endCxn xmlns:a="http://schemas.openxmlformats.org/drawingml/2006/main" id="3" idx="1"/>
           </p:cNvCxnSpPr>
           <p:nvPr/>
         </p:nvCxnSpPr>
         <p:spPr>
           <a:xfrm xmlns:a="http://schemas.openxmlformats.org/drawingml/2006/main">
             <a:off x="4095750" y="1952625"/>
-            <a:ext cx="2047875" cy="762000"/>
-          </a:xfrm>
-          <a:prstGeom xmlns:a="http://schemas.openxmlformats.org/drawingml/2006/main" prst="bentConnector4">
+            <a:ext cx="1000125" cy="1262063"/>
+          </a:xfrm>
+          <a:prstGeom xmlns:a="http://schemas.openxmlformats.org/drawingml/2006/main" prst="bentConnector5">
             <a:avLst>
               <a:gd name="adj1" fmla="val 0"/>
-              <a:gd name="adj2" fmla="val 50000"/>
+              <a:gd name="adj2" fmla="val 18113"/>
+              <a:gd name="adj3" fmla="val 77143"/>
             </a:avLst>
           </a:prstGeom>
           <a:ln xmlns:a="http://schemas.openxmlformats.org/drawingml/2006/main" w="28575">
@@ -8176,19 +8177,21 @@
         <p:nvCxnSpPr>
           <p:cNvPr id="27" name=""/>
           <p:cNvCxnSpPr>
-            <a:stCxn xmlns:a="http://schemas.openxmlformats.org/drawingml/2006/main" id="3" idx="3"/>
+            <a:stCxn xmlns:a="http://schemas.openxmlformats.org/drawingml/2006/main" id="3" idx="2"/>
             <a:endCxn xmlns:a="http://schemas.openxmlformats.org/drawingml/2006/main" id="4" idx="1"/>
           </p:cNvCxnSpPr>
           <p:nvPr/>
         </p:nvCxnSpPr>
         <p:spPr>
           <a:xfrm xmlns:a="http://schemas.openxmlformats.org/drawingml/2006/main">
-            <a:off x="7191375" y="3214688"/>
-            <a:ext cx="619125" cy="1690688"/>
-          </a:xfrm>
-          <a:prstGeom xmlns:a="http://schemas.openxmlformats.org/drawingml/2006/main" prst="bentConnector3">
+            <a:off x="6143625" y="3714750"/>
+            <a:ext cx="1666875" cy="1190625"/>
+          </a:xfrm>
+          <a:prstGeom xmlns:a="http://schemas.openxmlformats.org/drawingml/2006/main" prst="bentConnector5">
             <a:avLst>
-              <a:gd name="adj1" fmla="val 50000"/>
+              <a:gd name="adj1" fmla="val 0"/>
+              <a:gd name="adj2" fmla="val 19200"/>
+              <a:gd name="adj3" fmla="val 86286"/>
             </a:avLst>
           </a:prstGeom>
           <a:ln xmlns:a="http://schemas.openxmlformats.org/drawingml/2006/main" w="28575">
@@ -8204,21 +8207,18 @@
         <p:nvCxnSpPr>
           <p:cNvPr id="28" name=""/>
           <p:cNvCxnSpPr>
-            <a:stCxn xmlns:a="http://schemas.openxmlformats.org/drawingml/2006/main" id="4" idx="0"/>
+            <a:stCxn xmlns:a="http://schemas.openxmlformats.org/drawingml/2006/main" id="4" idx="3"/>
             <a:endCxn xmlns:a="http://schemas.openxmlformats.org/drawingml/2006/main" id="5" idx="2"/>
           </p:cNvCxnSpPr>
           <p:nvPr/>
         </p:nvCxnSpPr>
         <p:spPr>
           <a:xfrm xmlns:a="http://schemas.openxmlformats.org/drawingml/2006/main" flipV="1">
-            <a:off x="8810625" y="2143125"/>
-            <a:ext cx="1666875" cy="2286000"/>
-          </a:xfrm>
-          <a:prstGeom xmlns:a="http://schemas.openxmlformats.org/drawingml/2006/main" prst="bentConnector4">
-            <a:avLst>
-              <a:gd name="adj1" fmla="val 0"/>
-              <a:gd name="adj2" fmla="val 50000"/>
-            </a:avLst>
+            <a:off x="9810750" y="1952625"/>
+            <a:ext cx="666750" cy="2952750"/>
+          </a:xfrm>
+          <a:prstGeom xmlns:a="http://schemas.openxmlformats.org/drawingml/2006/main" prst="bentConnector2">
+            <a:avLst/>
           </a:prstGeom>
           <a:ln xmlns:a="http://schemas.openxmlformats.org/drawingml/2006/main" w="28575">
             <a:solidFill>
@@ -8239,14 +8239,12 @@
           <p:nvPr/>
         </p:nvCxnSpPr>
         <p:spPr>
-          <a:xfrm xmlns:a="http://schemas.openxmlformats.org/drawingml/2006/main" flipH="1" flipV="1">
+          <a:xfrm xmlns:a="http://schemas.openxmlformats.org/drawingml/2006/main" flipH="1">
             <a:off x="5143500" y="1452563"/>
-            <a:ext cx="4286250" cy="190500"/>
-          </a:xfrm>
-          <a:prstGeom xmlns:a="http://schemas.openxmlformats.org/drawingml/2006/main" prst="bentConnector3">
-            <a:avLst>
-              <a:gd name="adj1" fmla="val 50000"/>
-            </a:avLst>
+            <a:ext cx="4286250" cy="0"/>
+          </a:xfrm>
+          <a:prstGeom xmlns:a="http://schemas.openxmlformats.org/drawingml/2006/main" prst="straightConnector1">
+            <a:avLst/>
           </a:prstGeom>
           <a:ln xmlns:a="http://schemas.openxmlformats.org/drawingml/2006/main" w="28575">
             <a:solidFill>
@@ -8262,18 +8260,18 @@
           <p:cNvPr id="11" name="">
             <a:extLst xmlns:a="http://schemas.openxmlformats.org/drawingml/2006/main">
               <a:ext uri="{FF2B5EF4-FFF2-40B4-BE49-F238E27FC236}">
-                <a16:creationId xmlns:a16="http://schemas.microsoft.com/office/drawing/2014/main" id="{55C88E1C-0812-49B9-824E-52CA085324D7}"/>
-              </a:ext>
-            </a:extLst>
-          </p:cNvPr>
-          <p:cNvSpPr>
-            <a:spLocks xmlns:a="http://schemas.openxmlformats.org/drawingml/2006/main" noGrp="1"/>
-          </p:cNvSpPr>
-          <p:nvPr/>
-        </p:nvSpPr>
-        <p:spPr>
-          <a:xfrm xmlns:a="http://schemas.openxmlformats.org/drawingml/2006/main">
-            <a:off x="5429250" y="4762500"/>
+                <a16:creationId xmlns:a16="http://schemas.microsoft.com/office/drawing/2014/main" id="{79C1CE8B-13A6-41E0-98DF-E6328624AB24}"/>
+              </a:ext>
+            </a:extLst>
+          </p:cNvPr>
+          <p:cNvSpPr>
+            <a:spLocks xmlns:a="http://schemas.openxmlformats.org/drawingml/2006/main" noGrp="1"/>
+          </p:cNvSpPr>
+          <p:nvPr/>
+        </p:nvSpPr>
+        <p:spPr>
+          <a:xfrm xmlns:a="http://schemas.openxmlformats.org/drawingml/2006/main">
+            <a:off x="4619625" y="4953000"/>
             <a:ext cx="285750" cy="285750"/>
           </a:xfrm>
           <a:prstGeom xmlns:a="http://schemas.openxmlformats.org/drawingml/2006/main" prst="ellipse">
@@ -8295,18 +8293,18 @@
           <p:cNvPr id="12" name="">
             <a:extLst xmlns:a="http://schemas.openxmlformats.org/drawingml/2006/main">
               <a:ext uri="{FF2B5EF4-FFF2-40B4-BE49-F238E27FC236}">
-                <a16:creationId xmlns:a16="http://schemas.microsoft.com/office/drawing/2014/main" id="{84A9EEA7-97B1-4868-9A77-0BE088D029A3}"/>
-              </a:ext>
-            </a:extLst>
-          </p:cNvPr>
-          <p:cNvSpPr>
-            <a:spLocks xmlns:a="http://schemas.openxmlformats.org/drawingml/2006/main" noGrp="1"/>
-          </p:cNvSpPr>
-          <p:nvPr/>
-        </p:nvSpPr>
-        <p:spPr>
-          <a:xfrm xmlns:a="http://schemas.openxmlformats.org/drawingml/2006/main">
-            <a:off x="6210300" y="5067300"/>
+                <a16:creationId xmlns:a16="http://schemas.microsoft.com/office/drawing/2014/main" id="{8D183C50-9788-4F34-9861-EB2FD99DF2EA}"/>
+              </a:ext>
+            </a:extLst>
+          </p:cNvPr>
+          <p:cNvSpPr>
+            <a:spLocks xmlns:a="http://schemas.openxmlformats.org/drawingml/2006/main" noGrp="1"/>
+          </p:cNvSpPr>
+          <p:nvPr/>
+        </p:nvSpPr>
+        <p:spPr>
+          <a:xfrm xmlns:a="http://schemas.openxmlformats.org/drawingml/2006/main">
+            <a:off x="5400675" y="5257800"/>
             <a:ext cx="247650" cy="247650"/>
           </a:xfrm>
           <a:prstGeom xmlns:a="http://schemas.openxmlformats.org/drawingml/2006/main" prst="ellipse">
@@ -8328,18 +8326,18 @@
           <p:cNvPr id="13" name="">
             <a:extLst xmlns:a="http://schemas.openxmlformats.org/drawingml/2006/main">
               <a:ext uri="{FF2B5EF4-FFF2-40B4-BE49-F238E27FC236}">
-                <a16:creationId xmlns:a16="http://schemas.microsoft.com/office/drawing/2014/main" id="{8BD4D756-0DAF-451F-8C94-9262E6C6B471}"/>
-              </a:ext>
-            </a:extLst>
-          </p:cNvPr>
-          <p:cNvSpPr>
-            <a:spLocks xmlns:a="http://schemas.openxmlformats.org/drawingml/2006/main" noGrp="1"/>
-          </p:cNvSpPr>
-          <p:nvPr/>
-        </p:nvSpPr>
-        <p:spPr>
-          <a:xfrm xmlns:a="http://schemas.openxmlformats.org/drawingml/2006/main">
-            <a:off x="6953250" y="4619625"/>
+                <a16:creationId xmlns:a16="http://schemas.microsoft.com/office/drawing/2014/main" id="{250ADCDC-E9A2-4C77-9B49-B7A644AA8F73}"/>
+              </a:ext>
+            </a:extLst>
+          </p:cNvPr>
+          <p:cNvSpPr>
+            <a:spLocks xmlns:a="http://schemas.openxmlformats.org/drawingml/2006/main" noGrp="1"/>
+          </p:cNvSpPr>
+          <p:nvPr/>
+        </p:nvSpPr>
+        <p:spPr>
+          <a:xfrm xmlns:a="http://schemas.openxmlformats.org/drawingml/2006/main">
+            <a:off x="6143625" y="4810125"/>
             <a:ext cx="285750" cy="285750"/>
           </a:xfrm>
           <a:prstGeom xmlns:a="http://schemas.openxmlformats.org/drawingml/2006/main" prst="ellipse">
@@ -8361,18 +8359,18 @@
           <p:cNvPr id="14" name="">
             <a:extLst xmlns:a="http://schemas.openxmlformats.org/drawingml/2006/main">
               <a:ext uri="{FF2B5EF4-FFF2-40B4-BE49-F238E27FC236}">
-                <a16:creationId xmlns:a16="http://schemas.microsoft.com/office/drawing/2014/main" id="{16CB396A-B7D6-4169-964B-04267D998A3E}"/>
-              </a:ext>
-            </a:extLst>
-          </p:cNvPr>
-          <p:cNvSpPr>
-            <a:spLocks xmlns:a="http://schemas.openxmlformats.org/drawingml/2006/main" noGrp="1"/>
-          </p:cNvSpPr>
-          <p:nvPr/>
-        </p:nvSpPr>
-        <p:spPr>
-          <a:xfrm xmlns:a="http://schemas.openxmlformats.org/drawingml/2006/main">
-            <a:off x="6867525" y="4533900"/>
+                <a16:creationId xmlns:a16="http://schemas.microsoft.com/office/drawing/2014/main" id="{D503007E-5FC7-40F8-986F-0C3DA505785E}"/>
+              </a:ext>
+            </a:extLst>
+          </p:cNvPr>
+          <p:cNvSpPr>
+            <a:spLocks xmlns:a="http://schemas.openxmlformats.org/drawingml/2006/main" noGrp="1"/>
+          </p:cNvSpPr>
+          <p:nvPr/>
+        </p:nvSpPr>
+        <p:spPr>
+          <a:xfrm xmlns:a="http://schemas.openxmlformats.org/drawingml/2006/main">
+            <a:off x="6057900" y="4724400"/>
             <a:ext cx="457200" cy="457200"/>
           </a:xfrm>
           <a:prstGeom xmlns:a="http://schemas.openxmlformats.org/drawingml/2006/main" prst="ellipse">
@@ -8398,7 +8396,7 @@
         </p:nvCxnSpPr>
         <p:spPr>
           <a:xfrm xmlns:a="http://schemas.openxmlformats.org/drawingml/2006/main">
-            <a:off x="5715000" y="4905375"/>
+            <a:off x="4905375" y="5095875"/>
             <a:ext cx="531568" cy="198193"/>
           </a:xfrm>
           <a:prstGeom xmlns:a="http://schemas.openxmlformats.org/drawingml/2006/main" prst="straightConnector1">
@@ -8424,7 +8422,7 @@
         </p:nvCxnSpPr>
         <p:spPr>
           <a:xfrm xmlns:a="http://schemas.openxmlformats.org/drawingml/2006/main" flipV="1">
-            <a:off x="6421682" y="4863528"/>
+            <a:off x="5612057" y="5054028"/>
             <a:ext cx="573415" cy="240040"/>
           </a:xfrm>
           <a:prstGeom xmlns:a="http://schemas.openxmlformats.org/drawingml/2006/main" prst="straightConnector1">
@@ -8444,18 +8442,18 @@
           <p:cNvPr id="17" name="">
             <a:extLst xmlns:a="http://schemas.openxmlformats.org/drawingml/2006/main">
               <a:ext uri="{FF2B5EF4-FFF2-40B4-BE49-F238E27FC236}">
-                <a16:creationId xmlns:a16="http://schemas.microsoft.com/office/drawing/2014/main" id="{003FF246-B2DB-4607-BA0B-3F2749827064}"/>
-              </a:ext>
-            </a:extLst>
-          </p:cNvPr>
-          <p:cNvSpPr>
-            <a:spLocks xmlns:a="http://schemas.openxmlformats.org/drawingml/2006/main" noGrp="1"/>
-          </p:cNvSpPr>
-          <p:nvPr/>
-        </p:nvSpPr>
-        <p:spPr>
-          <a:xfrm xmlns:a="http://schemas.openxmlformats.org/drawingml/2006/main">
-            <a:off x="5429250" y="4048125"/>
+                <a16:creationId xmlns:a16="http://schemas.microsoft.com/office/drawing/2014/main" id="{55F8E0C2-BE2E-41ED-998B-D891DC767640}"/>
+              </a:ext>
+            </a:extLst>
+          </p:cNvPr>
+          <p:cNvSpPr>
+            <a:spLocks xmlns:a="http://schemas.openxmlformats.org/drawingml/2006/main" noGrp="1"/>
+          </p:cNvSpPr>
+          <p:nvPr/>
+        </p:nvSpPr>
+        <p:spPr>
+          <a:xfrm xmlns:a="http://schemas.openxmlformats.org/drawingml/2006/main">
+            <a:off x="4762500" y="4333875"/>
             <a:ext cx="1524000" cy="304800"/>
           </a:xfrm>
           <a:prstGeom xmlns:a="http://schemas.openxmlformats.org/drawingml/2006/main" prst="rect">
@@ -8502,19 +8500,19 @@
           <p:cNvPr id="18" name="">
             <a:extLst xmlns:a="http://schemas.openxmlformats.org/drawingml/2006/main">
               <a:ext uri="{FF2B5EF4-FFF2-40B4-BE49-F238E27FC236}">
-                <a16:creationId xmlns:a16="http://schemas.microsoft.com/office/drawing/2014/main" id="{7BA11C37-B554-4FC0-A102-8D85C0C11804}"/>
-              </a:ext>
-            </a:extLst>
-          </p:cNvPr>
-          <p:cNvSpPr>
-            <a:spLocks xmlns:a="http://schemas.openxmlformats.org/drawingml/2006/main" noGrp="1"/>
-          </p:cNvSpPr>
-          <p:nvPr/>
-        </p:nvSpPr>
-        <p:spPr>
-          <a:xfrm xmlns:a="http://schemas.openxmlformats.org/drawingml/2006/main">
-            <a:off x="5238750" y="495300"/>
-            <a:ext cx="1762125" cy="323850"/>
+                <a16:creationId xmlns:a16="http://schemas.microsoft.com/office/drawing/2014/main" id="{A8DCDB6C-0EF5-43D5-AB2D-1F043B239DA3}"/>
+              </a:ext>
+            </a:extLst>
+          </p:cNvPr>
+          <p:cNvSpPr>
+            <a:spLocks xmlns:a="http://schemas.openxmlformats.org/drawingml/2006/main" noGrp="1"/>
+          </p:cNvSpPr>
+          <p:nvPr/>
+        </p:nvSpPr>
+        <p:spPr>
+          <a:xfrm xmlns:a="http://schemas.openxmlformats.org/drawingml/2006/main">
+            <a:off x="6381750" y="1000125"/>
+            <a:ext cx="1809750" cy="323850"/>
           </a:xfrm>
           <a:prstGeom xmlns:a="http://schemas.openxmlformats.org/drawingml/2006/main" prst="rect">
             <a:avLst/>
@@ -8560,7 +8558,7 @@
           <p:cNvPr id="19" name="">
             <a:extLst xmlns:a="http://schemas.openxmlformats.org/drawingml/2006/main">
               <a:ext uri="{FF2B5EF4-FFF2-40B4-BE49-F238E27FC236}">
-                <a16:creationId xmlns:a16="http://schemas.microsoft.com/office/drawing/2014/main" id="{69E74A08-C51B-4F19-BA13-FFD78D11DD39}"/>
+                <a16:creationId xmlns:a16="http://schemas.microsoft.com/office/drawing/2014/main" id="{86738B7B-5804-43C3-A58B-327848501BC3}"/>
               </a:ext>
             </a:extLst>
           </p:cNvPr>
@@ -8616,7 +8614,7 @@
     </p:spTree>
     <p:extLst>
       <p:ext uri="{BB962C8B-B14F-4D97-AF65-F5344CB8AC3E}">
-        <p14:creationId xmlns:p14="http://schemas.microsoft.com/office/powerpoint/2010/main" val="1148971867"/>
+        <p14:creationId xmlns:p14="http://schemas.microsoft.com/office/powerpoint/2010/main" val="1916626574"/>
       </p:ext>
     </p:extLst>
   </p:cSld>
@@ -8647,7 +8645,7 @@
           <p:cNvPr id="31" name="">
             <a:extLst xmlns:a="http://schemas.openxmlformats.org/drawingml/2006/main">
               <a:ext uri="{FF2B5EF4-FFF2-40B4-BE49-F238E27FC236}">
-                <a16:creationId xmlns:a16="http://schemas.microsoft.com/office/drawing/2014/main" id="{8D3383F7-1E5F-4135-8CAA-7488C999E2FE}"/>
+                <a16:creationId xmlns:a16="http://schemas.microsoft.com/office/drawing/2014/main" id="{6584C78B-AC72-44A8-BE21-12E473E9F76E}"/>
               </a:ext>
             </a:extLst>
           </p:cNvPr>
@@ -8705,7 +8703,7 @@
           <p:cNvPr id="2" name="">
             <a:extLst xmlns:a="http://schemas.openxmlformats.org/drawingml/2006/main">
               <a:ext uri="{FF2B5EF4-FFF2-40B4-BE49-F238E27FC236}">
-                <a16:creationId xmlns:a16="http://schemas.microsoft.com/office/drawing/2014/main" id="{63C013F5-D2AF-4833-9998-AC20815D482F}"/>
+                <a16:creationId xmlns:a16="http://schemas.microsoft.com/office/drawing/2014/main" id="{24F5EFF4-B30E-4879-AC42-A5E155EE34F0}"/>
               </a:ext>
             </a:extLst>
           </p:cNvPr>
@@ -8763,7 +8761,7 @@
           <p:cNvPr id="3" name="">
             <a:extLst xmlns:a="http://schemas.openxmlformats.org/drawingml/2006/main">
               <a:ext uri="{FF2B5EF4-FFF2-40B4-BE49-F238E27FC236}">
-                <a16:creationId xmlns:a16="http://schemas.microsoft.com/office/drawing/2014/main" id="{E7A09721-005D-43EB-9279-BCF842AE8D2A}"/>
+                <a16:creationId xmlns:a16="http://schemas.microsoft.com/office/drawing/2014/main" id="{7E66FB90-C339-41D8-8273-5C77791EB9C4}"/>
               </a:ext>
             </a:extLst>
           </p:cNvPr>
@@ -8821,7 +8819,7 @@
           <p:cNvPr id="4" name="">
             <a:extLst xmlns:a="http://schemas.openxmlformats.org/drawingml/2006/main">
               <a:ext uri="{FF2B5EF4-FFF2-40B4-BE49-F238E27FC236}">
-                <a16:creationId xmlns:a16="http://schemas.microsoft.com/office/drawing/2014/main" id="{CBD2BAD6-6203-496B-9B13-A545654AE3B2}"/>
+                <a16:creationId xmlns:a16="http://schemas.microsoft.com/office/drawing/2014/main" id="{B3673F5E-BDC1-4E05-B4AE-CF9B2476CFBE}"/>
               </a:ext>
             </a:extLst>
           </p:cNvPr>
@@ -8879,7 +8877,7 @@
           <p:cNvPr id="5" name="">
             <a:extLst xmlns:a="http://schemas.openxmlformats.org/drawingml/2006/main">
               <a:ext uri="{FF2B5EF4-FFF2-40B4-BE49-F238E27FC236}">
-                <a16:creationId xmlns:a16="http://schemas.microsoft.com/office/drawing/2014/main" id="{33EB9102-4BE4-440F-8530-FFD92D5B356E}"/>
+                <a16:creationId xmlns:a16="http://schemas.microsoft.com/office/drawing/2014/main" id="{F50DB8A4-1B10-40FD-B940-96432D9F302A}"/>
               </a:ext>
             </a:extLst>
           </p:cNvPr>
@@ -8912,7 +8910,7 @@
           <p:cNvPr id="6" name="">
             <a:extLst xmlns:a="http://schemas.openxmlformats.org/drawingml/2006/main">
               <a:ext uri="{FF2B5EF4-FFF2-40B4-BE49-F238E27FC236}">
-                <a16:creationId xmlns:a16="http://schemas.microsoft.com/office/drawing/2014/main" id="{DD85EAC2-E308-441F-B8C7-7318AE07EB9E}"/>
+                <a16:creationId xmlns:a16="http://schemas.microsoft.com/office/drawing/2014/main" id="{CA417CEE-B9FB-40A6-9C41-09CE7E146966}"/>
               </a:ext>
             </a:extLst>
           </p:cNvPr>
@@ -8970,7 +8968,7 @@
           <p:cNvPr id="7" name="">
             <a:extLst xmlns:a="http://schemas.openxmlformats.org/drawingml/2006/main">
               <a:ext uri="{FF2B5EF4-FFF2-40B4-BE49-F238E27FC236}">
-                <a16:creationId xmlns:a16="http://schemas.microsoft.com/office/drawing/2014/main" id="{7A182FD0-D264-4373-8FDE-6F7E24E4512B}"/>
+                <a16:creationId xmlns:a16="http://schemas.microsoft.com/office/drawing/2014/main" id="{86499EE5-8639-4B10-A3A2-015C44BE65C0}"/>
               </a:ext>
             </a:extLst>
           </p:cNvPr>
@@ -9034,7 +9032,7 @@
           <p:cNvPr id="8" name="">
             <a:extLst xmlns:a="http://schemas.openxmlformats.org/drawingml/2006/main">
               <a:ext uri="{FF2B5EF4-FFF2-40B4-BE49-F238E27FC236}">
-                <a16:creationId xmlns:a16="http://schemas.microsoft.com/office/drawing/2014/main" id="{915449DA-EC7C-436A-8085-1045B6024E44}"/>
+                <a16:creationId xmlns:a16="http://schemas.microsoft.com/office/drawing/2014/main" id="{B3308572-AE2A-46B1-A56D-2F55E1C30970}"/>
               </a:ext>
             </a:extLst>
           </p:cNvPr>
@@ -9092,7 +9090,7 @@
           <p:cNvPr id="9" name="">
             <a:extLst xmlns:a="http://schemas.openxmlformats.org/drawingml/2006/main">
               <a:ext uri="{FF2B5EF4-FFF2-40B4-BE49-F238E27FC236}">
-                <a16:creationId xmlns:a16="http://schemas.microsoft.com/office/drawing/2014/main" id="{B08CBE7B-69DF-4FFD-9700-46A302540148}"/>
+                <a16:creationId xmlns:a16="http://schemas.microsoft.com/office/drawing/2014/main" id="{95E44C7C-95A9-4E3F-9561-75748EBE3008}"/>
               </a:ext>
             </a:extLst>
           </p:cNvPr>
@@ -9125,7 +9123,7 @@
           <p:cNvPr id="10" name="">
             <a:extLst xmlns:a="http://schemas.openxmlformats.org/drawingml/2006/main">
               <a:ext uri="{FF2B5EF4-FFF2-40B4-BE49-F238E27FC236}">
-                <a16:creationId xmlns:a16="http://schemas.microsoft.com/office/drawing/2014/main" id="{81921A17-D596-42A3-936C-D364F06772E5}"/>
+                <a16:creationId xmlns:a16="http://schemas.microsoft.com/office/drawing/2014/main" id="{C63F9480-0E62-4214-BC0F-6CD0AB2A136C}"/>
               </a:ext>
             </a:extLst>
           </p:cNvPr>
@@ -9158,7 +9156,7 @@
           <p:cNvPr id="11" name="">
             <a:extLst xmlns:a="http://schemas.openxmlformats.org/drawingml/2006/main">
               <a:ext uri="{FF2B5EF4-FFF2-40B4-BE49-F238E27FC236}">
-                <a16:creationId xmlns:a16="http://schemas.microsoft.com/office/drawing/2014/main" id="{DC581143-CF7D-435B-ABC3-E260F985F40D}"/>
+                <a16:creationId xmlns:a16="http://schemas.microsoft.com/office/drawing/2014/main" id="{ECB8E68E-6AC2-4DFD-922D-AD6D61C3E670}"/>
               </a:ext>
             </a:extLst>
           </p:cNvPr>
@@ -9191,7 +9189,7 @@
           <p:cNvPr id="12" name="">
             <a:extLst xmlns:a="http://schemas.openxmlformats.org/drawingml/2006/main">
               <a:ext uri="{FF2B5EF4-FFF2-40B4-BE49-F238E27FC236}">
-                <a16:creationId xmlns:a16="http://schemas.microsoft.com/office/drawing/2014/main" id="{918DB47C-C508-4F37-90D3-9D9CA0DF1016}"/>
+                <a16:creationId xmlns:a16="http://schemas.microsoft.com/office/drawing/2014/main" id="{6BF3AFF0-A159-4F8E-867A-8E48FBF597E9}"/>
               </a:ext>
             </a:extLst>
           </p:cNvPr>
@@ -9224,7 +9222,7 @@
           <p:cNvPr id="13" name="">
             <a:extLst xmlns:a="http://schemas.openxmlformats.org/drawingml/2006/main">
               <a:ext uri="{FF2B5EF4-FFF2-40B4-BE49-F238E27FC236}">
-                <a16:creationId xmlns:a16="http://schemas.microsoft.com/office/drawing/2014/main" id="{B7EBD13A-6069-4C1D-BB0C-4E9C4BBD3B75}"/>
+                <a16:creationId xmlns:a16="http://schemas.microsoft.com/office/drawing/2014/main" id="{CD56F96D-19DB-4769-924F-8BE504C4E901}"/>
               </a:ext>
             </a:extLst>
           </p:cNvPr>
@@ -9257,7 +9255,7 @@
           <p:cNvPr id="14" name="">
             <a:extLst xmlns:a="http://schemas.openxmlformats.org/drawingml/2006/main">
               <a:ext uri="{FF2B5EF4-FFF2-40B4-BE49-F238E27FC236}">
-                <a16:creationId xmlns:a16="http://schemas.microsoft.com/office/drawing/2014/main" id="{95AE6261-00B2-42D4-8F7E-91360001064E}"/>
+                <a16:creationId xmlns:a16="http://schemas.microsoft.com/office/drawing/2014/main" id="{A9DB9F68-8C7B-4057-A14F-7AC15150724A}"/>
               </a:ext>
             </a:extLst>
           </p:cNvPr>
@@ -9288,7 +9286,7 @@
           <p:cNvPr id="15" name="">
             <a:extLst xmlns:a="http://schemas.openxmlformats.org/drawingml/2006/main">
               <a:ext uri="{FF2B5EF4-FFF2-40B4-BE49-F238E27FC236}">
-                <a16:creationId xmlns:a16="http://schemas.microsoft.com/office/drawing/2014/main" id="{D4386C29-B68C-46FC-854D-80C5F967E787}"/>
+                <a16:creationId xmlns:a16="http://schemas.microsoft.com/office/drawing/2014/main" id="{3F1CAF31-E5C7-4843-9AB1-4527D9CA46E2}"/>
               </a:ext>
             </a:extLst>
           </p:cNvPr>
@@ -9346,7 +9344,7 @@
           <p:cNvPr id="16" name="">
             <a:extLst xmlns:a="http://schemas.openxmlformats.org/drawingml/2006/main">
               <a:ext uri="{FF2B5EF4-FFF2-40B4-BE49-F238E27FC236}">
-                <a16:creationId xmlns:a16="http://schemas.microsoft.com/office/drawing/2014/main" id="{56CE03CE-AAD6-4FC1-A8FF-770510FC7399}"/>
+                <a16:creationId xmlns:a16="http://schemas.microsoft.com/office/drawing/2014/main" id="{2A9AE9A7-F3BC-4E57-869F-81AFDD1157A3}"/>
               </a:ext>
             </a:extLst>
           </p:cNvPr>
@@ -9379,7 +9377,7 @@
           <p:cNvPr id="17" name="">
             <a:extLst xmlns:a="http://schemas.openxmlformats.org/drawingml/2006/main">
               <a:ext uri="{FF2B5EF4-FFF2-40B4-BE49-F238E27FC236}">
-                <a16:creationId xmlns:a16="http://schemas.microsoft.com/office/drawing/2014/main" id="{01F3A48E-E38F-4997-9AF7-B58841E89E30}"/>
+                <a16:creationId xmlns:a16="http://schemas.microsoft.com/office/drawing/2014/main" id="{C69E203E-1B1E-42B0-B4CF-1BC8B30380F1}"/>
               </a:ext>
             </a:extLst>
           </p:cNvPr>
@@ -9619,7 +9617,7 @@
           <p:cNvPr id="25" name="">
             <a:extLst xmlns:a="http://schemas.openxmlformats.org/drawingml/2006/main">
               <a:ext uri="{FF2B5EF4-FFF2-40B4-BE49-F238E27FC236}">
-                <a16:creationId xmlns:a16="http://schemas.microsoft.com/office/drawing/2014/main" id="{4F92A2F9-1B87-4BFE-8809-975DCBDDF27B}"/>
+                <a16:creationId xmlns:a16="http://schemas.microsoft.com/office/drawing/2014/main" id="{CB6EE6CE-175B-4A48-AEEA-3CB2747D6D23}"/>
               </a:ext>
             </a:extLst>
           </p:cNvPr>
@@ -9677,7 +9675,7 @@
           <p:cNvPr id="26" name="">
             <a:extLst xmlns:a="http://schemas.openxmlformats.org/drawingml/2006/main">
               <a:ext uri="{FF2B5EF4-FFF2-40B4-BE49-F238E27FC236}">
-                <a16:creationId xmlns:a16="http://schemas.microsoft.com/office/drawing/2014/main" id="{CD2DF238-0F4A-4538-93FA-2E4971D6D06F}"/>
+                <a16:creationId xmlns:a16="http://schemas.microsoft.com/office/drawing/2014/main" id="{1CCA1AC1-1591-4998-8513-41B1A97D3CD6}"/>
               </a:ext>
             </a:extLst>
           </p:cNvPr>
@@ -9735,7 +9733,7 @@
           <p:cNvPr id="27" name="">
             <a:extLst xmlns:a="http://schemas.openxmlformats.org/drawingml/2006/main">
               <a:ext uri="{FF2B5EF4-FFF2-40B4-BE49-F238E27FC236}">
-                <a16:creationId xmlns:a16="http://schemas.microsoft.com/office/drawing/2014/main" id="{95838DA9-C5B0-4A6A-B7A0-D7D3E8E47366}"/>
+                <a16:creationId xmlns:a16="http://schemas.microsoft.com/office/drawing/2014/main" id="{304D8F35-D116-4496-B5C1-CFE1BC9B3389}"/>
               </a:ext>
             </a:extLst>
           </p:cNvPr>
@@ -9793,7 +9791,7 @@
           <p:cNvPr id="28" name="">
             <a:extLst xmlns:a="http://schemas.openxmlformats.org/drawingml/2006/main">
               <a:ext uri="{FF2B5EF4-FFF2-40B4-BE49-F238E27FC236}">
-                <a16:creationId xmlns:a16="http://schemas.microsoft.com/office/drawing/2014/main" id="{7AD23270-EF74-4CDC-B803-7B3F2CC85B2D}"/>
+                <a16:creationId xmlns:a16="http://schemas.microsoft.com/office/drawing/2014/main" id="{329AA3E7-3B68-4C8C-87D6-A82B5887EA79}"/>
               </a:ext>
             </a:extLst>
           </p:cNvPr>
@@ -9857,7 +9855,7 @@
           <p:cNvPr id="29" name="">
             <a:extLst xmlns:a="http://schemas.openxmlformats.org/drawingml/2006/main">
               <a:ext uri="{FF2B5EF4-FFF2-40B4-BE49-F238E27FC236}">
-                <a16:creationId xmlns:a16="http://schemas.microsoft.com/office/drawing/2014/main" id="{5F67914D-7261-4474-8120-440BE96D4D0F}"/>
+                <a16:creationId xmlns:a16="http://schemas.microsoft.com/office/drawing/2014/main" id="{9C604FEF-BD45-4C43-AC21-0507A74BFCA1}"/>
               </a:ext>
             </a:extLst>
           </p:cNvPr>
@@ -9921,7 +9919,7 @@
           <p:cNvPr id="30" name="">
             <a:extLst xmlns:a="http://schemas.openxmlformats.org/drawingml/2006/main">
               <a:ext uri="{FF2B5EF4-FFF2-40B4-BE49-F238E27FC236}">
-                <a16:creationId xmlns:a16="http://schemas.microsoft.com/office/drawing/2014/main" id="{8692E244-58F4-4526-9080-774D540F945F}"/>
+                <a16:creationId xmlns:a16="http://schemas.microsoft.com/office/drawing/2014/main" id="{1D17ABF4-A65C-47B4-9FD7-A0407EABB3A3}"/>
               </a:ext>
             </a:extLst>
           </p:cNvPr>
@@ -9977,7 +9975,7 @@
     </p:spTree>
     <p:extLst>
       <p:ext uri="{BB962C8B-B14F-4D97-AF65-F5344CB8AC3E}">
-        <p14:creationId xmlns:p14="http://schemas.microsoft.com/office/powerpoint/2010/main" val="1169675795"/>
+        <p14:creationId xmlns:p14="http://schemas.microsoft.com/office/powerpoint/2010/main" val="2062243109"/>
       </p:ext>
     </p:extLst>
   </p:cSld>
@@ -10008,7 +10006,7 @@
           <p:cNvPr id="40" name="">
             <a:extLst xmlns:a="http://schemas.openxmlformats.org/drawingml/2006/main">
               <a:ext uri="{FF2B5EF4-FFF2-40B4-BE49-F238E27FC236}">
-                <a16:creationId xmlns:a16="http://schemas.microsoft.com/office/drawing/2014/main" id="{7E585299-F908-47D6-9BCD-355C01940D54}"/>
+                <a16:creationId xmlns:a16="http://schemas.microsoft.com/office/drawing/2014/main" id="{18D9699F-5BBC-4D7C-BD2B-0DA9309F8C80}"/>
               </a:ext>
             </a:extLst>
           </p:cNvPr>
@@ -10066,7 +10064,7 @@
           <p:cNvPr id="2" name="">
             <a:extLst xmlns:a="http://schemas.openxmlformats.org/drawingml/2006/main">
               <a:ext uri="{FF2B5EF4-FFF2-40B4-BE49-F238E27FC236}">
-                <a16:creationId xmlns:a16="http://schemas.microsoft.com/office/drawing/2014/main" id="{3EE2E0B8-7B08-4978-957D-71A9B90881B8}"/>
+                <a16:creationId xmlns:a16="http://schemas.microsoft.com/office/drawing/2014/main" id="{A5258690-B156-4942-9A29-C3B13A358DE9}"/>
               </a:ext>
             </a:extLst>
           </p:cNvPr>
@@ -10124,7 +10122,7 @@
           <p:cNvPr id="3" name="">
             <a:extLst xmlns:a="http://schemas.openxmlformats.org/drawingml/2006/main">
               <a:ext uri="{FF2B5EF4-FFF2-40B4-BE49-F238E27FC236}">
-                <a16:creationId xmlns:a16="http://schemas.microsoft.com/office/drawing/2014/main" id="{E94ABC10-0198-466D-BC27-8A763BC3C4EA}"/>
+                <a16:creationId xmlns:a16="http://schemas.microsoft.com/office/drawing/2014/main" id="{3E102322-B84D-4068-A090-B72D753EE01B}"/>
               </a:ext>
             </a:extLst>
           </p:cNvPr>
@@ -10155,7 +10153,7 @@
           <p:cNvPr id="4" name="">
             <a:extLst xmlns:a="http://schemas.openxmlformats.org/drawingml/2006/main">
               <a:ext uri="{FF2B5EF4-FFF2-40B4-BE49-F238E27FC236}">
-                <a16:creationId xmlns:a16="http://schemas.microsoft.com/office/drawing/2014/main" id="{A3B5F034-5331-4483-9D23-053262091563}"/>
+                <a16:creationId xmlns:a16="http://schemas.microsoft.com/office/drawing/2014/main" id="{6E685770-0C1F-47F1-A6E3-5FB72EF1CC52}"/>
               </a:ext>
             </a:extLst>
           </p:cNvPr>
@@ -10188,7 +10186,7 @@
           <p:cNvPr id="5" name="">
             <a:extLst xmlns:a="http://schemas.openxmlformats.org/drawingml/2006/main">
               <a:ext uri="{FF2B5EF4-FFF2-40B4-BE49-F238E27FC236}">
-                <a16:creationId xmlns:a16="http://schemas.microsoft.com/office/drawing/2014/main" id="{71031EB5-A719-493C-B94C-721BE479DA3F}"/>
+                <a16:creationId xmlns:a16="http://schemas.microsoft.com/office/drawing/2014/main" id="{B243C9EC-4E89-495F-8621-5913D5E9A4BD}"/>
               </a:ext>
             </a:extLst>
           </p:cNvPr>
@@ -10221,7 +10219,7 @@
           <p:cNvPr id="6" name="">
             <a:extLst xmlns:a="http://schemas.openxmlformats.org/drawingml/2006/main">
               <a:ext uri="{FF2B5EF4-FFF2-40B4-BE49-F238E27FC236}">
-                <a16:creationId xmlns:a16="http://schemas.microsoft.com/office/drawing/2014/main" id="{F73666ED-DE98-4237-957F-A6CDA90C7137}"/>
+                <a16:creationId xmlns:a16="http://schemas.microsoft.com/office/drawing/2014/main" id="{FDE02062-AA89-40E8-B17C-A74BE1CA74EE}"/>
               </a:ext>
             </a:extLst>
           </p:cNvPr>
@@ -10254,7 +10252,7 @@
           <p:cNvPr id="7" name="">
             <a:extLst xmlns:a="http://schemas.openxmlformats.org/drawingml/2006/main">
               <a:ext uri="{FF2B5EF4-FFF2-40B4-BE49-F238E27FC236}">
-                <a16:creationId xmlns:a16="http://schemas.microsoft.com/office/drawing/2014/main" id="{17AF9DF8-6A72-4861-BA13-5A28A4E2E874}"/>
+                <a16:creationId xmlns:a16="http://schemas.microsoft.com/office/drawing/2014/main" id="{7265659E-1212-4FD8-8E42-D4F0D5E15548}"/>
               </a:ext>
             </a:extLst>
           </p:cNvPr>
@@ -10287,7 +10285,7 @@
           <p:cNvPr id="8" name="">
             <a:extLst xmlns:a="http://schemas.openxmlformats.org/drawingml/2006/main">
               <a:ext uri="{FF2B5EF4-FFF2-40B4-BE49-F238E27FC236}">
-                <a16:creationId xmlns:a16="http://schemas.microsoft.com/office/drawing/2014/main" id="{DC5887D2-27DF-4D43-9681-FDAC661E3E00}"/>
+                <a16:creationId xmlns:a16="http://schemas.microsoft.com/office/drawing/2014/main" id="{99CB0846-DC3A-41ED-B95D-2B5D9BD16105}"/>
               </a:ext>
             </a:extLst>
           </p:cNvPr>
@@ -10320,7 +10318,7 @@
           <p:cNvPr id="9" name="">
             <a:extLst xmlns:a="http://schemas.openxmlformats.org/drawingml/2006/main">
               <a:ext uri="{FF2B5EF4-FFF2-40B4-BE49-F238E27FC236}">
-                <a16:creationId xmlns:a16="http://schemas.microsoft.com/office/drawing/2014/main" id="{E7ED0AA8-2069-4758-AABB-C741C151B897}"/>
+                <a16:creationId xmlns:a16="http://schemas.microsoft.com/office/drawing/2014/main" id="{D129D211-9EC1-4EF2-96BE-A23D7C7D4E3B}"/>
               </a:ext>
             </a:extLst>
           </p:cNvPr>
@@ -10351,7 +10349,7 @@
           <p:cNvPr id="10" name="">
             <a:extLst xmlns:a="http://schemas.openxmlformats.org/drawingml/2006/main">
               <a:ext uri="{FF2B5EF4-FFF2-40B4-BE49-F238E27FC236}">
-                <a16:creationId xmlns:a16="http://schemas.microsoft.com/office/drawing/2014/main" id="{DCE26FCE-3236-43C9-8F97-36AA37884536}"/>
+                <a16:creationId xmlns:a16="http://schemas.microsoft.com/office/drawing/2014/main" id="{C3A36157-A5E6-4518-81AF-EEC82C0D112E}"/>
               </a:ext>
             </a:extLst>
           </p:cNvPr>
@@ -10384,7 +10382,7 @@
           <p:cNvPr id="11" name="">
             <a:extLst xmlns:a="http://schemas.openxmlformats.org/drawingml/2006/main">
               <a:ext uri="{FF2B5EF4-FFF2-40B4-BE49-F238E27FC236}">
-                <a16:creationId xmlns:a16="http://schemas.microsoft.com/office/drawing/2014/main" id="{621BE33D-AEDA-44AF-A85D-CF46CAE00972}"/>
+                <a16:creationId xmlns:a16="http://schemas.microsoft.com/office/drawing/2014/main" id="{4ADADB5D-5AD1-4182-BC2D-4E56222454F7}"/>
               </a:ext>
             </a:extLst>
           </p:cNvPr>
@@ -10625,7 +10623,7 @@
           <p:cNvPr id="20" name="">
             <a:extLst xmlns:a="http://schemas.openxmlformats.org/drawingml/2006/main">
               <a:ext uri="{FF2B5EF4-FFF2-40B4-BE49-F238E27FC236}">
-                <a16:creationId xmlns:a16="http://schemas.microsoft.com/office/drawing/2014/main" id="{810DAFF8-3F09-4888-8D8A-D70B3C7EB728}"/>
+                <a16:creationId xmlns:a16="http://schemas.microsoft.com/office/drawing/2014/main" id="{4B81172A-9A15-4A66-9F8D-B9BC5AD52C4B}"/>
               </a:ext>
             </a:extLst>
           </p:cNvPr>
@@ -10658,7 +10656,7 @@
           <p:cNvPr id="21" name="">
             <a:extLst xmlns:a="http://schemas.openxmlformats.org/drawingml/2006/main">
               <a:ext uri="{FF2B5EF4-FFF2-40B4-BE49-F238E27FC236}">
-                <a16:creationId xmlns:a16="http://schemas.microsoft.com/office/drawing/2014/main" id="{42D39E94-7E90-41C0-9779-9FFF2FA138DC}"/>
+                <a16:creationId xmlns:a16="http://schemas.microsoft.com/office/drawing/2014/main" id="{F47CA5F7-D67B-4C9B-97F3-66ACAD1F6181}"/>
               </a:ext>
             </a:extLst>
           </p:cNvPr>
@@ -10691,7 +10689,7 @@
           <p:cNvPr id="22" name="">
             <a:extLst xmlns:a="http://schemas.openxmlformats.org/drawingml/2006/main">
               <a:ext uri="{FF2B5EF4-FFF2-40B4-BE49-F238E27FC236}">
-                <a16:creationId xmlns:a16="http://schemas.microsoft.com/office/drawing/2014/main" id="{9770BFE3-E3C8-4FF3-A521-52D379907E26}"/>
+                <a16:creationId xmlns:a16="http://schemas.microsoft.com/office/drawing/2014/main" id="{87B97E1A-5CFB-4F67-BF44-AC060037C94F}"/>
               </a:ext>
             </a:extLst>
           </p:cNvPr>
@@ -10724,7 +10722,7 @@
           <p:cNvPr id="23" name="">
             <a:extLst xmlns:a="http://schemas.openxmlformats.org/drawingml/2006/main">
               <a:ext uri="{FF2B5EF4-FFF2-40B4-BE49-F238E27FC236}">
-                <a16:creationId xmlns:a16="http://schemas.microsoft.com/office/drawing/2014/main" id="{6AAEA74E-8500-4D4F-8FDC-0C4C00F805F7}"/>
+                <a16:creationId xmlns:a16="http://schemas.microsoft.com/office/drawing/2014/main" id="{62164888-9756-44C6-99D9-6C81918AE55C}"/>
               </a:ext>
             </a:extLst>
           </p:cNvPr>
@@ -10757,7 +10755,7 @@
           <p:cNvPr id="24" name="">
             <a:extLst xmlns:a="http://schemas.openxmlformats.org/drawingml/2006/main">
               <a:ext uri="{FF2B5EF4-FFF2-40B4-BE49-F238E27FC236}">
-                <a16:creationId xmlns:a16="http://schemas.microsoft.com/office/drawing/2014/main" id="{B92DFCCF-5361-4D7F-B66E-A3B13D556989}"/>
+                <a16:creationId xmlns:a16="http://schemas.microsoft.com/office/drawing/2014/main" id="{9499023F-4BB6-4999-B17F-7F8431CC7CE6}"/>
               </a:ext>
             </a:extLst>
           </p:cNvPr>
@@ -10790,7 +10788,7 @@
           <p:cNvPr id="25" name="">
             <a:extLst xmlns:a="http://schemas.openxmlformats.org/drawingml/2006/main">
               <a:ext uri="{FF2B5EF4-FFF2-40B4-BE49-F238E27FC236}">
-                <a16:creationId xmlns:a16="http://schemas.microsoft.com/office/drawing/2014/main" id="{0E711168-6A75-4407-B846-FE1912EE947D}"/>
+                <a16:creationId xmlns:a16="http://schemas.microsoft.com/office/drawing/2014/main" id="{2BC8ACBB-185C-4C96-9B30-F9103CCF6BA6}"/>
               </a:ext>
             </a:extLst>
           </p:cNvPr>
@@ -10821,7 +10819,7 @@
           <p:cNvPr id="26" name="">
             <a:extLst xmlns:a="http://schemas.openxmlformats.org/drawingml/2006/main">
               <a:ext uri="{FF2B5EF4-FFF2-40B4-BE49-F238E27FC236}">
-                <a16:creationId xmlns:a16="http://schemas.microsoft.com/office/drawing/2014/main" id="{83A71AE1-42F7-4F75-93E1-1CA47D4A281F}"/>
+                <a16:creationId xmlns:a16="http://schemas.microsoft.com/office/drawing/2014/main" id="{A527C16C-B037-4A40-842A-3F2F21AF67B0}"/>
               </a:ext>
             </a:extLst>
           </p:cNvPr>
@@ -10854,7 +10852,7 @@
           <p:cNvPr id="27" name="">
             <a:extLst xmlns:a="http://schemas.openxmlformats.org/drawingml/2006/main">
               <a:ext uri="{FF2B5EF4-FFF2-40B4-BE49-F238E27FC236}">
-                <a16:creationId xmlns:a16="http://schemas.microsoft.com/office/drawing/2014/main" id="{E82074C6-492B-49A1-B2E6-BF5C19918FC3}"/>
+                <a16:creationId xmlns:a16="http://schemas.microsoft.com/office/drawing/2014/main" id="{A354CA44-8B2D-48A8-8E69-C7F060288D48}"/>
               </a:ext>
             </a:extLst>
           </p:cNvPr>
@@ -11095,7 +11093,7 @@
           <p:cNvPr id="36" name="">
             <a:extLst xmlns:a="http://schemas.openxmlformats.org/drawingml/2006/main">
               <a:ext uri="{FF2B5EF4-FFF2-40B4-BE49-F238E27FC236}">
-                <a16:creationId xmlns:a16="http://schemas.microsoft.com/office/drawing/2014/main" id="{C0F80E02-559A-4D71-954A-95750FB88559}"/>
+                <a16:creationId xmlns:a16="http://schemas.microsoft.com/office/drawing/2014/main" id="{49727152-0501-4160-8D10-666D71C14035}"/>
               </a:ext>
             </a:extLst>
           </p:cNvPr>
@@ -11153,7 +11151,7 @@
           <p:cNvPr id="37" name="">
             <a:extLst xmlns:a="http://schemas.openxmlformats.org/drawingml/2006/main">
               <a:ext uri="{FF2B5EF4-FFF2-40B4-BE49-F238E27FC236}">
-                <a16:creationId xmlns:a16="http://schemas.microsoft.com/office/drawing/2014/main" id="{781262CF-73A7-45B5-AD91-663C7F25ADF7}"/>
+                <a16:creationId xmlns:a16="http://schemas.microsoft.com/office/drawing/2014/main" id="{8C6FCA82-6570-4EE5-99D8-FE1DE8461607}"/>
               </a:ext>
             </a:extLst>
           </p:cNvPr>
@@ -11211,7 +11209,7 @@
           <p:cNvPr id="38" name="">
             <a:extLst xmlns:a="http://schemas.openxmlformats.org/drawingml/2006/main">
               <a:ext uri="{FF2B5EF4-FFF2-40B4-BE49-F238E27FC236}">
-                <a16:creationId xmlns:a16="http://schemas.microsoft.com/office/drawing/2014/main" id="{15534516-F8C3-4797-AF1C-D872F12E2F5D}"/>
+                <a16:creationId xmlns:a16="http://schemas.microsoft.com/office/drawing/2014/main" id="{86B3CD56-539F-4BDE-8B3E-1A2B24749371}"/>
               </a:ext>
             </a:extLst>
           </p:cNvPr>
@@ -11275,7 +11273,7 @@
           <p:cNvPr id="39" name="">
             <a:extLst xmlns:a="http://schemas.openxmlformats.org/drawingml/2006/main">
               <a:ext uri="{FF2B5EF4-FFF2-40B4-BE49-F238E27FC236}">
-                <a16:creationId xmlns:a16="http://schemas.microsoft.com/office/drawing/2014/main" id="{2824952F-5C0F-403A-957C-31BCE6295B2D}"/>
+                <a16:creationId xmlns:a16="http://schemas.microsoft.com/office/drawing/2014/main" id="{5C2CC3F5-C4B7-481D-AB6D-310AAC82B3F2}"/>
               </a:ext>
             </a:extLst>
           </p:cNvPr>
@@ -11337,7 +11335,7 @@
     </p:spTree>
     <p:extLst>
       <p:ext uri="{BB962C8B-B14F-4D97-AF65-F5344CB8AC3E}">
-        <p14:creationId xmlns:p14="http://schemas.microsoft.com/office/powerpoint/2010/main" val="2067324148"/>
+        <p14:creationId xmlns:p14="http://schemas.microsoft.com/office/powerpoint/2010/main" val="1866503886"/>
       </p:ext>
     </p:extLst>
   </p:cSld>
@@ -11368,7 +11366,7 @@
           <p:cNvPr id="41" name="">
             <a:extLst xmlns:a="http://schemas.openxmlformats.org/drawingml/2006/main">
               <a:ext uri="{FF2B5EF4-FFF2-40B4-BE49-F238E27FC236}">
-                <a16:creationId xmlns:a16="http://schemas.microsoft.com/office/drawing/2014/main" id="{74EB2949-6870-4EF6-93E5-22EADA1E23EE}"/>
+                <a16:creationId xmlns:a16="http://schemas.microsoft.com/office/drawing/2014/main" id="{10D986B0-FEBD-450A-AE64-3A59B19B521C}"/>
               </a:ext>
             </a:extLst>
           </p:cNvPr>
@@ -11426,7 +11424,7 @@
           <p:cNvPr id="2" name="">
             <a:extLst xmlns:a="http://schemas.openxmlformats.org/drawingml/2006/main">
               <a:ext uri="{FF2B5EF4-FFF2-40B4-BE49-F238E27FC236}">
-                <a16:creationId xmlns:a16="http://schemas.microsoft.com/office/drawing/2014/main" id="{07CC0864-7726-4DB2-A4FA-ABA4FDAFB41C}"/>
+                <a16:creationId xmlns:a16="http://schemas.microsoft.com/office/drawing/2014/main" id="{D65F4FA2-B250-4EF1-A974-3AB4F802A1C7}"/>
               </a:ext>
             </a:extLst>
           </p:cNvPr>
@@ -11507,7 +11505,7 @@
           <p:cNvPr id="3" name="">
             <a:extLst xmlns:a="http://schemas.openxmlformats.org/drawingml/2006/main">
               <a:ext uri="{FF2B5EF4-FFF2-40B4-BE49-F238E27FC236}">
-                <a16:creationId xmlns:a16="http://schemas.microsoft.com/office/drawing/2014/main" id="{6221B5B1-A47C-4082-AA07-A4E5E199D302}"/>
+                <a16:creationId xmlns:a16="http://schemas.microsoft.com/office/drawing/2014/main" id="{07628866-3DEC-48FF-A1CE-DD8CA361260C}"/>
               </a:ext>
             </a:extLst>
           </p:cNvPr>
@@ -11565,7 +11563,7 @@
           <p:cNvPr id="4" name="">
             <a:extLst xmlns:a="http://schemas.openxmlformats.org/drawingml/2006/main">
               <a:ext uri="{FF2B5EF4-FFF2-40B4-BE49-F238E27FC236}">
-                <a16:creationId xmlns:a16="http://schemas.microsoft.com/office/drawing/2014/main" id="{BE6EEA6E-5F15-460C-BF32-CA7CC785AC0A}"/>
+                <a16:creationId xmlns:a16="http://schemas.microsoft.com/office/drawing/2014/main" id="{F430101F-D0FC-4075-8CF8-4A9EB9280329}"/>
               </a:ext>
             </a:extLst>
           </p:cNvPr>
@@ -11623,7 +11621,7 @@
           <p:cNvPr id="5" name="">
             <a:extLst xmlns:a="http://schemas.openxmlformats.org/drawingml/2006/main">
               <a:ext uri="{FF2B5EF4-FFF2-40B4-BE49-F238E27FC236}">
-                <a16:creationId xmlns:a16="http://schemas.microsoft.com/office/drawing/2014/main" id="{79C9F046-C102-4F51-9BB1-C3CFEA7F1C12}"/>
+                <a16:creationId xmlns:a16="http://schemas.microsoft.com/office/drawing/2014/main" id="{FAF1CBC3-C9DD-4036-B223-44BFE8F46EEA}"/>
               </a:ext>
             </a:extLst>
           </p:cNvPr>
@@ -11656,7 +11654,7 @@
           <p:cNvPr id="6" name="">
             <a:extLst xmlns:a="http://schemas.openxmlformats.org/drawingml/2006/main">
               <a:ext uri="{FF2B5EF4-FFF2-40B4-BE49-F238E27FC236}">
-                <a16:creationId xmlns:a16="http://schemas.microsoft.com/office/drawing/2014/main" id="{B5AC7D3F-9DA0-457E-837A-2949D90BB2FC}"/>
+                <a16:creationId xmlns:a16="http://schemas.microsoft.com/office/drawing/2014/main" id="{F830C902-65F2-4F35-ABC9-6E732E5D997C}"/>
               </a:ext>
             </a:extLst>
           </p:cNvPr>
@@ -11689,7 +11687,7 @@
           <p:cNvPr id="7" name="">
             <a:extLst xmlns:a="http://schemas.openxmlformats.org/drawingml/2006/main">
               <a:ext uri="{FF2B5EF4-FFF2-40B4-BE49-F238E27FC236}">
-                <a16:creationId xmlns:a16="http://schemas.microsoft.com/office/drawing/2014/main" id="{F1D4BC22-6D1A-4FAC-A710-CFD7E85432C7}"/>
+                <a16:creationId xmlns:a16="http://schemas.microsoft.com/office/drawing/2014/main" id="{37FE1764-F11D-4A14-9E1F-F64D48CF1512}"/>
               </a:ext>
             </a:extLst>
           </p:cNvPr>
@@ -11722,7 +11720,7 @@
           <p:cNvPr id="8" name="">
             <a:extLst xmlns:a="http://schemas.openxmlformats.org/drawingml/2006/main">
               <a:ext uri="{FF2B5EF4-FFF2-40B4-BE49-F238E27FC236}">
-                <a16:creationId xmlns:a16="http://schemas.microsoft.com/office/drawing/2014/main" id="{FAD02D93-4EA0-44F7-BFCF-C1418CAF7A0E}"/>
+                <a16:creationId xmlns:a16="http://schemas.microsoft.com/office/drawing/2014/main" id="{C4AB61C7-D255-4ED6-BAEC-06C5CEAC428B}"/>
               </a:ext>
             </a:extLst>
           </p:cNvPr>
@@ -11833,7 +11831,7 @@
           <p:cNvPr id="12" name="">
             <a:extLst xmlns:a="http://schemas.openxmlformats.org/drawingml/2006/main">
               <a:ext uri="{FF2B5EF4-FFF2-40B4-BE49-F238E27FC236}">
-                <a16:creationId xmlns:a16="http://schemas.microsoft.com/office/drawing/2014/main" id="{1903AB74-B419-4490-9324-330EE000CAF8}"/>
+                <a16:creationId xmlns:a16="http://schemas.microsoft.com/office/drawing/2014/main" id="{E53F9862-7506-433A-AAF6-1F769BE291C5}"/>
               </a:ext>
             </a:extLst>
           </p:cNvPr>
@@ -11866,7 +11864,7 @@
           <p:cNvPr id="13" name="">
             <a:extLst xmlns:a="http://schemas.openxmlformats.org/drawingml/2006/main">
               <a:ext uri="{FF2B5EF4-FFF2-40B4-BE49-F238E27FC236}">
-                <a16:creationId xmlns:a16="http://schemas.microsoft.com/office/drawing/2014/main" id="{A93A63BC-90F8-4678-A674-206C283EB73E}"/>
+                <a16:creationId xmlns:a16="http://schemas.microsoft.com/office/drawing/2014/main" id="{1949DF79-652A-4746-97DB-F597C4992543}"/>
               </a:ext>
             </a:extLst>
           </p:cNvPr>
@@ -11899,7 +11897,7 @@
           <p:cNvPr id="14" name="">
             <a:extLst xmlns:a="http://schemas.openxmlformats.org/drawingml/2006/main">
               <a:ext uri="{FF2B5EF4-FFF2-40B4-BE49-F238E27FC236}">
-                <a16:creationId xmlns:a16="http://schemas.microsoft.com/office/drawing/2014/main" id="{6951ABD0-66E0-4EB6-850C-1310E917A350}"/>
+                <a16:creationId xmlns:a16="http://schemas.microsoft.com/office/drawing/2014/main" id="{0CBA962A-1A4F-4710-BED2-05F8EF890B61}"/>
               </a:ext>
             </a:extLst>
           </p:cNvPr>
@@ -11932,7 +11930,7 @@
           <p:cNvPr id="15" name="">
             <a:extLst xmlns:a="http://schemas.openxmlformats.org/drawingml/2006/main">
               <a:ext uri="{FF2B5EF4-FFF2-40B4-BE49-F238E27FC236}">
-                <a16:creationId xmlns:a16="http://schemas.microsoft.com/office/drawing/2014/main" id="{47518E8F-A4AB-471B-9ABE-CCC33BC8EDF5}"/>
+                <a16:creationId xmlns:a16="http://schemas.microsoft.com/office/drawing/2014/main" id="{82279E8C-1552-48BD-AE60-3735ADBB7526}"/>
               </a:ext>
             </a:extLst>
           </p:cNvPr>
@@ -11965,7 +11963,7 @@
           <p:cNvPr id="16" name="">
             <a:extLst xmlns:a="http://schemas.openxmlformats.org/drawingml/2006/main">
               <a:ext uri="{FF2B5EF4-FFF2-40B4-BE49-F238E27FC236}">
-                <a16:creationId xmlns:a16="http://schemas.microsoft.com/office/drawing/2014/main" id="{5A86DFBE-9ECC-45EA-B26B-653CD9AFA72E}"/>
+                <a16:creationId xmlns:a16="http://schemas.microsoft.com/office/drawing/2014/main" id="{4FFBDD6A-EE18-4D63-8AD9-F1E1C4ED4C79}"/>
               </a:ext>
             </a:extLst>
           </p:cNvPr>
@@ -11996,7 +11994,7 @@
           <p:cNvPr id="17" name="">
             <a:extLst xmlns:a="http://schemas.openxmlformats.org/drawingml/2006/main">
               <a:ext uri="{FF2B5EF4-FFF2-40B4-BE49-F238E27FC236}">
-                <a16:creationId xmlns:a16="http://schemas.microsoft.com/office/drawing/2014/main" id="{17AFE675-4E6A-4E6D-AC9F-E22175FE0AC5}"/>
+                <a16:creationId xmlns:a16="http://schemas.microsoft.com/office/drawing/2014/main" id="{CFEED74A-739A-4DF9-BB94-D52871E23A35}"/>
               </a:ext>
             </a:extLst>
           </p:cNvPr>
@@ -12159,7 +12157,7 @@
           <p:cNvPr id="23" name="">
             <a:extLst xmlns:a="http://schemas.openxmlformats.org/drawingml/2006/main">
               <a:ext uri="{FF2B5EF4-FFF2-40B4-BE49-F238E27FC236}">
-                <a16:creationId xmlns:a16="http://schemas.microsoft.com/office/drawing/2014/main" id="{97DE0F80-E1A7-4F1E-913F-C67436D60068}"/>
+                <a16:creationId xmlns:a16="http://schemas.microsoft.com/office/drawing/2014/main" id="{F28321A2-9BB1-41C7-8F95-E4F9060DA523}"/>
               </a:ext>
             </a:extLst>
           </p:cNvPr>
@@ -12192,7 +12190,7 @@
           <p:cNvPr id="24" name="">
             <a:extLst xmlns:a="http://schemas.openxmlformats.org/drawingml/2006/main">
               <a:ext uri="{FF2B5EF4-FFF2-40B4-BE49-F238E27FC236}">
-                <a16:creationId xmlns:a16="http://schemas.microsoft.com/office/drawing/2014/main" id="{DB537B7E-C788-42C7-A49D-EA53805EDB7A}"/>
+                <a16:creationId xmlns:a16="http://schemas.microsoft.com/office/drawing/2014/main" id="{43E1805A-02FE-4508-A62F-7DF05090B068}"/>
               </a:ext>
             </a:extLst>
           </p:cNvPr>
@@ -12225,7 +12223,7 @@
           <p:cNvPr id="25" name="">
             <a:extLst xmlns:a="http://schemas.openxmlformats.org/drawingml/2006/main">
               <a:ext uri="{FF2B5EF4-FFF2-40B4-BE49-F238E27FC236}">
-                <a16:creationId xmlns:a16="http://schemas.microsoft.com/office/drawing/2014/main" id="{3C4E196B-00A2-427B-9944-9B8679BF446D}"/>
+                <a16:creationId xmlns:a16="http://schemas.microsoft.com/office/drawing/2014/main" id="{F82F824D-64C9-40D3-9A46-FA5610389795}"/>
               </a:ext>
             </a:extLst>
           </p:cNvPr>
@@ -12258,7 +12256,7 @@
           <p:cNvPr id="26" name="">
             <a:extLst xmlns:a="http://schemas.openxmlformats.org/drawingml/2006/main">
               <a:ext uri="{FF2B5EF4-FFF2-40B4-BE49-F238E27FC236}">
-                <a16:creationId xmlns:a16="http://schemas.microsoft.com/office/drawing/2014/main" id="{5737C041-A37F-4430-B77F-6FA6618F166E}"/>
+                <a16:creationId xmlns:a16="http://schemas.microsoft.com/office/drawing/2014/main" id="{E8952A2C-3261-4C02-A315-2ACC996D1BF3}"/>
               </a:ext>
             </a:extLst>
           </p:cNvPr>
@@ -12289,7 +12287,7 @@
           <p:cNvPr id="27" name="">
             <a:extLst xmlns:a="http://schemas.openxmlformats.org/drawingml/2006/main">
               <a:ext uri="{FF2B5EF4-FFF2-40B4-BE49-F238E27FC236}">
-                <a16:creationId xmlns:a16="http://schemas.microsoft.com/office/drawing/2014/main" id="{14F87563-9631-4B45-A7F2-5306CAFEDE3D}"/>
+                <a16:creationId xmlns:a16="http://schemas.microsoft.com/office/drawing/2014/main" id="{C327C404-E21B-4996-8728-44C82F40E57F}"/>
               </a:ext>
             </a:extLst>
           </p:cNvPr>
@@ -12322,7 +12320,7 @@
           <p:cNvPr id="28" name="">
             <a:extLst xmlns:a="http://schemas.openxmlformats.org/drawingml/2006/main">
               <a:ext uri="{FF2B5EF4-FFF2-40B4-BE49-F238E27FC236}">
-                <a16:creationId xmlns:a16="http://schemas.microsoft.com/office/drawing/2014/main" id="{945FF476-3FA5-4773-815F-1862D112781F}"/>
+                <a16:creationId xmlns:a16="http://schemas.microsoft.com/office/drawing/2014/main" id="{3F1AC535-E828-421C-B3BF-804B4AAB4E1E}"/>
               </a:ext>
             </a:extLst>
           </p:cNvPr>
@@ -12355,7 +12353,7 @@
           <p:cNvPr id="29" name="">
             <a:extLst xmlns:a="http://schemas.openxmlformats.org/drawingml/2006/main">
               <a:ext uri="{FF2B5EF4-FFF2-40B4-BE49-F238E27FC236}">
-                <a16:creationId xmlns:a16="http://schemas.microsoft.com/office/drawing/2014/main" id="{31F5F32A-86EA-4E72-98CD-FD2877186A2E}"/>
+                <a16:creationId xmlns:a16="http://schemas.microsoft.com/office/drawing/2014/main" id="{0A5D4FBA-440E-4645-9CD4-3534997EE44A}"/>
               </a:ext>
             </a:extLst>
           </p:cNvPr>
@@ -12388,7 +12386,7 @@
           <p:cNvPr id="30" name="">
             <a:extLst xmlns:a="http://schemas.openxmlformats.org/drawingml/2006/main">
               <a:ext uri="{FF2B5EF4-FFF2-40B4-BE49-F238E27FC236}">
-                <a16:creationId xmlns:a16="http://schemas.microsoft.com/office/drawing/2014/main" id="{C5755324-5FD8-491F-9D05-8EE0B3E9011D}"/>
+                <a16:creationId xmlns:a16="http://schemas.microsoft.com/office/drawing/2014/main" id="{97746773-0BB3-44C1-A60C-4E93BE4685D3}"/>
               </a:ext>
             </a:extLst>
           </p:cNvPr>
@@ -12421,7 +12419,7 @@
           <p:cNvPr id="31" name="">
             <a:extLst xmlns:a="http://schemas.openxmlformats.org/drawingml/2006/main">
               <a:ext uri="{FF2B5EF4-FFF2-40B4-BE49-F238E27FC236}">
-                <a16:creationId xmlns:a16="http://schemas.microsoft.com/office/drawing/2014/main" id="{4704B868-7C84-4CD0-84B6-3233E5877589}"/>
+                <a16:creationId xmlns:a16="http://schemas.microsoft.com/office/drawing/2014/main" id="{8C8F5467-72CA-483F-B00C-12D726F51C26}"/>
               </a:ext>
             </a:extLst>
           </p:cNvPr>
@@ -12454,7 +12452,7 @@
           <p:cNvPr id="32" name="">
             <a:extLst xmlns:a="http://schemas.openxmlformats.org/drawingml/2006/main">
               <a:ext uri="{FF2B5EF4-FFF2-40B4-BE49-F238E27FC236}">
-                <a16:creationId xmlns:a16="http://schemas.microsoft.com/office/drawing/2014/main" id="{D2143338-3642-45A6-959B-4C987A564E94}"/>
+                <a16:creationId xmlns:a16="http://schemas.microsoft.com/office/drawing/2014/main" id="{8BA3303D-6D0C-4C9A-8EF7-3E18E70253A4}"/>
               </a:ext>
             </a:extLst>
           </p:cNvPr>
@@ -12487,7 +12485,7 @@
           <p:cNvPr id="33" name="">
             <a:extLst xmlns:a="http://schemas.openxmlformats.org/drawingml/2006/main">
               <a:ext uri="{FF2B5EF4-FFF2-40B4-BE49-F238E27FC236}">
-                <a16:creationId xmlns:a16="http://schemas.microsoft.com/office/drawing/2014/main" id="{88D5447F-FC68-4175-AD69-96ACCABA4A8A}"/>
+                <a16:creationId xmlns:a16="http://schemas.microsoft.com/office/drawing/2014/main" id="{C0CD4947-661E-4EC5-8577-B78402CFA74A}"/>
               </a:ext>
             </a:extLst>
           </p:cNvPr>
@@ -12570,7 +12568,7 @@
           <p:cNvPr id="36" name="">
             <a:extLst xmlns:a="http://schemas.openxmlformats.org/drawingml/2006/main">
               <a:ext uri="{FF2B5EF4-FFF2-40B4-BE49-F238E27FC236}">
-                <a16:creationId xmlns:a16="http://schemas.microsoft.com/office/drawing/2014/main" id="{ED036D62-4C73-4868-B8FF-B136F5E54741}"/>
+                <a16:creationId xmlns:a16="http://schemas.microsoft.com/office/drawing/2014/main" id="{CC627D14-F4B2-4274-8866-D88BC694819D}"/>
               </a:ext>
             </a:extLst>
           </p:cNvPr>
@@ -12603,7 +12601,7 @@
           <p:cNvPr id="37" name="">
             <a:extLst xmlns:a="http://schemas.openxmlformats.org/drawingml/2006/main">
               <a:ext uri="{FF2B5EF4-FFF2-40B4-BE49-F238E27FC236}">
-                <a16:creationId xmlns:a16="http://schemas.microsoft.com/office/drawing/2014/main" id="{37E4045F-CC8C-4C19-8F92-E9F81DD63E7E}"/>
+                <a16:creationId xmlns:a16="http://schemas.microsoft.com/office/drawing/2014/main" id="{3F879009-58BD-4727-ABB1-31C60B4DE1AC}"/>
               </a:ext>
             </a:extLst>
           </p:cNvPr>
@@ -12661,7 +12659,7 @@
           <p:cNvPr id="38" name="">
             <a:extLst xmlns:a="http://schemas.openxmlformats.org/drawingml/2006/main">
               <a:ext uri="{FF2B5EF4-FFF2-40B4-BE49-F238E27FC236}">
-                <a16:creationId xmlns:a16="http://schemas.microsoft.com/office/drawing/2014/main" id="{CC2859B7-01D2-4989-8F84-986B635CDD26}"/>
+                <a16:creationId xmlns:a16="http://schemas.microsoft.com/office/drawing/2014/main" id="{96FC2EE1-8EF9-40ED-B0FB-D4C1B897404B}"/>
               </a:ext>
             </a:extLst>
           </p:cNvPr>
@@ -12719,7 +12717,7 @@
           <p:cNvPr id="39" name="">
             <a:extLst xmlns:a="http://schemas.openxmlformats.org/drawingml/2006/main">
               <a:ext uri="{FF2B5EF4-FFF2-40B4-BE49-F238E27FC236}">
-                <a16:creationId xmlns:a16="http://schemas.microsoft.com/office/drawing/2014/main" id="{5D971506-9B14-46C8-80FE-0358AA47A3A0}"/>
+                <a16:creationId xmlns:a16="http://schemas.microsoft.com/office/drawing/2014/main" id="{446FB02C-AA92-4210-B951-0661E08D8BA0}"/>
               </a:ext>
             </a:extLst>
           </p:cNvPr>
@@ -12777,7 +12775,7 @@
           <p:cNvPr id="40" name="">
             <a:extLst xmlns:a="http://schemas.openxmlformats.org/drawingml/2006/main">
               <a:ext uri="{FF2B5EF4-FFF2-40B4-BE49-F238E27FC236}">
-                <a16:creationId xmlns:a16="http://schemas.microsoft.com/office/drawing/2014/main" id="{B5CE84FE-87AF-4EDB-9B0F-331B1898BFBA}"/>
+                <a16:creationId xmlns:a16="http://schemas.microsoft.com/office/drawing/2014/main" id="{A9F383E3-4744-4641-80EC-4175FF0FDCD7}"/>
               </a:ext>
             </a:extLst>
           </p:cNvPr>
@@ -12833,7 +12831,7 @@
     </p:spTree>
     <p:extLst>
       <p:ext uri="{BB962C8B-B14F-4D97-AF65-F5344CB8AC3E}">
-        <p14:creationId xmlns:p14="http://schemas.microsoft.com/office/powerpoint/2010/main" val="1097691391"/>
+        <p14:creationId xmlns:p14="http://schemas.microsoft.com/office/powerpoint/2010/main" val="1705801183"/>
       </p:ext>
     </p:extLst>
   </p:cSld>

</xml_diff>

<commit_message>
Refine presentation content and visuals: update terminology and clarify visual guidance
</commit_message>
<xml_diff>
--- a/.codex-build/presentation-visuals/candidate.pptx
+++ b/.codex-build/presentation-visuals/candidate.pptx
@@ -2,20 +2,20 @@
 <file path=ppt/presentation.xml><?xml version="1.0" encoding="utf-8"?>
 <p:presentation xmlns:p="http://schemas.openxmlformats.org/presentationml/2006/main">
   <p:sldMasterIdLst>
-    <p:sldMasterId xmlns:r="http://schemas.openxmlformats.org/officeDocument/2006/relationships" id="2147483648" r:id="Rd46b27ecbbd94a92"/>
+    <p:sldMasterId xmlns:r="http://schemas.openxmlformats.org/officeDocument/2006/relationships" id="2147483648" r:id="R4faf8983f4974186"/>
   </p:sldMasterIdLst>
   <p:notesMasterIdLst>
-    <p:notesMasterId xmlns:r="http://schemas.openxmlformats.org/officeDocument/2006/relationships" r:id="Reb63c760de5b41e8"/>
+    <p:notesMasterId xmlns:r="http://schemas.openxmlformats.org/officeDocument/2006/relationships" r:id="R468e7450726149d3"/>
   </p:notesMasterIdLst>
   <p:sldIdLst>
-    <p:sldId xmlns:r="http://schemas.openxmlformats.org/officeDocument/2006/relationships" id="256" r:id="Rd7a3c0ff76bd432c"/>
-    <p:sldId xmlns:r="http://schemas.openxmlformats.org/officeDocument/2006/relationships" id="257" r:id="R24525844922b49d9"/>
-    <p:sldId xmlns:r="http://schemas.openxmlformats.org/officeDocument/2006/relationships" id="258" r:id="R1f5ebbcddf644e84"/>
-    <p:sldId xmlns:r="http://schemas.openxmlformats.org/officeDocument/2006/relationships" id="259" r:id="R428175a7272144ec"/>
-    <p:sldId xmlns:r="http://schemas.openxmlformats.org/officeDocument/2006/relationships" id="260" r:id="Rad5a96ec54064dd4"/>
-    <p:sldId xmlns:r="http://schemas.openxmlformats.org/officeDocument/2006/relationships" id="261" r:id="Rfcadd324d2b34211"/>
-    <p:sldId xmlns:r="http://schemas.openxmlformats.org/officeDocument/2006/relationships" id="262" r:id="Rb95b1ac883154ad1"/>
-    <p:sldId xmlns:r="http://schemas.openxmlformats.org/officeDocument/2006/relationships" id="263" r:id="R10f962ce4f594be3"/>
+    <p:sldId xmlns:r="http://schemas.openxmlformats.org/officeDocument/2006/relationships" id="256" r:id="R831d3367a9ee4a48"/>
+    <p:sldId xmlns:r="http://schemas.openxmlformats.org/officeDocument/2006/relationships" id="257" r:id="R31777f90792a4675"/>
+    <p:sldId xmlns:r="http://schemas.openxmlformats.org/officeDocument/2006/relationships" id="258" r:id="R38299a90e5ff4066"/>
+    <p:sldId xmlns:r="http://schemas.openxmlformats.org/officeDocument/2006/relationships" id="259" r:id="Rdc4c490e5bd24e6a"/>
+    <p:sldId xmlns:r="http://schemas.openxmlformats.org/officeDocument/2006/relationships" id="260" r:id="Re5ef3f37d77242e3"/>
+    <p:sldId xmlns:r="http://schemas.openxmlformats.org/officeDocument/2006/relationships" id="261" r:id="R8e00c44baaf14e7f"/>
+    <p:sldId xmlns:r="http://schemas.openxmlformats.org/officeDocument/2006/relationships" id="262" r:id="Raaf10ab063744970"/>
+    <p:sldId xmlns:r="http://schemas.openxmlformats.org/officeDocument/2006/relationships" id="263" r:id="Rc67a2b5fc4844fda"/>
   </p:sldIdLst>
   <p:sldSz cx="12192000" cy="6858000"/>
   <p:notesSz cx="6858000" cy="9144000"/>
@@ -975,7 +975,7 @@
   </p:cSld>
   <p:clrMap bg1="lt1" tx1="dk1" bg2="lt2" tx2="dk2" accent1="accent1" accent2="accent2" accent3="accent3" accent4="accent4" accent5="accent5" accent6="accent6" hlink="hlink" folHlink="folHlink"/>
   <p:sldLayoutIdLst>
-    <p:sldLayoutId xmlns:r="http://schemas.openxmlformats.org/officeDocument/2006/relationships" id="2147483649" r:id="R3066184a8fba4c58"/>
+    <p:sldLayoutId xmlns:r="http://schemas.openxmlformats.org/officeDocument/2006/relationships" id="2147483649" r:id="R977c5c56637f4419"/>
   </p:sldLayoutIdLst>
   <p:txStyles>
     <p:titleStyle>
@@ -1526,7 +1526,7 @@
           <p:cNvPr id="29" name="">
             <a:extLst xmlns:a="http://schemas.openxmlformats.org/drawingml/2006/main">
               <a:ext uri="{FF2B5EF4-FFF2-40B4-BE49-F238E27FC236}">
-                <a16:creationId xmlns:a16="http://schemas.microsoft.com/office/drawing/2014/main" id="{11C95C42-946F-487A-B95A-325BE85137DB}"/>
+                <a16:creationId xmlns:a16="http://schemas.microsoft.com/office/drawing/2014/main" id="{8A32F8D7-006B-4C4F-BDE9-031E1CFB4383}"/>
               </a:ext>
             </a:extLst>
           </p:cNvPr>
@@ -1559,7 +1559,7 @@
           <p:cNvPr id="2" name="">
             <a:extLst xmlns:a="http://schemas.openxmlformats.org/drawingml/2006/main">
               <a:ext uri="{FF2B5EF4-FFF2-40B4-BE49-F238E27FC236}">
-                <a16:creationId xmlns:a16="http://schemas.microsoft.com/office/drawing/2014/main" id="{7D82F2AB-45BF-463B-9847-4BB2A7309F32}"/>
+                <a16:creationId xmlns:a16="http://schemas.microsoft.com/office/drawing/2014/main" id="{CD09EE97-6CED-42A4-8B18-554325418E87}"/>
               </a:ext>
             </a:extLst>
           </p:cNvPr>
@@ -1592,7 +1592,7 @@
           <p:cNvPr id="3" name="">
             <a:extLst xmlns:a="http://schemas.openxmlformats.org/drawingml/2006/main">
               <a:ext uri="{FF2B5EF4-FFF2-40B4-BE49-F238E27FC236}">
-                <a16:creationId xmlns:a16="http://schemas.microsoft.com/office/drawing/2014/main" id="{62870137-5732-4BBE-BC0E-EE6B1DF3E0BD}"/>
+                <a16:creationId xmlns:a16="http://schemas.microsoft.com/office/drawing/2014/main" id="{73990FC6-6969-4099-BB29-350F46CBB590}"/>
               </a:ext>
             </a:extLst>
           </p:cNvPr>
@@ -1625,7 +1625,7 @@
           <p:cNvPr id="4" name="">
             <a:extLst xmlns:a="http://schemas.openxmlformats.org/drawingml/2006/main">
               <a:ext uri="{FF2B5EF4-FFF2-40B4-BE49-F238E27FC236}">
-                <a16:creationId xmlns:a16="http://schemas.microsoft.com/office/drawing/2014/main" id="{E2DAF2C1-CCB9-4DE0-BC5C-28F07DCEB4C5}"/>
+                <a16:creationId xmlns:a16="http://schemas.microsoft.com/office/drawing/2014/main" id="{E60EFD57-EA05-4A9A-9312-AF04D7C45530}"/>
               </a:ext>
             </a:extLst>
           </p:cNvPr>
@@ -1658,7 +1658,7 @@
           <p:cNvPr id="5" name="">
             <a:extLst xmlns:a="http://schemas.openxmlformats.org/drawingml/2006/main">
               <a:ext uri="{FF2B5EF4-FFF2-40B4-BE49-F238E27FC236}">
-                <a16:creationId xmlns:a16="http://schemas.microsoft.com/office/drawing/2014/main" id="{67C213D9-8DB6-41E4-9700-8548B51A6AB5}"/>
+                <a16:creationId xmlns:a16="http://schemas.microsoft.com/office/drawing/2014/main" id="{6F5CEE48-0AB2-4C13-AA4A-BADAC064D376}"/>
               </a:ext>
             </a:extLst>
           </p:cNvPr>
@@ -1769,7 +1769,7 @@
           <p:cNvPr id="9" name="">
             <a:extLst xmlns:a="http://schemas.openxmlformats.org/drawingml/2006/main">
               <a:ext uri="{FF2B5EF4-FFF2-40B4-BE49-F238E27FC236}">
-                <a16:creationId xmlns:a16="http://schemas.microsoft.com/office/drawing/2014/main" id="{9E42E6E6-925B-4399-A7FF-294F314F72A5}"/>
+                <a16:creationId xmlns:a16="http://schemas.microsoft.com/office/drawing/2014/main" id="{AF7137EF-4718-46F3-9085-3D389915D5B6}"/>
               </a:ext>
             </a:extLst>
           </p:cNvPr>
@@ -1833,7 +1833,7 @@
           <p:cNvPr id="10" name="">
             <a:extLst xmlns:a="http://schemas.openxmlformats.org/drawingml/2006/main">
               <a:ext uri="{FF2B5EF4-FFF2-40B4-BE49-F238E27FC236}">
-                <a16:creationId xmlns:a16="http://schemas.microsoft.com/office/drawing/2014/main" id="{0BE2E47E-9D0B-4F50-A50F-3D2FE696F6A8}"/>
+                <a16:creationId xmlns:a16="http://schemas.microsoft.com/office/drawing/2014/main" id="{8454BA7C-717C-4F52-A527-E141DBADFA8E}"/>
               </a:ext>
             </a:extLst>
           </p:cNvPr>
@@ -1891,7 +1891,7 @@
           <p:cNvPr id="11" name="">
             <a:extLst xmlns:a="http://schemas.openxmlformats.org/drawingml/2006/main">
               <a:ext uri="{FF2B5EF4-FFF2-40B4-BE49-F238E27FC236}">
-                <a16:creationId xmlns:a16="http://schemas.microsoft.com/office/drawing/2014/main" id="{98803ECE-63B4-434E-B321-D027CE910B69}"/>
+                <a16:creationId xmlns:a16="http://schemas.microsoft.com/office/drawing/2014/main" id="{A426ED05-DD19-47D9-BE4B-6BDA7ADA43E1}"/>
               </a:ext>
             </a:extLst>
           </p:cNvPr>
@@ -1924,7 +1924,7 @@
           <p:cNvPr id="12" name="">
             <a:extLst xmlns:a="http://schemas.openxmlformats.org/drawingml/2006/main">
               <a:ext uri="{FF2B5EF4-FFF2-40B4-BE49-F238E27FC236}">
-                <a16:creationId xmlns:a16="http://schemas.microsoft.com/office/drawing/2014/main" id="{217F5523-9D24-4A8C-A33F-AA889EF32412}"/>
+                <a16:creationId xmlns:a16="http://schemas.microsoft.com/office/drawing/2014/main" id="{75CFBA0F-70CB-4841-B099-9A90D0AEEFC7}"/>
               </a:ext>
             </a:extLst>
           </p:cNvPr>
@@ -1982,7 +1982,7 @@
           <p:cNvPr id="13" name="">
             <a:extLst xmlns:a="http://schemas.openxmlformats.org/drawingml/2006/main">
               <a:ext uri="{FF2B5EF4-FFF2-40B4-BE49-F238E27FC236}">
-                <a16:creationId xmlns:a16="http://schemas.microsoft.com/office/drawing/2014/main" id="{DB1F46C8-B6D9-4B78-931F-FA785D38DA5A}"/>
+                <a16:creationId xmlns:a16="http://schemas.microsoft.com/office/drawing/2014/main" id="{D816C812-FB1C-4B32-8CA7-EA420F4F4494}"/>
               </a:ext>
             </a:extLst>
           </p:cNvPr>
@@ -2015,7 +2015,7 @@
           <p:cNvPr id="14" name="">
             <a:extLst xmlns:a="http://schemas.openxmlformats.org/drawingml/2006/main">
               <a:ext uri="{FF2B5EF4-FFF2-40B4-BE49-F238E27FC236}">
-                <a16:creationId xmlns:a16="http://schemas.microsoft.com/office/drawing/2014/main" id="{E260EF71-CC40-415A-AD21-EC74FDC64986}"/>
+                <a16:creationId xmlns:a16="http://schemas.microsoft.com/office/drawing/2014/main" id="{FD3B8A88-A554-4609-9D0A-A1101DCE5604}"/>
               </a:ext>
             </a:extLst>
           </p:cNvPr>
@@ -2073,7 +2073,7 @@
           <p:cNvPr id="15" name="">
             <a:extLst xmlns:a="http://schemas.openxmlformats.org/drawingml/2006/main">
               <a:ext uri="{FF2B5EF4-FFF2-40B4-BE49-F238E27FC236}">
-                <a16:creationId xmlns:a16="http://schemas.microsoft.com/office/drawing/2014/main" id="{966FF39B-7312-4650-992A-292B12B58AC3}"/>
+                <a16:creationId xmlns:a16="http://schemas.microsoft.com/office/drawing/2014/main" id="{62B1EAAA-B80D-4316-8D82-9DB290FCE740}"/>
               </a:ext>
             </a:extLst>
           </p:cNvPr>
@@ -2106,7 +2106,7 @@
           <p:cNvPr id="16" name="">
             <a:extLst xmlns:a="http://schemas.openxmlformats.org/drawingml/2006/main">
               <a:ext uri="{FF2B5EF4-FFF2-40B4-BE49-F238E27FC236}">
-                <a16:creationId xmlns:a16="http://schemas.microsoft.com/office/drawing/2014/main" id="{5524D2CB-AA23-4ECF-9428-95D80EC33046}"/>
+                <a16:creationId xmlns:a16="http://schemas.microsoft.com/office/drawing/2014/main" id="{79EA7464-DE90-4836-8684-43D1592D5814}"/>
               </a:ext>
             </a:extLst>
           </p:cNvPr>
@@ -2137,7 +2137,7 @@
           <p:cNvPr id="17" name="">
             <a:extLst xmlns:a="http://schemas.openxmlformats.org/drawingml/2006/main">
               <a:ext uri="{FF2B5EF4-FFF2-40B4-BE49-F238E27FC236}">
-                <a16:creationId xmlns:a16="http://schemas.microsoft.com/office/drawing/2014/main" id="{9CA7C3C3-7126-410D-A1E6-91D8D5FED066}"/>
+                <a16:creationId xmlns:a16="http://schemas.microsoft.com/office/drawing/2014/main" id="{DF792A13-C279-4EBD-9BD8-99198EA7B551}"/>
               </a:ext>
             </a:extLst>
           </p:cNvPr>
@@ -2195,7 +2195,7 @@
           <p:cNvPr id="18" name="">
             <a:extLst xmlns:a="http://schemas.openxmlformats.org/drawingml/2006/main">
               <a:ext uri="{FF2B5EF4-FFF2-40B4-BE49-F238E27FC236}">
-                <a16:creationId xmlns:a16="http://schemas.microsoft.com/office/drawing/2014/main" id="{76821C26-D28A-4B72-975B-817EC6630EB1}"/>
+                <a16:creationId xmlns:a16="http://schemas.microsoft.com/office/drawing/2014/main" id="{B6E77EAC-9E81-48C5-854F-E6ABEFACAD74}"/>
               </a:ext>
             </a:extLst>
           </p:cNvPr>
@@ -2228,7 +2228,7 @@
           <p:cNvPr id="19" name="">
             <a:extLst xmlns:a="http://schemas.openxmlformats.org/drawingml/2006/main">
               <a:ext uri="{FF2B5EF4-FFF2-40B4-BE49-F238E27FC236}">
-                <a16:creationId xmlns:a16="http://schemas.microsoft.com/office/drawing/2014/main" id="{4BC65BB9-BE8A-44E5-99C4-E04603CBD244}"/>
+                <a16:creationId xmlns:a16="http://schemas.microsoft.com/office/drawing/2014/main" id="{DDA39622-C1D9-404A-9479-7B78AED75A0E}"/>
               </a:ext>
             </a:extLst>
           </p:cNvPr>
@@ -2364,7 +2364,7 @@
           <p:cNvPr id="23" name="">
             <a:extLst xmlns:a="http://schemas.openxmlformats.org/drawingml/2006/main">
               <a:ext uri="{FF2B5EF4-FFF2-40B4-BE49-F238E27FC236}">
-                <a16:creationId xmlns:a16="http://schemas.microsoft.com/office/drawing/2014/main" id="{0494A262-C550-43A2-87C5-54EA90ACA155}"/>
+                <a16:creationId xmlns:a16="http://schemas.microsoft.com/office/drawing/2014/main" id="{9A9127A8-392F-4CC6-93AF-A5A96AB6EE6F}"/>
               </a:ext>
             </a:extLst>
           </p:cNvPr>
@@ -2422,7 +2422,7 @@
           <p:cNvPr id="24" name="">
             <a:extLst xmlns:a="http://schemas.openxmlformats.org/drawingml/2006/main">
               <a:ext uri="{FF2B5EF4-FFF2-40B4-BE49-F238E27FC236}">
-                <a16:creationId xmlns:a16="http://schemas.microsoft.com/office/drawing/2014/main" id="{4F7A3E9F-D5F1-4925-91FD-59EF5016ED9D}"/>
+                <a16:creationId xmlns:a16="http://schemas.microsoft.com/office/drawing/2014/main" id="{3B97A693-6159-40FB-B784-13484CE0AE92}"/>
               </a:ext>
             </a:extLst>
           </p:cNvPr>
@@ -2480,7 +2480,7 @@
           <p:cNvPr id="25" name="">
             <a:extLst xmlns:a="http://schemas.openxmlformats.org/drawingml/2006/main">
               <a:ext uri="{FF2B5EF4-FFF2-40B4-BE49-F238E27FC236}">
-                <a16:creationId xmlns:a16="http://schemas.microsoft.com/office/drawing/2014/main" id="{91908946-7BFE-4957-922D-B46DA8C0F47D}"/>
+                <a16:creationId xmlns:a16="http://schemas.microsoft.com/office/drawing/2014/main" id="{348C26BD-0A8E-4945-B844-E46995028FA3}"/>
               </a:ext>
             </a:extLst>
           </p:cNvPr>
@@ -2538,7 +2538,7 @@
           <p:cNvPr id="26" name="">
             <a:extLst xmlns:a="http://schemas.openxmlformats.org/drawingml/2006/main">
               <a:ext uri="{FF2B5EF4-FFF2-40B4-BE49-F238E27FC236}">
-                <a16:creationId xmlns:a16="http://schemas.microsoft.com/office/drawing/2014/main" id="{74A2C6C4-BAC9-4EA3-B782-29792FD7A47D}"/>
+                <a16:creationId xmlns:a16="http://schemas.microsoft.com/office/drawing/2014/main" id="{0211E56F-B8BC-4E80-AEFB-91EF75E8374B}"/>
               </a:ext>
             </a:extLst>
           </p:cNvPr>
@@ -2596,7 +2596,7 @@
           <p:cNvPr id="27" name="">
             <a:extLst xmlns:a="http://schemas.openxmlformats.org/drawingml/2006/main">
               <a:ext uri="{FF2B5EF4-FFF2-40B4-BE49-F238E27FC236}">
-                <a16:creationId xmlns:a16="http://schemas.microsoft.com/office/drawing/2014/main" id="{7DC0A2DD-E135-4ECF-9587-D9E259326858}"/>
+                <a16:creationId xmlns:a16="http://schemas.microsoft.com/office/drawing/2014/main" id="{EA989CF0-9F00-4957-AD7D-1A9FF7B9B5C4}"/>
               </a:ext>
             </a:extLst>
           </p:cNvPr>
@@ -2654,7 +2654,7 @@
           <p:cNvPr id="28" name="">
             <a:extLst xmlns:a="http://schemas.openxmlformats.org/drawingml/2006/main">
               <a:ext uri="{FF2B5EF4-FFF2-40B4-BE49-F238E27FC236}">
-                <a16:creationId xmlns:a16="http://schemas.microsoft.com/office/drawing/2014/main" id="{0948A6EB-6C58-4ECD-872B-5737FE30FF5E}"/>
+                <a16:creationId xmlns:a16="http://schemas.microsoft.com/office/drawing/2014/main" id="{BBA9D2BD-D71C-4D2C-8EC7-36012125B261}"/>
               </a:ext>
             </a:extLst>
           </p:cNvPr>
@@ -2710,7 +2710,7 @@
     </p:spTree>
     <p:extLst>
       <p:ext uri="{BB962C8B-B14F-4D97-AF65-F5344CB8AC3E}">
-        <p14:creationId xmlns:p14="http://schemas.microsoft.com/office/powerpoint/2010/main" val="444706214"/>
+        <p14:creationId xmlns:p14="http://schemas.microsoft.com/office/powerpoint/2010/main" val="743495473"/>
       </p:ext>
     </p:extLst>
   </p:cSld>
@@ -2741,7 +2741,7 @@
           <p:cNvPr id="42" name="">
             <a:extLst xmlns:a="http://schemas.openxmlformats.org/drawingml/2006/main">
               <a:ext uri="{FF2B5EF4-FFF2-40B4-BE49-F238E27FC236}">
-                <a16:creationId xmlns:a16="http://schemas.microsoft.com/office/drawing/2014/main" id="{A9506719-1A35-448E-96AC-2079E9B47F29}"/>
+                <a16:creationId xmlns:a16="http://schemas.microsoft.com/office/drawing/2014/main" id="{2DDABA41-05CE-42EE-AAD5-7829C388F73E}"/>
               </a:ext>
             </a:extLst>
           </p:cNvPr>
@@ -2774,7 +2774,7 @@
           <p:cNvPr id="2" name="">
             <a:extLst xmlns:a="http://schemas.openxmlformats.org/drawingml/2006/main">
               <a:ext uri="{FF2B5EF4-FFF2-40B4-BE49-F238E27FC236}">
-                <a16:creationId xmlns:a16="http://schemas.microsoft.com/office/drawing/2014/main" id="{7B48A253-3E09-4A73-94C4-7108B13FE151}"/>
+                <a16:creationId xmlns:a16="http://schemas.microsoft.com/office/drawing/2014/main" id="{AC476AC3-F430-4773-BB2D-A1751EA67BF3}"/>
               </a:ext>
             </a:extLst>
           </p:cNvPr>
@@ -2807,7 +2807,7 @@
           <p:cNvPr id="3" name="">
             <a:extLst xmlns:a="http://schemas.openxmlformats.org/drawingml/2006/main">
               <a:ext uri="{FF2B5EF4-FFF2-40B4-BE49-F238E27FC236}">
-                <a16:creationId xmlns:a16="http://schemas.microsoft.com/office/drawing/2014/main" id="{56EBF4A2-5D34-4B7B-9165-5DF48004B532}"/>
+                <a16:creationId xmlns:a16="http://schemas.microsoft.com/office/drawing/2014/main" id="{8D418523-2CDA-4F02-9D02-9518207E7A29}"/>
               </a:ext>
             </a:extLst>
           </p:cNvPr>
@@ -2840,7 +2840,7 @@
           <p:cNvPr id="4" name="">
             <a:extLst xmlns:a="http://schemas.openxmlformats.org/drawingml/2006/main">
               <a:ext uri="{FF2B5EF4-FFF2-40B4-BE49-F238E27FC236}">
-                <a16:creationId xmlns:a16="http://schemas.microsoft.com/office/drawing/2014/main" id="{7DFD148C-BAA3-4253-B6E6-2E0D5815CFDE}"/>
+                <a16:creationId xmlns:a16="http://schemas.microsoft.com/office/drawing/2014/main" id="{9E217D3F-0426-42A4-8CE5-FC6BF867DDAA}"/>
               </a:ext>
             </a:extLst>
           </p:cNvPr>
@@ -2951,7 +2951,7 @@
           <p:cNvPr id="8" name="">
             <a:extLst xmlns:a="http://schemas.openxmlformats.org/drawingml/2006/main">
               <a:ext uri="{FF2B5EF4-FFF2-40B4-BE49-F238E27FC236}">
-                <a16:creationId xmlns:a16="http://schemas.microsoft.com/office/drawing/2014/main" id="{F9CF5272-895E-466F-B459-EA0EFE8EE744}"/>
+                <a16:creationId xmlns:a16="http://schemas.microsoft.com/office/drawing/2014/main" id="{9E5110BF-92C1-4B31-BB64-B2ED0F8DCACE}"/>
               </a:ext>
             </a:extLst>
           </p:cNvPr>
@@ -2984,7 +2984,7 @@
           <p:cNvPr id="9" name="">
             <a:extLst xmlns:a="http://schemas.openxmlformats.org/drawingml/2006/main">
               <a:ext uri="{FF2B5EF4-FFF2-40B4-BE49-F238E27FC236}">
-                <a16:creationId xmlns:a16="http://schemas.microsoft.com/office/drawing/2014/main" id="{60E705A4-AC6D-4670-B18C-A6EA15CB9D07}"/>
+                <a16:creationId xmlns:a16="http://schemas.microsoft.com/office/drawing/2014/main" id="{26FDC8B1-AD28-4D0B-BA92-028CF49D79A7}"/>
               </a:ext>
             </a:extLst>
           </p:cNvPr>
@@ -3017,7 +3017,7 @@
           <p:cNvPr id="10" name="">
             <a:extLst xmlns:a="http://schemas.openxmlformats.org/drawingml/2006/main">
               <a:ext uri="{FF2B5EF4-FFF2-40B4-BE49-F238E27FC236}">
-                <a16:creationId xmlns:a16="http://schemas.microsoft.com/office/drawing/2014/main" id="{A1F1B38C-6B1A-4631-88DC-6275F60AE495}"/>
+                <a16:creationId xmlns:a16="http://schemas.microsoft.com/office/drawing/2014/main" id="{7AA3F276-E586-473B-BE1E-E98B284059E9}"/>
               </a:ext>
             </a:extLst>
           </p:cNvPr>
@@ -3050,7 +3050,7 @@
           <p:cNvPr id="11" name="">
             <a:extLst xmlns:a="http://schemas.openxmlformats.org/drawingml/2006/main">
               <a:ext uri="{FF2B5EF4-FFF2-40B4-BE49-F238E27FC236}">
-                <a16:creationId xmlns:a16="http://schemas.microsoft.com/office/drawing/2014/main" id="{5D18DA3B-8EDF-4C37-A175-D96C18BA4C33}"/>
+                <a16:creationId xmlns:a16="http://schemas.microsoft.com/office/drawing/2014/main" id="{A0F88ABF-2D14-4F76-B2A1-FBCD3B8A2FFC}"/>
               </a:ext>
             </a:extLst>
           </p:cNvPr>
@@ -3161,7 +3161,7 @@
           <p:cNvPr id="15" name="">
             <a:extLst xmlns:a="http://schemas.openxmlformats.org/drawingml/2006/main">
               <a:ext uri="{FF2B5EF4-FFF2-40B4-BE49-F238E27FC236}">
-                <a16:creationId xmlns:a16="http://schemas.microsoft.com/office/drawing/2014/main" id="{C5F6588D-0D4F-4BE3-9C56-E4109B0DCC56}"/>
+                <a16:creationId xmlns:a16="http://schemas.microsoft.com/office/drawing/2014/main" id="{2D4B92E1-7238-4AC3-A107-036703A3E2BB}"/>
               </a:ext>
             </a:extLst>
           </p:cNvPr>
@@ -3194,7 +3194,7 @@
           <p:cNvPr id="16" name="">
             <a:extLst xmlns:a="http://schemas.openxmlformats.org/drawingml/2006/main">
               <a:ext uri="{FF2B5EF4-FFF2-40B4-BE49-F238E27FC236}">
-                <a16:creationId xmlns:a16="http://schemas.microsoft.com/office/drawing/2014/main" id="{866BAC63-2613-424B-8B77-197B0BBFFF57}"/>
+                <a16:creationId xmlns:a16="http://schemas.microsoft.com/office/drawing/2014/main" id="{552B3213-747C-43C8-8CE9-6B6D83056FA9}"/>
               </a:ext>
             </a:extLst>
           </p:cNvPr>
@@ -3253,7 +3253,7 @@
           <p:cNvPr id="18" name="">
             <a:extLst xmlns:a="http://schemas.openxmlformats.org/drawingml/2006/main">
               <a:ext uri="{FF2B5EF4-FFF2-40B4-BE49-F238E27FC236}">
-                <a16:creationId xmlns:a16="http://schemas.microsoft.com/office/drawing/2014/main" id="{171E2545-F8BF-4C31-8CD6-5E7FA621C760}"/>
+                <a16:creationId xmlns:a16="http://schemas.microsoft.com/office/drawing/2014/main" id="{1D613D49-0DAE-48FE-8887-45850233F5DB}"/>
               </a:ext>
             </a:extLst>
           </p:cNvPr>
@@ -3312,7 +3312,7 @@
           <p:cNvPr id="20" name="">
             <a:extLst xmlns:a="http://schemas.openxmlformats.org/drawingml/2006/main">
               <a:ext uri="{FF2B5EF4-FFF2-40B4-BE49-F238E27FC236}">
-                <a16:creationId xmlns:a16="http://schemas.microsoft.com/office/drawing/2014/main" id="{466ED26F-97F6-4D0B-BD9D-2129265E6C65}"/>
+                <a16:creationId xmlns:a16="http://schemas.microsoft.com/office/drawing/2014/main" id="{2A5BCB1D-70C1-4D82-BC38-667BC9069FE5}"/>
               </a:ext>
             </a:extLst>
           </p:cNvPr>
@@ -3371,7 +3371,7 @@
           <p:cNvPr id="22" name="">
             <a:extLst xmlns:a="http://schemas.openxmlformats.org/drawingml/2006/main">
               <a:ext uri="{FF2B5EF4-FFF2-40B4-BE49-F238E27FC236}">
-                <a16:creationId xmlns:a16="http://schemas.microsoft.com/office/drawing/2014/main" id="{D4AD3DF8-D772-41D2-A912-C957F4B75249}"/>
+                <a16:creationId xmlns:a16="http://schemas.microsoft.com/office/drawing/2014/main" id="{6013204C-0EB3-4F3C-B466-CC3DE1932D98}"/>
               </a:ext>
             </a:extLst>
           </p:cNvPr>
@@ -3435,7 +3435,7 @@
           <p:cNvPr id="23" name="">
             <a:extLst xmlns:a="http://schemas.openxmlformats.org/drawingml/2006/main">
               <a:ext uri="{FF2B5EF4-FFF2-40B4-BE49-F238E27FC236}">
-                <a16:creationId xmlns:a16="http://schemas.microsoft.com/office/drawing/2014/main" id="{6A20FD47-E0FF-48EA-AD6E-353C0695BBA9}"/>
+                <a16:creationId xmlns:a16="http://schemas.microsoft.com/office/drawing/2014/main" id="{3DCF2D5B-4E40-407B-99D1-8B6AAD3CE61F}"/>
               </a:ext>
             </a:extLst>
           </p:cNvPr>
@@ -3551,7 +3551,7 @@
           <p:cNvPr id="26" name="">
             <a:extLst xmlns:a="http://schemas.openxmlformats.org/drawingml/2006/main">
               <a:ext uri="{FF2B5EF4-FFF2-40B4-BE49-F238E27FC236}">
-                <a16:creationId xmlns:a16="http://schemas.microsoft.com/office/drawing/2014/main" id="{2ECF2DAD-7C95-4C70-9CF6-C658B98D8688}"/>
+                <a16:creationId xmlns:a16="http://schemas.microsoft.com/office/drawing/2014/main" id="{17DE9755-AEAF-4C95-8301-A57D12830627}"/>
               </a:ext>
             </a:extLst>
           </p:cNvPr>
@@ -3584,7 +3584,7 @@
           <p:cNvPr id="27" name="">
             <a:extLst xmlns:a="http://schemas.openxmlformats.org/drawingml/2006/main">
               <a:ext uri="{FF2B5EF4-FFF2-40B4-BE49-F238E27FC236}">
-                <a16:creationId xmlns:a16="http://schemas.microsoft.com/office/drawing/2014/main" id="{74D95959-6854-4BEE-B33E-CC74A037CC7F}"/>
+                <a16:creationId xmlns:a16="http://schemas.microsoft.com/office/drawing/2014/main" id="{A0982E78-970A-4419-872A-2E0C5DF2F8C4}"/>
               </a:ext>
             </a:extLst>
           </p:cNvPr>
@@ -3617,7 +3617,7 @@
           <p:cNvPr id="28" name="">
             <a:extLst xmlns:a="http://schemas.openxmlformats.org/drawingml/2006/main">
               <a:ext uri="{FF2B5EF4-FFF2-40B4-BE49-F238E27FC236}">
-                <a16:creationId xmlns:a16="http://schemas.microsoft.com/office/drawing/2014/main" id="{F93F37AF-0BEF-443F-905B-2F02EC71498E}"/>
+                <a16:creationId xmlns:a16="http://schemas.microsoft.com/office/drawing/2014/main" id="{190885C0-80D1-4AFE-901B-51E104554384}"/>
               </a:ext>
             </a:extLst>
           </p:cNvPr>
@@ -3650,7 +3650,7 @@
           <p:cNvPr id="29" name="">
             <a:extLst xmlns:a="http://schemas.openxmlformats.org/drawingml/2006/main">
               <a:ext uri="{FF2B5EF4-FFF2-40B4-BE49-F238E27FC236}">
-                <a16:creationId xmlns:a16="http://schemas.microsoft.com/office/drawing/2014/main" id="{3C259C46-2388-4732-8495-653D302A4982}"/>
+                <a16:creationId xmlns:a16="http://schemas.microsoft.com/office/drawing/2014/main" id="{46927E05-28E3-42FD-B840-275BD690784D}"/>
               </a:ext>
             </a:extLst>
           </p:cNvPr>
@@ -3683,7 +3683,7 @@
           <p:cNvPr id="30" name="">
             <a:extLst xmlns:a="http://schemas.openxmlformats.org/drawingml/2006/main">
               <a:ext uri="{FF2B5EF4-FFF2-40B4-BE49-F238E27FC236}">
-                <a16:creationId xmlns:a16="http://schemas.microsoft.com/office/drawing/2014/main" id="{F5A9EBBA-2F37-4CD6-92DF-A3E173978DB5}"/>
+                <a16:creationId xmlns:a16="http://schemas.microsoft.com/office/drawing/2014/main" id="{1AFB5180-60DD-4521-822D-81D6B07B0AC3}"/>
               </a:ext>
             </a:extLst>
           </p:cNvPr>
@@ -3792,7 +3792,7 @@
           <p:cNvPr id="34" name="">
             <a:extLst xmlns:a="http://schemas.openxmlformats.org/drawingml/2006/main">
               <a:ext uri="{FF2B5EF4-FFF2-40B4-BE49-F238E27FC236}">
-                <a16:creationId xmlns:a16="http://schemas.microsoft.com/office/drawing/2014/main" id="{3E95765A-B05A-4974-B7BC-E6744D915A66}"/>
+                <a16:creationId xmlns:a16="http://schemas.microsoft.com/office/drawing/2014/main" id="{C1BE01C1-36D8-4172-B9A9-8A82EEC50676}"/>
               </a:ext>
             </a:extLst>
           </p:cNvPr>
@@ -3873,7 +3873,7 @@
           <p:cNvPr id="35" name="">
             <a:extLst xmlns:a="http://schemas.openxmlformats.org/drawingml/2006/main">
               <a:ext uri="{FF2B5EF4-FFF2-40B4-BE49-F238E27FC236}">
-                <a16:creationId xmlns:a16="http://schemas.microsoft.com/office/drawing/2014/main" id="{C2B29594-AF5F-4C32-B23B-544FFDB9AF70}"/>
+                <a16:creationId xmlns:a16="http://schemas.microsoft.com/office/drawing/2014/main" id="{63DB2E95-F86F-43AF-8836-0C4967D8F961}"/>
               </a:ext>
             </a:extLst>
           </p:cNvPr>
@@ -3931,7 +3931,7 @@
           <p:cNvPr id="36" name="">
             <a:extLst xmlns:a="http://schemas.openxmlformats.org/drawingml/2006/main">
               <a:ext uri="{FF2B5EF4-FFF2-40B4-BE49-F238E27FC236}">
-                <a16:creationId xmlns:a16="http://schemas.microsoft.com/office/drawing/2014/main" id="{B5D11F0F-F7E4-4582-95C4-909800EAB30E}"/>
+                <a16:creationId xmlns:a16="http://schemas.microsoft.com/office/drawing/2014/main" id="{4466D7B8-5884-4657-8D95-03EDB69B26CC}"/>
               </a:ext>
             </a:extLst>
           </p:cNvPr>
@@ -4012,7 +4012,7 @@
           <p:cNvPr id="37" name="">
             <a:extLst xmlns:a="http://schemas.openxmlformats.org/drawingml/2006/main">
               <a:ext uri="{FF2B5EF4-FFF2-40B4-BE49-F238E27FC236}">
-                <a16:creationId xmlns:a16="http://schemas.microsoft.com/office/drawing/2014/main" id="{0AABA3C5-ED4B-4A98-A303-D2B5BA7C25FB}"/>
+                <a16:creationId xmlns:a16="http://schemas.microsoft.com/office/drawing/2014/main" id="{0CB86AA1-35C8-43A6-9B5E-DE7D9729081E}"/>
               </a:ext>
             </a:extLst>
           </p:cNvPr>
@@ -4093,7 +4093,7 @@
           <p:cNvPr id="38" name="">
             <a:extLst xmlns:a="http://schemas.openxmlformats.org/drawingml/2006/main">
               <a:ext uri="{FF2B5EF4-FFF2-40B4-BE49-F238E27FC236}">
-                <a16:creationId xmlns:a16="http://schemas.microsoft.com/office/drawing/2014/main" id="{54169353-5E37-45CB-831A-050407FA536B}"/>
+                <a16:creationId xmlns:a16="http://schemas.microsoft.com/office/drawing/2014/main" id="{7B0AC71B-A22E-4684-B54A-9A9727B57A96}"/>
               </a:ext>
             </a:extLst>
           </p:cNvPr>
@@ -4174,7 +4174,7 @@
           <p:cNvPr id="39" name="">
             <a:extLst xmlns:a="http://schemas.openxmlformats.org/drawingml/2006/main">
               <a:ext uri="{FF2B5EF4-FFF2-40B4-BE49-F238E27FC236}">
-                <a16:creationId xmlns:a16="http://schemas.microsoft.com/office/drawing/2014/main" id="{7333E925-7ABB-4A20-AC85-0C3CD237B4AB}"/>
+                <a16:creationId xmlns:a16="http://schemas.microsoft.com/office/drawing/2014/main" id="{8407AC44-5682-42C6-82CA-EBA45D00DDF1}"/>
               </a:ext>
             </a:extLst>
           </p:cNvPr>
@@ -4232,7 +4232,7 @@
           <p:cNvPr id="40" name="">
             <a:extLst xmlns:a="http://schemas.openxmlformats.org/drawingml/2006/main">
               <a:ext uri="{FF2B5EF4-FFF2-40B4-BE49-F238E27FC236}">
-                <a16:creationId xmlns:a16="http://schemas.microsoft.com/office/drawing/2014/main" id="{0F6F0993-130B-4E3E-9AC1-F4FBE8D19B9B}"/>
+                <a16:creationId xmlns:a16="http://schemas.microsoft.com/office/drawing/2014/main" id="{3EF36DB9-C056-467C-ADAD-D4B0AB2714D0}"/>
               </a:ext>
             </a:extLst>
           </p:cNvPr>
@@ -4313,7 +4313,7 @@
           <p:cNvPr id="41" name="">
             <a:extLst xmlns:a="http://schemas.openxmlformats.org/drawingml/2006/main">
               <a:ext uri="{FF2B5EF4-FFF2-40B4-BE49-F238E27FC236}">
-                <a16:creationId xmlns:a16="http://schemas.microsoft.com/office/drawing/2014/main" id="{828A5806-F6C1-466B-B06F-ABF961E0F6AD}"/>
+                <a16:creationId xmlns:a16="http://schemas.microsoft.com/office/drawing/2014/main" id="{E7499737-C441-49F5-87E6-915AC019869D}"/>
               </a:ext>
             </a:extLst>
           </p:cNvPr>
@@ -4369,7 +4369,7 @@
     </p:spTree>
     <p:extLst>
       <p:ext uri="{BB962C8B-B14F-4D97-AF65-F5344CB8AC3E}">
-        <p14:creationId xmlns:p14="http://schemas.microsoft.com/office/powerpoint/2010/main" val="1890323679"/>
+        <p14:creationId xmlns:p14="http://schemas.microsoft.com/office/powerpoint/2010/main" val="1180627694"/>
       </p:ext>
     </p:extLst>
   </p:cSld>
@@ -4400,7 +4400,7 @@
           <p:cNvPr id="41" name="">
             <a:extLst xmlns:a="http://schemas.openxmlformats.org/drawingml/2006/main">
               <a:ext uri="{FF2B5EF4-FFF2-40B4-BE49-F238E27FC236}">
-                <a16:creationId xmlns:a16="http://schemas.microsoft.com/office/drawing/2014/main" id="{CA29AC96-4C46-40C1-A8DF-4261A0C9C749}"/>
+                <a16:creationId xmlns:a16="http://schemas.microsoft.com/office/drawing/2014/main" id="{B2EE9D36-97D9-4DA7-A0BC-069BE78EB1EC}"/>
               </a:ext>
             </a:extLst>
           </p:cNvPr>
@@ -4458,7 +4458,7 @@
           <p:cNvPr id="2" name="">
             <a:extLst xmlns:a="http://schemas.openxmlformats.org/drawingml/2006/main">
               <a:ext uri="{FF2B5EF4-FFF2-40B4-BE49-F238E27FC236}">
-                <a16:creationId xmlns:a16="http://schemas.microsoft.com/office/drawing/2014/main" id="{A9924616-AD83-41D4-844D-8C734B3DCFFE}"/>
+                <a16:creationId xmlns:a16="http://schemas.microsoft.com/office/drawing/2014/main" id="{DC20B30D-249E-466E-B454-7AD05D33B0DA}"/>
               </a:ext>
             </a:extLst>
           </p:cNvPr>
@@ -4516,7 +4516,7 @@
           <p:cNvPr id="3" name="">
             <a:extLst xmlns:a="http://schemas.openxmlformats.org/drawingml/2006/main">
               <a:ext uri="{FF2B5EF4-FFF2-40B4-BE49-F238E27FC236}">
-                <a16:creationId xmlns:a16="http://schemas.microsoft.com/office/drawing/2014/main" id="{54464880-811F-4FD6-9BBD-3287F4253753}"/>
+                <a16:creationId xmlns:a16="http://schemas.microsoft.com/office/drawing/2014/main" id="{117CD5A8-D7FF-4AFB-A2E5-6E7BCEB49319}"/>
               </a:ext>
             </a:extLst>
           </p:cNvPr>
@@ -4547,7 +4547,7 @@
           <p:cNvPr id="4" name="">
             <a:extLst xmlns:a="http://schemas.openxmlformats.org/drawingml/2006/main">
               <a:ext uri="{FF2B5EF4-FFF2-40B4-BE49-F238E27FC236}">
-                <a16:creationId xmlns:a16="http://schemas.microsoft.com/office/drawing/2014/main" id="{B607D659-55A1-42FC-8AFB-AF9B76A505AB}"/>
+                <a16:creationId xmlns:a16="http://schemas.microsoft.com/office/drawing/2014/main" id="{E7C2EFC1-A75D-4790-AB34-0E09C45DFE9F}"/>
               </a:ext>
             </a:extLst>
           </p:cNvPr>
@@ -4611,7 +4611,7 @@
           <p:cNvPr id="5" name="">
             <a:extLst xmlns:a="http://schemas.openxmlformats.org/drawingml/2006/main">
               <a:ext uri="{FF2B5EF4-FFF2-40B4-BE49-F238E27FC236}">
-                <a16:creationId xmlns:a16="http://schemas.microsoft.com/office/drawing/2014/main" id="{4CD43749-E146-4A67-AF24-BE784D1CDA5B}"/>
+                <a16:creationId xmlns:a16="http://schemas.microsoft.com/office/drawing/2014/main" id="{AD8EB18F-9C20-46F6-AFD1-E067E7B5A98B}"/>
               </a:ext>
             </a:extLst>
           </p:cNvPr>
@@ -4701,7 +4701,7 @@
           <p:cNvPr id="7" name="">
             <a:extLst xmlns:a="http://schemas.openxmlformats.org/drawingml/2006/main">
               <a:ext uri="{FF2B5EF4-FFF2-40B4-BE49-F238E27FC236}">
-                <a16:creationId xmlns:a16="http://schemas.microsoft.com/office/drawing/2014/main" id="{C20AFFE9-BD21-471D-9112-92A1A6359ADE}"/>
+                <a16:creationId xmlns:a16="http://schemas.microsoft.com/office/drawing/2014/main" id="{33893BE6-3421-4FD6-B83F-2637E14D333F}"/>
               </a:ext>
             </a:extLst>
           </p:cNvPr>
@@ -4734,7 +4734,7 @@
           <p:cNvPr id="8" name="">
             <a:extLst xmlns:a="http://schemas.openxmlformats.org/drawingml/2006/main">
               <a:ext uri="{FF2B5EF4-FFF2-40B4-BE49-F238E27FC236}">
-                <a16:creationId xmlns:a16="http://schemas.microsoft.com/office/drawing/2014/main" id="{74B8C956-9CCA-4531-AB5B-2852E9722D1B}"/>
+                <a16:creationId xmlns:a16="http://schemas.microsoft.com/office/drawing/2014/main" id="{910EE2DA-A379-41DB-AE63-8E58BF48D6C1}"/>
               </a:ext>
             </a:extLst>
           </p:cNvPr>
@@ -4793,23 +4793,23 @@
           <p:cNvPr id="10" name="">
             <a:extLst xmlns:a="http://schemas.openxmlformats.org/drawingml/2006/main">
               <a:ext uri="{FF2B5EF4-FFF2-40B4-BE49-F238E27FC236}">
-                <a16:creationId xmlns:a16="http://schemas.microsoft.com/office/drawing/2014/main" id="{29D5A2B7-91F6-4EC9-B9AA-7B86EAE0DB70}"/>
-              </a:ext>
-            </a:extLst>
-          </p:cNvPr>
-          <p:cNvSpPr>
-            <a:spLocks xmlns:a="http://schemas.openxmlformats.org/drawingml/2006/main" noGrp="1"/>
-          </p:cNvSpPr>
-          <p:nvPr/>
-        </p:nvSpPr>
-        <p:spPr>
-          <a:xfrm xmlns:a="http://schemas.openxmlformats.org/drawingml/2006/main">
-            <a:off x="2095500" y="2028825"/>
-            <a:ext cx="457200" cy="285750"/>
+                <a16:creationId xmlns:a16="http://schemas.microsoft.com/office/drawing/2014/main" id="{A558D522-0944-4814-8BA2-D64A657F9477}"/>
+              </a:ext>
+            </a:extLst>
+          </p:cNvPr>
+          <p:cNvSpPr>
+            <a:spLocks xmlns:a="http://schemas.openxmlformats.org/drawingml/2006/main" noGrp="1"/>
+          </p:cNvSpPr>
+          <p:nvPr/>
+        </p:nvSpPr>
+        <p:spPr>
+          <a:xfrm xmlns:a="http://schemas.openxmlformats.org/drawingml/2006/main">
+            <a:off x="2318027" y="2408307"/>
+            <a:ext cx="457200" cy="304800"/>
           </a:xfrm>
           <a:prstGeom xmlns:a="http://schemas.openxmlformats.org/drawingml/2006/main" prst="roundRect">
             <a:avLst>
-              <a:gd name="adj" fmla="val 13333"/>
+              <a:gd name="adj" fmla="val 9375"/>
             </a:avLst>
           </a:prstGeom>
           <a:solidFill xmlns:a="http://schemas.openxmlformats.org/drawingml/2006/main">
@@ -4822,12 +4822,12 @@
         </p:spPr>
         <p:txBody>
           <a:bodyPr xmlns:a="http://schemas.openxmlformats.org/drawingml/2006/main" lIns="76200" tIns="47625" rIns="76200" bIns="47625" anchor="ctr">
-            <a:normAutofit fontScale="86554"/>
+            <a:normAutofit fontScale="84344"/>
           </a:bodyPr>
           <a:lstStyle xmlns:a="http://schemas.openxmlformats.org/drawingml/2006/main"/>
           <a:p xmlns:a="http://schemas.openxmlformats.org/drawingml/2006/main">
             <a:pPr algn="ctr">
-              <a:defRPr sz="1275" b="1">
+              <a:defRPr sz="1500" b="1">
                 <a:solidFill>
                   <a:srgbClr val="4F86C6"/>
                 </a:solidFill>
@@ -4837,7 +4837,7 @@
               </a:defRPr>
             </a:pPr>
             <a:r>
-              <a:rPr sz="1275" b="1">
+              <a:rPr sz="1500" b="1">
                 <a:solidFill>
                   <a:srgbClr val="4F86C6"/>
                 </a:solidFill>
@@ -4855,7 +4855,7 @@
           <p:cNvPr id="11" name="">
             <a:extLst xmlns:a="http://schemas.openxmlformats.org/drawingml/2006/main">
               <a:ext uri="{FF2B5EF4-FFF2-40B4-BE49-F238E27FC236}">
-                <a16:creationId xmlns:a16="http://schemas.microsoft.com/office/drawing/2014/main" id="{D553DBC5-074F-41D9-B8CD-B57D4D565D59}"/>
+                <a16:creationId xmlns:a16="http://schemas.microsoft.com/office/drawing/2014/main" id="{5E388047-A105-4333-9BB5-C9D118FEA42A}"/>
               </a:ext>
             </a:extLst>
           </p:cNvPr>
@@ -4914,23 +4914,23 @@
           <p:cNvPr id="13" name="">
             <a:extLst xmlns:a="http://schemas.openxmlformats.org/drawingml/2006/main">
               <a:ext uri="{FF2B5EF4-FFF2-40B4-BE49-F238E27FC236}">
-                <a16:creationId xmlns:a16="http://schemas.microsoft.com/office/drawing/2014/main" id="{80B4056F-883B-44F2-AC78-387031717A4B}"/>
-              </a:ext>
-            </a:extLst>
-          </p:cNvPr>
-          <p:cNvSpPr>
-            <a:spLocks xmlns:a="http://schemas.openxmlformats.org/drawingml/2006/main" noGrp="1"/>
-          </p:cNvSpPr>
-          <p:nvPr/>
-        </p:nvSpPr>
-        <p:spPr>
-          <a:xfrm xmlns:a="http://schemas.openxmlformats.org/drawingml/2006/main">
-            <a:off x="2000250" y="3810000"/>
-            <a:ext cx="457200" cy="285750"/>
+                <a16:creationId xmlns:a16="http://schemas.microsoft.com/office/drawing/2014/main" id="{BAF5D545-7BFF-40F5-8579-7194EC94B2D6}"/>
+              </a:ext>
+            </a:extLst>
+          </p:cNvPr>
+          <p:cNvSpPr>
+            <a:spLocks xmlns:a="http://schemas.openxmlformats.org/drawingml/2006/main" noGrp="1"/>
+          </p:cNvSpPr>
+          <p:nvPr/>
+        </p:nvSpPr>
+        <p:spPr>
+          <a:xfrm xmlns:a="http://schemas.openxmlformats.org/drawingml/2006/main">
+            <a:off x="2097094" y="3651576"/>
+            <a:ext cx="457200" cy="304800"/>
           </a:xfrm>
           <a:prstGeom xmlns:a="http://schemas.openxmlformats.org/drawingml/2006/main" prst="roundRect">
             <a:avLst>
-              <a:gd name="adj" fmla="val 13333"/>
+              <a:gd name="adj" fmla="val 9375"/>
             </a:avLst>
           </a:prstGeom>
           <a:solidFill xmlns:a="http://schemas.openxmlformats.org/drawingml/2006/main">
@@ -4943,12 +4943,12 @@
         </p:spPr>
         <p:txBody>
           <a:bodyPr xmlns:a="http://schemas.openxmlformats.org/drawingml/2006/main" lIns="76200" tIns="47625" rIns="76200" bIns="47625" anchor="ctr">
-            <a:normAutofit fontScale="86554"/>
+            <a:normAutofit fontScale="84344"/>
           </a:bodyPr>
           <a:lstStyle xmlns:a="http://schemas.openxmlformats.org/drawingml/2006/main"/>
           <a:p xmlns:a="http://schemas.openxmlformats.org/drawingml/2006/main">
             <a:pPr algn="ctr">
-              <a:defRPr sz="1275" b="1">
+              <a:defRPr sz="1500" b="1">
                 <a:solidFill>
                   <a:srgbClr val="E5A23C"/>
                 </a:solidFill>
@@ -4958,7 +4958,7 @@
               </a:defRPr>
             </a:pPr>
             <a:r>
-              <a:rPr sz="1275" b="1">
+              <a:rPr sz="1500" b="1">
                 <a:solidFill>
                   <a:srgbClr val="E5A23C"/>
                 </a:solidFill>
@@ -4976,7 +4976,7 @@
           <p:cNvPr id="14" name="">
             <a:extLst xmlns:a="http://schemas.openxmlformats.org/drawingml/2006/main">
               <a:ext uri="{FF2B5EF4-FFF2-40B4-BE49-F238E27FC236}">
-                <a16:creationId xmlns:a16="http://schemas.microsoft.com/office/drawing/2014/main" id="{2AF2C188-6CFB-4436-BE31-9A70CDAE80F8}"/>
+                <a16:creationId xmlns:a16="http://schemas.microsoft.com/office/drawing/2014/main" id="{FDF5D0CE-07C2-4E00-833D-C857B928A152}"/>
               </a:ext>
             </a:extLst>
           </p:cNvPr>
@@ -5035,23 +5035,23 @@
           <p:cNvPr id="16" name="">
             <a:extLst xmlns:a="http://schemas.openxmlformats.org/drawingml/2006/main">
               <a:ext uri="{FF2B5EF4-FFF2-40B4-BE49-F238E27FC236}">
-                <a16:creationId xmlns:a16="http://schemas.microsoft.com/office/drawing/2014/main" id="{84B3962D-AEF8-4506-82D3-684CFFD1EBB3}"/>
-              </a:ext>
-            </a:extLst>
-          </p:cNvPr>
-          <p:cNvSpPr>
-            <a:spLocks xmlns:a="http://schemas.openxmlformats.org/drawingml/2006/main" noGrp="1"/>
-          </p:cNvSpPr>
-          <p:nvPr/>
-        </p:nvSpPr>
-        <p:spPr>
-          <a:xfrm xmlns:a="http://schemas.openxmlformats.org/drawingml/2006/main">
-            <a:off x="3629025" y="3838575"/>
-            <a:ext cx="457200" cy="285750"/>
+                <a16:creationId xmlns:a16="http://schemas.microsoft.com/office/drawing/2014/main" id="{49C4C990-5281-456C-B64B-1F2CF090D1E8}"/>
+              </a:ext>
+            </a:extLst>
+          </p:cNvPr>
+          <p:cNvSpPr>
+            <a:spLocks xmlns:a="http://schemas.openxmlformats.org/drawingml/2006/main" noGrp="1"/>
+          </p:cNvSpPr>
+          <p:nvPr/>
+        </p:nvSpPr>
+        <p:spPr>
+          <a:xfrm xmlns:a="http://schemas.openxmlformats.org/drawingml/2006/main">
+            <a:off x="3353550" y="3859129"/>
+            <a:ext cx="457200" cy="304800"/>
           </a:xfrm>
           <a:prstGeom xmlns:a="http://schemas.openxmlformats.org/drawingml/2006/main" prst="roundRect">
             <a:avLst>
-              <a:gd name="adj" fmla="val 13333"/>
+              <a:gd name="adj" fmla="val 9375"/>
             </a:avLst>
           </a:prstGeom>
           <a:solidFill xmlns:a="http://schemas.openxmlformats.org/drawingml/2006/main">
@@ -5064,12 +5064,12 @@
         </p:spPr>
         <p:txBody>
           <a:bodyPr xmlns:a="http://schemas.openxmlformats.org/drawingml/2006/main" lIns="76200" tIns="47625" rIns="76200" bIns="47625" anchor="ctr">
-            <a:normAutofit fontScale="86554"/>
+            <a:normAutofit fontScale="84344"/>
           </a:bodyPr>
           <a:lstStyle xmlns:a="http://schemas.openxmlformats.org/drawingml/2006/main"/>
           <a:p xmlns:a="http://schemas.openxmlformats.org/drawingml/2006/main">
             <a:pPr algn="ctr">
-              <a:defRPr sz="1275" b="1">
+              <a:defRPr sz="1500" b="1">
                 <a:solidFill>
                   <a:srgbClr val="398D84"/>
                 </a:solidFill>
@@ -5079,7 +5079,7 @@
               </a:defRPr>
             </a:pPr>
             <a:r>
-              <a:rPr sz="1275" b="1">
+              <a:rPr sz="1500" b="1">
                 <a:solidFill>
                   <a:srgbClr val="398D84"/>
                 </a:solidFill>
@@ -5097,7 +5097,7 @@
           <p:cNvPr id="17" name="">
             <a:extLst xmlns:a="http://schemas.openxmlformats.org/drawingml/2006/main">
               <a:ext uri="{FF2B5EF4-FFF2-40B4-BE49-F238E27FC236}">
-                <a16:creationId xmlns:a16="http://schemas.microsoft.com/office/drawing/2014/main" id="{74935C08-657F-43DA-A022-B749A26A2125}"/>
+                <a16:creationId xmlns:a16="http://schemas.microsoft.com/office/drawing/2014/main" id="{422C2A90-7596-42C8-9B07-0DF4B21A2DA6}"/>
               </a:ext>
             </a:extLst>
           </p:cNvPr>
@@ -5187,7 +5187,7 @@
           <p:cNvPr id="19" name="">
             <a:extLst xmlns:a="http://schemas.openxmlformats.org/drawingml/2006/main">
               <a:ext uri="{FF2B5EF4-FFF2-40B4-BE49-F238E27FC236}">
-                <a16:creationId xmlns:a16="http://schemas.microsoft.com/office/drawing/2014/main" id="{6D0033D1-6ACA-4778-B423-F893A170DA21}"/>
+                <a16:creationId xmlns:a16="http://schemas.microsoft.com/office/drawing/2014/main" id="{61FBBE85-BC71-4135-BFFC-35FFF4CC9B9C}"/>
               </a:ext>
             </a:extLst>
           </p:cNvPr>
@@ -5245,7 +5245,7 @@
           <p:cNvPr id="20" name="">
             <a:extLst xmlns:a="http://schemas.openxmlformats.org/drawingml/2006/main">
               <a:ext uri="{FF2B5EF4-FFF2-40B4-BE49-F238E27FC236}">
-                <a16:creationId xmlns:a16="http://schemas.microsoft.com/office/drawing/2014/main" id="{D4E42A81-E078-4C25-8AA4-6F110CA116D1}"/>
+                <a16:creationId xmlns:a16="http://schemas.microsoft.com/office/drawing/2014/main" id="{A959A5D2-B882-4F77-9154-EC87BA9B4476}"/>
               </a:ext>
             </a:extLst>
           </p:cNvPr>
@@ -5309,7 +5309,7 @@
           <p:cNvPr id="21" name="">
             <a:extLst xmlns:a="http://schemas.openxmlformats.org/drawingml/2006/main">
               <a:ext uri="{FF2B5EF4-FFF2-40B4-BE49-F238E27FC236}">
-                <a16:creationId xmlns:a16="http://schemas.microsoft.com/office/drawing/2014/main" id="{87E34118-938B-45B3-9E05-BD66A4EA11E8}"/>
+                <a16:creationId xmlns:a16="http://schemas.microsoft.com/office/drawing/2014/main" id="{C4DE22DA-DDF7-4241-BA1A-EAECA247886A}"/>
               </a:ext>
             </a:extLst>
           </p:cNvPr>
@@ -5363,7 +5363,7 @@
                 <a:ea typeface="Arial"/>
                 <a:cs typeface="Arial"/>
               </a:rPr>
-              <a:t>научен gate  α(q, r)</a:t>
+              <a:t>научен gate α(q, r)</a:t>
             </a:r>
           </a:p>
         </p:txBody>
@@ -5399,7 +5399,7 @@
           <p:cNvPr id="23" name="">
             <a:extLst xmlns:a="http://schemas.openxmlformats.org/drawingml/2006/main">
               <a:ext uri="{FF2B5EF4-FFF2-40B4-BE49-F238E27FC236}">
-                <a16:creationId xmlns:a16="http://schemas.microsoft.com/office/drawing/2014/main" id="{C176C460-BB48-41CA-B438-75EB57BB18C5}"/>
+                <a16:creationId xmlns:a16="http://schemas.microsoft.com/office/drawing/2014/main" id="{AF862738-8B77-489A-88EE-E579D2916797}"/>
               </a:ext>
             </a:extLst>
           </p:cNvPr>
@@ -5432,7 +5432,7 @@
           <p:cNvPr id="24" name="">
             <a:extLst xmlns:a="http://schemas.openxmlformats.org/drawingml/2006/main">
               <a:ext uri="{FF2B5EF4-FFF2-40B4-BE49-F238E27FC236}">
-                <a16:creationId xmlns:a16="http://schemas.microsoft.com/office/drawing/2014/main" id="{C4F0514B-33C7-4B8B-B5EF-21997E47CB0A}"/>
+                <a16:creationId xmlns:a16="http://schemas.microsoft.com/office/drawing/2014/main" id="{0A257AEF-C025-4A62-AE9B-70797094EC49}"/>
               </a:ext>
             </a:extLst>
           </p:cNvPr>
@@ -5517,23 +5517,23 @@
           <p:cNvPr id="27" name="">
             <a:extLst xmlns:a="http://schemas.openxmlformats.org/drawingml/2006/main">
               <a:ext uri="{FF2B5EF4-FFF2-40B4-BE49-F238E27FC236}">
-                <a16:creationId xmlns:a16="http://schemas.microsoft.com/office/drawing/2014/main" id="{947BE7E6-EC4C-4F09-8BA7-02168E5A9540}"/>
-              </a:ext>
-            </a:extLst>
-          </p:cNvPr>
-          <p:cNvSpPr>
-            <a:spLocks xmlns:a="http://schemas.openxmlformats.org/drawingml/2006/main" noGrp="1"/>
-          </p:cNvSpPr>
-          <p:nvPr/>
-        </p:nvSpPr>
-        <p:spPr>
-          <a:xfrm xmlns:a="http://schemas.openxmlformats.org/drawingml/2006/main">
-            <a:off x="7572375" y="2028825"/>
-            <a:ext cx="457200" cy="285750"/>
+                <a16:creationId xmlns:a16="http://schemas.microsoft.com/office/drawing/2014/main" id="{659C3534-BFFD-4817-A443-033AFC30E494}"/>
+              </a:ext>
+            </a:extLst>
+          </p:cNvPr>
+          <p:cNvSpPr>
+            <a:spLocks xmlns:a="http://schemas.openxmlformats.org/drawingml/2006/main" noGrp="1"/>
+          </p:cNvSpPr>
+          <p:nvPr/>
+        </p:nvSpPr>
+        <p:spPr>
+          <a:xfrm xmlns:a="http://schemas.openxmlformats.org/drawingml/2006/main">
+            <a:off x="7794902" y="2408307"/>
+            <a:ext cx="457200" cy="304800"/>
           </a:xfrm>
           <a:prstGeom xmlns:a="http://schemas.openxmlformats.org/drawingml/2006/main" prst="roundRect">
             <a:avLst>
-              <a:gd name="adj" fmla="val 13333"/>
+              <a:gd name="adj" fmla="val 9375"/>
             </a:avLst>
           </a:prstGeom>
           <a:solidFill xmlns:a="http://schemas.openxmlformats.org/drawingml/2006/main">
@@ -5546,12 +5546,12 @@
         </p:spPr>
         <p:txBody>
           <a:bodyPr xmlns:a="http://schemas.openxmlformats.org/drawingml/2006/main" lIns="76200" tIns="47625" rIns="76200" bIns="47625" anchor="ctr">
-            <a:normAutofit fontScale="86554"/>
+            <a:normAutofit fontScale="84344"/>
           </a:bodyPr>
           <a:lstStyle xmlns:a="http://schemas.openxmlformats.org/drawingml/2006/main"/>
           <a:p xmlns:a="http://schemas.openxmlformats.org/drawingml/2006/main">
             <a:pPr algn="ctr">
-              <a:defRPr sz="1275" b="1">
+              <a:defRPr sz="1500" b="1">
                 <a:solidFill>
                   <a:srgbClr val="4F86C6"/>
                 </a:solidFill>
@@ -5561,7 +5561,7 @@
               </a:defRPr>
             </a:pPr>
             <a:r>
-              <a:rPr sz="1275" b="1">
+              <a:rPr sz="1500" b="1">
                 <a:solidFill>
                   <a:srgbClr val="4F86C6"/>
                 </a:solidFill>
@@ -5579,7 +5579,7 @@
           <p:cNvPr id="28" name="">
             <a:extLst xmlns:a="http://schemas.openxmlformats.org/drawingml/2006/main">
               <a:ext uri="{FF2B5EF4-FFF2-40B4-BE49-F238E27FC236}">
-                <a16:creationId xmlns:a16="http://schemas.microsoft.com/office/drawing/2014/main" id="{510C5B0B-7374-49BF-9DF0-9908A77DE2DC}"/>
+                <a16:creationId xmlns:a16="http://schemas.microsoft.com/office/drawing/2014/main" id="{7978B3EF-69D6-4E31-BB9B-1B1517B2DB73}"/>
               </a:ext>
             </a:extLst>
           </p:cNvPr>
@@ -5664,23 +5664,23 @@
           <p:cNvPr id="31" name="">
             <a:extLst xmlns:a="http://schemas.openxmlformats.org/drawingml/2006/main">
               <a:ext uri="{FF2B5EF4-FFF2-40B4-BE49-F238E27FC236}">
-                <a16:creationId xmlns:a16="http://schemas.microsoft.com/office/drawing/2014/main" id="{BECA28F5-7331-4298-9E5A-486B7E16E303}"/>
-              </a:ext>
-            </a:extLst>
-          </p:cNvPr>
-          <p:cNvSpPr>
-            <a:spLocks xmlns:a="http://schemas.openxmlformats.org/drawingml/2006/main" noGrp="1"/>
-          </p:cNvSpPr>
-          <p:nvPr/>
-        </p:nvSpPr>
-        <p:spPr>
-          <a:xfrm xmlns:a="http://schemas.openxmlformats.org/drawingml/2006/main">
-            <a:off x="7477125" y="3810000"/>
-            <a:ext cx="457200" cy="285750"/>
+                <a16:creationId xmlns:a16="http://schemas.microsoft.com/office/drawing/2014/main" id="{B26864B2-4FF2-4A76-ABD2-00E62072B232}"/>
+              </a:ext>
+            </a:extLst>
+          </p:cNvPr>
+          <p:cNvSpPr>
+            <a:spLocks xmlns:a="http://schemas.openxmlformats.org/drawingml/2006/main" noGrp="1"/>
+          </p:cNvSpPr>
+          <p:nvPr/>
+        </p:nvSpPr>
+        <p:spPr>
+          <a:xfrm xmlns:a="http://schemas.openxmlformats.org/drawingml/2006/main">
+            <a:off x="7573969" y="3651576"/>
+            <a:ext cx="457200" cy="304800"/>
           </a:xfrm>
           <a:prstGeom xmlns:a="http://schemas.openxmlformats.org/drawingml/2006/main" prst="roundRect">
             <a:avLst>
-              <a:gd name="adj" fmla="val 13333"/>
+              <a:gd name="adj" fmla="val 9375"/>
             </a:avLst>
           </a:prstGeom>
           <a:solidFill xmlns:a="http://schemas.openxmlformats.org/drawingml/2006/main">
@@ -5693,12 +5693,12 @@
         </p:spPr>
         <p:txBody>
           <a:bodyPr xmlns:a="http://schemas.openxmlformats.org/drawingml/2006/main" lIns="76200" tIns="47625" rIns="76200" bIns="47625" anchor="ctr">
-            <a:normAutofit fontScale="86554"/>
+            <a:normAutofit fontScale="84344"/>
           </a:bodyPr>
           <a:lstStyle xmlns:a="http://schemas.openxmlformats.org/drawingml/2006/main"/>
           <a:p xmlns:a="http://schemas.openxmlformats.org/drawingml/2006/main">
             <a:pPr algn="ctr">
-              <a:defRPr sz="1275" b="1">
+              <a:defRPr sz="1500" b="1">
                 <a:solidFill>
                   <a:srgbClr val="E5A23C"/>
                 </a:solidFill>
@@ -5708,7 +5708,7 @@
               </a:defRPr>
             </a:pPr>
             <a:r>
-              <a:rPr sz="1275" b="1">
+              <a:rPr sz="1500" b="1">
                 <a:solidFill>
                   <a:srgbClr val="E5A23C"/>
                 </a:solidFill>
@@ -5726,7 +5726,7 @@
           <p:cNvPr id="32" name="">
             <a:extLst xmlns:a="http://schemas.openxmlformats.org/drawingml/2006/main">
               <a:ext uri="{FF2B5EF4-FFF2-40B4-BE49-F238E27FC236}">
-                <a16:creationId xmlns:a16="http://schemas.microsoft.com/office/drawing/2014/main" id="{EADEE7F3-559E-40AC-B7AB-0E77633EEBA3}"/>
+                <a16:creationId xmlns:a16="http://schemas.microsoft.com/office/drawing/2014/main" id="{047EE168-6BE2-46DD-BAFE-A5E06388311F}"/>
               </a:ext>
             </a:extLst>
           </p:cNvPr>
@@ -5811,23 +5811,23 @@
           <p:cNvPr id="35" name="">
             <a:extLst xmlns:a="http://schemas.openxmlformats.org/drawingml/2006/main">
               <a:ext uri="{FF2B5EF4-FFF2-40B4-BE49-F238E27FC236}">
-                <a16:creationId xmlns:a16="http://schemas.microsoft.com/office/drawing/2014/main" id="{EA6DC067-1A03-4471-B235-AF48FB2ECB3F}"/>
-              </a:ext>
-            </a:extLst>
-          </p:cNvPr>
-          <p:cNvSpPr>
-            <a:spLocks xmlns:a="http://schemas.openxmlformats.org/drawingml/2006/main" noGrp="1"/>
-          </p:cNvSpPr>
-          <p:nvPr/>
-        </p:nvSpPr>
-        <p:spPr>
-          <a:xfrm xmlns:a="http://schemas.openxmlformats.org/drawingml/2006/main">
-            <a:off x="9105900" y="3838575"/>
-            <a:ext cx="457200" cy="285750"/>
+                <a16:creationId xmlns:a16="http://schemas.microsoft.com/office/drawing/2014/main" id="{73CCC891-1783-431C-972C-284F0C207EFF}"/>
+              </a:ext>
+            </a:extLst>
+          </p:cNvPr>
+          <p:cNvSpPr>
+            <a:spLocks xmlns:a="http://schemas.openxmlformats.org/drawingml/2006/main" noGrp="1"/>
+          </p:cNvSpPr>
+          <p:nvPr/>
+        </p:nvSpPr>
+        <p:spPr>
+          <a:xfrm xmlns:a="http://schemas.openxmlformats.org/drawingml/2006/main">
+            <a:off x="8830425" y="3859129"/>
+            <a:ext cx="457200" cy="304800"/>
           </a:xfrm>
           <a:prstGeom xmlns:a="http://schemas.openxmlformats.org/drawingml/2006/main" prst="roundRect">
             <a:avLst>
-              <a:gd name="adj" fmla="val 13333"/>
+              <a:gd name="adj" fmla="val 9375"/>
             </a:avLst>
           </a:prstGeom>
           <a:solidFill xmlns:a="http://schemas.openxmlformats.org/drawingml/2006/main">
@@ -5840,12 +5840,12 @@
         </p:spPr>
         <p:txBody>
           <a:bodyPr xmlns:a="http://schemas.openxmlformats.org/drawingml/2006/main" lIns="76200" tIns="47625" rIns="76200" bIns="47625" anchor="ctr">
-            <a:normAutofit fontScale="86554"/>
+            <a:normAutofit fontScale="84344"/>
           </a:bodyPr>
           <a:lstStyle xmlns:a="http://schemas.openxmlformats.org/drawingml/2006/main"/>
           <a:p xmlns:a="http://schemas.openxmlformats.org/drawingml/2006/main">
             <a:pPr algn="ctr">
-              <a:defRPr sz="1275" b="1">
+              <a:defRPr sz="1500" b="1">
                 <a:solidFill>
                   <a:srgbClr val="398D84"/>
                 </a:solidFill>
@@ -5855,7 +5855,7 @@
               </a:defRPr>
             </a:pPr>
             <a:r>
-              <a:rPr sz="1275" b="1">
+              <a:rPr sz="1500" b="1">
                 <a:solidFill>
                   <a:srgbClr val="398D84"/>
                 </a:solidFill>
@@ -5873,7 +5873,7 @@
           <p:cNvPr id="36" name="">
             <a:extLst xmlns:a="http://schemas.openxmlformats.org/drawingml/2006/main">
               <a:ext uri="{FF2B5EF4-FFF2-40B4-BE49-F238E27FC236}">
-                <a16:creationId xmlns:a16="http://schemas.microsoft.com/office/drawing/2014/main" id="{E4B5A022-1AAB-4A16-934D-6882D27D081A}"/>
+                <a16:creationId xmlns:a16="http://schemas.microsoft.com/office/drawing/2014/main" id="{9DF17A35-CBD5-4CAD-BEF0-50A4A0832062}"/>
               </a:ext>
             </a:extLst>
           </p:cNvPr>
@@ -5963,7 +5963,7 @@
           <p:cNvPr id="38" name="">
             <a:extLst xmlns:a="http://schemas.openxmlformats.org/drawingml/2006/main">
               <a:ext uri="{FF2B5EF4-FFF2-40B4-BE49-F238E27FC236}">
-                <a16:creationId xmlns:a16="http://schemas.microsoft.com/office/drawing/2014/main" id="{E895E7BE-654E-4FF5-BF30-3A5E49EC54D1}"/>
+                <a16:creationId xmlns:a16="http://schemas.microsoft.com/office/drawing/2014/main" id="{14590D2C-85B6-47E7-BC14-ED76B6533055}"/>
               </a:ext>
             </a:extLst>
           </p:cNvPr>
@@ -6053,7 +6053,7 @@
           <p:cNvPr id="40" name="">
             <a:extLst xmlns:a="http://schemas.openxmlformats.org/drawingml/2006/main">
               <a:ext uri="{FF2B5EF4-FFF2-40B4-BE49-F238E27FC236}">
-                <a16:creationId xmlns:a16="http://schemas.microsoft.com/office/drawing/2014/main" id="{6375BC3B-53ED-4547-903D-569CEC4A802F}"/>
+                <a16:creationId xmlns:a16="http://schemas.microsoft.com/office/drawing/2014/main" id="{83097E38-A5F6-4CCF-8186-B92492064720}"/>
               </a:ext>
             </a:extLst>
           </p:cNvPr>
@@ -6109,7 +6109,7 @@
     </p:spTree>
     <p:extLst>
       <p:ext uri="{BB962C8B-B14F-4D97-AF65-F5344CB8AC3E}">
-        <p14:creationId xmlns:p14="http://schemas.microsoft.com/office/powerpoint/2010/main" val="787081097"/>
+        <p14:creationId xmlns:p14="http://schemas.microsoft.com/office/powerpoint/2010/main" val="1770532358"/>
       </p:ext>
     </p:extLst>
   </p:cSld>
@@ -6137,10 +6137,10 @@
       </p:grpSpPr>
       <p:sp>
         <p:nvSpPr>
-          <p:cNvPr id="36" name="">
-            <a:extLst xmlns:a="http://schemas.openxmlformats.org/drawingml/2006/main">
-              <a:ext uri="{FF2B5EF4-FFF2-40B4-BE49-F238E27FC236}">
-                <a16:creationId xmlns:a16="http://schemas.microsoft.com/office/drawing/2014/main" id="{2E8373D3-E449-46A0-9866-CB10E24049C3}"/>
+          <p:cNvPr id="35" name="">
+            <a:extLst xmlns:a="http://schemas.openxmlformats.org/drawingml/2006/main">
+              <a:ext uri="{FF2B5EF4-FFF2-40B4-BE49-F238E27FC236}">
+                <a16:creationId xmlns:a16="http://schemas.microsoft.com/office/drawing/2014/main" id="{E45DE238-32DD-4AC7-A7DA-553920065D31}"/>
               </a:ext>
             </a:extLst>
           </p:cNvPr>
@@ -6198,7 +6198,7 @@
           <p:cNvPr id="2" name="">
             <a:extLst xmlns:a="http://schemas.openxmlformats.org/drawingml/2006/main">
               <a:ext uri="{FF2B5EF4-FFF2-40B4-BE49-F238E27FC236}">
-                <a16:creationId xmlns:a16="http://schemas.microsoft.com/office/drawing/2014/main" id="{50A9E707-8771-4B29-8647-F07FA79CE92A}"/>
+                <a16:creationId xmlns:a16="http://schemas.microsoft.com/office/drawing/2014/main" id="{54F9F0FA-EB41-44F4-83F8-E6AF683086A8}"/>
               </a:ext>
             </a:extLst>
           </p:cNvPr>
@@ -6256,7 +6256,7 @@
           <p:cNvPr id="3" name="">
             <a:extLst xmlns:a="http://schemas.openxmlformats.org/drawingml/2006/main">
               <a:ext uri="{FF2B5EF4-FFF2-40B4-BE49-F238E27FC236}">
-                <a16:creationId xmlns:a16="http://schemas.microsoft.com/office/drawing/2014/main" id="{C5F130AB-89ED-4531-AF7E-A0CB6BE157DD}"/>
+                <a16:creationId xmlns:a16="http://schemas.microsoft.com/office/drawing/2014/main" id="{C38C6E8C-002F-4CC7-BC01-6C1FD157597C}"/>
               </a:ext>
             </a:extLst>
           </p:cNvPr>
@@ -6287,7 +6287,7 @@
           <p:cNvPr id="4" name="">
             <a:extLst xmlns:a="http://schemas.openxmlformats.org/drawingml/2006/main">
               <a:ext uri="{FF2B5EF4-FFF2-40B4-BE49-F238E27FC236}">
-                <a16:creationId xmlns:a16="http://schemas.microsoft.com/office/drawing/2014/main" id="{E516B5D2-4F77-4819-925D-F2AF775463C3}"/>
+                <a16:creationId xmlns:a16="http://schemas.microsoft.com/office/drawing/2014/main" id="{3B15AAD3-A191-4345-95EE-69AC1F336D73}"/>
               </a:ext>
             </a:extLst>
           </p:cNvPr>
@@ -6320,7 +6320,7 @@
           <p:cNvPr id="5" name="">
             <a:extLst xmlns:a="http://schemas.openxmlformats.org/drawingml/2006/main">
               <a:ext uri="{FF2B5EF4-FFF2-40B4-BE49-F238E27FC236}">
-                <a16:creationId xmlns:a16="http://schemas.microsoft.com/office/drawing/2014/main" id="{909E1AC8-3092-4F69-A0B9-32DB2519B05D}"/>
+                <a16:creationId xmlns:a16="http://schemas.microsoft.com/office/drawing/2014/main" id="{05FFE77B-BB34-409B-B541-5DBEF2029CD7}"/>
               </a:ext>
             </a:extLst>
           </p:cNvPr>
@@ -6353,7 +6353,7 @@
           <p:cNvPr id="6" name="">
             <a:extLst xmlns:a="http://schemas.openxmlformats.org/drawingml/2006/main">
               <a:ext uri="{FF2B5EF4-FFF2-40B4-BE49-F238E27FC236}">
-                <a16:creationId xmlns:a16="http://schemas.microsoft.com/office/drawing/2014/main" id="{03B7FC66-B034-4106-94F7-8975B2374940}"/>
+                <a16:creationId xmlns:a16="http://schemas.microsoft.com/office/drawing/2014/main" id="{87F4F5B1-C55B-426A-B15B-2B38765FC4B5}"/>
               </a:ext>
             </a:extLst>
           </p:cNvPr>
@@ -6414,7 +6414,7 @@
       </p:sp>
       <p:cxnSp>
         <p:nvCxnSpPr>
-          <p:cNvPr id="42" name=""/>
+          <p:cNvPr id="41" name=""/>
           <p:cNvCxnSpPr>
             <a:stCxn xmlns:a="http://schemas.openxmlformats.org/drawingml/2006/main" id="5" idx="6"/>
             <a:endCxn xmlns:a="http://schemas.openxmlformats.org/drawingml/2006/main" id="6" idx="1"/>
@@ -6440,7 +6440,7 @@
       </p:cxnSp>
       <p:cxnSp>
         <p:nvCxnSpPr>
-          <p:cNvPr id="43" name=""/>
+          <p:cNvPr id="42" name=""/>
           <p:cNvCxnSpPr>
             <a:stCxn xmlns:a="http://schemas.openxmlformats.org/drawingml/2006/main" id="6" idx="3"/>
             <a:endCxn xmlns:a="http://schemas.openxmlformats.org/drawingml/2006/main" id="4" idx="1"/>
@@ -6469,37 +6469,41 @@
           <p:cNvPr id="9" name="">
             <a:extLst xmlns:a="http://schemas.openxmlformats.org/drawingml/2006/main">
               <a:ext uri="{FF2B5EF4-FFF2-40B4-BE49-F238E27FC236}">
-                <a16:creationId xmlns:a16="http://schemas.microsoft.com/office/drawing/2014/main" id="{D729B96A-6F71-4475-B876-0D4FA42D833D}"/>
-              </a:ext>
-            </a:extLst>
-          </p:cNvPr>
-          <p:cNvSpPr>
-            <a:spLocks xmlns:a="http://schemas.openxmlformats.org/drawingml/2006/main" noGrp="1"/>
-          </p:cNvSpPr>
-          <p:nvPr/>
-        </p:nvSpPr>
-        <p:spPr>
-          <a:xfrm xmlns:a="http://schemas.openxmlformats.org/drawingml/2006/main">
-            <a:off x="2238375" y="1933575"/>
-            <a:ext cx="419100" cy="266700"/>
-          </a:xfrm>
-          <a:prstGeom xmlns:a="http://schemas.openxmlformats.org/drawingml/2006/main" prst="rect">
-            <a:avLst/>
-          </a:prstGeom>
-          <a:noFill xmlns:a="http://schemas.openxmlformats.org/drawingml/2006/main"/>
+                <a16:creationId xmlns:a16="http://schemas.microsoft.com/office/drawing/2014/main" id="{073E39EF-404A-4F45-B3FD-18735CF729F3}"/>
+              </a:ext>
+            </a:extLst>
+          </p:cNvPr>
+          <p:cNvSpPr>
+            <a:spLocks xmlns:a="http://schemas.openxmlformats.org/drawingml/2006/main" noGrp="1"/>
+          </p:cNvSpPr>
+          <p:nvPr/>
+        </p:nvSpPr>
+        <p:spPr>
+          <a:xfrm xmlns:a="http://schemas.openxmlformats.org/drawingml/2006/main">
+            <a:off x="2247892" y="1860835"/>
+            <a:ext cx="457200" cy="304800"/>
+          </a:xfrm>
+          <a:prstGeom xmlns:a="http://schemas.openxmlformats.org/drawingml/2006/main" prst="roundRect">
+            <a:avLst>
+              <a:gd name="adj" fmla="val 9375"/>
+            </a:avLst>
+          </a:prstGeom>
+          <a:solidFill xmlns:a="http://schemas.openxmlformats.org/drawingml/2006/main">
+            <a:srgbClr val="FFFFFF"/>
+          </a:solidFill>
           <a:ln xmlns:a="http://schemas.openxmlformats.org/drawingml/2006/main" w="0">
             <a:noFill/>
             <a:prstDash val="solid"/>
           </a:ln>
         </p:spPr>
         <p:txBody>
-          <a:bodyPr xmlns:a="http://schemas.openxmlformats.org/drawingml/2006/main" wrap="square" lIns="38100" tIns="19050" rIns="38100" bIns="19050" anchor="ctr">
-            <a:normAutofit fontScale="100000"/>
+          <a:bodyPr xmlns:a="http://schemas.openxmlformats.org/drawingml/2006/main" lIns="76200" tIns="47625" rIns="76200" bIns="47625" anchor="ctr">
+            <a:normAutofit fontScale="84344"/>
           </a:bodyPr>
           <a:lstStyle xmlns:a="http://schemas.openxmlformats.org/drawingml/2006/main"/>
           <a:p xmlns:a="http://schemas.openxmlformats.org/drawingml/2006/main">
             <a:pPr algn="ctr">
-              <a:defRPr sz="1275" b="1">
+              <a:defRPr sz="1500" b="1">
                 <a:solidFill>
                   <a:srgbClr val="4F86C6"/>
                 </a:solidFill>
@@ -6509,7 +6513,7 @@
               </a:defRPr>
             </a:pPr>
             <a:r>
-              <a:rPr sz="1275" b="1">
+              <a:rPr sz="1500" b="1">
                 <a:solidFill>
                   <a:srgbClr val="4F86C6"/>
                 </a:solidFill>
@@ -6527,7 +6531,7 @@
           <p:cNvPr id="10" name="">
             <a:extLst xmlns:a="http://schemas.openxmlformats.org/drawingml/2006/main">
               <a:ext uri="{FF2B5EF4-FFF2-40B4-BE49-F238E27FC236}">
-                <a16:creationId xmlns:a16="http://schemas.microsoft.com/office/drawing/2014/main" id="{ED8A018F-F0C4-49BE-B6B4-75B47BDBBCEC}"/>
+                <a16:creationId xmlns:a16="http://schemas.microsoft.com/office/drawing/2014/main" id="{A72903B8-DABF-47B1-8EE2-9F6CA292FDDD}"/>
               </a:ext>
             </a:extLst>
           </p:cNvPr>
@@ -6560,7 +6564,7 @@
           <p:cNvPr id="11" name="">
             <a:extLst xmlns:a="http://schemas.openxmlformats.org/drawingml/2006/main">
               <a:ext uri="{FF2B5EF4-FFF2-40B4-BE49-F238E27FC236}">
-                <a16:creationId xmlns:a16="http://schemas.microsoft.com/office/drawing/2014/main" id="{8D4922BA-8121-4FA7-9657-8FD5F366A71D}"/>
+                <a16:creationId xmlns:a16="http://schemas.microsoft.com/office/drawing/2014/main" id="{2F96AD4A-C687-49A6-8562-554C061D343B}"/>
               </a:ext>
             </a:extLst>
           </p:cNvPr>
@@ -6621,7 +6625,7 @@
       </p:sp>
       <p:cxnSp>
         <p:nvCxnSpPr>
-          <p:cNvPr id="47" name=""/>
+          <p:cNvPr id="46" name=""/>
           <p:cNvCxnSpPr>
             <a:stCxn xmlns:a="http://schemas.openxmlformats.org/drawingml/2006/main" id="10" idx="6"/>
             <a:endCxn xmlns:a="http://schemas.openxmlformats.org/drawingml/2006/main" id="11" idx="1"/>
@@ -6647,7 +6651,7 @@
       </p:cxnSp>
       <p:cxnSp>
         <p:nvCxnSpPr>
-          <p:cNvPr id="48" name=""/>
+          <p:cNvPr id="47" name=""/>
           <p:cNvCxnSpPr>
             <a:stCxn xmlns:a="http://schemas.openxmlformats.org/drawingml/2006/main" id="11" idx="3"/>
             <a:endCxn xmlns:a="http://schemas.openxmlformats.org/drawingml/2006/main" id="4" idx="2"/>
@@ -6676,37 +6680,41 @@
           <p:cNvPr id="14" name="">
             <a:extLst xmlns:a="http://schemas.openxmlformats.org/drawingml/2006/main">
               <a:ext uri="{FF2B5EF4-FFF2-40B4-BE49-F238E27FC236}">
-                <a16:creationId xmlns:a16="http://schemas.microsoft.com/office/drawing/2014/main" id="{1800A91E-D4E8-42BA-A5A9-52C8AD423D18}"/>
-              </a:ext>
-            </a:extLst>
-          </p:cNvPr>
-          <p:cNvSpPr>
-            <a:spLocks xmlns:a="http://schemas.openxmlformats.org/drawingml/2006/main" noGrp="1"/>
-          </p:cNvSpPr>
-          <p:nvPr/>
-        </p:nvSpPr>
-        <p:spPr>
-          <a:xfrm xmlns:a="http://schemas.openxmlformats.org/drawingml/2006/main">
-            <a:off x="2047875" y="3219450"/>
-            <a:ext cx="419100" cy="266700"/>
-          </a:xfrm>
-          <a:prstGeom xmlns:a="http://schemas.openxmlformats.org/drawingml/2006/main" prst="rect">
-            <a:avLst/>
-          </a:prstGeom>
-          <a:noFill xmlns:a="http://schemas.openxmlformats.org/drawingml/2006/main"/>
+                <a16:creationId xmlns:a16="http://schemas.microsoft.com/office/drawing/2014/main" id="{E5E17AA7-D31A-4954-AAD3-E9E93AF8AB06}"/>
+              </a:ext>
+            </a:extLst>
+          </p:cNvPr>
+          <p:cNvSpPr>
+            <a:spLocks xmlns:a="http://schemas.openxmlformats.org/drawingml/2006/main" noGrp="1"/>
+          </p:cNvSpPr>
+          <p:nvPr/>
+        </p:nvSpPr>
+        <p:spPr>
+          <a:xfrm xmlns:a="http://schemas.openxmlformats.org/drawingml/2006/main">
+            <a:off x="2059649" y="3520220"/>
+            <a:ext cx="457200" cy="304800"/>
+          </a:xfrm>
+          <a:prstGeom xmlns:a="http://schemas.openxmlformats.org/drawingml/2006/main" prst="roundRect">
+            <a:avLst>
+              <a:gd name="adj" fmla="val 9375"/>
+            </a:avLst>
+          </a:prstGeom>
+          <a:solidFill xmlns:a="http://schemas.openxmlformats.org/drawingml/2006/main">
+            <a:srgbClr val="FFFFFF"/>
+          </a:solidFill>
           <a:ln xmlns:a="http://schemas.openxmlformats.org/drawingml/2006/main" w="0">
             <a:noFill/>
             <a:prstDash val="solid"/>
           </a:ln>
         </p:spPr>
         <p:txBody>
-          <a:bodyPr xmlns:a="http://schemas.openxmlformats.org/drawingml/2006/main" wrap="square" lIns="38100" tIns="19050" rIns="38100" bIns="19050" anchor="ctr">
-            <a:normAutofit fontScale="100000"/>
+          <a:bodyPr xmlns:a="http://schemas.openxmlformats.org/drawingml/2006/main" lIns="76200" tIns="47625" rIns="76200" bIns="47625" anchor="ctr">
+            <a:normAutofit fontScale="84344"/>
           </a:bodyPr>
           <a:lstStyle xmlns:a="http://schemas.openxmlformats.org/drawingml/2006/main"/>
           <a:p xmlns:a="http://schemas.openxmlformats.org/drawingml/2006/main">
             <a:pPr algn="ctr">
-              <a:defRPr sz="1275" b="1">
+              <a:defRPr sz="1500" b="1">
                 <a:solidFill>
                   <a:srgbClr val="E5A23C"/>
                 </a:solidFill>
@@ -6716,7 +6724,7 @@
               </a:defRPr>
             </a:pPr>
             <a:r>
-              <a:rPr sz="1275" b="1">
+              <a:rPr sz="1500" b="1">
                 <a:solidFill>
                   <a:srgbClr val="E5A23C"/>
                 </a:solidFill>
@@ -6734,7 +6742,7 @@
           <p:cNvPr id="15" name="">
             <a:extLst xmlns:a="http://schemas.openxmlformats.org/drawingml/2006/main">
               <a:ext uri="{FF2B5EF4-FFF2-40B4-BE49-F238E27FC236}">
-                <a16:creationId xmlns:a16="http://schemas.microsoft.com/office/drawing/2014/main" id="{C15171B8-D3D3-48CE-8D7F-B5AEE7785DB0}"/>
+                <a16:creationId xmlns:a16="http://schemas.microsoft.com/office/drawing/2014/main" id="{107D3643-68FE-4527-87C5-20C897B1350D}"/>
               </a:ext>
             </a:extLst>
           </p:cNvPr>
@@ -6767,7 +6775,7 @@
           <p:cNvPr id="16" name="">
             <a:extLst xmlns:a="http://schemas.openxmlformats.org/drawingml/2006/main">
               <a:ext uri="{FF2B5EF4-FFF2-40B4-BE49-F238E27FC236}">
-                <a16:creationId xmlns:a16="http://schemas.microsoft.com/office/drawing/2014/main" id="{B70B73BA-B560-4888-B736-8231D772C655}"/>
+                <a16:creationId xmlns:a16="http://schemas.microsoft.com/office/drawing/2014/main" id="{7BE5B69F-D118-4BA2-BE19-66B9C8118189}"/>
               </a:ext>
             </a:extLst>
           </p:cNvPr>
@@ -6828,7 +6836,7 @@
       </p:sp>
       <p:cxnSp>
         <p:nvCxnSpPr>
-          <p:cNvPr id="52" name=""/>
+          <p:cNvPr id="51" name=""/>
           <p:cNvCxnSpPr>
             <a:stCxn xmlns:a="http://schemas.openxmlformats.org/drawingml/2006/main" id="15" idx="7"/>
             <a:endCxn xmlns:a="http://schemas.openxmlformats.org/drawingml/2006/main" id="16" idx="1"/>
@@ -6854,7 +6862,7 @@
       </p:cxnSp>
       <p:cxnSp>
         <p:nvCxnSpPr>
-          <p:cNvPr id="53" name=""/>
+          <p:cNvPr id="52" name=""/>
           <p:cNvCxnSpPr>
             <a:stCxn xmlns:a="http://schemas.openxmlformats.org/drawingml/2006/main" id="16" idx="3"/>
             <a:endCxn xmlns:a="http://schemas.openxmlformats.org/drawingml/2006/main" id="4" idx="3"/>
@@ -6883,37 +6891,41 @@
           <p:cNvPr id="19" name="">
             <a:extLst xmlns:a="http://schemas.openxmlformats.org/drawingml/2006/main">
               <a:ext uri="{FF2B5EF4-FFF2-40B4-BE49-F238E27FC236}">
-                <a16:creationId xmlns:a16="http://schemas.microsoft.com/office/drawing/2014/main" id="{29864516-F7AD-4414-86FE-8854DDB020B9}"/>
-              </a:ext>
-            </a:extLst>
-          </p:cNvPr>
-          <p:cNvSpPr>
-            <a:spLocks xmlns:a="http://schemas.openxmlformats.org/drawingml/2006/main" noGrp="1"/>
-          </p:cNvSpPr>
-          <p:nvPr/>
-        </p:nvSpPr>
-        <p:spPr>
-          <a:xfrm xmlns:a="http://schemas.openxmlformats.org/drawingml/2006/main">
-            <a:off x="2905125" y="4410075"/>
-            <a:ext cx="419100" cy="266700"/>
-          </a:xfrm>
-          <a:prstGeom xmlns:a="http://schemas.openxmlformats.org/drawingml/2006/main" prst="rect">
-            <a:avLst/>
-          </a:prstGeom>
-          <a:noFill xmlns:a="http://schemas.openxmlformats.org/drawingml/2006/main"/>
+                <a16:creationId xmlns:a16="http://schemas.microsoft.com/office/drawing/2014/main" id="{1297F629-A6A9-4B21-BA4B-2D485E78E7E3}"/>
+              </a:ext>
+            </a:extLst>
+          </p:cNvPr>
+          <p:cNvSpPr>
+            <a:spLocks xmlns:a="http://schemas.openxmlformats.org/drawingml/2006/main" noGrp="1"/>
+          </p:cNvSpPr>
+          <p:nvPr/>
+        </p:nvSpPr>
+        <p:spPr>
+          <a:xfrm xmlns:a="http://schemas.openxmlformats.org/drawingml/2006/main">
+            <a:off x="2763653" y="4562244"/>
+            <a:ext cx="457200" cy="304800"/>
+          </a:xfrm>
+          <a:prstGeom xmlns:a="http://schemas.openxmlformats.org/drawingml/2006/main" prst="roundRect">
+            <a:avLst>
+              <a:gd name="adj" fmla="val 9375"/>
+            </a:avLst>
+          </a:prstGeom>
+          <a:solidFill xmlns:a="http://schemas.openxmlformats.org/drawingml/2006/main">
+            <a:srgbClr val="FFFFFF"/>
+          </a:solidFill>
           <a:ln xmlns:a="http://schemas.openxmlformats.org/drawingml/2006/main" w="0">
             <a:noFill/>
             <a:prstDash val="solid"/>
           </a:ln>
         </p:spPr>
         <p:txBody>
-          <a:bodyPr xmlns:a="http://schemas.openxmlformats.org/drawingml/2006/main" wrap="square" lIns="38100" tIns="19050" rIns="38100" bIns="19050" anchor="ctr">
-            <a:normAutofit fontScale="100000"/>
+          <a:bodyPr xmlns:a="http://schemas.openxmlformats.org/drawingml/2006/main" lIns="76200" tIns="47625" rIns="76200" bIns="47625" anchor="ctr">
+            <a:normAutofit fontScale="84344"/>
           </a:bodyPr>
           <a:lstStyle xmlns:a="http://schemas.openxmlformats.org/drawingml/2006/main"/>
           <a:p xmlns:a="http://schemas.openxmlformats.org/drawingml/2006/main">
             <a:pPr algn="ctr">
-              <a:defRPr sz="1275" b="1">
+              <a:defRPr sz="1500" b="1">
                 <a:solidFill>
                   <a:srgbClr val="398D84"/>
                 </a:solidFill>
@@ -6923,7 +6935,7 @@
               </a:defRPr>
             </a:pPr>
             <a:r>
-              <a:rPr sz="1275" b="1">
+              <a:rPr sz="1500" b="1">
                 <a:solidFill>
                   <a:srgbClr val="398D84"/>
                 </a:solidFill>
@@ -6941,7 +6953,7 @@
           <p:cNvPr id="20" name="">
             <a:extLst xmlns:a="http://schemas.openxmlformats.org/drawingml/2006/main">
               <a:ext uri="{FF2B5EF4-FFF2-40B4-BE49-F238E27FC236}">
-                <a16:creationId xmlns:a16="http://schemas.microsoft.com/office/drawing/2014/main" id="{D4D1D1B9-28E9-4F33-B9C6-224B9F46112E}"/>
+                <a16:creationId xmlns:a16="http://schemas.microsoft.com/office/drawing/2014/main" id="{AED7D429-2447-4F66-8B23-32E36047A5E3}"/>
               </a:ext>
             </a:extLst>
           </p:cNvPr>
@@ -6974,7 +6986,7 @@
           <p:cNvPr id="21" name="">
             <a:extLst xmlns:a="http://schemas.openxmlformats.org/drawingml/2006/main">
               <a:ext uri="{FF2B5EF4-FFF2-40B4-BE49-F238E27FC236}">
-                <a16:creationId xmlns:a16="http://schemas.microsoft.com/office/drawing/2014/main" id="{31D2261F-293C-4046-925D-AE19EBD74B3F}"/>
+                <a16:creationId xmlns:a16="http://schemas.microsoft.com/office/drawing/2014/main" id="{5A1C5051-D944-4B89-96AA-E567BAAA735D}"/>
               </a:ext>
             </a:extLst>
           </p:cNvPr>
@@ -7004,7 +7016,7 @@
       </p:sp>
       <p:cxnSp>
         <p:nvCxnSpPr>
-          <p:cNvPr id="57" name=""/>
+          <p:cNvPr id="56" name=""/>
           <p:cNvCxnSpPr>
             <a:stCxn xmlns:a="http://schemas.openxmlformats.org/drawingml/2006/main" id="21" idx="6"/>
             <a:endCxn xmlns:a="http://schemas.openxmlformats.org/drawingml/2006/main" id="20" idx="1"/>
@@ -7033,37 +7045,41 @@
           <p:cNvPr id="23" name="">
             <a:extLst xmlns:a="http://schemas.openxmlformats.org/drawingml/2006/main">
               <a:ext uri="{FF2B5EF4-FFF2-40B4-BE49-F238E27FC236}">
-                <a16:creationId xmlns:a16="http://schemas.microsoft.com/office/drawing/2014/main" id="{196FEAC4-5D6E-4ED0-9FEA-7BDB9695F22D}"/>
-              </a:ext>
-            </a:extLst>
-          </p:cNvPr>
-          <p:cNvSpPr>
-            <a:spLocks xmlns:a="http://schemas.openxmlformats.org/drawingml/2006/main" noGrp="1"/>
-          </p:cNvSpPr>
-          <p:nvPr/>
-        </p:nvSpPr>
-        <p:spPr>
-          <a:xfrm xmlns:a="http://schemas.openxmlformats.org/drawingml/2006/main">
-            <a:off x="7762875" y="1885950"/>
-            <a:ext cx="419100" cy="266700"/>
-          </a:xfrm>
-          <a:prstGeom xmlns:a="http://schemas.openxmlformats.org/drawingml/2006/main" prst="rect">
-            <a:avLst/>
-          </a:prstGeom>
-          <a:noFill xmlns:a="http://schemas.openxmlformats.org/drawingml/2006/main"/>
+                <a16:creationId xmlns:a16="http://schemas.microsoft.com/office/drawing/2014/main" id="{E2557C75-E784-43C6-A0F0-627019590F5E}"/>
+              </a:ext>
+            </a:extLst>
+          </p:cNvPr>
+          <p:cNvSpPr>
+            <a:spLocks xmlns:a="http://schemas.openxmlformats.org/drawingml/2006/main" noGrp="1"/>
+          </p:cNvSpPr>
+          <p:nvPr/>
+        </p:nvSpPr>
+        <p:spPr>
+          <a:xfrm xmlns:a="http://schemas.openxmlformats.org/drawingml/2006/main">
+            <a:off x="7965545" y="1932680"/>
+            <a:ext cx="457200" cy="304800"/>
+          </a:xfrm>
+          <a:prstGeom xmlns:a="http://schemas.openxmlformats.org/drawingml/2006/main" prst="roundRect">
+            <a:avLst>
+              <a:gd name="adj" fmla="val 9375"/>
+            </a:avLst>
+          </a:prstGeom>
+          <a:solidFill xmlns:a="http://schemas.openxmlformats.org/drawingml/2006/main">
+            <a:srgbClr val="FFFFFF"/>
+          </a:solidFill>
           <a:ln xmlns:a="http://schemas.openxmlformats.org/drawingml/2006/main" w="0">
             <a:noFill/>
             <a:prstDash val="solid"/>
           </a:ln>
         </p:spPr>
         <p:txBody>
-          <a:bodyPr xmlns:a="http://schemas.openxmlformats.org/drawingml/2006/main" wrap="square" lIns="38100" tIns="19050" rIns="38100" bIns="19050" anchor="ctr">
-            <a:normAutofit fontScale="100000"/>
+          <a:bodyPr xmlns:a="http://schemas.openxmlformats.org/drawingml/2006/main" lIns="76200" tIns="47625" rIns="76200" bIns="47625" anchor="ctr">
+            <a:normAutofit fontScale="84344"/>
           </a:bodyPr>
           <a:lstStyle xmlns:a="http://schemas.openxmlformats.org/drawingml/2006/main"/>
           <a:p xmlns:a="http://schemas.openxmlformats.org/drawingml/2006/main">
             <a:pPr algn="ctr">
-              <a:defRPr sz="1275" b="1">
+              <a:defRPr sz="1500" b="1">
                 <a:solidFill>
                   <a:srgbClr val="4F86C6"/>
                 </a:solidFill>
@@ -7073,7 +7089,7 @@
               </a:defRPr>
             </a:pPr>
             <a:r>
-              <a:rPr sz="1275" b="1">
+              <a:rPr sz="1500" b="1">
                 <a:solidFill>
                   <a:srgbClr val="4F86C6"/>
                 </a:solidFill>
@@ -7091,7 +7107,7 @@
           <p:cNvPr id="24" name="">
             <a:extLst xmlns:a="http://schemas.openxmlformats.org/drawingml/2006/main">
               <a:ext uri="{FF2B5EF4-FFF2-40B4-BE49-F238E27FC236}">
-                <a16:creationId xmlns:a16="http://schemas.microsoft.com/office/drawing/2014/main" id="{2C80C723-C97D-42F9-8135-26067343B7C1}"/>
+                <a16:creationId xmlns:a16="http://schemas.microsoft.com/office/drawing/2014/main" id="{F70F8AE7-C26A-4EAB-87CB-4761B7F28217}"/>
               </a:ext>
             </a:extLst>
           </p:cNvPr>
@@ -7149,7 +7165,7 @@
           <p:cNvPr id="25" name="">
             <a:extLst xmlns:a="http://schemas.openxmlformats.org/drawingml/2006/main">
               <a:ext uri="{FF2B5EF4-FFF2-40B4-BE49-F238E27FC236}">
-                <a16:creationId xmlns:a16="http://schemas.microsoft.com/office/drawing/2014/main" id="{CCE679ED-444B-4A8F-9A5A-D33EF83BD7F3}"/>
+                <a16:creationId xmlns:a16="http://schemas.microsoft.com/office/drawing/2014/main" id="{BBC638FF-E8DE-4BDC-B6FD-74F7A61120D1}"/>
               </a:ext>
             </a:extLst>
           </p:cNvPr>
@@ -7179,7 +7195,7 @@
       </p:sp>
       <p:cxnSp>
         <p:nvCxnSpPr>
-          <p:cNvPr id="61" name=""/>
+          <p:cNvPr id="60" name=""/>
           <p:cNvCxnSpPr>
             <a:stCxn xmlns:a="http://schemas.openxmlformats.org/drawingml/2006/main" id="25" idx="6"/>
             <a:endCxn xmlns:a="http://schemas.openxmlformats.org/drawingml/2006/main" id="20" idx="2"/>
@@ -7208,37 +7224,41 @@
           <p:cNvPr id="27" name="">
             <a:extLst xmlns:a="http://schemas.openxmlformats.org/drawingml/2006/main">
               <a:ext uri="{FF2B5EF4-FFF2-40B4-BE49-F238E27FC236}">
-                <a16:creationId xmlns:a16="http://schemas.microsoft.com/office/drawing/2014/main" id="{223A9329-E88D-46E6-A2AF-4066F2862FC6}"/>
-              </a:ext>
-            </a:extLst>
-          </p:cNvPr>
-          <p:cNvSpPr>
-            <a:spLocks xmlns:a="http://schemas.openxmlformats.org/drawingml/2006/main" noGrp="1"/>
-          </p:cNvSpPr>
-          <p:nvPr/>
-        </p:nvSpPr>
-        <p:spPr>
-          <a:xfrm xmlns:a="http://schemas.openxmlformats.org/drawingml/2006/main">
-            <a:off x="7572375" y="3267075"/>
-            <a:ext cx="419100" cy="266700"/>
-          </a:xfrm>
-          <a:prstGeom xmlns:a="http://schemas.openxmlformats.org/drawingml/2006/main" prst="rect">
-            <a:avLst/>
-          </a:prstGeom>
-          <a:noFill xmlns:a="http://schemas.openxmlformats.org/drawingml/2006/main"/>
+                <a16:creationId xmlns:a16="http://schemas.microsoft.com/office/drawing/2014/main" id="{9F83E3E0-2B6D-4B95-AEC3-66FEDD711726}"/>
+              </a:ext>
+            </a:extLst>
+          </p:cNvPr>
+          <p:cNvSpPr>
+            <a:spLocks xmlns:a="http://schemas.openxmlformats.org/drawingml/2006/main" noGrp="1"/>
+          </p:cNvSpPr>
+          <p:nvPr/>
+        </p:nvSpPr>
+        <p:spPr>
+          <a:xfrm xmlns:a="http://schemas.openxmlformats.org/drawingml/2006/main">
+            <a:off x="7720360" y="3515057"/>
+            <a:ext cx="457200" cy="304800"/>
+          </a:xfrm>
+          <a:prstGeom xmlns:a="http://schemas.openxmlformats.org/drawingml/2006/main" prst="roundRect">
+            <a:avLst>
+              <a:gd name="adj" fmla="val 9375"/>
+            </a:avLst>
+          </a:prstGeom>
+          <a:solidFill xmlns:a="http://schemas.openxmlformats.org/drawingml/2006/main">
+            <a:srgbClr val="FFFFFF"/>
+          </a:solidFill>
           <a:ln xmlns:a="http://schemas.openxmlformats.org/drawingml/2006/main" w="0">
             <a:noFill/>
             <a:prstDash val="solid"/>
           </a:ln>
         </p:spPr>
         <p:txBody>
-          <a:bodyPr xmlns:a="http://schemas.openxmlformats.org/drawingml/2006/main" wrap="square" lIns="38100" tIns="19050" rIns="38100" bIns="19050" anchor="ctr">
-            <a:normAutofit fontScale="100000"/>
+          <a:bodyPr xmlns:a="http://schemas.openxmlformats.org/drawingml/2006/main" lIns="76200" tIns="47625" rIns="76200" bIns="47625" anchor="ctr">
+            <a:normAutofit fontScale="84344"/>
           </a:bodyPr>
           <a:lstStyle xmlns:a="http://schemas.openxmlformats.org/drawingml/2006/main"/>
           <a:p xmlns:a="http://schemas.openxmlformats.org/drawingml/2006/main">
             <a:pPr algn="ctr">
-              <a:defRPr sz="1275" b="1">
+              <a:defRPr sz="1500" b="1">
                 <a:solidFill>
                   <a:srgbClr val="E5A23C"/>
                 </a:solidFill>
@@ -7248,7 +7268,7 @@
               </a:defRPr>
             </a:pPr>
             <a:r>
-              <a:rPr sz="1275" b="1">
+              <a:rPr sz="1500" b="1">
                 <a:solidFill>
                   <a:srgbClr val="E5A23C"/>
                 </a:solidFill>
@@ -7266,7 +7286,7 @@
           <p:cNvPr id="28" name="">
             <a:extLst xmlns:a="http://schemas.openxmlformats.org/drawingml/2006/main">
               <a:ext uri="{FF2B5EF4-FFF2-40B4-BE49-F238E27FC236}">
-                <a16:creationId xmlns:a16="http://schemas.microsoft.com/office/drawing/2014/main" id="{C299A432-F5BD-4C60-A5CD-16F109A1BBB7}"/>
+                <a16:creationId xmlns:a16="http://schemas.microsoft.com/office/drawing/2014/main" id="{DFF7CB64-BF45-49CE-BAA7-99474211E9F8}"/>
               </a:ext>
             </a:extLst>
           </p:cNvPr>
@@ -7324,7 +7344,7 @@
           <p:cNvPr id="29" name="">
             <a:extLst xmlns:a="http://schemas.openxmlformats.org/drawingml/2006/main">
               <a:ext uri="{FF2B5EF4-FFF2-40B4-BE49-F238E27FC236}">
-                <a16:creationId xmlns:a16="http://schemas.microsoft.com/office/drawing/2014/main" id="{7CAEC61D-A984-41D4-AA14-FB6B12995344}"/>
+                <a16:creationId xmlns:a16="http://schemas.microsoft.com/office/drawing/2014/main" id="{EE0572AA-0BE1-429C-BF5E-D7B089784C26}"/>
               </a:ext>
             </a:extLst>
           </p:cNvPr>
@@ -7354,7 +7374,7 @@
       </p:sp>
       <p:cxnSp>
         <p:nvCxnSpPr>
-          <p:cNvPr id="65" name=""/>
+          <p:cNvPr id="64" name=""/>
           <p:cNvCxnSpPr>
             <a:stCxn xmlns:a="http://schemas.openxmlformats.org/drawingml/2006/main" id="29" idx="7"/>
             <a:endCxn xmlns:a="http://schemas.openxmlformats.org/drawingml/2006/main" id="20" idx="3"/>
@@ -7383,37 +7403,41 @@
           <p:cNvPr id="31" name="">
             <a:extLst xmlns:a="http://schemas.openxmlformats.org/drawingml/2006/main">
               <a:ext uri="{FF2B5EF4-FFF2-40B4-BE49-F238E27FC236}">
-                <a16:creationId xmlns:a16="http://schemas.microsoft.com/office/drawing/2014/main" id="{3522710C-9A33-4F34-9847-1C544BE17D89}"/>
-              </a:ext>
-            </a:extLst>
-          </p:cNvPr>
-          <p:cNvSpPr>
-            <a:spLocks xmlns:a="http://schemas.openxmlformats.org/drawingml/2006/main" noGrp="1"/>
-          </p:cNvSpPr>
-          <p:nvPr/>
-        </p:nvSpPr>
-        <p:spPr>
-          <a:xfrm xmlns:a="http://schemas.openxmlformats.org/drawingml/2006/main">
-            <a:off x="8477250" y="4410075"/>
-            <a:ext cx="419100" cy="266700"/>
-          </a:xfrm>
-          <a:prstGeom xmlns:a="http://schemas.openxmlformats.org/drawingml/2006/main" prst="rect">
-            <a:avLst/>
-          </a:prstGeom>
-          <a:noFill xmlns:a="http://schemas.openxmlformats.org/drawingml/2006/main"/>
+                <a16:creationId xmlns:a16="http://schemas.microsoft.com/office/drawing/2014/main" id="{85D1ACD1-9CFE-4D3A-A788-DADCD0616F52}"/>
+              </a:ext>
+            </a:extLst>
+          </p:cNvPr>
+          <p:cNvSpPr>
+            <a:spLocks xmlns:a="http://schemas.openxmlformats.org/drawingml/2006/main" noGrp="1"/>
+          </p:cNvSpPr>
+          <p:nvPr/>
+        </p:nvSpPr>
+        <p:spPr>
+          <a:xfrm xmlns:a="http://schemas.openxmlformats.org/drawingml/2006/main">
+            <a:off x="8543978" y="4315269"/>
+            <a:ext cx="457200" cy="304800"/>
+          </a:xfrm>
+          <a:prstGeom xmlns:a="http://schemas.openxmlformats.org/drawingml/2006/main" prst="roundRect">
+            <a:avLst>
+              <a:gd name="adj" fmla="val 9375"/>
+            </a:avLst>
+          </a:prstGeom>
+          <a:solidFill xmlns:a="http://schemas.openxmlformats.org/drawingml/2006/main">
+            <a:srgbClr val="FFFFFF"/>
+          </a:solidFill>
           <a:ln xmlns:a="http://schemas.openxmlformats.org/drawingml/2006/main" w="0">
             <a:noFill/>
             <a:prstDash val="solid"/>
           </a:ln>
         </p:spPr>
         <p:txBody>
-          <a:bodyPr xmlns:a="http://schemas.openxmlformats.org/drawingml/2006/main" wrap="square" lIns="38100" tIns="19050" rIns="38100" bIns="19050" anchor="ctr">
-            <a:normAutofit fontScale="100000"/>
+          <a:bodyPr xmlns:a="http://schemas.openxmlformats.org/drawingml/2006/main" lIns="76200" tIns="47625" rIns="76200" bIns="47625" anchor="ctr">
+            <a:normAutofit fontScale="84344"/>
           </a:bodyPr>
           <a:lstStyle xmlns:a="http://schemas.openxmlformats.org/drawingml/2006/main"/>
           <a:p xmlns:a="http://schemas.openxmlformats.org/drawingml/2006/main">
             <a:pPr algn="ctr">
-              <a:defRPr sz="1275" b="1">
+              <a:defRPr sz="1500" b="1">
                 <a:solidFill>
                   <a:srgbClr val="398D84"/>
                 </a:solidFill>
@@ -7423,7 +7447,7 @@
               </a:defRPr>
             </a:pPr>
             <a:r>
-              <a:rPr sz="1275" b="1">
+              <a:rPr sz="1500" b="1">
                 <a:solidFill>
                   <a:srgbClr val="398D84"/>
                 </a:solidFill>
@@ -7441,7 +7465,7 @@
           <p:cNvPr id="32" name="">
             <a:extLst xmlns:a="http://schemas.openxmlformats.org/drawingml/2006/main">
               <a:ext uri="{FF2B5EF4-FFF2-40B4-BE49-F238E27FC236}">
-                <a16:creationId xmlns:a16="http://schemas.microsoft.com/office/drawing/2014/main" id="{90EEB22B-FA52-4FC2-84A5-D14695432BEA}"/>
+                <a16:creationId xmlns:a16="http://schemas.microsoft.com/office/drawing/2014/main" id="{20EED424-136A-4B51-A112-C0404435506E}"/>
               </a:ext>
             </a:extLst>
           </p:cNvPr>
@@ -7499,71 +7523,7 @@
           <p:cNvPr id="33" name="">
             <a:extLst xmlns:a="http://schemas.openxmlformats.org/drawingml/2006/main">
               <a:ext uri="{FF2B5EF4-FFF2-40B4-BE49-F238E27FC236}">
-                <a16:creationId xmlns:a16="http://schemas.microsoft.com/office/drawing/2014/main" id="{5650606E-370A-43FF-BE36-7B849BB7BF53}"/>
-              </a:ext>
-            </a:extLst>
-          </p:cNvPr>
-          <p:cNvSpPr>
-            <a:spLocks xmlns:a="http://schemas.openxmlformats.org/drawingml/2006/main" noGrp="1"/>
-          </p:cNvSpPr>
-          <p:nvPr/>
-        </p:nvSpPr>
-        <p:spPr>
-          <a:xfrm xmlns:a="http://schemas.openxmlformats.org/drawingml/2006/main">
-            <a:off x="8477250" y="5143500"/>
-            <a:ext cx="2381250" cy="428625"/>
-          </a:xfrm>
-          <a:prstGeom xmlns:a="http://schemas.openxmlformats.org/drawingml/2006/main" prst="roundRect">
-            <a:avLst>
-              <a:gd name="adj" fmla="val 31111"/>
-            </a:avLst>
-          </a:prstGeom>
-          <a:solidFill xmlns:a="http://schemas.openxmlformats.org/drawingml/2006/main">
-            <a:srgbClr val="F1ECF7"/>
-          </a:solidFill>
-          <a:ln xmlns:a="http://schemas.openxmlformats.org/drawingml/2006/main" w="19050">
-            <a:solidFill>
-              <a:srgbClr val="8064A2"/>
-            </a:solidFill>
-            <a:prstDash val="solid"/>
-          </a:ln>
-        </p:spPr>
-        <p:txBody>
-          <a:bodyPr xmlns:a="http://schemas.openxmlformats.org/drawingml/2006/main" lIns="76200" tIns="47625" rIns="76200" bIns="47625" anchor="ctr">
-            <a:normAutofit fontScale="100000"/>
-          </a:bodyPr>
-          <a:lstStyle xmlns:a="http://schemas.openxmlformats.org/drawingml/2006/main"/>
-          <a:p xmlns:a="http://schemas.openxmlformats.org/drawingml/2006/main">
-            <a:pPr algn="ctr">
-              <a:defRPr sz="1350" b="1">
-                <a:solidFill>
-                  <a:srgbClr val="8064A2"/>
-                </a:solidFill>
-                <a:latin typeface="Arial"/>
-                <a:ea typeface="Arial"/>
-                <a:cs typeface="Arial"/>
-              </a:defRPr>
-            </a:pPr>
-            <a:r>
-              <a:rPr sz="1350" b="1">
-                <a:solidFill>
-                  <a:srgbClr val="8064A2"/>
-                </a:solidFill>
-                <a:latin typeface="Arial"/>
-                <a:ea typeface="Arial"/>
-                <a:cs typeface="Arial"/>
-              </a:rPr>
-              <a:t>multi-head attention</a:t>
-            </a:r>
-          </a:p>
-        </p:txBody>
-      </p:sp>
-      <p:sp>
-        <p:nvSpPr>
-          <p:cNvPr id="34" name="">
-            <a:extLst xmlns:a="http://schemas.openxmlformats.org/drawingml/2006/main">
-              <a:ext uri="{FF2B5EF4-FFF2-40B4-BE49-F238E27FC236}">
-                <a16:creationId xmlns:a16="http://schemas.microsoft.com/office/drawing/2014/main" id="{5EAB9987-DF1D-45C6-968A-065F7A1475E2}"/>
+                <a16:creationId xmlns:a16="http://schemas.microsoft.com/office/drawing/2014/main" id="{7E6B3781-BC25-4CB0-A9A4-61B2E9701EFF}"/>
               </a:ext>
             </a:extLst>
           </p:cNvPr>
@@ -7618,10 +7578,10 @@
       </p:sp>
       <p:sp>
         <p:nvSpPr>
-          <p:cNvPr id="35" name="">
-            <a:extLst xmlns:a="http://schemas.openxmlformats.org/drawingml/2006/main">
-              <a:ext uri="{FF2B5EF4-FFF2-40B4-BE49-F238E27FC236}">
-                <a16:creationId xmlns:a16="http://schemas.microsoft.com/office/drawing/2014/main" id="{02CB7A75-1DE6-4470-BBD5-4BE887222EB0}"/>
+          <p:cNvPr id="34" name="">
+            <a:extLst xmlns:a="http://schemas.openxmlformats.org/drawingml/2006/main">
+              <a:ext uri="{FF2B5EF4-FFF2-40B4-BE49-F238E27FC236}">
+                <a16:creationId xmlns:a16="http://schemas.microsoft.com/office/drawing/2014/main" id="{4298B516-36A9-49C4-8297-09F07566DDFD}"/>
               </a:ext>
             </a:extLst>
           </p:cNvPr>
@@ -7646,7 +7606,7 @@
         </p:spPr>
         <p:txBody>
           <a:bodyPr xmlns:a="http://schemas.openxmlformats.org/drawingml/2006/main" wrap="square" lIns="38100" tIns="19050" rIns="38100" bIns="19050" anchor="ctr">
-            <a:normAutofit fontScale="98770"/>
+            <a:normAutofit fontScale="100000"/>
           </a:bodyPr>
           <a:lstStyle xmlns:a="http://schemas.openxmlformats.org/drawingml/2006/main"/>
           <a:p xmlns:a="http://schemas.openxmlformats.org/drawingml/2006/main">
@@ -7669,7 +7629,7 @@
                 <a:ea typeface="Arial"/>
                 <a:cs typeface="Arial"/>
               </a:rPr>
-              <a:t>Релациски зависна тежина на вниманието</a:t>
+              <a:t>Релациски зависен attention</a:t>
             </a:r>
           </a:p>
         </p:txBody>
@@ -7677,7 +7637,7 @@
     </p:spTree>
     <p:extLst>
       <p:ext uri="{BB962C8B-B14F-4D97-AF65-F5344CB8AC3E}">
-        <p14:creationId xmlns:p14="http://schemas.microsoft.com/office/powerpoint/2010/main" val="463479179"/>
+        <p14:creationId xmlns:p14="http://schemas.microsoft.com/office/powerpoint/2010/main" val="1094501853"/>
       </p:ext>
     </p:extLst>
   </p:cSld>
@@ -7708,18 +7668,18 @@
           <p:cNvPr id="20" name="">
             <a:extLst xmlns:a="http://schemas.openxmlformats.org/drawingml/2006/main">
               <a:ext uri="{FF2B5EF4-FFF2-40B4-BE49-F238E27FC236}">
-                <a16:creationId xmlns:a16="http://schemas.microsoft.com/office/drawing/2014/main" id="{F4D10922-71E7-4DE4-84D4-20919FCD9C70}"/>
-              </a:ext>
-            </a:extLst>
-          </p:cNvPr>
-          <p:cNvSpPr>
-            <a:spLocks xmlns:a="http://schemas.openxmlformats.org/drawingml/2006/main" noGrp="1"/>
-          </p:cNvSpPr>
-          <p:nvPr/>
-        </p:nvSpPr>
-        <p:spPr>
-          <a:xfrm xmlns:a="http://schemas.openxmlformats.org/drawingml/2006/main">
-            <a:off x="666750" y="2619375"/>
+                <a16:creationId xmlns:a16="http://schemas.microsoft.com/office/drawing/2014/main" id="{2E3AFA8B-4427-4273-B0BE-CDDE59078B3E}"/>
+              </a:ext>
+            </a:extLst>
+          </p:cNvPr>
+          <p:cNvSpPr>
+            <a:spLocks xmlns:a="http://schemas.openxmlformats.org/drawingml/2006/main" noGrp="1"/>
+          </p:cNvSpPr>
+          <p:nvPr/>
+        </p:nvSpPr>
+        <p:spPr>
+          <a:xfrm xmlns:a="http://schemas.openxmlformats.org/drawingml/2006/main">
+            <a:off x="666750" y="2881313"/>
             <a:ext cx="1571625" cy="666750"/>
           </a:xfrm>
           <a:prstGeom xmlns:a="http://schemas.openxmlformats.org/drawingml/2006/main" prst="roundRect">
@@ -7772,7 +7732,7 @@
           <p:cNvPr id="2" name="">
             <a:extLst xmlns:a="http://schemas.openxmlformats.org/drawingml/2006/main">
               <a:ext uri="{FF2B5EF4-FFF2-40B4-BE49-F238E27FC236}">
-                <a16:creationId xmlns:a16="http://schemas.microsoft.com/office/drawing/2014/main" id="{748716F2-711D-4BC2-8832-49EC530B59CA}"/>
+                <a16:creationId xmlns:a16="http://schemas.microsoft.com/office/drawing/2014/main" id="{7673DC5D-C89B-4D08-B5EA-42664C68AAFA}"/>
               </a:ext>
             </a:extLst>
           </p:cNvPr>
@@ -7859,7 +7819,7 @@
           <p:cNvPr id="3" name="">
             <a:extLst xmlns:a="http://schemas.openxmlformats.org/drawingml/2006/main">
               <a:ext uri="{FF2B5EF4-FFF2-40B4-BE49-F238E27FC236}">
-                <a16:creationId xmlns:a16="http://schemas.microsoft.com/office/drawing/2014/main" id="{FADC536D-67D4-4122-9EEB-56B3B7BBDABD}"/>
+                <a16:creationId xmlns:a16="http://schemas.microsoft.com/office/drawing/2014/main" id="{AE85C559-4651-427A-90C0-2C424A08AC27}"/>
               </a:ext>
             </a:extLst>
           </p:cNvPr>
@@ -7946,7 +7906,7 @@
           <p:cNvPr id="4" name="">
             <a:extLst xmlns:a="http://schemas.openxmlformats.org/drawingml/2006/main">
               <a:ext uri="{FF2B5EF4-FFF2-40B4-BE49-F238E27FC236}">
-                <a16:creationId xmlns:a16="http://schemas.microsoft.com/office/drawing/2014/main" id="{CD75036E-DEDC-40DD-9B30-7170AF08A81B}"/>
+                <a16:creationId xmlns:a16="http://schemas.microsoft.com/office/drawing/2014/main" id="{057D4A76-6977-4027-8041-C95F43D2FBCD}"/>
               </a:ext>
             </a:extLst>
           </p:cNvPr>
@@ -8033,7 +7993,7 @@
           <p:cNvPr id="5" name="">
             <a:extLst xmlns:a="http://schemas.openxmlformats.org/drawingml/2006/main">
               <a:ext uri="{FF2B5EF4-FFF2-40B4-BE49-F238E27FC236}">
-                <a16:creationId xmlns:a16="http://schemas.microsoft.com/office/drawing/2014/main" id="{E8966D6D-B6F7-4361-9F9D-075ABAA84679}"/>
+                <a16:creationId xmlns:a16="http://schemas.microsoft.com/office/drawing/2014/main" id="{212C3E75-D08A-46CD-9D6B-A31FCE78A411}"/>
               </a:ext>
             </a:extLst>
           </p:cNvPr>
@@ -8127,7 +8087,7 @@
         <p:spPr>
           <a:xfrm xmlns:a="http://schemas.openxmlformats.org/drawingml/2006/main" flipV="1">
             <a:off x="2238375" y="1452563"/>
-            <a:ext cx="809625" cy="1500188"/>
+            <a:ext cx="809625" cy="1762126"/>
           </a:xfrm>
           <a:prstGeom xmlns:a="http://schemas.openxmlformats.org/drawingml/2006/main" prst="bentConnector3">
             <a:avLst>
@@ -8260,7 +8220,7 @@
           <p:cNvPr id="11" name="">
             <a:extLst xmlns:a="http://schemas.openxmlformats.org/drawingml/2006/main">
               <a:ext uri="{FF2B5EF4-FFF2-40B4-BE49-F238E27FC236}">
-                <a16:creationId xmlns:a16="http://schemas.microsoft.com/office/drawing/2014/main" id="{79C1CE8B-13A6-41E0-98DF-E6328624AB24}"/>
+                <a16:creationId xmlns:a16="http://schemas.microsoft.com/office/drawing/2014/main" id="{3C3FC464-14E1-424E-AAF9-2977294ECB1B}"/>
               </a:ext>
             </a:extLst>
           </p:cNvPr>
@@ -8293,7 +8253,7 @@
           <p:cNvPr id="12" name="">
             <a:extLst xmlns:a="http://schemas.openxmlformats.org/drawingml/2006/main">
               <a:ext uri="{FF2B5EF4-FFF2-40B4-BE49-F238E27FC236}">
-                <a16:creationId xmlns:a16="http://schemas.microsoft.com/office/drawing/2014/main" id="{8D183C50-9788-4F34-9861-EB2FD99DF2EA}"/>
+                <a16:creationId xmlns:a16="http://schemas.microsoft.com/office/drawing/2014/main" id="{6E8A49B1-CDCA-4BDB-8CD7-1C2791230D83}"/>
               </a:ext>
             </a:extLst>
           </p:cNvPr>
@@ -8326,7 +8286,7 @@
           <p:cNvPr id="13" name="">
             <a:extLst xmlns:a="http://schemas.openxmlformats.org/drawingml/2006/main">
               <a:ext uri="{FF2B5EF4-FFF2-40B4-BE49-F238E27FC236}">
-                <a16:creationId xmlns:a16="http://schemas.microsoft.com/office/drawing/2014/main" id="{250ADCDC-E9A2-4C77-9B49-B7A644AA8F73}"/>
+                <a16:creationId xmlns:a16="http://schemas.microsoft.com/office/drawing/2014/main" id="{AD110F1A-33C8-4818-8F30-2606F44C182B}"/>
               </a:ext>
             </a:extLst>
           </p:cNvPr>
@@ -8359,7 +8319,7 @@
           <p:cNvPr id="14" name="">
             <a:extLst xmlns:a="http://schemas.openxmlformats.org/drawingml/2006/main">
               <a:ext uri="{FF2B5EF4-FFF2-40B4-BE49-F238E27FC236}">
-                <a16:creationId xmlns:a16="http://schemas.microsoft.com/office/drawing/2014/main" id="{D503007E-5FC7-40F8-986F-0C3DA505785E}"/>
+                <a16:creationId xmlns:a16="http://schemas.microsoft.com/office/drawing/2014/main" id="{E298F19E-FB15-4D91-A552-BCAFA8886A75}"/>
               </a:ext>
             </a:extLst>
           </p:cNvPr>
@@ -8442,7 +8402,7 @@
           <p:cNvPr id="17" name="">
             <a:extLst xmlns:a="http://schemas.openxmlformats.org/drawingml/2006/main">
               <a:ext uri="{FF2B5EF4-FFF2-40B4-BE49-F238E27FC236}">
-                <a16:creationId xmlns:a16="http://schemas.microsoft.com/office/drawing/2014/main" id="{55F8E0C2-BE2E-41ED-998B-D891DC767640}"/>
+                <a16:creationId xmlns:a16="http://schemas.microsoft.com/office/drawing/2014/main" id="{CFE61F5B-A454-416F-91E7-68C3FF8603AE}"/>
               </a:ext>
             </a:extLst>
           </p:cNvPr>
@@ -8500,7 +8460,7 @@
           <p:cNvPr id="18" name="">
             <a:extLst xmlns:a="http://schemas.openxmlformats.org/drawingml/2006/main">
               <a:ext uri="{FF2B5EF4-FFF2-40B4-BE49-F238E27FC236}">
-                <a16:creationId xmlns:a16="http://schemas.microsoft.com/office/drawing/2014/main" id="{A8DCDB6C-0EF5-43D5-AB2D-1F043B239DA3}"/>
+                <a16:creationId xmlns:a16="http://schemas.microsoft.com/office/drawing/2014/main" id="{B4768A90-9213-4334-8EB0-95B2BF7445E4}"/>
               </a:ext>
             </a:extLst>
           </p:cNvPr>
@@ -8558,7 +8518,7 @@
           <p:cNvPr id="19" name="">
             <a:extLst xmlns:a="http://schemas.openxmlformats.org/drawingml/2006/main">
               <a:ext uri="{FF2B5EF4-FFF2-40B4-BE49-F238E27FC236}">
-                <a16:creationId xmlns:a16="http://schemas.microsoft.com/office/drawing/2014/main" id="{86738B7B-5804-43C3-A58B-327848501BC3}"/>
+                <a16:creationId xmlns:a16="http://schemas.microsoft.com/office/drawing/2014/main" id="{03AE4EC4-5541-4552-A958-357A5F5E58AF}"/>
               </a:ext>
             </a:extLst>
           </p:cNvPr>
@@ -8614,7 +8574,7 @@
     </p:spTree>
     <p:extLst>
       <p:ext uri="{BB962C8B-B14F-4D97-AF65-F5344CB8AC3E}">
-        <p14:creationId xmlns:p14="http://schemas.microsoft.com/office/powerpoint/2010/main" val="1916626574"/>
+        <p14:creationId xmlns:p14="http://schemas.microsoft.com/office/powerpoint/2010/main" val="633598746"/>
       </p:ext>
     </p:extLst>
   </p:cSld>
@@ -8645,7 +8605,7 @@
           <p:cNvPr id="31" name="">
             <a:extLst xmlns:a="http://schemas.openxmlformats.org/drawingml/2006/main">
               <a:ext uri="{FF2B5EF4-FFF2-40B4-BE49-F238E27FC236}">
-                <a16:creationId xmlns:a16="http://schemas.microsoft.com/office/drawing/2014/main" id="{6584C78B-AC72-44A8-BE21-12E473E9F76E}"/>
+                <a16:creationId xmlns:a16="http://schemas.microsoft.com/office/drawing/2014/main" id="{C8459D33-58D1-4B4C-A0FE-A6D1E1F180B9}"/>
               </a:ext>
             </a:extLst>
           </p:cNvPr>
@@ -8703,7 +8663,7 @@
           <p:cNvPr id="2" name="">
             <a:extLst xmlns:a="http://schemas.openxmlformats.org/drawingml/2006/main">
               <a:ext uri="{FF2B5EF4-FFF2-40B4-BE49-F238E27FC236}">
-                <a16:creationId xmlns:a16="http://schemas.microsoft.com/office/drawing/2014/main" id="{24F5EFF4-B30E-4879-AC42-A5E155EE34F0}"/>
+                <a16:creationId xmlns:a16="http://schemas.microsoft.com/office/drawing/2014/main" id="{D47C0A17-AB03-44F1-9288-F89C560672BF}"/>
               </a:ext>
             </a:extLst>
           </p:cNvPr>
@@ -8761,7 +8721,7 @@
           <p:cNvPr id="3" name="">
             <a:extLst xmlns:a="http://schemas.openxmlformats.org/drawingml/2006/main">
               <a:ext uri="{FF2B5EF4-FFF2-40B4-BE49-F238E27FC236}">
-                <a16:creationId xmlns:a16="http://schemas.microsoft.com/office/drawing/2014/main" id="{7E66FB90-C339-41D8-8273-5C77791EB9C4}"/>
+                <a16:creationId xmlns:a16="http://schemas.microsoft.com/office/drawing/2014/main" id="{20396FA9-2427-4582-B513-D4BF8C546244}"/>
               </a:ext>
             </a:extLst>
           </p:cNvPr>
@@ -8819,7 +8779,7 @@
           <p:cNvPr id="4" name="">
             <a:extLst xmlns:a="http://schemas.openxmlformats.org/drawingml/2006/main">
               <a:ext uri="{FF2B5EF4-FFF2-40B4-BE49-F238E27FC236}">
-                <a16:creationId xmlns:a16="http://schemas.microsoft.com/office/drawing/2014/main" id="{B3673F5E-BDC1-4E05-B4AE-CF9B2476CFBE}"/>
+                <a16:creationId xmlns:a16="http://schemas.microsoft.com/office/drawing/2014/main" id="{B37010A4-2BD7-4C2D-8F86-9E67590BE22C}"/>
               </a:ext>
             </a:extLst>
           </p:cNvPr>
@@ -8877,7 +8837,7 @@
           <p:cNvPr id="5" name="">
             <a:extLst xmlns:a="http://schemas.openxmlformats.org/drawingml/2006/main">
               <a:ext uri="{FF2B5EF4-FFF2-40B4-BE49-F238E27FC236}">
-                <a16:creationId xmlns:a16="http://schemas.microsoft.com/office/drawing/2014/main" id="{F50DB8A4-1B10-40FD-B940-96432D9F302A}"/>
+                <a16:creationId xmlns:a16="http://schemas.microsoft.com/office/drawing/2014/main" id="{E204DCD1-1171-4A25-B1B7-DB2A1067F413}"/>
               </a:ext>
             </a:extLst>
           </p:cNvPr>
@@ -8910,7 +8870,7 @@
           <p:cNvPr id="6" name="">
             <a:extLst xmlns:a="http://schemas.openxmlformats.org/drawingml/2006/main">
               <a:ext uri="{FF2B5EF4-FFF2-40B4-BE49-F238E27FC236}">
-                <a16:creationId xmlns:a16="http://schemas.microsoft.com/office/drawing/2014/main" id="{CA417CEE-B9FB-40A6-9C41-09CE7E146966}"/>
+                <a16:creationId xmlns:a16="http://schemas.microsoft.com/office/drawing/2014/main" id="{1B669113-52FE-4DED-8B2C-57BECED9D3F7}"/>
               </a:ext>
             </a:extLst>
           </p:cNvPr>
@@ -8968,7 +8928,7 @@
           <p:cNvPr id="7" name="">
             <a:extLst xmlns:a="http://schemas.openxmlformats.org/drawingml/2006/main">
               <a:ext uri="{FF2B5EF4-FFF2-40B4-BE49-F238E27FC236}">
-                <a16:creationId xmlns:a16="http://schemas.microsoft.com/office/drawing/2014/main" id="{86499EE5-8639-4B10-A3A2-015C44BE65C0}"/>
+                <a16:creationId xmlns:a16="http://schemas.microsoft.com/office/drawing/2014/main" id="{3FF5B224-1DD4-473B-8720-0AE6208BA02A}"/>
               </a:ext>
             </a:extLst>
           </p:cNvPr>
@@ -9032,7 +8992,7 @@
           <p:cNvPr id="8" name="">
             <a:extLst xmlns:a="http://schemas.openxmlformats.org/drawingml/2006/main">
               <a:ext uri="{FF2B5EF4-FFF2-40B4-BE49-F238E27FC236}">
-                <a16:creationId xmlns:a16="http://schemas.microsoft.com/office/drawing/2014/main" id="{B3308572-AE2A-46B1-A56D-2F55E1C30970}"/>
+                <a16:creationId xmlns:a16="http://schemas.microsoft.com/office/drawing/2014/main" id="{04F2D261-9B5F-4CBD-A904-5FAE1B6736D2}"/>
               </a:ext>
             </a:extLst>
           </p:cNvPr>
@@ -9090,7 +9050,7 @@
           <p:cNvPr id="9" name="">
             <a:extLst xmlns:a="http://schemas.openxmlformats.org/drawingml/2006/main">
               <a:ext uri="{FF2B5EF4-FFF2-40B4-BE49-F238E27FC236}">
-                <a16:creationId xmlns:a16="http://schemas.microsoft.com/office/drawing/2014/main" id="{95E44C7C-95A9-4E3F-9561-75748EBE3008}"/>
+                <a16:creationId xmlns:a16="http://schemas.microsoft.com/office/drawing/2014/main" id="{696C30FA-59F8-4B23-95E9-3BE17A11A801}"/>
               </a:ext>
             </a:extLst>
           </p:cNvPr>
@@ -9123,7 +9083,7 @@
           <p:cNvPr id="10" name="">
             <a:extLst xmlns:a="http://schemas.openxmlformats.org/drawingml/2006/main">
               <a:ext uri="{FF2B5EF4-FFF2-40B4-BE49-F238E27FC236}">
-                <a16:creationId xmlns:a16="http://schemas.microsoft.com/office/drawing/2014/main" id="{C63F9480-0E62-4214-BC0F-6CD0AB2A136C}"/>
+                <a16:creationId xmlns:a16="http://schemas.microsoft.com/office/drawing/2014/main" id="{6F930DAF-4BBA-4557-BB58-39016FD14F5A}"/>
               </a:ext>
             </a:extLst>
           </p:cNvPr>
@@ -9156,7 +9116,7 @@
           <p:cNvPr id="11" name="">
             <a:extLst xmlns:a="http://schemas.openxmlformats.org/drawingml/2006/main">
               <a:ext uri="{FF2B5EF4-FFF2-40B4-BE49-F238E27FC236}">
-                <a16:creationId xmlns:a16="http://schemas.microsoft.com/office/drawing/2014/main" id="{ECB8E68E-6AC2-4DFD-922D-AD6D61C3E670}"/>
+                <a16:creationId xmlns:a16="http://schemas.microsoft.com/office/drawing/2014/main" id="{302E75A6-5A21-4912-AF63-07E7BF89C6C1}"/>
               </a:ext>
             </a:extLst>
           </p:cNvPr>
@@ -9189,7 +9149,7 @@
           <p:cNvPr id="12" name="">
             <a:extLst xmlns:a="http://schemas.openxmlformats.org/drawingml/2006/main">
               <a:ext uri="{FF2B5EF4-FFF2-40B4-BE49-F238E27FC236}">
-                <a16:creationId xmlns:a16="http://schemas.microsoft.com/office/drawing/2014/main" id="{6BF3AFF0-A159-4F8E-867A-8E48FBF597E9}"/>
+                <a16:creationId xmlns:a16="http://schemas.microsoft.com/office/drawing/2014/main" id="{591F86E3-1FFD-4AF2-870E-FD3454ED6544}"/>
               </a:ext>
             </a:extLst>
           </p:cNvPr>
@@ -9222,7 +9182,7 @@
           <p:cNvPr id="13" name="">
             <a:extLst xmlns:a="http://schemas.openxmlformats.org/drawingml/2006/main">
               <a:ext uri="{FF2B5EF4-FFF2-40B4-BE49-F238E27FC236}">
-                <a16:creationId xmlns:a16="http://schemas.microsoft.com/office/drawing/2014/main" id="{CD56F96D-19DB-4769-924F-8BE504C4E901}"/>
+                <a16:creationId xmlns:a16="http://schemas.microsoft.com/office/drawing/2014/main" id="{C8C5B7F8-CEFB-4D07-A07F-999D78C405EB}"/>
               </a:ext>
             </a:extLst>
           </p:cNvPr>
@@ -9255,7 +9215,7 @@
           <p:cNvPr id="14" name="">
             <a:extLst xmlns:a="http://schemas.openxmlformats.org/drawingml/2006/main">
               <a:ext uri="{FF2B5EF4-FFF2-40B4-BE49-F238E27FC236}">
-                <a16:creationId xmlns:a16="http://schemas.microsoft.com/office/drawing/2014/main" id="{A9DB9F68-8C7B-4057-A14F-7AC15150724A}"/>
+                <a16:creationId xmlns:a16="http://schemas.microsoft.com/office/drawing/2014/main" id="{E7283E01-6AFA-4C42-B495-1AC6CCA96FFD}"/>
               </a:ext>
             </a:extLst>
           </p:cNvPr>
@@ -9286,7 +9246,7 @@
           <p:cNvPr id="15" name="">
             <a:extLst xmlns:a="http://schemas.openxmlformats.org/drawingml/2006/main">
               <a:ext uri="{FF2B5EF4-FFF2-40B4-BE49-F238E27FC236}">
-                <a16:creationId xmlns:a16="http://schemas.microsoft.com/office/drawing/2014/main" id="{3F1CAF31-E5C7-4843-9AB1-4527D9CA46E2}"/>
+                <a16:creationId xmlns:a16="http://schemas.microsoft.com/office/drawing/2014/main" id="{3977F16D-984D-4463-9BBA-BF788A753F65}"/>
               </a:ext>
             </a:extLst>
           </p:cNvPr>
@@ -9344,7 +9304,7 @@
           <p:cNvPr id="16" name="">
             <a:extLst xmlns:a="http://schemas.openxmlformats.org/drawingml/2006/main">
               <a:ext uri="{FF2B5EF4-FFF2-40B4-BE49-F238E27FC236}">
-                <a16:creationId xmlns:a16="http://schemas.microsoft.com/office/drawing/2014/main" id="{2A9AE9A7-F3BC-4E57-869F-81AFDD1157A3}"/>
+                <a16:creationId xmlns:a16="http://schemas.microsoft.com/office/drawing/2014/main" id="{05112559-A6E1-4F9D-A839-7262F892A9E3}"/>
               </a:ext>
             </a:extLst>
           </p:cNvPr>
@@ -9377,7 +9337,7 @@
           <p:cNvPr id="17" name="">
             <a:extLst xmlns:a="http://schemas.openxmlformats.org/drawingml/2006/main">
               <a:ext uri="{FF2B5EF4-FFF2-40B4-BE49-F238E27FC236}">
-                <a16:creationId xmlns:a16="http://schemas.microsoft.com/office/drawing/2014/main" id="{C69E203E-1B1E-42B0-B4CF-1BC8B30380F1}"/>
+                <a16:creationId xmlns:a16="http://schemas.microsoft.com/office/drawing/2014/main" id="{933E2968-492C-4D56-8992-FCDD33226534}"/>
               </a:ext>
             </a:extLst>
           </p:cNvPr>
@@ -9617,7 +9577,7 @@
           <p:cNvPr id="25" name="">
             <a:extLst xmlns:a="http://schemas.openxmlformats.org/drawingml/2006/main">
               <a:ext uri="{FF2B5EF4-FFF2-40B4-BE49-F238E27FC236}">
-                <a16:creationId xmlns:a16="http://schemas.microsoft.com/office/drawing/2014/main" id="{CB6EE6CE-175B-4A48-AEEA-3CB2747D6D23}"/>
+                <a16:creationId xmlns:a16="http://schemas.microsoft.com/office/drawing/2014/main" id="{82D76A54-4DC1-4B41-9B01-1C002AB9A70F}"/>
               </a:ext>
             </a:extLst>
           </p:cNvPr>
@@ -9675,7 +9635,7 @@
           <p:cNvPr id="26" name="">
             <a:extLst xmlns:a="http://schemas.openxmlformats.org/drawingml/2006/main">
               <a:ext uri="{FF2B5EF4-FFF2-40B4-BE49-F238E27FC236}">
-                <a16:creationId xmlns:a16="http://schemas.microsoft.com/office/drawing/2014/main" id="{1CCA1AC1-1591-4998-8513-41B1A97D3CD6}"/>
+                <a16:creationId xmlns:a16="http://schemas.microsoft.com/office/drawing/2014/main" id="{92C802DB-CD0C-469B-BA43-9F0A1E1AAB18}"/>
               </a:ext>
             </a:extLst>
           </p:cNvPr>
@@ -9733,7 +9693,7 @@
           <p:cNvPr id="27" name="">
             <a:extLst xmlns:a="http://schemas.openxmlformats.org/drawingml/2006/main">
               <a:ext uri="{FF2B5EF4-FFF2-40B4-BE49-F238E27FC236}">
-                <a16:creationId xmlns:a16="http://schemas.microsoft.com/office/drawing/2014/main" id="{304D8F35-D116-4496-B5C1-CFE1BC9B3389}"/>
+                <a16:creationId xmlns:a16="http://schemas.microsoft.com/office/drawing/2014/main" id="{F2217E46-5396-40F2-B313-18472B792D0C}"/>
               </a:ext>
             </a:extLst>
           </p:cNvPr>
@@ -9791,7 +9751,7 @@
           <p:cNvPr id="28" name="">
             <a:extLst xmlns:a="http://schemas.openxmlformats.org/drawingml/2006/main">
               <a:ext uri="{FF2B5EF4-FFF2-40B4-BE49-F238E27FC236}">
-                <a16:creationId xmlns:a16="http://schemas.microsoft.com/office/drawing/2014/main" id="{329AA3E7-3B68-4C8C-87D6-A82B5887EA79}"/>
+                <a16:creationId xmlns:a16="http://schemas.microsoft.com/office/drawing/2014/main" id="{5916DA3B-6213-4566-A57A-A6B13B88163C}"/>
               </a:ext>
             </a:extLst>
           </p:cNvPr>
@@ -9855,7 +9815,7 @@
           <p:cNvPr id="29" name="">
             <a:extLst xmlns:a="http://schemas.openxmlformats.org/drawingml/2006/main">
               <a:ext uri="{FF2B5EF4-FFF2-40B4-BE49-F238E27FC236}">
-                <a16:creationId xmlns:a16="http://schemas.microsoft.com/office/drawing/2014/main" id="{9C604FEF-BD45-4C43-AC21-0507A74BFCA1}"/>
+                <a16:creationId xmlns:a16="http://schemas.microsoft.com/office/drawing/2014/main" id="{7E1DAC37-AFEB-4F83-8CA3-103FA01F41B7}"/>
               </a:ext>
             </a:extLst>
           </p:cNvPr>
@@ -9919,7 +9879,7 @@
           <p:cNvPr id="30" name="">
             <a:extLst xmlns:a="http://schemas.openxmlformats.org/drawingml/2006/main">
               <a:ext uri="{FF2B5EF4-FFF2-40B4-BE49-F238E27FC236}">
-                <a16:creationId xmlns:a16="http://schemas.microsoft.com/office/drawing/2014/main" id="{1D17ABF4-A65C-47B4-9FD7-A0407EABB3A3}"/>
+                <a16:creationId xmlns:a16="http://schemas.microsoft.com/office/drawing/2014/main" id="{5F9F156F-C948-41E6-9C2E-00A0D0FC1BD7}"/>
               </a:ext>
             </a:extLst>
           </p:cNvPr>
@@ -9975,7 +9935,7 @@
     </p:spTree>
     <p:extLst>
       <p:ext uri="{BB962C8B-B14F-4D97-AF65-F5344CB8AC3E}">
-        <p14:creationId xmlns:p14="http://schemas.microsoft.com/office/powerpoint/2010/main" val="2062243109"/>
+        <p14:creationId xmlns:p14="http://schemas.microsoft.com/office/powerpoint/2010/main" val="320681199"/>
       </p:ext>
     </p:extLst>
   </p:cSld>
@@ -10003,10 +9963,10 @@
       </p:grpSpPr>
       <p:sp>
         <p:nvSpPr>
-          <p:cNvPr id="40" name="">
-            <a:extLst xmlns:a="http://schemas.openxmlformats.org/drawingml/2006/main">
-              <a:ext uri="{FF2B5EF4-FFF2-40B4-BE49-F238E27FC236}">
-                <a16:creationId xmlns:a16="http://schemas.microsoft.com/office/drawing/2014/main" id="{18D9699F-5BBC-4D7C-BD2B-0DA9309F8C80}"/>
+          <p:cNvPr id="38" name="">
+            <a:extLst xmlns:a="http://schemas.openxmlformats.org/drawingml/2006/main">
+              <a:ext uri="{FF2B5EF4-FFF2-40B4-BE49-F238E27FC236}">
+                <a16:creationId xmlns:a16="http://schemas.microsoft.com/office/drawing/2014/main" id="{F6F4B4AB-D065-4F07-ACA0-EA32469E7D8B}"/>
               </a:ext>
             </a:extLst>
           </p:cNvPr>
@@ -10064,7 +10024,7 @@
           <p:cNvPr id="2" name="">
             <a:extLst xmlns:a="http://schemas.openxmlformats.org/drawingml/2006/main">
               <a:ext uri="{FF2B5EF4-FFF2-40B4-BE49-F238E27FC236}">
-                <a16:creationId xmlns:a16="http://schemas.microsoft.com/office/drawing/2014/main" id="{A5258690-B156-4942-9A29-C3B13A358DE9}"/>
+                <a16:creationId xmlns:a16="http://schemas.microsoft.com/office/drawing/2014/main" id="{E8AC0D95-D96E-4D3D-859B-4BA72C686ECA}"/>
               </a:ext>
             </a:extLst>
           </p:cNvPr>
@@ -10122,7 +10082,7 @@
           <p:cNvPr id="3" name="">
             <a:extLst xmlns:a="http://schemas.openxmlformats.org/drawingml/2006/main">
               <a:ext uri="{FF2B5EF4-FFF2-40B4-BE49-F238E27FC236}">
-                <a16:creationId xmlns:a16="http://schemas.microsoft.com/office/drawing/2014/main" id="{3E102322-B84D-4068-A090-B72D753EE01B}"/>
+                <a16:creationId xmlns:a16="http://schemas.microsoft.com/office/drawing/2014/main" id="{A16AF2D5-6DE3-4738-BB13-52E7C6B31F77}"/>
               </a:ext>
             </a:extLst>
           </p:cNvPr>
@@ -10153,7 +10113,7 @@
           <p:cNvPr id="4" name="">
             <a:extLst xmlns:a="http://schemas.openxmlformats.org/drawingml/2006/main">
               <a:ext uri="{FF2B5EF4-FFF2-40B4-BE49-F238E27FC236}">
-                <a16:creationId xmlns:a16="http://schemas.microsoft.com/office/drawing/2014/main" id="{6E685770-0C1F-47F1-A6E3-5FB72EF1CC52}"/>
+                <a16:creationId xmlns:a16="http://schemas.microsoft.com/office/drawing/2014/main" id="{B00A9CFD-6A3F-45DF-BCC0-E5A54DC2FE62}"/>
               </a:ext>
             </a:extLst>
           </p:cNvPr>
@@ -10186,7 +10146,7 @@
           <p:cNvPr id="5" name="">
             <a:extLst xmlns:a="http://schemas.openxmlformats.org/drawingml/2006/main">
               <a:ext uri="{FF2B5EF4-FFF2-40B4-BE49-F238E27FC236}">
-                <a16:creationId xmlns:a16="http://schemas.microsoft.com/office/drawing/2014/main" id="{B243C9EC-4E89-495F-8621-5913D5E9A4BD}"/>
+                <a16:creationId xmlns:a16="http://schemas.microsoft.com/office/drawing/2014/main" id="{3DC54B27-1BF4-42EA-8E9E-18E832CF98C9}"/>
               </a:ext>
             </a:extLst>
           </p:cNvPr>
@@ -10219,7 +10179,7 @@
           <p:cNvPr id="6" name="">
             <a:extLst xmlns:a="http://schemas.openxmlformats.org/drawingml/2006/main">
               <a:ext uri="{FF2B5EF4-FFF2-40B4-BE49-F238E27FC236}">
-                <a16:creationId xmlns:a16="http://schemas.microsoft.com/office/drawing/2014/main" id="{FDE02062-AA89-40E8-B17C-A74BE1CA74EE}"/>
+                <a16:creationId xmlns:a16="http://schemas.microsoft.com/office/drawing/2014/main" id="{F7C2F928-B9C2-4287-AFA6-D62954F1C448}"/>
               </a:ext>
             </a:extLst>
           </p:cNvPr>
@@ -10252,7 +10212,7 @@
           <p:cNvPr id="7" name="">
             <a:extLst xmlns:a="http://schemas.openxmlformats.org/drawingml/2006/main">
               <a:ext uri="{FF2B5EF4-FFF2-40B4-BE49-F238E27FC236}">
-                <a16:creationId xmlns:a16="http://schemas.microsoft.com/office/drawing/2014/main" id="{7265659E-1212-4FD8-8E42-D4F0D5E15548}"/>
+                <a16:creationId xmlns:a16="http://schemas.microsoft.com/office/drawing/2014/main" id="{D45E6EE9-2182-4C01-8952-59A25E8764DE}"/>
               </a:ext>
             </a:extLst>
           </p:cNvPr>
@@ -10285,7 +10245,7 @@
           <p:cNvPr id="8" name="">
             <a:extLst xmlns:a="http://schemas.openxmlformats.org/drawingml/2006/main">
               <a:ext uri="{FF2B5EF4-FFF2-40B4-BE49-F238E27FC236}">
-                <a16:creationId xmlns:a16="http://schemas.microsoft.com/office/drawing/2014/main" id="{99CB0846-DC3A-41ED-B95D-2B5D9BD16105}"/>
+                <a16:creationId xmlns:a16="http://schemas.microsoft.com/office/drawing/2014/main" id="{589DBDDB-9380-47DC-8156-E605282BF76F}"/>
               </a:ext>
             </a:extLst>
           </p:cNvPr>
@@ -10318,7 +10278,7 @@
           <p:cNvPr id="9" name="">
             <a:extLst xmlns:a="http://schemas.openxmlformats.org/drawingml/2006/main">
               <a:ext uri="{FF2B5EF4-FFF2-40B4-BE49-F238E27FC236}">
-                <a16:creationId xmlns:a16="http://schemas.microsoft.com/office/drawing/2014/main" id="{D129D211-9EC1-4EF2-96BE-A23D7C7D4E3B}"/>
+                <a16:creationId xmlns:a16="http://schemas.microsoft.com/office/drawing/2014/main" id="{E82172A7-CAC9-45E9-B4C7-273FCBEF2976}"/>
               </a:ext>
             </a:extLst>
           </p:cNvPr>
@@ -10349,7 +10309,7 @@
           <p:cNvPr id="10" name="">
             <a:extLst xmlns:a="http://schemas.openxmlformats.org/drawingml/2006/main">
               <a:ext uri="{FF2B5EF4-FFF2-40B4-BE49-F238E27FC236}">
-                <a16:creationId xmlns:a16="http://schemas.microsoft.com/office/drawing/2014/main" id="{C3A36157-A5E6-4518-81AF-EEC82C0D112E}"/>
+                <a16:creationId xmlns:a16="http://schemas.microsoft.com/office/drawing/2014/main" id="{E5872CDF-7601-41B7-AF56-BD000D31BD3C}"/>
               </a:ext>
             </a:extLst>
           </p:cNvPr>
@@ -10382,7 +10342,7 @@
           <p:cNvPr id="11" name="">
             <a:extLst xmlns:a="http://schemas.openxmlformats.org/drawingml/2006/main">
               <a:ext uri="{FF2B5EF4-FFF2-40B4-BE49-F238E27FC236}">
-                <a16:creationId xmlns:a16="http://schemas.microsoft.com/office/drawing/2014/main" id="{4ADADB5D-5AD1-4182-BC2D-4E56222454F7}"/>
+                <a16:creationId xmlns:a16="http://schemas.microsoft.com/office/drawing/2014/main" id="{CC268A9F-5324-4E64-83DB-770CEB3EBA61}"/>
               </a:ext>
             </a:extLst>
           </p:cNvPr>
@@ -10410,19 +10370,71 @@
           </a:ln>
         </p:spPr>
       </p:sp>
+      <p:cxnSp>
+        <p:nvCxnSpPr>
+          <p:cNvPr id="49" name=""/>
+          <p:cNvCxnSpPr>
+            <a:stCxn xmlns:a="http://schemas.openxmlformats.org/drawingml/2006/main" id="4" idx="7"/>
+            <a:endCxn xmlns:a="http://schemas.openxmlformats.org/drawingml/2006/main" id="5" idx="3"/>
+          </p:cNvCxnSpPr>
+          <p:nvPr/>
+        </p:nvCxnSpPr>
+        <p:spPr>
+          <a:xfrm xmlns:a="http://schemas.openxmlformats.org/drawingml/2006/main" flipV="1">
+            <a:off x="876498" y="2352873"/>
+            <a:ext cx="866378" cy="914003"/>
+          </a:xfrm>
+          <a:prstGeom xmlns:a="http://schemas.openxmlformats.org/drawingml/2006/main" prst="straightConnector1">
+            <a:avLst/>
+          </a:prstGeom>
+          <a:ln xmlns:a="http://schemas.openxmlformats.org/drawingml/2006/main" w="33338">
+            <a:solidFill>
+              <a:srgbClr val="263746"/>
+            </a:solidFill>
+            <a:prstDash val="solid"/>
+            <a:tailEnd type="none" w="med" len="med"/>
+          </a:ln>
+        </p:spPr>
+      </p:cxnSp>
+      <p:cxnSp>
+        <p:nvCxnSpPr>
+          <p:cNvPr id="50" name=""/>
+          <p:cNvCxnSpPr>
+            <a:stCxn xmlns:a="http://schemas.openxmlformats.org/drawingml/2006/main" id="5" idx="5"/>
+            <a:endCxn xmlns:a="http://schemas.openxmlformats.org/drawingml/2006/main" id="6" idx="1"/>
+          </p:cNvCxnSpPr>
+          <p:nvPr/>
+        </p:nvCxnSpPr>
+        <p:spPr>
+          <a:xfrm xmlns:a="http://schemas.openxmlformats.org/drawingml/2006/main">
+            <a:off x="1971873" y="2352873"/>
+            <a:ext cx="866378" cy="675878"/>
+          </a:xfrm>
+          <a:prstGeom xmlns:a="http://schemas.openxmlformats.org/drawingml/2006/main" prst="straightConnector1">
+            <a:avLst/>
+          </a:prstGeom>
+          <a:ln xmlns:a="http://schemas.openxmlformats.org/drawingml/2006/main" w="33338">
+            <a:solidFill>
+              <a:srgbClr val="263746"/>
+            </a:solidFill>
+            <a:prstDash val="solid"/>
+            <a:tailEnd type="none" w="med" len="med"/>
+          </a:ln>
+        </p:spPr>
+      </p:cxnSp>
       <p:cxnSp>
         <p:nvCxnSpPr>
           <p:cNvPr id="51" name=""/>
           <p:cNvCxnSpPr>
-            <a:stCxn xmlns:a="http://schemas.openxmlformats.org/drawingml/2006/main" id="4" idx="7"/>
-            <a:endCxn xmlns:a="http://schemas.openxmlformats.org/drawingml/2006/main" id="5" idx="3"/>
+            <a:stCxn xmlns:a="http://schemas.openxmlformats.org/drawingml/2006/main" id="6" idx="7"/>
+            <a:endCxn xmlns:a="http://schemas.openxmlformats.org/drawingml/2006/main" id="7" idx="3"/>
           </p:cNvCxnSpPr>
           <p:nvPr/>
         </p:nvCxnSpPr>
         <p:spPr>
           <a:xfrm xmlns:a="http://schemas.openxmlformats.org/drawingml/2006/main" flipV="1">
-            <a:off x="876498" y="2352873"/>
-            <a:ext cx="866378" cy="914003"/>
+            <a:off x="3067248" y="2067123"/>
+            <a:ext cx="914003" cy="961628"/>
           </a:xfrm>
           <a:prstGeom xmlns:a="http://schemas.openxmlformats.org/drawingml/2006/main" prst="straightConnector1">
             <a:avLst/>
@@ -10440,15 +10452,15 @@
         <p:nvCxnSpPr>
           <p:cNvPr id="52" name=""/>
           <p:cNvCxnSpPr>
-            <a:stCxn xmlns:a="http://schemas.openxmlformats.org/drawingml/2006/main" id="5" idx="5"/>
-            <a:endCxn xmlns:a="http://schemas.openxmlformats.org/drawingml/2006/main" id="6" idx="1"/>
+            <a:stCxn xmlns:a="http://schemas.openxmlformats.org/drawingml/2006/main" id="7" idx="5"/>
+            <a:endCxn xmlns:a="http://schemas.openxmlformats.org/drawingml/2006/main" id="8" idx="1"/>
           </p:cNvCxnSpPr>
           <p:nvPr/>
         </p:nvCxnSpPr>
         <p:spPr>
           <a:xfrm xmlns:a="http://schemas.openxmlformats.org/drawingml/2006/main">
-            <a:off x="1971873" y="2352873"/>
-            <a:ext cx="866378" cy="675878"/>
+            <a:off x="4210248" y="2067123"/>
+            <a:ext cx="818753" cy="866378"/>
           </a:xfrm>
           <a:prstGeom xmlns:a="http://schemas.openxmlformats.org/drawingml/2006/main" prst="straightConnector1">
             <a:avLst/>
@@ -10466,15 +10478,15 @@
         <p:nvCxnSpPr>
           <p:cNvPr id="53" name=""/>
           <p:cNvCxnSpPr>
-            <a:stCxn xmlns:a="http://schemas.openxmlformats.org/drawingml/2006/main" id="6" idx="7"/>
-            <a:endCxn xmlns:a="http://schemas.openxmlformats.org/drawingml/2006/main" id="7" idx="3"/>
+            <a:stCxn xmlns:a="http://schemas.openxmlformats.org/drawingml/2006/main" id="6" idx="5"/>
+            <a:endCxn xmlns:a="http://schemas.openxmlformats.org/drawingml/2006/main" id="10" idx="1"/>
           </p:cNvCxnSpPr>
           <p:nvPr/>
         </p:nvCxnSpPr>
         <p:spPr>
-          <a:xfrm xmlns:a="http://schemas.openxmlformats.org/drawingml/2006/main" flipV="1">
-            <a:off x="3067248" y="2067123"/>
-            <a:ext cx="914003" cy="961628"/>
+          <a:xfrm xmlns:a="http://schemas.openxmlformats.org/drawingml/2006/main">
+            <a:off x="3067248" y="3257748"/>
+            <a:ext cx="675878" cy="1247378"/>
           </a:xfrm>
           <a:prstGeom xmlns:a="http://schemas.openxmlformats.org/drawingml/2006/main" prst="straightConnector1">
             <a:avLst/>
@@ -10492,15 +10504,15 @@
         <p:nvCxnSpPr>
           <p:cNvPr id="54" name=""/>
           <p:cNvCxnSpPr>
-            <a:stCxn xmlns:a="http://schemas.openxmlformats.org/drawingml/2006/main" id="7" idx="5"/>
-            <a:endCxn xmlns:a="http://schemas.openxmlformats.org/drawingml/2006/main" id="8" idx="1"/>
+            <a:stCxn xmlns:a="http://schemas.openxmlformats.org/drawingml/2006/main" id="10" idx="2"/>
+            <a:endCxn xmlns:a="http://schemas.openxmlformats.org/drawingml/2006/main" id="11" idx="6"/>
           </p:cNvCxnSpPr>
           <p:nvPr/>
         </p:nvCxnSpPr>
         <p:spPr>
-          <a:xfrm xmlns:a="http://schemas.openxmlformats.org/drawingml/2006/main">
-            <a:off x="4210248" y="2067123"/>
-            <a:ext cx="818753" cy="866378"/>
+          <a:xfrm xmlns:a="http://schemas.openxmlformats.org/drawingml/2006/main" flipH="1">
+            <a:off x="2019300" y="4619625"/>
+            <a:ext cx="1676400" cy="142875"/>
           </a:xfrm>
           <a:prstGeom xmlns:a="http://schemas.openxmlformats.org/drawingml/2006/main" prst="straightConnector1">
             <a:avLst/>
@@ -10518,15 +10530,303 @@
         <p:nvCxnSpPr>
           <p:cNvPr id="55" name=""/>
           <p:cNvCxnSpPr>
-            <a:stCxn xmlns:a="http://schemas.openxmlformats.org/drawingml/2006/main" id="6" idx="5"/>
-            <a:endCxn xmlns:a="http://schemas.openxmlformats.org/drawingml/2006/main" id="10" idx="1"/>
+            <a:stCxn xmlns:a="http://schemas.openxmlformats.org/drawingml/2006/main" id="5" idx="4"/>
+            <a:endCxn xmlns:a="http://schemas.openxmlformats.org/drawingml/2006/main" id="11" idx="0"/>
           </p:cNvCxnSpPr>
           <p:nvPr/>
         </p:nvCxnSpPr>
         <p:spPr>
           <a:xfrm xmlns:a="http://schemas.openxmlformats.org/drawingml/2006/main">
-            <a:off x="3067248" y="3257748"/>
-            <a:ext cx="675878" cy="1247378"/>
+            <a:off x="1857375" y="2400300"/>
+            <a:ext cx="0" cy="2200275"/>
+          </a:xfrm>
+          <a:prstGeom xmlns:a="http://schemas.openxmlformats.org/drawingml/2006/main" prst="straightConnector1">
+            <a:avLst/>
+          </a:prstGeom>
+          <a:ln xmlns:a="http://schemas.openxmlformats.org/drawingml/2006/main" w="33338">
+            <a:solidFill>
+              <a:srgbClr val="263746"/>
+            </a:solidFill>
+            <a:prstDash val="solid"/>
+            <a:tailEnd type="none" w="med" len="med"/>
+          </a:ln>
+        </p:spPr>
+      </p:cxnSp>
+      <p:sp>
+        <p:nvSpPr>
+          <p:cNvPr id="19" name="">
+            <a:extLst xmlns:a="http://schemas.openxmlformats.org/drawingml/2006/main">
+              <a:ext uri="{FF2B5EF4-FFF2-40B4-BE49-F238E27FC236}">
+                <a16:creationId xmlns:a16="http://schemas.microsoft.com/office/drawing/2014/main" id="{2B4ECA32-5154-44E7-B818-77599C28F45F}"/>
+              </a:ext>
+            </a:extLst>
+          </p:cNvPr>
+          <p:cNvSpPr>
+            <a:spLocks xmlns:a="http://schemas.openxmlformats.org/drawingml/2006/main" noGrp="1"/>
+          </p:cNvSpPr>
+          <p:nvPr/>
+        </p:nvSpPr>
+        <p:spPr>
+          <a:xfrm xmlns:a="http://schemas.openxmlformats.org/drawingml/2006/main">
+            <a:off x="6743700" y="3219450"/>
+            <a:ext cx="323850" cy="323850"/>
+          </a:xfrm>
+          <a:prstGeom xmlns:a="http://schemas.openxmlformats.org/drawingml/2006/main" prst="ellipse">
+            <a:avLst/>
+          </a:prstGeom>
+          <a:solidFill xmlns:a="http://schemas.openxmlformats.org/drawingml/2006/main">
+            <a:srgbClr val="EAF2FB"/>
+          </a:solidFill>
+          <a:ln xmlns:a="http://schemas.openxmlformats.org/drawingml/2006/main" w="23813">
+            <a:solidFill>
+              <a:srgbClr val="4F86C6"/>
+            </a:solidFill>
+            <a:prstDash val="solid"/>
+          </a:ln>
+        </p:spPr>
+      </p:sp>
+      <p:sp>
+        <p:nvSpPr>
+          <p:cNvPr id="20" name="">
+            <a:extLst xmlns:a="http://schemas.openxmlformats.org/drawingml/2006/main">
+              <a:ext uri="{FF2B5EF4-FFF2-40B4-BE49-F238E27FC236}">
+                <a16:creationId xmlns:a16="http://schemas.microsoft.com/office/drawing/2014/main" id="{E4ED2D9A-0C28-4722-B996-55F81A03CA26}"/>
+              </a:ext>
+            </a:extLst>
+          </p:cNvPr>
+          <p:cNvSpPr>
+            <a:spLocks xmlns:a="http://schemas.openxmlformats.org/drawingml/2006/main" noGrp="1"/>
+          </p:cNvSpPr>
+          <p:nvPr/>
+        </p:nvSpPr>
+        <p:spPr>
+          <a:xfrm xmlns:a="http://schemas.openxmlformats.org/drawingml/2006/main">
+            <a:off x="7839075" y="2076450"/>
+            <a:ext cx="323850" cy="323850"/>
+          </a:xfrm>
+          <a:prstGeom xmlns:a="http://schemas.openxmlformats.org/drawingml/2006/main" prst="ellipse">
+            <a:avLst/>
+          </a:prstGeom>
+          <a:solidFill xmlns:a="http://schemas.openxmlformats.org/drawingml/2006/main">
+            <a:srgbClr val="FFFFFF"/>
+          </a:solidFill>
+          <a:ln xmlns:a="http://schemas.openxmlformats.org/drawingml/2006/main" w="23813">
+            <a:solidFill>
+              <a:srgbClr val="617080"/>
+            </a:solidFill>
+            <a:prstDash val="solid"/>
+          </a:ln>
+        </p:spPr>
+      </p:sp>
+      <p:sp>
+        <p:nvSpPr>
+          <p:cNvPr id="21" name="">
+            <a:extLst xmlns:a="http://schemas.openxmlformats.org/drawingml/2006/main">
+              <a:ext uri="{FF2B5EF4-FFF2-40B4-BE49-F238E27FC236}">
+                <a16:creationId xmlns:a16="http://schemas.microsoft.com/office/drawing/2014/main" id="{21F61214-28B0-4427-8F8E-36C3BD87A6E6}"/>
+              </a:ext>
+            </a:extLst>
+          </p:cNvPr>
+          <p:cNvSpPr>
+            <a:spLocks xmlns:a="http://schemas.openxmlformats.org/drawingml/2006/main" noGrp="1"/>
+          </p:cNvSpPr>
+          <p:nvPr/>
+        </p:nvSpPr>
+        <p:spPr>
+          <a:xfrm xmlns:a="http://schemas.openxmlformats.org/drawingml/2006/main">
+            <a:off x="8934450" y="2981325"/>
+            <a:ext cx="323850" cy="323850"/>
+          </a:xfrm>
+          <a:prstGeom xmlns:a="http://schemas.openxmlformats.org/drawingml/2006/main" prst="ellipse">
+            <a:avLst/>
+          </a:prstGeom>
+          <a:solidFill xmlns:a="http://schemas.openxmlformats.org/drawingml/2006/main">
+            <a:srgbClr val="FFFFFF"/>
+          </a:solidFill>
+          <a:ln xmlns:a="http://schemas.openxmlformats.org/drawingml/2006/main" w="23813">
+            <a:solidFill>
+              <a:srgbClr val="617080"/>
+            </a:solidFill>
+            <a:prstDash val="solid"/>
+          </a:ln>
+        </p:spPr>
+      </p:sp>
+      <p:sp>
+        <p:nvSpPr>
+          <p:cNvPr id="22" name="">
+            <a:extLst xmlns:a="http://schemas.openxmlformats.org/drawingml/2006/main">
+              <a:ext uri="{FF2B5EF4-FFF2-40B4-BE49-F238E27FC236}">
+                <a16:creationId xmlns:a16="http://schemas.microsoft.com/office/drawing/2014/main" id="{E1D587C6-3432-4A0A-B59F-F6AC3EE03F4A}"/>
+              </a:ext>
+            </a:extLst>
+          </p:cNvPr>
+          <p:cNvSpPr>
+            <a:spLocks xmlns:a="http://schemas.openxmlformats.org/drawingml/2006/main" noGrp="1"/>
+          </p:cNvSpPr>
+          <p:nvPr/>
+        </p:nvSpPr>
+        <p:spPr>
+          <a:xfrm xmlns:a="http://schemas.openxmlformats.org/drawingml/2006/main">
+            <a:off x="10077450" y="1790700"/>
+            <a:ext cx="323850" cy="323850"/>
+          </a:xfrm>
+          <a:prstGeom xmlns:a="http://schemas.openxmlformats.org/drawingml/2006/main" prst="ellipse">
+            <a:avLst/>
+          </a:prstGeom>
+          <a:solidFill xmlns:a="http://schemas.openxmlformats.org/drawingml/2006/main">
+            <a:srgbClr val="FFF4DF"/>
+          </a:solidFill>
+          <a:ln xmlns:a="http://schemas.openxmlformats.org/drawingml/2006/main" w="23813">
+            <a:solidFill>
+              <a:srgbClr val="E5A23C"/>
+            </a:solidFill>
+            <a:prstDash val="solid"/>
+          </a:ln>
+        </p:spPr>
+      </p:sp>
+      <p:sp>
+        <p:nvSpPr>
+          <p:cNvPr id="23" name="">
+            <a:extLst xmlns:a="http://schemas.openxmlformats.org/drawingml/2006/main">
+              <a:ext uri="{FF2B5EF4-FFF2-40B4-BE49-F238E27FC236}">
+                <a16:creationId xmlns:a16="http://schemas.microsoft.com/office/drawing/2014/main" id="{F372E9F8-40A1-43F9-A9E7-7111883791F0}"/>
+              </a:ext>
+            </a:extLst>
+          </p:cNvPr>
+          <p:cNvSpPr>
+            <a:spLocks xmlns:a="http://schemas.openxmlformats.org/drawingml/2006/main" noGrp="1"/>
+          </p:cNvSpPr>
+          <p:nvPr/>
+        </p:nvSpPr>
+        <p:spPr>
+          <a:xfrm xmlns:a="http://schemas.openxmlformats.org/drawingml/2006/main">
+            <a:off x="11125200" y="2886075"/>
+            <a:ext cx="323850" cy="323850"/>
+          </a:xfrm>
+          <a:prstGeom xmlns:a="http://schemas.openxmlformats.org/drawingml/2006/main" prst="ellipse">
+            <a:avLst/>
+          </a:prstGeom>
+          <a:solidFill xmlns:a="http://schemas.openxmlformats.org/drawingml/2006/main">
+            <a:srgbClr val="EAF6EE"/>
+          </a:solidFill>
+          <a:ln xmlns:a="http://schemas.openxmlformats.org/drawingml/2006/main" w="23813">
+            <a:solidFill>
+              <a:srgbClr val="4E9B69"/>
+            </a:solidFill>
+            <a:prstDash val="solid"/>
+          </a:ln>
+        </p:spPr>
+      </p:sp>
+      <p:sp>
+        <p:nvSpPr>
+          <p:cNvPr id="24" name="">
+            <a:extLst xmlns:a="http://schemas.openxmlformats.org/drawingml/2006/main">
+              <a:ext uri="{FF2B5EF4-FFF2-40B4-BE49-F238E27FC236}">
+                <a16:creationId xmlns:a16="http://schemas.microsoft.com/office/drawing/2014/main" id="{61FF84F6-BC43-47C8-B9E2-C66243F58160}"/>
+              </a:ext>
+            </a:extLst>
+          </p:cNvPr>
+          <p:cNvSpPr>
+            <a:spLocks xmlns:a="http://schemas.openxmlformats.org/drawingml/2006/main" noGrp="1"/>
+          </p:cNvSpPr>
+          <p:nvPr/>
+        </p:nvSpPr>
+        <p:spPr>
+          <a:xfrm xmlns:a="http://schemas.openxmlformats.org/drawingml/2006/main">
+            <a:off x="11039475" y="2800350"/>
+            <a:ext cx="495300" cy="495300"/>
+          </a:xfrm>
+          <a:prstGeom xmlns:a="http://schemas.openxmlformats.org/drawingml/2006/main" prst="ellipse">
+            <a:avLst/>
+          </a:prstGeom>
+          <a:noFill xmlns:a="http://schemas.openxmlformats.org/drawingml/2006/main"/>
+          <a:ln xmlns:a="http://schemas.openxmlformats.org/drawingml/2006/main" w="23813">
+            <a:solidFill>
+              <a:srgbClr val="4E9B69"/>
+            </a:solidFill>
+            <a:prstDash val="dot"/>
+          </a:ln>
+        </p:spPr>
+      </p:sp>
+      <p:sp>
+        <p:nvSpPr>
+          <p:cNvPr id="25" name="">
+            <a:extLst xmlns:a="http://schemas.openxmlformats.org/drawingml/2006/main">
+              <a:ext uri="{FF2B5EF4-FFF2-40B4-BE49-F238E27FC236}">
+                <a16:creationId xmlns:a16="http://schemas.microsoft.com/office/drawing/2014/main" id="{D9E3B0F4-FAD6-49EB-891C-9F057C892347}"/>
+              </a:ext>
+            </a:extLst>
+          </p:cNvPr>
+          <p:cNvSpPr>
+            <a:spLocks xmlns:a="http://schemas.openxmlformats.org/drawingml/2006/main" noGrp="1"/>
+          </p:cNvSpPr>
+          <p:nvPr/>
+        </p:nvSpPr>
+        <p:spPr>
+          <a:xfrm xmlns:a="http://schemas.openxmlformats.org/drawingml/2006/main">
+            <a:off x="9839325" y="4457700"/>
+            <a:ext cx="323850" cy="323850"/>
+          </a:xfrm>
+          <a:prstGeom xmlns:a="http://schemas.openxmlformats.org/drawingml/2006/main" prst="ellipse">
+            <a:avLst/>
+          </a:prstGeom>
+          <a:solidFill xmlns:a="http://schemas.openxmlformats.org/drawingml/2006/main">
+            <a:srgbClr val="F7F9FB"/>
+          </a:solidFill>
+          <a:ln xmlns:a="http://schemas.openxmlformats.org/drawingml/2006/main" w="23813">
+            <a:solidFill>
+              <a:srgbClr val="DDE3E8"/>
+            </a:solidFill>
+            <a:prstDash val="solid"/>
+          </a:ln>
+        </p:spPr>
+      </p:sp>
+      <p:sp>
+        <p:nvSpPr>
+          <p:cNvPr id="26" name="">
+            <a:extLst xmlns:a="http://schemas.openxmlformats.org/drawingml/2006/main">
+              <a:ext uri="{FF2B5EF4-FFF2-40B4-BE49-F238E27FC236}">
+                <a16:creationId xmlns:a16="http://schemas.microsoft.com/office/drawing/2014/main" id="{23FD4DA6-854E-4404-BEB8-F62B60AD43DC}"/>
+              </a:ext>
+            </a:extLst>
+          </p:cNvPr>
+          <p:cNvSpPr>
+            <a:spLocks xmlns:a="http://schemas.openxmlformats.org/drawingml/2006/main" noGrp="1"/>
+          </p:cNvSpPr>
+          <p:nvPr/>
+        </p:nvSpPr>
+        <p:spPr>
+          <a:xfrm xmlns:a="http://schemas.openxmlformats.org/drawingml/2006/main">
+            <a:off x="7839075" y="4600575"/>
+            <a:ext cx="323850" cy="323850"/>
+          </a:xfrm>
+          <a:prstGeom xmlns:a="http://schemas.openxmlformats.org/drawingml/2006/main" prst="ellipse">
+            <a:avLst/>
+          </a:prstGeom>
+          <a:solidFill xmlns:a="http://schemas.openxmlformats.org/drawingml/2006/main">
+            <a:srgbClr val="F7F9FB"/>
+          </a:solidFill>
+          <a:ln xmlns:a="http://schemas.openxmlformats.org/drawingml/2006/main" w="23813">
+            <a:solidFill>
+              <a:srgbClr val="DDE3E8"/>
+            </a:solidFill>
+            <a:prstDash val="solid"/>
+          </a:ln>
+        </p:spPr>
+      </p:sp>
+      <p:cxnSp>
+        <p:nvCxnSpPr>
+          <p:cNvPr id="64" name=""/>
+          <p:cNvCxnSpPr>
+            <a:stCxn xmlns:a="http://schemas.openxmlformats.org/drawingml/2006/main" id="19" idx="7"/>
+            <a:endCxn xmlns:a="http://schemas.openxmlformats.org/drawingml/2006/main" id="20" idx="3"/>
+          </p:cNvCxnSpPr>
+          <p:nvPr/>
+        </p:nvCxnSpPr>
+        <p:spPr>
+          <a:xfrm xmlns:a="http://schemas.openxmlformats.org/drawingml/2006/main" flipV="1">
+            <a:off x="7020123" y="2352873"/>
+            <a:ext cx="866378" cy="914003"/>
           </a:xfrm>
           <a:prstGeom xmlns:a="http://schemas.openxmlformats.org/drawingml/2006/main" prst="straightConnector1">
             <a:avLst/>
@@ -10542,17 +10842,17 @@
       </p:cxnSp>
       <p:cxnSp>
         <p:nvCxnSpPr>
-          <p:cNvPr id="56" name=""/>
+          <p:cNvPr id="65" name=""/>
           <p:cNvCxnSpPr>
-            <a:stCxn xmlns:a="http://schemas.openxmlformats.org/drawingml/2006/main" id="10" idx="2"/>
-            <a:endCxn xmlns:a="http://schemas.openxmlformats.org/drawingml/2006/main" id="11" idx="6"/>
+            <a:stCxn xmlns:a="http://schemas.openxmlformats.org/drawingml/2006/main" id="20" idx="5"/>
+            <a:endCxn xmlns:a="http://schemas.openxmlformats.org/drawingml/2006/main" id="21" idx="1"/>
           </p:cNvCxnSpPr>
           <p:nvPr/>
         </p:nvCxnSpPr>
         <p:spPr>
-          <a:xfrm xmlns:a="http://schemas.openxmlformats.org/drawingml/2006/main" flipH="1">
-            <a:off x="2019300" y="4619625"/>
-            <a:ext cx="1676400" cy="142875"/>
+          <a:xfrm xmlns:a="http://schemas.openxmlformats.org/drawingml/2006/main">
+            <a:off x="8115498" y="2352873"/>
+            <a:ext cx="866378" cy="675878"/>
           </a:xfrm>
           <a:prstGeom xmlns:a="http://schemas.openxmlformats.org/drawingml/2006/main" prst="straightConnector1">
             <a:avLst/>
@@ -10568,17 +10868,17 @@
       </p:cxnSp>
       <p:cxnSp>
         <p:nvCxnSpPr>
-          <p:cNvPr id="57" name=""/>
+          <p:cNvPr id="66" name=""/>
           <p:cNvCxnSpPr>
-            <a:stCxn xmlns:a="http://schemas.openxmlformats.org/drawingml/2006/main" id="11" idx="1"/>
-            <a:endCxn xmlns:a="http://schemas.openxmlformats.org/drawingml/2006/main" id="4" idx="5"/>
+            <a:stCxn xmlns:a="http://schemas.openxmlformats.org/drawingml/2006/main" id="21" idx="7"/>
+            <a:endCxn xmlns:a="http://schemas.openxmlformats.org/drawingml/2006/main" id="22" idx="3"/>
           </p:cNvCxnSpPr>
           <p:nvPr/>
         </p:nvCxnSpPr>
         <p:spPr>
-          <a:xfrm xmlns:a="http://schemas.openxmlformats.org/drawingml/2006/main" flipH="1" flipV="1">
-            <a:off x="876498" y="3495873"/>
-            <a:ext cx="866378" cy="1152128"/>
+          <a:xfrm xmlns:a="http://schemas.openxmlformats.org/drawingml/2006/main" flipV="1">
+            <a:off x="9210873" y="2067123"/>
+            <a:ext cx="914003" cy="961628"/>
           </a:xfrm>
           <a:prstGeom xmlns:a="http://schemas.openxmlformats.org/drawingml/2006/main" prst="straightConnector1">
             <a:avLst/>
@@ -10592,307 +10892,19 @@
           </a:ln>
         </p:spPr>
       </p:cxnSp>
-      <p:cxnSp>
-        <p:nvCxnSpPr>
-          <p:cNvPr id="58" name=""/>
-          <p:cNvCxnSpPr>
-            <a:stCxn xmlns:a="http://schemas.openxmlformats.org/drawingml/2006/main" id="5" idx="4"/>
-            <a:endCxn xmlns:a="http://schemas.openxmlformats.org/drawingml/2006/main" id="11" idx="0"/>
-          </p:cNvCxnSpPr>
-          <p:nvPr/>
-        </p:nvCxnSpPr>
-        <p:spPr>
-          <a:xfrm xmlns:a="http://schemas.openxmlformats.org/drawingml/2006/main">
-            <a:off x="1857375" y="2400300"/>
-            <a:ext cx="0" cy="2200275"/>
-          </a:xfrm>
-          <a:prstGeom xmlns:a="http://schemas.openxmlformats.org/drawingml/2006/main" prst="straightConnector1">
-            <a:avLst/>
-          </a:prstGeom>
-          <a:ln xmlns:a="http://schemas.openxmlformats.org/drawingml/2006/main" w="33338">
-            <a:solidFill>
-              <a:srgbClr val="263746"/>
-            </a:solidFill>
-            <a:prstDash val="solid"/>
-            <a:tailEnd type="none" w="med" len="med"/>
-          </a:ln>
-        </p:spPr>
-      </p:cxnSp>
-      <p:sp>
-        <p:nvSpPr>
-          <p:cNvPr id="20" name="">
-            <a:extLst xmlns:a="http://schemas.openxmlformats.org/drawingml/2006/main">
-              <a:ext uri="{FF2B5EF4-FFF2-40B4-BE49-F238E27FC236}">
-                <a16:creationId xmlns:a16="http://schemas.microsoft.com/office/drawing/2014/main" id="{4B81172A-9A15-4A66-9F8D-B9BC5AD52C4B}"/>
-              </a:ext>
-            </a:extLst>
-          </p:cNvPr>
-          <p:cNvSpPr>
-            <a:spLocks xmlns:a="http://schemas.openxmlformats.org/drawingml/2006/main" noGrp="1"/>
-          </p:cNvSpPr>
-          <p:nvPr/>
-        </p:nvSpPr>
-        <p:spPr>
-          <a:xfrm xmlns:a="http://schemas.openxmlformats.org/drawingml/2006/main">
-            <a:off x="6743700" y="3219450"/>
-            <a:ext cx="323850" cy="323850"/>
-          </a:xfrm>
-          <a:prstGeom xmlns:a="http://schemas.openxmlformats.org/drawingml/2006/main" prst="ellipse">
-            <a:avLst/>
-          </a:prstGeom>
-          <a:solidFill xmlns:a="http://schemas.openxmlformats.org/drawingml/2006/main">
-            <a:srgbClr val="EAF2FB"/>
-          </a:solidFill>
-          <a:ln xmlns:a="http://schemas.openxmlformats.org/drawingml/2006/main" w="23813">
-            <a:solidFill>
-              <a:srgbClr val="4F86C6"/>
-            </a:solidFill>
-            <a:prstDash val="solid"/>
-          </a:ln>
-        </p:spPr>
-      </p:sp>
-      <p:sp>
-        <p:nvSpPr>
-          <p:cNvPr id="21" name="">
-            <a:extLst xmlns:a="http://schemas.openxmlformats.org/drawingml/2006/main">
-              <a:ext uri="{FF2B5EF4-FFF2-40B4-BE49-F238E27FC236}">
-                <a16:creationId xmlns:a16="http://schemas.microsoft.com/office/drawing/2014/main" id="{F47CA5F7-D67B-4C9B-97F3-66ACAD1F6181}"/>
-              </a:ext>
-            </a:extLst>
-          </p:cNvPr>
-          <p:cNvSpPr>
-            <a:spLocks xmlns:a="http://schemas.openxmlformats.org/drawingml/2006/main" noGrp="1"/>
-          </p:cNvSpPr>
-          <p:nvPr/>
-        </p:nvSpPr>
-        <p:spPr>
-          <a:xfrm xmlns:a="http://schemas.openxmlformats.org/drawingml/2006/main">
-            <a:off x="7839075" y="2076450"/>
-            <a:ext cx="323850" cy="323850"/>
-          </a:xfrm>
-          <a:prstGeom xmlns:a="http://schemas.openxmlformats.org/drawingml/2006/main" prst="ellipse">
-            <a:avLst/>
-          </a:prstGeom>
-          <a:solidFill xmlns:a="http://schemas.openxmlformats.org/drawingml/2006/main">
-            <a:srgbClr val="FFFFFF"/>
-          </a:solidFill>
-          <a:ln xmlns:a="http://schemas.openxmlformats.org/drawingml/2006/main" w="23813">
-            <a:solidFill>
-              <a:srgbClr val="617080"/>
-            </a:solidFill>
-            <a:prstDash val="solid"/>
-          </a:ln>
-        </p:spPr>
-      </p:sp>
-      <p:sp>
-        <p:nvSpPr>
-          <p:cNvPr id="22" name="">
-            <a:extLst xmlns:a="http://schemas.openxmlformats.org/drawingml/2006/main">
-              <a:ext uri="{FF2B5EF4-FFF2-40B4-BE49-F238E27FC236}">
-                <a16:creationId xmlns:a16="http://schemas.microsoft.com/office/drawing/2014/main" id="{87B97E1A-5CFB-4F67-BF44-AC060037C94F}"/>
-              </a:ext>
-            </a:extLst>
-          </p:cNvPr>
-          <p:cNvSpPr>
-            <a:spLocks xmlns:a="http://schemas.openxmlformats.org/drawingml/2006/main" noGrp="1"/>
-          </p:cNvSpPr>
-          <p:nvPr/>
-        </p:nvSpPr>
-        <p:spPr>
-          <a:xfrm xmlns:a="http://schemas.openxmlformats.org/drawingml/2006/main">
-            <a:off x="8934450" y="2981325"/>
-            <a:ext cx="323850" cy="323850"/>
-          </a:xfrm>
-          <a:prstGeom xmlns:a="http://schemas.openxmlformats.org/drawingml/2006/main" prst="ellipse">
-            <a:avLst/>
-          </a:prstGeom>
-          <a:solidFill xmlns:a="http://schemas.openxmlformats.org/drawingml/2006/main">
-            <a:srgbClr val="FFFFFF"/>
-          </a:solidFill>
-          <a:ln xmlns:a="http://schemas.openxmlformats.org/drawingml/2006/main" w="23813">
-            <a:solidFill>
-              <a:srgbClr val="617080"/>
-            </a:solidFill>
-            <a:prstDash val="solid"/>
-          </a:ln>
-        </p:spPr>
-      </p:sp>
-      <p:sp>
-        <p:nvSpPr>
-          <p:cNvPr id="23" name="">
-            <a:extLst xmlns:a="http://schemas.openxmlformats.org/drawingml/2006/main">
-              <a:ext uri="{FF2B5EF4-FFF2-40B4-BE49-F238E27FC236}">
-                <a16:creationId xmlns:a16="http://schemas.microsoft.com/office/drawing/2014/main" id="{62164888-9756-44C6-99D9-6C81918AE55C}"/>
-              </a:ext>
-            </a:extLst>
-          </p:cNvPr>
-          <p:cNvSpPr>
-            <a:spLocks xmlns:a="http://schemas.openxmlformats.org/drawingml/2006/main" noGrp="1"/>
-          </p:cNvSpPr>
-          <p:nvPr/>
-        </p:nvSpPr>
-        <p:spPr>
-          <a:xfrm xmlns:a="http://schemas.openxmlformats.org/drawingml/2006/main">
-            <a:off x="10077450" y="1790700"/>
-            <a:ext cx="323850" cy="323850"/>
-          </a:xfrm>
-          <a:prstGeom xmlns:a="http://schemas.openxmlformats.org/drawingml/2006/main" prst="ellipse">
-            <a:avLst/>
-          </a:prstGeom>
-          <a:solidFill xmlns:a="http://schemas.openxmlformats.org/drawingml/2006/main">
-            <a:srgbClr val="FFF4DF"/>
-          </a:solidFill>
-          <a:ln xmlns:a="http://schemas.openxmlformats.org/drawingml/2006/main" w="23813">
-            <a:solidFill>
-              <a:srgbClr val="E5A23C"/>
-            </a:solidFill>
-            <a:prstDash val="solid"/>
-          </a:ln>
-        </p:spPr>
-      </p:sp>
-      <p:sp>
-        <p:nvSpPr>
-          <p:cNvPr id="24" name="">
-            <a:extLst xmlns:a="http://schemas.openxmlformats.org/drawingml/2006/main">
-              <a:ext uri="{FF2B5EF4-FFF2-40B4-BE49-F238E27FC236}">
-                <a16:creationId xmlns:a16="http://schemas.microsoft.com/office/drawing/2014/main" id="{9499023F-4BB6-4999-B17F-7F8431CC7CE6}"/>
-              </a:ext>
-            </a:extLst>
-          </p:cNvPr>
-          <p:cNvSpPr>
-            <a:spLocks xmlns:a="http://schemas.openxmlformats.org/drawingml/2006/main" noGrp="1"/>
-          </p:cNvSpPr>
-          <p:nvPr/>
-        </p:nvSpPr>
-        <p:spPr>
-          <a:xfrm xmlns:a="http://schemas.openxmlformats.org/drawingml/2006/main">
-            <a:off x="11125200" y="2886075"/>
-            <a:ext cx="323850" cy="323850"/>
-          </a:xfrm>
-          <a:prstGeom xmlns:a="http://schemas.openxmlformats.org/drawingml/2006/main" prst="ellipse">
-            <a:avLst/>
-          </a:prstGeom>
-          <a:solidFill xmlns:a="http://schemas.openxmlformats.org/drawingml/2006/main">
-            <a:srgbClr val="EAF6EE"/>
-          </a:solidFill>
-          <a:ln xmlns:a="http://schemas.openxmlformats.org/drawingml/2006/main" w="23813">
-            <a:solidFill>
-              <a:srgbClr val="4E9B69"/>
-            </a:solidFill>
-            <a:prstDash val="solid"/>
-          </a:ln>
-        </p:spPr>
-      </p:sp>
-      <p:sp>
-        <p:nvSpPr>
-          <p:cNvPr id="25" name="">
-            <a:extLst xmlns:a="http://schemas.openxmlformats.org/drawingml/2006/main">
-              <a:ext uri="{FF2B5EF4-FFF2-40B4-BE49-F238E27FC236}">
-                <a16:creationId xmlns:a16="http://schemas.microsoft.com/office/drawing/2014/main" id="{2BC8ACBB-185C-4C96-9B30-F9103CCF6BA6}"/>
-              </a:ext>
-            </a:extLst>
-          </p:cNvPr>
-          <p:cNvSpPr>
-            <a:spLocks xmlns:a="http://schemas.openxmlformats.org/drawingml/2006/main" noGrp="1"/>
-          </p:cNvSpPr>
-          <p:nvPr/>
-        </p:nvSpPr>
-        <p:spPr>
-          <a:xfrm xmlns:a="http://schemas.openxmlformats.org/drawingml/2006/main">
-            <a:off x="11039475" y="2800350"/>
-            <a:ext cx="495300" cy="495300"/>
-          </a:xfrm>
-          <a:prstGeom xmlns:a="http://schemas.openxmlformats.org/drawingml/2006/main" prst="ellipse">
-            <a:avLst/>
-          </a:prstGeom>
-          <a:noFill xmlns:a="http://schemas.openxmlformats.org/drawingml/2006/main"/>
-          <a:ln xmlns:a="http://schemas.openxmlformats.org/drawingml/2006/main" w="23813">
-            <a:solidFill>
-              <a:srgbClr val="4E9B69"/>
-            </a:solidFill>
-            <a:prstDash val="dot"/>
-          </a:ln>
-        </p:spPr>
-      </p:sp>
-      <p:sp>
-        <p:nvSpPr>
-          <p:cNvPr id="26" name="">
-            <a:extLst xmlns:a="http://schemas.openxmlformats.org/drawingml/2006/main">
-              <a:ext uri="{FF2B5EF4-FFF2-40B4-BE49-F238E27FC236}">
-                <a16:creationId xmlns:a16="http://schemas.microsoft.com/office/drawing/2014/main" id="{A527C16C-B037-4A40-842A-3F2F21AF67B0}"/>
-              </a:ext>
-            </a:extLst>
-          </p:cNvPr>
-          <p:cNvSpPr>
-            <a:spLocks xmlns:a="http://schemas.openxmlformats.org/drawingml/2006/main" noGrp="1"/>
-          </p:cNvSpPr>
-          <p:nvPr/>
-        </p:nvSpPr>
-        <p:spPr>
-          <a:xfrm xmlns:a="http://schemas.openxmlformats.org/drawingml/2006/main">
-            <a:off x="9839325" y="4457700"/>
-            <a:ext cx="323850" cy="323850"/>
-          </a:xfrm>
-          <a:prstGeom xmlns:a="http://schemas.openxmlformats.org/drawingml/2006/main" prst="ellipse">
-            <a:avLst/>
-          </a:prstGeom>
-          <a:solidFill xmlns:a="http://schemas.openxmlformats.org/drawingml/2006/main">
-            <a:srgbClr val="F7F9FB"/>
-          </a:solidFill>
-          <a:ln xmlns:a="http://schemas.openxmlformats.org/drawingml/2006/main" w="23813">
-            <a:solidFill>
-              <a:srgbClr val="DDE3E8"/>
-            </a:solidFill>
-            <a:prstDash val="solid"/>
-          </a:ln>
-        </p:spPr>
-      </p:sp>
-      <p:sp>
-        <p:nvSpPr>
-          <p:cNvPr id="27" name="">
-            <a:extLst xmlns:a="http://schemas.openxmlformats.org/drawingml/2006/main">
-              <a:ext uri="{FF2B5EF4-FFF2-40B4-BE49-F238E27FC236}">
-                <a16:creationId xmlns:a16="http://schemas.microsoft.com/office/drawing/2014/main" id="{A354CA44-8B2D-48A8-8E69-C7F060288D48}"/>
-              </a:ext>
-            </a:extLst>
-          </p:cNvPr>
-          <p:cNvSpPr>
-            <a:spLocks xmlns:a="http://schemas.openxmlformats.org/drawingml/2006/main" noGrp="1"/>
-          </p:cNvSpPr>
-          <p:nvPr/>
-        </p:nvSpPr>
-        <p:spPr>
-          <a:xfrm xmlns:a="http://schemas.openxmlformats.org/drawingml/2006/main">
-            <a:off x="7839075" y="4600575"/>
-            <a:ext cx="323850" cy="323850"/>
-          </a:xfrm>
-          <a:prstGeom xmlns:a="http://schemas.openxmlformats.org/drawingml/2006/main" prst="ellipse">
-            <a:avLst/>
-          </a:prstGeom>
-          <a:solidFill xmlns:a="http://schemas.openxmlformats.org/drawingml/2006/main">
-            <a:srgbClr val="F7F9FB"/>
-          </a:solidFill>
-          <a:ln xmlns:a="http://schemas.openxmlformats.org/drawingml/2006/main" w="23813">
-            <a:solidFill>
-              <a:srgbClr val="DDE3E8"/>
-            </a:solidFill>
-            <a:prstDash val="solid"/>
-          </a:ln>
-        </p:spPr>
-      </p:sp>
       <p:cxnSp>
         <p:nvCxnSpPr>
           <p:cNvPr id="67" name=""/>
           <p:cNvCxnSpPr>
-            <a:stCxn xmlns:a="http://schemas.openxmlformats.org/drawingml/2006/main" id="20" idx="7"/>
-            <a:endCxn xmlns:a="http://schemas.openxmlformats.org/drawingml/2006/main" id="21" idx="3"/>
+            <a:stCxn xmlns:a="http://schemas.openxmlformats.org/drawingml/2006/main" id="22" idx="5"/>
+            <a:endCxn xmlns:a="http://schemas.openxmlformats.org/drawingml/2006/main" id="23" idx="1"/>
           </p:cNvCxnSpPr>
           <p:nvPr/>
         </p:nvCxnSpPr>
         <p:spPr>
-          <a:xfrm xmlns:a="http://schemas.openxmlformats.org/drawingml/2006/main" flipV="1">
-            <a:off x="7020123" y="2352873"/>
-            <a:ext cx="866378" cy="914003"/>
+          <a:xfrm xmlns:a="http://schemas.openxmlformats.org/drawingml/2006/main">
+            <a:off x="10353873" y="2067123"/>
+            <a:ext cx="818753" cy="866378"/>
           </a:xfrm>
           <a:prstGeom xmlns:a="http://schemas.openxmlformats.org/drawingml/2006/main" prst="straightConnector1">
             <a:avLst/>
@@ -10911,21 +10923,21 @@
           <p:cNvPr id="68" name=""/>
           <p:cNvCxnSpPr>
             <a:stCxn xmlns:a="http://schemas.openxmlformats.org/drawingml/2006/main" id="21" idx="5"/>
-            <a:endCxn xmlns:a="http://schemas.openxmlformats.org/drawingml/2006/main" id="22" idx="1"/>
+            <a:endCxn xmlns:a="http://schemas.openxmlformats.org/drawingml/2006/main" id="25" idx="1"/>
           </p:cNvCxnSpPr>
           <p:nvPr/>
         </p:nvCxnSpPr>
         <p:spPr>
           <a:xfrm xmlns:a="http://schemas.openxmlformats.org/drawingml/2006/main">
-            <a:off x="8115498" y="2352873"/>
-            <a:ext cx="866378" cy="675878"/>
+            <a:off x="9210873" y="3257748"/>
+            <a:ext cx="675878" cy="1247378"/>
           </a:xfrm>
           <a:prstGeom xmlns:a="http://schemas.openxmlformats.org/drawingml/2006/main" prst="straightConnector1">
             <a:avLst/>
           </a:prstGeom>
-          <a:ln xmlns:a="http://schemas.openxmlformats.org/drawingml/2006/main" w="33338">
-            <a:solidFill>
-              <a:srgbClr val="263746"/>
+          <a:ln xmlns:a="http://schemas.openxmlformats.org/drawingml/2006/main" w="14288">
+            <a:solidFill>
+              <a:srgbClr val="DDE3E8"/>
             </a:solidFill>
             <a:prstDash val="solid"/>
             <a:tailEnd type="none" w="med" len="med"/>
@@ -10936,22 +10948,22 @@
         <p:nvCxnSpPr>
           <p:cNvPr id="69" name=""/>
           <p:cNvCxnSpPr>
-            <a:stCxn xmlns:a="http://schemas.openxmlformats.org/drawingml/2006/main" id="22" idx="7"/>
-            <a:endCxn xmlns:a="http://schemas.openxmlformats.org/drawingml/2006/main" id="23" idx="3"/>
+            <a:stCxn xmlns:a="http://schemas.openxmlformats.org/drawingml/2006/main" id="25" idx="2"/>
+            <a:endCxn xmlns:a="http://schemas.openxmlformats.org/drawingml/2006/main" id="26" idx="6"/>
           </p:cNvCxnSpPr>
           <p:nvPr/>
         </p:nvCxnSpPr>
         <p:spPr>
-          <a:xfrm xmlns:a="http://schemas.openxmlformats.org/drawingml/2006/main" flipV="1">
-            <a:off x="9210873" y="2067123"/>
-            <a:ext cx="914003" cy="961628"/>
+          <a:xfrm xmlns:a="http://schemas.openxmlformats.org/drawingml/2006/main" flipH="1">
+            <a:off x="8162925" y="4619625"/>
+            <a:ext cx="1676400" cy="142875"/>
           </a:xfrm>
           <a:prstGeom xmlns:a="http://schemas.openxmlformats.org/drawingml/2006/main" prst="straightConnector1">
             <a:avLst/>
           </a:prstGeom>
-          <a:ln xmlns:a="http://schemas.openxmlformats.org/drawingml/2006/main" w="33338">
-            <a:solidFill>
-              <a:srgbClr val="263746"/>
+          <a:ln xmlns:a="http://schemas.openxmlformats.org/drawingml/2006/main" w="14288">
+            <a:solidFill>
+              <a:srgbClr val="DDE3E8"/>
             </a:solidFill>
             <a:prstDash val="solid"/>
             <a:tailEnd type="none" w="med" len="med"/>
@@ -10962,112 +10974,8 @@
         <p:nvCxnSpPr>
           <p:cNvPr id="70" name=""/>
           <p:cNvCxnSpPr>
-            <a:stCxn xmlns:a="http://schemas.openxmlformats.org/drawingml/2006/main" id="23" idx="5"/>
-            <a:endCxn xmlns:a="http://schemas.openxmlformats.org/drawingml/2006/main" id="24" idx="1"/>
-          </p:cNvCxnSpPr>
-          <p:nvPr/>
-        </p:nvCxnSpPr>
-        <p:spPr>
-          <a:xfrm xmlns:a="http://schemas.openxmlformats.org/drawingml/2006/main">
-            <a:off x="10353873" y="2067123"/>
-            <a:ext cx="818753" cy="866378"/>
-          </a:xfrm>
-          <a:prstGeom xmlns:a="http://schemas.openxmlformats.org/drawingml/2006/main" prst="straightConnector1">
-            <a:avLst/>
-          </a:prstGeom>
-          <a:ln xmlns:a="http://schemas.openxmlformats.org/drawingml/2006/main" w="33338">
-            <a:solidFill>
-              <a:srgbClr val="263746"/>
-            </a:solidFill>
-            <a:prstDash val="solid"/>
-            <a:tailEnd type="none" w="med" len="med"/>
-          </a:ln>
-        </p:spPr>
-      </p:cxnSp>
-      <p:cxnSp>
-        <p:nvCxnSpPr>
-          <p:cNvPr id="71" name=""/>
-          <p:cNvCxnSpPr>
-            <a:stCxn xmlns:a="http://schemas.openxmlformats.org/drawingml/2006/main" id="22" idx="5"/>
-            <a:endCxn xmlns:a="http://schemas.openxmlformats.org/drawingml/2006/main" id="26" idx="1"/>
-          </p:cNvCxnSpPr>
-          <p:nvPr/>
-        </p:nvCxnSpPr>
-        <p:spPr>
-          <a:xfrm xmlns:a="http://schemas.openxmlformats.org/drawingml/2006/main">
-            <a:off x="9210873" y="3257748"/>
-            <a:ext cx="675878" cy="1247378"/>
-          </a:xfrm>
-          <a:prstGeom xmlns:a="http://schemas.openxmlformats.org/drawingml/2006/main" prst="straightConnector1">
-            <a:avLst/>
-          </a:prstGeom>
-          <a:ln xmlns:a="http://schemas.openxmlformats.org/drawingml/2006/main" w="14288">
-            <a:solidFill>
-              <a:srgbClr val="DDE3E8"/>
-            </a:solidFill>
-            <a:prstDash val="solid"/>
-            <a:tailEnd type="none" w="med" len="med"/>
-          </a:ln>
-        </p:spPr>
-      </p:cxnSp>
-      <p:cxnSp>
-        <p:nvCxnSpPr>
-          <p:cNvPr id="72" name=""/>
-          <p:cNvCxnSpPr>
-            <a:stCxn xmlns:a="http://schemas.openxmlformats.org/drawingml/2006/main" id="26" idx="2"/>
-            <a:endCxn xmlns:a="http://schemas.openxmlformats.org/drawingml/2006/main" id="27" idx="6"/>
-          </p:cNvCxnSpPr>
-          <p:nvPr/>
-        </p:nvCxnSpPr>
-        <p:spPr>
-          <a:xfrm xmlns:a="http://schemas.openxmlformats.org/drawingml/2006/main" flipH="1">
-            <a:off x="8162925" y="4619625"/>
-            <a:ext cx="1676400" cy="142875"/>
-          </a:xfrm>
-          <a:prstGeom xmlns:a="http://schemas.openxmlformats.org/drawingml/2006/main" prst="straightConnector1">
-            <a:avLst/>
-          </a:prstGeom>
-          <a:ln xmlns:a="http://schemas.openxmlformats.org/drawingml/2006/main" w="14288">
-            <a:solidFill>
-              <a:srgbClr val="DDE3E8"/>
-            </a:solidFill>
-            <a:prstDash val="solid"/>
-            <a:tailEnd type="none" w="med" len="med"/>
-          </a:ln>
-        </p:spPr>
-      </p:cxnSp>
-      <p:cxnSp>
-        <p:nvCxnSpPr>
-          <p:cNvPr id="73" name=""/>
-          <p:cNvCxnSpPr>
-            <a:stCxn xmlns:a="http://schemas.openxmlformats.org/drawingml/2006/main" id="27" idx="1"/>
-            <a:endCxn xmlns:a="http://schemas.openxmlformats.org/drawingml/2006/main" id="20" idx="5"/>
-          </p:cNvCxnSpPr>
-          <p:nvPr/>
-        </p:nvCxnSpPr>
-        <p:spPr>
-          <a:xfrm xmlns:a="http://schemas.openxmlformats.org/drawingml/2006/main" flipH="1" flipV="1">
-            <a:off x="7020123" y="3495873"/>
-            <a:ext cx="866378" cy="1152128"/>
-          </a:xfrm>
-          <a:prstGeom xmlns:a="http://schemas.openxmlformats.org/drawingml/2006/main" prst="straightConnector1">
-            <a:avLst/>
-          </a:prstGeom>
-          <a:ln xmlns:a="http://schemas.openxmlformats.org/drawingml/2006/main" w="14288">
-            <a:solidFill>
-              <a:srgbClr val="DDE3E8"/>
-            </a:solidFill>
-            <a:prstDash val="solid"/>
-            <a:tailEnd type="none" w="med" len="med"/>
-          </a:ln>
-        </p:spPr>
-      </p:cxnSp>
-      <p:cxnSp>
-        <p:nvCxnSpPr>
-          <p:cNvPr id="74" name=""/>
-          <p:cNvCxnSpPr>
-            <a:stCxn xmlns:a="http://schemas.openxmlformats.org/drawingml/2006/main" id="21" idx="4"/>
-            <a:endCxn xmlns:a="http://schemas.openxmlformats.org/drawingml/2006/main" id="27" idx="0"/>
+            <a:stCxn xmlns:a="http://schemas.openxmlformats.org/drawingml/2006/main" id="20" idx="4"/>
+            <a:endCxn xmlns:a="http://schemas.openxmlformats.org/drawingml/2006/main" id="26" idx="0"/>
           </p:cNvCxnSpPr>
           <p:nvPr/>
         </p:nvCxnSpPr>
@@ -11090,10 +10998,10 @@
       </p:cxnSp>
       <p:sp>
         <p:nvSpPr>
-          <p:cNvPr id="36" name="">
-            <a:extLst xmlns:a="http://schemas.openxmlformats.org/drawingml/2006/main">
-              <a:ext uri="{FF2B5EF4-FFF2-40B4-BE49-F238E27FC236}">
-                <a16:creationId xmlns:a16="http://schemas.microsoft.com/office/drawing/2014/main" id="{49727152-0501-4160-8D10-666D71C14035}"/>
+          <p:cNvPr id="34" name="">
+            <a:extLst xmlns:a="http://schemas.openxmlformats.org/drawingml/2006/main">
+              <a:ext uri="{FF2B5EF4-FFF2-40B4-BE49-F238E27FC236}">
+                <a16:creationId xmlns:a16="http://schemas.microsoft.com/office/drawing/2014/main" id="{986026D0-81D7-4337-9099-F400F070CD92}"/>
               </a:ext>
             </a:extLst>
           </p:cNvPr>
@@ -11148,10 +11056,10 @@
       </p:sp>
       <p:sp>
         <p:nvSpPr>
-          <p:cNvPr id="37" name="">
-            <a:extLst xmlns:a="http://schemas.openxmlformats.org/drawingml/2006/main">
-              <a:ext uri="{FF2B5EF4-FFF2-40B4-BE49-F238E27FC236}">
-                <a16:creationId xmlns:a16="http://schemas.microsoft.com/office/drawing/2014/main" id="{8C6FCA82-6570-4EE5-99D8-FE1DE8461607}"/>
+          <p:cNvPr id="35" name="">
+            <a:extLst xmlns:a="http://schemas.openxmlformats.org/drawingml/2006/main">
+              <a:ext uri="{FF2B5EF4-FFF2-40B4-BE49-F238E27FC236}">
+                <a16:creationId xmlns:a16="http://schemas.microsoft.com/office/drawing/2014/main" id="{FEF1AB85-24F9-4C75-8C41-485CF544ECD1}"/>
               </a:ext>
             </a:extLst>
           </p:cNvPr>
@@ -11206,10 +11114,10 @@
       </p:sp>
       <p:sp>
         <p:nvSpPr>
-          <p:cNvPr id="38" name="">
-            <a:extLst xmlns:a="http://schemas.openxmlformats.org/drawingml/2006/main">
-              <a:ext uri="{FF2B5EF4-FFF2-40B4-BE49-F238E27FC236}">
-                <a16:creationId xmlns:a16="http://schemas.microsoft.com/office/drawing/2014/main" id="{86B3CD56-539F-4BDE-8B3E-1A2B24749371}"/>
+          <p:cNvPr id="36" name="">
+            <a:extLst xmlns:a="http://schemas.openxmlformats.org/drawingml/2006/main">
+              <a:ext uri="{FF2B5EF4-FFF2-40B4-BE49-F238E27FC236}">
+                <a16:creationId xmlns:a16="http://schemas.microsoft.com/office/drawing/2014/main" id="{02749308-C41E-4A3E-982D-7B02765BA4F8}"/>
               </a:ext>
             </a:extLst>
           </p:cNvPr>
@@ -11270,10 +11178,10 @@
       </p:sp>
       <p:sp>
         <p:nvSpPr>
-          <p:cNvPr id="39" name="">
-            <a:extLst xmlns:a="http://schemas.openxmlformats.org/drawingml/2006/main">
-              <a:ext uri="{FF2B5EF4-FFF2-40B4-BE49-F238E27FC236}">
-                <a16:creationId xmlns:a16="http://schemas.microsoft.com/office/drawing/2014/main" id="{5C2CC3F5-C4B7-481D-AB6D-310AAC82B3F2}"/>
+          <p:cNvPr id="37" name="">
+            <a:extLst xmlns:a="http://schemas.openxmlformats.org/drawingml/2006/main">
+              <a:ext uri="{FF2B5EF4-FFF2-40B4-BE49-F238E27FC236}">
+                <a16:creationId xmlns:a16="http://schemas.microsoft.com/office/drawing/2014/main" id="{AC0ADC46-D06A-4BB1-B2A1-D8AD5216BF8E}"/>
               </a:ext>
             </a:extLst>
           </p:cNvPr>
@@ -11335,7 +11243,7 @@
     </p:spTree>
     <p:extLst>
       <p:ext uri="{BB962C8B-B14F-4D97-AF65-F5344CB8AC3E}">
-        <p14:creationId xmlns:p14="http://schemas.microsoft.com/office/powerpoint/2010/main" val="1866503886"/>
+        <p14:creationId xmlns:p14="http://schemas.microsoft.com/office/powerpoint/2010/main" val="218718583"/>
       </p:ext>
     </p:extLst>
   </p:cSld>
@@ -11366,7 +11274,7 @@
           <p:cNvPr id="41" name="">
             <a:extLst xmlns:a="http://schemas.openxmlformats.org/drawingml/2006/main">
               <a:ext uri="{FF2B5EF4-FFF2-40B4-BE49-F238E27FC236}">
-                <a16:creationId xmlns:a16="http://schemas.microsoft.com/office/drawing/2014/main" id="{10D986B0-FEBD-450A-AE64-3A59B19B521C}"/>
+                <a16:creationId xmlns:a16="http://schemas.microsoft.com/office/drawing/2014/main" id="{ACB99BBE-2173-449F-8528-F7250CFCA127}"/>
               </a:ext>
             </a:extLst>
           </p:cNvPr>
@@ -11424,7 +11332,7 @@
           <p:cNvPr id="2" name="">
             <a:extLst xmlns:a="http://schemas.openxmlformats.org/drawingml/2006/main">
               <a:ext uri="{FF2B5EF4-FFF2-40B4-BE49-F238E27FC236}">
-                <a16:creationId xmlns:a16="http://schemas.microsoft.com/office/drawing/2014/main" id="{D65F4FA2-B250-4EF1-A974-3AB4F802A1C7}"/>
+                <a16:creationId xmlns:a16="http://schemas.microsoft.com/office/drawing/2014/main" id="{822E0A71-696B-4C9A-8636-5B9CA7F7176F}"/>
               </a:ext>
             </a:extLst>
           </p:cNvPr>
@@ -11505,7 +11413,7 @@
           <p:cNvPr id="3" name="">
             <a:extLst xmlns:a="http://schemas.openxmlformats.org/drawingml/2006/main">
               <a:ext uri="{FF2B5EF4-FFF2-40B4-BE49-F238E27FC236}">
-                <a16:creationId xmlns:a16="http://schemas.microsoft.com/office/drawing/2014/main" id="{07628866-3DEC-48FF-A1CE-DD8CA361260C}"/>
+                <a16:creationId xmlns:a16="http://schemas.microsoft.com/office/drawing/2014/main" id="{284018C4-440F-43D8-807B-36FC7362D34F}"/>
               </a:ext>
             </a:extLst>
           </p:cNvPr>
@@ -11563,7 +11471,7 @@
           <p:cNvPr id="4" name="">
             <a:extLst xmlns:a="http://schemas.openxmlformats.org/drawingml/2006/main">
               <a:ext uri="{FF2B5EF4-FFF2-40B4-BE49-F238E27FC236}">
-                <a16:creationId xmlns:a16="http://schemas.microsoft.com/office/drawing/2014/main" id="{F430101F-D0FC-4075-8CF8-4A9EB9280329}"/>
+                <a16:creationId xmlns:a16="http://schemas.microsoft.com/office/drawing/2014/main" id="{79582C16-1E01-4D06-98B3-1BC0B7A724AB}"/>
               </a:ext>
             </a:extLst>
           </p:cNvPr>
@@ -11621,7 +11529,7 @@
           <p:cNvPr id="5" name="">
             <a:extLst xmlns:a="http://schemas.openxmlformats.org/drawingml/2006/main">
               <a:ext uri="{FF2B5EF4-FFF2-40B4-BE49-F238E27FC236}">
-                <a16:creationId xmlns:a16="http://schemas.microsoft.com/office/drawing/2014/main" id="{FAF1CBC3-C9DD-4036-B223-44BFE8F46EEA}"/>
+                <a16:creationId xmlns:a16="http://schemas.microsoft.com/office/drawing/2014/main" id="{39229480-7187-4BFF-BE6C-B246F40036FC}"/>
               </a:ext>
             </a:extLst>
           </p:cNvPr>
@@ -11654,7 +11562,7 @@
           <p:cNvPr id="6" name="">
             <a:extLst xmlns:a="http://schemas.openxmlformats.org/drawingml/2006/main">
               <a:ext uri="{FF2B5EF4-FFF2-40B4-BE49-F238E27FC236}">
-                <a16:creationId xmlns:a16="http://schemas.microsoft.com/office/drawing/2014/main" id="{F830C902-65F2-4F35-ABC9-6E732E5D997C}"/>
+                <a16:creationId xmlns:a16="http://schemas.microsoft.com/office/drawing/2014/main" id="{35AB4EC5-4184-4C11-ACCC-E5C9C649FAB3}"/>
               </a:ext>
             </a:extLst>
           </p:cNvPr>
@@ -11687,7 +11595,7 @@
           <p:cNvPr id="7" name="">
             <a:extLst xmlns:a="http://schemas.openxmlformats.org/drawingml/2006/main">
               <a:ext uri="{FF2B5EF4-FFF2-40B4-BE49-F238E27FC236}">
-                <a16:creationId xmlns:a16="http://schemas.microsoft.com/office/drawing/2014/main" id="{37FE1764-F11D-4A14-9E1F-F64D48CF1512}"/>
+                <a16:creationId xmlns:a16="http://schemas.microsoft.com/office/drawing/2014/main" id="{FA544881-F199-4474-8B06-66B0FF12542B}"/>
               </a:ext>
             </a:extLst>
           </p:cNvPr>
@@ -11720,7 +11628,7 @@
           <p:cNvPr id="8" name="">
             <a:extLst xmlns:a="http://schemas.openxmlformats.org/drawingml/2006/main">
               <a:ext uri="{FF2B5EF4-FFF2-40B4-BE49-F238E27FC236}">
-                <a16:creationId xmlns:a16="http://schemas.microsoft.com/office/drawing/2014/main" id="{C4AB61C7-D255-4ED6-BAEC-06C5CEAC428B}"/>
+                <a16:creationId xmlns:a16="http://schemas.microsoft.com/office/drawing/2014/main" id="{07E027E3-5CAC-454B-9F80-D8CDE5278ADA}"/>
               </a:ext>
             </a:extLst>
           </p:cNvPr>
@@ -11831,7 +11739,7 @@
           <p:cNvPr id="12" name="">
             <a:extLst xmlns:a="http://schemas.openxmlformats.org/drawingml/2006/main">
               <a:ext uri="{FF2B5EF4-FFF2-40B4-BE49-F238E27FC236}">
-                <a16:creationId xmlns:a16="http://schemas.microsoft.com/office/drawing/2014/main" id="{E53F9862-7506-433A-AAF6-1F769BE291C5}"/>
+                <a16:creationId xmlns:a16="http://schemas.microsoft.com/office/drawing/2014/main" id="{2B3530E8-6A53-42F2-B1F3-F4E03193836F}"/>
               </a:ext>
             </a:extLst>
           </p:cNvPr>
@@ -11864,7 +11772,7 @@
           <p:cNvPr id="13" name="">
             <a:extLst xmlns:a="http://schemas.openxmlformats.org/drawingml/2006/main">
               <a:ext uri="{FF2B5EF4-FFF2-40B4-BE49-F238E27FC236}">
-                <a16:creationId xmlns:a16="http://schemas.microsoft.com/office/drawing/2014/main" id="{1949DF79-652A-4746-97DB-F597C4992543}"/>
+                <a16:creationId xmlns:a16="http://schemas.microsoft.com/office/drawing/2014/main" id="{A7B85598-0187-4317-949F-1A9195023FCF}"/>
               </a:ext>
             </a:extLst>
           </p:cNvPr>
@@ -11897,7 +11805,7 @@
           <p:cNvPr id="14" name="">
             <a:extLst xmlns:a="http://schemas.openxmlformats.org/drawingml/2006/main">
               <a:ext uri="{FF2B5EF4-FFF2-40B4-BE49-F238E27FC236}">
-                <a16:creationId xmlns:a16="http://schemas.microsoft.com/office/drawing/2014/main" id="{0CBA962A-1A4F-4710-BED2-05F8EF890B61}"/>
+                <a16:creationId xmlns:a16="http://schemas.microsoft.com/office/drawing/2014/main" id="{DB15ABAD-59E5-4DDC-856D-CEB0BD5AA26C}"/>
               </a:ext>
             </a:extLst>
           </p:cNvPr>
@@ -11930,7 +11838,7 @@
           <p:cNvPr id="15" name="">
             <a:extLst xmlns:a="http://schemas.openxmlformats.org/drawingml/2006/main">
               <a:ext uri="{FF2B5EF4-FFF2-40B4-BE49-F238E27FC236}">
-                <a16:creationId xmlns:a16="http://schemas.microsoft.com/office/drawing/2014/main" id="{82279E8C-1552-48BD-AE60-3735ADBB7526}"/>
+                <a16:creationId xmlns:a16="http://schemas.microsoft.com/office/drawing/2014/main" id="{759843D8-FF45-4E20-8B17-3AA79FDF92BB}"/>
               </a:ext>
             </a:extLst>
           </p:cNvPr>
@@ -11963,7 +11871,7 @@
           <p:cNvPr id="16" name="">
             <a:extLst xmlns:a="http://schemas.openxmlformats.org/drawingml/2006/main">
               <a:ext uri="{FF2B5EF4-FFF2-40B4-BE49-F238E27FC236}">
-                <a16:creationId xmlns:a16="http://schemas.microsoft.com/office/drawing/2014/main" id="{4FFBDD6A-EE18-4D63-8AD9-F1E1C4ED4C79}"/>
+                <a16:creationId xmlns:a16="http://schemas.microsoft.com/office/drawing/2014/main" id="{01273B52-7950-49BD-BEA1-7EAD855CB89F}"/>
               </a:ext>
             </a:extLst>
           </p:cNvPr>
@@ -11994,7 +11902,7 @@
           <p:cNvPr id="17" name="">
             <a:extLst xmlns:a="http://schemas.openxmlformats.org/drawingml/2006/main">
               <a:ext uri="{FF2B5EF4-FFF2-40B4-BE49-F238E27FC236}">
-                <a16:creationId xmlns:a16="http://schemas.microsoft.com/office/drawing/2014/main" id="{CFEED74A-739A-4DF9-BB94-D52871E23A35}"/>
+                <a16:creationId xmlns:a16="http://schemas.microsoft.com/office/drawing/2014/main" id="{BBA93532-6392-44D5-A0BC-435BF9CC5C6B}"/>
               </a:ext>
             </a:extLst>
           </p:cNvPr>
@@ -12157,7 +12065,7 @@
           <p:cNvPr id="23" name="">
             <a:extLst xmlns:a="http://schemas.openxmlformats.org/drawingml/2006/main">
               <a:ext uri="{FF2B5EF4-FFF2-40B4-BE49-F238E27FC236}">
-                <a16:creationId xmlns:a16="http://schemas.microsoft.com/office/drawing/2014/main" id="{F28321A2-9BB1-41C7-8F95-E4F9060DA523}"/>
+                <a16:creationId xmlns:a16="http://schemas.microsoft.com/office/drawing/2014/main" id="{F8B9B3C8-941C-4BE9-92B7-B31D27EE12D5}"/>
               </a:ext>
             </a:extLst>
           </p:cNvPr>
@@ -12190,7 +12098,7 @@
           <p:cNvPr id="24" name="">
             <a:extLst xmlns:a="http://schemas.openxmlformats.org/drawingml/2006/main">
               <a:ext uri="{FF2B5EF4-FFF2-40B4-BE49-F238E27FC236}">
-                <a16:creationId xmlns:a16="http://schemas.microsoft.com/office/drawing/2014/main" id="{43E1805A-02FE-4508-A62F-7DF05090B068}"/>
+                <a16:creationId xmlns:a16="http://schemas.microsoft.com/office/drawing/2014/main" id="{6466F1EA-B1AD-4239-BACC-D66AF4D81798}"/>
               </a:ext>
             </a:extLst>
           </p:cNvPr>
@@ -12223,7 +12131,7 @@
           <p:cNvPr id="25" name="">
             <a:extLst xmlns:a="http://schemas.openxmlformats.org/drawingml/2006/main">
               <a:ext uri="{FF2B5EF4-FFF2-40B4-BE49-F238E27FC236}">
-                <a16:creationId xmlns:a16="http://schemas.microsoft.com/office/drawing/2014/main" id="{F82F824D-64C9-40D3-9A46-FA5610389795}"/>
+                <a16:creationId xmlns:a16="http://schemas.microsoft.com/office/drawing/2014/main" id="{AC39C985-53DF-4F4B-9E46-04EF8C00F29F}"/>
               </a:ext>
             </a:extLst>
           </p:cNvPr>
@@ -12256,7 +12164,7 @@
           <p:cNvPr id="26" name="">
             <a:extLst xmlns:a="http://schemas.openxmlformats.org/drawingml/2006/main">
               <a:ext uri="{FF2B5EF4-FFF2-40B4-BE49-F238E27FC236}">
-                <a16:creationId xmlns:a16="http://schemas.microsoft.com/office/drawing/2014/main" id="{E8952A2C-3261-4C02-A315-2ACC996D1BF3}"/>
+                <a16:creationId xmlns:a16="http://schemas.microsoft.com/office/drawing/2014/main" id="{4E4A45CA-174A-48F0-8D84-C477C66C3366}"/>
               </a:ext>
             </a:extLst>
           </p:cNvPr>
@@ -12287,7 +12195,7 @@
           <p:cNvPr id="27" name="">
             <a:extLst xmlns:a="http://schemas.openxmlformats.org/drawingml/2006/main">
               <a:ext uri="{FF2B5EF4-FFF2-40B4-BE49-F238E27FC236}">
-                <a16:creationId xmlns:a16="http://schemas.microsoft.com/office/drawing/2014/main" id="{C327C404-E21B-4996-8728-44C82F40E57F}"/>
+                <a16:creationId xmlns:a16="http://schemas.microsoft.com/office/drawing/2014/main" id="{96DD8387-171A-41D1-92D5-D3345047C664}"/>
               </a:ext>
             </a:extLst>
           </p:cNvPr>
@@ -12320,7 +12228,7 @@
           <p:cNvPr id="28" name="">
             <a:extLst xmlns:a="http://schemas.openxmlformats.org/drawingml/2006/main">
               <a:ext uri="{FF2B5EF4-FFF2-40B4-BE49-F238E27FC236}">
-                <a16:creationId xmlns:a16="http://schemas.microsoft.com/office/drawing/2014/main" id="{3F1AC535-E828-421C-B3BF-804B4AAB4E1E}"/>
+                <a16:creationId xmlns:a16="http://schemas.microsoft.com/office/drawing/2014/main" id="{94C11415-1673-4624-ADE6-42DEE300493D}"/>
               </a:ext>
             </a:extLst>
           </p:cNvPr>
@@ -12353,7 +12261,7 @@
           <p:cNvPr id="29" name="">
             <a:extLst xmlns:a="http://schemas.openxmlformats.org/drawingml/2006/main">
               <a:ext uri="{FF2B5EF4-FFF2-40B4-BE49-F238E27FC236}">
-                <a16:creationId xmlns:a16="http://schemas.microsoft.com/office/drawing/2014/main" id="{0A5D4FBA-440E-4645-9CD4-3534997EE44A}"/>
+                <a16:creationId xmlns:a16="http://schemas.microsoft.com/office/drawing/2014/main" id="{8E73999F-27B9-4D0F-806B-D8266B27DC63}"/>
               </a:ext>
             </a:extLst>
           </p:cNvPr>
@@ -12386,7 +12294,7 @@
           <p:cNvPr id="30" name="">
             <a:extLst xmlns:a="http://schemas.openxmlformats.org/drawingml/2006/main">
               <a:ext uri="{FF2B5EF4-FFF2-40B4-BE49-F238E27FC236}">
-                <a16:creationId xmlns:a16="http://schemas.microsoft.com/office/drawing/2014/main" id="{97746773-0BB3-44C1-A60C-4E93BE4685D3}"/>
+                <a16:creationId xmlns:a16="http://schemas.microsoft.com/office/drawing/2014/main" id="{4A37AF52-7169-42B4-9921-D1E98B924DD5}"/>
               </a:ext>
             </a:extLst>
           </p:cNvPr>
@@ -12419,7 +12327,7 @@
           <p:cNvPr id="31" name="">
             <a:extLst xmlns:a="http://schemas.openxmlformats.org/drawingml/2006/main">
               <a:ext uri="{FF2B5EF4-FFF2-40B4-BE49-F238E27FC236}">
-                <a16:creationId xmlns:a16="http://schemas.microsoft.com/office/drawing/2014/main" id="{8C8F5467-72CA-483F-B00C-12D726F51C26}"/>
+                <a16:creationId xmlns:a16="http://schemas.microsoft.com/office/drawing/2014/main" id="{081A1824-E89F-4A27-B4BC-E8D8048CF9DE}"/>
               </a:ext>
             </a:extLst>
           </p:cNvPr>
@@ -12452,7 +12360,7 @@
           <p:cNvPr id="32" name="">
             <a:extLst xmlns:a="http://schemas.openxmlformats.org/drawingml/2006/main">
               <a:ext uri="{FF2B5EF4-FFF2-40B4-BE49-F238E27FC236}">
-                <a16:creationId xmlns:a16="http://schemas.microsoft.com/office/drawing/2014/main" id="{8BA3303D-6D0C-4C9A-8EF7-3E18E70253A4}"/>
+                <a16:creationId xmlns:a16="http://schemas.microsoft.com/office/drawing/2014/main" id="{2525F027-16E9-45A2-9D63-4FA42703E972}"/>
               </a:ext>
             </a:extLst>
           </p:cNvPr>
@@ -12485,7 +12393,7 @@
           <p:cNvPr id="33" name="">
             <a:extLst xmlns:a="http://schemas.openxmlformats.org/drawingml/2006/main">
               <a:ext uri="{FF2B5EF4-FFF2-40B4-BE49-F238E27FC236}">
-                <a16:creationId xmlns:a16="http://schemas.microsoft.com/office/drawing/2014/main" id="{C0CD4947-661E-4EC5-8577-B78402CFA74A}"/>
+                <a16:creationId xmlns:a16="http://schemas.microsoft.com/office/drawing/2014/main" id="{1B1A6255-8EDB-465B-89FF-CBA9A482F260}"/>
               </a:ext>
             </a:extLst>
           </p:cNvPr>
@@ -12568,7 +12476,7 @@
           <p:cNvPr id="36" name="">
             <a:extLst xmlns:a="http://schemas.openxmlformats.org/drawingml/2006/main">
               <a:ext uri="{FF2B5EF4-FFF2-40B4-BE49-F238E27FC236}">
-                <a16:creationId xmlns:a16="http://schemas.microsoft.com/office/drawing/2014/main" id="{CC627D14-F4B2-4274-8866-D88BC694819D}"/>
+                <a16:creationId xmlns:a16="http://schemas.microsoft.com/office/drawing/2014/main" id="{8F111739-7546-4504-A515-E6C6DCBF8A03}"/>
               </a:ext>
             </a:extLst>
           </p:cNvPr>
@@ -12601,7 +12509,7 @@
           <p:cNvPr id="37" name="">
             <a:extLst xmlns:a="http://schemas.openxmlformats.org/drawingml/2006/main">
               <a:ext uri="{FF2B5EF4-FFF2-40B4-BE49-F238E27FC236}">
-                <a16:creationId xmlns:a16="http://schemas.microsoft.com/office/drawing/2014/main" id="{3F879009-58BD-4727-ABB1-31C60B4DE1AC}"/>
+                <a16:creationId xmlns:a16="http://schemas.microsoft.com/office/drawing/2014/main" id="{38F8A948-B313-41BF-BA1C-061C4FF4BDF6}"/>
               </a:ext>
             </a:extLst>
           </p:cNvPr>
@@ -12659,7 +12567,7 @@
           <p:cNvPr id="38" name="">
             <a:extLst xmlns:a="http://schemas.openxmlformats.org/drawingml/2006/main">
               <a:ext uri="{FF2B5EF4-FFF2-40B4-BE49-F238E27FC236}">
-                <a16:creationId xmlns:a16="http://schemas.microsoft.com/office/drawing/2014/main" id="{96FC2EE1-8EF9-40ED-B0FB-D4C1B897404B}"/>
+                <a16:creationId xmlns:a16="http://schemas.microsoft.com/office/drawing/2014/main" id="{7A97747B-0059-48DF-AB25-B36A4539335A}"/>
               </a:ext>
             </a:extLst>
           </p:cNvPr>
@@ -12717,7 +12625,7 @@
           <p:cNvPr id="39" name="">
             <a:extLst xmlns:a="http://schemas.openxmlformats.org/drawingml/2006/main">
               <a:ext uri="{FF2B5EF4-FFF2-40B4-BE49-F238E27FC236}">
-                <a16:creationId xmlns:a16="http://schemas.microsoft.com/office/drawing/2014/main" id="{446FB02C-AA92-4210-B951-0661E08D8BA0}"/>
+                <a16:creationId xmlns:a16="http://schemas.microsoft.com/office/drawing/2014/main" id="{D7FD2DE1-4735-415F-8115-E239E7537AD4}"/>
               </a:ext>
             </a:extLst>
           </p:cNvPr>
@@ -12775,7 +12683,7 @@
           <p:cNvPr id="40" name="">
             <a:extLst xmlns:a="http://schemas.openxmlformats.org/drawingml/2006/main">
               <a:ext uri="{FF2B5EF4-FFF2-40B4-BE49-F238E27FC236}">
-                <a16:creationId xmlns:a16="http://schemas.microsoft.com/office/drawing/2014/main" id="{A9F383E3-4744-4641-80EC-4175FF0FDCD7}"/>
+                <a16:creationId xmlns:a16="http://schemas.microsoft.com/office/drawing/2014/main" id="{FBC8F4D2-12E9-43E7-98DD-738C556D5C7B}"/>
               </a:ext>
             </a:extLst>
           </p:cNvPr>
@@ -12831,7 +12739,7 @@
     </p:spTree>
     <p:extLst>
       <p:ext uri="{BB962C8B-B14F-4D97-AF65-F5344CB8AC3E}">
-        <p14:creationId xmlns:p14="http://schemas.microsoft.com/office/powerpoint/2010/main" val="1705801183"/>
+        <p14:creationId xmlns:p14="http://schemas.microsoft.com/office/powerpoint/2010/main" val="989708105"/>
       </p:ext>
     </p:extLst>
   </p:cSld>

</xml_diff>

<commit_message>
Update presentation content and visuals: refine example requirements and clarify visual guidance
</commit_message>
<xml_diff>
--- a/.codex-build/presentation-visuals/candidate.pptx
+++ b/.codex-build/presentation-visuals/candidate.pptx
@@ -2,20 +2,20 @@
 <file path=ppt/presentation.xml><?xml version="1.0" encoding="utf-8"?>
 <p:presentation xmlns:p="http://schemas.openxmlformats.org/presentationml/2006/main">
   <p:sldMasterIdLst>
-    <p:sldMasterId xmlns:r="http://schemas.openxmlformats.org/officeDocument/2006/relationships" id="2147483648" r:id="R4faf8983f4974186"/>
+    <p:sldMasterId xmlns:r="http://schemas.openxmlformats.org/officeDocument/2006/relationships" id="2147483648" r:id="Rc5f46194076e4014"/>
   </p:sldMasterIdLst>
   <p:notesMasterIdLst>
-    <p:notesMasterId xmlns:r="http://schemas.openxmlformats.org/officeDocument/2006/relationships" r:id="R468e7450726149d3"/>
+    <p:notesMasterId xmlns:r="http://schemas.openxmlformats.org/officeDocument/2006/relationships" r:id="R94520bc91aaf420e"/>
   </p:notesMasterIdLst>
   <p:sldIdLst>
-    <p:sldId xmlns:r="http://schemas.openxmlformats.org/officeDocument/2006/relationships" id="256" r:id="R831d3367a9ee4a48"/>
-    <p:sldId xmlns:r="http://schemas.openxmlformats.org/officeDocument/2006/relationships" id="257" r:id="R31777f90792a4675"/>
-    <p:sldId xmlns:r="http://schemas.openxmlformats.org/officeDocument/2006/relationships" id="258" r:id="R38299a90e5ff4066"/>
-    <p:sldId xmlns:r="http://schemas.openxmlformats.org/officeDocument/2006/relationships" id="259" r:id="Rdc4c490e5bd24e6a"/>
-    <p:sldId xmlns:r="http://schemas.openxmlformats.org/officeDocument/2006/relationships" id="260" r:id="Re5ef3f37d77242e3"/>
-    <p:sldId xmlns:r="http://schemas.openxmlformats.org/officeDocument/2006/relationships" id="261" r:id="R8e00c44baaf14e7f"/>
-    <p:sldId xmlns:r="http://schemas.openxmlformats.org/officeDocument/2006/relationships" id="262" r:id="Raaf10ab063744970"/>
-    <p:sldId xmlns:r="http://schemas.openxmlformats.org/officeDocument/2006/relationships" id="263" r:id="Rc67a2b5fc4844fda"/>
+    <p:sldId xmlns:r="http://schemas.openxmlformats.org/officeDocument/2006/relationships" id="256" r:id="R0be4b8cfcce04fc7"/>
+    <p:sldId xmlns:r="http://schemas.openxmlformats.org/officeDocument/2006/relationships" id="257" r:id="R8bcc506e388c4315"/>
+    <p:sldId xmlns:r="http://schemas.openxmlformats.org/officeDocument/2006/relationships" id="258" r:id="R08b97f6f2cbe4af9"/>
+    <p:sldId xmlns:r="http://schemas.openxmlformats.org/officeDocument/2006/relationships" id="259" r:id="Rd60406571f3e4103"/>
+    <p:sldId xmlns:r="http://schemas.openxmlformats.org/officeDocument/2006/relationships" id="260" r:id="Rff35c53d38e14eaa"/>
+    <p:sldId xmlns:r="http://schemas.openxmlformats.org/officeDocument/2006/relationships" id="261" r:id="Red1ac3ecf93449ad"/>
+    <p:sldId xmlns:r="http://schemas.openxmlformats.org/officeDocument/2006/relationships" id="262" r:id="R7d7ded5e11a94a24"/>
+    <p:sldId xmlns:r="http://schemas.openxmlformats.org/officeDocument/2006/relationships" id="263" r:id="R118b83d270854ca8"/>
   </p:sldIdLst>
   <p:sldSz cx="12192000" cy="6858000"/>
   <p:notesSz cx="6858000" cy="9144000"/>
@@ -975,7 +975,7 @@
   </p:cSld>
   <p:clrMap bg1="lt1" tx1="dk1" bg2="lt2" tx2="dk2" accent1="accent1" accent2="accent2" accent3="accent3" accent4="accent4" accent5="accent5" accent6="accent6" hlink="hlink" folHlink="folHlink"/>
   <p:sldLayoutIdLst>
-    <p:sldLayoutId xmlns:r="http://schemas.openxmlformats.org/officeDocument/2006/relationships" id="2147483649" r:id="R977c5c56637f4419"/>
+    <p:sldLayoutId xmlns:r="http://schemas.openxmlformats.org/officeDocument/2006/relationships" id="2147483649" r:id="Rd1d7861826bb4509"/>
   </p:sldLayoutIdLst>
   <p:txStyles>
     <p:titleStyle>
@@ -1523,253 +1523,10 @@
       </p:grpSpPr>
       <p:sp>
         <p:nvSpPr>
-          <p:cNvPr id="29" name="">
-            <a:extLst xmlns:a="http://schemas.openxmlformats.org/drawingml/2006/main">
-              <a:ext uri="{FF2B5EF4-FFF2-40B4-BE49-F238E27FC236}">
-                <a16:creationId xmlns:a16="http://schemas.microsoft.com/office/drawing/2014/main" id="{8A32F8D7-006B-4C4F-BDE9-031E1CFB4383}"/>
-              </a:ext>
-            </a:extLst>
-          </p:cNvPr>
-          <p:cNvSpPr>
-            <a:spLocks xmlns:a="http://schemas.openxmlformats.org/drawingml/2006/main" noGrp="1"/>
-          </p:cNvSpPr>
-          <p:nvPr/>
-        </p:nvSpPr>
-        <p:spPr>
-          <a:xfrm xmlns:a="http://schemas.openxmlformats.org/drawingml/2006/main">
-            <a:off x="876300" y="3543300"/>
-            <a:ext cx="247650" cy="247650"/>
-          </a:xfrm>
-          <a:prstGeom xmlns:a="http://schemas.openxmlformats.org/drawingml/2006/main" prst="ellipse">
-            <a:avLst/>
-          </a:prstGeom>
-          <a:solidFill xmlns:a="http://schemas.openxmlformats.org/drawingml/2006/main">
-            <a:srgbClr val="F7F9FB"/>
-          </a:solidFill>
-          <a:ln xmlns:a="http://schemas.openxmlformats.org/drawingml/2006/main" w="23813">
-            <a:solidFill>
-              <a:srgbClr val="DDE3E8"/>
-            </a:solidFill>
-            <a:prstDash val="solid"/>
-          </a:ln>
-        </p:spPr>
-      </p:sp>
-      <p:sp>
-        <p:nvSpPr>
-          <p:cNvPr id="2" name="">
-            <a:extLst xmlns:a="http://schemas.openxmlformats.org/drawingml/2006/main">
-              <a:ext uri="{FF2B5EF4-FFF2-40B4-BE49-F238E27FC236}">
-                <a16:creationId xmlns:a16="http://schemas.microsoft.com/office/drawing/2014/main" id="{CD09EE97-6CED-42A4-8B18-554325418E87}"/>
-              </a:ext>
-            </a:extLst>
-          </p:cNvPr>
-          <p:cNvSpPr>
-            <a:spLocks xmlns:a="http://schemas.openxmlformats.org/drawingml/2006/main" noGrp="1"/>
-          </p:cNvSpPr>
-          <p:nvPr/>
-        </p:nvSpPr>
-        <p:spPr>
-          <a:xfrm xmlns:a="http://schemas.openxmlformats.org/drawingml/2006/main">
-            <a:off x="1352550" y="4638675"/>
-            <a:ext cx="247650" cy="247650"/>
-          </a:xfrm>
-          <a:prstGeom xmlns:a="http://schemas.openxmlformats.org/drawingml/2006/main" prst="ellipse">
-            <a:avLst/>
-          </a:prstGeom>
-          <a:solidFill xmlns:a="http://schemas.openxmlformats.org/drawingml/2006/main">
-            <a:srgbClr val="F7F9FB"/>
-          </a:solidFill>
-          <a:ln xmlns:a="http://schemas.openxmlformats.org/drawingml/2006/main" w="23813">
-            <a:solidFill>
-              <a:srgbClr val="DDE3E8"/>
-            </a:solidFill>
-            <a:prstDash val="solid"/>
-          </a:ln>
-        </p:spPr>
-      </p:sp>
-      <p:sp>
-        <p:nvSpPr>
-          <p:cNvPr id="3" name="">
-            <a:extLst xmlns:a="http://schemas.openxmlformats.org/drawingml/2006/main">
-              <a:ext uri="{FF2B5EF4-FFF2-40B4-BE49-F238E27FC236}">
-                <a16:creationId xmlns:a16="http://schemas.microsoft.com/office/drawing/2014/main" id="{73990FC6-6969-4099-BB29-350F46CBB590}"/>
-              </a:ext>
-            </a:extLst>
-          </p:cNvPr>
-          <p:cNvSpPr>
-            <a:spLocks xmlns:a="http://schemas.openxmlformats.org/drawingml/2006/main" noGrp="1"/>
-          </p:cNvSpPr>
-          <p:nvPr/>
-        </p:nvSpPr>
-        <p:spPr>
-          <a:xfrm xmlns:a="http://schemas.openxmlformats.org/drawingml/2006/main">
-            <a:off x="3067050" y="5067300"/>
-            <a:ext cx="247650" cy="247650"/>
-          </a:xfrm>
-          <a:prstGeom xmlns:a="http://schemas.openxmlformats.org/drawingml/2006/main" prst="ellipse">
-            <a:avLst/>
-          </a:prstGeom>
-          <a:solidFill xmlns:a="http://schemas.openxmlformats.org/drawingml/2006/main">
-            <a:srgbClr val="F7F9FB"/>
-          </a:solidFill>
-          <a:ln xmlns:a="http://schemas.openxmlformats.org/drawingml/2006/main" w="23813">
-            <a:solidFill>
-              <a:srgbClr val="DDE3E8"/>
-            </a:solidFill>
-            <a:prstDash val="solid"/>
-          </a:ln>
-        </p:spPr>
-      </p:sp>
-      <p:sp>
-        <p:nvSpPr>
-          <p:cNvPr id="4" name="">
-            <a:extLst xmlns:a="http://schemas.openxmlformats.org/drawingml/2006/main">
-              <a:ext uri="{FF2B5EF4-FFF2-40B4-BE49-F238E27FC236}">
-                <a16:creationId xmlns:a16="http://schemas.microsoft.com/office/drawing/2014/main" id="{E60EFD57-EA05-4A9A-9312-AF04D7C45530}"/>
-              </a:ext>
-            </a:extLst>
-          </p:cNvPr>
-          <p:cNvSpPr>
-            <a:spLocks xmlns:a="http://schemas.openxmlformats.org/drawingml/2006/main" noGrp="1"/>
-          </p:cNvSpPr>
-          <p:nvPr/>
-        </p:nvSpPr>
-        <p:spPr>
-          <a:xfrm xmlns:a="http://schemas.openxmlformats.org/drawingml/2006/main">
-            <a:off x="10163175" y="4352925"/>
-            <a:ext cx="247650" cy="247650"/>
-          </a:xfrm>
-          <a:prstGeom xmlns:a="http://schemas.openxmlformats.org/drawingml/2006/main" prst="ellipse">
-            <a:avLst/>
-          </a:prstGeom>
-          <a:solidFill xmlns:a="http://schemas.openxmlformats.org/drawingml/2006/main">
-            <a:srgbClr val="F7F9FB"/>
-          </a:solidFill>
-          <a:ln xmlns:a="http://schemas.openxmlformats.org/drawingml/2006/main" w="23813">
-            <a:solidFill>
-              <a:srgbClr val="DDE3E8"/>
-            </a:solidFill>
-            <a:prstDash val="solid"/>
-          </a:ln>
-        </p:spPr>
-      </p:sp>
-      <p:sp>
-        <p:nvSpPr>
-          <p:cNvPr id="5" name="">
-            <a:extLst xmlns:a="http://schemas.openxmlformats.org/drawingml/2006/main">
-              <a:ext uri="{FF2B5EF4-FFF2-40B4-BE49-F238E27FC236}">
-                <a16:creationId xmlns:a16="http://schemas.microsoft.com/office/drawing/2014/main" id="{6F5CEE48-0AB2-4C13-AA4A-BADAC064D376}"/>
-              </a:ext>
-            </a:extLst>
-          </p:cNvPr>
-          <p:cNvSpPr>
-            <a:spLocks xmlns:a="http://schemas.openxmlformats.org/drawingml/2006/main" noGrp="1"/>
-          </p:cNvSpPr>
-          <p:nvPr/>
-        </p:nvSpPr>
-        <p:spPr>
-          <a:xfrm xmlns:a="http://schemas.openxmlformats.org/drawingml/2006/main">
-            <a:off x="10972800" y="3495675"/>
-            <a:ext cx="247650" cy="247650"/>
-          </a:xfrm>
-          <a:prstGeom xmlns:a="http://schemas.openxmlformats.org/drawingml/2006/main" prst="ellipse">
-            <a:avLst/>
-          </a:prstGeom>
-          <a:solidFill xmlns:a="http://schemas.openxmlformats.org/drawingml/2006/main">
-            <a:srgbClr val="F7F9FB"/>
-          </a:solidFill>
-          <a:ln xmlns:a="http://schemas.openxmlformats.org/drawingml/2006/main" w="23813">
-            <a:solidFill>
-              <a:srgbClr val="DDE3E8"/>
-            </a:solidFill>
-            <a:prstDash val="solid"/>
-          </a:ln>
-        </p:spPr>
-      </p:sp>
-      <p:cxnSp>
-        <p:nvCxnSpPr>
-          <p:cNvPr id="34" name=""/>
-          <p:cNvCxnSpPr>
-            <a:stCxn xmlns:a="http://schemas.openxmlformats.org/drawingml/2006/main" id="1" idx="4"/>
-            <a:endCxn xmlns:a="http://schemas.openxmlformats.org/drawingml/2006/main" id="2" idx="1"/>
-          </p:cNvCxnSpPr>
-          <p:nvPr/>
-        </p:nvCxnSpPr>
-        <p:spPr>
-          <a:xfrm xmlns:a="http://schemas.openxmlformats.org/drawingml/2006/main">
-            <a:off x="1000125" y="3790950"/>
-            <a:ext cx="388693" cy="883993"/>
-          </a:xfrm>
-          <a:prstGeom xmlns:a="http://schemas.openxmlformats.org/drawingml/2006/main" prst="straightConnector1">
-            <a:avLst/>
-          </a:prstGeom>
-          <a:ln xmlns:a="http://schemas.openxmlformats.org/drawingml/2006/main" w="14288">
-            <a:solidFill>
-              <a:srgbClr val="DDE3E8"/>
-            </a:solidFill>
-            <a:prstDash val="solid"/>
-            <a:tailEnd type="none" w="med" len="med"/>
-          </a:ln>
-        </p:spPr>
-      </p:cxnSp>
-      <p:cxnSp>
-        <p:nvCxnSpPr>
-          <p:cNvPr id="35" name=""/>
-          <p:cNvCxnSpPr>
-            <a:stCxn xmlns:a="http://schemas.openxmlformats.org/drawingml/2006/main" id="2" idx="6"/>
-            <a:endCxn xmlns:a="http://schemas.openxmlformats.org/drawingml/2006/main" id="3" idx="2"/>
-          </p:cNvCxnSpPr>
-          <p:nvPr/>
-        </p:nvCxnSpPr>
-        <p:spPr>
-          <a:xfrm xmlns:a="http://schemas.openxmlformats.org/drawingml/2006/main">
-            <a:off x="1600200" y="4762500"/>
-            <a:ext cx="1466850" cy="428625"/>
-          </a:xfrm>
-          <a:prstGeom xmlns:a="http://schemas.openxmlformats.org/drawingml/2006/main" prst="straightConnector1">
-            <a:avLst/>
-          </a:prstGeom>
-          <a:ln xmlns:a="http://schemas.openxmlformats.org/drawingml/2006/main" w="14288">
-            <a:solidFill>
-              <a:srgbClr val="DDE3E8"/>
-            </a:solidFill>
-            <a:prstDash val="solid"/>
-            <a:tailEnd type="none" w="med" len="med"/>
-          </a:ln>
-        </p:spPr>
-      </p:cxnSp>
-      <p:cxnSp>
-        <p:nvCxnSpPr>
-          <p:cNvPr id="36" name=""/>
-          <p:cNvCxnSpPr>
-            <a:stCxn xmlns:a="http://schemas.openxmlformats.org/drawingml/2006/main" id="4" idx="7"/>
-            <a:endCxn xmlns:a="http://schemas.openxmlformats.org/drawingml/2006/main" id="5" idx="3"/>
-          </p:cNvCxnSpPr>
-          <p:nvPr/>
-        </p:nvCxnSpPr>
-        <p:spPr>
-          <a:xfrm xmlns:a="http://schemas.openxmlformats.org/drawingml/2006/main" flipV="1">
-            <a:off x="10374557" y="3707057"/>
-            <a:ext cx="634510" cy="682135"/>
-          </a:xfrm>
-          <a:prstGeom xmlns:a="http://schemas.openxmlformats.org/drawingml/2006/main" prst="straightConnector1">
-            <a:avLst/>
-          </a:prstGeom>
-          <a:ln xmlns:a="http://schemas.openxmlformats.org/drawingml/2006/main" w="14288">
-            <a:solidFill>
-              <a:srgbClr val="DDE3E8"/>
-            </a:solidFill>
-            <a:prstDash val="solid"/>
-            <a:tailEnd type="none" w="med" len="med"/>
-          </a:ln>
-        </p:spPr>
-      </p:cxnSp>
-      <p:sp>
-        <p:nvSpPr>
-          <p:cNvPr id="9" name="">
-            <a:extLst xmlns:a="http://schemas.openxmlformats.org/drawingml/2006/main">
-              <a:ext uri="{FF2B5EF4-FFF2-40B4-BE49-F238E27FC236}">
-                <a16:creationId xmlns:a16="http://schemas.microsoft.com/office/drawing/2014/main" id="{AF7137EF-4718-46F3-9085-3D389915D5B6}"/>
+          <p:cNvPr id="25" name="">
+            <a:extLst xmlns:a="http://schemas.openxmlformats.org/drawingml/2006/main">
+              <a:ext uri="{FF2B5EF4-FFF2-40B4-BE49-F238E27FC236}">
+                <a16:creationId xmlns:a16="http://schemas.microsoft.com/office/drawing/2014/main" id="{CBF538E0-EC3B-46A1-B5BF-A306829CE0A9}"/>
               </a:ext>
             </a:extLst>
           </p:cNvPr>
@@ -1823,17 +1580,17 @@
                 <a:ea typeface="Arial"/>
                 <a:cs typeface="Arial"/>
               </a:rPr>
-              <a:t>Who did Viggo Mortensen play in The Lord of the Rings?</a:t>
+              <a:t>На кој континент се наоѓа Колосеумот?</a:t>
             </a:r>
           </a:p>
         </p:txBody>
       </p:sp>
       <p:sp>
         <p:nvSpPr>
-          <p:cNvPr id="10" name="">
-            <a:extLst xmlns:a="http://schemas.openxmlformats.org/drawingml/2006/main">
-              <a:ext uri="{FF2B5EF4-FFF2-40B4-BE49-F238E27FC236}">
-                <a16:creationId xmlns:a16="http://schemas.microsoft.com/office/drawing/2014/main" id="{8454BA7C-717C-4F52-A527-E141DBADFA8E}"/>
+          <p:cNvPr id="2" name="">
+            <a:extLst xmlns:a="http://schemas.openxmlformats.org/drawingml/2006/main">
+              <a:ext uri="{FF2B5EF4-FFF2-40B4-BE49-F238E27FC236}">
+                <a16:creationId xmlns:a16="http://schemas.microsoft.com/office/drawing/2014/main" id="{1975D2C9-CE20-4D77-B021-98EFA55FA2B6}"/>
               </a:ext>
             </a:extLst>
           </p:cNvPr>
@@ -1881,28 +1638,28 @@
                 <a:ea typeface="Arial"/>
                 <a:cs typeface="Arial"/>
               </a:rPr>
-              <a:t>Прашање од WebQSP</a:t>
+              <a:t>Прашање</a:t>
             </a:r>
           </a:p>
         </p:txBody>
       </p:sp>
       <p:sp>
         <p:nvSpPr>
-          <p:cNvPr id="11" name="">
-            <a:extLst xmlns:a="http://schemas.openxmlformats.org/drawingml/2006/main">
-              <a:ext uri="{FF2B5EF4-FFF2-40B4-BE49-F238E27FC236}">
-                <a16:creationId xmlns:a16="http://schemas.microsoft.com/office/drawing/2014/main" id="{A426ED05-DD19-47D9-BE4B-6BDA7ADA43E1}"/>
-              </a:ext>
-            </a:extLst>
-          </p:cNvPr>
-          <p:cNvSpPr>
-            <a:spLocks xmlns:a="http://schemas.openxmlformats.org/drawingml/2006/main" noGrp="1"/>
-          </p:cNvSpPr>
-          <p:nvPr/>
-        </p:nvSpPr>
-        <p:spPr>
-          <a:xfrm xmlns:a="http://schemas.openxmlformats.org/drawingml/2006/main">
-            <a:off x="2124075" y="2981325"/>
+          <p:cNvPr id="3" name="">
+            <a:extLst xmlns:a="http://schemas.openxmlformats.org/drawingml/2006/main">
+              <a:ext uri="{FF2B5EF4-FFF2-40B4-BE49-F238E27FC236}">
+                <a16:creationId xmlns:a16="http://schemas.microsoft.com/office/drawing/2014/main" id="{A80CBBD3-B4F2-4CF3-A941-1F28118AC0BE}"/>
+              </a:ext>
+            </a:extLst>
+          </p:cNvPr>
+          <p:cNvSpPr>
+            <a:spLocks xmlns:a="http://schemas.openxmlformats.org/drawingml/2006/main" noGrp="1"/>
+          </p:cNvSpPr>
+          <p:nvPr/>
+        </p:nvSpPr>
+        <p:spPr>
+          <a:xfrm xmlns:a="http://schemas.openxmlformats.org/drawingml/2006/main">
+            <a:off x="1219200" y="2933700"/>
             <a:ext cx="514350" cy="514350"/>
           </a:xfrm>
           <a:prstGeom xmlns:a="http://schemas.openxmlformats.org/drawingml/2006/main" prst="ellipse">
@@ -1921,22 +1678,22 @@
       </p:sp>
       <p:sp>
         <p:nvSpPr>
-          <p:cNvPr id="12" name="">
-            <a:extLst xmlns:a="http://schemas.openxmlformats.org/drawingml/2006/main">
-              <a:ext uri="{FF2B5EF4-FFF2-40B4-BE49-F238E27FC236}">
-                <a16:creationId xmlns:a16="http://schemas.microsoft.com/office/drawing/2014/main" id="{75CFBA0F-70CB-4841-B099-9A90D0AEEFC7}"/>
-              </a:ext>
-            </a:extLst>
-          </p:cNvPr>
-          <p:cNvSpPr>
-            <a:spLocks xmlns:a="http://schemas.openxmlformats.org/drawingml/2006/main" noGrp="1"/>
-          </p:cNvSpPr>
-          <p:nvPr/>
-        </p:nvSpPr>
-        <p:spPr>
-          <a:xfrm xmlns:a="http://schemas.openxmlformats.org/drawingml/2006/main">
-            <a:off x="1381125" y="3562350"/>
-            <a:ext cx="2000250" cy="342900"/>
+          <p:cNvPr id="4" name="">
+            <a:extLst xmlns:a="http://schemas.openxmlformats.org/drawingml/2006/main">
+              <a:ext uri="{FF2B5EF4-FFF2-40B4-BE49-F238E27FC236}">
+                <a16:creationId xmlns:a16="http://schemas.microsoft.com/office/drawing/2014/main" id="{5D21EA18-60AE-4D62-9547-3CEF810A4422}"/>
+              </a:ext>
+            </a:extLst>
+          </p:cNvPr>
+          <p:cNvSpPr>
+            <a:spLocks xmlns:a="http://schemas.openxmlformats.org/drawingml/2006/main" noGrp="1"/>
+          </p:cNvSpPr>
+          <p:nvPr/>
+        </p:nvSpPr>
+        <p:spPr>
+          <a:xfrm xmlns:a="http://schemas.openxmlformats.org/drawingml/2006/main">
+            <a:off x="666750" y="3514725"/>
+            <a:ext cx="1619250" cy="342900"/>
           </a:xfrm>
           <a:prstGeom xmlns:a="http://schemas.openxmlformats.org/drawingml/2006/main" prst="rect">
             <a:avLst/>
@@ -1972,28 +1729,28 @@
                 <a:ea typeface="Arial"/>
                 <a:cs typeface="Arial"/>
               </a:rPr>
-              <a:t>Viggo Mortensen</a:t>
+              <a:t>Колосеум</a:t>
             </a:r>
           </a:p>
         </p:txBody>
       </p:sp>
       <p:sp>
         <p:nvSpPr>
-          <p:cNvPr id="13" name="">
-            <a:extLst xmlns:a="http://schemas.openxmlformats.org/drawingml/2006/main">
-              <a:ext uri="{FF2B5EF4-FFF2-40B4-BE49-F238E27FC236}">
-                <a16:creationId xmlns:a16="http://schemas.microsoft.com/office/drawing/2014/main" id="{D816C812-FB1C-4B32-8CA7-EA420F4F4494}"/>
-              </a:ext>
-            </a:extLst>
-          </p:cNvPr>
-          <p:cNvSpPr>
-            <a:spLocks xmlns:a="http://schemas.openxmlformats.org/drawingml/2006/main" noGrp="1"/>
-          </p:cNvSpPr>
-          <p:nvPr/>
-        </p:nvSpPr>
-        <p:spPr>
-          <a:xfrm xmlns:a="http://schemas.openxmlformats.org/drawingml/2006/main">
-            <a:off x="5676900" y="3009900"/>
+          <p:cNvPr id="5" name="">
+            <a:extLst xmlns:a="http://schemas.openxmlformats.org/drawingml/2006/main">
+              <a:ext uri="{FF2B5EF4-FFF2-40B4-BE49-F238E27FC236}">
+                <a16:creationId xmlns:a16="http://schemas.microsoft.com/office/drawing/2014/main" id="{68814A2C-54A3-4763-85C1-C4A09AD3E61C}"/>
+              </a:ext>
+            </a:extLst>
+          </p:cNvPr>
+          <p:cNvSpPr>
+            <a:spLocks xmlns:a="http://schemas.openxmlformats.org/drawingml/2006/main" noGrp="1"/>
+          </p:cNvSpPr>
+          <p:nvPr/>
+        </p:nvSpPr>
+        <p:spPr>
+          <a:xfrm xmlns:a="http://schemas.openxmlformats.org/drawingml/2006/main">
+            <a:off x="3962400" y="2962275"/>
             <a:ext cx="457200" cy="457200"/>
           </a:xfrm>
           <a:prstGeom xmlns:a="http://schemas.openxmlformats.org/drawingml/2006/main" prst="ellipse">
@@ -2012,22 +1769,22 @@
       </p:sp>
       <p:sp>
         <p:nvSpPr>
-          <p:cNvPr id="14" name="">
-            <a:extLst xmlns:a="http://schemas.openxmlformats.org/drawingml/2006/main">
-              <a:ext uri="{FF2B5EF4-FFF2-40B4-BE49-F238E27FC236}">
-                <a16:creationId xmlns:a16="http://schemas.microsoft.com/office/drawing/2014/main" id="{FD3B8A88-A554-4609-9D0A-A1101DCE5604}"/>
-              </a:ext>
-            </a:extLst>
-          </p:cNvPr>
-          <p:cNvSpPr>
-            <a:spLocks xmlns:a="http://schemas.openxmlformats.org/drawingml/2006/main" noGrp="1"/>
-          </p:cNvSpPr>
-          <p:nvPr/>
-        </p:nvSpPr>
-        <p:spPr>
-          <a:xfrm xmlns:a="http://schemas.openxmlformats.org/drawingml/2006/main">
-            <a:off x="5048250" y="3533775"/>
-            <a:ext cx="1714500" cy="342900"/>
+          <p:cNvPr id="6" name="">
+            <a:extLst xmlns:a="http://schemas.openxmlformats.org/drawingml/2006/main">
+              <a:ext uri="{FF2B5EF4-FFF2-40B4-BE49-F238E27FC236}">
+                <a16:creationId xmlns:a16="http://schemas.microsoft.com/office/drawing/2014/main" id="{22271ED9-ADEA-443E-8F85-E0FF341EBE57}"/>
+              </a:ext>
+            </a:extLst>
+          </p:cNvPr>
+          <p:cNvSpPr>
+            <a:spLocks xmlns:a="http://schemas.openxmlformats.org/drawingml/2006/main" noGrp="1"/>
+          </p:cNvSpPr>
+          <p:nvPr/>
+        </p:nvSpPr>
+        <p:spPr>
+          <a:xfrm xmlns:a="http://schemas.openxmlformats.org/drawingml/2006/main">
+            <a:off x="3571875" y="3486150"/>
+            <a:ext cx="1238250" cy="342900"/>
           </a:xfrm>
           <a:prstGeom xmlns:a="http://schemas.openxmlformats.org/drawingml/2006/main" prst="rect">
             <a:avLst/>
@@ -2063,28 +1820,119 @@
                 <a:ea typeface="Arial"/>
                 <a:cs typeface="Arial"/>
               </a:rPr>
-              <a:t>настап / улога</a:t>
+              <a:t>Рим</a:t>
             </a:r>
           </a:p>
         </p:txBody>
       </p:sp>
       <p:sp>
         <p:nvSpPr>
-          <p:cNvPr id="15" name="">
-            <a:extLst xmlns:a="http://schemas.openxmlformats.org/drawingml/2006/main">
-              <a:ext uri="{FF2B5EF4-FFF2-40B4-BE49-F238E27FC236}">
-                <a16:creationId xmlns:a16="http://schemas.microsoft.com/office/drawing/2014/main" id="{62B1EAAA-B80D-4316-8D82-9DB290FCE740}"/>
-              </a:ext>
-            </a:extLst>
-          </p:cNvPr>
-          <p:cNvSpPr>
-            <a:spLocks xmlns:a="http://schemas.openxmlformats.org/drawingml/2006/main" noGrp="1"/>
-          </p:cNvSpPr>
-          <p:nvPr/>
-        </p:nvSpPr>
-        <p:spPr>
-          <a:xfrm xmlns:a="http://schemas.openxmlformats.org/drawingml/2006/main">
-            <a:off x="9267825" y="2981325"/>
+          <p:cNvPr id="7" name="">
+            <a:extLst xmlns:a="http://schemas.openxmlformats.org/drawingml/2006/main">
+              <a:ext uri="{FF2B5EF4-FFF2-40B4-BE49-F238E27FC236}">
+                <a16:creationId xmlns:a16="http://schemas.microsoft.com/office/drawing/2014/main" id="{985D2AA5-D51C-4ED1-A58B-3E606B4EE7B0}"/>
+              </a:ext>
+            </a:extLst>
+          </p:cNvPr>
+          <p:cNvSpPr>
+            <a:spLocks xmlns:a="http://schemas.openxmlformats.org/drawingml/2006/main" noGrp="1"/>
+          </p:cNvSpPr>
+          <p:nvPr/>
+        </p:nvSpPr>
+        <p:spPr>
+          <a:xfrm xmlns:a="http://schemas.openxmlformats.org/drawingml/2006/main">
+            <a:off x="6677025" y="2962275"/>
+            <a:ext cx="457200" cy="457200"/>
+          </a:xfrm>
+          <a:prstGeom xmlns:a="http://schemas.openxmlformats.org/drawingml/2006/main" prst="ellipse">
+            <a:avLst/>
+          </a:prstGeom>
+          <a:solidFill xmlns:a="http://schemas.openxmlformats.org/drawingml/2006/main">
+            <a:srgbClr val="FFFFFF"/>
+          </a:solidFill>
+          <a:ln xmlns:a="http://schemas.openxmlformats.org/drawingml/2006/main" w="23813">
+            <a:solidFill>
+              <a:srgbClr val="617080"/>
+            </a:solidFill>
+            <a:prstDash val="solid"/>
+          </a:ln>
+        </p:spPr>
+      </p:sp>
+      <p:sp>
+        <p:nvSpPr>
+          <p:cNvPr id="8" name="">
+            <a:extLst xmlns:a="http://schemas.openxmlformats.org/drawingml/2006/main">
+              <a:ext uri="{FF2B5EF4-FFF2-40B4-BE49-F238E27FC236}">
+                <a16:creationId xmlns:a16="http://schemas.microsoft.com/office/drawing/2014/main" id="{D1EB83C4-BC30-44B9-BC3D-98096CD8400A}"/>
+              </a:ext>
+            </a:extLst>
+          </p:cNvPr>
+          <p:cNvSpPr>
+            <a:spLocks xmlns:a="http://schemas.openxmlformats.org/drawingml/2006/main" noGrp="1"/>
+          </p:cNvSpPr>
+          <p:nvPr/>
+        </p:nvSpPr>
+        <p:spPr>
+          <a:xfrm xmlns:a="http://schemas.openxmlformats.org/drawingml/2006/main">
+            <a:off x="6191250" y="3486150"/>
+            <a:ext cx="1428750" cy="342900"/>
+          </a:xfrm>
+          <a:prstGeom xmlns:a="http://schemas.openxmlformats.org/drawingml/2006/main" prst="rect">
+            <a:avLst/>
+          </a:prstGeom>
+          <a:noFill xmlns:a="http://schemas.openxmlformats.org/drawingml/2006/main"/>
+          <a:ln xmlns:a="http://schemas.openxmlformats.org/drawingml/2006/main" w="0">
+            <a:noFill/>
+            <a:prstDash val="solid"/>
+          </a:ln>
+        </p:spPr>
+        <p:txBody>
+          <a:bodyPr xmlns:a="http://schemas.openxmlformats.org/drawingml/2006/main" wrap="square" lIns="38100" tIns="19050" rIns="38100" bIns="19050" anchor="ctr">
+            <a:normAutofit fontScale="100000"/>
+          </a:bodyPr>
+          <a:lstStyle xmlns:a="http://schemas.openxmlformats.org/drawingml/2006/main"/>
+          <a:p xmlns:a="http://schemas.openxmlformats.org/drawingml/2006/main">
+            <a:pPr algn="ctr">
+              <a:defRPr sz="1500" b="0">
+                <a:solidFill>
+                  <a:srgbClr val="263746"/>
+                </a:solidFill>
+                <a:latin typeface="Arial"/>
+                <a:ea typeface="Arial"/>
+                <a:cs typeface="Arial"/>
+              </a:defRPr>
+            </a:pPr>
+            <a:r>
+              <a:rPr sz="1500" b="0">
+                <a:solidFill>
+                  <a:srgbClr val="263746"/>
+                </a:solidFill>
+                <a:latin typeface="Arial"/>
+                <a:ea typeface="Arial"/>
+                <a:cs typeface="Arial"/>
+              </a:rPr>
+              <a:t>Италија</a:t>
+            </a:r>
+          </a:p>
+        </p:txBody>
+      </p:sp>
+      <p:sp>
+        <p:nvSpPr>
+          <p:cNvPr id="9" name="">
+            <a:extLst xmlns:a="http://schemas.openxmlformats.org/drawingml/2006/main">
+              <a:ext uri="{FF2B5EF4-FFF2-40B4-BE49-F238E27FC236}">
+                <a16:creationId xmlns:a16="http://schemas.microsoft.com/office/drawing/2014/main" id="{E27AD7CC-8932-4DD9-9254-1C1C932F9383}"/>
+              </a:ext>
+            </a:extLst>
+          </p:cNvPr>
+          <p:cNvSpPr>
+            <a:spLocks xmlns:a="http://schemas.openxmlformats.org/drawingml/2006/main" noGrp="1"/>
+          </p:cNvSpPr>
+          <p:nvPr/>
+        </p:nvSpPr>
+        <p:spPr>
+          <a:xfrm xmlns:a="http://schemas.openxmlformats.org/drawingml/2006/main">
+            <a:off x="9553575" y="2933700"/>
             <a:ext cx="514350" cy="514350"/>
           </a:xfrm>
           <a:prstGeom xmlns:a="http://schemas.openxmlformats.org/drawingml/2006/main" prst="ellipse">
@@ -2103,21 +1951,21 @@
       </p:sp>
       <p:sp>
         <p:nvSpPr>
-          <p:cNvPr id="16" name="">
-            <a:extLst xmlns:a="http://schemas.openxmlformats.org/drawingml/2006/main">
-              <a:ext uri="{FF2B5EF4-FFF2-40B4-BE49-F238E27FC236}">
-                <a16:creationId xmlns:a16="http://schemas.microsoft.com/office/drawing/2014/main" id="{79EA7464-DE90-4836-8684-43D1592D5814}"/>
-              </a:ext>
-            </a:extLst>
-          </p:cNvPr>
-          <p:cNvSpPr>
-            <a:spLocks xmlns:a="http://schemas.openxmlformats.org/drawingml/2006/main" noGrp="1"/>
-          </p:cNvSpPr>
-          <p:nvPr/>
-        </p:nvSpPr>
-        <p:spPr>
-          <a:xfrm xmlns:a="http://schemas.openxmlformats.org/drawingml/2006/main">
-            <a:off x="9182100" y="2895600"/>
+          <p:cNvPr id="10" name="">
+            <a:extLst xmlns:a="http://schemas.openxmlformats.org/drawingml/2006/main">
+              <a:ext uri="{FF2B5EF4-FFF2-40B4-BE49-F238E27FC236}">
+                <a16:creationId xmlns:a16="http://schemas.microsoft.com/office/drawing/2014/main" id="{E5BB8C29-6704-4659-BB8C-B0F3867947FC}"/>
+              </a:ext>
+            </a:extLst>
+          </p:cNvPr>
+          <p:cNvSpPr>
+            <a:spLocks xmlns:a="http://schemas.openxmlformats.org/drawingml/2006/main" noGrp="1"/>
+          </p:cNvSpPr>
+          <p:nvPr/>
+        </p:nvSpPr>
+        <p:spPr>
+          <a:xfrm xmlns:a="http://schemas.openxmlformats.org/drawingml/2006/main">
+            <a:off x="9467850" y="2847975"/>
             <a:ext cx="685800" cy="685800"/>
           </a:xfrm>
           <a:prstGeom xmlns:a="http://schemas.openxmlformats.org/drawingml/2006/main" prst="ellipse">
@@ -2134,21 +1982,21 @@
       </p:sp>
       <p:sp>
         <p:nvSpPr>
-          <p:cNvPr id="17" name="">
-            <a:extLst xmlns:a="http://schemas.openxmlformats.org/drawingml/2006/main">
-              <a:ext uri="{FF2B5EF4-FFF2-40B4-BE49-F238E27FC236}">
-                <a16:creationId xmlns:a16="http://schemas.microsoft.com/office/drawing/2014/main" id="{DF792A13-C279-4EBD-9BD8-99198EA7B551}"/>
-              </a:ext>
-            </a:extLst>
-          </p:cNvPr>
-          <p:cNvSpPr>
-            <a:spLocks xmlns:a="http://schemas.openxmlformats.org/drawingml/2006/main" noGrp="1"/>
-          </p:cNvSpPr>
-          <p:nvPr/>
-        </p:nvSpPr>
-        <p:spPr>
-          <a:xfrm xmlns:a="http://schemas.openxmlformats.org/drawingml/2006/main">
-            <a:off x="8858250" y="3562350"/>
+          <p:cNvPr id="11" name="">
+            <a:extLst xmlns:a="http://schemas.openxmlformats.org/drawingml/2006/main">
+              <a:ext uri="{FF2B5EF4-FFF2-40B4-BE49-F238E27FC236}">
+                <a16:creationId xmlns:a16="http://schemas.microsoft.com/office/drawing/2014/main" id="{AA8A98D0-4B22-4E83-A76A-D4ED4CF92DA6}"/>
+              </a:ext>
+            </a:extLst>
+          </p:cNvPr>
+          <p:cNvSpPr>
+            <a:spLocks xmlns:a="http://schemas.openxmlformats.org/drawingml/2006/main" noGrp="1"/>
+          </p:cNvSpPr>
+          <p:nvPr/>
+        </p:nvSpPr>
+        <p:spPr>
+          <a:xfrm xmlns:a="http://schemas.openxmlformats.org/drawingml/2006/main">
+            <a:off x="9144000" y="3514725"/>
             <a:ext cx="1333500" cy="342900"/>
           </a:xfrm>
           <a:prstGeom xmlns:a="http://schemas.openxmlformats.org/drawingml/2006/main" prst="rect">
@@ -2185,35 +2033,35 @@
                 <a:ea typeface="Arial"/>
                 <a:cs typeface="Arial"/>
               </a:rPr>
-              <a:t>Aragorn</a:t>
+              <a:t>Европа</a:t>
             </a:r>
           </a:p>
         </p:txBody>
       </p:sp>
       <p:sp>
         <p:nvSpPr>
-          <p:cNvPr id="18" name="">
-            <a:extLst xmlns:a="http://schemas.openxmlformats.org/drawingml/2006/main">
-              <a:ext uri="{FF2B5EF4-FFF2-40B4-BE49-F238E27FC236}">
-                <a16:creationId xmlns:a16="http://schemas.microsoft.com/office/drawing/2014/main" id="{B6E77EAC-9E81-48C5-854F-E6ABEFACAD74}"/>
-              </a:ext>
-            </a:extLst>
-          </p:cNvPr>
-          <p:cNvSpPr>
-            <a:spLocks xmlns:a="http://schemas.openxmlformats.org/drawingml/2006/main" noGrp="1"/>
-          </p:cNvSpPr>
-          <p:nvPr/>
-        </p:nvSpPr>
-        <p:spPr>
-          <a:xfrm xmlns:a="http://schemas.openxmlformats.org/drawingml/2006/main">
-            <a:off x="5695950" y="5219700"/>
+          <p:cNvPr id="12" name="">
+            <a:extLst xmlns:a="http://schemas.openxmlformats.org/drawingml/2006/main">
+              <a:ext uri="{FF2B5EF4-FFF2-40B4-BE49-F238E27FC236}">
+                <a16:creationId xmlns:a16="http://schemas.microsoft.com/office/drawing/2014/main" id="{9F73C66C-A8AB-49F0-AF8E-56A1FABB0B75}"/>
+              </a:ext>
+            </a:extLst>
+          </p:cNvPr>
+          <p:cNvSpPr>
+            <a:spLocks xmlns:a="http://schemas.openxmlformats.org/drawingml/2006/main" noGrp="1"/>
+          </p:cNvSpPr>
+          <p:nvPr/>
+        </p:nvSpPr>
+        <p:spPr>
+          <a:xfrm xmlns:a="http://schemas.openxmlformats.org/drawingml/2006/main">
+            <a:off x="6696075" y="4933950"/>
             <a:ext cx="419100" cy="419100"/>
           </a:xfrm>
           <a:prstGeom xmlns:a="http://schemas.openxmlformats.org/drawingml/2006/main" prst="ellipse">
             <a:avLst/>
           </a:prstGeom>
           <a:solidFill xmlns:a="http://schemas.openxmlformats.org/drawingml/2006/main">
-            <a:srgbClr val="F7F9FB"/>
+            <a:srgbClr val="FFFFFF"/>
           </a:solidFill>
           <a:ln xmlns:a="http://schemas.openxmlformats.org/drawingml/2006/main" w="23813">
             <a:solidFill>
@@ -2225,22 +2073,22 @@
       </p:sp>
       <p:sp>
         <p:nvSpPr>
-          <p:cNvPr id="19" name="">
-            <a:extLst xmlns:a="http://schemas.openxmlformats.org/drawingml/2006/main">
-              <a:ext uri="{FF2B5EF4-FFF2-40B4-BE49-F238E27FC236}">
-                <a16:creationId xmlns:a16="http://schemas.microsoft.com/office/drawing/2014/main" id="{DDA39622-C1D9-404A-9479-7B78AED75A0E}"/>
-              </a:ext>
-            </a:extLst>
-          </p:cNvPr>
-          <p:cNvSpPr>
-            <a:spLocks xmlns:a="http://schemas.openxmlformats.org/drawingml/2006/main" noGrp="1"/>
-          </p:cNvSpPr>
-          <p:nvPr/>
-        </p:nvSpPr>
-        <p:spPr>
-          <a:xfrm xmlns:a="http://schemas.openxmlformats.org/drawingml/2006/main">
-            <a:off x="4714875" y="5705475"/>
-            <a:ext cx="2381250" cy="342900"/>
+          <p:cNvPr id="13" name="">
+            <a:extLst xmlns:a="http://schemas.openxmlformats.org/drawingml/2006/main">
+              <a:ext uri="{FF2B5EF4-FFF2-40B4-BE49-F238E27FC236}">
+                <a16:creationId xmlns:a16="http://schemas.microsoft.com/office/drawing/2014/main" id="{709CEAC8-561B-4199-8F38-03185619F508}"/>
+              </a:ext>
+            </a:extLst>
+          </p:cNvPr>
+          <p:cNvSpPr>
+            <a:spLocks xmlns:a="http://schemas.openxmlformats.org/drawingml/2006/main" noGrp="1"/>
+          </p:cNvSpPr>
+          <p:nvPr/>
+        </p:nvSpPr>
+        <p:spPr>
+          <a:xfrm xmlns:a="http://schemas.openxmlformats.org/drawingml/2006/main">
+            <a:off x="5857875" y="5419725"/>
+            <a:ext cx="2095500" cy="342900"/>
           </a:xfrm>
           <a:prstGeom xmlns:a="http://schemas.openxmlformats.org/drawingml/2006/main" prst="rect">
             <a:avLst/>
@@ -2276,24 +2124,24 @@
                 <a:ea typeface="Arial"/>
                 <a:cs typeface="Arial"/>
               </a:rPr>
-              <a:t>The Lord of the Rings</a:t>
+              <a:t>Италијански јазик</a:t>
             </a:r>
           </a:p>
         </p:txBody>
       </p:sp>
       <p:cxnSp>
         <p:nvCxnSpPr>
-          <p:cNvPr id="48" name=""/>
+          <p:cNvPr id="38" name=""/>
           <p:cNvCxnSpPr>
-            <a:stCxn xmlns:a="http://schemas.openxmlformats.org/drawingml/2006/main" id="11" idx="6"/>
-            <a:endCxn xmlns:a="http://schemas.openxmlformats.org/drawingml/2006/main" id="13" idx="2"/>
+            <a:stCxn xmlns:a="http://schemas.openxmlformats.org/drawingml/2006/main" id="3" idx="6"/>
+            <a:endCxn xmlns:a="http://schemas.openxmlformats.org/drawingml/2006/main" id="5" idx="2"/>
           </p:cNvCxnSpPr>
           <p:nvPr/>
         </p:nvCxnSpPr>
         <p:spPr>
           <a:xfrm xmlns:a="http://schemas.openxmlformats.org/drawingml/2006/main">
-            <a:off x="2638425" y="3238500"/>
-            <a:ext cx="3038475" cy="0"/>
+            <a:off x="1733550" y="3190875"/>
+            <a:ext cx="2228850" cy="0"/>
           </a:xfrm>
           <a:prstGeom xmlns:a="http://schemas.openxmlformats.org/drawingml/2006/main" prst="straightConnector1">
             <a:avLst/>
@@ -2309,17 +2157,17 @@
       </p:cxnSp>
       <p:cxnSp>
         <p:nvCxnSpPr>
-          <p:cNvPr id="49" name=""/>
+          <p:cNvPr id="39" name=""/>
           <p:cNvCxnSpPr>
-            <a:stCxn xmlns:a="http://schemas.openxmlformats.org/drawingml/2006/main" id="13" idx="6"/>
-            <a:endCxn xmlns:a="http://schemas.openxmlformats.org/drawingml/2006/main" id="15" idx="2"/>
+            <a:stCxn xmlns:a="http://schemas.openxmlformats.org/drawingml/2006/main" id="5" idx="6"/>
+            <a:endCxn xmlns:a="http://schemas.openxmlformats.org/drawingml/2006/main" id="7" idx="2"/>
           </p:cNvCxnSpPr>
           <p:nvPr/>
         </p:nvCxnSpPr>
         <p:spPr>
           <a:xfrm xmlns:a="http://schemas.openxmlformats.org/drawingml/2006/main">
-            <a:off x="6134100" y="3238500"/>
-            <a:ext cx="3133725" cy="0"/>
+            <a:off x="4419600" y="3190875"/>
+            <a:ext cx="2257425" cy="0"/>
           </a:xfrm>
           <a:prstGeom xmlns:a="http://schemas.openxmlformats.org/drawingml/2006/main" prst="straightConnector1">
             <a:avLst/>
@@ -2335,21 +2183,47 @@
       </p:cxnSp>
       <p:cxnSp>
         <p:nvCxnSpPr>
-          <p:cNvPr id="50" name=""/>
+          <p:cNvPr id="40" name=""/>
           <p:cNvCxnSpPr>
-            <a:stCxn xmlns:a="http://schemas.openxmlformats.org/drawingml/2006/main" id="13" idx="4"/>
-            <a:endCxn xmlns:a="http://schemas.openxmlformats.org/drawingml/2006/main" id="18" idx="0"/>
+            <a:stCxn xmlns:a="http://schemas.openxmlformats.org/drawingml/2006/main" id="7" idx="6"/>
+            <a:endCxn xmlns:a="http://schemas.openxmlformats.org/drawingml/2006/main" id="9" idx="2"/>
           </p:cNvCxnSpPr>
           <p:nvPr/>
         </p:nvCxnSpPr>
         <p:spPr>
           <a:xfrm xmlns:a="http://schemas.openxmlformats.org/drawingml/2006/main">
-            <a:off x="5905500" y="3467100"/>
-            <a:ext cx="0" cy="1752600"/>
+            <a:off x="7134225" y="3190875"/>
+            <a:ext cx="2419350" cy="0"/>
           </a:xfrm>
           <a:prstGeom xmlns:a="http://schemas.openxmlformats.org/drawingml/2006/main" prst="straightConnector1">
             <a:avLst/>
           </a:prstGeom>
+          <a:ln xmlns:a="http://schemas.openxmlformats.org/drawingml/2006/main" w="28575">
+            <a:solidFill>
+              <a:srgbClr val="263746"/>
+            </a:solidFill>
+            <a:prstDash val="solid"/>
+            <a:tailEnd type="triangle" w="sm" len="sm"/>
+          </a:ln>
+        </p:spPr>
+      </p:cxnSp>
+      <p:cxnSp>
+        <p:nvCxnSpPr>
+          <p:cNvPr id="41" name=""/>
+          <p:cNvCxnSpPr>
+            <a:stCxn xmlns:a="http://schemas.openxmlformats.org/drawingml/2006/main" id="7" idx="4"/>
+            <a:endCxn xmlns:a="http://schemas.openxmlformats.org/drawingml/2006/main" id="12" idx="0"/>
+          </p:cNvCxnSpPr>
+          <p:nvPr/>
+        </p:nvCxnSpPr>
+        <p:spPr>
+          <a:xfrm xmlns:a="http://schemas.openxmlformats.org/drawingml/2006/main">
+            <a:off x="6905625" y="3419475"/>
+            <a:ext cx="0" cy="1514475"/>
+          </a:xfrm>
+          <a:prstGeom xmlns:a="http://schemas.openxmlformats.org/drawingml/2006/main" prst="straightConnector1">
+            <a:avLst/>
+          </a:prstGeom>
           <a:ln xmlns:a="http://schemas.openxmlformats.org/drawingml/2006/main" w="23813">
             <a:solidFill>
               <a:srgbClr val="398D84"/>
@@ -2361,22 +2235,208 @@
       </p:cxnSp>
       <p:sp>
         <p:nvSpPr>
-          <p:cNvPr id="23" name="">
-            <a:extLst xmlns:a="http://schemas.openxmlformats.org/drawingml/2006/main">
-              <a:ext uri="{FF2B5EF4-FFF2-40B4-BE49-F238E27FC236}">
-                <a16:creationId xmlns:a16="http://schemas.microsoft.com/office/drawing/2014/main" id="{9A9127A8-392F-4CC6-93AF-A5A96AB6EE6F}"/>
-              </a:ext>
-            </a:extLst>
-          </p:cNvPr>
-          <p:cNvSpPr>
-            <a:spLocks xmlns:a="http://schemas.openxmlformats.org/drawingml/2006/main" noGrp="1"/>
-          </p:cNvSpPr>
-          <p:nvPr/>
-        </p:nvSpPr>
-        <p:spPr>
-          <a:xfrm xmlns:a="http://schemas.openxmlformats.org/drawingml/2006/main">
-            <a:off x="3333750" y="2609850"/>
-            <a:ext cx="1714500" cy="266700"/>
+          <p:cNvPr id="18" name="">
+            <a:extLst xmlns:a="http://schemas.openxmlformats.org/drawingml/2006/main">
+              <a:ext uri="{FF2B5EF4-FFF2-40B4-BE49-F238E27FC236}">
+                <a16:creationId xmlns:a16="http://schemas.microsoft.com/office/drawing/2014/main" id="{E7C8EEE0-79CE-430C-ADE4-13051FEAE47D}"/>
+              </a:ext>
+            </a:extLst>
+          </p:cNvPr>
+          <p:cNvSpPr>
+            <a:spLocks xmlns:a="http://schemas.openxmlformats.org/drawingml/2006/main" noGrp="1"/>
+          </p:cNvSpPr>
+          <p:nvPr/>
+        </p:nvSpPr>
+        <p:spPr>
+          <a:xfrm xmlns:a="http://schemas.openxmlformats.org/drawingml/2006/main">
+            <a:off x="2119313" y="2771775"/>
+            <a:ext cx="1428750" cy="304800"/>
+          </a:xfrm>
+          <a:prstGeom xmlns:a="http://schemas.openxmlformats.org/drawingml/2006/main" prst="roundRect">
+            <a:avLst>
+              <a:gd name="adj" fmla="val 9375"/>
+            </a:avLst>
+          </a:prstGeom>
+          <a:solidFill xmlns:a="http://schemas.openxmlformats.org/drawingml/2006/main">
+            <a:srgbClr val="FFFFFF"/>
+          </a:solidFill>
+          <a:ln xmlns:a="http://schemas.openxmlformats.org/drawingml/2006/main" w="0">
+            <a:noFill/>
+            <a:prstDash val="solid"/>
+          </a:ln>
+        </p:spPr>
+        <p:txBody>
+          <a:bodyPr xmlns:a="http://schemas.openxmlformats.org/drawingml/2006/main" lIns="76200" tIns="47625" rIns="76200" bIns="47625" anchor="ctr">
+            <a:normAutofit fontScale="84344"/>
+          </a:bodyPr>
+          <a:lstStyle xmlns:a="http://schemas.openxmlformats.org/drawingml/2006/main"/>
+          <a:p xmlns:a="http://schemas.openxmlformats.org/drawingml/2006/main">
+            <a:pPr algn="ctr">
+              <a:defRPr sz="1500" b="1">
+                <a:solidFill>
+                  <a:srgbClr val="263746"/>
+                </a:solidFill>
+                <a:latin typeface="Arial"/>
+                <a:ea typeface="Arial"/>
+                <a:cs typeface="Arial"/>
+              </a:defRPr>
+            </a:pPr>
+            <a:r>
+              <a:rPr sz="1500" b="1">
+                <a:solidFill>
+                  <a:srgbClr val="263746"/>
+                </a:solidFill>
+                <a:latin typeface="Arial"/>
+                <a:ea typeface="Arial"/>
+                <a:cs typeface="Arial"/>
+              </a:rPr>
+              <a:t>се наоѓа во</a:t>
+            </a:r>
+          </a:p>
+        </p:txBody>
+      </p:sp>
+      <p:sp>
+        <p:nvSpPr>
+          <p:cNvPr id="19" name="">
+            <a:extLst xmlns:a="http://schemas.openxmlformats.org/drawingml/2006/main">
+              <a:ext uri="{FF2B5EF4-FFF2-40B4-BE49-F238E27FC236}">
+                <a16:creationId xmlns:a16="http://schemas.microsoft.com/office/drawing/2014/main" id="{F1E8D8BF-D475-4F9F-9907-13693AEB0EF2}"/>
+              </a:ext>
+            </a:extLst>
+          </p:cNvPr>
+          <p:cNvSpPr>
+            <a:spLocks xmlns:a="http://schemas.openxmlformats.org/drawingml/2006/main" noGrp="1"/>
+          </p:cNvSpPr>
+          <p:nvPr/>
+        </p:nvSpPr>
+        <p:spPr>
+          <a:xfrm xmlns:a="http://schemas.openxmlformats.org/drawingml/2006/main">
+            <a:off x="5048250" y="2771775"/>
+            <a:ext cx="1000125" cy="304800"/>
+          </a:xfrm>
+          <a:prstGeom xmlns:a="http://schemas.openxmlformats.org/drawingml/2006/main" prst="roundRect">
+            <a:avLst>
+              <a:gd name="adj" fmla="val 9375"/>
+            </a:avLst>
+          </a:prstGeom>
+          <a:solidFill xmlns:a="http://schemas.openxmlformats.org/drawingml/2006/main">
+            <a:srgbClr val="FFFFFF"/>
+          </a:solidFill>
+          <a:ln xmlns:a="http://schemas.openxmlformats.org/drawingml/2006/main" w="0">
+            <a:noFill/>
+            <a:prstDash val="solid"/>
+          </a:ln>
+        </p:spPr>
+        <p:txBody>
+          <a:bodyPr xmlns:a="http://schemas.openxmlformats.org/drawingml/2006/main" lIns="76200" tIns="47625" rIns="76200" bIns="47625" anchor="ctr">
+            <a:normAutofit fontScale="84344"/>
+          </a:bodyPr>
+          <a:lstStyle xmlns:a="http://schemas.openxmlformats.org/drawingml/2006/main"/>
+          <a:p xmlns:a="http://schemas.openxmlformats.org/drawingml/2006/main">
+            <a:pPr algn="ctr">
+              <a:defRPr sz="1500" b="1">
+                <a:solidFill>
+                  <a:srgbClr val="263746"/>
+                </a:solidFill>
+                <a:latin typeface="Arial"/>
+                <a:ea typeface="Arial"/>
+                <a:cs typeface="Arial"/>
+              </a:defRPr>
+            </a:pPr>
+            <a:r>
+              <a:rPr sz="1500" b="1">
+                <a:solidFill>
+                  <a:srgbClr val="263746"/>
+                </a:solidFill>
+                <a:latin typeface="Arial"/>
+                <a:ea typeface="Arial"/>
+                <a:cs typeface="Arial"/>
+              </a:rPr>
+              <a:t>дел од</a:t>
+            </a:r>
+          </a:p>
+        </p:txBody>
+      </p:sp>
+      <p:sp>
+        <p:nvSpPr>
+          <p:cNvPr id="20" name="">
+            <a:extLst xmlns:a="http://schemas.openxmlformats.org/drawingml/2006/main">
+              <a:ext uri="{FF2B5EF4-FFF2-40B4-BE49-F238E27FC236}">
+                <a16:creationId xmlns:a16="http://schemas.microsoft.com/office/drawing/2014/main" id="{27B9E3D6-C1E3-40F8-BE25-E935700717A9}"/>
+              </a:ext>
+            </a:extLst>
+          </p:cNvPr>
+          <p:cNvSpPr>
+            <a:spLocks xmlns:a="http://schemas.openxmlformats.org/drawingml/2006/main" noGrp="1"/>
+          </p:cNvSpPr>
+          <p:nvPr/>
+        </p:nvSpPr>
+        <p:spPr>
+          <a:xfrm xmlns:a="http://schemas.openxmlformats.org/drawingml/2006/main">
+            <a:off x="7762875" y="2771775"/>
+            <a:ext cx="1190625" cy="304800"/>
+          </a:xfrm>
+          <a:prstGeom xmlns:a="http://schemas.openxmlformats.org/drawingml/2006/main" prst="roundRect">
+            <a:avLst>
+              <a:gd name="adj" fmla="val 9375"/>
+            </a:avLst>
+          </a:prstGeom>
+          <a:solidFill xmlns:a="http://schemas.openxmlformats.org/drawingml/2006/main">
+            <a:srgbClr val="FFFFFF"/>
+          </a:solidFill>
+          <a:ln xmlns:a="http://schemas.openxmlformats.org/drawingml/2006/main" w="0">
+            <a:noFill/>
+            <a:prstDash val="solid"/>
+          </a:ln>
+        </p:spPr>
+        <p:txBody>
+          <a:bodyPr xmlns:a="http://schemas.openxmlformats.org/drawingml/2006/main" lIns="76200" tIns="47625" rIns="76200" bIns="47625" anchor="ctr">
+            <a:normAutofit fontScale="84344"/>
+          </a:bodyPr>
+          <a:lstStyle xmlns:a="http://schemas.openxmlformats.org/drawingml/2006/main"/>
+          <a:p xmlns:a="http://schemas.openxmlformats.org/drawingml/2006/main">
+            <a:pPr algn="ctr">
+              <a:defRPr sz="1500" b="1">
+                <a:solidFill>
+                  <a:srgbClr val="263746"/>
+                </a:solidFill>
+                <a:latin typeface="Arial"/>
+                <a:ea typeface="Arial"/>
+                <a:cs typeface="Arial"/>
+              </a:defRPr>
+            </a:pPr>
+            <a:r>
+              <a:rPr sz="1500" b="1">
+                <a:solidFill>
+                  <a:srgbClr val="263746"/>
+                </a:solidFill>
+                <a:latin typeface="Arial"/>
+                <a:ea typeface="Arial"/>
+                <a:cs typeface="Arial"/>
+              </a:rPr>
+              <a:t>континент</a:t>
+            </a:r>
+          </a:p>
+        </p:txBody>
+      </p:sp>
+      <p:sp>
+        <p:nvSpPr>
+          <p:cNvPr id="21" name="">
+            <a:extLst xmlns:a="http://schemas.openxmlformats.org/drawingml/2006/main">
+              <a:ext uri="{FF2B5EF4-FFF2-40B4-BE49-F238E27FC236}">
+                <a16:creationId xmlns:a16="http://schemas.microsoft.com/office/drawing/2014/main" id="{F864C10B-C6B8-4F60-ACC2-19F0ACB8D69D}"/>
+              </a:ext>
+            </a:extLst>
+          </p:cNvPr>
+          <p:cNvSpPr>
+            <a:spLocks xmlns:a="http://schemas.openxmlformats.org/drawingml/2006/main" noGrp="1"/>
+          </p:cNvSpPr>
+          <p:nvPr/>
+        </p:nvSpPr>
+        <p:spPr>
+          <a:xfrm xmlns:a="http://schemas.openxmlformats.org/drawingml/2006/main">
+            <a:off x="7143750" y="4000500"/>
+            <a:ext cx="1762125" cy="266700"/>
           </a:xfrm>
           <a:prstGeom xmlns:a="http://schemas.openxmlformats.org/drawingml/2006/main" prst="rect">
             <a:avLst/>
@@ -2394,9 +2454,9 @@
           <a:lstStyle xmlns:a="http://schemas.openxmlformats.org/drawingml/2006/main"/>
           <a:p xmlns:a="http://schemas.openxmlformats.org/drawingml/2006/main">
             <a:pPr algn="ctr">
-              <a:defRPr sz="1350" b="0">
-                <a:solidFill>
-                  <a:srgbClr val="263746"/>
+              <a:defRPr sz="1425" b="1">
+                <a:solidFill>
+                  <a:srgbClr val="398D84"/>
                 </a:solidFill>
                 <a:latin typeface="Arial"/>
                 <a:ea typeface="Arial"/>
@@ -2404,152 +2464,36 @@
               </a:defRPr>
             </a:pPr>
             <a:r>
-              <a:rPr sz="1350" b="0">
-                <a:solidFill>
-                  <a:srgbClr val="263746"/>
+              <a:rPr sz="1425" b="1">
+                <a:solidFill>
+                  <a:srgbClr val="398D84"/>
                 </a:solidFill>
                 <a:latin typeface="Arial"/>
                 <a:ea typeface="Arial"/>
                 <a:cs typeface="Arial"/>
               </a:rPr>
-              <a:t>film.actor.film</a:t>
+              <a:t>службен јазик</a:t>
             </a:r>
           </a:p>
         </p:txBody>
       </p:sp>
       <p:sp>
         <p:nvSpPr>
-          <p:cNvPr id="24" name="">
-            <a:extLst xmlns:a="http://schemas.openxmlformats.org/drawingml/2006/main">
-              <a:ext uri="{FF2B5EF4-FFF2-40B4-BE49-F238E27FC236}">
-                <a16:creationId xmlns:a16="http://schemas.microsoft.com/office/drawing/2014/main" id="{3B97A693-6159-40FB-B784-13484CE0AE92}"/>
-              </a:ext>
-            </a:extLst>
-          </p:cNvPr>
-          <p:cNvSpPr>
-            <a:spLocks xmlns:a="http://schemas.openxmlformats.org/drawingml/2006/main" noGrp="1"/>
-          </p:cNvSpPr>
-          <p:nvPr/>
-        </p:nvSpPr>
-        <p:spPr>
-          <a:xfrm xmlns:a="http://schemas.openxmlformats.org/drawingml/2006/main">
-            <a:off x="6819900" y="2609850"/>
-            <a:ext cx="2524125" cy="266700"/>
-          </a:xfrm>
-          <a:prstGeom xmlns:a="http://schemas.openxmlformats.org/drawingml/2006/main" prst="rect">
-            <a:avLst/>
-          </a:prstGeom>
-          <a:noFill xmlns:a="http://schemas.openxmlformats.org/drawingml/2006/main"/>
-          <a:ln xmlns:a="http://schemas.openxmlformats.org/drawingml/2006/main" w="0">
-            <a:noFill/>
-            <a:prstDash val="solid"/>
-          </a:ln>
-        </p:spPr>
-        <p:txBody>
-          <a:bodyPr xmlns:a="http://schemas.openxmlformats.org/drawingml/2006/main" wrap="square" lIns="38100" tIns="19050" rIns="38100" bIns="19050" anchor="ctr">
-            <a:normAutofit fontScale="100000"/>
-          </a:bodyPr>
-          <a:lstStyle xmlns:a="http://schemas.openxmlformats.org/drawingml/2006/main"/>
-          <a:p xmlns:a="http://schemas.openxmlformats.org/drawingml/2006/main">
-            <a:pPr algn="ctr">
-              <a:defRPr sz="1350" b="0">
-                <a:solidFill>
-                  <a:srgbClr val="263746"/>
-                </a:solidFill>
-                <a:latin typeface="Arial"/>
-                <a:ea typeface="Arial"/>
-                <a:cs typeface="Arial"/>
-              </a:defRPr>
-            </a:pPr>
-            <a:r>
-              <a:rPr sz="1350" b="0">
-                <a:solidFill>
-                  <a:srgbClr val="263746"/>
-                </a:solidFill>
-                <a:latin typeface="Arial"/>
-                <a:ea typeface="Arial"/>
-                <a:cs typeface="Arial"/>
-              </a:rPr>
-              <a:t>film.performance.character</a:t>
-            </a:r>
-          </a:p>
-        </p:txBody>
-      </p:sp>
-      <p:sp>
-        <p:nvSpPr>
-          <p:cNvPr id="25" name="">
-            <a:extLst xmlns:a="http://schemas.openxmlformats.org/drawingml/2006/main">
-              <a:ext uri="{FF2B5EF4-FFF2-40B4-BE49-F238E27FC236}">
-                <a16:creationId xmlns:a16="http://schemas.microsoft.com/office/drawing/2014/main" id="{348C26BD-0A8E-4945-B844-E46995028FA3}"/>
-              </a:ext>
-            </a:extLst>
-          </p:cNvPr>
-          <p:cNvSpPr>
-            <a:spLocks xmlns:a="http://schemas.openxmlformats.org/drawingml/2006/main" noGrp="1"/>
-          </p:cNvSpPr>
-          <p:nvPr/>
-        </p:nvSpPr>
-        <p:spPr>
-          <a:xfrm xmlns:a="http://schemas.openxmlformats.org/drawingml/2006/main">
-            <a:off x="6143625" y="4333875"/>
-            <a:ext cx="2190750" cy="266700"/>
-          </a:xfrm>
-          <a:prstGeom xmlns:a="http://schemas.openxmlformats.org/drawingml/2006/main" prst="rect">
-            <a:avLst/>
-          </a:prstGeom>
-          <a:noFill xmlns:a="http://schemas.openxmlformats.org/drawingml/2006/main"/>
-          <a:ln xmlns:a="http://schemas.openxmlformats.org/drawingml/2006/main" w="0">
-            <a:noFill/>
-            <a:prstDash val="solid"/>
-          </a:ln>
-        </p:spPr>
-        <p:txBody>
-          <a:bodyPr xmlns:a="http://schemas.openxmlformats.org/drawingml/2006/main" wrap="square" lIns="38100" tIns="19050" rIns="38100" bIns="19050" anchor="ctr">
-            <a:normAutofit fontScale="100000"/>
-          </a:bodyPr>
-          <a:lstStyle xmlns:a="http://schemas.openxmlformats.org/drawingml/2006/main"/>
-          <a:p xmlns:a="http://schemas.openxmlformats.org/drawingml/2006/main">
-            <a:pPr algn="ctr">
-              <a:defRPr sz="1275" b="0">
-                <a:solidFill>
-                  <a:srgbClr val="398D84"/>
-                </a:solidFill>
-                <a:latin typeface="Arial"/>
-                <a:ea typeface="Arial"/>
-                <a:cs typeface="Arial"/>
-              </a:defRPr>
-            </a:pPr>
-            <a:r>
-              <a:rPr sz="1275" b="0">
-                <a:solidFill>
-                  <a:srgbClr val="398D84"/>
-                </a:solidFill>
-                <a:latin typeface="Arial"/>
-                <a:ea typeface="Arial"/>
-                <a:cs typeface="Arial"/>
-              </a:rPr>
-              <a:t>film.performance.film</a:t>
-            </a:r>
-          </a:p>
-        </p:txBody>
-      </p:sp>
-      <p:sp>
-        <p:nvSpPr>
-          <p:cNvPr id="26" name="">
-            <a:extLst xmlns:a="http://schemas.openxmlformats.org/drawingml/2006/main">
-              <a:ext uri="{FF2B5EF4-FFF2-40B4-BE49-F238E27FC236}">
-                <a16:creationId xmlns:a16="http://schemas.microsoft.com/office/drawing/2014/main" id="{0211E56F-B8BC-4E80-AEFB-91EF75E8374B}"/>
-              </a:ext>
-            </a:extLst>
-          </p:cNvPr>
-          <p:cNvSpPr>
-            <a:spLocks xmlns:a="http://schemas.openxmlformats.org/drawingml/2006/main" noGrp="1"/>
-          </p:cNvSpPr>
-          <p:nvPr/>
-        </p:nvSpPr>
-        <p:spPr>
-          <a:xfrm xmlns:a="http://schemas.openxmlformats.org/drawingml/2006/main">
-            <a:off x="1476375" y="3952875"/>
+          <p:cNvPr id="22" name="">
+            <a:extLst xmlns:a="http://schemas.openxmlformats.org/drawingml/2006/main">
+              <a:ext uri="{FF2B5EF4-FFF2-40B4-BE49-F238E27FC236}">
+                <a16:creationId xmlns:a16="http://schemas.microsoft.com/office/drawing/2014/main" id="{44DC6D5C-ACBD-44A5-A901-11F7ED4CBBC5}"/>
+              </a:ext>
+            </a:extLst>
+          </p:cNvPr>
+          <p:cNvSpPr>
+            <a:spLocks xmlns:a="http://schemas.openxmlformats.org/drawingml/2006/main" noGrp="1"/>
+          </p:cNvSpPr>
+          <p:nvPr/>
+        </p:nvSpPr>
+        <p:spPr>
+          <a:xfrm xmlns:a="http://schemas.openxmlformats.org/drawingml/2006/main">
+            <a:off x="571500" y="3952875"/>
             <a:ext cx="1809750" cy="285750"/>
           </a:xfrm>
           <a:prstGeom xmlns:a="http://schemas.openxmlformats.org/drawingml/2006/main" prst="rect">
@@ -2593,21 +2537,21 @@
       </p:sp>
       <p:sp>
         <p:nvSpPr>
-          <p:cNvPr id="27" name="">
-            <a:extLst xmlns:a="http://schemas.openxmlformats.org/drawingml/2006/main">
-              <a:ext uri="{FF2B5EF4-FFF2-40B4-BE49-F238E27FC236}">
-                <a16:creationId xmlns:a16="http://schemas.microsoft.com/office/drawing/2014/main" id="{EA989CF0-9F00-4957-AD7D-1A9FF7B9B5C4}"/>
-              </a:ext>
-            </a:extLst>
-          </p:cNvPr>
-          <p:cNvSpPr>
-            <a:spLocks xmlns:a="http://schemas.openxmlformats.org/drawingml/2006/main" noGrp="1"/>
-          </p:cNvSpPr>
-          <p:nvPr/>
-        </p:nvSpPr>
-        <p:spPr>
-          <a:xfrm xmlns:a="http://schemas.openxmlformats.org/drawingml/2006/main">
-            <a:off x="8667750" y="3952875"/>
+          <p:cNvPr id="23" name="">
+            <a:extLst xmlns:a="http://schemas.openxmlformats.org/drawingml/2006/main">
+              <a:ext uri="{FF2B5EF4-FFF2-40B4-BE49-F238E27FC236}">
+                <a16:creationId xmlns:a16="http://schemas.microsoft.com/office/drawing/2014/main" id="{1AD47D10-76B5-485D-92A4-4F2235BB4DD0}"/>
+              </a:ext>
+            </a:extLst>
+          </p:cNvPr>
+          <p:cNvSpPr>
+            <a:spLocks xmlns:a="http://schemas.openxmlformats.org/drawingml/2006/main" noGrp="1"/>
+          </p:cNvSpPr>
+          <p:nvPr/>
+        </p:nvSpPr>
+        <p:spPr>
+          <a:xfrm xmlns:a="http://schemas.openxmlformats.org/drawingml/2006/main">
+            <a:off x="8953500" y="3952875"/>
             <a:ext cx="1714500" cy="285750"/>
           </a:xfrm>
           <a:prstGeom xmlns:a="http://schemas.openxmlformats.org/drawingml/2006/main" prst="rect">
@@ -2651,22 +2595,22 @@
       </p:sp>
       <p:sp>
         <p:nvSpPr>
-          <p:cNvPr id="28" name="">
-            <a:extLst xmlns:a="http://schemas.openxmlformats.org/drawingml/2006/main">
-              <a:ext uri="{FF2B5EF4-FFF2-40B4-BE49-F238E27FC236}">
-                <a16:creationId xmlns:a16="http://schemas.microsoft.com/office/drawing/2014/main" id="{BBA9D2BD-D71C-4D2C-8EC7-36012125B261}"/>
-              </a:ext>
-            </a:extLst>
-          </p:cNvPr>
-          <p:cNvSpPr>
-            <a:spLocks xmlns:a="http://schemas.openxmlformats.org/drawingml/2006/main" noGrp="1"/>
-          </p:cNvSpPr>
-          <p:nvPr/>
-        </p:nvSpPr>
-        <p:spPr>
-          <a:xfrm xmlns:a="http://schemas.openxmlformats.org/drawingml/2006/main">
-            <a:off x="4238625" y="6238875"/>
-            <a:ext cx="3333750" cy="323850"/>
+          <p:cNvPr id="24" name="">
+            <a:extLst xmlns:a="http://schemas.openxmlformats.org/drawingml/2006/main">
+              <a:ext uri="{FF2B5EF4-FFF2-40B4-BE49-F238E27FC236}">
+                <a16:creationId xmlns:a16="http://schemas.microsoft.com/office/drawing/2014/main" id="{DEC85F4D-CDF6-4A10-9FF2-21FD48336057}"/>
+              </a:ext>
+            </a:extLst>
+          </p:cNvPr>
+          <p:cNvSpPr>
+            <a:spLocks xmlns:a="http://schemas.openxmlformats.org/drawingml/2006/main" noGrp="1"/>
+          </p:cNvSpPr>
+          <p:nvPr/>
+        </p:nvSpPr>
+        <p:spPr>
+          <a:xfrm xmlns:a="http://schemas.openxmlformats.org/drawingml/2006/main">
+            <a:off x="3190875" y="6191250"/>
+            <a:ext cx="5810250" cy="323850"/>
           </a:xfrm>
           <a:prstGeom xmlns:a="http://schemas.openxmlformats.org/drawingml/2006/main" prst="rect">
             <a:avLst/>
@@ -2679,12 +2623,12 @@
         </p:spPr>
         <p:txBody>
           <a:bodyPr xmlns:a="http://schemas.openxmlformats.org/drawingml/2006/main" wrap="square" lIns="38100" tIns="19050" rIns="38100" bIns="19050" anchor="ctr">
-            <a:normAutofit fontScale="100000"/>
+            <a:normAutofit fontScale="94907"/>
           </a:bodyPr>
           <a:lstStyle xmlns:a="http://schemas.openxmlformats.org/drawingml/2006/main"/>
           <a:p xmlns:a="http://schemas.openxmlformats.org/drawingml/2006/main">
             <a:pPr algn="ctr">
-              <a:defRPr sz="1575" b="1">
+              <a:defRPr sz="1500" b="1">
                 <a:solidFill>
                   <a:srgbClr val="263746"/>
                 </a:solidFill>
@@ -2694,7 +2638,7 @@
               </a:defRPr>
             </a:pPr>
             <a:r>
-              <a:rPr sz="1575" b="1">
+              <a:rPr sz="1500" b="1">
                 <a:solidFill>
                   <a:srgbClr val="263746"/>
                 </a:solidFill>
@@ -2702,7 +2646,7 @@
                 <a:ea typeface="Arial"/>
                 <a:cs typeface="Arial"/>
               </a:rPr>
-              <a:t>две последователни релации</a:t>
+              <a:t>Два посредни ентитети го поврзуваат прашањето со одговорот</a:t>
             </a:r>
           </a:p>
         </p:txBody>
@@ -2710,7 +2654,7 @@
     </p:spTree>
     <p:extLst>
       <p:ext uri="{BB962C8B-B14F-4D97-AF65-F5344CB8AC3E}">
-        <p14:creationId xmlns:p14="http://schemas.microsoft.com/office/powerpoint/2010/main" val="743495473"/>
+        <p14:creationId xmlns:p14="http://schemas.microsoft.com/office/powerpoint/2010/main" val="1688205310"/>
       </p:ext>
     </p:extLst>
   </p:cSld>
@@ -2741,7 +2685,7 @@
           <p:cNvPr id="42" name="">
             <a:extLst xmlns:a="http://schemas.openxmlformats.org/drawingml/2006/main">
               <a:ext uri="{FF2B5EF4-FFF2-40B4-BE49-F238E27FC236}">
-                <a16:creationId xmlns:a16="http://schemas.microsoft.com/office/drawing/2014/main" id="{2DDABA41-05CE-42EE-AAD5-7829C388F73E}"/>
+                <a16:creationId xmlns:a16="http://schemas.microsoft.com/office/drawing/2014/main" id="{26FBDD7F-FDD9-4CF2-B292-762DFD31DE51}"/>
               </a:ext>
             </a:extLst>
           </p:cNvPr>
@@ -2774,7 +2718,7 @@
           <p:cNvPr id="2" name="">
             <a:extLst xmlns:a="http://schemas.openxmlformats.org/drawingml/2006/main">
               <a:ext uri="{FF2B5EF4-FFF2-40B4-BE49-F238E27FC236}">
-                <a16:creationId xmlns:a16="http://schemas.microsoft.com/office/drawing/2014/main" id="{AC476AC3-F430-4773-BB2D-A1751EA67BF3}"/>
+                <a16:creationId xmlns:a16="http://schemas.microsoft.com/office/drawing/2014/main" id="{FD88E435-C345-489F-8CC2-4DF4E4BA784A}"/>
               </a:ext>
             </a:extLst>
           </p:cNvPr>
@@ -2807,7 +2751,7 @@
           <p:cNvPr id="3" name="">
             <a:extLst xmlns:a="http://schemas.openxmlformats.org/drawingml/2006/main">
               <a:ext uri="{FF2B5EF4-FFF2-40B4-BE49-F238E27FC236}">
-                <a16:creationId xmlns:a16="http://schemas.microsoft.com/office/drawing/2014/main" id="{8D418523-2CDA-4F02-9D02-9518207E7A29}"/>
+                <a16:creationId xmlns:a16="http://schemas.microsoft.com/office/drawing/2014/main" id="{4F1D8FF3-3775-4BFE-8535-B79E2BFB5B7C}"/>
               </a:ext>
             </a:extLst>
           </p:cNvPr>
@@ -2840,7 +2784,7 @@
           <p:cNvPr id="4" name="">
             <a:extLst xmlns:a="http://schemas.openxmlformats.org/drawingml/2006/main">
               <a:ext uri="{FF2B5EF4-FFF2-40B4-BE49-F238E27FC236}">
-                <a16:creationId xmlns:a16="http://schemas.microsoft.com/office/drawing/2014/main" id="{9E217D3F-0426-42A4-8CE5-FC6BF867DDAA}"/>
+                <a16:creationId xmlns:a16="http://schemas.microsoft.com/office/drawing/2014/main" id="{A1AAE07B-B35D-4DBC-A82F-5C53097032A5}"/>
               </a:ext>
             </a:extLst>
           </p:cNvPr>
@@ -2951,7 +2895,7 @@
           <p:cNvPr id="8" name="">
             <a:extLst xmlns:a="http://schemas.openxmlformats.org/drawingml/2006/main">
               <a:ext uri="{FF2B5EF4-FFF2-40B4-BE49-F238E27FC236}">
-                <a16:creationId xmlns:a16="http://schemas.microsoft.com/office/drawing/2014/main" id="{9E5110BF-92C1-4B31-BB64-B2ED0F8DCACE}"/>
+                <a16:creationId xmlns:a16="http://schemas.microsoft.com/office/drawing/2014/main" id="{BDBD4C41-4E6D-4546-913C-0E0A47EC4BF0}"/>
               </a:ext>
             </a:extLst>
           </p:cNvPr>
@@ -2984,7 +2928,7 @@
           <p:cNvPr id="9" name="">
             <a:extLst xmlns:a="http://schemas.openxmlformats.org/drawingml/2006/main">
               <a:ext uri="{FF2B5EF4-FFF2-40B4-BE49-F238E27FC236}">
-                <a16:creationId xmlns:a16="http://schemas.microsoft.com/office/drawing/2014/main" id="{26FDC8B1-AD28-4D0B-BA92-028CF49D79A7}"/>
+                <a16:creationId xmlns:a16="http://schemas.microsoft.com/office/drawing/2014/main" id="{6ECB205F-B3DA-4DED-9E40-CDBA3C91505B}"/>
               </a:ext>
             </a:extLst>
           </p:cNvPr>
@@ -3017,7 +2961,7 @@
           <p:cNvPr id="10" name="">
             <a:extLst xmlns:a="http://schemas.openxmlformats.org/drawingml/2006/main">
               <a:ext uri="{FF2B5EF4-FFF2-40B4-BE49-F238E27FC236}">
-                <a16:creationId xmlns:a16="http://schemas.microsoft.com/office/drawing/2014/main" id="{7AA3F276-E586-473B-BE1E-E98B284059E9}"/>
+                <a16:creationId xmlns:a16="http://schemas.microsoft.com/office/drawing/2014/main" id="{B752780A-6C4B-4386-96F8-7664CAECA390}"/>
               </a:ext>
             </a:extLst>
           </p:cNvPr>
@@ -3050,7 +2994,7 @@
           <p:cNvPr id="11" name="">
             <a:extLst xmlns:a="http://schemas.openxmlformats.org/drawingml/2006/main">
               <a:ext uri="{FF2B5EF4-FFF2-40B4-BE49-F238E27FC236}">
-                <a16:creationId xmlns:a16="http://schemas.microsoft.com/office/drawing/2014/main" id="{A0F88ABF-2D14-4F76-B2A1-FBCD3B8A2FFC}"/>
+                <a16:creationId xmlns:a16="http://schemas.microsoft.com/office/drawing/2014/main" id="{F7CA803F-DF4D-4377-B546-EB5D92BAF556}"/>
               </a:ext>
             </a:extLst>
           </p:cNvPr>
@@ -3161,7 +3105,7 @@
           <p:cNvPr id="15" name="">
             <a:extLst xmlns:a="http://schemas.openxmlformats.org/drawingml/2006/main">
               <a:ext uri="{FF2B5EF4-FFF2-40B4-BE49-F238E27FC236}">
-                <a16:creationId xmlns:a16="http://schemas.microsoft.com/office/drawing/2014/main" id="{2D4B92E1-7238-4AC3-A107-036703A3E2BB}"/>
+                <a16:creationId xmlns:a16="http://schemas.microsoft.com/office/drawing/2014/main" id="{EA0D0108-090F-4C04-9FAD-F00BEE4504E7}"/>
               </a:ext>
             </a:extLst>
           </p:cNvPr>
@@ -3194,7 +3138,7 @@
           <p:cNvPr id="16" name="">
             <a:extLst xmlns:a="http://schemas.openxmlformats.org/drawingml/2006/main">
               <a:ext uri="{FF2B5EF4-FFF2-40B4-BE49-F238E27FC236}">
-                <a16:creationId xmlns:a16="http://schemas.microsoft.com/office/drawing/2014/main" id="{552B3213-747C-43C8-8CE9-6B6D83056FA9}"/>
+                <a16:creationId xmlns:a16="http://schemas.microsoft.com/office/drawing/2014/main" id="{2C05C7B5-2889-4D57-B08A-293CBFC4D12F}"/>
               </a:ext>
             </a:extLst>
           </p:cNvPr>
@@ -3253,7 +3197,7 @@
           <p:cNvPr id="18" name="">
             <a:extLst xmlns:a="http://schemas.openxmlformats.org/drawingml/2006/main">
               <a:ext uri="{FF2B5EF4-FFF2-40B4-BE49-F238E27FC236}">
-                <a16:creationId xmlns:a16="http://schemas.microsoft.com/office/drawing/2014/main" id="{1D613D49-0DAE-48FE-8887-45850233F5DB}"/>
+                <a16:creationId xmlns:a16="http://schemas.microsoft.com/office/drawing/2014/main" id="{7074A580-3D62-4400-959F-AE394DCD8F53}"/>
               </a:ext>
             </a:extLst>
           </p:cNvPr>
@@ -3312,7 +3256,7 @@
           <p:cNvPr id="20" name="">
             <a:extLst xmlns:a="http://schemas.openxmlformats.org/drawingml/2006/main">
               <a:ext uri="{FF2B5EF4-FFF2-40B4-BE49-F238E27FC236}">
-                <a16:creationId xmlns:a16="http://schemas.microsoft.com/office/drawing/2014/main" id="{2A5BCB1D-70C1-4D82-BC38-667BC9069FE5}"/>
+                <a16:creationId xmlns:a16="http://schemas.microsoft.com/office/drawing/2014/main" id="{46106A68-CA02-4FAA-8284-2B55D0531B19}"/>
               </a:ext>
             </a:extLst>
           </p:cNvPr>
@@ -3371,7 +3315,7 @@
           <p:cNvPr id="22" name="">
             <a:extLst xmlns:a="http://schemas.openxmlformats.org/drawingml/2006/main">
               <a:ext uri="{FF2B5EF4-FFF2-40B4-BE49-F238E27FC236}">
-                <a16:creationId xmlns:a16="http://schemas.microsoft.com/office/drawing/2014/main" id="{6013204C-0EB3-4F3C-B466-CC3DE1932D98}"/>
+                <a16:creationId xmlns:a16="http://schemas.microsoft.com/office/drawing/2014/main" id="{3AE72CFA-7195-4DB0-9CEF-C55B5BAD87EB}"/>
               </a:ext>
             </a:extLst>
           </p:cNvPr>
@@ -3435,7 +3379,7 @@
           <p:cNvPr id="23" name="">
             <a:extLst xmlns:a="http://schemas.openxmlformats.org/drawingml/2006/main">
               <a:ext uri="{FF2B5EF4-FFF2-40B4-BE49-F238E27FC236}">
-                <a16:creationId xmlns:a16="http://schemas.microsoft.com/office/drawing/2014/main" id="{3DCF2D5B-4E40-407B-99D1-8B6AAD3CE61F}"/>
+                <a16:creationId xmlns:a16="http://schemas.microsoft.com/office/drawing/2014/main" id="{0B86354F-3C5F-4FA8-8605-C5B14AFA52FC}"/>
               </a:ext>
             </a:extLst>
           </p:cNvPr>
@@ -3551,7 +3495,7 @@
           <p:cNvPr id="26" name="">
             <a:extLst xmlns:a="http://schemas.openxmlformats.org/drawingml/2006/main">
               <a:ext uri="{FF2B5EF4-FFF2-40B4-BE49-F238E27FC236}">
-                <a16:creationId xmlns:a16="http://schemas.microsoft.com/office/drawing/2014/main" id="{17DE9755-AEAF-4C95-8301-A57D12830627}"/>
+                <a16:creationId xmlns:a16="http://schemas.microsoft.com/office/drawing/2014/main" id="{8109C64E-AEFB-4B3C-8F23-479CD5A3E8D4}"/>
               </a:ext>
             </a:extLst>
           </p:cNvPr>
@@ -3584,7 +3528,7 @@
           <p:cNvPr id="27" name="">
             <a:extLst xmlns:a="http://schemas.openxmlformats.org/drawingml/2006/main">
               <a:ext uri="{FF2B5EF4-FFF2-40B4-BE49-F238E27FC236}">
-                <a16:creationId xmlns:a16="http://schemas.microsoft.com/office/drawing/2014/main" id="{A0982E78-970A-4419-872A-2E0C5DF2F8C4}"/>
+                <a16:creationId xmlns:a16="http://schemas.microsoft.com/office/drawing/2014/main" id="{AD5204E2-292C-4079-B160-F6FF8C5EF903}"/>
               </a:ext>
             </a:extLst>
           </p:cNvPr>
@@ -3617,7 +3561,7 @@
           <p:cNvPr id="28" name="">
             <a:extLst xmlns:a="http://schemas.openxmlformats.org/drawingml/2006/main">
               <a:ext uri="{FF2B5EF4-FFF2-40B4-BE49-F238E27FC236}">
-                <a16:creationId xmlns:a16="http://schemas.microsoft.com/office/drawing/2014/main" id="{190885C0-80D1-4AFE-901B-51E104554384}"/>
+                <a16:creationId xmlns:a16="http://schemas.microsoft.com/office/drawing/2014/main" id="{E4AA3E6B-ADB5-40A5-8B13-D374C12DCEAD}"/>
               </a:ext>
             </a:extLst>
           </p:cNvPr>
@@ -3650,7 +3594,7 @@
           <p:cNvPr id="29" name="">
             <a:extLst xmlns:a="http://schemas.openxmlformats.org/drawingml/2006/main">
               <a:ext uri="{FF2B5EF4-FFF2-40B4-BE49-F238E27FC236}">
-                <a16:creationId xmlns:a16="http://schemas.microsoft.com/office/drawing/2014/main" id="{46927E05-28E3-42FD-B840-275BD690784D}"/>
+                <a16:creationId xmlns:a16="http://schemas.microsoft.com/office/drawing/2014/main" id="{246F8851-7761-4AD2-8414-084371DB9951}"/>
               </a:ext>
             </a:extLst>
           </p:cNvPr>
@@ -3683,7 +3627,7 @@
           <p:cNvPr id="30" name="">
             <a:extLst xmlns:a="http://schemas.openxmlformats.org/drawingml/2006/main">
               <a:ext uri="{FF2B5EF4-FFF2-40B4-BE49-F238E27FC236}">
-                <a16:creationId xmlns:a16="http://schemas.microsoft.com/office/drawing/2014/main" id="{1AFB5180-60DD-4521-822D-81D6B07B0AC3}"/>
+                <a16:creationId xmlns:a16="http://schemas.microsoft.com/office/drawing/2014/main" id="{598E5193-DE2F-4D7E-B1B1-FFAD65FBC511}"/>
               </a:ext>
             </a:extLst>
           </p:cNvPr>
@@ -3792,7 +3736,7 @@
           <p:cNvPr id="34" name="">
             <a:extLst xmlns:a="http://schemas.openxmlformats.org/drawingml/2006/main">
               <a:ext uri="{FF2B5EF4-FFF2-40B4-BE49-F238E27FC236}">
-                <a16:creationId xmlns:a16="http://schemas.microsoft.com/office/drawing/2014/main" id="{C1BE01C1-36D8-4172-B9A9-8A82EEC50676}"/>
+                <a16:creationId xmlns:a16="http://schemas.microsoft.com/office/drawing/2014/main" id="{684E141F-7C9B-4857-B40B-9869C25BB575}"/>
               </a:ext>
             </a:extLst>
           </p:cNvPr>
@@ -3873,7 +3817,7 @@
           <p:cNvPr id="35" name="">
             <a:extLst xmlns:a="http://schemas.openxmlformats.org/drawingml/2006/main">
               <a:ext uri="{FF2B5EF4-FFF2-40B4-BE49-F238E27FC236}">
-                <a16:creationId xmlns:a16="http://schemas.microsoft.com/office/drawing/2014/main" id="{63DB2E95-F86F-43AF-8836-0C4967D8F961}"/>
+                <a16:creationId xmlns:a16="http://schemas.microsoft.com/office/drawing/2014/main" id="{9537A1B0-6DA2-4E11-A86A-34EF711D55DD}"/>
               </a:ext>
             </a:extLst>
           </p:cNvPr>
@@ -3931,7 +3875,7 @@
           <p:cNvPr id="36" name="">
             <a:extLst xmlns:a="http://schemas.openxmlformats.org/drawingml/2006/main">
               <a:ext uri="{FF2B5EF4-FFF2-40B4-BE49-F238E27FC236}">
-                <a16:creationId xmlns:a16="http://schemas.microsoft.com/office/drawing/2014/main" id="{4466D7B8-5884-4657-8D95-03EDB69B26CC}"/>
+                <a16:creationId xmlns:a16="http://schemas.microsoft.com/office/drawing/2014/main" id="{E709D984-427F-48A3-8450-C21811D7DF26}"/>
               </a:ext>
             </a:extLst>
           </p:cNvPr>
@@ -4012,7 +3956,7 @@
           <p:cNvPr id="37" name="">
             <a:extLst xmlns:a="http://schemas.openxmlformats.org/drawingml/2006/main">
               <a:ext uri="{FF2B5EF4-FFF2-40B4-BE49-F238E27FC236}">
-                <a16:creationId xmlns:a16="http://schemas.microsoft.com/office/drawing/2014/main" id="{0CB86AA1-35C8-43A6-9B5E-DE7D9729081E}"/>
+                <a16:creationId xmlns:a16="http://schemas.microsoft.com/office/drawing/2014/main" id="{B7A67276-8753-4092-B2BE-A71B47F4046E}"/>
               </a:ext>
             </a:extLst>
           </p:cNvPr>
@@ -4093,7 +4037,7 @@
           <p:cNvPr id="38" name="">
             <a:extLst xmlns:a="http://schemas.openxmlformats.org/drawingml/2006/main">
               <a:ext uri="{FF2B5EF4-FFF2-40B4-BE49-F238E27FC236}">
-                <a16:creationId xmlns:a16="http://schemas.microsoft.com/office/drawing/2014/main" id="{7B0AC71B-A22E-4684-B54A-9A9727B57A96}"/>
+                <a16:creationId xmlns:a16="http://schemas.microsoft.com/office/drawing/2014/main" id="{48AEA571-CABE-4970-BA2D-B7898BA743D0}"/>
               </a:ext>
             </a:extLst>
           </p:cNvPr>
@@ -4174,7 +4118,7 @@
           <p:cNvPr id="39" name="">
             <a:extLst xmlns:a="http://schemas.openxmlformats.org/drawingml/2006/main">
               <a:ext uri="{FF2B5EF4-FFF2-40B4-BE49-F238E27FC236}">
-                <a16:creationId xmlns:a16="http://schemas.microsoft.com/office/drawing/2014/main" id="{8407AC44-5682-42C6-82CA-EBA45D00DDF1}"/>
+                <a16:creationId xmlns:a16="http://schemas.microsoft.com/office/drawing/2014/main" id="{2C8DEC15-956A-4411-8716-4F51B6DA4B25}"/>
               </a:ext>
             </a:extLst>
           </p:cNvPr>
@@ -4232,7 +4176,7 @@
           <p:cNvPr id="40" name="">
             <a:extLst xmlns:a="http://schemas.openxmlformats.org/drawingml/2006/main">
               <a:ext uri="{FF2B5EF4-FFF2-40B4-BE49-F238E27FC236}">
-                <a16:creationId xmlns:a16="http://schemas.microsoft.com/office/drawing/2014/main" id="{3EF36DB9-C056-467C-ADAD-D4B0AB2714D0}"/>
+                <a16:creationId xmlns:a16="http://schemas.microsoft.com/office/drawing/2014/main" id="{23E02C19-9B0A-48AD-AC1F-1CA36B133EB3}"/>
               </a:ext>
             </a:extLst>
           </p:cNvPr>
@@ -4313,7 +4257,7 @@
           <p:cNvPr id="41" name="">
             <a:extLst xmlns:a="http://schemas.openxmlformats.org/drawingml/2006/main">
               <a:ext uri="{FF2B5EF4-FFF2-40B4-BE49-F238E27FC236}">
-                <a16:creationId xmlns:a16="http://schemas.microsoft.com/office/drawing/2014/main" id="{E7499737-C441-49F5-87E6-915AC019869D}"/>
+                <a16:creationId xmlns:a16="http://schemas.microsoft.com/office/drawing/2014/main" id="{EA74E713-FFA7-4606-B1AF-9FD145848ACB}"/>
               </a:ext>
             </a:extLst>
           </p:cNvPr>
@@ -4369,7 +4313,7 @@
     </p:spTree>
     <p:extLst>
       <p:ext uri="{BB962C8B-B14F-4D97-AF65-F5344CB8AC3E}">
-        <p14:creationId xmlns:p14="http://schemas.microsoft.com/office/powerpoint/2010/main" val="1180627694"/>
+        <p14:creationId xmlns:p14="http://schemas.microsoft.com/office/powerpoint/2010/main" val="1916370940"/>
       </p:ext>
     </p:extLst>
   </p:cSld>
@@ -4400,7 +4344,7 @@
           <p:cNvPr id="41" name="">
             <a:extLst xmlns:a="http://schemas.openxmlformats.org/drawingml/2006/main">
               <a:ext uri="{FF2B5EF4-FFF2-40B4-BE49-F238E27FC236}">
-                <a16:creationId xmlns:a16="http://schemas.microsoft.com/office/drawing/2014/main" id="{B2EE9D36-97D9-4DA7-A0BC-069BE78EB1EC}"/>
+                <a16:creationId xmlns:a16="http://schemas.microsoft.com/office/drawing/2014/main" id="{3ADE97D6-2DBE-4456-A1AD-6B314A5FB524}"/>
               </a:ext>
             </a:extLst>
           </p:cNvPr>
@@ -4458,7 +4402,7 @@
           <p:cNvPr id="2" name="">
             <a:extLst xmlns:a="http://schemas.openxmlformats.org/drawingml/2006/main">
               <a:ext uri="{FF2B5EF4-FFF2-40B4-BE49-F238E27FC236}">
-                <a16:creationId xmlns:a16="http://schemas.microsoft.com/office/drawing/2014/main" id="{DC20B30D-249E-466E-B454-7AD05D33B0DA}"/>
+                <a16:creationId xmlns:a16="http://schemas.microsoft.com/office/drawing/2014/main" id="{A1DBE386-BEC7-4B8C-A3A9-E80A2AD19DC6}"/>
               </a:ext>
             </a:extLst>
           </p:cNvPr>
@@ -4516,7 +4460,7 @@
           <p:cNvPr id="3" name="">
             <a:extLst xmlns:a="http://schemas.openxmlformats.org/drawingml/2006/main">
               <a:ext uri="{FF2B5EF4-FFF2-40B4-BE49-F238E27FC236}">
-                <a16:creationId xmlns:a16="http://schemas.microsoft.com/office/drawing/2014/main" id="{117CD5A8-D7FF-4AFB-A2E5-6E7BCEB49319}"/>
+                <a16:creationId xmlns:a16="http://schemas.microsoft.com/office/drawing/2014/main" id="{559093CB-61F7-491D-9102-C342224F2627}"/>
               </a:ext>
             </a:extLst>
           </p:cNvPr>
@@ -4547,7 +4491,7 @@
           <p:cNvPr id="4" name="">
             <a:extLst xmlns:a="http://schemas.openxmlformats.org/drawingml/2006/main">
               <a:ext uri="{FF2B5EF4-FFF2-40B4-BE49-F238E27FC236}">
-                <a16:creationId xmlns:a16="http://schemas.microsoft.com/office/drawing/2014/main" id="{E7C2EFC1-A75D-4790-AB34-0E09C45DFE9F}"/>
+                <a16:creationId xmlns:a16="http://schemas.microsoft.com/office/drawing/2014/main" id="{A10F3D31-40B9-48D5-A78C-4B60D63C015B}"/>
               </a:ext>
             </a:extLst>
           </p:cNvPr>
@@ -4611,7 +4555,7 @@
           <p:cNvPr id="5" name="">
             <a:extLst xmlns:a="http://schemas.openxmlformats.org/drawingml/2006/main">
               <a:ext uri="{FF2B5EF4-FFF2-40B4-BE49-F238E27FC236}">
-                <a16:creationId xmlns:a16="http://schemas.microsoft.com/office/drawing/2014/main" id="{AD8EB18F-9C20-46F6-AFD1-E067E7B5A98B}"/>
+                <a16:creationId xmlns:a16="http://schemas.microsoft.com/office/drawing/2014/main" id="{3803DB3E-4749-48E5-8232-8DE6D131D86B}"/>
               </a:ext>
             </a:extLst>
           </p:cNvPr>
@@ -4701,7 +4645,7 @@
           <p:cNvPr id="7" name="">
             <a:extLst xmlns:a="http://schemas.openxmlformats.org/drawingml/2006/main">
               <a:ext uri="{FF2B5EF4-FFF2-40B4-BE49-F238E27FC236}">
-                <a16:creationId xmlns:a16="http://schemas.microsoft.com/office/drawing/2014/main" id="{33893BE6-3421-4FD6-B83F-2637E14D333F}"/>
+                <a16:creationId xmlns:a16="http://schemas.microsoft.com/office/drawing/2014/main" id="{4B2C7802-EAD1-424F-BE70-7EC5A1756845}"/>
               </a:ext>
             </a:extLst>
           </p:cNvPr>
@@ -4734,7 +4678,7 @@
           <p:cNvPr id="8" name="">
             <a:extLst xmlns:a="http://schemas.openxmlformats.org/drawingml/2006/main">
               <a:ext uri="{FF2B5EF4-FFF2-40B4-BE49-F238E27FC236}">
-                <a16:creationId xmlns:a16="http://schemas.microsoft.com/office/drawing/2014/main" id="{910EE2DA-A379-41DB-AE63-8E58BF48D6C1}"/>
+                <a16:creationId xmlns:a16="http://schemas.microsoft.com/office/drawing/2014/main" id="{4E5405BB-C5B3-4A8F-9785-34A852698578}"/>
               </a:ext>
             </a:extLst>
           </p:cNvPr>
@@ -4793,7 +4737,7 @@
           <p:cNvPr id="10" name="">
             <a:extLst xmlns:a="http://schemas.openxmlformats.org/drawingml/2006/main">
               <a:ext uri="{FF2B5EF4-FFF2-40B4-BE49-F238E27FC236}">
-                <a16:creationId xmlns:a16="http://schemas.microsoft.com/office/drawing/2014/main" id="{A558D522-0944-4814-8BA2-D64A657F9477}"/>
+                <a16:creationId xmlns:a16="http://schemas.microsoft.com/office/drawing/2014/main" id="{EB2C16F1-5AAC-4BA2-8BE4-0A4495A10ED5}"/>
               </a:ext>
             </a:extLst>
           </p:cNvPr>
@@ -4855,7 +4799,7 @@
           <p:cNvPr id="11" name="">
             <a:extLst xmlns:a="http://schemas.openxmlformats.org/drawingml/2006/main">
               <a:ext uri="{FF2B5EF4-FFF2-40B4-BE49-F238E27FC236}">
-                <a16:creationId xmlns:a16="http://schemas.microsoft.com/office/drawing/2014/main" id="{5E388047-A105-4333-9BB5-C9D118FEA42A}"/>
+                <a16:creationId xmlns:a16="http://schemas.microsoft.com/office/drawing/2014/main" id="{61598A84-9F16-447C-B236-E72634DEC6C5}"/>
               </a:ext>
             </a:extLst>
           </p:cNvPr>
@@ -4914,7 +4858,7 @@
           <p:cNvPr id="13" name="">
             <a:extLst xmlns:a="http://schemas.openxmlformats.org/drawingml/2006/main">
               <a:ext uri="{FF2B5EF4-FFF2-40B4-BE49-F238E27FC236}">
-                <a16:creationId xmlns:a16="http://schemas.microsoft.com/office/drawing/2014/main" id="{BAF5D545-7BFF-40F5-8579-7194EC94B2D6}"/>
+                <a16:creationId xmlns:a16="http://schemas.microsoft.com/office/drawing/2014/main" id="{24FE09A0-11CA-4E17-8722-BF0DFB317A8F}"/>
               </a:ext>
             </a:extLst>
           </p:cNvPr>
@@ -4976,7 +4920,7 @@
           <p:cNvPr id="14" name="">
             <a:extLst xmlns:a="http://schemas.openxmlformats.org/drawingml/2006/main">
               <a:ext uri="{FF2B5EF4-FFF2-40B4-BE49-F238E27FC236}">
-                <a16:creationId xmlns:a16="http://schemas.microsoft.com/office/drawing/2014/main" id="{FDF5D0CE-07C2-4E00-833D-C857B928A152}"/>
+                <a16:creationId xmlns:a16="http://schemas.microsoft.com/office/drawing/2014/main" id="{071877B1-62AF-45E4-A073-7E83F6F6FAF5}"/>
               </a:ext>
             </a:extLst>
           </p:cNvPr>
@@ -5035,7 +4979,7 @@
           <p:cNvPr id="16" name="">
             <a:extLst xmlns:a="http://schemas.openxmlformats.org/drawingml/2006/main">
               <a:ext uri="{FF2B5EF4-FFF2-40B4-BE49-F238E27FC236}">
-                <a16:creationId xmlns:a16="http://schemas.microsoft.com/office/drawing/2014/main" id="{49C4C990-5281-456C-B64B-1F2CF090D1E8}"/>
+                <a16:creationId xmlns:a16="http://schemas.microsoft.com/office/drawing/2014/main" id="{D5DB4454-BCA8-45CE-B820-F084195000DA}"/>
               </a:ext>
             </a:extLst>
           </p:cNvPr>
@@ -5097,7 +5041,7 @@
           <p:cNvPr id="17" name="">
             <a:extLst xmlns:a="http://schemas.openxmlformats.org/drawingml/2006/main">
               <a:ext uri="{FF2B5EF4-FFF2-40B4-BE49-F238E27FC236}">
-                <a16:creationId xmlns:a16="http://schemas.microsoft.com/office/drawing/2014/main" id="{422C2A90-7596-42C8-9B07-0DF4B21A2DA6}"/>
+                <a16:creationId xmlns:a16="http://schemas.microsoft.com/office/drawing/2014/main" id="{F037ECD6-D4EF-49CF-8ABD-2374465CB5D8}"/>
               </a:ext>
             </a:extLst>
           </p:cNvPr>
@@ -5187,7 +5131,7 @@
           <p:cNvPr id="19" name="">
             <a:extLst xmlns:a="http://schemas.openxmlformats.org/drawingml/2006/main">
               <a:ext uri="{FF2B5EF4-FFF2-40B4-BE49-F238E27FC236}">
-                <a16:creationId xmlns:a16="http://schemas.microsoft.com/office/drawing/2014/main" id="{61FBBE85-BC71-4135-BFFC-35FFF4CC9B9C}"/>
+                <a16:creationId xmlns:a16="http://schemas.microsoft.com/office/drawing/2014/main" id="{626B3F44-FA27-43E0-B9A1-E04F3ACEE186}"/>
               </a:ext>
             </a:extLst>
           </p:cNvPr>
@@ -5245,7 +5189,7 @@
           <p:cNvPr id="20" name="">
             <a:extLst xmlns:a="http://schemas.openxmlformats.org/drawingml/2006/main">
               <a:ext uri="{FF2B5EF4-FFF2-40B4-BE49-F238E27FC236}">
-                <a16:creationId xmlns:a16="http://schemas.microsoft.com/office/drawing/2014/main" id="{A959A5D2-B882-4F77-9154-EC87BA9B4476}"/>
+                <a16:creationId xmlns:a16="http://schemas.microsoft.com/office/drawing/2014/main" id="{C2D84763-7909-4A18-AD68-F0D2E646E339}"/>
               </a:ext>
             </a:extLst>
           </p:cNvPr>
@@ -5309,7 +5253,7 @@
           <p:cNvPr id="21" name="">
             <a:extLst xmlns:a="http://schemas.openxmlformats.org/drawingml/2006/main">
               <a:ext uri="{FF2B5EF4-FFF2-40B4-BE49-F238E27FC236}">
-                <a16:creationId xmlns:a16="http://schemas.microsoft.com/office/drawing/2014/main" id="{C4DE22DA-DDF7-4241-BA1A-EAECA247886A}"/>
+                <a16:creationId xmlns:a16="http://schemas.microsoft.com/office/drawing/2014/main" id="{CA5E5F6A-6E36-45D1-B7E1-CFD065205153}"/>
               </a:ext>
             </a:extLst>
           </p:cNvPr>
@@ -5399,7 +5343,7 @@
           <p:cNvPr id="23" name="">
             <a:extLst xmlns:a="http://schemas.openxmlformats.org/drawingml/2006/main">
               <a:ext uri="{FF2B5EF4-FFF2-40B4-BE49-F238E27FC236}">
-                <a16:creationId xmlns:a16="http://schemas.microsoft.com/office/drawing/2014/main" id="{AF862738-8B77-489A-88EE-E579D2916797}"/>
+                <a16:creationId xmlns:a16="http://schemas.microsoft.com/office/drawing/2014/main" id="{06F457B8-E96D-412A-A98B-78C597D9B6CA}"/>
               </a:ext>
             </a:extLst>
           </p:cNvPr>
@@ -5432,7 +5376,7 @@
           <p:cNvPr id="24" name="">
             <a:extLst xmlns:a="http://schemas.openxmlformats.org/drawingml/2006/main">
               <a:ext uri="{FF2B5EF4-FFF2-40B4-BE49-F238E27FC236}">
-                <a16:creationId xmlns:a16="http://schemas.microsoft.com/office/drawing/2014/main" id="{0A257AEF-C025-4A62-AE9B-70797094EC49}"/>
+                <a16:creationId xmlns:a16="http://schemas.microsoft.com/office/drawing/2014/main" id="{86E9207D-ACDD-4DDC-8163-DBC5A6F620E8}"/>
               </a:ext>
             </a:extLst>
           </p:cNvPr>
@@ -5517,7 +5461,7 @@
           <p:cNvPr id="27" name="">
             <a:extLst xmlns:a="http://schemas.openxmlformats.org/drawingml/2006/main">
               <a:ext uri="{FF2B5EF4-FFF2-40B4-BE49-F238E27FC236}">
-                <a16:creationId xmlns:a16="http://schemas.microsoft.com/office/drawing/2014/main" id="{659C3534-BFFD-4817-A443-033AFC30E494}"/>
+                <a16:creationId xmlns:a16="http://schemas.microsoft.com/office/drawing/2014/main" id="{0B9BDBEF-2FD9-46CD-924E-5461FE3ED952}"/>
               </a:ext>
             </a:extLst>
           </p:cNvPr>
@@ -5579,7 +5523,7 @@
           <p:cNvPr id="28" name="">
             <a:extLst xmlns:a="http://schemas.openxmlformats.org/drawingml/2006/main">
               <a:ext uri="{FF2B5EF4-FFF2-40B4-BE49-F238E27FC236}">
-                <a16:creationId xmlns:a16="http://schemas.microsoft.com/office/drawing/2014/main" id="{7978B3EF-69D6-4E31-BB9B-1B1517B2DB73}"/>
+                <a16:creationId xmlns:a16="http://schemas.microsoft.com/office/drawing/2014/main" id="{AAAFC494-64EB-4C7E-B90A-51F764DDA50A}"/>
               </a:ext>
             </a:extLst>
           </p:cNvPr>
@@ -5664,7 +5608,7 @@
           <p:cNvPr id="31" name="">
             <a:extLst xmlns:a="http://schemas.openxmlformats.org/drawingml/2006/main">
               <a:ext uri="{FF2B5EF4-FFF2-40B4-BE49-F238E27FC236}">
-                <a16:creationId xmlns:a16="http://schemas.microsoft.com/office/drawing/2014/main" id="{B26864B2-4FF2-4A76-ABD2-00E62072B232}"/>
+                <a16:creationId xmlns:a16="http://schemas.microsoft.com/office/drawing/2014/main" id="{46A0B29A-038B-4902-8ECE-5F20EF518DAD}"/>
               </a:ext>
             </a:extLst>
           </p:cNvPr>
@@ -5726,7 +5670,7 @@
           <p:cNvPr id="32" name="">
             <a:extLst xmlns:a="http://schemas.openxmlformats.org/drawingml/2006/main">
               <a:ext uri="{FF2B5EF4-FFF2-40B4-BE49-F238E27FC236}">
-                <a16:creationId xmlns:a16="http://schemas.microsoft.com/office/drawing/2014/main" id="{047EE168-6BE2-46DD-BAFE-A5E06388311F}"/>
+                <a16:creationId xmlns:a16="http://schemas.microsoft.com/office/drawing/2014/main" id="{D5273D2D-2DA1-4AF9-BBD1-471A206B3443}"/>
               </a:ext>
             </a:extLst>
           </p:cNvPr>
@@ -5811,7 +5755,7 @@
           <p:cNvPr id="35" name="">
             <a:extLst xmlns:a="http://schemas.openxmlformats.org/drawingml/2006/main">
               <a:ext uri="{FF2B5EF4-FFF2-40B4-BE49-F238E27FC236}">
-                <a16:creationId xmlns:a16="http://schemas.microsoft.com/office/drawing/2014/main" id="{73CCC891-1783-431C-972C-284F0C207EFF}"/>
+                <a16:creationId xmlns:a16="http://schemas.microsoft.com/office/drawing/2014/main" id="{C6628665-035D-4C93-B29A-FA2691DACB22}"/>
               </a:ext>
             </a:extLst>
           </p:cNvPr>
@@ -5873,7 +5817,7 @@
           <p:cNvPr id="36" name="">
             <a:extLst xmlns:a="http://schemas.openxmlformats.org/drawingml/2006/main">
               <a:ext uri="{FF2B5EF4-FFF2-40B4-BE49-F238E27FC236}">
-                <a16:creationId xmlns:a16="http://schemas.microsoft.com/office/drawing/2014/main" id="{9DF17A35-CBD5-4CAD-BEF0-50A4A0832062}"/>
+                <a16:creationId xmlns:a16="http://schemas.microsoft.com/office/drawing/2014/main" id="{7DF6A9F4-DAD5-499D-B304-690E06EAC843}"/>
               </a:ext>
             </a:extLst>
           </p:cNvPr>
@@ -5963,7 +5907,7 @@
           <p:cNvPr id="38" name="">
             <a:extLst xmlns:a="http://schemas.openxmlformats.org/drawingml/2006/main">
               <a:ext uri="{FF2B5EF4-FFF2-40B4-BE49-F238E27FC236}">
-                <a16:creationId xmlns:a16="http://schemas.microsoft.com/office/drawing/2014/main" id="{14590D2C-85B6-47E7-BC14-ED76B6533055}"/>
+                <a16:creationId xmlns:a16="http://schemas.microsoft.com/office/drawing/2014/main" id="{8B165037-A67D-4766-B1E8-85A7BF6F88B0}"/>
               </a:ext>
             </a:extLst>
           </p:cNvPr>
@@ -6053,7 +5997,7 @@
           <p:cNvPr id="40" name="">
             <a:extLst xmlns:a="http://schemas.openxmlformats.org/drawingml/2006/main">
               <a:ext uri="{FF2B5EF4-FFF2-40B4-BE49-F238E27FC236}">
-                <a16:creationId xmlns:a16="http://schemas.microsoft.com/office/drawing/2014/main" id="{83097E38-A5F6-4CCF-8186-B92492064720}"/>
+                <a16:creationId xmlns:a16="http://schemas.microsoft.com/office/drawing/2014/main" id="{9B955848-574B-4AFA-B400-9D4A682E6656}"/>
               </a:ext>
             </a:extLst>
           </p:cNvPr>
@@ -6109,7 +6053,7 @@
     </p:spTree>
     <p:extLst>
       <p:ext uri="{BB962C8B-B14F-4D97-AF65-F5344CB8AC3E}">
-        <p14:creationId xmlns:p14="http://schemas.microsoft.com/office/powerpoint/2010/main" val="1770532358"/>
+        <p14:creationId xmlns:p14="http://schemas.microsoft.com/office/powerpoint/2010/main" val="719687032"/>
       </p:ext>
     </p:extLst>
   </p:cSld>
@@ -6140,7 +6084,7 @@
           <p:cNvPr id="35" name="">
             <a:extLst xmlns:a="http://schemas.openxmlformats.org/drawingml/2006/main">
               <a:ext uri="{FF2B5EF4-FFF2-40B4-BE49-F238E27FC236}">
-                <a16:creationId xmlns:a16="http://schemas.microsoft.com/office/drawing/2014/main" id="{E45DE238-32DD-4AC7-A7DA-553920065D31}"/>
+                <a16:creationId xmlns:a16="http://schemas.microsoft.com/office/drawing/2014/main" id="{6A4D9DE7-5DED-4EE8-B6A1-290E3AF9FD1C}"/>
               </a:ext>
             </a:extLst>
           </p:cNvPr>
@@ -6198,7 +6142,7 @@
           <p:cNvPr id="2" name="">
             <a:extLst xmlns:a="http://schemas.openxmlformats.org/drawingml/2006/main">
               <a:ext uri="{FF2B5EF4-FFF2-40B4-BE49-F238E27FC236}">
-                <a16:creationId xmlns:a16="http://schemas.microsoft.com/office/drawing/2014/main" id="{54F9F0FA-EB41-44F4-83F8-E6AF683086A8}"/>
+                <a16:creationId xmlns:a16="http://schemas.microsoft.com/office/drawing/2014/main" id="{67F21EB5-1CD3-4E1A-B9B1-60F2A0B24034}"/>
               </a:ext>
             </a:extLst>
           </p:cNvPr>
@@ -6256,7 +6200,7 @@
           <p:cNvPr id="3" name="">
             <a:extLst xmlns:a="http://schemas.openxmlformats.org/drawingml/2006/main">
               <a:ext uri="{FF2B5EF4-FFF2-40B4-BE49-F238E27FC236}">
-                <a16:creationId xmlns:a16="http://schemas.microsoft.com/office/drawing/2014/main" id="{C38C6E8C-002F-4CC7-BC01-6C1FD157597C}"/>
+                <a16:creationId xmlns:a16="http://schemas.microsoft.com/office/drawing/2014/main" id="{793F5602-4A8D-44C2-9E5A-ACFDB3F083DE}"/>
               </a:ext>
             </a:extLst>
           </p:cNvPr>
@@ -6287,7 +6231,7 @@
           <p:cNvPr id="4" name="">
             <a:extLst xmlns:a="http://schemas.openxmlformats.org/drawingml/2006/main">
               <a:ext uri="{FF2B5EF4-FFF2-40B4-BE49-F238E27FC236}">
-                <a16:creationId xmlns:a16="http://schemas.microsoft.com/office/drawing/2014/main" id="{3B15AAD3-A191-4345-95EE-69AC1F336D73}"/>
+                <a16:creationId xmlns:a16="http://schemas.microsoft.com/office/drawing/2014/main" id="{E42EDE41-7A6C-42AC-B393-65487D6E2986}"/>
               </a:ext>
             </a:extLst>
           </p:cNvPr>
@@ -6320,7 +6264,7 @@
           <p:cNvPr id="5" name="">
             <a:extLst xmlns:a="http://schemas.openxmlformats.org/drawingml/2006/main">
               <a:ext uri="{FF2B5EF4-FFF2-40B4-BE49-F238E27FC236}">
-                <a16:creationId xmlns:a16="http://schemas.microsoft.com/office/drawing/2014/main" id="{05FFE77B-BB34-409B-B541-5DBEF2029CD7}"/>
+                <a16:creationId xmlns:a16="http://schemas.microsoft.com/office/drawing/2014/main" id="{78398BE3-D1A6-4FEF-A1CB-5F547AAFAA40}"/>
               </a:ext>
             </a:extLst>
           </p:cNvPr>
@@ -6353,7 +6297,7 @@
           <p:cNvPr id="6" name="">
             <a:extLst xmlns:a="http://schemas.openxmlformats.org/drawingml/2006/main">
               <a:ext uri="{FF2B5EF4-FFF2-40B4-BE49-F238E27FC236}">
-                <a16:creationId xmlns:a16="http://schemas.microsoft.com/office/drawing/2014/main" id="{87F4F5B1-C55B-426A-B15B-2B38765FC4B5}"/>
+                <a16:creationId xmlns:a16="http://schemas.microsoft.com/office/drawing/2014/main" id="{02E2B3FA-A658-4FEA-8627-3EF9EBD86FFF}"/>
               </a:ext>
             </a:extLst>
           </p:cNvPr>
@@ -6469,7 +6413,7 @@
           <p:cNvPr id="9" name="">
             <a:extLst xmlns:a="http://schemas.openxmlformats.org/drawingml/2006/main">
               <a:ext uri="{FF2B5EF4-FFF2-40B4-BE49-F238E27FC236}">
-                <a16:creationId xmlns:a16="http://schemas.microsoft.com/office/drawing/2014/main" id="{073E39EF-404A-4F45-B3FD-18735CF729F3}"/>
+                <a16:creationId xmlns:a16="http://schemas.microsoft.com/office/drawing/2014/main" id="{6B5C52DD-9F7F-47F5-A62D-B0953E37C87F}"/>
               </a:ext>
             </a:extLst>
           </p:cNvPr>
@@ -6531,7 +6475,7 @@
           <p:cNvPr id="10" name="">
             <a:extLst xmlns:a="http://schemas.openxmlformats.org/drawingml/2006/main">
               <a:ext uri="{FF2B5EF4-FFF2-40B4-BE49-F238E27FC236}">
-                <a16:creationId xmlns:a16="http://schemas.microsoft.com/office/drawing/2014/main" id="{A72903B8-DABF-47B1-8EE2-9F6CA292FDDD}"/>
+                <a16:creationId xmlns:a16="http://schemas.microsoft.com/office/drawing/2014/main" id="{BB59ED25-9AAD-4315-A547-67D3A94211B5}"/>
               </a:ext>
             </a:extLst>
           </p:cNvPr>
@@ -6564,7 +6508,7 @@
           <p:cNvPr id="11" name="">
             <a:extLst xmlns:a="http://schemas.openxmlformats.org/drawingml/2006/main">
               <a:ext uri="{FF2B5EF4-FFF2-40B4-BE49-F238E27FC236}">
-                <a16:creationId xmlns:a16="http://schemas.microsoft.com/office/drawing/2014/main" id="{2F96AD4A-C687-49A6-8562-554C061D343B}"/>
+                <a16:creationId xmlns:a16="http://schemas.microsoft.com/office/drawing/2014/main" id="{FE7F4E68-C9D4-4CF6-A045-69B60ECE97B2}"/>
               </a:ext>
             </a:extLst>
           </p:cNvPr>
@@ -6680,7 +6624,7 @@
           <p:cNvPr id="14" name="">
             <a:extLst xmlns:a="http://schemas.openxmlformats.org/drawingml/2006/main">
               <a:ext uri="{FF2B5EF4-FFF2-40B4-BE49-F238E27FC236}">
-                <a16:creationId xmlns:a16="http://schemas.microsoft.com/office/drawing/2014/main" id="{E5E17AA7-D31A-4954-AAD3-E9E93AF8AB06}"/>
+                <a16:creationId xmlns:a16="http://schemas.microsoft.com/office/drawing/2014/main" id="{B39DE3DA-9F26-4E35-B294-CEBF3F359FB8}"/>
               </a:ext>
             </a:extLst>
           </p:cNvPr>
@@ -6742,7 +6686,7 @@
           <p:cNvPr id="15" name="">
             <a:extLst xmlns:a="http://schemas.openxmlformats.org/drawingml/2006/main">
               <a:ext uri="{FF2B5EF4-FFF2-40B4-BE49-F238E27FC236}">
-                <a16:creationId xmlns:a16="http://schemas.microsoft.com/office/drawing/2014/main" id="{107D3643-68FE-4527-87C5-20C897B1350D}"/>
+                <a16:creationId xmlns:a16="http://schemas.microsoft.com/office/drawing/2014/main" id="{D1532367-3495-4F92-BE87-C8EE5D21FCA9}"/>
               </a:ext>
             </a:extLst>
           </p:cNvPr>
@@ -6775,7 +6719,7 @@
           <p:cNvPr id="16" name="">
             <a:extLst xmlns:a="http://schemas.openxmlformats.org/drawingml/2006/main">
               <a:ext uri="{FF2B5EF4-FFF2-40B4-BE49-F238E27FC236}">
-                <a16:creationId xmlns:a16="http://schemas.microsoft.com/office/drawing/2014/main" id="{7BE5B69F-D118-4BA2-BE19-66B9C8118189}"/>
+                <a16:creationId xmlns:a16="http://schemas.microsoft.com/office/drawing/2014/main" id="{792CF789-7EBA-46BB-8D63-4F1353D8F116}"/>
               </a:ext>
             </a:extLst>
           </p:cNvPr>
@@ -6891,7 +6835,7 @@
           <p:cNvPr id="19" name="">
             <a:extLst xmlns:a="http://schemas.openxmlformats.org/drawingml/2006/main">
               <a:ext uri="{FF2B5EF4-FFF2-40B4-BE49-F238E27FC236}">
-                <a16:creationId xmlns:a16="http://schemas.microsoft.com/office/drawing/2014/main" id="{1297F629-A6A9-4B21-BA4B-2D485E78E7E3}"/>
+                <a16:creationId xmlns:a16="http://schemas.microsoft.com/office/drawing/2014/main" id="{142E7CFF-2461-401D-8223-9C50C4738191}"/>
               </a:ext>
             </a:extLst>
           </p:cNvPr>
@@ -6953,7 +6897,7 @@
           <p:cNvPr id="20" name="">
             <a:extLst xmlns:a="http://schemas.openxmlformats.org/drawingml/2006/main">
               <a:ext uri="{FF2B5EF4-FFF2-40B4-BE49-F238E27FC236}">
-                <a16:creationId xmlns:a16="http://schemas.microsoft.com/office/drawing/2014/main" id="{AED7D429-2447-4F66-8B23-32E36047A5E3}"/>
+                <a16:creationId xmlns:a16="http://schemas.microsoft.com/office/drawing/2014/main" id="{7B5D7464-BBF7-4F15-AE03-C74D34495720}"/>
               </a:ext>
             </a:extLst>
           </p:cNvPr>
@@ -6986,7 +6930,7 @@
           <p:cNvPr id="21" name="">
             <a:extLst xmlns:a="http://schemas.openxmlformats.org/drawingml/2006/main">
               <a:ext uri="{FF2B5EF4-FFF2-40B4-BE49-F238E27FC236}">
-                <a16:creationId xmlns:a16="http://schemas.microsoft.com/office/drawing/2014/main" id="{5A1C5051-D944-4B89-96AA-E567BAAA735D}"/>
+                <a16:creationId xmlns:a16="http://schemas.microsoft.com/office/drawing/2014/main" id="{339BC205-95F3-45E9-8046-C56D3A258929}"/>
               </a:ext>
             </a:extLst>
           </p:cNvPr>
@@ -7045,7 +6989,7 @@
           <p:cNvPr id="23" name="">
             <a:extLst xmlns:a="http://schemas.openxmlformats.org/drawingml/2006/main">
               <a:ext uri="{FF2B5EF4-FFF2-40B4-BE49-F238E27FC236}">
-                <a16:creationId xmlns:a16="http://schemas.microsoft.com/office/drawing/2014/main" id="{E2557C75-E784-43C6-A0F0-627019590F5E}"/>
+                <a16:creationId xmlns:a16="http://schemas.microsoft.com/office/drawing/2014/main" id="{E43814D9-59AC-4068-BF8C-BBF020CEF58B}"/>
               </a:ext>
             </a:extLst>
           </p:cNvPr>
@@ -7107,7 +7051,7 @@
           <p:cNvPr id="24" name="">
             <a:extLst xmlns:a="http://schemas.openxmlformats.org/drawingml/2006/main">
               <a:ext uri="{FF2B5EF4-FFF2-40B4-BE49-F238E27FC236}">
-                <a16:creationId xmlns:a16="http://schemas.microsoft.com/office/drawing/2014/main" id="{F70F8AE7-C26A-4EAB-87CB-4761B7F28217}"/>
+                <a16:creationId xmlns:a16="http://schemas.microsoft.com/office/drawing/2014/main" id="{DF47EECE-0ECA-4F54-A886-CF49D0807C7E}"/>
               </a:ext>
             </a:extLst>
           </p:cNvPr>
@@ -7165,7 +7109,7 @@
           <p:cNvPr id="25" name="">
             <a:extLst xmlns:a="http://schemas.openxmlformats.org/drawingml/2006/main">
               <a:ext uri="{FF2B5EF4-FFF2-40B4-BE49-F238E27FC236}">
-                <a16:creationId xmlns:a16="http://schemas.microsoft.com/office/drawing/2014/main" id="{BBC638FF-E8DE-4BDC-B6FD-74F7A61120D1}"/>
+                <a16:creationId xmlns:a16="http://schemas.microsoft.com/office/drawing/2014/main" id="{3C16CFCF-A2AB-4EE5-B6FD-E3425A781849}"/>
               </a:ext>
             </a:extLst>
           </p:cNvPr>
@@ -7224,7 +7168,7 @@
           <p:cNvPr id="27" name="">
             <a:extLst xmlns:a="http://schemas.openxmlformats.org/drawingml/2006/main">
               <a:ext uri="{FF2B5EF4-FFF2-40B4-BE49-F238E27FC236}">
-                <a16:creationId xmlns:a16="http://schemas.microsoft.com/office/drawing/2014/main" id="{9F83E3E0-2B6D-4B95-AEC3-66FEDD711726}"/>
+                <a16:creationId xmlns:a16="http://schemas.microsoft.com/office/drawing/2014/main" id="{65A3FE04-1D8A-4E6A-A0BD-3985B37231D7}"/>
               </a:ext>
             </a:extLst>
           </p:cNvPr>
@@ -7286,7 +7230,7 @@
           <p:cNvPr id="28" name="">
             <a:extLst xmlns:a="http://schemas.openxmlformats.org/drawingml/2006/main">
               <a:ext uri="{FF2B5EF4-FFF2-40B4-BE49-F238E27FC236}">
-                <a16:creationId xmlns:a16="http://schemas.microsoft.com/office/drawing/2014/main" id="{DFF7CB64-BF45-49CE-BAA7-99474211E9F8}"/>
+                <a16:creationId xmlns:a16="http://schemas.microsoft.com/office/drawing/2014/main" id="{6E9A5183-4FEE-4C4F-AEAC-D2516010B48A}"/>
               </a:ext>
             </a:extLst>
           </p:cNvPr>
@@ -7344,7 +7288,7 @@
           <p:cNvPr id="29" name="">
             <a:extLst xmlns:a="http://schemas.openxmlformats.org/drawingml/2006/main">
               <a:ext uri="{FF2B5EF4-FFF2-40B4-BE49-F238E27FC236}">
-                <a16:creationId xmlns:a16="http://schemas.microsoft.com/office/drawing/2014/main" id="{EE0572AA-0BE1-429C-BF5E-D7B089784C26}"/>
+                <a16:creationId xmlns:a16="http://schemas.microsoft.com/office/drawing/2014/main" id="{74E212BB-0534-4D32-A7CB-0BE5889124EC}"/>
               </a:ext>
             </a:extLst>
           </p:cNvPr>
@@ -7403,7 +7347,7 @@
           <p:cNvPr id="31" name="">
             <a:extLst xmlns:a="http://schemas.openxmlformats.org/drawingml/2006/main">
               <a:ext uri="{FF2B5EF4-FFF2-40B4-BE49-F238E27FC236}">
-                <a16:creationId xmlns:a16="http://schemas.microsoft.com/office/drawing/2014/main" id="{85D1ACD1-9CFE-4D3A-A788-DADCD0616F52}"/>
+                <a16:creationId xmlns:a16="http://schemas.microsoft.com/office/drawing/2014/main" id="{71213B19-B8A5-4AC5-9508-F51371A1945D}"/>
               </a:ext>
             </a:extLst>
           </p:cNvPr>
@@ -7465,7 +7409,7 @@
           <p:cNvPr id="32" name="">
             <a:extLst xmlns:a="http://schemas.openxmlformats.org/drawingml/2006/main">
               <a:ext uri="{FF2B5EF4-FFF2-40B4-BE49-F238E27FC236}">
-                <a16:creationId xmlns:a16="http://schemas.microsoft.com/office/drawing/2014/main" id="{20EED424-136A-4B51-A112-C0404435506E}"/>
+                <a16:creationId xmlns:a16="http://schemas.microsoft.com/office/drawing/2014/main" id="{54FAD20C-345D-42B9-A812-B27708DB9202}"/>
               </a:ext>
             </a:extLst>
           </p:cNvPr>
@@ -7523,7 +7467,7 @@
           <p:cNvPr id="33" name="">
             <a:extLst xmlns:a="http://schemas.openxmlformats.org/drawingml/2006/main">
               <a:ext uri="{FF2B5EF4-FFF2-40B4-BE49-F238E27FC236}">
-                <a16:creationId xmlns:a16="http://schemas.microsoft.com/office/drawing/2014/main" id="{7E6B3781-BC25-4CB0-A9A4-61B2E9701EFF}"/>
+                <a16:creationId xmlns:a16="http://schemas.microsoft.com/office/drawing/2014/main" id="{4DF88C56-E684-4B8A-814E-44E6BA223B1E}"/>
               </a:ext>
             </a:extLst>
           </p:cNvPr>
@@ -7581,7 +7525,7 @@
           <p:cNvPr id="34" name="">
             <a:extLst xmlns:a="http://schemas.openxmlformats.org/drawingml/2006/main">
               <a:ext uri="{FF2B5EF4-FFF2-40B4-BE49-F238E27FC236}">
-                <a16:creationId xmlns:a16="http://schemas.microsoft.com/office/drawing/2014/main" id="{4298B516-36A9-49C4-8297-09F07566DDFD}"/>
+                <a16:creationId xmlns:a16="http://schemas.microsoft.com/office/drawing/2014/main" id="{520AC615-5F67-4577-AF35-367257438180}"/>
               </a:ext>
             </a:extLst>
           </p:cNvPr>
@@ -7637,7 +7581,7 @@
     </p:spTree>
     <p:extLst>
       <p:ext uri="{BB962C8B-B14F-4D97-AF65-F5344CB8AC3E}">
-        <p14:creationId xmlns:p14="http://schemas.microsoft.com/office/powerpoint/2010/main" val="1094501853"/>
+        <p14:creationId xmlns:p14="http://schemas.microsoft.com/office/powerpoint/2010/main" val="1993989723"/>
       </p:ext>
     </p:extLst>
   </p:cSld>
@@ -7668,7 +7612,7 @@
           <p:cNvPr id="20" name="">
             <a:extLst xmlns:a="http://schemas.openxmlformats.org/drawingml/2006/main">
               <a:ext uri="{FF2B5EF4-FFF2-40B4-BE49-F238E27FC236}">
-                <a16:creationId xmlns:a16="http://schemas.microsoft.com/office/drawing/2014/main" id="{2E3AFA8B-4427-4273-B0BE-CDDE59078B3E}"/>
+                <a16:creationId xmlns:a16="http://schemas.microsoft.com/office/drawing/2014/main" id="{682CE0CE-6D07-4A80-A882-BED3ED4968EF}"/>
               </a:ext>
             </a:extLst>
           </p:cNvPr>
@@ -7732,7 +7676,7 @@
           <p:cNvPr id="2" name="">
             <a:extLst xmlns:a="http://schemas.openxmlformats.org/drawingml/2006/main">
               <a:ext uri="{FF2B5EF4-FFF2-40B4-BE49-F238E27FC236}">
-                <a16:creationId xmlns:a16="http://schemas.microsoft.com/office/drawing/2014/main" id="{7673DC5D-C89B-4D08-B5EA-42664C68AAFA}"/>
+                <a16:creationId xmlns:a16="http://schemas.microsoft.com/office/drawing/2014/main" id="{1FFD3E75-E03F-49D2-9736-B9E713CB5491}"/>
               </a:ext>
             </a:extLst>
           </p:cNvPr>
@@ -7819,7 +7763,7 @@
           <p:cNvPr id="3" name="">
             <a:extLst xmlns:a="http://schemas.openxmlformats.org/drawingml/2006/main">
               <a:ext uri="{FF2B5EF4-FFF2-40B4-BE49-F238E27FC236}">
-                <a16:creationId xmlns:a16="http://schemas.microsoft.com/office/drawing/2014/main" id="{AE85C559-4651-427A-90C0-2C424A08AC27}"/>
+                <a16:creationId xmlns:a16="http://schemas.microsoft.com/office/drawing/2014/main" id="{85EF393E-8360-4281-9FAB-27D50C9E1201}"/>
               </a:ext>
             </a:extLst>
           </p:cNvPr>
@@ -7906,7 +7850,7 @@
           <p:cNvPr id="4" name="">
             <a:extLst xmlns:a="http://schemas.openxmlformats.org/drawingml/2006/main">
               <a:ext uri="{FF2B5EF4-FFF2-40B4-BE49-F238E27FC236}">
-                <a16:creationId xmlns:a16="http://schemas.microsoft.com/office/drawing/2014/main" id="{057D4A76-6977-4027-8041-C95F43D2FBCD}"/>
+                <a16:creationId xmlns:a16="http://schemas.microsoft.com/office/drawing/2014/main" id="{22DEF947-B1F4-4980-8EDF-9474D6BFF219}"/>
               </a:ext>
             </a:extLst>
           </p:cNvPr>
@@ -7993,7 +7937,7 @@
           <p:cNvPr id="5" name="">
             <a:extLst xmlns:a="http://schemas.openxmlformats.org/drawingml/2006/main">
               <a:ext uri="{FF2B5EF4-FFF2-40B4-BE49-F238E27FC236}">
-                <a16:creationId xmlns:a16="http://schemas.microsoft.com/office/drawing/2014/main" id="{212C3E75-D08A-46CD-9D6B-A31FCE78A411}"/>
+                <a16:creationId xmlns:a16="http://schemas.microsoft.com/office/drawing/2014/main" id="{22272988-EEB4-4A3E-B56E-17D0355DCC63}"/>
               </a:ext>
             </a:extLst>
           </p:cNvPr>
@@ -8220,7 +8164,7 @@
           <p:cNvPr id="11" name="">
             <a:extLst xmlns:a="http://schemas.openxmlformats.org/drawingml/2006/main">
               <a:ext uri="{FF2B5EF4-FFF2-40B4-BE49-F238E27FC236}">
-                <a16:creationId xmlns:a16="http://schemas.microsoft.com/office/drawing/2014/main" id="{3C3FC464-14E1-424E-AAF9-2977294ECB1B}"/>
+                <a16:creationId xmlns:a16="http://schemas.microsoft.com/office/drawing/2014/main" id="{9B36D53C-E4DF-4F07-B3D7-C2D7CBBF25C5}"/>
               </a:ext>
             </a:extLst>
           </p:cNvPr>
@@ -8253,7 +8197,7 @@
           <p:cNvPr id="12" name="">
             <a:extLst xmlns:a="http://schemas.openxmlformats.org/drawingml/2006/main">
               <a:ext uri="{FF2B5EF4-FFF2-40B4-BE49-F238E27FC236}">
-                <a16:creationId xmlns:a16="http://schemas.microsoft.com/office/drawing/2014/main" id="{6E8A49B1-CDCA-4BDB-8CD7-1C2791230D83}"/>
+                <a16:creationId xmlns:a16="http://schemas.microsoft.com/office/drawing/2014/main" id="{5D454BB6-7FF6-4934-B6F6-BFE7192C59BE}"/>
               </a:ext>
             </a:extLst>
           </p:cNvPr>
@@ -8286,7 +8230,7 @@
           <p:cNvPr id="13" name="">
             <a:extLst xmlns:a="http://schemas.openxmlformats.org/drawingml/2006/main">
               <a:ext uri="{FF2B5EF4-FFF2-40B4-BE49-F238E27FC236}">
-                <a16:creationId xmlns:a16="http://schemas.microsoft.com/office/drawing/2014/main" id="{AD110F1A-33C8-4818-8F30-2606F44C182B}"/>
+                <a16:creationId xmlns:a16="http://schemas.microsoft.com/office/drawing/2014/main" id="{7D3F923C-0D45-4B56-A15F-86553474BE22}"/>
               </a:ext>
             </a:extLst>
           </p:cNvPr>
@@ -8319,7 +8263,7 @@
           <p:cNvPr id="14" name="">
             <a:extLst xmlns:a="http://schemas.openxmlformats.org/drawingml/2006/main">
               <a:ext uri="{FF2B5EF4-FFF2-40B4-BE49-F238E27FC236}">
-                <a16:creationId xmlns:a16="http://schemas.microsoft.com/office/drawing/2014/main" id="{E298F19E-FB15-4D91-A552-BCAFA8886A75}"/>
+                <a16:creationId xmlns:a16="http://schemas.microsoft.com/office/drawing/2014/main" id="{4393CE02-C182-4135-8AB1-AA8A8F255862}"/>
               </a:ext>
             </a:extLst>
           </p:cNvPr>
@@ -8402,7 +8346,7 @@
           <p:cNvPr id="17" name="">
             <a:extLst xmlns:a="http://schemas.openxmlformats.org/drawingml/2006/main">
               <a:ext uri="{FF2B5EF4-FFF2-40B4-BE49-F238E27FC236}">
-                <a16:creationId xmlns:a16="http://schemas.microsoft.com/office/drawing/2014/main" id="{CFE61F5B-A454-416F-91E7-68C3FF8603AE}"/>
+                <a16:creationId xmlns:a16="http://schemas.microsoft.com/office/drawing/2014/main" id="{282B1FD9-93BF-4F8D-9F61-90FD105E65EE}"/>
               </a:ext>
             </a:extLst>
           </p:cNvPr>
@@ -8460,7 +8404,7 @@
           <p:cNvPr id="18" name="">
             <a:extLst xmlns:a="http://schemas.openxmlformats.org/drawingml/2006/main">
               <a:ext uri="{FF2B5EF4-FFF2-40B4-BE49-F238E27FC236}">
-                <a16:creationId xmlns:a16="http://schemas.microsoft.com/office/drawing/2014/main" id="{B4768A90-9213-4334-8EB0-95B2BF7445E4}"/>
+                <a16:creationId xmlns:a16="http://schemas.microsoft.com/office/drawing/2014/main" id="{44E774DB-2A68-47A0-A917-0845682E4D87}"/>
               </a:ext>
             </a:extLst>
           </p:cNvPr>
@@ -8518,7 +8462,7 @@
           <p:cNvPr id="19" name="">
             <a:extLst xmlns:a="http://schemas.openxmlformats.org/drawingml/2006/main">
               <a:ext uri="{FF2B5EF4-FFF2-40B4-BE49-F238E27FC236}">
-                <a16:creationId xmlns:a16="http://schemas.microsoft.com/office/drawing/2014/main" id="{03AE4EC4-5541-4552-A958-357A5F5E58AF}"/>
+                <a16:creationId xmlns:a16="http://schemas.microsoft.com/office/drawing/2014/main" id="{0D6A33FB-E85F-46AD-803A-C34693AC2D13}"/>
               </a:ext>
             </a:extLst>
           </p:cNvPr>
@@ -8574,7 +8518,7 @@
     </p:spTree>
     <p:extLst>
       <p:ext uri="{BB962C8B-B14F-4D97-AF65-F5344CB8AC3E}">
-        <p14:creationId xmlns:p14="http://schemas.microsoft.com/office/powerpoint/2010/main" val="633598746"/>
+        <p14:creationId xmlns:p14="http://schemas.microsoft.com/office/powerpoint/2010/main" val="251609509"/>
       </p:ext>
     </p:extLst>
   </p:cSld>
@@ -8605,7 +8549,7 @@
           <p:cNvPr id="31" name="">
             <a:extLst xmlns:a="http://schemas.openxmlformats.org/drawingml/2006/main">
               <a:ext uri="{FF2B5EF4-FFF2-40B4-BE49-F238E27FC236}">
-                <a16:creationId xmlns:a16="http://schemas.microsoft.com/office/drawing/2014/main" id="{C8459D33-58D1-4B4C-A0FE-A6D1E1F180B9}"/>
+                <a16:creationId xmlns:a16="http://schemas.microsoft.com/office/drawing/2014/main" id="{A0820C71-ACD0-42B7-B02D-2C8785B8C0F1}"/>
               </a:ext>
             </a:extLst>
           </p:cNvPr>
@@ -8663,7 +8607,7 @@
           <p:cNvPr id="2" name="">
             <a:extLst xmlns:a="http://schemas.openxmlformats.org/drawingml/2006/main">
               <a:ext uri="{FF2B5EF4-FFF2-40B4-BE49-F238E27FC236}">
-                <a16:creationId xmlns:a16="http://schemas.microsoft.com/office/drawing/2014/main" id="{D47C0A17-AB03-44F1-9288-F89C560672BF}"/>
+                <a16:creationId xmlns:a16="http://schemas.microsoft.com/office/drawing/2014/main" id="{E6D5FA48-7F29-497F-8368-3256F2DD199C}"/>
               </a:ext>
             </a:extLst>
           </p:cNvPr>
@@ -8721,7 +8665,7 @@
           <p:cNvPr id="3" name="">
             <a:extLst xmlns:a="http://schemas.openxmlformats.org/drawingml/2006/main">
               <a:ext uri="{FF2B5EF4-FFF2-40B4-BE49-F238E27FC236}">
-                <a16:creationId xmlns:a16="http://schemas.microsoft.com/office/drawing/2014/main" id="{20396FA9-2427-4582-B513-D4BF8C546244}"/>
+                <a16:creationId xmlns:a16="http://schemas.microsoft.com/office/drawing/2014/main" id="{90B18EDB-DE10-4C2B-8869-997EB400D9A5}"/>
               </a:ext>
             </a:extLst>
           </p:cNvPr>
@@ -8779,7 +8723,7 @@
           <p:cNvPr id="4" name="">
             <a:extLst xmlns:a="http://schemas.openxmlformats.org/drawingml/2006/main">
               <a:ext uri="{FF2B5EF4-FFF2-40B4-BE49-F238E27FC236}">
-                <a16:creationId xmlns:a16="http://schemas.microsoft.com/office/drawing/2014/main" id="{B37010A4-2BD7-4C2D-8F86-9E67590BE22C}"/>
+                <a16:creationId xmlns:a16="http://schemas.microsoft.com/office/drawing/2014/main" id="{5FBEB865-1339-44DF-89C9-49A9E2E94E55}"/>
               </a:ext>
             </a:extLst>
           </p:cNvPr>
@@ -8837,7 +8781,7 @@
           <p:cNvPr id="5" name="">
             <a:extLst xmlns:a="http://schemas.openxmlformats.org/drawingml/2006/main">
               <a:ext uri="{FF2B5EF4-FFF2-40B4-BE49-F238E27FC236}">
-                <a16:creationId xmlns:a16="http://schemas.microsoft.com/office/drawing/2014/main" id="{E204DCD1-1171-4A25-B1B7-DB2A1067F413}"/>
+                <a16:creationId xmlns:a16="http://schemas.microsoft.com/office/drawing/2014/main" id="{8B14BE42-9B5C-41A5-8EBF-5845F848780E}"/>
               </a:ext>
             </a:extLst>
           </p:cNvPr>
@@ -8870,7 +8814,7 @@
           <p:cNvPr id="6" name="">
             <a:extLst xmlns:a="http://schemas.openxmlformats.org/drawingml/2006/main">
               <a:ext uri="{FF2B5EF4-FFF2-40B4-BE49-F238E27FC236}">
-                <a16:creationId xmlns:a16="http://schemas.microsoft.com/office/drawing/2014/main" id="{1B669113-52FE-4DED-8B2C-57BECED9D3F7}"/>
+                <a16:creationId xmlns:a16="http://schemas.microsoft.com/office/drawing/2014/main" id="{6490FDAA-3B9B-401D-811B-2191DC894DFE}"/>
               </a:ext>
             </a:extLst>
           </p:cNvPr>
@@ -8928,7 +8872,7 @@
           <p:cNvPr id="7" name="">
             <a:extLst xmlns:a="http://schemas.openxmlformats.org/drawingml/2006/main">
               <a:ext uri="{FF2B5EF4-FFF2-40B4-BE49-F238E27FC236}">
-                <a16:creationId xmlns:a16="http://schemas.microsoft.com/office/drawing/2014/main" id="{3FF5B224-1DD4-473B-8720-0AE6208BA02A}"/>
+                <a16:creationId xmlns:a16="http://schemas.microsoft.com/office/drawing/2014/main" id="{BA6ED14C-14B7-4205-B966-CA8961E78882}"/>
               </a:ext>
             </a:extLst>
           </p:cNvPr>
@@ -8992,7 +8936,7 @@
           <p:cNvPr id="8" name="">
             <a:extLst xmlns:a="http://schemas.openxmlformats.org/drawingml/2006/main">
               <a:ext uri="{FF2B5EF4-FFF2-40B4-BE49-F238E27FC236}">
-                <a16:creationId xmlns:a16="http://schemas.microsoft.com/office/drawing/2014/main" id="{04F2D261-9B5F-4CBD-A904-5FAE1B6736D2}"/>
+                <a16:creationId xmlns:a16="http://schemas.microsoft.com/office/drawing/2014/main" id="{4EFBC547-EBEC-4DDA-81FB-7730FB7AFBAD}"/>
               </a:ext>
             </a:extLst>
           </p:cNvPr>
@@ -9050,7 +8994,7 @@
           <p:cNvPr id="9" name="">
             <a:extLst xmlns:a="http://schemas.openxmlformats.org/drawingml/2006/main">
               <a:ext uri="{FF2B5EF4-FFF2-40B4-BE49-F238E27FC236}">
-                <a16:creationId xmlns:a16="http://schemas.microsoft.com/office/drawing/2014/main" id="{696C30FA-59F8-4B23-95E9-3BE17A11A801}"/>
+                <a16:creationId xmlns:a16="http://schemas.microsoft.com/office/drawing/2014/main" id="{DFCCE584-555D-4EC6-AC3D-F0B2FFAD7AF0}"/>
               </a:ext>
             </a:extLst>
           </p:cNvPr>
@@ -9083,7 +9027,7 @@
           <p:cNvPr id="10" name="">
             <a:extLst xmlns:a="http://schemas.openxmlformats.org/drawingml/2006/main">
               <a:ext uri="{FF2B5EF4-FFF2-40B4-BE49-F238E27FC236}">
-                <a16:creationId xmlns:a16="http://schemas.microsoft.com/office/drawing/2014/main" id="{6F930DAF-4BBA-4557-BB58-39016FD14F5A}"/>
+                <a16:creationId xmlns:a16="http://schemas.microsoft.com/office/drawing/2014/main" id="{4D046AD9-5484-4BE2-A51D-84C607C2E784}"/>
               </a:ext>
             </a:extLst>
           </p:cNvPr>
@@ -9116,7 +9060,7 @@
           <p:cNvPr id="11" name="">
             <a:extLst xmlns:a="http://schemas.openxmlformats.org/drawingml/2006/main">
               <a:ext uri="{FF2B5EF4-FFF2-40B4-BE49-F238E27FC236}">
-                <a16:creationId xmlns:a16="http://schemas.microsoft.com/office/drawing/2014/main" id="{302E75A6-5A21-4912-AF63-07E7BF89C6C1}"/>
+                <a16:creationId xmlns:a16="http://schemas.microsoft.com/office/drawing/2014/main" id="{EEBDAAF0-A7BE-4E23-BAAD-0259E5189F76}"/>
               </a:ext>
             </a:extLst>
           </p:cNvPr>
@@ -9149,7 +9093,7 @@
           <p:cNvPr id="12" name="">
             <a:extLst xmlns:a="http://schemas.openxmlformats.org/drawingml/2006/main">
               <a:ext uri="{FF2B5EF4-FFF2-40B4-BE49-F238E27FC236}">
-                <a16:creationId xmlns:a16="http://schemas.microsoft.com/office/drawing/2014/main" id="{591F86E3-1FFD-4AF2-870E-FD3454ED6544}"/>
+                <a16:creationId xmlns:a16="http://schemas.microsoft.com/office/drawing/2014/main" id="{14CFCB9E-0AE7-46B3-AC5C-2997084A0E8F}"/>
               </a:ext>
             </a:extLst>
           </p:cNvPr>
@@ -9182,7 +9126,7 @@
           <p:cNvPr id="13" name="">
             <a:extLst xmlns:a="http://schemas.openxmlformats.org/drawingml/2006/main">
               <a:ext uri="{FF2B5EF4-FFF2-40B4-BE49-F238E27FC236}">
-                <a16:creationId xmlns:a16="http://schemas.microsoft.com/office/drawing/2014/main" id="{C8C5B7F8-CEFB-4D07-A07F-999D78C405EB}"/>
+                <a16:creationId xmlns:a16="http://schemas.microsoft.com/office/drawing/2014/main" id="{FF8F1238-5FA2-4EA4-8C42-13DB863FBFD0}"/>
               </a:ext>
             </a:extLst>
           </p:cNvPr>
@@ -9215,7 +9159,7 @@
           <p:cNvPr id="14" name="">
             <a:extLst xmlns:a="http://schemas.openxmlformats.org/drawingml/2006/main">
               <a:ext uri="{FF2B5EF4-FFF2-40B4-BE49-F238E27FC236}">
-                <a16:creationId xmlns:a16="http://schemas.microsoft.com/office/drawing/2014/main" id="{E7283E01-6AFA-4C42-B495-1AC6CCA96FFD}"/>
+                <a16:creationId xmlns:a16="http://schemas.microsoft.com/office/drawing/2014/main" id="{6471D7A0-1135-43ED-9B4E-7368D14F2449}"/>
               </a:ext>
             </a:extLst>
           </p:cNvPr>
@@ -9246,7 +9190,7 @@
           <p:cNvPr id="15" name="">
             <a:extLst xmlns:a="http://schemas.openxmlformats.org/drawingml/2006/main">
               <a:ext uri="{FF2B5EF4-FFF2-40B4-BE49-F238E27FC236}">
-                <a16:creationId xmlns:a16="http://schemas.microsoft.com/office/drawing/2014/main" id="{3977F16D-984D-4463-9BBA-BF788A753F65}"/>
+                <a16:creationId xmlns:a16="http://schemas.microsoft.com/office/drawing/2014/main" id="{335B9786-32FB-4978-A84A-3ED4E5CD569C}"/>
               </a:ext>
             </a:extLst>
           </p:cNvPr>
@@ -9304,7 +9248,7 @@
           <p:cNvPr id="16" name="">
             <a:extLst xmlns:a="http://schemas.openxmlformats.org/drawingml/2006/main">
               <a:ext uri="{FF2B5EF4-FFF2-40B4-BE49-F238E27FC236}">
-                <a16:creationId xmlns:a16="http://schemas.microsoft.com/office/drawing/2014/main" id="{05112559-A6E1-4F9D-A839-7262F892A9E3}"/>
+                <a16:creationId xmlns:a16="http://schemas.microsoft.com/office/drawing/2014/main" id="{7E9CA831-71A8-4B17-B2D3-D3C21B01B21D}"/>
               </a:ext>
             </a:extLst>
           </p:cNvPr>
@@ -9337,7 +9281,7 @@
           <p:cNvPr id="17" name="">
             <a:extLst xmlns:a="http://schemas.openxmlformats.org/drawingml/2006/main">
               <a:ext uri="{FF2B5EF4-FFF2-40B4-BE49-F238E27FC236}">
-                <a16:creationId xmlns:a16="http://schemas.microsoft.com/office/drawing/2014/main" id="{933E2968-492C-4D56-8992-FCDD33226534}"/>
+                <a16:creationId xmlns:a16="http://schemas.microsoft.com/office/drawing/2014/main" id="{8039B676-9AEC-4885-8723-88B60B4F7558}"/>
               </a:ext>
             </a:extLst>
           </p:cNvPr>
@@ -9577,7 +9521,7 @@
           <p:cNvPr id="25" name="">
             <a:extLst xmlns:a="http://schemas.openxmlformats.org/drawingml/2006/main">
               <a:ext uri="{FF2B5EF4-FFF2-40B4-BE49-F238E27FC236}">
-                <a16:creationId xmlns:a16="http://schemas.microsoft.com/office/drawing/2014/main" id="{82D76A54-4DC1-4B41-9B01-1C002AB9A70F}"/>
+                <a16:creationId xmlns:a16="http://schemas.microsoft.com/office/drawing/2014/main" id="{48ED5475-D5A0-4A42-BD9A-7C75E7F2ACCF}"/>
               </a:ext>
             </a:extLst>
           </p:cNvPr>
@@ -9635,7 +9579,7 @@
           <p:cNvPr id="26" name="">
             <a:extLst xmlns:a="http://schemas.openxmlformats.org/drawingml/2006/main">
               <a:ext uri="{FF2B5EF4-FFF2-40B4-BE49-F238E27FC236}">
-                <a16:creationId xmlns:a16="http://schemas.microsoft.com/office/drawing/2014/main" id="{92C802DB-CD0C-469B-BA43-9F0A1E1AAB18}"/>
+                <a16:creationId xmlns:a16="http://schemas.microsoft.com/office/drawing/2014/main" id="{081D4746-0113-4EE8-90C5-3E19878C773F}"/>
               </a:ext>
             </a:extLst>
           </p:cNvPr>
@@ -9693,7 +9637,7 @@
           <p:cNvPr id="27" name="">
             <a:extLst xmlns:a="http://schemas.openxmlformats.org/drawingml/2006/main">
               <a:ext uri="{FF2B5EF4-FFF2-40B4-BE49-F238E27FC236}">
-                <a16:creationId xmlns:a16="http://schemas.microsoft.com/office/drawing/2014/main" id="{F2217E46-5396-40F2-B313-18472B792D0C}"/>
+                <a16:creationId xmlns:a16="http://schemas.microsoft.com/office/drawing/2014/main" id="{E17AA2C5-AA18-4042-A414-6857BFF36CFE}"/>
               </a:ext>
             </a:extLst>
           </p:cNvPr>
@@ -9751,7 +9695,7 @@
           <p:cNvPr id="28" name="">
             <a:extLst xmlns:a="http://schemas.openxmlformats.org/drawingml/2006/main">
               <a:ext uri="{FF2B5EF4-FFF2-40B4-BE49-F238E27FC236}">
-                <a16:creationId xmlns:a16="http://schemas.microsoft.com/office/drawing/2014/main" id="{5916DA3B-6213-4566-A57A-A6B13B88163C}"/>
+                <a16:creationId xmlns:a16="http://schemas.microsoft.com/office/drawing/2014/main" id="{EF3A7431-C032-491F-8B45-F0CB5888C447}"/>
               </a:ext>
             </a:extLst>
           </p:cNvPr>
@@ -9815,7 +9759,7 @@
           <p:cNvPr id="29" name="">
             <a:extLst xmlns:a="http://schemas.openxmlformats.org/drawingml/2006/main">
               <a:ext uri="{FF2B5EF4-FFF2-40B4-BE49-F238E27FC236}">
-                <a16:creationId xmlns:a16="http://schemas.microsoft.com/office/drawing/2014/main" id="{7E1DAC37-AFEB-4F83-8CA3-103FA01F41B7}"/>
+                <a16:creationId xmlns:a16="http://schemas.microsoft.com/office/drawing/2014/main" id="{90580475-F4E0-4404-8868-60E117CD4107}"/>
               </a:ext>
             </a:extLst>
           </p:cNvPr>
@@ -9879,7 +9823,7 @@
           <p:cNvPr id="30" name="">
             <a:extLst xmlns:a="http://schemas.openxmlformats.org/drawingml/2006/main">
               <a:ext uri="{FF2B5EF4-FFF2-40B4-BE49-F238E27FC236}">
-                <a16:creationId xmlns:a16="http://schemas.microsoft.com/office/drawing/2014/main" id="{5F9F156F-C948-41E6-9C2E-00A0D0FC1BD7}"/>
+                <a16:creationId xmlns:a16="http://schemas.microsoft.com/office/drawing/2014/main" id="{A2AA929E-90B4-4080-AE01-1B9B343C0BC5}"/>
               </a:ext>
             </a:extLst>
           </p:cNvPr>
@@ -9935,7 +9879,7 @@
     </p:spTree>
     <p:extLst>
       <p:ext uri="{BB962C8B-B14F-4D97-AF65-F5344CB8AC3E}">
-        <p14:creationId xmlns:p14="http://schemas.microsoft.com/office/powerpoint/2010/main" val="320681199"/>
+        <p14:creationId xmlns:p14="http://schemas.microsoft.com/office/powerpoint/2010/main" val="625692090"/>
       </p:ext>
     </p:extLst>
   </p:cSld>
@@ -9966,7 +9910,7 @@
           <p:cNvPr id="38" name="">
             <a:extLst xmlns:a="http://schemas.openxmlformats.org/drawingml/2006/main">
               <a:ext uri="{FF2B5EF4-FFF2-40B4-BE49-F238E27FC236}">
-                <a16:creationId xmlns:a16="http://schemas.microsoft.com/office/drawing/2014/main" id="{F6F4B4AB-D065-4F07-ACA0-EA32469E7D8B}"/>
+                <a16:creationId xmlns:a16="http://schemas.microsoft.com/office/drawing/2014/main" id="{1C8ABA63-A844-41EF-8883-250A57CBCD53}"/>
               </a:ext>
             </a:extLst>
           </p:cNvPr>
@@ -10024,7 +9968,7 @@
           <p:cNvPr id="2" name="">
             <a:extLst xmlns:a="http://schemas.openxmlformats.org/drawingml/2006/main">
               <a:ext uri="{FF2B5EF4-FFF2-40B4-BE49-F238E27FC236}">
-                <a16:creationId xmlns:a16="http://schemas.microsoft.com/office/drawing/2014/main" id="{E8AC0D95-D96E-4D3D-859B-4BA72C686ECA}"/>
+                <a16:creationId xmlns:a16="http://schemas.microsoft.com/office/drawing/2014/main" id="{FF420BA3-BB1A-42AC-BD86-458E4D9FC40A}"/>
               </a:ext>
             </a:extLst>
           </p:cNvPr>
@@ -10082,7 +10026,7 @@
           <p:cNvPr id="3" name="">
             <a:extLst xmlns:a="http://schemas.openxmlformats.org/drawingml/2006/main">
               <a:ext uri="{FF2B5EF4-FFF2-40B4-BE49-F238E27FC236}">
-                <a16:creationId xmlns:a16="http://schemas.microsoft.com/office/drawing/2014/main" id="{A16AF2D5-6DE3-4738-BB13-52E7C6B31F77}"/>
+                <a16:creationId xmlns:a16="http://schemas.microsoft.com/office/drawing/2014/main" id="{64C1688B-AC2C-484C-A59C-07817459E166}"/>
               </a:ext>
             </a:extLst>
           </p:cNvPr>
@@ -10113,7 +10057,7 @@
           <p:cNvPr id="4" name="">
             <a:extLst xmlns:a="http://schemas.openxmlformats.org/drawingml/2006/main">
               <a:ext uri="{FF2B5EF4-FFF2-40B4-BE49-F238E27FC236}">
-                <a16:creationId xmlns:a16="http://schemas.microsoft.com/office/drawing/2014/main" id="{B00A9CFD-6A3F-45DF-BCC0-E5A54DC2FE62}"/>
+                <a16:creationId xmlns:a16="http://schemas.microsoft.com/office/drawing/2014/main" id="{FC8C410D-EC03-46A0-8B66-011C05B57255}"/>
               </a:ext>
             </a:extLst>
           </p:cNvPr>
@@ -10146,7 +10090,7 @@
           <p:cNvPr id="5" name="">
             <a:extLst xmlns:a="http://schemas.openxmlformats.org/drawingml/2006/main">
               <a:ext uri="{FF2B5EF4-FFF2-40B4-BE49-F238E27FC236}">
-                <a16:creationId xmlns:a16="http://schemas.microsoft.com/office/drawing/2014/main" id="{3DC54B27-1BF4-42EA-8E9E-18E832CF98C9}"/>
+                <a16:creationId xmlns:a16="http://schemas.microsoft.com/office/drawing/2014/main" id="{15F3CC62-1CF8-4446-A525-C96187AFA729}"/>
               </a:ext>
             </a:extLst>
           </p:cNvPr>
@@ -10179,7 +10123,7 @@
           <p:cNvPr id="6" name="">
             <a:extLst xmlns:a="http://schemas.openxmlformats.org/drawingml/2006/main">
               <a:ext uri="{FF2B5EF4-FFF2-40B4-BE49-F238E27FC236}">
-                <a16:creationId xmlns:a16="http://schemas.microsoft.com/office/drawing/2014/main" id="{F7C2F928-B9C2-4287-AFA6-D62954F1C448}"/>
+                <a16:creationId xmlns:a16="http://schemas.microsoft.com/office/drawing/2014/main" id="{CC0F1540-7610-4098-B41A-2D7C9555A755}"/>
               </a:ext>
             </a:extLst>
           </p:cNvPr>
@@ -10212,7 +10156,7 @@
           <p:cNvPr id="7" name="">
             <a:extLst xmlns:a="http://schemas.openxmlformats.org/drawingml/2006/main">
               <a:ext uri="{FF2B5EF4-FFF2-40B4-BE49-F238E27FC236}">
-                <a16:creationId xmlns:a16="http://schemas.microsoft.com/office/drawing/2014/main" id="{D45E6EE9-2182-4C01-8952-59A25E8764DE}"/>
+                <a16:creationId xmlns:a16="http://schemas.microsoft.com/office/drawing/2014/main" id="{C8A9C370-494C-4BB9-A8DE-8277C72BE71A}"/>
               </a:ext>
             </a:extLst>
           </p:cNvPr>
@@ -10245,7 +10189,7 @@
           <p:cNvPr id="8" name="">
             <a:extLst xmlns:a="http://schemas.openxmlformats.org/drawingml/2006/main">
               <a:ext uri="{FF2B5EF4-FFF2-40B4-BE49-F238E27FC236}">
-                <a16:creationId xmlns:a16="http://schemas.microsoft.com/office/drawing/2014/main" id="{589DBDDB-9380-47DC-8156-E605282BF76F}"/>
+                <a16:creationId xmlns:a16="http://schemas.microsoft.com/office/drawing/2014/main" id="{37234B6D-9F97-4B38-9641-7C45B67CE486}"/>
               </a:ext>
             </a:extLst>
           </p:cNvPr>
@@ -10278,7 +10222,7 @@
           <p:cNvPr id="9" name="">
             <a:extLst xmlns:a="http://schemas.openxmlformats.org/drawingml/2006/main">
               <a:ext uri="{FF2B5EF4-FFF2-40B4-BE49-F238E27FC236}">
-                <a16:creationId xmlns:a16="http://schemas.microsoft.com/office/drawing/2014/main" id="{E82172A7-CAC9-45E9-B4C7-273FCBEF2976}"/>
+                <a16:creationId xmlns:a16="http://schemas.microsoft.com/office/drawing/2014/main" id="{96099301-8A23-47EA-AECA-9F606F7CF5BA}"/>
               </a:ext>
             </a:extLst>
           </p:cNvPr>
@@ -10309,7 +10253,7 @@
           <p:cNvPr id="10" name="">
             <a:extLst xmlns:a="http://schemas.openxmlformats.org/drawingml/2006/main">
               <a:ext uri="{FF2B5EF4-FFF2-40B4-BE49-F238E27FC236}">
-                <a16:creationId xmlns:a16="http://schemas.microsoft.com/office/drawing/2014/main" id="{E5872CDF-7601-41B7-AF56-BD000D31BD3C}"/>
+                <a16:creationId xmlns:a16="http://schemas.microsoft.com/office/drawing/2014/main" id="{EC3C1D03-DFA0-48A1-ABCC-91BB6BC49D35}"/>
               </a:ext>
             </a:extLst>
           </p:cNvPr>
@@ -10342,7 +10286,7 @@
           <p:cNvPr id="11" name="">
             <a:extLst xmlns:a="http://schemas.openxmlformats.org/drawingml/2006/main">
               <a:ext uri="{FF2B5EF4-FFF2-40B4-BE49-F238E27FC236}">
-                <a16:creationId xmlns:a16="http://schemas.microsoft.com/office/drawing/2014/main" id="{CC268A9F-5324-4E64-83DB-770CEB3EBA61}"/>
+                <a16:creationId xmlns:a16="http://schemas.microsoft.com/office/drawing/2014/main" id="{6BB5908E-F8F3-4EFF-9894-D285AF6C5D15}"/>
               </a:ext>
             </a:extLst>
           </p:cNvPr>
@@ -10557,7 +10501,7 @@
           <p:cNvPr id="19" name="">
             <a:extLst xmlns:a="http://schemas.openxmlformats.org/drawingml/2006/main">
               <a:ext uri="{FF2B5EF4-FFF2-40B4-BE49-F238E27FC236}">
-                <a16:creationId xmlns:a16="http://schemas.microsoft.com/office/drawing/2014/main" id="{2B4ECA32-5154-44E7-B818-77599C28F45F}"/>
+                <a16:creationId xmlns:a16="http://schemas.microsoft.com/office/drawing/2014/main" id="{C891F2C4-B865-4735-BF15-A538A4F8AA4D}"/>
               </a:ext>
             </a:extLst>
           </p:cNvPr>
@@ -10590,7 +10534,7 @@
           <p:cNvPr id="20" name="">
             <a:extLst xmlns:a="http://schemas.openxmlformats.org/drawingml/2006/main">
               <a:ext uri="{FF2B5EF4-FFF2-40B4-BE49-F238E27FC236}">
-                <a16:creationId xmlns:a16="http://schemas.microsoft.com/office/drawing/2014/main" id="{E4ED2D9A-0C28-4722-B996-55F81A03CA26}"/>
+                <a16:creationId xmlns:a16="http://schemas.microsoft.com/office/drawing/2014/main" id="{DA6F91E8-9C50-4FB6-A30B-369F009EC4A1}"/>
               </a:ext>
             </a:extLst>
           </p:cNvPr>
@@ -10623,7 +10567,7 @@
           <p:cNvPr id="21" name="">
             <a:extLst xmlns:a="http://schemas.openxmlformats.org/drawingml/2006/main">
               <a:ext uri="{FF2B5EF4-FFF2-40B4-BE49-F238E27FC236}">
-                <a16:creationId xmlns:a16="http://schemas.microsoft.com/office/drawing/2014/main" id="{21F61214-28B0-4427-8F8E-36C3BD87A6E6}"/>
+                <a16:creationId xmlns:a16="http://schemas.microsoft.com/office/drawing/2014/main" id="{5BBF5F04-E980-4EA8-9B89-60CF8EBA6728}"/>
               </a:ext>
             </a:extLst>
           </p:cNvPr>
@@ -10656,7 +10600,7 @@
           <p:cNvPr id="22" name="">
             <a:extLst xmlns:a="http://schemas.openxmlformats.org/drawingml/2006/main">
               <a:ext uri="{FF2B5EF4-FFF2-40B4-BE49-F238E27FC236}">
-                <a16:creationId xmlns:a16="http://schemas.microsoft.com/office/drawing/2014/main" id="{E1D587C6-3432-4A0A-B59F-F6AC3EE03F4A}"/>
+                <a16:creationId xmlns:a16="http://schemas.microsoft.com/office/drawing/2014/main" id="{AA39A74C-D88E-454F-B33A-F4B9A0629B5C}"/>
               </a:ext>
             </a:extLst>
           </p:cNvPr>
@@ -10689,7 +10633,7 @@
           <p:cNvPr id="23" name="">
             <a:extLst xmlns:a="http://schemas.openxmlformats.org/drawingml/2006/main">
               <a:ext uri="{FF2B5EF4-FFF2-40B4-BE49-F238E27FC236}">
-                <a16:creationId xmlns:a16="http://schemas.microsoft.com/office/drawing/2014/main" id="{F372E9F8-40A1-43F9-A9E7-7111883791F0}"/>
+                <a16:creationId xmlns:a16="http://schemas.microsoft.com/office/drawing/2014/main" id="{26F17908-65C3-4B59-B168-39424F53D06B}"/>
               </a:ext>
             </a:extLst>
           </p:cNvPr>
@@ -10722,7 +10666,7 @@
           <p:cNvPr id="24" name="">
             <a:extLst xmlns:a="http://schemas.openxmlformats.org/drawingml/2006/main">
               <a:ext uri="{FF2B5EF4-FFF2-40B4-BE49-F238E27FC236}">
-                <a16:creationId xmlns:a16="http://schemas.microsoft.com/office/drawing/2014/main" id="{61FF84F6-BC43-47C8-B9E2-C66243F58160}"/>
+                <a16:creationId xmlns:a16="http://schemas.microsoft.com/office/drawing/2014/main" id="{B7D77BDF-EEDD-41D1-BEA3-576AA33E5658}"/>
               </a:ext>
             </a:extLst>
           </p:cNvPr>
@@ -10753,7 +10697,7 @@
           <p:cNvPr id="25" name="">
             <a:extLst xmlns:a="http://schemas.openxmlformats.org/drawingml/2006/main">
               <a:ext uri="{FF2B5EF4-FFF2-40B4-BE49-F238E27FC236}">
-                <a16:creationId xmlns:a16="http://schemas.microsoft.com/office/drawing/2014/main" id="{D9E3B0F4-FAD6-49EB-891C-9F057C892347}"/>
+                <a16:creationId xmlns:a16="http://schemas.microsoft.com/office/drawing/2014/main" id="{BD99F43E-D3B2-4F35-A8D6-D0D64968B149}"/>
               </a:ext>
             </a:extLst>
           </p:cNvPr>
@@ -10786,7 +10730,7 @@
           <p:cNvPr id="26" name="">
             <a:extLst xmlns:a="http://schemas.openxmlformats.org/drawingml/2006/main">
               <a:ext uri="{FF2B5EF4-FFF2-40B4-BE49-F238E27FC236}">
-                <a16:creationId xmlns:a16="http://schemas.microsoft.com/office/drawing/2014/main" id="{23FD4DA6-854E-4404-BEB8-F62B60AD43DC}"/>
+                <a16:creationId xmlns:a16="http://schemas.microsoft.com/office/drawing/2014/main" id="{EB52BD84-0D1C-4520-A776-853520B38471}"/>
               </a:ext>
             </a:extLst>
           </p:cNvPr>
@@ -11001,7 +10945,7 @@
           <p:cNvPr id="34" name="">
             <a:extLst xmlns:a="http://schemas.openxmlformats.org/drawingml/2006/main">
               <a:ext uri="{FF2B5EF4-FFF2-40B4-BE49-F238E27FC236}">
-                <a16:creationId xmlns:a16="http://schemas.microsoft.com/office/drawing/2014/main" id="{986026D0-81D7-4337-9099-F400F070CD92}"/>
+                <a16:creationId xmlns:a16="http://schemas.microsoft.com/office/drawing/2014/main" id="{531506EB-34DB-4A0A-93DF-9B1B646DC995}"/>
               </a:ext>
             </a:extLst>
           </p:cNvPr>
@@ -11059,7 +11003,7 @@
           <p:cNvPr id="35" name="">
             <a:extLst xmlns:a="http://schemas.openxmlformats.org/drawingml/2006/main">
               <a:ext uri="{FF2B5EF4-FFF2-40B4-BE49-F238E27FC236}">
-                <a16:creationId xmlns:a16="http://schemas.microsoft.com/office/drawing/2014/main" id="{FEF1AB85-24F9-4C75-8C41-485CF544ECD1}"/>
+                <a16:creationId xmlns:a16="http://schemas.microsoft.com/office/drawing/2014/main" id="{1281C1FC-306B-4B32-866E-7E296EBC9619}"/>
               </a:ext>
             </a:extLst>
           </p:cNvPr>
@@ -11117,7 +11061,7 @@
           <p:cNvPr id="36" name="">
             <a:extLst xmlns:a="http://schemas.openxmlformats.org/drawingml/2006/main">
               <a:ext uri="{FF2B5EF4-FFF2-40B4-BE49-F238E27FC236}">
-                <a16:creationId xmlns:a16="http://schemas.microsoft.com/office/drawing/2014/main" id="{02749308-C41E-4A3E-982D-7B02765BA4F8}"/>
+                <a16:creationId xmlns:a16="http://schemas.microsoft.com/office/drawing/2014/main" id="{0986320D-713B-4B77-9891-5903EC5D2763}"/>
               </a:ext>
             </a:extLst>
           </p:cNvPr>
@@ -11181,7 +11125,7 @@
           <p:cNvPr id="37" name="">
             <a:extLst xmlns:a="http://schemas.openxmlformats.org/drawingml/2006/main">
               <a:ext uri="{FF2B5EF4-FFF2-40B4-BE49-F238E27FC236}">
-                <a16:creationId xmlns:a16="http://schemas.microsoft.com/office/drawing/2014/main" id="{AC0ADC46-D06A-4BB1-B2A1-D8AD5216BF8E}"/>
+                <a16:creationId xmlns:a16="http://schemas.microsoft.com/office/drawing/2014/main" id="{C74F8215-4E0C-402D-8BC9-DC1BA2E94845}"/>
               </a:ext>
             </a:extLst>
           </p:cNvPr>
@@ -11243,7 +11187,7 @@
     </p:spTree>
     <p:extLst>
       <p:ext uri="{BB962C8B-B14F-4D97-AF65-F5344CB8AC3E}">
-        <p14:creationId xmlns:p14="http://schemas.microsoft.com/office/powerpoint/2010/main" val="218718583"/>
+        <p14:creationId xmlns:p14="http://schemas.microsoft.com/office/powerpoint/2010/main" val="2130178473"/>
       </p:ext>
     </p:extLst>
   </p:cSld>
@@ -11274,7 +11218,7 @@
           <p:cNvPr id="41" name="">
             <a:extLst xmlns:a="http://schemas.openxmlformats.org/drawingml/2006/main">
               <a:ext uri="{FF2B5EF4-FFF2-40B4-BE49-F238E27FC236}">
-                <a16:creationId xmlns:a16="http://schemas.microsoft.com/office/drawing/2014/main" id="{ACB99BBE-2173-449F-8528-F7250CFCA127}"/>
+                <a16:creationId xmlns:a16="http://schemas.microsoft.com/office/drawing/2014/main" id="{D931642B-A434-4938-ADF0-DA0293ECE288}"/>
               </a:ext>
             </a:extLst>
           </p:cNvPr>
@@ -11332,7 +11276,7 @@
           <p:cNvPr id="2" name="">
             <a:extLst xmlns:a="http://schemas.openxmlformats.org/drawingml/2006/main">
               <a:ext uri="{FF2B5EF4-FFF2-40B4-BE49-F238E27FC236}">
-                <a16:creationId xmlns:a16="http://schemas.microsoft.com/office/drawing/2014/main" id="{822E0A71-696B-4C9A-8636-5B9CA7F7176F}"/>
+                <a16:creationId xmlns:a16="http://schemas.microsoft.com/office/drawing/2014/main" id="{D6205271-AF82-453D-9701-725EEFF32A39}"/>
               </a:ext>
             </a:extLst>
           </p:cNvPr>
@@ -11413,7 +11357,7 @@
           <p:cNvPr id="3" name="">
             <a:extLst xmlns:a="http://schemas.openxmlformats.org/drawingml/2006/main">
               <a:ext uri="{FF2B5EF4-FFF2-40B4-BE49-F238E27FC236}">
-                <a16:creationId xmlns:a16="http://schemas.microsoft.com/office/drawing/2014/main" id="{284018C4-440F-43D8-807B-36FC7362D34F}"/>
+                <a16:creationId xmlns:a16="http://schemas.microsoft.com/office/drawing/2014/main" id="{BE3DBECD-F5A1-4E4B-8A55-5C9889C8BECF}"/>
               </a:ext>
             </a:extLst>
           </p:cNvPr>
@@ -11471,7 +11415,7 @@
           <p:cNvPr id="4" name="">
             <a:extLst xmlns:a="http://schemas.openxmlformats.org/drawingml/2006/main">
               <a:ext uri="{FF2B5EF4-FFF2-40B4-BE49-F238E27FC236}">
-                <a16:creationId xmlns:a16="http://schemas.microsoft.com/office/drawing/2014/main" id="{79582C16-1E01-4D06-98B3-1BC0B7A724AB}"/>
+                <a16:creationId xmlns:a16="http://schemas.microsoft.com/office/drawing/2014/main" id="{B4FC212C-3162-4E9F-AB1C-22DAD4CB05EC}"/>
               </a:ext>
             </a:extLst>
           </p:cNvPr>
@@ -11529,7 +11473,7 @@
           <p:cNvPr id="5" name="">
             <a:extLst xmlns:a="http://schemas.openxmlformats.org/drawingml/2006/main">
               <a:ext uri="{FF2B5EF4-FFF2-40B4-BE49-F238E27FC236}">
-                <a16:creationId xmlns:a16="http://schemas.microsoft.com/office/drawing/2014/main" id="{39229480-7187-4BFF-BE6C-B246F40036FC}"/>
+                <a16:creationId xmlns:a16="http://schemas.microsoft.com/office/drawing/2014/main" id="{6F84F8D8-5D69-4BC5-BD19-F6174FB08385}"/>
               </a:ext>
             </a:extLst>
           </p:cNvPr>
@@ -11562,7 +11506,7 @@
           <p:cNvPr id="6" name="">
             <a:extLst xmlns:a="http://schemas.openxmlformats.org/drawingml/2006/main">
               <a:ext uri="{FF2B5EF4-FFF2-40B4-BE49-F238E27FC236}">
-                <a16:creationId xmlns:a16="http://schemas.microsoft.com/office/drawing/2014/main" id="{35AB4EC5-4184-4C11-ACCC-E5C9C649FAB3}"/>
+                <a16:creationId xmlns:a16="http://schemas.microsoft.com/office/drawing/2014/main" id="{9DF0573E-BAB4-4D27-9BF2-0113C4406B6E}"/>
               </a:ext>
             </a:extLst>
           </p:cNvPr>
@@ -11595,7 +11539,7 @@
           <p:cNvPr id="7" name="">
             <a:extLst xmlns:a="http://schemas.openxmlformats.org/drawingml/2006/main">
               <a:ext uri="{FF2B5EF4-FFF2-40B4-BE49-F238E27FC236}">
-                <a16:creationId xmlns:a16="http://schemas.microsoft.com/office/drawing/2014/main" id="{FA544881-F199-4474-8B06-66B0FF12542B}"/>
+                <a16:creationId xmlns:a16="http://schemas.microsoft.com/office/drawing/2014/main" id="{B179ACD5-4F09-4A09-9260-36FFA6741E38}"/>
               </a:ext>
             </a:extLst>
           </p:cNvPr>
@@ -11628,7 +11572,7 @@
           <p:cNvPr id="8" name="">
             <a:extLst xmlns:a="http://schemas.openxmlformats.org/drawingml/2006/main">
               <a:ext uri="{FF2B5EF4-FFF2-40B4-BE49-F238E27FC236}">
-                <a16:creationId xmlns:a16="http://schemas.microsoft.com/office/drawing/2014/main" id="{07E027E3-5CAC-454B-9F80-D8CDE5278ADA}"/>
+                <a16:creationId xmlns:a16="http://schemas.microsoft.com/office/drawing/2014/main" id="{A6065108-93E6-4265-9282-BBB1676A9A71}"/>
               </a:ext>
             </a:extLst>
           </p:cNvPr>
@@ -11739,7 +11683,7 @@
           <p:cNvPr id="12" name="">
             <a:extLst xmlns:a="http://schemas.openxmlformats.org/drawingml/2006/main">
               <a:ext uri="{FF2B5EF4-FFF2-40B4-BE49-F238E27FC236}">
-                <a16:creationId xmlns:a16="http://schemas.microsoft.com/office/drawing/2014/main" id="{2B3530E8-6A53-42F2-B1F3-F4E03193836F}"/>
+                <a16:creationId xmlns:a16="http://schemas.microsoft.com/office/drawing/2014/main" id="{7A8BD283-D1A2-4DA2-8F9C-DA3CB927E902}"/>
               </a:ext>
             </a:extLst>
           </p:cNvPr>
@@ -11772,7 +11716,7 @@
           <p:cNvPr id="13" name="">
             <a:extLst xmlns:a="http://schemas.openxmlformats.org/drawingml/2006/main">
               <a:ext uri="{FF2B5EF4-FFF2-40B4-BE49-F238E27FC236}">
-                <a16:creationId xmlns:a16="http://schemas.microsoft.com/office/drawing/2014/main" id="{A7B85598-0187-4317-949F-1A9195023FCF}"/>
+                <a16:creationId xmlns:a16="http://schemas.microsoft.com/office/drawing/2014/main" id="{6D78A4A9-033E-470C-B664-86559B5885ED}"/>
               </a:ext>
             </a:extLst>
           </p:cNvPr>
@@ -11805,7 +11749,7 @@
           <p:cNvPr id="14" name="">
             <a:extLst xmlns:a="http://schemas.openxmlformats.org/drawingml/2006/main">
               <a:ext uri="{FF2B5EF4-FFF2-40B4-BE49-F238E27FC236}">
-                <a16:creationId xmlns:a16="http://schemas.microsoft.com/office/drawing/2014/main" id="{DB15ABAD-59E5-4DDC-856D-CEB0BD5AA26C}"/>
+                <a16:creationId xmlns:a16="http://schemas.microsoft.com/office/drawing/2014/main" id="{D49B49CC-59BD-4AC5-8B20-E5E6E36D0A74}"/>
               </a:ext>
             </a:extLst>
           </p:cNvPr>
@@ -11838,7 +11782,7 @@
           <p:cNvPr id="15" name="">
             <a:extLst xmlns:a="http://schemas.openxmlformats.org/drawingml/2006/main">
               <a:ext uri="{FF2B5EF4-FFF2-40B4-BE49-F238E27FC236}">
-                <a16:creationId xmlns:a16="http://schemas.microsoft.com/office/drawing/2014/main" id="{759843D8-FF45-4E20-8B17-3AA79FDF92BB}"/>
+                <a16:creationId xmlns:a16="http://schemas.microsoft.com/office/drawing/2014/main" id="{1266FD67-CC83-4E1B-9DAD-A1D49A0F2F82}"/>
               </a:ext>
             </a:extLst>
           </p:cNvPr>
@@ -11871,7 +11815,7 @@
           <p:cNvPr id="16" name="">
             <a:extLst xmlns:a="http://schemas.openxmlformats.org/drawingml/2006/main">
               <a:ext uri="{FF2B5EF4-FFF2-40B4-BE49-F238E27FC236}">
-                <a16:creationId xmlns:a16="http://schemas.microsoft.com/office/drawing/2014/main" id="{01273B52-7950-49BD-BEA1-7EAD855CB89F}"/>
+                <a16:creationId xmlns:a16="http://schemas.microsoft.com/office/drawing/2014/main" id="{CC572E4F-C82C-4B26-A02A-75E7BED553F6}"/>
               </a:ext>
             </a:extLst>
           </p:cNvPr>
@@ -11902,7 +11846,7 @@
           <p:cNvPr id="17" name="">
             <a:extLst xmlns:a="http://schemas.openxmlformats.org/drawingml/2006/main">
               <a:ext uri="{FF2B5EF4-FFF2-40B4-BE49-F238E27FC236}">
-                <a16:creationId xmlns:a16="http://schemas.microsoft.com/office/drawing/2014/main" id="{BBA93532-6392-44D5-A0BC-435BF9CC5C6B}"/>
+                <a16:creationId xmlns:a16="http://schemas.microsoft.com/office/drawing/2014/main" id="{06E7DDF6-C31E-40CA-A677-D09EF75BEF84}"/>
               </a:ext>
             </a:extLst>
           </p:cNvPr>
@@ -12065,7 +12009,7 @@
           <p:cNvPr id="23" name="">
             <a:extLst xmlns:a="http://schemas.openxmlformats.org/drawingml/2006/main">
               <a:ext uri="{FF2B5EF4-FFF2-40B4-BE49-F238E27FC236}">
-                <a16:creationId xmlns:a16="http://schemas.microsoft.com/office/drawing/2014/main" id="{F8B9B3C8-941C-4BE9-92B7-B31D27EE12D5}"/>
+                <a16:creationId xmlns:a16="http://schemas.microsoft.com/office/drawing/2014/main" id="{5AE594E8-DC42-446E-B30B-3C6D5602249E}"/>
               </a:ext>
             </a:extLst>
           </p:cNvPr>
@@ -12098,7 +12042,7 @@
           <p:cNvPr id="24" name="">
             <a:extLst xmlns:a="http://schemas.openxmlformats.org/drawingml/2006/main">
               <a:ext uri="{FF2B5EF4-FFF2-40B4-BE49-F238E27FC236}">
-                <a16:creationId xmlns:a16="http://schemas.microsoft.com/office/drawing/2014/main" id="{6466F1EA-B1AD-4239-BACC-D66AF4D81798}"/>
+                <a16:creationId xmlns:a16="http://schemas.microsoft.com/office/drawing/2014/main" id="{619BF329-9F82-4A34-B445-B43F1E90776F}"/>
               </a:ext>
             </a:extLst>
           </p:cNvPr>
@@ -12131,7 +12075,7 @@
           <p:cNvPr id="25" name="">
             <a:extLst xmlns:a="http://schemas.openxmlformats.org/drawingml/2006/main">
               <a:ext uri="{FF2B5EF4-FFF2-40B4-BE49-F238E27FC236}">
-                <a16:creationId xmlns:a16="http://schemas.microsoft.com/office/drawing/2014/main" id="{AC39C985-53DF-4F4B-9E46-04EF8C00F29F}"/>
+                <a16:creationId xmlns:a16="http://schemas.microsoft.com/office/drawing/2014/main" id="{80D8374E-68D3-4C6D-8A36-E0FDAFDF7A5F}"/>
               </a:ext>
             </a:extLst>
           </p:cNvPr>
@@ -12164,7 +12108,7 @@
           <p:cNvPr id="26" name="">
             <a:extLst xmlns:a="http://schemas.openxmlformats.org/drawingml/2006/main">
               <a:ext uri="{FF2B5EF4-FFF2-40B4-BE49-F238E27FC236}">
-                <a16:creationId xmlns:a16="http://schemas.microsoft.com/office/drawing/2014/main" id="{4E4A45CA-174A-48F0-8D84-C477C66C3366}"/>
+                <a16:creationId xmlns:a16="http://schemas.microsoft.com/office/drawing/2014/main" id="{2BBE9985-8C3D-4BDB-A5CA-ACF398BEF7E0}"/>
               </a:ext>
             </a:extLst>
           </p:cNvPr>
@@ -12195,7 +12139,7 @@
           <p:cNvPr id="27" name="">
             <a:extLst xmlns:a="http://schemas.openxmlformats.org/drawingml/2006/main">
               <a:ext uri="{FF2B5EF4-FFF2-40B4-BE49-F238E27FC236}">
-                <a16:creationId xmlns:a16="http://schemas.microsoft.com/office/drawing/2014/main" id="{96DD8387-171A-41D1-92D5-D3345047C664}"/>
+                <a16:creationId xmlns:a16="http://schemas.microsoft.com/office/drawing/2014/main" id="{47170205-069F-4FA5-A17E-DE9F9B3F98B0}"/>
               </a:ext>
             </a:extLst>
           </p:cNvPr>
@@ -12228,7 +12172,7 @@
           <p:cNvPr id="28" name="">
             <a:extLst xmlns:a="http://schemas.openxmlformats.org/drawingml/2006/main">
               <a:ext uri="{FF2B5EF4-FFF2-40B4-BE49-F238E27FC236}">
-                <a16:creationId xmlns:a16="http://schemas.microsoft.com/office/drawing/2014/main" id="{94C11415-1673-4624-ADE6-42DEE300493D}"/>
+                <a16:creationId xmlns:a16="http://schemas.microsoft.com/office/drawing/2014/main" id="{C010154A-C1FB-455E-AC18-C1233BE81F97}"/>
               </a:ext>
             </a:extLst>
           </p:cNvPr>
@@ -12261,7 +12205,7 @@
           <p:cNvPr id="29" name="">
             <a:extLst xmlns:a="http://schemas.openxmlformats.org/drawingml/2006/main">
               <a:ext uri="{FF2B5EF4-FFF2-40B4-BE49-F238E27FC236}">
-                <a16:creationId xmlns:a16="http://schemas.microsoft.com/office/drawing/2014/main" id="{8E73999F-27B9-4D0F-806B-D8266B27DC63}"/>
+                <a16:creationId xmlns:a16="http://schemas.microsoft.com/office/drawing/2014/main" id="{83188471-819C-4A07-B9A8-E6F25A2B1D98}"/>
               </a:ext>
             </a:extLst>
           </p:cNvPr>
@@ -12294,7 +12238,7 @@
           <p:cNvPr id="30" name="">
             <a:extLst xmlns:a="http://schemas.openxmlformats.org/drawingml/2006/main">
               <a:ext uri="{FF2B5EF4-FFF2-40B4-BE49-F238E27FC236}">
-                <a16:creationId xmlns:a16="http://schemas.microsoft.com/office/drawing/2014/main" id="{4A37AF52-7169-42B4-9921-D1E98B924DD5}"/>
+                <a16:creationId xmlns:a16="http://schemas.microsoft.com/office/drawing/2014/main" id="{333CEF17-59A8-489E-BC05-7D94D4E1D99A}"/>
               </a:ext>
             </a:extLst>
           </p:cNvPr>
@@ -12327,7 +12271,7 @@
           <p:cNvPr id="31" name="">
             <a:extLst xmlns:a="http://schemas.openxmlformats.org/drawingml/2006/main">
               <a:ext uri="{FF2B5EF4-FFF2-40B4-BE49-F238E27FC236}">
-                <a16:creationId xmlns:a16="http://schemas.microsoft.com/office/drawing/2014/main" id="{081A1824-E89F-4A27-B4BC-E8D8048CF9DE}"/>
+                <a16:creationId xmlns:a16="http://schemas.microsoft.com/office/drawing/2014/main" id="{EE17D24A-B5CB-453F-B890-77E19525B58A}"/>
               </a:ext>
             </a:extLst>
           </p:cNvPr>
@@ -12360,7 +12304,7 @@
           <p:cNvPr id="32" name="">
             <a:extLst xmlns:a="http://schemas.openxmlformats.org/drawingml/2006/main">
               <a:ext uri="{FF2B5EF4-FFF2-40B4-BE49-F238E27FC236}">
-                <a16:creationId xmlns:a16="http://schemas.microsoft.com/office/drawing/2014/main" id="{2525F027-16E9-45A2-9D63-4FA42703E972}"/>
+                <a16:creationId xmlns:a16="http://schemas.microsoft.com/office/drawing/2014/main" id="{BAE13C24-A4A5-4972-83A8-CB94EBB20F9B}"/>
               </a:ext>
             </a:extLst>
           </p:cNvPr>
@@ -12393,7 +12337,7 @@
           <p:cNvPr id="33" name="">
             <a:extLst xmlns:a="http://schemas.openxmlformats.org/drawingml/2006/main">
               <a:ext uri="{FF2B5EF4-FFF2-40B4-BE49-F238E27FC236}">
-                <a16:creationId xmlns:a16="http://schemas.microsoft.com/office/drawing/2014/main" id="{1B1A6255-8EDB-465B-89FF-CBA9A482F260}"/>
+                <a16:creationId xmlns:a16="http://schemas.microsoft.com/office/drawing/2014/main" id="{D38E590A-27F8-4A3A-963C-C1E698CAE645}"/>
               </a:ext>
             </a:extLst>
           </p:cNvPr>
@@ -12476,7 +12420,7 @@
           <p:cNvPr id="36" name="">
             <a:extLst xmlns:a="http://schemas.openxmlformats.org/drawingml/2006/main">
               <a:ext uri="{FF2B5EF4-FFF2-40B4-BE49-F238E27FC236}">
-                <a16:creationId xmlns:a16="http://schemas.microsoft.com/office/drawing/2014/main" id="{8F111739-7546-4504-A515-E6C6DCBF8A03}"/>
+                <a16:creationId xmlns:a16="http://schemas.microsoft.com/office/drawing/2014/main" id="{B660857A-D6D8-4659-9FA4-8F234BDF313F}"/>
               </a:ext>
             </a:extLst>
           </p:cNvPr>
@@ -12509,7 +12453,7 @@
           <p:cNvPr id="37" name="">
             <a:extLst xmlns:a="http://schemas.openxmlformats.org/drawingml/2006/main">
               <a:ext uri="{FF2B5EF4-FFF2-40B4-BE49-F238E27FC236}">
-                <a16:creationId xmlns:a16="http://schemas.microsoft.com/office/drawing/2014/main" id="{38F8A948-B313-41BF-BA1C-061C4FF4BDF6}"/>
+                <a16:creationId xmlns:a16="http://schemas.microsoft.com/office/drawing/2014/main" id="{6AE140D6-154E-4E78-8A17-A8F33480893E}"/>
               </a:ext>
             </a:extLst>
           </p:cNvPr>
@@ -12567,7 +12511,7 @@
           <p:cNvPr id="38" name="">
             <a:extLst xmlns:a="http://schemas.openxmlformats.org/drawingml/2006/main">
               <a:ext uri="{FF2B5EF4-FFF2-40B4-BE49-F238E27FC236}">
-                <a16:creationId xmlns:a16="http://schemas.microsoft.com/office/drawing/2014/main" id="{7A97747B-0059-48DF-AB25-B36A4539335A}"/>
+                <a16:creationId xmlns:a16="http://schemas.microsoft.com/office/drawing/2014/main" id="{84737D91-774D-442F-A8EE-FFD8C28A77C0}"/>
               </a:ext>
             </a:extLst>
           </p:cNvPr>
@@ -12625,7 +12569,7 @@
           <p:cNvPr id="39" name="">
             <a:extLst xmlns:a="http://schemas.openxmlformats.org/drawingml/2006/main">
               <a:ext uri="{FF2B5EF4-FFF2-40B4-BE49-F238E27FC236}">
-                <a16:creationId xmlns:a16="http://schemas.microsoft.com/office/drawing/2014/main" id="{D7FD2DE1-4735-415F-8115-E239E7537AD4}"/>
+                <a16:creationId xmlns:a16="http://schemas.microsoft.com/office/drawing/2014/main" id="{FD675030-3A2E-44A4-8296-BB4BB1E35FA3}"/>
               </a:ext>
             </a:extLst>
           </p:cNvPr>
@@ -12683,7 +12627,7 @@
           <p:cNvPr id="40" name="">
             <a:extLst xmlns:a="http://schemas.openxmlformats.org/drawingml/2006/main">
               <a:ext uri="{FF2B5EF4-FFF2-40B4-BE49-F238E27FC236}">
-                <a16:creationId xmlns:a16="http://schemas.microsoft.com/office/drawing/2014/main" id="{FBC8F4D2-12E9-43E7-98DD-738C556D5C7B}"/>
+                <a16:creationId xmlns:a16="http://schemas.microsoft.com/office/drawing/2014/main" id="{8980C753-8F8E-462A-83B3-48B5BFDE5351}"/>
               </a:ext>
             </a:extLst>
           </p:cNvPr>
@@ -12739,7 +12683,7 @@
     </p:spTree>
     <p:extLst>
       <p:ext uri="{BB962C8B-B14F-4D97-AF65-F5344CB8AC3E}">
-        <p14:creationId xmlns:p14="http://schemas.microsoft.com/office/powerpoint/2010/main" val="989708105"/>
+        <p14:creationId xmlns:p14="http://schemas.microsoft.com/office/powerpoint/2010/main" val="108895675"/>
       </p:ext>
     </p:extLst>
   </p:cSld>

</xml_diff>